<commit_message>
Replace analysis clips with gameplay videos
</commit_message>
<xml_diff>
--- a/presentations/final/CODE_BLUE_RL_FINAL.pptx
+++ b/presentations/final/CODE_BLUE_RL_FINAL.pptx
@@ -2,30 +2,30 @@
 <file path=ppt/presentation.xml><?xml version="1.0" encoding="utf-8"?>
 <p:presentation xmlns:p="http://schemas.openxmlformats.org/presentationml/2006/main">
   <p:sldMasterIdLst>
-    <p:sldMasterId xmlns:r="http://schemas.openxmlformats.org/officeDocument/2006/relationships" id="2147483648" r:id="Rb86fbb86300d4db3"/>
+    <p:sldMasterId xmlns:r="http://schemas.openxmlformats.org/officeDocument/2006/relationships" id="2147483648" r:id="R52d7725644114391"/>
   </p:sldMasterIdLst>
   <p:notesMasterIdLst>
-    <p:notesMasterId xmlns:r="http://schemas.openxmlformats.org/officeDocument/2006/relationships" r:id="R762eae3915044a87"/>
+    <p:notesMasterId xmlns:r="http://schemas.openxmlformats.org/officeDocument/2006/relationships" r:id="R104b511619e74603"/>
   </p:notesMasterIdLst>
   <p:sldIdLst>
-    <p:sldId xmlns:r="http://schemas.openxmlformats.org/officeDocument/2006/relationships" id="256" r:id="R0cdfb1f08f6048e5"/>
-    <p:sldId xmlns:r="http://schemas.openxmlformats.org/officeDocument/2006/relationships" id="257" r:id="Rdab99014b0034e01"/>
-    <p:sldId xmlns:r="http://schemas.openxmlformats.org/officeDocument/2006/relationships" id="258" r:id="R342b3fbbfc6b49d9"/>
-    <p:sldId xmlns:r="http://schemas.openxmlformats.org/officeDocument/2006/relationships" id="259" r:id="R7b23e5a46df84ae0"/>
-    <p:sldId xmlns:r="http://schemas.openxmlformats.org/officeDocument/2006/relationships" id="260" r:id="Rb3d6607205674659"/>
-    <p:sldId xmlns:r="http://schemas.openxmlformats.org/officeDocument/2006/relationships" id="261" r:id="R3fdcd2270920455d"/>
-    <p:sldId xmlns:r="http://schemas.openxmlformats.org/officeDocument/2006/relationships" id="262" r:id="Rf889f6d488314eaa"/>
-    <p:sldId xmlns:r="http://schemas.openxmlformats.org/officeDocument/2006/relationships" id="263" r:id="Rdfe242cc447047bd"/>
-    <p:sldId xmlns:r="http://schemas.openxmlformats.org/officeDocument/2006/relationships" id="264" r:id="R684d00e3fee84f04"/>
-    <p:sldId xmlns:r="http://schemas.openxmlformats.org/officeDocument/2006/relationships" id="265" r:id="Raa8499e45e534395"/>
-    <p:sldId xmlns:r="http://schemas.openxmlformats.org/officeDocument/2006/relationships" id="266" r:id="Re6567f1e9ecc41c2"/>
-    <p:sldId xmlns:r="http://schemas.openxmlformats.org/officeDocument/2006/relationships" id="267" r:id="R21948671eaae4afb"/>
-    <p:sldId xmlns:r="http://schemas.openxmlformats.org/officeDocument/2006/relationships" id="268" r:id="R74bb5c9a50ec42e4"/>
-    <p:sldId xmlns:r="http://schemas.openxmlformats.org/officeDocument/2006/relationships" id="269" r:id="Raabe3f19372a4c81"/>
-    <p:sldId xmlns:r="http://schemas.openxmlformats.org/officeDocument/2006/relationships" id="270" r:id="R65fbf368d1d64996"/>
-    <p:sldId xmlns:r="http://schemas.openxmlformats.org/officeDocument/2006/relationships" id="271" r:id="R7c4b7ad0f8dd4ddc"/>
-    <p:sldId xmlns:r="http://schemas.openxmlformats.org/officeDocument/2006/relationships" id="272" r:id="Re2e6b609530b4f73"/>
-    <p:sldId xmlns:r="http://schemas.openxmlformats.org/officeDocument/2006/relationships" id="273" r:id="R9fe13a894b2145d0"/>
+    <p:sldId xmlns:r="http://schemas.openxmlformats.org/officeDocument/2006/relationships" id="256" r:id="R8d79d93590fe475c"/>
+    <p:sldId xmlns:r="http://schemas.openxmlformats.org/officeDocument/2006/relationships" id="257" r:id="R79a1547025724a35"/>
+    <p:sldId xmlns:r="http://schemas.openxmlformats.org/officeDocument/2006/relationships" id="258" r:id="R1bf3ff047ab54439"/>
+    <p:sldId xmlns:r="http://schemas.openxmlformats.org/officeDocument/2006/relationships" id="259" r:id="R745949bac3ef47f2"/>
+    <p:sldId xmlns:r="http://schemas.openxmlformats.org/officeDocument/2006/relationships" id="260" r:id="R701b544c6ff34fc3"/>
+    <p:sldId xmlns:r="http://schemas.openxmlformats.org/officeDocument/2006/relationships" id="261" r:id="R0b9bf305b6954c3d"/>
+    <p:sldId xmlns:r="http://schemas.openxmlformats.org/officeDocument/2006/relationships" id="262" r:id="R2148578dfe9040a7"/>
+    <p:sldId xmlns:r="http://schemas.openxmlformats.org/officeDocument/2006/relationships" id="263" r:id="R5251335c4aec48c0"/>
+    <p:sldId xmlns:r="http://schemas.openxmlformats.org/officeDocument/2006/relationships" id="264" r:id="Rb89219f37c58464f"/>
+    <p:sldId xmlns:r="http://schemas.openxmlformats.org/officeDocument/2006/relationships" id="265" r:id="R2f3f43abda3b4448"/>
+    <p:sldId xmlns:r="http://schemas.openxmlformats.org/officeDocument/2006/relationships" id="266" r:id="R1c3a8f1366c842a8"/>
+    <p:sldId xmlns:r="http://schemas.openxmlformats.org/officeDocument/2006/relationships" id="267" r:id="R200642ed07af4784"/>
+    <p:sldId xmlns:r="http://schemas.openxmlformats.org/officeDocument/2006/relationships" id="268" r:id="Redf122642a2043fa"/>
+    <p:sldId xmlns:r="http://schemas.openxmlformats.org/officeDocument/2006/relationships" id="269" r:id="R4d51d750cc504276"/>
+    <p:sldId xmlns:r="http://schemas.openxmlformats.org/officeDocument/2006/relationships" id="270" r:id="Ra563284621f44edf"/>
+    <p:sldId xmlns:r="http://schemas.openxmlformats.org/officeDocument/2006/relationships" id="271" r:id="Rcd1871f22fd94d3a"/>
+    <p:sldId xmlns:r="http://schemas.openxmlformats.org/officeDocument/2006/relationships" id="272" r:id="R42d473ca427a4388"/>
+    <p:sldId xmlns:r="http://schemas.openxmlformats.org/officeDocument/2006/relationships" id="273" r:id="Rb80755d3b5dd4559"/>
   </p:sldIdLst>
   <p:sldSz cx="12192000" cy="6858000"/>
   <p:notesSz cx="6858000" cy="9144000"/>
@@ -1694,7 +1694,7 @@
   </p:cSld>
   <p:clrMap bg1="lt1" tx1="dk1" bg2="lt2" tx2="dk2" accent1="accent1" accent2="accent2" accent3="accent3" accent4="accent4" accent5="accent5" accent6="accent6" hlink="hlink" folHlink="folHlink"/>
   <p:sldLayoutIdLst>
-    <p:sldLayoutId xmlns:r="http://schemas.openxmlformats.org/officeDocument/2006/relationships" id="2147483649" r:id="R45920e50d81a4916"/>
+    <p:sldLayoutId xmlns:r="http://schemas.openxmlformats.org/officeDocument/2006/relationships" id="2147483649" r:id="Ra63a5442513d4189"/>
   </p:sldLayoutIdLst>
   <p:txStyles>
     <p:titleStyle>
@@ -2192,7 +2192,7 @@
           <p:cNvPr id="1" name="">
             <a:extLst xmlns:a="http://schemas.openxmlformats.org/drawingml/2006/main">
               <a:ext uri="{FF2B5EF4-FFF2-40B4-BE49-F238E27FC236}">
-                <a16:creationId xmlns:a16="http://schemas.microsoft.com/office/drawing/2014/main" id="{B35BF8B6-78F4-4A3D-8924-6AC241DB412C}"/>
+                <a16:creationId xmlns:a16="http://schemas.microsoft.com/office/drawing/2014/main" id="{7024000B-08A8-477B-BCA2-AB78AE3FCAFE}"/>
               </a:ext>
             </a:extLst>
           </p:cNvPr>
@@ -2225,7 +2225,7 @@
           <p:cNvPr id="2" name="">
             <a:extLst xmlns:a="http://schemas.openxmlformats.org/drawingml/2006/main">
               <a:ext uri="{FF2B5EF4-FFF2-40B4-BE49-F238E27FC236}">
-                <a16:creationId xmlns:a16="http://schemas.microsoft.com/office/drawing/2014/main" id="{C52B8DC0-FD27-4CC2-A416-D7F838E04A01}"/>
+                <a16:creationId xmlns:a16="http://schemas.microsoft.com/office/drawing/2014/main" id="{8262DF5A-E5F3-4092-81BE-E32C6CD6CB47}"/>
               </a:ext>
             </a:extLst>
           </p:cNvPr>
@@ -2258,7 +2258,7 @@
           <p:cNvPr id="3" name="">
             <a:extLst xmlns:a="http://schemas.openxmlformats.org/drawingml/2006/main">
               <a:ext uri="{FF2B5EF4-FFF2-40B4-BE49-F238E27FC236}">
-                <a16:creationId xmlns:a16="http://schemas.microsoft.com/office/drawing/2014/main" id="{38B7A004-F0A5-463F-9F0E-0FC9408EAB36}"/>
+                <a16:creationId xmlns:a16="http://schemas.microsoft.com/office/drawing/2014/main" id="{9289742B-CB25-4174-9651-F79B72A49D0C}"/>
               </a:ext>
             </a:extLst>
           </p:cNvPr>
@@ -2322,7 +2322,7 @@
           <p:cNvPr id="4" name="">
             <a:extLst xmlns:a="http://schemas.openxmlformats.org/drawingml/2006/main">
               <a:ext uri="{FF2B5EF4-FFF2-40B4-BE49-F238E27FC236}">
-                <a16:creationId xmlns:a16="http://schemas.microsoft.com/office/drawing/2014/main" id="{D8BB2694-7165-4C59-824E-1D10C094F5C2}"/>
+                <a16:creationId xmlns:a16="http://schemas.microsoft.com/office/drawing/2014/main" id="{062E8DB0-94C1-46B9-B531-487BEBF63459}"/>
               </a:ext>
             </a:extLst>
           </p:cNvPr>
@@ -2386,7 +2386,7 @@
           <p:cNvPr id="5" name="">
             <a:extLst xmlns:a="http://schemas.openxmlformats.org/drawingml/2006/main">
               <a:ext uri="{FF2B5EF4-FFF2-40B4-BE49-F238E27FC236}">
-                <a16:creationId xmlns:a16="http://schemas.microsoft.com/office/drawing/2014/main" id="{E821A612-A055-4EB5-B6C4-DF6CF9009A6C}"/>
+                <a16:creationId xmlns:a16="http://schemas.microsoft.com/office/drawing/2014/main" id="{5EE43105-3ACF-49DA-A759-F21A184B0DAC}"/>
               </a:ext>
             </a:extLst>
           </p:cNvPr>
@@ -2419,7 +2419,7 @@
           <p:cNvPr id="6" name="">
             <a:extLst xmlns:a="http://schemas.openxmlformats.org/drawingml/2006/main">
               <a:ext uri="{FF2B5EF4-FFF2-40B4-BE49-F238E27FC236}">
-                <a16:creationId xmlns:a16="http://schemas.microsoft.com/office/drawing/2014/main" id="{5FF4374C-C301-4A5D-A406-91EEB06E0423}"/>
+                <a16:creationId xmlns:a16="http://schemas.microsoft.com/office/drawing/2014/main" id="{E24F6A60-8EE8-48D4-8347-0EC38B3A01B4}"/>
               </a:ext>
             </a:extLst>
           </p:cNvPr>
@@ -2452,7 +2452,7 @@
           <p:cNvPr id="7" name="">
             <a:extLst xmlns:a="http://schemas.openxmlformats.org/drawingml/2006/main">
               <a:ext uri="{FF2B5EF4-FFF2-40B4-BE49-F238E27FC236}">
-                <a16:creationId xmlns:a16="http://schemas.microsoft.com/office/drawing/2014/main" id="{DC3E3648-75E7-47DD-B7B4-2D82CB1454F9}"/>
+                <a16:creationId xmlns:a16="http://schemas.microsoft.com/office/drawing/2014/main" id="{65F35E72-A77E-4BFA-A1AF-3298C3FB392B}"/>
               </a:ext>
             </a:extLst>
           </p:cNvPr>
@@ -2516,7 +2516,7 @@
           <p:cNvPr id="8" name="">
             <a:extLst xmlns:a="http://schemas.openxmlformats.org/drawingml/2006/main">
               <a:ext uri="{FF2B5EF4-FFF2-40B4-BE49-F238E27FC236}">
-                <a16:creationId xmlns:a16="http://schemas.microsoft.com/office/drawing/2014/main" id="{BA22E01A-B233-4C46-A55E-B038778666F8}"/>
+                <a16:creationId xmlns:a16="http://schemas.microsoft.com/office/drawing/2014/main" id="{28726E05-7120-4BBF-A17C-2950940BDF58}"/>
               </a:ext>
             </a:extLst>
           </p:cNvPr>
@@ -2580,7 +2580,7 @@
           <p:cNvPr id="9" name="">
             <a:extLst xmlns:a="http://schemas.openxmlformats.org/drawingml/2006/main">
               <a:ext uri="{FF2B5EF4-FFF2-40B4-BE49-F238E27FC236}">
-                <a16:creationId xmlns:a16="http://schemas.microsoft.com/office/drawing/2014/main" id="{5B294328-44B6-47FF-BE97-54D8D989DEE6}"/>
+                <a16:creationId xmlns:a16="http://schemas.microsoft.com/office/drawing/2014/main" id="{CDB611C3-EA1C-48D1-8628-A43711115B61}"/>
               </a:ext>
             </a:extLst>
           </p:cNvPr>
@@ -2613,7 +2613,7 @@
           <p:cNvPr id="10" name="">
             <a:extLst xmlns:a="http://schemas.openxmlformats.org/drawingml/2006/main">
               <a:ext uri="{FF2B5EF4-FFF2-40B4-BE49-F238E27FC236}">
-                <a16:creationId xmlns:a16="http://schemas.microsoft.com/office/drawing/2014/main" id="{6C511165-40DC-4D71-BFEC-A30EA79817A2}"/>
+                <a16:creationId xmlns:a16="http://schemas.microsoft.com/office/drawing/2014/main" id="{61518698-5C34-4D29-91C2-6A05727F1D94}"/>
               </a:ext>
             </a:extLst>
           </p:cNvPr>
@@ -2677,7 +2677,7 @@
           <p:cNvPr id="11" name="">
             <a:extLst xmlns:a="http://schemas.openxmlformats.org/drawingml/2006/main">
               <a:ext uri="{FF2B5EF4-FFF2-40B4-BE49-F238E27FC236}">
-                <a16:creationId xmlns:a16="http://schemas.microsoft.com/office/drawing/2014/main" id="{1AA2366A-3A58-483A-9CAA-FFC57BEC4C23}"/>
+                <a16:creationId xmlns:a16="http://schemas.microsoft.com/office/drawing/2014/main" id="{8F79BF80-475F-4F1A-A237-6D9DCA7C958B}"/>
               </a:ext>
             </a:extLst>
           </p:cNvPr>
@@ -2741,7 +2741,7 @@
           <p:cNvPr id="12" name="">
             <a:extLst xmlns:a="http://schemas.openxmlformats.org/drawingml/2006/main">
               <a:ext uri="{FF2B5EF4-FFF2-40B4-BE49-F238E27FC236}">
-                <a16:creationId xmlns:a16="http://schemas.microsoft.com/office/drawing/2014/main" id="{C612C7A9-BB9D-45BB-B3E2-C8B33CACA4A0}"/>
+                <a16:creationId xmlns:a16="http://schemas.microsoft.com/office/drawing/2014/main" id="{34970671-773F-4DB2-B79E-DB2AC1579113}"/>
               </a:ext>
             </a:extLst>
           </p:cNvPr>
@@ -2774,7 +2774,7 @@
           <p:cNvPr id="13" name="">
             <a:extLst xmlns:a="http://schemas.openxmlformats.org/drawingml/2006/main">
               <a:ext uri="{FF2B5EF4-FFF2-40B4-BE49-F238E27FC236}">
-                <a16:creationId xmlns:a16="http://schemas.microsoft.com/office/drawing/2014/main" id="{77C8734A-315E-4DE9-BFF5-BFF5F08F1C28}"/>
+                <a16:creationId xmlns:a16="http://schemas.microsoft.com/office/drawing/2014/main" id="{8C40727C-CFFA-4CF7-B125-E579200CE377}"/>
               </a:ext>
             </a:extLst>
           </p:cNvPr>
@@ -2838,7 +2838,7 @@
           <p:cNvPr id="14" name="">
             <a:extLst xmlns:a="http://schemas.openxmlformats.org/drawingml/2006/main">
               <a:ext uri="{FF2B5EF4-FFF2-40B4-BE49-F238E27FC236}">
-                <a16:creationId xmlns:a16="http://schemas.microsoft.com/office/drawing/2014/main" id="{AE0B1E17-30DE-4013-AB9A-16DB7206139F}"/>
+                <a16:creationId xmlns:a16="http://schemas.microsoft.com/office/drawing/2014/main" id="{049A35B1-B765-4AE7-8580-DA3198ED380A}"/>
               </a:ext>
             </a:extLst>
           </p:cNvPr>
@@ -2902,7 +2902,7 @@
           <p:cNvPr id="15" name="">
             <a:extLst xmlns:a="http://schemas.openxmlformats.org/drawingml/2006/main">
               <a:ext uri="{FF2B5EF4-FFF2-40B4-BE49-F238E27FC236}">
-                <a16:creationId xmlns:a16="http://schemas.microsoft.com/office/drawing/2014/main" id="{8ED4DC57-86E7-4178-A656-9BA8066D8E17}"/>
+                <a16:creationId xmlns:a16="http://schemas.microsoft.com/office/drawing/2014/main" id="{1AE4FEA1-A9E0-4797-A293-62977D362EFF}"/>
               </a:ext>
             </a:extLst>
           </p:cNvPr>
@@ -2935,7 +2935,7 @@
           <p:cNvPr id="16" name="">
             <a:extLst xmlns:a="http://schemas.openxmlformats.org/drawingml/2006/main">
               <a:ext uri="{FF2B5EF4-FFF2-40B4-BE49-F238E27FC236}">
-                <a16:creationId xmlns:a16="http://schemas.microsoft.com/office/drawing/2014/main" id="{6099880B-4D95-4090-9902-855AE735F61D}"/>
+                <a16:creationId xmlns:a16="http://schemas.microsoft.com/office/drawing/2014/main" id="{D3318D82-0290-4F7D-AD1F-E4C81012CDA7}"/>
               </a:ext>
             </a:extLst>
           </p:cNvPr>
@@ -2999,7 +2999,7 @@
           <p:cNvPr id="17" name="">
             <a:extLst xmlns:a="http://schemas.openxmlformats.org/drawingml/2006/main">
               <a:ext uri="{FF2B5EF4-FFF2-40B4-BE49-F238E27FC236}">
-                <a16:creationId xmlns:a16="http://schemas.microsoft.com/office/drawing/2014/main" id="{12695202-9E8C-41C5-9B34-F037810BFB1C}"/>
+                <a16:creationId xmlns:a16="http://schemas.microsoft.com/office/drawing/2014/main" id="{0DD8251A-040A-4A9E-85FC-2C5068EA94A2}"/>
               </a:ext>
             </a:extLst>
           </p:cNvPr>
@@ -3063,7 +3063,7 @@
           <p:cNvPr id="18" name="">
             <a:extLst xmlns:a="http://schemas.openxmlformats.org/drawingml/2006/main">
               <a:ext uri="{FF2B5EF4-FFF2-40B4-BE49-F238E27FC236}">
-                <a16:creationId xmlns:a16="http://schemas.microsoft.com/office/drawing/2014/main" id="{08BE522D-75F9-46D1-A5DB-ADDB66A2F95A}"/>
+                <a16:creationId xmlns:a16="http://schemas.microsoft.com/office/drawing/2014/main" id="{D97674FE-F945-4AE0-9791-3DAFEAB2091E}"/>
               </a:ext>
             </a:extLst>
           </p:cNvPr>
@@ -3096,7 +3096,7 @@
           <p:cNvPr id="19" name="">
             <a:extLst xmlns:a="http://schemas.openxmlformats.org/drawingml/2006/main">
               <a:ext uri="{FF2B5EF4-FFF2-40B4-BE49-F238E27FC236}">
-                <a16:creationId xmlns:a16="http://schemas.microsoft.com/office/drawing/2014/main" id="{4CA95105-5709-4C19-BDD9-9061016286C7}"/>
+                <a16:creationId xmlns:a16="http://schemas.microsoft.com/office/drawing/2014/main" id="{1D36C3CB-BFFA-4836-8D64-0A4EB5F24728}"/>
               </a:ext>
             </a:extLst>
           </p:cNvPr>
@@ -3160,7 +3160,7 @@
           <p:cNvPr id="20" name="">
             <a:extLst xmlns:a="http://schemas.openxmlformats.org/drawingml/2006/main">
               <a:ext uri="{FF2B5EF4-FFF2-40B4-BE49-F238E27FC236}">
-                <a16:creationId xmlns:a16="http://schemas.microsoft.com/office/drawing/2014/main" id="{D32C6E7C-9BCE-4ABE-B886-32665C79A291}"/>
+                <a16:creationId xmlns:a16="http://schemas.microsoft.com/office/drawing/2014/main" id="{EB2E85FD-4448-47BC-B024-BE5585059161}"/>
               </a:ext>
             </a:extLst>
           </p:cNvPr>
@@ -3193,7 +3193,7 @@
           <p:cNvPr id="21" name="">
             <a:extLst xmlns:a="http://schemas.openxmlformats.org/drawingml/2006/main">
               <a:ext uri="{FF2B5EF4-FFF2-40B4-BE49-F238E27FC236}">
-                <a16:creationId xmlns:a16="http://schemas.microsoft.com/office/drawing/2014/main" id="{A27E987E-6A1F-44BD-9E06-4ADC9EB8AFB6}"/>
+                <a16:creationId xmlns:a16="http://schemas.microsoft.com/office/drawing/2014/main" id="{B72F75AE-C9C2-4DF7-8994-98E9BF07B990}"/>
               </a:ext>
             </a:extLst>
           </p:cNvPr>
@@ -3257,7 +3257,7 @@
           <p:cNvPr id="22" name="">
             <a:extLst xmlns:a="http://schemas.openxmlformats.org/drawingml/2006/main">
               <a:ext uri="{FF2B5EF4-FFF2-40B4-BE49-F238E27FC236}">
-                <a16:creationId xmlns:a16="http://schemas.microsoft.com/office/drawing/2014/main" id="{A5207D97-E3A1-4DBB-B486-7B42C3C72450}"/>
+                <a16:creationId xmlns:a16="http://schemas.microsoft.com/office/drawing/2014/main" id="{C637890B-5D95-459A-AFD3-B883F369433F}"/>
               </a:ext>
             </a:extLst>
           </p:cNvPr>
@@ -3290,7 +3290,7 @@
           <p:cNvPr id="23" name="">
             <a:extLst xmlns:a="http://schemas.openxmlformats.org/drawingml/2006/main">
               <a:ext uri="{FF2B5EF4-FFF2-40B4-BE49-F238E27FC236}">
-                <a16:creationId xmlns:a16="http://schemas.microsoft.com/office/drawing/2014/main" id="{CC016B6C-8FA7-4C90-BED3-B31CEACCBFDB}"/>
+                <a16:creationId xmlns:a16="http://schemas.microsoft.com/office/drawing/2014/main" id="{16093573-0EBB-4C3C-A4D1-741B752E1ABA}"/>
               </a:ext>
             </a:extLst>
           </p:cNvPr>
@@ -3354,7 +3354,7 @@
           <p:cNvPr id="24" name="">
             <a:extLst xmlns:a="http://schemas.openxmlformats.org/drawingml/2006/main">
               <a:ext uri="{FF2B5EF4-FFF2-40B4-BE49-F238E27FC236}">
-                <a16:creationId xmlns:a16="http://schemas.microsoft.com/office/drawing/2014/main" id="{280D5D5A-0920-44B7-BE28-3DE4CD6C4FE1}"/>
+                <a16:creationId xmlns:a16="http://schemas.microsoft.com/office/drawing/2014/main" id="{7EE3F6A6-1529-44F8-ABDB-6C62EFEDF556}"/>
               </a:ext>
             </a:extLst>
           </p:cNvPr>
@@ -3387,7 +3387,7 @@
           <p:cNvPr id="25" name="">
             <a:extLst xmlns:a="http://schemas.openxmlformats.org/drawingml/2006/main">
               <a:ext uri="{FF2B5EF4-FFF2-40B4-BE49-F238E27FC236}">
-                <a16:creationId xmlns:a16="http://schemas.microsoft.com/office/drawing/2014/main" id="{3F359A28-FA07-4F92-A83F-7B4587831D8B}"/>
+                <a16:creationId xmlns:a16="http://schemas.microsoft.com/office/drawing/2014/main" id="{ABD42D75-8520-4740-9576-986AD9225E5C}"/>
               </a:ext>
             </a:extLst>
           </p:cNvPr>
@@ -3451,7 +3451,7 @@
           <p:cNvPr id="26" name="">
             <a:extLst xmlns:a="http://schemas.openxmlformats.org/drawingml/2006/main">
               <a:ext uri="{FF2B5EF4-FFF2-40B4-BE49-F238E27FC236}">
-                <a16:creationId xmlns:a16="http://schemas.microsoft.com/office/drawing/2014/main" id="{FD428C36-4BF8-4B44-AAE3-E69810B046CA}"/>
+                <a16:creationId xmlns:a16="http://schemas.microsoft.com/office/drawing/2014/main" id="{982BBD56-04AB-48A4-AF24-76ACF4D7ED97}"/>
               </a:ext>
             </a:extLst>
           </p:cNvPr>
@@ -3484,7 +3484,7 @@
           <p:cNvPr id="27" name="">
             <a:extLst xmlns:a="http://schemas.openxmlformats.org/drawingml/2006/main">
               <a:ext uri="{FF2B5EF4-FFF2-40B4-BE49-F238E27FC236}">
-                <a16:creationId xmlns:a16="http://schemas.microsoft.com/office/drawing/2014/main" id="{49EF5AD5-BD13-47BD-8A26-CC9291D66BA3}"/>
+                <a16:creationId xmlns:a16="http://schemas.microsoft.com/office/drawing/2014/main" id="{CA04A76A-5A6F-4ACF-8389-FB821724914E}"/>
               </a:ext>
             </a:extLst>
           </p:cNvPr>
@@ -3548,7 +3548,7 @@
           <p:cNvPr id="28" name="">
             <a:extLst xmlns:a="http://schemas.openxmlformats.org/drawingml/2006/main">
               <a:ext uri="{FF2B5EF4-FFF2-40B4-BE49-F238E27FC236}">
-                <a16:creationId xmlns:a16="http://schemas.microsoft.com/office/drawing/2014/main" id="{790251F2-8989-471C-80B4-6E403F0A3E7B}"/>
+                <a16:creationId xmlns:a16="http://schemas.microsoft.com/office/drawing/2014/main" id="{987EA59E-0D5A-49B9-8578-DDA6B3855D06}"/>
               </a:ext>
             </a:extLst>
           </p:cNvPr>
@@ -3612,7 +3612,7 @@
           <p:cNvPr id="29" name="">
             <a:extLst xmlns:a="http://schemas.openxmlformats.org/drawingml/2006/main">
               <a:ext uri="{FF2B5EF4-FFF2-40B4-BE49-F238E27FC236}">
-                <a16:creationId xmlns:a16="http://schemas.microsoft.com/office/drawing/2014/main" id="{28786D68-03A7-4C07-B9BF-997B11416104}"/>
+                <a16:creationId xmlns:a16="http://schemas.microsoft.com/office/drawing/2014/main" id="{47A36635-1230-4A49-B2F3-81568527F078}"/>
               </a:ext>
             </a:extLst>
           </p:cNvPr>
@@ -3674,7 +3674,7 @@
     </p:spTree>
     <p:extLst>
       <p:ext uri="{BB962C8B-B14F-4D97-AF65-F5344CB8AC3E}">
-        <p14:creationId xmlns:p14="http://schemas.microsoft.com/office/powerpoint/2010/main" val="341617460"/>
+        <p14:creationId xmlns:p14="http://schemas.microsoft.com/office/powerpoint/2010/main" val="8427515"/>
       </p:ext>
     </p:extLst>
   </p:cSld>
@@ -3698,7 +3698,7 @@
           <p:cNvPr id="1" name="">
             <a:extLst xmlns:a="http://schemas.openxmlformats.org/drawingml/2006/main">
               <a:ext uri="{FF2B5EF4-FFF2-40B4-BE49-F238E27FC236}">
-                <a16:creationId xmlns:a16="http://schemas.microsoft.com/office/drawing/2014/main" id="{7B59F911-D1DA-474F-BDFF-A3A1D019576C}"/>
+                <a16:creationId xmlns:a16="http://schemas.microsoft.com/office/drawing/2014/main" id="{0421BBF7-C0A1-4072-93C7-57C962C2EDE9}"/>
               </a:ext>
             </a:extLst>
           </p:cNvPr>
@@ -3731,7 +3731,7 @@
           <p:cNvPr id="2" name="">
             <a:extLst xmlns:a="http://schemas.openxmlformats.org/drawingml/2006/main">
               <a:ext uri="{FF2B5EF4-FFF2-40B4-BE49-F238E27FC236}">
-                <a16:creationId xmlns:a16="http://schemas.microsoft.com/office/drawing/2014/main" id="{F83DCCA9-7703-414C-88FB-26328E2D0AF3}"/>
+                <a16:creationId xmlns:a16="http://schemas.microsoft.com/office/drawing/2014/main" id="{7724EDC9-D4F8-44A1-AB71-132F81DC1121}"/>
               </a:ext>
             </a:extLst>
           </p:cNvPr>
@@ -3764,7 +3764,7 @@
           <p:cNvPr id="3" name="">
             <a:extLst xmlns:a="http://schemas.openxmlformats.org/drawingml/2006/main">
               <a:ext uri="{FF2B5EF4-FFF2-40B4-BE49-F238E27FC236}">
-                <a16:creationId xmlns:a16="http://schemas.microsoft.com/office/drawing/2014/main" id="{C1D0EE22-96CC-4EAD-9D48-F3191389E39A}"/>
+                <a16:creationId xmlns:a16="http://schemas.microsoft.com/office/drawing/2014/main" id="{9F2FAE58-0B6A-415D-AA76-2EEF064E0754}"/>
               </a:ext>
             </a:extLst>
           </p:cNvPr>
@@ -3828,7 +3828,7 @@
           <p:cNvPr id="4" name="">
             <a:extLst xmlns:a="http://schemas.openxmlformats.org/drawingml/2006/main">
               <a:ext uri="{FF2B5EF4-FFF2-40B4-BE49-F238E27FC236}">
-                <a16:creationId xmlns:a16="http://schemas.microsoft.com/office/drawing/2014/main" id="{B67D0673-0A78-467E-BE40-3D81049B3106}"/>
+                <a16:creationId xmlns:a16="http://schemas.microsoft.com/office/drawing/2014/main" id="{B378BCB6-C7A9-4DE7-9EE8-8C7221D20BD5}"/>
               </a:ext>
             </a:extLst>
           </p:cNvPr>
@@ -3892,7 +3892,7 @@
           <p:cNvPr id="5" name="">
             <a:extLst xmlns:a="http://schemas.openxmlformats.org/drawingml/2006/main">
               <a:ext uri="{FF2B5EF4-FFF2-40B4-BE49-F238E27FC236}">
-                <a16:creationId xmlns:a16="http://schemas.microsoft.com/office/drawing/2014/main" id="{C11BDDB0-2C0F-4343-A2B0-6DFC500DAB93}"/>
+                <a16:creationId xmlns:a16="http://schemas.microsoft.com/office/drawing/2014/main" id="{2DFC97EF-4E44-4FF0-94C2-86356EA984B4}"/>
               </a:ext>
             </a:extLst>
           </p:cNvPr>
@@ -3925,7 +3925,7 @@
           <p:cNvPr id="6" name="">
             <a:extLst xmlns:a="http://schemas.openxmlformats.org/drawingml/2006/main">
               <a:ext uri="{FF2B5EF4-FFF2-40B4-BE49-F238E27FC236}">
-                <a16:creationId xmlns:a16="http://schemas.microsoft.com/office/drawing/2014/main" id="{710862B4-B579-4CE0-8C9A-3DC041245BD6}"/>
+                <a16:creationId xmlns:a16="http://schemas.microsoft.com/office/drawing/2014/main" id="{22E2A748-F09C-4551-B9FB-54592254DCC6}"/>
               </a:ext>
             </a:extLst>
           </p:cNvPr>
@@ -3958,7 +3958,7 @@
           <p:cNvPr id="7" name="">
             <a:extLst xmlns:a="http://schemas.openxmlformats.org/drawingml/2006/main">
               <a:ext uri="{FF2B5EF4-FFF2-40B4-BE49-F238E27FC236}">
-                <a16:creationId xmlns:a16="http://schemas.microsoft.com/office/drawing/2014/main" id="{FF0FBA9D-362F-4BA6-83ED-BEEE661420E8}"/>
+                <a16:creationId xmlns:a16="http://schemas.microsoft.com/office/drawing/2014/main" id="{4A61A1A0-322D-49EF-B0D8-599A3EA7C802}"/>
               </a:ext>
             </a:extLst>
           </p:cNvPr>
@@ -4022,7 +4022,7 @@
           <p:cNvPr id="8" name="">
             <a:extLst xmlns:a="http://schemas.openxmlformats.org/drawingml/2006/main">
               <a:ext uri="{FF2B5EF4-FFF2-40B4-BE49-F238E27FC236}">
-                <a16:creationId xmlns:a16="http://schemas.microsoft.com/office/drawing/2014/main" id="{8FD10A15-07A0-41F9-9ECC-BB28FF527846}"/>
+                <a16:creationId xmlns:a16="http://schemas.microsoft.com/office/drawing/2014/main" id="{0F090D74-6249-47EA-BC7C-55EF4F156EB2}"/>
               </a:ext>
             </a:extLst>
           </p:cNvPr>
@@ -4055,7 +4055,7 @@
           <p:cNvPr id="9" name="">
             <a:extLst xmlns:a="http://schemas.openxmlformats.org/drawingml/2006/main">
               <a:ext uri="{FF2B5EF4-FFF2-40B4-BE49-F238E27FC236}">
-                <a16:creationId xmlns:a16="http://schemas.microsoft.com/office/drawing/2014/main" id="{06038487-2CB1-458B-AFC4-AD3B10DEA500}"/>
+                <a16:creationId xmlns:a16="http://schemas.microsoft.com/office/drawing/2014/main" id="{27280F51-6E23-4A2F-AE7D-3A6AC8BB4419}"/>
               </a:ext>
             </a:extLst>
           </p:cNvPr>
@@ -4119,7 +4119,7 @@
           <p:cNvPr id="10" name="">
             <a:extLst xmlns:a="http://schemas.openxmlformats.org/drawingml/2006/main">
               <a:ext uri="{FF2B5EF4-FFF2-40B4-BE49-F238E27FC236}">
-                <a16:creationId xmlns:a16="http://schemas.microsoft.com/office/drawing/2014/main" id="{3307D019-0F9A-4E7B-BF04-F2902D1DEF3D}"/>
+                <a16:creationId xmlns:a16="http://schemas.microsoft.com/office/drawing/2014/main" id="{1FA5A333-70EE-49BC-AE2D-186A685417AA}"/>
               </a:ext>
             </a:extLst>
           </p:cNvPr>
@@ -4152,7 +4152,7 @@
           <p:cNvPr id="11" name="">
             <a:extLst xmlns:a="http://schemas.openxmlformats.org/drawingml/2006/main">
               <a:ext uri="{FF2B5EF4-FFF2-40B4-BE49-F238E27FC236}">
-                <a16:creationId xmlns:a16="http://schemas.microsoft.com/office/drawing/2014/main" id="{A077DA73-2301-4EC1-B116-69F3B31B4D54}"/>
+                <a16:creationId xmlns:a16="http://schemas.microsoft.com/office/drawing/2014/main" id="{0BDC542D-0143-489A-909D-E507FCAA0EF8}"/>
               </a:ext>
             </a:extLst>
           </p:cNvPr>
@@ -4216,7 +4216,7 @@
           <p:cNvPr id="12" name="">
             <a:extLst xmlns:a="http://schemas.openxmlformats.org/drawingml/2006/main">
               <a:ext uri="{FF2B5EF4-FFF2-40B4-BE49-F238E27FC236}">
-                <a16:creationId xmlns:a16="http://schemas.microsoft.com/office/drawing/2014/main" id="{4A1D68F6-48C7-4A09-AB06-56A0E5FA4827}"/>
+                <a16:creationId xmlns:a16="http://schemas.microsoft.com/office/drawing/2014/main" id="{8D5A533C-5523-4067-AF21-1DC3C8CC80C9}"/>
               </a:ext>
             </a:extLst>
           </p:cNvPr>
@@ -4249,7 +4249,7 @@
           <p:cNvPr id="13" name="">
             <a:extLst xmlns:a="http://schemas.openxmlformats.org/drawingml/2006/main">
               <a:ext uri="{FF2B5EF4-FFF2-40B4-BE49-F238E27FC236}">
-                <a16:creationId xmlns:a16="http://schemas.microsoft.com/office/drawing/2014/main" id="{5BF85526-F3EB-49BA-8BD2-FACF11589823}"/>
+                <a16:creationId xmlns:a16="http://schemas.microsoft.com/office/drawing/2014/main" id="{EE20B45B-68B3-4954-B7DE-4A7E1A2BD71A}"/>
               </a:ext>
             </a:extLst>
           </p:cNvPr>
@@ -4313,7 +4313,7 @@
           <p:cNvPr id="14" name="">
             <a:extLst xmlns:a="http://schemas.openxmlformats.org/drawingml/2006/main">
               <a:ext uri="{FF2B5EF4-FFF2-40B4-BE49-F238E27FC236}">
-                <a16:creationId xmlns:a16="http://schemas.microsoft.com/office/drawing/2014/main" id="{2995A4C4-EB76-4E94-8E5E-3F97B6BAFA37}"/>
+                <a16:creationId xmlns:a16="http://schemas.microsoft.com/office/drawing/2014/main" id="{2D18FEEF-CECA-4844-93E2-64BC2A640D5C}"/>
               </a:ext>
             </a:extLst>
           </p:cNvPr>
@@ -4346,7 +4346,7 @@
           <p:cNvPr id="15" name="">
             <a:extLst xmlns:a="http://schemas.openxmlformats.org/drawingml/2006/main">
               <a:ext uri="{FF2B5EF4-FFF2-40B4-BE49-F238E27FC236}">
-                <a16:creationId xmlns:a16="http://schemas.microsoft.com/office/drawing/2014/main" id="{B3E39AEA-C811-4814-9EFE-A7C6675460C5}"/>
+                <a16:creationId xmlns:a16="http://schemas.microsoft.com/office/drawing/2014/main" id="{68D83C95-6D22-4C0A-B01B-5B6B0C87B163}"/>
               </a:ext>
             </a:extLst>
           </p:cNvPr>
@@ -4410,7 +4410,7 @@
           <p:cNvPr id="16" name="">
             <a:extLst xmlns:a="http://schemas.openxmlformats.org/drawingml/2006/main">
               <a:ext uri="{FF2B5EF4-FFF2-40B4-BE49-F238E27FC236}">
-                <a16:creationId xmlns:a16="http://schemas.microsoft.com/office/drawing/2014/main" id="{9056BDAD-A166-46B9-B9F9-FA06A243AD63}"/>
+                <a16:creationId xmlns:a16="http://schemas.microsoft.com/office/drawing/2014/main" id="{7FEB3238-5517-4869-857C-F4F8669A8C8C}"/>
               </a:ext>
             </a:extLst>
           </p:cNvPr>
@@ -4443,7 +4443,7 @@
           <p:cNvPr id="17" name="">
             <a:extLst xmlns:a="http://schemas.openxmlformats.org/drawingml/2006/main">
               <a:ext uri="{FF2B5EF4-FFF2-40B4-BE49-F238E27FC236}">
-                <a16:creationId xmlns:a16="http://schemas.microsoft.com/office/drawing/2014/main" id="{33675D56-F74C-4EDA-AF41-D4C7CE022113}"/>
+                <a16:creationId xmlns:a16="http://schemas.microsoft.com/office/drawing/2014/main" id="{8B2931C0-A4DE-4445-ABB7-D6408E317F22}"/>
               </a:ext>
             </a:extLst>
           </p:cNvPr>
@@ -4507,7 +4507,7 @@
           <p:cNvPr id="18" name="">
             <a:extLst xmlns:a="http://schemas.openxmlformats.org/drawingml/2006/main">
               <a:ext uri="{FF2B5EF4-FFF2-40B4-BE49-F238E27FC236}">
-                <a16:creationId xmlns:a16="http://schemas.microsoft.com/office/drawing/2014/main" id="{169159D7-FAB8-4609-BCA0-EC439616D4DE}"/>
+                <a16:creationId xmlns:a16="http://schemas.microsoft.com/office/drawing/2014/main" id="{53BE2549-411E-4AD6-B478-1D247411B610}"/>
               </a:ext>
             </a:extLst>
           </p:cNvPr>
@@ -4571,7 +4571,7 @@
           <p:cNvPr id="19" name="">
             <a:extLst xmlns:a="http://schemas.openxmlformats.org/drawingml/2006/main">
               <a:ext uri="{FF2B5EF4-FFF2-40B4-BE49-F238E27FC236}">
-                <a16:creationId xmlns:a16="http://schemas.microsoft.com/office/drawing/2014/main" id="{DEEC3CA5-50E9-4758-B18B-ABC0AA556163}"/>
+                <a16:creationId xmlns:a16="http://schemas.microsoft.com/office/drawing/2014/main" id="{C4F2FB9F-66AE-487F-B577-FACD4AE8AC45}"/>
               </a:ext>
             </a:extLst>
           </p:cNvPr>
@@ -4633,7 +4633,7 @@
     </p:spTree>
     <p:extLst>
       <p:ext uri="{BB962C8B-B14F-4D97-AF65-F5344CB8AC3E}">
-        <p14:creationId xmlns:p14="http://schemas.microsoft.com/office/powerpoint/2010/main" val="356513676"/>
+        <p14:creationId xmlns:p14="http://schemas.microsoft.com/office/powerpoint/2010/main" val="1962218869"/>
       </p:ext>
     </p:extLst>
   </p:cSld>
@@ -4657,7 +4657,7 @@
           <p:cNvPr id="1" name="">
             <a:extLst xmlns:a="http://schemas.openxmlformats.org/drawingml/2006/main">
               <a:ext uri="{FF2B5EF4-FFF2-40B4-BE49-F238E27FC236}">
-                <a16:creationId xmlns:a16="http://schemas.microsoft.com/office/drawing/2014/main" id="{681A1A0E-4A34-40A7-8593-881AA6DC91DA}"/>
+                <a16:creationId xmlns:a16="http://schemas.microsoft.com/office/drawing/2014/main" id="{30D41E84-E3FB-4344-AEDE-45F92EC616E1}"/>
               </a:ext>
             </a:extLst>
           </p:cNvPr>
@@ -4690,7 +4690,7 @@
           <p:cNvPr id="2" name="">
             <a:extLst xmlns:a="http://schemas.openxmlformats.org/drawingml/2006/main">
               <a:ext uri="{FF2B5EF4-FFF2-40B4-BE49-F238E27FC236}">
-                <a16:creationId xmlns:a16="http://schemas.microsoft.com/office/drawing/2014/main" id="{57C5D209-17C2-4C41-8602-B58D08210C8B}"/>
+                <a16:creationId xmlns:a16="http://schemas.microsoft.com/office/drawing/2014/main" id="{1D69BFB6-3716-446A-850F-E70B842C4F27}"/>
               </a:ext>
             </a:extLst>
           </p:cNvPr>
@@ -4723,7 +4723,7 @@
           <p:cNvPr id="3" name="">
             <a:extLst xmlns:a="http://schemas.openxmlformats.org/drawingml/2006/main">
               <a:ext uri="{FF2B5EF4-FFF2-40B4-BE49-F238E27FC236}">
-                <a16:creationId xmlns:a16="http://schemas.microsoft.com/office/drawing/2014/main" id="{B336A499-C126-46C7-A3C6-9361F0088A4C}"/>
+                <a16:creationId xmlns:a16="http://schemas.microsoft.com/office/drawing/2014/main" id="{0779B165-EEC3-451A-8FCF-6A6D63283A78}"/>
               </a:ext>
             </a:extLst>
           </p:cNvPr>
@@ -4787,7 +4787,7 @@
           <p:cNvPr id="4" name="">
             <a:extLst xmlns:a="http://schemas.openxmlformats.org/drawingml/2006/main">
               <a:ext uri="{FF2B5EF4-FFF2-40B4-BE49-F238E27FC236}">
-                <a16:creationId xmlns:a16="http://schemas.microsoft.com/office/drawing/2014/main" id="{BBA6FE07-06D0-4162-982F-A8C8C82DC358}"/>
+                <a16:creationId xmlns:a16="http://schemas.microsoft.com/office/drawing/2014/main" id="{1140FDB4-199E-44C4-B2FD-46F493163C8D}"/>
               </a:ext>
             </a:extLst>
           </p:cNvPr>
@@ -4851,7 +4851,7 @@
           <p:cNvPr id="5" name="">
             <a:extLst xmlns:a="http://schemas.openxmlformats.org/drawingml/2006/main">
               <a:ext uri="{FF2B5EF4-FFF2-40B4-BE49-F238E27FC236}">
-                <a16:creationId xmlns:a16="http://schemas.microsoft.com/office/drawing/2014/main" id="{4B494C65-B474-46E3-B19F-A7F3C8528AA4}"/>
+                <a16:creationId xmlns:a16="http://schemas.microsoft.com/office/drawing/2014/main" id="{73724613-A078-47FF-9AB2-1491AEFAA4C2}"/>
               </a:ext>
             </a:extLst>
           </p:cNvPr>
@@ -4884,7 +4884,7 @@
           <p:cNvPr id="6" name="">
             <a:extLst xmlns:a="http://schemas.openxmlformats.org/drawingml/2006/main">
               <a:ext uri="{FF2B5EF4-FFF2-40B4-BE49-F238E27FC236}">
-                <a16:creationId xmlns:a16="http://schemas.microsoft.com/office/drawing/2014/main" id="{62B0DA8D-4CEB-48B6-B9D1-8806ADF1DF4F}"/>
+                <a16:creationId xmlns:a16="http://schemas.microsoft.com/office/drawing/2014/main" id="{43C667D1-4D5A-4FE2-A36B-2C9781D24A46}"/>
               </a:ext>
             </a:extLst>
           </p:cNvPr>
@@ -4917,7 +4917,7 @@
           <p:cNvPr id="7" name="">
             <a:extLst xmlns:a="http://schemas.openxmlformats.org/drawingml/2006/main">
               <a:ext uri="{FF2B5EF4-FFF2-40B4-BE49-F238E27FC236}">
-                <a16:creationId xmlns:a16="http://schemas.microsoft.com/office/drawing/2014/main" id="{3FAF12B6-C9D6-4C22-A39C-67A7556B76E9}"/>
+                <a16:creationId xmlns:a16="http://schemas.microsoft.com/office/drawing/2014/main" id="{3AE1B85A-1C68-40A3-98C5-E529A90D8A2C}"/>
               </a:ext>
             </a:extLst>
           </p:cNvPr>
@@ -4981,7 +4981,7 @@
           <p:cNvPr id="8" name="">
             <a:extLst xmlns:a="http://schemas.openxmlformats.org/drawingml/2006/main">
               <a:ext uri="{FF2B5EF4-FFF2-40B4-BE49-F238E27FC236}">
-                <a16:creationId xmlns:a16="http://schemas.microsoft.com/office/drawing/2014/main" id="{6C5F082A-84C3-4C4C-91D5-E36FD4711BFC}"/>
+                <a16:creationId xmlns:a16="http://schemas.microsoft.com/office/drawing/2014/main" id="{29D554D2-035B-4CE3-8715-A0B7D66BAC67}"/>
               </a:ext>
             </a:extLst>
           </p:cNvPr>
@@ -5045,7 +5045,7 @@
           <p:cNvPr id="9" name="">
             <a:extLst xmlns:a="http://schemas.openxmlformats.org/drawingml/2006/main">
               <a:ext uri="{FF2B5EF4-FFF2-40B4-BE49-F238E27FC236}">
-                <a16:creationId xmlns:a16="http://schemas.microsoft.com/office/drawing/2014/main" id="{3C60470C-5D03-499B-8313-CB3E7D2F8577}"/>
+                <a16:creationId xmlns:a16="http://schemas.microsoft.com/office/drawing/2014/main" id="{3AB21C40-931D-450B-9C11-6561D6F76DC8}"/>
               </a:ext>
             </a:extLst>
           </p:cNvPr>
@@ -5078,7 +5078,7 @@
           <p:cNvPr id="10" name="">
             <a:extLst xmlns:a="http://schemas.openxmlformats.org/drawingml/2006/main">
               <a:ext uri="{FF2B5EF4-FFF2-40B4-BE49-F238E27FC236}">
-                <a16:creationId xmlns:a16="http://schemas.microsoft.com/office/drawing/2014/main" id="{EB918C2A-0BDA-4F18-88BE-7A4670EECCC8}"/>
+                <a16:creationId xmlns:a16="http://schemas.microsoft.com/office/drawing/2014/main" id="{ED77449F-90AB-4962-94CA-72BE46652FD3}"/>
               </a:ext>
             </a:extLst>
           </p:cNvPr>
@@ -5142,7 +5142,7 @@
           <p:cNvPr id="11" name="">
             <a:extLst xmlns:a="http://schemas.openxmlformats.org/drawingml/2006/main">
               <a:ext uri="{FF2B5EF4-FFF2-40B4-BE49-F238E27FC236}">
-                <a16:creationId xmlns:a16="http://schemas.microsoft.com/office/drawing/2014/main" id="{6C8F57A4-A201-4BFE-99F7-D3EEED1A8AF7}"/>
+                <a16:creationId xmlns:a16="http://schemas.microsoft.com/office/drawing/2014/main" id="{0CE7B341-D2A3-47C4-85B8-0B3F0219932D}"/>
               </a:ext>
             </a:extLst>
           </p:cNvPr>
@@ -5206,7 +5206,7 @@
           <p:cNvPr id="12" name="">
             <a:extLst xmlns:a="http://schemas.openxmlformats.org/drawingml/2006/main">
               <a:ext uri="{FF2B5EF4-FFF2-40B4-BE49-F238E27FC236}">
-                <a16:creationId xmlns:a16="http://schemas.microsoft.com/office/drawing/2014/main" id="{C44AA5F4-21AB-42CC-A3D4-1BA4CF2CB8F8}"/>
+                <a16:creationId xmlns:a16="http://schemas.microsoft.com/office/drawing/2014/main" id="{7D19D466-F0F5-4577-9C1D-59F715C7512B}"/>
               </a:ext>
             </a:extLst>
           </p:cNvPr>
@@ -5239,7 +5239,7 @@
           <p:cNvPr id="13" name="">
             <a:extLst xmlns:a="http://schemas.openxmlformats.org/drawingml/2006/main">
               <a:ext uri="{FF2B5EF4-FFF2-40B4-BE49-F238E27FC236}">
-                <a16:creationId xmlns:a16="http://schemas.microsoft.com/office/drawing/2014/main" id="{FE9739E6-B5A7-4E70-BF15-146FC7295F62}"/>
+                <a16:creationId xmlns:a16="http://schemas.microsoft.com/office/drawing/2014/main" id="{9BA840E9-C86D-4722-B378-CB5E53B4E9A6}"/>
               </a:ext>
             </a:extLst>
           </p:cNvPr>
@@ -5303,7 +5303,7 @@
           <p:cNvPr id="14" name="">
             <a:extLst xmlns:a="http://schemas.openxmlformats.org/drawingml/2006/main">
               <a:ext uri="{FF2B5EF4-FFF2-40B4-BE49-F238E27FC236}">
-                <a16:creationId xmlns:a16="http://schemas.microsoft.com/office/drawing/2014/main" id="{6B35F658-8667-4783-B526-7FA029D555DD}"/>
+                <a16:creationId xmlns:a16="http://schemas.microsoft.com/office/drawing/2014/main" id="{0352EC0F-C384-49F8-820D-BE11017728B9}"/>
               </a:ext>
             </a:extLst>
           </p:cNvPr>
@@ -5367,7 +5367,7 @@
           <p:cNvPr id="15" name="">
             <a:extLst xmlns:a="http://schemas.openxmlformats.org/drawingml/2006/main">
               <a:ext uri="{FF2B5EF4-FFF2-40B4-BE49-F238E27FC236}">
-                <a16:creationId xmlns:a16="http://schemas.microsoft.com/office/drawing/2014/main" id="{16CB080D-BF9C-463E-B4FF-C6764F7209E2}"/>
+                <a16:creationId xmlns:a16="http://schemas.microsoft.com/office/drawing/2014/main" id="{E57B5028-300A-49D5-897E-7F381C5502EE}"/>
               </a:ext>
             </a:extLst>
           </p:cNvPr>
@@ -5400,7 +5400,7 @@
           <p:cNvPr id="16" name="">
             <a:extLst xmlns:a="http://schemas.openxmlformats.org/drawingml/2006/main">
               <a:ext uri="{FF2B5EF4-FFF2-40B4-BE49-F238E27FC236}">
-                <a16:creationId xmlns:a16="http://schemas.microsoft.com/office/drawing/2014/main" id="{591D1AF6-F79F-485C-9E83-0D1F9A61509F}"/>
+                <a16:creationId xmlns:a16="http://schemas.microsoft.com/office/drawing/2014/main" id="{5D3CB7EB-B840-4062-B9D7-8BDEE658D4F9}"/>
               </a:ext>
             </a:extLst>
           </p:cNvPr>
@@ -5464,7 +5464,7 @@
           <p:cNvPr id="17" name="">
             <a:extLst xmlns:a="http://schemas.openxmlformats.org/drawingml/2006/main">
               <a:ext uri="{FF2B5EF4-FFF2-40B4-BE49-F238E27FC236}">
-                <a16:creationId xmlns:a16="http://schemas.microsoft.com/office/drawing/2014/main" id="{9436474A-502F-4674-BBDF-DC7C8367974E}"/>
+                <a16:creationId xmlns:a16="http://schemas.microsoft.com/office/drawing/2014/main" id="{73F9C485-C96B-4F84-9330-077579A7DA05}"/>
               </a:ext>
             </a:extLst>
           </p:cNvPr>
@@ -5528,7 +5528,7 @@
           <p:cNvPr id="18" name="">
             <a:extLst xmlns:a="http://schemas.openxmlformats.org/drawingml/2006/main">
               <a:ext uri="{FF2B5EF4-FFF2-40B4-BE49-F238E27FC236}">
-                <a16:creationId xmlns:a16="http://schemas.microsoft.com/office/drawing/2014/main" id="{E45311F6-C4AA-4892-98F1-7A2DD420488A}"/>
+                <a16:creationId xmlns:a16="http://schemas.microsoft.com/office/drawing/2014/main" id="{7D8F8937-D800-40E7-86FE-24DCEC6E7FF6}"/>
               </a:ext>
             </a:extLst>
           </p:cNvPr>
@@ -5592,7 +5592,7 @@
           <p:cNvPr id="19" name="">
             <a:extLst xmlns:a="http://schemas.openxmlformats.org/drawingml/2006/main">
               <a:ext uri="{FF2B5EF4-FFF2-40B4-BE49-F238E27FC236}">
-                <a16:creationId xmlns:a16="http://schemas.microsoft.com/office/drawing/2014/main" id="{ECCD79D3-B331-4AEB-8529-E24839EE3843}"/>
+                <a16:creationId xmlns:a16="http://schemas.microsoft.com/office/drawing/2014/main" id="{4CB99097-2F6F-4EFE-B729-2C3417B7D28C}"/>
               </a:ext>
             </a:extLst>
           </p:cNvPr>
@@ -5625,7 +5625,7 @@
           <p:cNvPr id="20" name="">
             <a:extLst xmlns:a="http://schemas.openxmlformats.org/drawingml/2006/main">
               <a:ext uri="{FF2B5EF4-FFF2-40B4-BE49-F238E27FC236}">
-                <a16:creationId xmlns:a16="http://schemas.microsoft.com/office/drawing/2014/main" id="{FF0026F2-205F-4A24-A710-875BBC6FBD04}"/>
+                <a16:creationId xmlns:a16="http://schemas.microsoft.com/office/drawing/2014/main" id="{77DAB6A8-0F8F-4A2B-A0EC-4361231F3C86}"/>
               </a:ext>
             </a:extLst>
           </p:cNvPr>
@@ -5658,7 +5658,7 @@
           <p:cNvPr id="21" name="">
             <a:extLst xmlns:a="http://schemas.openxmlformats.org/drawingml/2006/main">
               <a:ext uri="{FF2B5EF4-FFF2-40B4-BE49-F238E27FC236}">
-                <a16:creationId xmlns:a16="http://schemas.microsoft.com/office/drawing/2014/main" id="{F45A1190-3758-46EA-B516-1E163D5D4284}"/>
+                <a16:creationId xmlns:a16="http://schemas.microsoft.com/office/drawing/2014/main" id="{C3E3CD90-4B29-42FB-A9F0-13FC09473268}"/>
               </a:ext>
             </a:extLst>
           </p:cNvPr>
@@ -5722,7 +5722,7 @@
           <p:cNvPr id="22" name="">
             <a:extLst xmlns:a="http://schemas.openxmlformats.org/drawingml/2006/main">
               <a:ext uri="{FF2B5EF4-FFF2-40B4-BE49-F238E27FC236}">
-                <a16:creationId xmlns:a16="http://schemas.microsoft.com/office/drawing/2014/main" id="{21981D9E-3104-4B6B-B166-A9B2E7FE441E}"/>
+                <a16:creationId xmlns:a16="http://schemas.microsoft.com/office/drawing/2014/main" id="{B9D870E4-AF3C-4F7C-B4CD-7E73DCAEEA9E}"/>
               </a:ext>
             </a:extLst>
           </p:cNvPr>
@@ -5755,7 +5755,7 @@
           <p:cNvPr id="23" name="">
             <a:extLst xmlns:a="http://schemas.openxmlformats.org/drawingml/2006/main">
               <a:ext uri="{FF2B5EF4-FFF2-40B4-BE49-F238E27FC236}">
-                <a16:creationId xmlns:a16="http://schemas.microsoft.com/office/drawing/2014/main" id="{19A3705E-3C7A-4A86-83F2-E824D89DDD7F}"/>
+                <a16:creationId xmlns:a16="http://schemas.microsoft.com/office/drawing/2014/main" id="{35EEA282-62C5-4FEF-A442-EFD569F0B46D}"/>
               </a:ext>
             </a:extLst>
           </p:cNvPr>
@@ -5788,7 +5788,7 @@
           <p:cNvPr id="24" name="">
             <a:extLst xmlns:a="http://schemas.openxmlformats.org/drawingml/2006/main">
               <a:ext uri="{FF2B5EF4-FFF2-40B4-BE49-F238E27FC236}">
-                <a16:creationId xmlns:a16="http://schemas.microsoft.com/office/drawing/2014/main" id="{BAD1B83C-6FBB-4FDC-AB30-ECC5B37D8DDB}"/>
+                <a16:creationId xmlns:a16="http://schemas.microsoft.com/office/drawing/2014/main" id="{CFF106B7-C20A-4493-879B-ED7F7E1379DB}"/>
               </a:ext>
             </a:extLst>
           </p:cNvPr>
@@ -5852,7 +5852,7 @@
           <p:cNvPr id="25" name="">
             <a:extLst xmlns:a="http://schemas.openxmlformats.org/drawingml/2006/main">
               <a:ext uri="{FF2B5EF4-FFF2-40B4-BE49-F238E27FC236}">
-                <a16:creationId xmlns:a16="http://schemas.microsoft.com/office/drawing/2014/main" id="{812FD10A-C916-4E94-84E4-241992330E80}"/>
+                <a16:creationId xmlns:a16="http://schemas.microsoft.com/office/drawing/2014/main" id="{99EBCFF1-41E4-45C7-9FDA-60AD71DAF100}"/>
               </a:ext>
             </a:extLst>
           </p:cNvPr>
@@ -5885,7 +5885,7 @@
           <p:cNvPr id="26" name="">
             <a:extLst xmlns:a="http://schemas.openxmlformats.org/drawingml/2006/main">
               <a:ext uri="{FF2B5EF4-FFF2-40B4-BE49-F238E27FC236}">
-                <a16:creationId xmlns:a16="http://schemas.microsoft.com/office/drawing/2014/main" id="{61BEB115-AA08-491C-B66D-DF2C76893F18}"/>
+                <a16:creationId xmlns:a16="http://schemas.microsoft.com/office/drawing/2014/main" id="{98AFAFF3-3EE0-46C8-926E-786433E75B0B}"/>
               </a:ext>
             </a:extLst>
           </p:cNvPr>
@@ -5918,7 +5918,7 @@
           <p:cNvPr id="27" name="">
             <a:extLst xmlns:a="http://schemas.openxmlformats.org/drawingml/2006/main">
               <a:ext uri="{FF2B5EF4-FFF2-40B4-BE49-F238E27FC236}">
-                <a16:creationId xmlns:a16="http://schemas.microsoft.com/office/drawing/2014/main" id="{7B639A38-1996-4D58-AD7F-D475EE7AB915}"/>
+                <a16:creationId xmlns:a16="http://schemas.microsoft.com/office/drawing/2014/main" id="{7040DD48-FF44-4644-982E-584EE2073241}"/>
               </a:ext>
             </a:extLst>
           </p:cNvPr>
@@ -5951,7 +5951,7 @@
           <p:cNvPr id="28" name="">
             <a:extLst xmlns:a="http://schemas.openxmlformats.org/drawingml/2006/main">
               <a:ext uri="{FF2B5EF4-FFF2-40B4-BE49-F238E27FC236}">
-                <a16:creationId xmlns:a16="http://schemas.microsoft.com/office/drawing/2014/main" id="{311A5BC0-A344-4FCC-86D4-3D72155B7640}"/>
+                <a16:creationId xmlns:a16="http://schemas.microsoft.com/office/drawing/2014/main" id="{1D96FDC2-5924-4022-A573-48C9D9774855}"/>
               </a:ext>
             </a:extLst>
           </p:cNvPr>
@@ -6015,7 +6015,7 @@
           <p:cNvPr id="29" name="">
             <a:extLst xmlns:a="http://schemas.openxmlformats.org/drawingml/2006/main">
               <a:ext uri="{FF2B5EF4-FFF2-40B4-BE49-F238E27FC236}">
-                <a16:creationId xmlns:a16="http://schemas.microsoft.com/office/drawing/2014/main" id="{CCC5973F-FAF4-4D12-9B3A-D30383F00B18}"/>
+                <a16:creationId xmlns:a16="http://schemas.microsoft.com/office/drawing/2014/main" id="{8D32AACC-F532-4446-9971-9B91F6471036}"/>
               </a:ext>
             </a:extLst>
           </p:cNvPr>
@@ -6048,7 +6048,7 @@
           <p:cNvPr id="30" name="">
             <a:extLst xmlns:a="http://schemas.openxmlformats.org/drawingml/2006/main">
               <a:ext uri="{FF2B5EF4-FFF2-40B4-BE49-F238E27FC236}">
-                <a16:creationId xmlns:a16="http://schemas.microsoft.com/office/drawing/2014/main" id="{DC5BE429-7344-4238-95F5-3FAF37C0CAD7}"/>
+                <a16:creationId xmlns:a16="http://schemas.microsoft.com/office/drawing/2014/main" id="{34926D96-999D-40EF-81EC-B3F900704A28}"/>
               </a:ext>
             </a:extLst>
           </p:cNvPr>
@@ -6112,7 +6112,7 @@
           <p:cNvPr id="31" name="">
             <a:extLst xmlns:a="http://schemas.openxmlformats.org/drawingml/2006/main">
               <a:ext uri="{FF2B5EF4-FFF2-40B4-BE49-F238E27FC236}">
-                <a16:creationId xmlns:a16="http://schemas.microsoft.com/office/drawing/2014/main" id="{C5626909-803E-4A4E-B105-51752204416C}"/>
+                <a16:creationId xmlns:a16="http://schemas.microsoft.com/office/drawing/2014/main" id="{276FE41A-F0BF-42A8-A9C0-E69A0EBE5519}"/>
               </a:ext>
             </a:extLst>
           </p:cNvPr>
@@ -6145,7 +6145,7 @@
           <p:cNvPr id="32" name="">
             <a:extLst xmlns:a="http://schemas.openxmlformats.org/drawingml/2006/main">
               <a:ext uri="{FF2B5EF4-FFF2-40B4-BE49-F238E27FC236}">
-                <a16:creationId xmlns:a16="http://schemas.microsoft.com/office/drawing/2014/main" id="{A6D658DA-A328-493D-8A37-7976DD91BAC1}"/>
+                <a16:creationId xmlns:a16="http://schemas.microsoft.com/office/drawing/2014/main" id="{6C16F63A-131E-4D9B-BD7E-5041145AFBB1}"/>
               </a:ext>
             </a:extLst>
           </p:cNvPr>
@@ -6209,7 +6209,7 @@
           <p:cNvPr id="33" name="">
             <a:extLst xmlns:a="http://schemas.openxmlformats.org/drawingml/2006/main">
               <a:ext uri="{FF2B5EF4-FFF2-40B4-BE49-F238E27FC236}">
-                <a16:creationId xmlns:a16="http://schemas.microsoft.com/office/drawing/2014/main" id="{C15BBA3A-109A-4990-8C13-E7F083E88266}"/>
+                <a16:creationId xmlns:a16="http://schemas.microsoft.com/office/drawing/2014/main" id="{B7D7470A-084F-4394-B9BF-8AA6765AD1F2}"/>
               </a:ext>
             </a:extLst>
           </p:cNvPr>
@@ -6242,7 +6242,7 @@
           <p:cNvPr id="34" name="">
             <a:extLst xmlns:a="http://schemas.openxmlformats.org/drawingml/2006/main">
               <a:ext uri="{FF2B5EF4-FFF2-40B4-BE49-F238E27FC236}">
-                <a16:creationId xmlns:a16="http://schemas.microsoft.com/office/drawing/2014/main" id="{A9C176BD-7C0D-4AE4-8721-E5DB66083695}"/>
+                <a16:creationId xmlns:a16="http://schemas.microsoft.com/office/drawing/2014/main" id="{0E7DC25D-E270-4A1F-AA21-81B224B99915}"/>
               </a:ext>
             </a:extLst>
           </p:cNvPr>
@@ -6306,7 +6306,7 @@
           <p:cNvPr id="35" name="">
             <a:extLst xmlns:a="http://schemas.openxmlformats.org/drawingml/2006/main">
               <a:ext uri="{FF2B5EF4-FFF2-40B4-BE49-F238E27FC236}">
-                <a16:creationId xmlns:a16="http://schemas.microsoft.com/office/drawing/2014/main" id="{97AE742C-EE8B-41B4-AB28-ADB02EC8BD52}"/>
+                <a16:creationId xmlns:a16="http://schemas.microsoft.com/office/drawing/2014/main" id="{68CDF0A6-124A-4161-8877-D880F7C2C2C5}"/>
               </a:ext>
             </a:extLst>
           </p:cNvPr>
@@ -6339,7 +6339,7 @@
           <p:cNvPr id="36" name="">
             <a:extLst xmlns:a="http://schemas.openxmlformats.org/drawingml/2006/main">
               <a:ext uri="{FF2B5EF4-FFF2-40B4-BE49-F238E27FC236}">
-                <a16:creationId xmlns:a16="http://schemas.microsoft.com/office/drawing/2014/main" id="{9276929B-6411-4D59-99DB-A2A2A1588C92}"/>
+                <a16:creationId xmlns:a16="http://schemas.microsoft.com/office/drawing/2014/main" id="{906638E5-4377-4422-87E9-55BABAEF5BBB}"/>
               </a:ext>
             </a:extLst>
           </p:cNvPr>
@@ -6403,7 +6403,7 @@
           <p:cNvPr id="37" name="">
             <a:extLst xmlns:a="http://schemas.openxmlformats.org/drawingml/2006/main">
               <a:ext uri="{FF2B5EF4-FFF2-40B4-BE49-F238E27FC236}">
-                <a16:creationId xmlns:a16="http://schemas.microsoft.com/office/drawing/2014/main" id="{15C874A2-2902-41C3-8BBE-095DC846C107}"/>
+                <a16:creationId xmlns:a16="http://schemas.microsoft.com/office/drawing/2014/main" id="{2108A7E7-834E-4334-B463-88CFC5F59331}"/>
               </a:ext>
             </a:extLst>
           </p:cNvPr>
@@ -6467,7 +6467,7 @@
           <p:cNvPr id="38" name="">
             <a:extLst xmlns:a="http://schemas.openxmlformats.org/drawingml/2006/main">
               <a:ext uri="{FF2B5EF4-FFF2-40B4-BE49-F238E27FC236}">
-                <a16:creationId xmlns:a16="http://schemas.microsoft.com/office/drawing/2014/main" id="{BF91074A-C08C-4028-8861-1BF725BE7E2D}"/>
+                <a16:creationId xmlns:a16="http://schemas.microsoft.com/office/drawing/2014/main" id="{3908ECF8-72EB-4F2F-A336-33196840BB7A}"/>
               </a:ext>
             </a:extLst>
           </p:cNvPr>
@@ -6529,7 +6529,7 @@
     </p:spTree>
     <p:extLst>
       <p:ext uri="{BB962C8B-B14F-4D97-AF65-F5344CB8AC3E}">
-        <p14:creationId xmlns:p14="http://schemas.microsoft.com/office/powerpoint/2010/main" val="479130976"/>
+        <p14:creationId xmlns:p14="http://schemas.microsoft.com/office/powerpoint/2010/main" val="978331381"/>
       </p:ext>
     </p:extLst>
   </p:cSld>
@@ -6553,7 +6553,7 @@
           <p:cNvPr id="1" name="">
             <a:extLst xmlns:a="http://schemas.openxmlformats.org/drawingml/2006/main">
               <a:ext uri="{FF2B5EF4-FFF2-40B4-BE49-F238E27FC236}">
-                <a16:creationId xmlns:a16="http://schemas.microsoft.com/office/drawing/2014/main" id="{D43517F8-667B-49B3-BB91-FEB5348E732E}"/>
+                <a16:creationId xmlns:a16="http://schemas.microsoft.com/office/drawing/2014/main" id="{38FDF30E-CB8E-4D8A-81FB-AB5C01A2E042}"/>
               </a:ext>
             </a:extLst>
           </p:cNvPr>
@@ -6586,7 +6586,7 @@
           <p:cNvPr id="2" name="">
             <a:extLst xmlns:a="http://schemas.openxmlformats.org/drawingml/2006/main">
               <a:ext uri="{FF2B5EF4-FFF2-40B4-BE49-F238E27FC236}">
-                <a16:creationId xmlns:a16="http://schemas.microsoft.com/office/drawing/2014/main" id="{D5692791-49BA-4502-837A-19C53FA772C3}"/>
+                <a16:creationId xmlns:a16="http://schemas.microsoft.com/office/drawing/2014/main" id="{24893034-09DB-4C2F-965F-FF67FC58A14E}"/>
               </a:ext>
             </a:extLst>
           </p:cNvPr>
@@ -6619,7 +6619,7 @@
           <p:cNvPr id="3" name="">
             <a:extLst xmlns:a="http://schemas.openxmlformats.org/drawingml/2006/main">
               <a:ext uri="{FF2B5EF4-FFF2-40B4-BE49-F238E27FC236}">
-                <a16:creationId xmlns:a16="http://schemas.microsoft.com/office/drawing/2014/main" id="{E758ABA5-53A6-4A3D-87C1-3AFF89BC5975}"/>
+                <a16:creationId xmlns:a16="http://schemas.microsoft.com/office/drawing/2014/main" id="{0C8FF635-38B7-424F-BE53-3FA4684E6094}"/>
               </a:ext>
             </a:extLst>
           </p:cNvPr>
@@ -6683,7 +6683,7 @@
           <p:cNvPr id="4" name="">
             <a:extLst xmlns:a="http://schemas.openxmlformats.org/drawingml/2006/main">
               <a:ext uri="{FF2B5EF4-FFF2-40B4-BE49-F238E27FC236}">
-                <a16:creationId xmlns:a16="http://schemas.microsoft.com/office/drawing/2014/main" id="{AD03C6FF-38FC-4ADC-8926-D31DA72F988B}"/>
+                <a16:creationId xmlns:a16="http://schemas.microsoft.com/office/drawing/2014/main" id="{CAAA8D5E-526E-40BF-8FE0-6E2308ECFB63}"/>
               </a:ext>
             </a:extLst>
           </p:cNvPr>
@@ -6747,7 +6747,7 @@
           <p:cNvPr id="5" name="">
             <a:extLst xmlns:a="http://schemas.openxmlformats.org/drawingml/2006/main">
               <a:ext uri="{FF2B5EF4-FFF2-40B4-BE49-F238E27FC236}">
-                <a16:creationId xmlns:a16="http://schemas.microsoft.com/office/drawing/2014/main" id="{1C173506-DD42-4065-84CA-1A4395464BAE}"/>
+                <a16:creationId xmlns:a16="http://schemas.microsoft.com/office/drawing/2014/main" id="{0116F5C2-B4F2-4C6E-A07B-BD17FB3C2D9D}"/>
               </a:ext>
             </a:extLst>
           </p:cNvPr>
@@ -6780,7 +6780,7 @@
           <p:cNvPr id="6" name="">
             <a:extLst xmlns:a="http://schemas.openxmlformats.org/drawingml/2006/main">
               <a:ext uri="{FF2B5EF4-FFF2-40B4-BE49-F238E27FC236}">
-                <a16:creationId xmlns:a16="http://schemas.microsoft.com/office/drawing/2014/main" id="{8829FB62-6B6E-4B2A-AB40-1AD3078AE2C3}"/>
+                <a16:creationId xmlns:a16="http://schemas.microsoft.com/office/drawing/2014/main" id="{4BFFFF1C-6309-497B-AD9B-C91BDCAE04B4}"/>
               </a:ext>
             </a:extLst>
           </p:cNvPr>
@@ -6813,7 +6813,7 @@
           <p:cNvPr id="7" name="">
             <a:extLst xmlns:a="http://schemas.openxmlformats.org/drawingml/2006/main">
               <a:ext uri="{FF2B5EF4-FFF2-40B4-BE49-F238E27FC236}">
-                <a16:creationId xmlns:a16="http://schemas.microsoft.com/office/drawing/2014/main" id="{A67AFEB8-94DF-48F5-B99F-6385D3E87E7B}"/>
+                <a16:creationId xmlns:a16="http://schemas.microsoft.com/office/drawing/2014/main" id="{068EF2ED-44FF-479D-80F8-4F2B1E076590}"/>
               </a:ext>
             </a:extLst>
           </p:cNvPr>
@@ -6877,7 +6877,7 @@
           <p:cNvPr id="8" name="">
             <a:extLst xmlns:a="http://schemas.openxmlformats.org/drawingml/2006/main">
               <a:ext uri="{FF2B5EF4-FFF2-40B4-BE49-F238E27FC236}">
-                <a16:creationId xmlns:a16="http://schemas.microsoft.com/office/drawing/2014/main" id="{E9898D38-D2DB-4FD7-BD97-80CE8047E297}"/>
+                <a16:creationId xmlns:a16="http://schemas.microsoft.com/office/drawing/2014/main" id="{5D149A31-C3EB-498B-BE46-D7B4C1C47EA9}"/>
               </a:ext>
             </a:extLst>
           </p:cNvPr>
@@ -6910,7 +6910,7 @@
           <p:cNvPr id="9" name="">
             <a:extLst xmlns:a="http://schemas.openxmlformats.org/drawingml/2006/main">
               <a:ext uri="{FF2B5EF4-FFF2-40B4-BE49-F238E27FC236}">
-                <a16:creationId xmlns:a16="http://schemas.microsoft.com/office/drawing/2014/main" id="{1A141CE4-2E7C-4FDE-8470-C30704DD7308}"/>
+                <a16:creationId xmlns:a16="http://schemas.microsoft.com/office/drawing/2014/main" id="{1B47364E-72AF-463C-B700-D7FBC03B5925}"/>
               </a:ext>
             </a:extLst>
           </p:cNvPr>
@@ -6974,7 +6974,7 @@
           <p:cNvPr id="10" name="">
             <a:extLst xmlns:a="http://schemas.openxmlformats.org/drawingml/2006/main">
               <a:ext uri="{FF2B5EF4-FFF2-40B4-BE49-F238E27FC236}">
-                <a16:creationId xmlns:a16="http://schemas.microsoft.com/office/drawing/2014/main" id="{B79897A2-9E1D-445A-8BAD-8B39823A1372}"/>
+                <a16:creationId xmlns:a16="http://schemas.microsoft.com/office/drawing/2014/main" id="{0363CA20-69AF-42E1-8EA9-F9358FB125ED}"/>
               </a:ext>
             </a:extLst>
           </p:cNvPr>
@@ -7007,7 +7007,7 @@
           <p:cNvPr id="11" name="">
             <a:extLst xmlns:a="http://schemas.openxmlformats.org/drawingml/2006/main">
               <a:ext uri="{FF2B5EF4-FFF2-40B4-BE49-F238E27FC236}">
-                <a16:creationId xmlns:a16="http://schemas.microsoft.com/office/drawing/2014/main" id="{87E6ABF3-C16E-4CCE-ACF2-4FC0BF6A7CBB}"/>
+                <a16:creationId xmlns:a16="http://schemas.microsoft.com/office/drawing/2014/main" id="{4AAA6183-D9DF-4AF2-9603-90D49B6CCC19}"/>
               </a:ext>
             </a:extLst>
           </p:cNvPr>
@@ -7071,7 +7071,7 @@
           <p:cNvPr id="12" name="">
             <a:extLst xmlns:a="http://schemas.openxmlformats.org/drawingml/2006/main">
               <a:ext uri="{FF2B5EF4-FFF2-40B4-BE49-F238E27FC236}">
-                <a16:creationId xmlns:a16="http://schemas.microsoft.com/office/drawing/2014/main" id="{40E57F21-599C-4A81-8997-3B40FE11F35A}"/>
+                <a16:creationId xmlns:a16="http://schemas.microsoft.com/office/drawing/2014/main" id="{7ECB4EB3-C4A1-4CD5-9933-FC6CA90E1A3E}"/>
               </a:ext>
             </a:extLst>
           </p:cNvPr>
@@ -7104,7 +7104,7 @@
           <p:cNvPr id="13" name="">
             <a:extLst xmlns:a="http://schemas.openxmlformats.org/drawingml/2006/main">
               <a:ext uri="{FF2B5EF4-FFF2-40B4-BE49-F238E27FC236}">
-                <a16:creationId xmlns:a16="http://schemas.microsoft.com/office/drawing/2014/main" id="{BC814C0A-C564-4119-80A9-B11361B37564}"/>
+                <a16:creationId xmlns:a16="http://schemas.microsoft.com/office/drawing/2014/main" id="{8C107B92-691C-4097-9CD4-2A44F1CA48C6}"/>
               </a:ext>
             </a:extLst>
           </p:cNvPr>
@@ -7168,7 +7168,7 @@
           <p:cNvPr id="14" name="">
             <a:extLst xmlns:a="http://schemas.openxmlformats.org/drawingml/2006/main">
               <a:ext uri="{FF2B5EF4-FFF2-40B4-BE49-F238E27FC236}">
-                <a16:creationId xmlns:a16="http://schemas.microsoft.com/office/drawing/2014/main" id="{10273747-F49A-4B1A-9B51-C1E6A79BE119}"/>
+                <a16:creationId xmlns:a16="http://schemas.microsoft.com/office/drawing/2014/main" id="{2DDE08B6-2337-482B-B53F-CA0D5DAA852E}"/>
               </a:ext>
             </a:extLst>
           </p:cNvPr>
@@ -7201,7 +7201,7 @@
           <p:cNvPr id="15" name="">
             <a:extLst xmlns:a="http://schemas.openxmlformats.org/drawingml/2006/main">
               <a:ext uri="{FF2B5EF4-FFF2-40B4-BE49-F238E27FC236}">
-                <a16:creationId xmlns:a16="http://schemas.microsoft.com/office/drawing/2014/main" id="{FA4F7CC6-008C-4D00-92B0-D1FDA70B19AD}"/>
+                <a16:creationId xmlns:a16="http://schemas.microsoft.com/office/drawing/2014/main" id="{31FBEB18-13F5-4D7A-B32E-B2ADE8C48A83}"/>
               </a:ext>
             </a:extLst>
           </p:cNvPr>
@@ -7265,7 +7265,7 @@
           <p:cNvPr id="16" name="">
             <a:extLst xmlns:a="http://schemas.openxmlformats.org/drawingml/2006/main">
               <a:ext uri="{FF2B5EF4-FFF2-40B4-BE49-F238E27FC236}">
-                <a16:creationId xmlns:a16="http://schemas.microsoft.com/office/drawing/2014/main" id="{64A34271-A3F9-464B-A684-546277D5A612}"/>
+                <a16:creationId xmlns:a16="http://schemas.microsoft.com/office/drawing/2014/main" id="{85928106-3177-4C28-88C9-95CB3BB60BA7}"/>
               </a:ext>
             </a:extLst>
           </p:cNvPr>
@@ -7298,7 +7298,7 @@
           <p:cNvPr id="17" name="">
             <a:extLst xmlns:a="http://schemas.openxmlformats.org/drawingml/2006/main">
               <a:ext uri="{FF2B5EF4-FFF2-40B4-BE49-F238E27FC236}">
-                <a16:creationId xmlns:a16="http://schemas.microsoft.com/office/drawing/2014/main" id="{7FADA085-CBD6-482C-970A-1B8945BEAC7D}"/>
+                <a16:creationId xmlns:a16="http://schemas.microsoft.com/office/drawing/2014/main" id="{D9A05751-5AB7-4A88-BE79-A0C06F035E92}"/>
               </a:ext>
             </a:extLst>
           </p:cNvPr>
@@ -7362,7 +7362,7 @@
           <p:cNvPr id="18" name="">
             <a:extLst xmlns:a="http://schemas.openxmlformats.org/drawingml/2006/main">
               <a:ext uri="{FF2B5EF4-FFF2-40B4-BE49-F238E27FC236}">
-                <a16:creationId xmlns:a16="http://schemas.microsoft.com/office/drawing/2014/main" id="{8E861E12-DDB5-478E-A915-A542D3A2C07C}"/>
+                <a16:creationId xmlns:a16="http://schemas.microsoft.com/office/drawing/2014/main" id="{53470D1E-0E60-4831-AE85-4356895F8BFC}"/>
               </a:ext>
             </a:extLst>
           </p:cNvPr>
@@ -7395,7 +7395,7 @@
           <p:cNvPr id="19" name="">
             <a:extLst xmlns:a="http://schemas.openxmlformats.org/drawingml/2006/main">
               <a:ext uri="{FF2B5EF4-FFF2-40B4-BE49-F238E27FC236}">
-                <a16:creationId xmlns:a16="http://schemas.microsoft.com/office/drawing/2014/main" id="{59861ABA-C852-4175-95C8-AB87B5887BEB}"/>
+                <a16:creationId xmlns:a16="http://schemas.microsoft.com/office/drawing/2014/main" id="{51F97E80-A7ED-452B-9B76-DF98C6C364D8}"/>
               </a:ext>
             </a:extLst>
           </p:cNvPr>
@@ -7459,7 +7459,7 @@
           <p:cNvPr id="20" name="">
             <a:extLst xmlns:a="http://schemas.openxmlformats.org/drawingml/2006/main">
               <a:ext uri="{FF2B5EF4-FFF2-40B4-BE49-F238E27FC236}">
-                <a16:creationId xmlns:a16="http://schemas.microsoft.com/office/drawing/2014/main" id="{24E5A509-C74C-4046-990E-0F0B6E9EDC48}"/>
+                <a16:creationId xmlns:a16="http://schemas.microsoft.com/office/drawing/2014/main" id="{44C8E1AC-47A1-4045-B542-5856199B49B5}"/>
               </a:ext>
             </a:extLst>
           </p:cNvPr>
@@ -7492,7 +7492,7 @@
           <p:cNvPr id="21" name="">
             <a:extLst xmlns:a="http://schemas.openxmlformats.org/drawingml/2006/main">
               <a:ext uri="{FF2B5EF4-FFF2-40B4-BE49-F238E27FC236}">
-                <a16:creationId xmlns:a16="http://schemas.microsoft.com/office/drawing/2014/main" id="{D8234AAB-4EB0-4FE8-A6A2-83028738C46F}"/>
+                <a16:creationId xmlns:a16="http://schemas.microsoft.com/office/drawing/2014/main" id="{AF26E5C2-113D-4F69-87CD-5BFE44DB325C}"/>
               </a:ext>
             </a:extLst>
           </p:cNvPr>
@@ -7556,7 +7556,7 @@
           <p:cNvPr id="22" name="">
             <a:extLst xmlns:a="http://schemas.openxmlformats.org/drawingml/2006/main">
               <a:ext uri="{FF2B5EF4-FFF2-40B4-BE49-F238E27FC236}">
-                <a16:creationId xmlns:a16="http://schemas.microsoft.com/office/drawing/2014/main" id="{5F2C25B9-C78C-4D51-AC63-FCCE4DB8DEC0}"/>
+                <a16:creationId xmlns:a16="http://schemas.microsoft.com/office/drawing/2014/main" id="{3BED5440-D013-4442-96AC-0E615095008F}"/>
               </a:ext>
             </a:extLst>
           </p:cNvPr>
@@ -7589,7 +7589,7 @@
           <p:cNvPr id="23" name="">
             <a:extLst xmlns:a="http://schemas.openxmlformats.org/drawingml/2006/main">
               <a:ext uri="{FF2B5EF4-FFF2-40B4-BE49-F238E27FC236}">
-                <a16:creationId xmlns:a16="http://schemas.microsoft.com/office/drawing/2014/main" id="{6D2420BA-0A83-4D95-BE11-1C2B09E7097C}"/>
+                <a16:creationId xmlns:a16="http://schemas.microsoft.com/office/drawing/2014/main" id="{8D12C8C3-6B85-4465-9B00-5AF0FC0490FC}"/>
               </a:ext>
             </a:extLst>
           </p:cNvPr>
@@ -7653,7 +7653,7 @@
           <p:cNvPr id="24" name="">
             <a:extLst xmlns:a="http://schemas.openxmlformats.org/drawingml/2006/main">
               <a:ext uri="{FF2B5EF4-FFF2-40B4-BE49-F238E27FC236}">
-                <a16:creationId xmlns:a16="http://schemas.microsoft.com/office/drawing/2014/main" id="{90CA309E-6558-4A3E-AA41-10ACA7835647}"/>
+                <a16:creationId xmlns:a16="http://schemas.microsoft.com/office/drawing/2014/main" id="{A79D3158-0988-47FE-8B73-03FB55432757}"/>
               </a:ext>
             </a:extLst>
           </p:cNvPr>
@@ -7686,7 +7686,7 @@
           <p:cNvPr id="25" name="">
             <a:extLst xmlns:a="http://schemas.openxmlformats.org/drawingml/2006/main">
               <a:ext uri="{FF2B5EF4-FFF2-40B4-BE49-F238E27FC236}">
-                <a16:creationId xmlns:a16="http://schemas.microsoft.com/office/drawing/2014/main" id="{0CBFA453-AC6F-40F3-8CD6-7922570E6CCB}"/>
+                <a16:creationId xmlns:a16="http://schemas.microsoft.com/office/drawing/2014/main" id="{EDA022F9-BE34-4B0C-BFCE-42AF0514AE01}"/>
               </a:ext>
             </a:extLst>
           </p:cNvPr>
@@ -7750,7 +7750,7 @@
           <p:cNvPr id="26" name="">
             <a:extLst xmlns:a="http://schemas.openxmlformats.org/drawingml/2006/main">
               <a:ext uri="{FF2B5EF4-FFF2-40B4-BE49-F238E27FC236}">
-                <a16:creationId xmlns:a16="http://schemas.microsoft.com/office/drawing/2014/main" id="{DC0C25DB-654D-4372-A780-C8C19E010B86}"/>
+                <a16:creationId xmlns:a16="http://schemas.microsoft.com/office/drawing/2014/main" id="{D5E10844-A222-495C-AD6F-F9B1B9799C15}"/>
               </a:ext>
             </a:extLst>
           </p:cNvPr>
@@ -7783,7 +7783,7 @@
           <p:cNvPr id="27" name="">
             <a:extLst xmlns:a="http://schemas.openxmlformats.org/drawingml/2006/main">
               <a:ext uri="{FF2B5EF4-FFF2-40B4-BE49-F238E27FC236}">
-                <a16:creationId xmlns:a16="http://schemas.microsoft.com/office/drawing/2014/main" id="{F0392B07-7B95-4CF7-B3E8-E4C80C96BEC5}"/>
+                <a16:creationId xmlns:a16="http://schemas.microsoft.com/office/drawing/2014/main" id="{E9B48F7A-2394-445B-8DF2-8416E701E72B}"/>
               </a:ext>
             </a:extLst>
           </p:cNvPr>
@@ -7847,7 +7847,7 @@
           <p:cNvPr id="28" name="">
             <a:extLst xmlns:a="http://schemas.openxmlformats.org/drawingml/2006/main">
               <a:ext uri="{FF2B5EF4-FFF2-40B4-BE49-F238E27FC236}">
-                <a16:creationId xmlns:a16="http://schemas.microsoft.com/office/drawing/2014/main" id="{9C7AC47B-52CA-4455-9DF7-A6A9F8E63588}"/>
+                <a16:creationId xmlns:a16="http://schemas.microsoft.com/office/drawing/2014/main" id="{876FC809-2552-4161-9A88-78E326CA6DB6}"/>
               </a:ext>
             </a:extLst>
           </p:cNvPr>
@@ -7880,7 +7880,7 @@
           <p:cNvPr id="29" name="">
             <a:extLst xmlns:a="http://schemas.openxmlformats.org/drawingml/2006/main">
               <a:ext uri="{FF2B5EF4-FFF2-40B4-BE49-F238E27FC236}">
-                <a16:creationId xmlns:a16="http://schemas.microsoft.com/office/drawing/2014/main" id="{2B593604-639F-499B-B98C-579F9C1D00D8}"/>
+                <a16:creationId xmlns:a16="http://schemas.microsoft.com/office/drawing/2014/main" id="{B3592F27-01B8-413D-BF61-06F9B90FB208}"/>
               </a:ext>
             </a:extLst>
           </p:cNvPr>
@@ -7944,7 +7944,7 @@
           <p:cNvPr id="30" name="">
             <a:extLst xmlns:a="http://schemas.openxmlformats.org/drawingml/2006/main">
               <a:ext uri="{FF2B5EF4-FFF2-40B4-BE49-F238E27FC236}">
-                <a16:creationId xmlns:a16="http://schemas.microsoft.com/office/drawing/2014/main" id="{20064613-999E-44B9-8435-1DF325349F49}"/>
+                <a16:creationId xmlns:a16="http://schemas.microsoft.com/office/drawing/2014/main" id="{5D9B55B6-B494-430D-870B-D5191BBFD994}"/>
               </a:ext>
             </a:extLst>
           </p:cNvPr>
@@ -7977,7 +7977,7 @@
           <p:cNvPr id="31" name="">
             <a:extLst xmlns:a="http://schemas.openxmlformats.org/drawingml/2006/main">
               <a:ext uri="{FF2B5EF4-FFF2-40B4-BE49-F238E27FC236}">
-                <a16:creationId xmlns:a16="http://schemas.microsoft.com/office/drawing/2014/main" id="{F77BEB45-7C82-4A9E-ADF6-35F4CF62663E}"/>
+                <a16:creationId xmlns:a16="http://schemas.microsoft.com/office/drawing/2014/main" id="{10F09E3D-288D-464F-A6C5-510DC3F610BE}"/>
               </a:ext>
             </a:extLst>
           </p:cNvPr>
@@ -8041,7 +8041,7 @@
           <p:cNvPr id="32" name="">
             <a:extLst xmlns:a="http://schemas.openxmlformats.org/drawingml/2006/main">
               <a:ext uri="{FF2B5EF4-FFF2-40B4-BE49-F238E27FC236}">
-                <a16:creationId xmlns:a16="http://schemas.microsoft.com/office/drawing/2014/main" id="{49677881-6700-4517-B4F3-50C7D60BAC7F}"/>
+                <a16:creationId xmlns:a16="http://schemas.microsoft.com/office/drawing/2014/main" id="{ED4F33B5-195B-48AD-A37E-619FEE5AEB4C}"/>
               </a:ext>
             </a:extLst>
           </p:cNvPr>
@@ -8074,7 +8074,7 @@
           <p:cNvPr id="33" name="">
             <a:extLst xmlns:a="http://schemas.openxmlformats.org/drawingml/2006/main">
               <a:ext uri="{FF2B5EF4-FFF2-40B4-BE49-F238E27FC236}">
-                <a16:creationId xmlns:a16="http://schemas.microsoft.com/office/drawing/2014/main" id="{696D39D1-C68B-4608-9E46-D7BF7AEAA2BA}"/>
+                <a16:creationId xmlns:a16="http://schemas.microsoft.com/office/drawing/2014/main" id="{C10D562E-25CC-47B3-9A19-991283EC4D06}"/>
               </a:ext>
             </a:extLst>
           </p:cNvPr>
@@ -8138,7 +8138,7 @@
           <p:cNvPr id="34" name="">
             <a:extLst xmlns:a="http://schemas.openxmlformats.org/drawingml/2006/main">
               <a:ext uri="{FF2B5EF4-FFF2-40B4-BE49-F238E27FC236}">
-                <a16:creationId xmlns:a16="http://schemas.microsoft.com/office/drawing/2014/main" id="{A2E54D7D-C092-41B0-B4AB-FBD8556D3E1D}"/>
+                <a16:creationId xmlns:a16="http://schemas.microsoft.com/office/drawing/2014/main" id="{00ACB91D-ABDE-4465-9E6C-C381B68A52B1}"/>
               </a:ext>
             </a:extLst>
           </p:cNvPr>
@@ -8171,7 +8171,7 @@
           <p:cNvPr id="35" name="">
             <a:extLst xmlns:a="http://schemas.openxmlformats.org/drawingml/2006/main">
               <a:ext uri="{FF2B5EF4-FFF2-40B4-BE49-F238E27FC236}">
-                <a16:creationId xmlns:a16="http://schemas.microsoft.com/office/drawing/2014/main" id="{2332736B-5394-4156-A128-DEFFF698708A}"/>
+                <a16:creationId xmlns:a16="http://schemas.microsoft.com/office/drawing/2014/main" id="{6FB617E1-401F-47AF-8DE0-FC76C14E9301}"/>
               </a:ext>
             </a:extLst>
           </p:cNvPr>
@@ -8235,7 +8235,7 @@
           <p:cNvPr id="36" name="">
             <a:extLst xmlns:a="http://schemas.openxmlformats.org/drawingml/2006/main">
               <a:ext uri="{FF2B5EF4-FFF2-40B4-BE49-F238E27FC236}">
-                <a16:creationId xmlns:a16="http://schemas.microsoft.com/office/drawing/2014/main" id="{DBFD6776-B1FE-45FC-8C7A-F9B102AED2AD}"/>
+                <a16:creationId xmlns:a16="http://schemas.microsoft.com/office/drawing/2014/main" id="{7DD040CD-A55F-4141-867B-027505A2A274}"/>
               </a:ext>
             </a:extLst>
           </p:cNvPr>
@@ -8268,7 +8268,7 @@
           <p:cNvPr id="37" name="">
             <a:extLst xmlns:a="http://schemas.openxmlformats.org/drawingml/2006/main">
               <a:ext uri="{FF2B5EF4-FFF2-40B4-BE49-F238E27FC236}">
-                <a16:creationId xmlns:a16="http://schemas.microsoft.com/office/drawing/2014/main" id="{EB214BE2-D46E-43C2-BDA8-F18732384B62}"/>
+                <a16:creationId xmlns:a16="http://schemas.microsoft.com/office/drawing/2014/main" id="{053ADA4D-B90A-4C95-8632-F1E20162E008}"/>
               </a:ext>
             </a:extLst>
           </p:cNvPr>
@@ -8332,7 +8332,7 @@
           <p:cNvPr id="38" name="">
             <a:extLst xmlns:a="http://schemas.openxmlformats.org/drawingml/2006/main">
               <a:ext uri="{FF2B5EF4-FFF2-40B4-BE49-F238E27FC236}">
-                <a16:creationId xmlns:a16="http://schemas.microsoft.com/office/drawing/2014/main" id="{5406DC4D-003A-4995-9E71-59AE29CC3A03}"/>
+                <a16:creationId xmlns:a16="http://schemas.microsoft.com/office/drawing/2014/main" id="{C01A2F74-DD24-411F-9905-A406CCF69830}"/>
               </a:ext>
             </a:extLst>
           </p:cNvPr>
@@ -8365,7 +8365,7 @@
           <p:cNvPr id="39" name="">
             <a:extLst xmlns:a="http://schemas.openxmlformats.org/drawingml/2006/main">
               <a:ext uri="{FF2B5EF4-FFF2-40B4-BE49-F238E27FC236}">
-                <a16:creationId xmlns:a16="http://schemas.microsoft.com/office/drawing/2014/main" id="{8DEE4B62-E57E-4A07-89C1-CC9843B9DCBA}"/>
+                <a16:creationId xmlns:a16="http://schemas.microsoft.com/office/drawing/2014/main" id="{AFE9269A-3CF6-4AFC-98F8-B9FBF846227E}"/>
               </a:ext>
             </a:extLst>
           </p:cNvPr>
@@ -8429,7 +8429,7 @@
           <p:cNvPr id="40" name="">
             <a:extLst xmlns:a="http://schemas.openxmlformats.org/drawingml/2006/main">
               <a:ext uri="{FF2B5EF4-FFF2-40B4-BE49-F238E27FC236}">
-                <a16:creationId xmlns:a16="http://schemas.microsoft.com/office/drawing/2014/main" id="{DB04EB01-3124-4C08-AFEA-E3FFAFB72564}"/>
+                <a16:creationId xmlns:a16="http://schemas.microsoft.com/office/drawing/2014/main" id="{BADB8278-2049-4A46-85A7-56737E4D86B8}"/>
               </a:ext>
             </a:extLst>
           </p:cNvPr>
@@ -8462,7 +8462,7 @@
           <p:cNvPr id="41" name="">
             <a:extLst xmlns:a="http://schemas.openxmlformats.org/drawingml/2006/main">
               <a:ext uri="{FF2B5EF4-FFF2-40B4-BE49-F238E27FC236}">
-                <a16:creationId xmlns:a16="http://schemas.microsoft.com/office/drawing/2014/main" id="{D4864A93-A4DA-4584-96AC-ED1C358A13EA}"/>
+                <a16:creationId xmlns:a16="http://schemas.microsoft.com/office/drawing/2014/main" id="{6A824577-7E9E-4343-8C95-8BFE11E8B83B}"/>
               </a:ext>
             </a:extLst>
           </p:cNvPr>
@@ -8526,7 +8526,7 @@
           <p:cNvPr id="42" name="">
             <a:extLst xmlns:a="http://schemas.openxmlformats.org/drawingml/2006/main">
               <a:ext uri="{FF2B5EF4-FFF2-40B4-BE49-F238E27FC236}">
-                <a16:creationId xmlns:a16="http://schemas.microsoft.com/office/drawing/2014/main" id="{43CD01B6-9F99-4E4F-BAC4-990F17625669}"/>
+                <a16:creationId xmlns:a16="http://schemas.microsoft.com/office/drawing/2014/main" id="{D91BE27D-83E5-4B45-8D72-26C5D2230073}"/>
               </a:ext>
             </a:extLst>
           </p:cNvPr>
@@ -8559,7 +8559,7 @@
           <p:cNvPr id="43" name="">
             <a:extLst xmlns:a="http://schemas.openxmlformats.org/drawingml/2006/main">
               <a:ext uri="{FF2B5EF4-FFF2-40B4-BE49-F238E27FC236}">
-                <a16:creationId xmlns:a16="http://schemas.microsoft.com/office/drawing/2014/main" id="{F6F71FE4-E9A4-48CE-A8CD-ADF492F58540}"/>
+                <a16:creationId xmlns:a16="http://schemas.microsoft.com/office/drawing/2014/main" id="{34583E81-5185-4688-83AC-0CB5BF602D67}"/>
               </a:ext>
             </a:extLst>
           </p:cNvPr>
@@ -8623,7 +8623,7 @@
           <p:cNvPr id="44" name="">
             <a:extLst xmlns:a="http://schemas.openxmlformats.org/drawingml/2006/main">
               <a:ext uri="{FF2B5EF4-FFF2-40B4-BE49-F238E27FC236}">
-                <a16:creationId xmlns:a16="http://schemas.microsoft.com/office/drawing/2014/main" id="{8696ACDF-E316-4296-9F4D-D13F3D8DDE25}"/>
+                <a16:creationId xmlns:a16="http://schemas.microsoft.com/office/drawing/2014/main" id="{93533DF7-CE04-490C-ACD4-93988549240B}"/>
               </a:ext>
             </a:extLst>
           </p:cNvPr>
@@ -8656,7 +8656,7 @@
           <p:cNvPr id="45" name="">
             <a:extLst xmlns:a="http://schemas.openxmlformats.org/drawingml/2006/main">
               <a:ext uri="{FF2B5EF4-FFF2-40B4-BE49-F238E27FC236}">
-                <a16:creationId xmlns:a16="http://schemas.microsoft.com/office/drawing/2014/main" id="{AB5E0352-9BFD-40C2-B681-5439D043787E}"/>
+                <a16:creationId xmlns:a16="http://schemas.microsoft.com/office/drawing/2014/main" id="{368358AD-2911-4B46-83F3-2A3104C9B49F}"/>
               </a:ext>
             </a:extLst>
           </p:cNvPr>
@@ -8720,7 +8720,7 @@
           <p:cNvPr id="46" name="">
             <a:extLst xmlns:a="http://schemas.openxmlformats.org/drawingml/2006/main">
               <a:ext uri="{FF2B5EF4-FFF2-40B4-BE49-F238E27FC236}">
-                <a16:creationId xmlns:a16="http://schemas.microsoft.com/office/drawing/2014/main" id="{6C90930E-CC33-427B-BFE2-B8B9F24FE0E7}"/>
+                <a16:creationId xmlns:a16="http://schemas.microsoft.com/office/drawing/2014/main" id="{BA63619B-6C64-4F53-BEFE-3B20993BD802}"/>
               </a:ext>
             </a:extLst>
           </p:cNvPr>
@@ -8753,7 +8753,7 @@
           <p:cNvPr id="47" name="">
             <a:extLst xmlns:a="http://schemas.openxmlformats.org/drawingml/2006/main">
               <a:ext uri="{FF2B5EF4-FFF2-40B4-BE49-F238E27FC236}">
-                <a16:creationId xmlns:a16="http://schemas.microsoft.com/office/drawing/2014/main" id="{90EFA4DC-1B2E-400E-A51F-F6298109E7F3}"/>
+                <a16:creationId xmlns:a16="http://schemas.microsoft.com/office/drawing/2014/main" id="{90971CBB-120B-47F6-B1B3-5BAE21FD2798}"/>
               </a:ext>
             </a:extLst>
           </p:cNvPr>
@@ -8817,7 +8817,7 @@
           <p:cNvPr id="48" name="">
             <a:extLst xmlns:a="http://schemas.openxmlformats.org/drawingml/2006/main">
               <a:ext uri="{FF2B5EF4-FFF2-40B4-BE49-F238E27FC236}">
-                <a16:creationId xmlns:a16="http://schemas.microsoft.com/office/drawing/2014/main" id="{95520FC4-6F60-4BFE-B05D-2AD9BF5CF3A2}"/>
+                <a16:creationId xmlns:a16="http://schemas.microsoft.com/office/drawing/2014/main" id="{5B49FED2-2E46-4B56-BD16-AF6E1519DE16}"/>
               </a:ext>
             </a:extLst>
           </p:cNvPr>
@@ -8881,7 +8881,7 @@
           <p:cNvPr id="49" name="">
             <a:extLst xmlns:a="http://schemas.openxmlformats.org/drawingml/2006/main">
               <a:ext uri="{FF2B5EF4-FFF2-40B4-BE49-F238E27FC236}">
-                <a16:creationId xmlns:a16="http://schemas.microsoft.com/office/drawing/2014/main" id="{7B60DE2B-D5E7-48D8-8AE7-665937B05F59}"/>
+                <a16:creationId xmlns:a16="http://schemas.microsoft.com/office/drawing/2014/main" id="{77DCD44B-FD5C-4A5B-BCBC-4B1B78FC4F73}"/>
               </a:ext>
             </a:extLst>
           </p:cNvPr>
@@ -8943,7 +8943,7 @@
     </p:spTree>
     <p:extLst>
       <p:ext uri="{BB962C8B-B14F-4D97-AF65-F5344CB8AC3E}">
-        <p14:creationId xmlns:p14="http://schemas.microsoft.com/office/powerpoint/2010/main" val="2147228395"/>
+        <p14:creationId xmlns:p14="http://schemas.microsoft.com/office/powerpoint/2010/main" val="1276119812"/>
       </p:ext>
     </p:extLst>
   </p:cSld>
@@ -8967,7 +8967,7 @@
           <p:cNvPr id="1" name="">
             <a:extLst xmlns:a="http://schemas.openxmlformats.org/drawingml/2006/main">
               <a:ext uri="{FF2B5EF4-FFF2-40B4-BE49-F238E27FC236}">
-                <a16:creationId xmlns:a16="http://schemas.microsoft.com/office/drawing/2014/main" id="{98F47662-9DD2-4179-91C2-FD1C52D7B3EF}"/>
+                <a16:creationId xmlns:a16="http://schemas.microsoft.com/office/drawing/2014/main" id="{62F56A14-EF66-4E64-A0E5-4D82372ECFBE}"/>
               </a:ext>
             </a:extLst>
           </p:cNvPr>
@@ -9000,7 +9000,7 @@
           <p:cNvPr id="2" name="">
             <a:extLst xmlns:a="http://schemas.openxmlformats.org/drawingml/2006/main">
               <a:ext uri="{FF2B5EF4-FFF2-40B4-BE49-F238E27FC236}">
-                <a16:creationId xmlns:a16="http://schemas.microsoft.com/office/drawing/2014/main" id="{1C0D51C2-2295-4635-9362-277D03255B78}"/>
+                <a16:creationId xmlns:a16="http://schemas.microsoft.com/office/drawing/2014/main" id="{E252B595-CB76-4B99-84BE-B7149B7B7117}"/>
               </a:ext>
             </a:extLst>
           </p:cNvPr>
@@ -9033,7 +9033,7 @@
           <p:cNvPr id="3" name="">
             <a:extLst xmlns:a="http://schemas.openxmlformats.org/drawingml/2006/main">
               <a:ext uri="{FF2B5EF4-FFF2-40B4-BE49-F238E27FC236}">
-                <a16:creationId xmlns:a16="http://schemas.microsoft.com/office/drawing/2014/main" id="{A6CC5258-6F96-4F39-971E-5F46D1A98410}"/>
+                <a16:creationId xmlns:a16="http://schemas.microsoft.com/office/drawing/2014/main" id="{A3966BEF-7C43-4AB0-8872-143CF433A568}"/>
               </a:ext>
             </a:extLst>
           </p:cNvPr>
@@ -9097,7 +9097,7 @@
           <p:cNvPr id="4" name="">
             <a:extLst xmlns:a="http://schemas.openxmlformats.org/drawingml/2006/main">
               <a:ext uri="{FF2B5EF4-FFF2-40B4-BE49-F238E27FC236}">
-                <a16:creationId xmlns:a16="http://schemas.microsoft.com/office/drawing/2014/main" id="{7BF14B11-1ED0-43E9-8BCA-D62719D9433A}"/>
+                <a16:creationId xmlns:a16="http://schemas.microsoft.com/office/drawing/2014/main" id="{7B0C0A16-F24C-470E-80FE-99C958D30FB9}"/>
               </a:ext>
             </a:extLst>
           </p:cNvPr>
@@ -9161,7 +9161,7 @@
           <p:cNvPr id="5" name="">
             <a:extLst xmlns:a="http://schemas.openxmlformats.org/drawingml/2006/main">
               <a:ext uri="{FF2B5EF4-FFF2-40B4-BE49-F238E27FC236}">
-                <a16:creationId xmlns:a16="http://schemas.microsoft.com/office/drawing/2014/main" id="{91F3D058-64C6-4143-B67E-7E19D234EAC3}"/>
+                <a16:creationId xmlns:a16="http://schemas.microsoft.com/office/drawing/2014/main" id="{32364304-5673-4363-9C81-FFA4F2268731}"/>
               </a:ext>
             </a:extLst>
           </p:cNvPr>
@@ -9194,7 +9194,7 @@
           <p:cNvPr id="6" name="">
             <a:extLst xmlns:a="http://schemas.openxmlformats.org/drawingml/2006/main">
               <a:ext uri="{FF2B5EF4-FFF2-40B4-BE49-F238E27FC236}">
-                <a16:creationId xmlns:a16="http://schemas.microsoft.com/office/drawing/2014/main" id="{49F9210B-5645-4225-9F4E-773438B5393A}"/>
+                <a16:creationId xmlns:a16="http://schemas.microsoft.com/office/drawing/2014/main" id="{5B87DB39-CF43-449E-B692-6B9548B3B954}"/>
               </a:ext>
             </a:extLst>
           </p:cNvPr>
@@ -9227,7 +9227,7 @@
           <p:cNvPr id="7" name="">
             <a:extLst xmlns:a="http://schemas.openxmlformats.org/drawingml/2006/main">
               <a:ext uri="{FF2B5EF4-FFF2-40B4-BE49-F238E27FC236}">
-                <a16:creationId xmlns:a16="http://schemas.microsoft.com/office/drawing/2014/main" id="{E4A822AB-4A58-4044-8B18-6ACE757FB45E}"/>
+                <a16:creationId xmlns:a16="http://schemas.microsoft.com/office/drawing/2014/main" id="{18E0F4DE-EA71-4CE2-8DF0-F4535B8E0E23}"/>
               </a:ext>
             </a:extLst>
           </p:cNvPr>
@@ -9291,7 +9291,7 @@
           <p:cNvPr id="8" name="">
             <a:extLst xmlns:a="http://schemas.openxmlformats.org/drawingml/2006/main">
               <a:ext uri="{FF2B5EF4-FFF2-40B4-BE49-F238E27FC236}">
-                <a16:creationId xmlns:a16="http://schemas.microsoft.com/office/drawing/2014/main" id="{2538ECB6-A6D0-4172-8D3B-7C209AF610E6}"/>
+                <a16:creationId xmlns:a16="http://schemas.microsoft.com/office/drawing/2014/main" id="{7DD0A23E-D3C9-4FED-BBDF-49FE521CEAAC}"/>
               </a:ext>
             </a:extLst>
           </p:cNvPr>
@@ -9324,7 +9324,7 @@
           <p:cNvPr id="9" name="">
             <a:extLst xmlns:a="http://schemas.openxmlformats.org/drawingml/2006/main">
               <a:ext uri="{FF2B5EF4-FFF2-40B4-BE49-F238E27FC236}">
-                <a16:creationId xmlns:a16="http://schemas.microsoft.com/office/drawing/2014/main" id="{F408CB68-75EA-4B59-B24B-1A89C8471EF5}"/>
+                <a16:creationId xmlns:a16="http://schemas.microsoft.com/office/drawing/2014/main" id="{71954F30-B73E-41AE-85F6-99FB9A86F9C3}"/>
               </a:ext>
             </a:extLst>
           </p:cNvPr>
@@ -9378,7 +9378,7 @@
                 <a:ea typeface="Malgun Gothic"/>
                 <a:cs typeface="Malgun Gothic"/>
               </a:rPr>
-              <a:t>로그 기반 분석형 보조 영상</a:t>
+              <a:t>99K checkpoint 실제 gameplay</a:t>
             </a:r>
           </a:p>
         </p:txBody>
@@ -9388,7 +9388,7 @@
           <p:cNvPr id="10" name="">
             <a:extLst xmlns:a="http://schemas.openxmlformats.org/drawingml/2006/main">
               <a:ext uri="{FF2B5EF4-FFF2-40B4-BE49-F238E27FC236}">
-                <a16:creationId xmlns:a16="http://schemas.microsoft.com/office/drawing/2014/main" id="{9CEF63E3-EAF2-4537-AAEA-68B2C62F1F7D}"/>
+                <a16:creationId xmlns:a16="http://schemas.microsoft.com/office/drawing/2014/main" id="{9C70D6C2-2438-404B-803C-FA4450497775}"/>
               </a:ext>
             </a:extLst>
           </p:cNvPr>
@@ -9421,7 +9421,7 @@
           <p:cNvPr id="11" name="">
             <a:extLst xmlns:a="http://schemas.openxmlformats.org/drawingml/2006/main">
               <a:ext uri="{FF2B5EF4-FFF2-40B4-BE49-F238E27FC236}">
-                <a16:creationId xmlns:a16="http://schemas.microsoft.com/office/drawing/2014/main" id="{161B3CAC-F03A-496D-8F4F-538D381168E5}"/>
+                <a16:creationId xmlns:a16="http://schemas.microsoft.com/office/drawing/2014/main" id="{8C0AB0A5-1C98-4FD9-9938-45777F6DD9E1}"/>
               </a:ext>
             </a:extLst>
           </p:cNvPr>
@@ -9475,7 +9475,7 @@
                 <a:ea typeface="Malgun Gothic"/>
                 <a:cs typeface="Malgun Gothic"/>
               </a:rPr>
-              <a:t>학습 초반 정책</a:t>
+              <a:t>BossPlayer-99957.onnx</a:t>
             </a:r>
           </a:p>
         </p:txBody>
@@ -9485,7 +9485,7 @@
           <p:cNvPr id="12" name="">
             <a:extLst xmlns:a="http://schemas.openxmlformats.org/drawingml/2006/main">
               <a:ext uri="{FF2B5EF4-FFF2-40B4-BE49-F238E27FC236}">
-                <a16:creationId xmlns:a16="http://schemas.microsoft.com/office/drawing/2014/main" id="{D9D8EB20-D6C2-495E-B927-333B4675B1BB}"/>
+                <a16:creationId xmlns:a16="http://schemas.microsoft.com/office/drawing/2014/main" id="{E6909545-5694-47BC-9278-21FF183E5249}"/>
               </a:ext>
             </a:extLst>
           </p:cNvPr>
@@ -9518,7 +9518,7 @@
           <p:cNvPr id="13" name="">
             <a:extLst xmlns:a="http://schemas.openxmlformats.org/drawingml/2006/main">
               <a:ext uri="{FF2B5EF4-FFF2-40B4-BE49-F238E27FC236}">
-                <a16:creationId xmlns:a16="http://schemas.microsoft.com/office/drawing/2014/main" id="{D7790D38-8DAD-4BE2-BD86-993D4EFA14F3}"/>
+                <a16:creationId xmlns:a16="http://schemas.microsoft.com/office/drawing/2014/main" id="{44599A29-0431-4E31-9F40-5082012223D0}"/>
               </a:ext>
             </a:extLst>
           </p:cNvPr>
@@ -9582,7 +9582,7 @@
           <p:cNvPr id="14" name="">
             <a:extLst xmlns:a="http://schemas.openxmlformats.org/drawingml/2006/main">
               <a:ext uri="{FF2B5EF4-FFF2-40B4-BE49-F238E27FC236}">
-                <a16:creationId xmlns:a16="http://schemas.microsoft.com/office/drawing/2014/main" id="{EBB92846-8F55-4DE0-9B61-DFC3D4E6A310}"/>
+                <a16:creationId xmlns:a16="http://schemas.microsoft.com/office/drawing/2014/main" id="{B8B3DA88-19FD-4A68-B631-53F64D6065AD}"/>
               </a:ext>
             </a:extLst>
           </p:cNvPr>
@@ -9615,7 +9615,7 @@
           <p:cNvPr id="15" name="">
             <a:extLst xmlns:a="http://schemas.openxmlformats.org/drawingml/2006/main">
               <a:ext uri="{FF2B5EF4-FFF2-40B4-BE49-F238E27FC236}">
-                <a16:creationId xmlns:a16="http://schemas.microsoft.com/office/drawing/2014/main" id="{88179B99-C071-42F9-97DD-AA909B9C9654}"/>
+                <a16:creationId xmlns:a16="http://schemas.microsoft.com/office/drawing/2014/main" id="{D0114FE0-0F76-4CF4-9407-45B49D6146FD}"/>
               </a:ext>
             </a:extLst>
           </p:cNvPr>
@@ -9669,7 +9669,7 @@
                 <a:ea typeface="Malgun Gothic"/>
                 <a:cs typeface="Malgun Gothic"/>
               </a:rPr>
-              <a:t>피격 및 사망</a:t>
+              <a:t>피격 위험 장면</a:t>
             </a:r>
           </a:p>
         </p:txBody>
@@ -9679,7 +9679,7 @@
           <p:cNvPr id="16" name="">
             <a:extLst xmlns:a="http://schemas.openxmlformats.org/drawingml/2006/main">
               <a:ext uri="{FF2B5EF4-FFF2-40B4-BE49-F238E27FC236}">
-                <a16:creationId xmlns:a16="http://schemas.microsoft.com/office/drawing/2014/main" id="{914A10D9-E547-4918-B4B0-1669DC2268F8}"/>
+                <a16:creationId xmlns:a16="http://schemas.microsoft.com/office/drawing/2014/main" id="{7C0CC1AB-7EC7-4423-84E0-E0796CF7A35B}"/>
               </a:ext>
             </a:extLst>
           </p:cNvPr>
@@ -9712,7 +9712,7 @@
           <p:cNvPr id="17" name="">
             <a:extLst xmlns:a="http://schemas.openxmlformats.org/drawingml/2006/main">
               <a:ext uri="{FF2B5EF4-FFF2-40B4-BE49-F238E27FC236}">
-                <a16:creationId xmlns:a16="http://schemas.microsoft.com/office/drawing/2014/main" id="{DDEFD9FD-C362-4081-A09B-EED5AC16807E}"/>
+                <a16:creationId xmlns:a16="http://schemas.microsoft.com/office/drawing/2014/main" id="{0B9A2E2B-7D41-4543-82F4-1D23ECB6EF7A}"/>
               </a:ext>
             </a:extLst>
           </p:cNvPr>
@@ -9776,7 +9776,7 @@
           <p:cNvPr id="18" name="">
             <a:extLst xmlns:a="http://schemas.openxmlformats.org/drawingml/2006/main">
               <a:ext uri="{FF2B5EF4-FFF2-40B4-BE49-F238E27FC236}">
-                <a16:creationId xmlns:a16="http://schemas.microsoft.com/office/drawing/2014/main" id="{6F7E68FE-8A3D-49E4-A0CA-A7ED4379DC36}"/>
+                <a16:creationId xmlns:a16="http://schemas.microsoft.com/office/drawing/2014/main" id="{DF6E6A2F-C5DC-4AAD-AEAD-12C14E6ABC2E}"/>
               </a:ext>
             </a:extLst>
           </p:cNvPr>
@@ -9809,7 +9809,7 @@
           <p:cNvPr id="19" name="">
             <a:extLst xmlns:a="http://schemas.openxmlformats.org/drawingml/2006/main">
               <a:ext uri="{FF2B5EF4-FFF2-40B4-BE49-F238E27FC236}">
-                <a16:creationId xmlns:a16="http://schemas.microsoft.com/office/drawing/2014/main" id="{1A7BDA9D-9BFE-43A3-8D62-61749D9C605B}"/>
+                <a16:creationId xmlns:a16="http://schemas.microsoft.com/office/drawing/2014/main" id="{BCB1F725-681C-4253-A8E8-68051536E2E7}"/>
               </a:ext>
             </a:extLst>
           </p:cNvPr>
@@ -9863,7 +9863,7 @@
                 <a:ea typeface="Malgun Gothic"/>
                 <a:cs typeface="Malgun Gothic"/>
               </a:rPr>
-              <a:t>gameplay 재라벨링 없음</a:t>
+              <a:t>설명 슬라이드 사용 없음</a:t>
             </a:r>
           </a:p>
         </p:txBody>
@@ -9873,7 +9873,7 @@
           <p:cNvPr id="20" name="">
             <a:extLst xmlns:a="http://schemas.openxmlformats.org/drawingml/2006/main">
               <a:ext uri="{FF2B5EF4-FFF2-40B4-BE49-F238E27FC236}">
-                <a16:creationId xmlns:a16="http://schemas.microsoft.com/office/drawing/2014/main" id="{EFB2A4E7-D32E-4CDD-AB89-0F161D6B46C1}"/>
+                <a16:creationId xmlns:a16="http://schemas.microsoft.com/office/drawing/2014/main" id="{8DF6970B-7220-49FA-B9D6-B53B0ABDD36D}"/>
               </a:ext>
             </a:extLst>
           </p:cNvPr>
@@ -9937,7 +9937,7 @@
           <p:cNvPr id="21" name="">
             <a:extLst xmlns:a="http://schemas.openxmlformats.org/drawingml/2006/main">
               <a:ext uri="{FF2B5EF4-FFF2-40B4-BE49-F238E27FC236}">
-                <a16:creationId xmlns:a16="http://schemas.microsoft.com/office/drawing/2014/main" id="{95C7E772-3B61-4DCB-8841-C79F0A49BBE2}"/>
+                <a16:creationId xmlns:a16="http://schemas.microsoft.com/office/drawing/2014/main" id="{906EFE5F-FFFD-43E1-88F3-702F4B8452B6}"/>
               </a:ext>
             </a:extLst>
           </p:cNvPr>
@@ -9999,7 +9999,7 @@
     </p:spTree>
     <p:extLst>
       <p:ext uri="{BB962C8B-B14F-4D97-AF65-F5344CB8AC3E}">
-        <p14:creationId xmlns:p14="http://schemas.microsoft.com/office/powerpoint/2010/main" val="1396018527"/>
+        <p14:creationId xmlns:p14="http://schemas.microsoft.com/office/powerpoint/2010/main" val="292248782"/>
       </p:ext>
     </p:extLst>
   </p:cSld>
@@ -10023,7 +10023,7 @@
           <p:cNvPr id="1" name="">
             <a:extLst xmlns:a="http://schemas.openxmlformats.org/drawingml/2006/main">
               <a:ext uri="{FF2B5EF4-FFF2-40B4-BE49-F238E27FC236}">
-                <a16:creationId xmlns:a16="http://schemas.microsoft.com/office/drawing/2014/main" id="{8FA2B5F7-29C5-4BE6-98D8-9CDA6F905A14}"/>
+                <a16:creationId xmlns:a16="http://schemas.microsoft.com/office/drawing/2014/main" id="{1D04B483-F589-4F25-AF2B-BF92B9F9F0CE}"/>
               </a:ext>
             </a:extLst>
           </p:cNvPr>
@@ -10056,7 +10056,7 @@
           <p:cNvPr id="2" name="">
             <a:extLst xmlns:a="http://schemas.openxmlformats.org/drawingml/2006/main">
               <a:ext uri="{FF2B5EF4-FFF2-40B4-BE49-F238E27FC236}">
-                <a16:creationId xmlns:a16="http://schemas.microsoft.com/office/drawing/2014/main" id="{10C8F116-9443-489F-AB70-70D75E06AB0D}"/>
+                <a16:creationId xmlns:a16="http://schemas.microsoft.com/office/drawing/2014/main" id="{558ABD3F-F796-487C-A576-DF22700E6B5C}"/>
               </a:ext>
             </a:extLst>
           </p:cNvPr>
@@ -10089,7 +10089,7 @@
           <p:cNvPr id="3" name="">
             <a:extLst xmlns:a="http://schemas.openxmlformats.org/drawingml/2006/main">
               <a:ext uri="{FF2B5EF4-FFF2-40B4-BE49-F238E27FC236}">
-                <a16:creationId xmlns:a16="http://schemas.microsoft.com/office/drawing/2014/main" id="{C042CFBE-583A-4150-A233-8821E8916CFD}"/>
+                <a16:creationId xmlns:a16="http://schemas.microsoft.com/office/drawing/2014/main" id="{77CBAEEE-3B12-4C5E-ACF3-02EE93C1CB2E}"/>
               </a:ext>
             </a:extLst>
           </p:cNvPr>
@@ -10153,7 +10153,7 @@
           <p:cNvPr id="4" name="">
             <a:extLst xmlns:a="http://schemas.openxmlformats.org/drawingml/2006/main">
               <a:ext uri="{FF2B5EF4-FFF2-40B4-BE49-F238E27FC236}">
-                <a16:creationId xmlns:a16="http://schemas.microsoft.com/office/drawing/2014/main" id="{9001611F-A9D7-45AA-A9AF-B522F543035D}"/>
+                <a16:creationId xmlns:a16="http://schemas.microsoft.com/office/drawing/2014/main" id="{ACF1CDF0-6F27-4AE8-B672-9078979581CE}"/>
               </a:ext>
             </a:extLst>
           </p:cNvPr>
@@ -10217,7 +10217,7 @@
           <p:cNvPr id="5" name="">
             <a:extLst xmlns:a="http://schemas.openxmlformats.org/drawingml/2006/main">
               <a:ext uri="{FF2B5EF4-FFF2-40B4-BE49-F238E27FC236}">
-                <a16:creationId xmlns:a16="http://schemas.microsoft.com/office/drawing/2014/main" id="{FBFC512B-6140-41CC-8B95-28407A281481}"/>
+                <a16:creationId xmlns:a16="http://schemas.microsoft.com/office/drawing/2014/main" id="{ECDD4522-2D25-44F2-845A-D8031B39C45E}"/>
               </a:ext>
             </a:extLst>
           </p:cNvPr>
@@ -10250,7 +10250,7 @@
           <p:cNvPr id="6" name="">
             <a:extLst xmlns:a="http://schemas.openxmlformats.org/drawingml/2006/main">
               <a:ext uri="{FF2B5EF4-FFF2-40B4-BE49-F238E27FC236}">
-                <a16:creationId xmlns:a16="http://schemas.microsoft.com/office/drawing/2014/main" id="{C7B593F4-F276-4E83-B3AB-BA42C80D1E21}"/>
+                <a16:creationId xmlns:a16="http://schemas.microsoft.com/office/drawing/2014/main" id="{9A9945C1-8A4D-4838-B81B-85531CA797E7}"/>
               </a:ext>
             </a:extLst>
           </p:cNvPr>
@@ -10283,7 +10283,7 @@
           <p:cNvPr id="7" name="">
             <a:extLst xmlns:a="http://schemas.openxmlformats.org/drawingml/2006/main">
               <a:ext uri="{FF2B5EF4-FFF2-40B4-BE49-F238E27FC236}">
-                <a16:creationId xmlns:a16="http://schemas.microsoft.com/office/drawing/2014/main" id="{C3716303-FE32-42B8-BE34-2080F4AA64D5}"/>
+                <a16:creationId xmlns:a16="http://schemas.microsoft.com/office/drawing/2014/main" id="{F6781BF5-3FC8-4CA7-AE4B-DCCD0591FDD4}"/>
               </a:ext>
             </a:extLst>
           </p:cNvPr>
@@ -10295,7 +10295,7 @@
         <p:spPr>
           <a:xfrm xmlns:a="http://schemas.openxmlformats.org/drawingml/2006/main">
             <a:off x="971550" y="1581150"/>
-            <a:ext cx="9696450" cy="419100"/>
+            <a:ext cx="9696450" cy="342900"/>
           </a:xfrm>
           <a:prstGeom xmlns:a="http://schemas.openxmlformats.org/drawingml/2006/main" prst="rect">
             <a:avLst/>
@@ -10319,7 +10319,7 @@
           <a:lstStyle xmlns:a="http://schemas.openxmlformats.org/drawingml/2006/main"/>
           <a:p xmlns:a="http://schemas.openxmlformats.org/drawingml/2006/main">
             <a:pPr algn="l">
-              <a:defRPr sz="1725" b="0">
+              <a:defRPr sz="1500" b="0">
                 <a:solidFill>
                   <a:srgbClr val="1F2933"/>
                 </a:solidFill>
@@ -10329,7 +10329,7 @@
               </a:defRPr>
             </a:pPr>
             <a:r>
-              <a:rPr sz="1725" b="0">
+              <a:rPr sz="1500" b="0">
                 <a:solidFill>
                   <a:srgbClr val="1F2933"/>
                 </a:solidFill>
@@ -10347,18 +10347,18 @@
           <p:cNvPr id="8" name="">
             <a:extLst xmlns:a="http://schemas.openxmlformats.org/drawingml/2006/main">
               <a:ext uri="{FF2B5EF4-FFF2-40B4-BE49-F238E27FC236}">
-                <a16:creationId xmlns:a16="http://schemas.microsoft.com/office/drawing/2014/main" id="{553E9B47-1277-48A1-96FB-73B268303B8A}"/>
-              </a:ext>
-            </a:extLst>
-          </p:cNvPr>
-          <p:cNvSpPr>
-            <a:spLocks xmlns:a="http://schemas.openxmlformats.org/drawingml/2006/main" noGrp="1"/>
-          </p:cNvSpPr>
-          <p:nvPr/>
-        </p:nvSpPr>
-        <p:spPr>
-          <a:xfrm xmlns:a="http://schemas.openxmlformats.org/drawingml/2006/main">
-            <a:off x="762000" y="2085975"/>
+                <a16:creationId xmlns:a16="http://schemas.microsoft.com/office/drawing/2014/main" id="{CEE71E93-BE0B-4D79-AAF0-42D1C5F3774F}"/>
+              </a:ext>
+            </a:extLst>
+          </p:cNvPr>
+          <p:cNvSpPr>
+            <a:spLocks xmlns:a="http://schemas.openxmlformats.org/drawingml/2006/main" noGrp="1"/>
+          </p:cNvSpPr>
+          <p:nvPr/>
+        </p:nvSpPr>
+        <p:spPr>
+          <a:xfrm xmlns:a="http://schemas.openxmlformats.org/drawingml/2006/main">
+            <a:off x="762000" y="2009775"/>
             <a:ext cx="95250" cy="95250"/>
           </a:xfrm>
           <a:prstGeom xmlns:a="http://schemas.openxmlformats.org/drawingml/2006/main" prst="rect">
@@ -10380,19 +10380,19 @@
           <p:cNvPr id="9" name="">
             <a:extLst xmlns:a="http://schemas.openxmlformats.org/drawingml/2006/main">
               <a:ext uri="{FF2B5EF4-FFF2-40B4-BE49-F238E27FC236}">
-                <a16:creationId xmlns:a16="http://schemas.microsoft.com/office/drawing/2014/main" id="{6291D423-BE96-4795-A56A-2E0CF084BC73}"/>
-              </a:ext>
-            </a:extLst>
-          </p:cNvPr>
-          <p:cNvSpPr>
-            <a:spLocks xmlns:a="http://schemas.openxmlformats.org/drawingml/2006/main" noGrp="1"/>
-          </p:cNvSpPr>
-          <p:nvPr/>
-        </p:nvSpPr>
-        <p:spPr>
-          <a:xfrm xmlns:a="http://schemas.openxmlformats.org/drawingml/2006/main">
-            <a:off x="971550" y="2000250"/>
-            <a:ext cx="9696450" cy="419100"/>
+                <a16:creationId xmlns:a16="http://schemas.microsoft.com/office/drawing/2014/main" id="{3AD0BB5B-2451-43CE-99A3-DB761029DBB0}"/>
+              </a:ext>
+            </a:extLst>
+          </p:cNvPr>
+          <p:cNvSpPr>
+            <a:spLocks xmlns:a="http://schemas.openxmlformats.org/drawingml/2006/main" noGrp="1"/>
+          </p:cNvSpPr>
+          <p:nvPr/>
+        </p:nvSpPr>
+        <p:spPr>
+          <a:xfrm xmlns:a="http://schemas.openxmlformats.org/drawingml/2006/main">
+            <a:off x="971550" y="1924050"/>
+            <a:ext cx="9696450" cy="342900"/>
           </a:xfrm>
           <a:prstGeom xmlns:a="http://schemas.openxmlformats.org/drawingml/2006/main" prst="rect">
             <a:avLst/>
@@ -10416,7 +10416,7 @@
           <a:lstStyle xmlns:a="http://schemas.openxmlformats.org/drawingml/2006/main"/>
           <a:p xmlns:a="http://schemas.openxmlformats.org/drawingml/2006/main">
             <a:pPr algn="l">
-              <a:defRPr sz="1725" b="0">
+              <a:defRPr sz="1500" b="0">
                 <a:solidFill>
                   <a:srgbClr val="1F2933"/>
                 </a:solidFill>
@@ -10426,7 +10426,7 @@
               </a:defRPr>
             </a:pPr>
             <a:r>
-              <a:rPr sz="1725" b="0">
+              <a:rPr sz="1500" b="0">
                 <a:solidFill>
                   <a:srgbClr val="1F2933"/>
                 </a:solidFill>
@@ -10434,7 +10434,7 @@
                 <a:ea typeface="Malgun Gothic"/>
                 <a:cs typeface="Malgun Gothic"/>
               </a:rPr>
-              <a:t>checkpoint reward 및 그래프 기반</a:t>
+              <a:t>99K 499K 799K 1M 실제 gameplay montage</a:t>
             </a:r>
           </a:p>
         </p:txBody>
@@ -10444,18 +10444,18 @@
           <p:cNvPr id="10" name="">
             <a:extLst xmlns:a="http://schemas.openxmlformats.org/drawingml/2006/main">
               <a:ext uri="{FF2B5EF4-FFF2-40B4-BE49-F238E27FC236}">
-                <a16:creationId xmlns:a16="http://schemas.microsoft.com/office/drawing/2014/main" id="{F477134F-8AAE-4574-9D06-9D47527FEE03}"/>
-              </a:ext>
-            </a:extLst>
-          </p:cNvPr>
-          <p:cNvSpPr>
-            <a:spLocks xmlns:a="http://schemas.openxmlformats.org/drawingml/2006/main" noGrp="1"/>
-          </p:cNvSpPr>
-          <p:nvPr/>
-        </p:nvSpPr>
-        <p:spPr>
-          <a:xfrm xmlns:a="http://schemas.openxmlformats.org/drawingml/2006/main">
-            <a:off x="762000" y="2505075"/>
+                <a16:creationId xmlns:a16="http://schemas.microsoft.com/office/drawing/2014/main" id="{6C6FE1E1-1DBF-453E-AA18-3BD7E22E53DD}"/>
+              </a:ext>
+            </a:extLst>
+          </p:cNvPr>
+          <p:cNvSpPr>
+            <a:spLocks xmlns:a="http://schemas.openxmlformats.org/drawingml/2006/main" noGrp="1"/>
+          </p:cNvSpPr>
+          <p:nvPr/>
+        </p:nvSpPr>
+        <p:spPr>
+          <a:xfrm xmlns:a="http://schemas.openxmlformats.org/drawingml/2006/main">
+            <a:off x="762000" y="2352675"/>
             <a:ext cx="95250" cy="95250"/>
           </a:xfrm>
           <a:prstGeom xmlns:a="http://schemas.openxmlformats.org/drawingml/2006/main" prst="rect">
@@ -10477,19 +10477,19 @@
           <p:cNvPr id="11" name="">
             <a:extLst xmlns:a="http://schemas.openxmlformats.org/drawingml/2006/main">
               <a:ext uri="{FF2B5EF4-FFF2-40B4-BE49-F238E27FC236}">
-                <a16:creationId xmlns:a16="http://schemas.microsoft.com/office/drawing/2014/main" id="{0EF65BC1-1E91-48D9-B333-B30CD8437C11}"/>
-              </a:ext>
-            </a:extLst>
-          </p:cNvPr>
-          <p:cNvSpPr>
-            <a:spLocks xmlns:a="http://schemas.openxmlformats.org/drawingml/2006/main" noGrp="1"/>
-          </p:cNvSpPr>
-          <p:nvPr/>
-        </p:nvSpPr>
-        <p:spPr>
-          <a:xfrm xmlns:a="http://schemas.openxmlformats.org/drawingml/2006/main">
-            <a:off x="971550" y="2419350"/>
-            <a:ext cx="9696450" cy="419100"/>
+                <a16:creationId xmlns:a16="http://schemas.microsoft.com/office/drawing/2014/main" id="{0FCACF69-65B8-4927-93F1-76241AD5E8F9}"/>
+              </a:ext>
+            </a:extLst>
+          </p:cNvPr>
+          <p:cNvSpPr>
+            <a:spLocks xmlns:a="http://schemas.openxmlformats.org/drawingml/2006/main" noGrp="1"/>
+          </p:cNvSpPr>
+          <p:nvPr/>
+        </p:nvSpPr>
+        <p:spPr>
+          <a:xfrm xmlns:a="http://schemas.openxmlformats.org/drawingml/2006/main">
+            <a:off x="971550" y="2266950"/>
+            <a:ext cx="9696450" cy="342900"/>
           </a:xfrm>
           <a:prstGeom xmlns:a="http://schemas.openxmlformats.org/drawingml/2006/main" prst="rect">
             <a:avLst/>
@@ -10513,7 +10513,7 @@
           <a:lstStyle xmlns:a="http://schemas.openxmlformats.org/drawingml/2006/main"/>
           <a:p xmlns:a="http://schemas.openxmlformats.org/drawingml/2006/main">
             <a:pPr algn="l">
-              <a:defRPr sz="1725" b="0">
+              <a:defRPr sz="1500" b="0">
                 <a:solidFill>
                   <a:srgbClr val="1F2933"/>
                 </a:solidFill>
@@ -10523,7 +10523,104 @@
               </a:defRPr>
             </a:pPr>
             <a:r>
-              <a:rPr sz="1725" b="0">
+              <a:rPr sz="1500" b="0">
+                <a:solidFill>
+                  <a:srgbClr val="1F2933"/>
+                </a:solidFill>
+                <a:latin typeface="Malgun Gothic"/>
+                <a:ea typeface="Malgun Gothic"/>
+                <a:cs typeface="Malgun Gothic"/>
+              </a:rPr>
+              <a:t>checkpoint별 실제 플레이 비교</a:t>
+            </a:r>
+          </a:p>
+        </p:txBody>
+      </p:sp>
+      <p:sp>
+        <p:nvSpPr>
+          <p:cNvPr id="12" name="">
+            <a:extLst xmlns:a="http://schemas.openxmlformats.org/drawingml/2006/main">
+              <a:ext uri="{FF2B5EF4-FFF2-40B4-BE49-F238E27FC236}">
+                <a16:creationId xmlns:a16="http://schemas.microsoft.com/office/drawing/2014/main" id="{E838B746-0901-422B-BFFA-27ED786B092F}"/>
+              </a:ext>
+            </a:extLst>
+          </p:cNvPr>
+          <p:cNvSpPr>
+            <a:spLocks xmlns:a="http://schemas.openxmlformats.org/drawingml/2006/main" noGrp="1"/>
+          </p:cNvSpPr>
+          <p:nvPr/>
+        </p:nvSpPr>
+        <p:spPr>
+          <a:xfrm xmlns:a="http://schemas.openxmlformats.org/drawingml/2006/main">
+            <a:off x="762000" y="2695575"/>
+            <a:ext cx="95250" cy="95250"/>
+          </a:xfrm>
+          <a:prstGeom xmlns:a="http://schemas.openxmlformats.org/drawingml/2006/main" prst="rect">
+            <a:avLst/>
+          </a:prstGeom>
+          <a:solidFill xmlns:a="http://schemas.openxmlformats.org/drawingml/2006/main">
+            <a:srgbClr val="C44536"/>
+          </a:solidFill>
+          <a:ln xmlns:a="http://schemas.openxmlformats.org/drawingml/2006/main" w="0">
+            <a:solidFill>
+              <a:srgbClr val="C44536"/>
+            </a:solidFill>
+            <a:prstDash val="solid"/>
+          </a:ln>
+        </p:spPr>
+      </p:sp>
+      <p:sp>
+        <p:nvSpPr>
+          <p:cNvPr id="13" name="">
+            <a:extLst xmlns:a="http://schemas.openxmlformats.org/drawingml/2006/main">
+              <a:ext uri="{FF2B5EF4-FFF2-40B4-BE49-F238E27FC236}">
+                <a16:creationId xmlns:a16="http://schemas.microsoft.com/office/drawing/2014/main" id="{8F55AC3D-15D5-4E80-94C9-77E78D6B402B}"/>
+              </a:ext>
+            </a:extLst>
+          </p:cNvPr>
+          <p:cNvSpPr>
+            <a:spLocks xmlns:a="http://schemas.openxmlformats.org/drawingml/2006/main" noGrp="1"/>
+          </p:cNvSpPr>
+          <p:nvPr/>
+        </p:nvSpPr>
+        <p:spPr>
+          <a:xfrm xmlns:a="http://schemas.openxmlformats.org/drawingml/2006/main">
+            <a:off x="971550" y="2609850"/>
+            <a:ext cx="9696450" cy="342900"/>
+          </a:xfrm>
+          <a:prstGeom xmlns:a="http://schemas.openxmlformats.org/drawingml/2006/main" prst="rect">
+            <a:avLst/>
+          </a:prstGeom>
+          <a:solidFill xmlns:a="http://schemas.openxmlformats.org/drawingml/2006/main">
+            <a:srgbClr val="FFFFFF">
+              <a:alpha val="0"/>
+            </a:srgbClr>
+          </a:solidFill>
+          <a:ln xmlns:a="http://schemas.openxmlformats.org/drawingml/2006/main" w="0">
+            <a:solidFill>
+              <a:srgbClr val="FFFFFF">
+                <a:alpha val="0"/>
+              </a:srgbClr>
+            </a:solidFill>
+            <a:prstDash val="solid"/>
+          </a:ln>
+        </p:spPr>
+        <p:txBody>
+          <a:bodyPr xmlns:a="http://schemas.openxmlformats.org/drawingml/2006/main" lIns="0" tIns="0" rIns="38100" bIns="0" anchor="t"/>
+          <a:lstStyle xmlns:a="http://schemas.openxmlformats.org/drawingml/2006/main"/>
+          <a:p xmlns:a="http://schemas.openxmlformats.org/drawingml/2006/main">
+            <a:pPr algn="l">
+              <a:defRPr sz="1500" b="0">
+                <a:solidFill>
+                  <a:srgbClr val="1F2933"/>
+                </a:solidFill>
+                <a:latin typeface="Malgun Gothic"/>
+                <a:ea typeface="Malgun Gothic"/>
+                <a:cs typeface="Malgun Gothic"/>
+              </a:defRPr>
+            </a:pPr>
+            <a:r>
+              <a:rPr sz="1500" b="0">
                 <a:solidFill>
                   <a:srgbClr val="1F2933"/>
                 </a:solidFill>
@@ -10538,21 +10635,21 @@
       </p:sp>
       <p:sp>
         <p:nvSpPr>
-          <p:cNvPr id="12" name="">
-            <a:extLst xmlns:a="http://schemas.openxmlformats.org/drawingml/2006/main">
-              <a:ext uri="{FF2B5EF4-FFF2-40B4-BE49-F238E27FC236}">
-                <a16:creationId xmlns:a16="http://schemas.microsoft.com/office/drawing/2014/main" id="{07AA5192-F211-49DA-AA11-422C4F6B92BE}"/>
-              </a:ext>
-            </a:extLst>
-          </p:cNvPr>
-          <p:cNvSpPr>
-            <a:spLocks xmlns:a="http://schemas.openxmlformats.org/drawingml/2006/main" noGrp="1"/>
-          </p:cNvSpPr>
-          <p:nvPr/>
-        </p:nvSpPr>
-        <p:spPr>
-          <a:xfrm xmlns:a="http://schemas.openxmlformats.org/drawingml/2006/main">
-            <a:off x="762000" y="2924175"/>
+          <p:cNvPr id="14" name="">
+            <a:extLst xmlns:a="http://schemas.openxmlformats.org/drawingml/2006/main">
+              <a:ext uri="{FF2B5EF4-FFF2-40B4-BE49-F238E27FC236}">
+                <a16:creationId xmlns:a16="http://schemas.microsoft.com/office/drawing/2014/main" id="{63F4CF9A-CF12-4963-B548-300ECF76AD28}"/>
+              </a:ext>
+            </a:extLst>
+          </p:cNvPr>
+          <p:cNvSpPr>
+            <a:spLocks xmlns:a="http://schemas.openxmlformats.org/drawingml/2006/main" noGrp="1"/>
+          </p:cNvSpPr>
+          <p:nvPr/>
+        </p:nvSpPr>
+        <p:spPr>
+          <a:xfrm xmlns:a="http://schemas.openxmlformats.org/drawingml/2006/main">
+            <a:off x="762000" y="3038475"/>
             <a:ext cx="95250" cy="95250"/>
           </a:xfrm>
           <a:prstGeom xmlns:a="http://schemas.openxmlformats.org/drawingml/2006/main" prst="rect">
@@ -10571,22 +10668,22 @@
       </p:sp>
       <p:sp>
         <p:nvSpPr>
-          <p:cNvPr id="13" name="">
-            <a:extLst xmlns:a="http://schemas.openxmlformats.org/drawingml/2006/main">
-              <a:ext uri="{FF2B5EF4-FFF2-40B4-BE49-F238E27FC236}">
-                <a16:creationId xmlns:a16="http://schemas.microsoft.com/office/drawing/2014/main" id="{A3CB41C7-4140-44A1-9547-E4D068D0E36B}"/>
-              </a:ext>
-            </a:extLst>
-          </p:cNvPr>
-          <p:cNvSpPr>
-            <a:spLocks xmlns:a="http://schemas.openxmlformats.org/drawingml/2006/main" noGrp="1"/>
-          </p:cNvSpPr>
-          <p:nvPr/>
-        </p:nvSpPr>
-        <p:spPr>
-          <a:xfrm xmlns:a="http://schemas.openxmlformats.org/drawingml/2006/main">
-            <a:off x="971550" y="2838450"/>
-            <a:ext cx="9696450" cy="419100"/>
+          <p:cNvPr id="15" name="">
+            <a:extLst xmlns:a="http://schemas.openxmlformats.org/drawingml/2006/main">
+              <a:ext uri="{FF2B5EF4-FFF2-40B4-BE49-F238E27FC236}">
+                <a16:creationId xmlns:a16="http://schemas.microsoft.com/office/drawing/2014/main" id="{FE2571A9-37EF-4851-BA4B-114B256996F8}"/>
+              </a:ext>
+            </a:extLst>
+          </p:cNvPr>
+          <p:cNvSpPr>
+            <a:spLocks xmlns:a="http://schemas.openxmlformats.org/drawingml/2006/main" noGrp="1"/>
+          </p:cNvSpPr>
+          <p:nvPr/>
+        </p:nvSpPr>
+        <p:spPr>
+          <a:xfrm xmlns:a="http://schemas.openxmlformats.org/drawingml/2006/main">
+            <a:off x="971550" y="2952750"/>
+            <a:ext cx="9696450" cy="342900"/>
           </a:xfrm>
           <a:prstGeom xmlns:a="http://schemas.openxmlformats.org/drawingml/2006/main" prst="rect">
             <a:avLst/>
@@ -10610,7 +10707,7 @@
           <a:lstStyle xmlns:a="http://schemas.openxmlformats.org/drawingml/2006/main"/>
           <a:p xmlns:a="http://schemas.openxmlformats.org/drawingml/2006/main">
             <a:pPr algn="l">
-              <a:defRPr sz="1725" b="0">
+              <a:defRPr sz="1500" b="0">
                 <a:solidFill>
                   <a:srgbClr val="1F2933"/>
                 </a:solidFill>
@@ -10620,7 +10717,7 @@
               </a:defRPr>
             </a:pPr>
             <a:r>
-              <a:rPr sz="1725" b="0">
+              <a:rPr sz="1500" b="0">
                 <a:solidFill>
                   <a:srgbClr val="1F2933"/>
                 </a:solidFill>
@@ -10635,21 +10732,21 @@
       </p:sp>
       <p:sp>
         <p:nvSpPr>
-          <p:cNvPr id="14" name="">
-            <a:extLst xmlns:a="http://schemas.openxmlformats.org/drawingml/2006/main">
-              <a:ext uri="{FF2B5EF4-FFF2-40B4-BE49-F238E27FC236}">
-                <a16:creationId xmlns:a16="http://schemas.microsoft.com/office/drawing/2014/main" id="{9C900BAD-5030-4E80-85A4-C631A3CD2132}"/>
-              </a:ext>
-            </a:extLst>
-          </p:cNvPr>
-          <p:cNvSpPr>
-            <a:spLocks xmlns:a="http://schemas.openxmlformats.org/drawingml/2006/main" noGrp="1"/>
-          </p:cNvSpPr>
-          <p:nvPr/>
-        </p:nvSpPr>
-        <p:spPr>
-          <a:xfrm xmlns:a="http://schemas.openxmlformats.org/drawingml/2006/main">
-            <a:off x="762000" y="3343275"/>
+          <p:cNvPr id="16" name="">
+            <a:extLst xmlns:a="http://schemas.openxmlformats.org/drawingml/2006/main">
+              <a:ext uri="{FF2B5EF4-FFF2-40B4-BE49-F238E27FC236}">
+                <a16:creationId xmlns:a16="http://schemas.microsoft.com/office/drawing/2014/main" id="{B9E3AA1B-0F7D-4A8F-80AF-3A9CB9616CE1}"/>
+              </a:ext>
+            </a:extLst>
+          </p:cNvPr>
+          <p:cNvSpPr>
+            <a:spLocks xmlns:a="http://schemas.openxmlformats.org/drawingml/2006/main" noGrp="1"/>
+          </p:cNvSpPr>
+          <p:nvPr/>
+        </p:nvSpPr>
+        <p:spPr>
+          <a:xfrm xmlns:a="http://schemas.openxmlformats.org/drawingml/2006/main">
+            <a:off x="762000" y="3381375"/>
             <a:ext cx="95250" cy="95250"/>
           </a:xfrm>
           <a:prstGeom xmlns:a="http://schemas.openxmlformats.org/drawingml/2006/main" prst="rect">
@@ -10668,22 +10765,22 @@
       </p:sp>
       <p:sp>
         <p:nvSpPr>
-          <p:cNvPr id="15" name="">
-            <a:extLst xmlns:a="http://schemas.openxmlformats.org/drawingml/2006/main">
-              <a:ext uri="{FF2B5EF4-FFF2-40B4-BE49-F238E27FC236}">
-                <a16:creationId xmlns:a16="http://schemas.microsoft.com/office/drawing/2014/main" id="{C073257A-F897-4F03-8051-31D3E06D52F3}"/>
-              </a:ext>
-            </a:extLst>
-          </p:cNvPr>
-          <p:cNvSpPr>
-            <a:spLocks xmlns:a="http://schemas.openxmlformats.org/drawingml/2006/main" noGrp="1"/>
-          </p:cNvSpPr>
-          <p:nvPr/>
-        </p:nvSpPr>
-        <p:spPr>
-          <a:xfrm xmlns:a="http://schemas.openxmlformats.org/drawingml/2006/main">
-            <a:off x="971550" y="3257550"/>
-            <a:ext cx="9696450" cy="419100"/>
+          <p:cNvPr id="17" name="">
+            <a:extLst xmlns:a="http://schemas.openxmlformats.org/drawingml/2006/main">
+              <a:ext uri="{FF2B5EF4-FFF2-40B4-BE49-F238E27FC236}">
+                <a16:creationId xmlns:a16="http://schemas.microsoft.com/office/drawing/2014/main" id="{45F5EF45-CB58-443F-AD1A-A968BD96BF1E}"/>
+              </a:ext>
+            </a:extLst>
+          </p:cNvPr>
+          <p:cNvSpPr>
+            <a:spLocks xmlns:a="http://schemas.openxmlformats.org/drawingml/2006/main" noGrp="1"/>
+          </p:cNvSpPr>
+          <p:nvPr/>
+        </p:nvSpPr>
+        <p:spPr>
+          <a:xfrm xmlns:a="http://schemas.openxmlformats.org/drawingml/2006/main">
+            <a:off x="971550" y="3295650"/>
+            <a:ext cx="9696450" cy="342900"/>
           </a:xfrm>
           <a:prstGeom xmlns:a="http://schemas.openxmlformats.org/drawingml/2006/main" prst="rect">
             <a:avLst/>
@@ -10707,7 +10804,7 @@
           <a:lstStyle xmlns:a="http://schemas.openxmlformats.org/drawingml/2006/main"/>
           <a:p xmlns:a="http://schemas.openxmlformats.org/drawingml/2006/main">
             <a:pPr algn="l">
-              <a:defRPr sz="1725" b="0">
+              <a:defRPr sz="1500" b="0">
                 <a:solidFill>
                   <a:srgbClr val="1F2933"/>
                 </a:solidFill>
@@ -10717,7 +10814,7 @@
               </a:defRPr>
             </a:pPr>
             <a:r>
-              <a:rPr sz="1725" b="0">
+              <a:rPr sz="1500" b="0">
                 <a:solidFill>
                   <a:srgbClr val="1F2933"/>
                 </a:solidFill>
@@ -10732,21 +10829,21 @@
       </p:sp>
       <p:sp>
         <p:nvSpPr>
-          <p:cNvPr id="16" name="">
-            <a:extLst xmlns:a="http://schemas.openxmlformats.org/drawingml/2006/main">
-              <a:ext uri="{FF2B5EF4-FFF2-40B4-BE49-F238E27FC236}">
-                <a16:creationId xmlns:a16="http://schemas.microsoft.com/office/drawing/2014/main" id="{E0A37EA4-C1D4-4381-AE2A-0A0F39FB313E}"/>
-              </a:ext>
-            </a:extLst>
-          </p:cNvPr>
-          <p:cNvSpPr>
-            <a:spLocks xmlns:a="http://schemas.openxmlformats.org/drawingml/2006/main" noGrp="1"/>
-          </p:cNvSpPr>
-          <p:nvPr/>
-        </p:nvSpPr>
-        <p:spPr>
-          <a:xfrm xmlns:a="http://schemas.openxmlformats.org/drawingml/2006/main">
-            <a:off x="762000" y="3762375"/>
+          <p:cNvPr id="18" name="">
+            <a:extLst xmlns:a="http://schemas.openxmlformats.org/drawingml/2006/main">
+              <a:ext uri="{FF2B5EF4-FFF2-40B4-BE49-F238E27FC236}">
+                <a16:creationId xmlns:a16="http://schemas.microsoft.com/office/drawing/2014/main" id="{C212F16F-4690-4077-9516-25AB57FCE799}"/>
+              </a:ext>
+            </a:extLst>
+          </p:cNvPr>
+          <p:cNvSpPr>
+            <a:spLocks xmlns:a="http://schemas.openxmlformats.org/drawingml/2006/main" noGrp="1"/>
+          </p:cNvSpPr>
+          <p:nvPr/>
+        </p:nvSpPr>
+        <p:spPr>
+          <a:xfrm xmlns:a="http://schemas.openxmlformats.org/drawingml/2006/main">
+            <a:off x="762000" y="3724275"/>
             <a:ext cx="95250" cy="95250"/>
           </a:xfrm>
           <a:prstGeom xmlns:a="http://schemas.openxmlformats.org/drawingml/2006/main" prst="rect">
@@ -10765,22 +10862,22 @@
       </p:sp>
       <p:sp>
         <p:nvSpPr>
-          <p:cNvPr id="17" name="">
-            <a:extLst xmlns:a="http://schemas.openxmlformats.org/drawingml/2006/main">
-              <a:ext uri="{FF2B5EF4-FFF2-40B4-BE49-F238E27FC236}">
-                <a16:creationId xmlns:a16="http://schemas.microsoft.com/office/drawing/2014/main" id="{4ED9B3BF-E0E6-4FFE-8572-90F1ED410AF0}"/>
-              </a:ext>
-            </a:extLst>
-          </p:cNvPr>
-          <p:cNvSpPr>
-            <a:spLocks xmlns:a="http://schemas.openxmlformats.org/drawingml/2006/main" noGrp="1"/>
-          </p:cNvSpPr>
-          <p:nvPr/>
-        </p:nvSpPr>
-        <p:spPr>
-          <a:xfrm xmlns:a="http://schemas.openxmlformats.org/drawingml/2006/main">
-            <a:off x="971550" y="3676650"/>
-            <a:ext cx="9696450" cy="419100"/>
+          <p:cNvPr id="19" name="">
+            <a:extLst xmlns:a="http://schemas.openxmlformats.org/drawingml/2006/main">
+              <a:ext uri="{FF2B5EF4-FFF2-40B4-BE49-F238E27FC236}">
+                <a16:creationId xmlns:a16="http://schemas.microsoft.com/office/drawing/2014/main" id="{5016F848-D3B2-44B9-9EC3-8BB162678448}"/>
+              </a:ext>
+            </a:extLst>
+          </p:cNvPr>
+          <p:cNvSpPr>
+            <a:spLocks xmlns:a="http://schemas.openxmlformats.org/drawingml/2006/main" noGrp="1"/>
+          </p:cNvSpPr>
+          <p:nvPr/>
+        </p:nvSpPr>
+        <p:spPr>
+          <a:xfrm xmlns:a="http://schemas.openxmlformats.org/drawingml/2006/main">
+            <a:off x="971550" y="3638550"/>
+            <a:ext cx="9696450" cy="342900"/>
           </a:xfrm>
           <a:prstGeom xmlns:a="http://schemas.openxmlformats.org/drawingml/2006/main" prst="rect">
             <a:avLst/>
@@ -10804,7 +10901,7 @@
           <a:lstStyle xmlns:a="http://schemas.openxmlformats.org/drawingml/2006/main"/>
           <a:p xmlns:a="http://schemas.openxmlformats.org/drawingml/2006/main">
             <a:pPr algn="l">
-              <a:defRPr sz="1725" b="0">
+              <a:defRPr sz="1500" b="0">
                 <a:solidFill>
                   <a:srgbClr val="1F2933"/>
                 </a:solidFill>
@@ -10814,7 +10911,7 @@
               </a:defRPr>
             </a:pPr>
             <a:r>
-              <a:rPr sz="1725" b="0">
+              <a:rPr sz="1500" b="0">
                 <a:solidFill>
                   <a:srgbClr val="1F2933"/>
                 </a:solidFill>
@@ -10822,17 +10919,17 @@
                 <a:ea typeface="Malgun Gothic"/>
                 <a:cs typeface="Malgun Gothic"/>
               </a:rPr>
-              <a:t>최종 정책으로 수렴하는 흐름</a:t>
+              <a:t>설명 슬라이드 사용 없음</a:t>
             </a:r>
           </a:p>
         </p:txBody>
       </p:sp>
       <p:sp>
         <p:nvSpPr>
-          <p:cNvPr id="18" name="">
-            <a:extLst xmlns:a="http://schemas.openxmlformats.org/drawingml/2006/main">
-              <a:ext uri="{FF2B5EF4-FFF2-40B4-BE49-F238E27FC236}">
-                <a16:creationId xmlns:a16="http://schemas.microsoft.com/office/drawing/2014/main" id="{EBAA52A7-30A9-45DB-964F-0CFDED4FD170}"/>
+          <p:cNvPr id="20" name="">
+            <a:extLst xmlns:a="http://schemas.openxmlformats.org/drawingml/2006/main">
+              <a:ext uri="{FF2B5EF4-FFF2-40B4-BE49-F238E27FC236}">
+                <a16:creationId xmlns:a16="http://schemas.microsoft.com/office/drawing/2014/main" id="{0A8480B6-14A6-4CF8-8456-ADD23D85202F}"/>
               </a:ext>
             </a:extLst>
           </p:cNvPr>
@@ -10893,10 +10990,10 @@
       </p:sp>
       <p:sp>
         <p:nvSpPr>
-          <p:cNvPr id="19" name="">
-            <a:extLst xmlns:a="http://schemas.openxmlformats.org/drawingml/2006/main">
-              <a:ext uri="{FF2B5EF4-FFF2-40B4-BE49-F238E27FC236}">
-                <a16:creationId xmlns:a16="http://schemas.microsoft.com/office/drawing/2014/main" id="{0B527F6C-913E-43BC-8F5B-09FB5893698B}"/>
+          <p:cNvPr id="21" name="">
+            <a:extLst xmlns:a="http://schemas.openxmlformats.org/drawingml/2006/main">
+              <a:ext uri="{FF2B5EF4-FFF2-40B4-BE49-F238E27FC236}">
+                <a16:creationId xmlns:a16="http://schemas.microsoft.com/office/drawing/2014/main" id="{8281D9D9-3FE4-41A8-9D86-C2398C95297D}"/>
               </a:ext>
             </a:extLst>
           </p:cNvPr>
@@ -10958,7 +11055,7 @@
     </p:spTree>
     <p:extLst>
       <p:ext uri="{BB962C8B-B14F-4D97-AF65-F5344CB8AC3E}">
-        <p14:creationId xmlns:p14="http://schemas.microsoft.com/office/powerpoint/2010/main" val="1293189315"/>
+        <p14:creationId xmlns:p14="http://schemas.microsoft.com/office/powerpoint/2010/main" val="436206472"/>
       </p:ext>
     </p:extLst>
   </p:cSld>
@@ -10982,7 +11079,7 @@
           <p:cNvPr id="1" name="">
             <a:extLst xmlns:a="http://schemas.openxmlformats.org/drawingml/2006/main">
               <a:ext uri="{FF2B5EF4-FFF2-40B4-BE49-F238E27FC236}">
-                <a16:creationId xmlns:a16="http://schemas.microsoft.com/office/drawing/2014/main" id="{70BA382F-1F26-4E0D-A1ED-35BAB8E991A7}"/>
+                <a16:creationId xmlns:a16="http://schemas.microsoft.com/office/drawing/2014/main" id="{7DD72D40-8C6D-4B32-BD22-E82BBC65F2C8}"/>
               </a:ext>
             </a:extLst>
           </p:cNvPr>
@@ -11015,7 +11112,7 @@
           <p:cNvPr id="2" name="">
             <a:extLst xmlns:a="http://schemas.openxmlformats.org/drawingml/2006/main">
               <a:ext uri="{FF2B5EF4-FFF2-40B4-BE49-F238E27FC236}">
-                <a16:creationId xmlns:a16="http://schemas.microsoft.com/office/drawing/2014/main" id="{E0FC74F3-466B-4646-A6ED-88FBFCB6BF7E}"/>
+                <a16:creationId xmlns:a16="http://schemas.microsoft.com/office/drawing/2014/main" id="{D9292D2B-E02C-4691-B24F-04AB69D3BD1E}"/>
               </a:ext>
             </a:extLst>
           </p:cNvPr>
@@ -11048,7 +11145,7 @@
           <p:cNvPr id="3" name="">
             <a:extLst xmlns:a="http://schemas.openxmlformats.org/drawingml/2006/main">
               <a:ext uri="{FF2B5EF4-FFF2-40B4-BE49-F238E27FC236}">
-                <a16:creationId xmlns:a16="http://schemas.microsoft.com/office/drawing/2014/main" id="{4B747A71-F817-4142-8DD9-A4F600DD9036}"/>
+                <a16:creationId xmlns:a16="http://schemas.microsoft.com/office/drawing/2014/main" id="{43B4FF6B-59C2-42DE-86C1-CA7320FA380A}"/>
               </a:ext>
             </a:extLst>
           </p:cNvPr>
@@ -11112,7 +11209,7 @@
           <p:cNvPr id="4" name="">
             <a:extLst xmlns:a="http://schemas.openxmlformats.org/drawingml/2006/main">
               <a:ext uri="{FF2B5EF4-FFF2-40B4-BE49-F238E27FC236}">
-                <a16:creationId xmlns:a16="http://schemas.microsoft.com/office/drawing/2014/main" id="{51A80132-29FE-49D6-9B56-C462A1B17334}"/>
+                <a16:creationId xmlns:a16="http://schemas.microsoft.com/office/drawing/2014/main" id="{BD59E87F-5817-4DDE-B961-A6718041043F}"/>
               </a:ext>
             </a:extLst>
           </p:cNvPr>
@@ -11176,7 +11273,7 @@
           <p:cNvPr id="5" name="">
             <a:extLst xmlns:a="http://schemas.openxmlformats.org/drawingml/2006/main">
               <a:ext uri="{FF2B5EF4-FFF2-40B4-BE49-F238E27FC236}">
-                <a16:creationId xmlns:a16="http://schemas.microsoft.com/office/drawing/2014/main" id="{DD19939C-768C-4FF9-A90D-A3725F25E64F}"/>
+                <a16:creationId xmlns:a16="http://schemas.microsoft.com/office/drawing/2014/main" id="{B1B5BA86-77CB-410E-A58C-C14C732F506A}"/>
               </a:ext>
             </a:extLst>
           </p:cNvPr>
@@ -11209,7 +11306,7 @@
           <p:cNvPr id="6" name="">
             <a:extLst xmlns:a="http://schemas.openxmlformats.org/drawingml/2006/main">
               <a:ext uri="{FF2B5EF4-FFF2-40B4-BE49-F238E27FC236}">
-                <a16:creationId xmlns:a16="http://schemas.microsoft.com/office/drawing/2014/main" id="{472E2EC5-9BFE-43D5-8B73-673611BF67AF}"/>
+                <a16:creationId xmlns:a16="http://schemas.microsoft.com/office/drawing/2014/main" id="{DADA5E46-5604-485F-A416-F8FC3FAC112D}"/>
               </a:ext>
             </a:extLst>
           </p:cNvPr>
@@ -11242,7 +11339,7 @@
           <p:cNvPr id="7" name="">
             <a:extLst xmlns:a="http://schemas.openxmlformats.org/drawingml/2006/main">
               <a:ext uri="{FF2B5EF4-FFF2-40B4-BE49-F238E27FC236}">
-                <a16:creationId xmlns:a16="http://schemas.microsoft.com/office/drawing/2014/main" id="{DB72B998-5D3A-454B-824E-66CDD19995BF}"/>
+                <a16:creationId xmlns:a16="http://schemas.microsoft.com/office/drawing/2014/main" id="{E056BDD7-A09B-4F21-9E68-7F1E73C3B4E8}"/>
               </a:ext>
             </a:extLst>
           </p:cNvPr>
@@ -11306,7 +11403,7 @@
           <p:cNvPr id="8" name="">
             <a:extLst xmlns:a="http://schemas.openxmlformats.org/drawingml/2006/main">
               <a:ext uri="{FF2B5EF4-FFF2-40B4-BE49-F238E27FC236}">
-                <a16:creationId xmlns:a16="http://schemas.microsoft.com/office/drawing/2014/main" id="{A182A164-2B03-4606-BC5C-5002BC776F38}"/>
+                <a16:creationId xmlns:a16="http://schemas.microsoft.com/office/drawing/2014/main" id="{49838B25-330F-4EA0-ADAA-86546B63D385}"/>
               </a:ext>
             </a:extLst>
           </p:cNvPr>
@@ -11339,7 +11436,7 @@
           <p:cNvPr id="9" name="">
             <a:extLst xmlns:a="http://schemas.openxmlformats.org/drawingml/2006/main">
               <a:ext uri="{FF2B5EF4-FFF2-40B4-BE49-F238E27FC236}">
-                <a16:creationId xmlns:a16="http://schemas.microsoft.com/office/drawing/2014/main" id="{AA85C9ED-E952-40E5-A742-CD6241DAF51F}"/>
+                <a16:creationId xmlns:a16="http://schemas.microsoft.com/office/drawing/2014/main" id="{DB10BE0C-C0F1-4F67-A67B-3D21F8FE2341}"/>
               </a:ext>
             </a:extLst>
           </p:cNvPr>
@@ -11403,7 +11500,7 @@
           <p:cNvPr id="10" name="">
             <a:extLst xmlns:a="http://schemas.openxmlformats.org/drawingml/2006/main">
               <a:ext uri="{FF2B5EF4-FFF2-40B4-BE49-F238E27FC236}">
-                <a16:creationId xmlns:a16="http://schemas.microsoft.com/office/drawing/2014/main" id="{E824B6AC-6018-42E1-B8E8-275A01586FA2}"/>
+                <a16:creationId xmlns:a16="http://schemas.microsoft.com/office/drawing/2014/main" id="{B707A4CB-7668-4EA0-B669-9D4A4F31A0EC}"/>
               </a:ext>
             </a:extLst>
           </p:cNvPr>
@@ -11436,7 +11533,7 @@
           <p:cNvPr id="11" name="">
             <a:extLst xmlns:a="http://schemas.openxmlformats.org/drawingml/2006/main">
               <a:ext uri="{FF2B5EF4-FFF2-40B4-BE49-F238E27FC236}">
-                <a16:creationId xmlns:a16="http://schemas.microsoft.com/office/drawing/2014/main" id="{2A2836BF-F5D4-4A00-A3B7-53F8C0B3BE13}"/>
+                <a16:creationId xmlns:a16="http://schemas.microsoft.com/office/drawing/2014/main" id="{8D13CFBA-2B82-4026-9EAD-6F9693530762}"/>
               </a:ext>
             </a:extLst>
           </p:cNvPr>
@@ -11500,7 +11597,7 @@
           <p:cNvPr id="12" name="">
             <a:extLst xmlns:a="http://schemas.openxmlformats.org/drawingml/2006/main">
               <a:ext uri="{FF2B5EF4-FFF2-40B4-BE49-F238E27FC236}">
-                <a16:creationId xmlns:a16="http://schemas.microsoft.com/office/drawing/2014/main" id="{F64B6BAB-A1E8-4844-A168-83CC64A9510E}"/>
+                <a16:creationId xmlns:a16="http://schemas.microsoft.com/office/drawing/2014/main" id="{6F7CA58C-BE2E-400F-A84F-A6354E5802E8}"/>
               </a:ext>
             </a:extLst>
           </p:cNvPr>
@@ -11533,7 +11630,7 @@
           <p:cNvPr id="13" name="">
             <a:extLst xmlns:a="http://schemas.openxmlformats.org/drawingml/2006/main">
               <a:ext uri="{FF2B5EF4-FFF2-40B4-BE49-F238E27FC236}">
-                <a16:creationId xmlns:a16="http://schemas.microsoft.com/office/drawing/2014/main" id="{280F7418-0AE5-4097-BC50-27592D6351A1}"/>
+                <a16:creationId xmlns:a16="http://schemas.microsoft.com/office/drawing/2014/main" id="{9BC5D190-054A-4841-BCEF-66B68D188DFA}"/>
               </a:ext>
             </a:extLst>
           </p:cNvPr>
@@ -11597,7 +11694,7 @@
           <p:cNvPr id="14" name="">
             <a:extLst xmlns:a="http://schemas.openxmlformats.org/drawingml/2006/main">
               <a:ext uri="{FF2B5EF4-FFF2-40B4-BE49-F238E27FC236}">
-                <a16:creationId xmlns:a16="http://schemas.microsoft.com/office/drawing/2014/main" id="{655C356B-C8D7-4CE0-81BC-8975F8EDCBCB}"/>
+                <a16:creationId xmlns:a16="http://schemas.microsoft.com/office/drawing/2014/main" id="{F9E3A09B-59C4-4E6B-BCEA-B808FFF8CD15}"/>
               </a:ext>
             </a:extLst>
           </p:cNvPr>
@@ -11630,7 +11727,7 @@
           <p:cNvPr id="15" name="">
             <a:extLst xmlns:a="http://schemas.openxmlformats.org/drawingml/2006/main">
               <a:ext uri="{FF2B5EF4-FFF2-40B4-BE49-F238E27FC236}">
-                <a16:creationId xmlns:a16="http://schemas.microsoft.com/office/drawing/2014/main" id="{A811AA6D-7BAF-421B-A30F-CBEDC47D7082}"/>
+                <a16:creationId xmlns:a16="http://schemas.microsoft.com/office/drawing/2014/main" id="{11F838B6-3FE2-4D9A-9AD7-97306CB6B577}"/>
               </a:ext>
             </a:extLst>
           </p:cNvPr>
@@ -11694,7 +11791,7 @@
           <p:cNvPr id="16" name="">
             <a:extLst xmlns:a="http://schemas.openxmlformats.org/drawingml/2006/main">
               <a:ext uri="{FF2B5EF4-FFF2-40B4-BE49-F238E27FC236}">
-                <a16:creationId xmlns:a16="http://schemas.microsoft.com/office/drawing/2014/main" id="{04503D5A-4A2F-49E3-8BBD-D4CA9D67572A}"/>
+                <a16:creationId xmlns:a16="http://schemas.microsoft.com/office/drawing/2014/main" id="{701604C4-735B-41FF-9006-95BF1B0EF04B}"/>
               </a:ext>
             </a:extLst>
           </p:cNvPr>
@@ -11727,7 +11824,7 @@
           <p:cNvPr id="17" name="">
             <a:extLst xmlns:a="http://schemas.openxmlformats.org/drawingml/2006/main">
               <a:ext uri="{FF2B5EF4-FFF2-40B4-BE49-F238E27FC236}">
-                <a16:creationId xmlns:a16="http://schemas.microsoft.com/office/drawing/2014/main" id="{6CD482BF-9193-4DA5-BB48-F1A3B74E3B17}"/>
+                <a16:creationId xmlns:a16="http://schemas.microsoft.com/office/drawing/2014/main" id="{0A52B95A-25A6-413E-B5D5-38CBF3E9093D}"/>
               </a:ext>
             </a:extLst>
           </p:cNvPr>
@@ -11791,7 +11888,7 @@
           <p:cNvPr id="18" name="">
             <a:extLst xmlns:a="http://schemas.openxmlformats.org/drawingml/2006/main">
               <a:ext uri="{FF2B5EF4-FFF2-40B4-BE49-F238E27FC236}">
-                <a16:creationId xmlns:a16="http://schemas.microsoft.com/office/drawing/2014/main" id="{0B85EFD7-07A0-4C90-AEC1-84171DD50628}"/>
+                <a16:creationId xmlns:a16="http://schemas.microsoft.com/office/drawing/2014/main" id="{370EBB3E-419F-4E49-ABFE-E590F52C2813}"/>
               </a:ext>
             </a:extLst>
           </p:cNvPr>
@@ -11855,7 +11952,7 @@
           <p:cNvPr id="19" name="">
             <a:extLst xmlns:a="http://schemas.openxmlformats.org/drawingml/2006/main">
               <a:ext uri="{FF2B5EF4-FFF2-40B4-BE49-F238E27FC236}">
-                <a16:creationId xmlns:a16="http://schemas.microsoft.com/office/drawing/2014/main" id="{CED93DAE-FE89-4538-B099-B3522DFC20C8}"/>
+                <a16:creationId xmlns:a16="http://schemas.microsoft.com/office/drawing/2014/main" id="{E78265EE-7B48-47FC-8395-B21F77E6C7EF}"/>
               </a:ext>
             </a:extLst>
           </p:cNvPr>
@@ -11917,7 +12014,7 @@
     </p:spTree>
     <p:extLst>
       <p:ext uri="{BB962C8B-B14F-4D97-AF65-F5344CB8AC3E}">
-        <p14:creationId xmlns:p14="http://schemas.microsoft.com/office/powerpoint/2010/main" val="1719535855"/>
+        <p14:creationId xmlns:p14="http://schemas.microsoft.com/office/powerpoint/2010/main" val="560985683"/>
       </p:ext>
     </p:extLst>
   </p:cSld>
@@ -11941,7 +12038,7 @@
           <p:cNvPr id="1" name="">
             <a:extLst xmlns:a="http://schemas.openxmlformats.org/drawingml/2006/main">
               <a:ext uri="{FF2B5EF4-FFF2-40B4-BE49-F238E27FC236}">
-                <a16:creationId xmlns:a16="http://schemas.microsoft.com/office/drawing/2014/main" id="{C65F2569-8DE0-434F-951A-7BECD629F379}"/>
+                <a16:creationId xmlns:a16="http://schemas.microsoft.com/office/drawing/2014/main" id="{3AFB99FE-23BA-4C09-9DFD-89B9FA885E9C}"/>
               </a:ext>
             </a:extLst>
           </p:cNvPr>
@@ -11974,7 +12071,7 @@
           <p:cNvPr id="2" name="">
             <a:extLst xmlns:a="http://schemas.openxmlformats.org/drawingml/2006/main">
               <a:ext uri="{FF2B5EF4-FFF2-40B4-BE49-F238E27FC236}">
-                <a16:creationId xmlns:a16="http://schemas.microsoft.com/office/drawing/2014/main" id="{8B2023AD-35C5-40EB-A8B3-AA345973D741}"/>
+                <a16:creationId xmlns:a16="http://schemas.microsoft.com/office/drawing/2014/main" id="{51D095CE-195E-42E8-A5DE-3AC3994BBFF5}"/>
               </a:ext>
             </a:extLst>
           </p:cNvPr>
@@ -12007,7 +12104,7 @@
           <p:cNvPr id="3" name="">
             <a:extLst xmlns:a="http://schemas.openxmlformats.org/drawingml/2006/main">
               <a:ext uri="{FF2B5EF4-FFF2-40B4-BE49-F238E27FC236}">
-                <a16:creationId xmlns:a16="http://schemas.microsoft.com/office/drawing/2014/main" id="{A885ABE2-0D92-4F44-A3EA-B71ACE66C1F8}"/>
+                <a16:creationId xmlns:a16="http://schemas.microsoft.com/office/drawing/2014/main" id="{A7A7C610-F753-483F-9C4C-D3481C12EDA7}"/>
               </a:ext>
             </a:extLst>
           </p:cNvPr>
@@ -12071,7 +12168,7 @@
           <p:cNvPr id="4" name="">
             <a:extLst xmlns:a="http://schemas.openxmlformats.org/drawingml/2006/main">
               <a:ext uri="{FF2B5EF4-FFF2-40B4-BE49-F238E27FC236}">
-                <a16:creationId xmlns:a16="http://schemas.microsoft.com/office/drawing/2014/main" id="{13999E25-8BA4-42F9-B19E-9F4440528950}"/>
+                <a16:creationId xmlns:a16="http://schemas.microsoft.com/office/drawing/2014/main" id="{C717A070-DB68-4065-9A75-60C88892F9D6}"/>
               </a:ext>
             </a:extLst>
           </p:cNvPr>
@@ -12135,7 +12232,7 @@
           <p:cNvPr id="5" name="">
             <a:extLst xmlns:a="http://schemas.openxmlformats.org/drawingml/2006/main">
               <a:ext uri="{FF2B5EF4-FFF2-40B4-BE49-F238E27FC236}">
-                <a16:creationId xmlns:a16="http://schemas.microsoft.com/office/drawing/2014/main" id="{04EB67E1-0E8A-4FE3-BDD7-A1EBC9B29CE8}"/>
+                <a16:creationId xmlns:a16="http://schemas.microsoft.com/office/drawing/2014/main" id="{BDCC1EE9-8AFE-43A4-B0DB-67951DF28D28}"/>
               </a:ext>
             </a:extLst>
           </p:cNvPr>
@@ -12168,7 +12265,7 @@
           <p:cNvPr id="6" name="">
             <a:extLst xmlns:a="http://schemas.openxmlformats.org/drawingml/2006/main">
               <a:ext uri="{FF2B5EF4-FFF2-40B4-BE49-F238E27FC236}">
-                <a16:creationId xmlns:a16="http://schemas.microsoft.com/office/drawing/2014/main" id="{9DFD460F-DD09-400F-98BC-3CD8500AF223}"/>
+                <a16:creationId xmlns:a16="http://schemas.microsoft.com/office/drawing/2014/main" id="{100566C8-DCA0-4D14-BA54-49B2081C5C31}"/>
               </a:ext>
             </a:extLst>
           </p:cNvPr>
@@ -12201,7 +12298,7 @@
           <p:cNvPr id="7" name="">
             <a:extLst xmlns:a="http://schemas.openxmlformats.org/drawingml/2006/main">
               <a:ext uri="{FF2B5EF4-FFF2-40B4-BE49-F238E27FC236}">
-                <a16:creationId xmlns:a16="http://schemas.microsoft.com/office/drawing/2014/main" id="{2A9663D8-C626-4507-9E79-E707A6F44013}"/>
+                <a16:creationId xmlns:a16="http://schemas.microsoft.com/office/drawing/2014/main" id="{6539FEB8-2265-4D47-B536-62261C5325ED}"/>
               </a:ext>
             </a:extLst>
           </p:cNvPr>
@@ -12265,7 +12362,7 @@
           <p:cNvPr id="8" name="">
             <a:extLst xmlns:a="http://schemas.openxmlformats.org/drawingml/2006/main">
               <a:ext uri="{FF2B5EF4-FFF2-40B4-BE49-F238E27FC236}">
-                <a16:creationId xmlns:a16="http://schemas.microsoft.com/office/drawing/2014/main" id="{67A2DE43-BAC6-446F-A809-2409068F8FF0}"/>
+                <a16:creationId xmlns:a16="http://schemas.microsoft.com/office/drawing/2014/main" id="{BD118551-7354-497A-A267-5747C3FF8C0A}"/>
               </a:ext>
             </a:extLst>
           </p:cNvPr>
@@ -12298,7 +12395,7 @@
           <p:cNvPr id="9" name="">
             <a:extLst xmlns:a="http://schemas.openxmlformats.org/drawingml/2006/main">
               <a:ext uri="{FF2B5EF4-FFF2-40B4-BE49-F238E27FC236}">
-                <a16:creationId xmlns:a16="http://schemas.microsoft.com/office/drawing/2014/main" id="{A005813B-A3D1-4B87-B6F4-AF86B84990E7}"/>
+                <a16:creationId xmlns:a16="http://schemas.microsoft.com/office/drawing/2014/main" id="{0B978200-EEF9-44A9-B5CB-74750E5E5AA8}"/>
               </a:ext>
             </a:extLst>
           </p:cNvPr>
@@ -12362,7 +12459,7 @@
           <p:cNvPr id="10" name="">
             <a:extLst xmlns:a="http://schemas.openxmlformats.org/drawingml/2006/main">
               <a:ext uri="{FF2B5EF4-FFF2-40B4-BE49-F238E27FC236}">
-                <a16:creationId xmlns:a16="http://schemas.microsoft.com/office/drawing/2014/main" id="{0FC333CE-E3F3-40BF-90A2-575A0EA748CB}"/>
+                <a16:creationId xmlns:a16="http://schemas.microsoft.com/office/drawing/2014/main" id="{16551D17-7583-4768-A4C9-A103708E4EF8}"/>
               </a:ext>
             </a:extLst>
           </p:cNvPr>
@@ -12395,7 +12492,7 @@
           <p:cNvPr id="11" name="">
             <a:extLst xmlns:a="http://schemas.openxmlformats.org/drawingml/2006/main">
               <a:ext uri="{FF2B5EF4-FFF2-40B4-BE49-F238E27FC236}">
-                <a16:creationId xmlns:a16="http://schemas.microsoft.com/office/drawing/2014/main" id="{7703AC79-6734-42C6-BD16-EE6EDAB30446}"/>
+                <a16:creationId xmlns:a16="http://schemas.microsoft.com/office/drawing/2014/main" id="{9B8A43ED-C3F4-4ADA-8D70-FA608A9C7544}"/>
               </a:ext>
             </a:extLst>
           </p:cNvPr>
@@ -12459,7 +12556,7 @@
           <p:cNvPr id="12" name="">
             <a:extLst xmlns:a="http://schemas.openxmlformats.org/drawingml/2006/main">
               <a:ext uri="{FF2B5EF4-FFF2-40B4-BE49-F238E27FC236}">
-                <a16:creationId xmlns:a16="http://schemas.microsoft.com/office/drawing/2014/main" id="{D24820D4-B18D-4E64-AE5B-7773314C9FED}"/>
+                <a16:creationId xmlns:a16="http://schemas.microsoft.com/office/drawing/2014/main" id="{F1A3E725-B373-489B-99B8-95771CB4DF46}"/>
               </a:ext>
             </a:extLst>
           </p:cNvPr>
@@ -12492,7 +12589,7 @@
           <p:cNvPr id="13" name="">
             <a:extLst xmlns:a="http://schemas.openxmlformats.org/drawingml/2006/main">
               <a:ext uri="{FF2B5EF4-FFF2-40B4-BE49-F238E27FC236}">
-                <a16:creationId xmlns:a16="http://schemas.microsoft.com/office/drawing/2014/main" id="{77803DF4-D743-4285-9EDB-257EF6CADCB5}"/>
+                <a16:creationId xmlns:a16="http://schemas.microsoft.com/office/drawing/2014/main" id="{C0A831C2-88F1-4297-A4C9-9A7E79764216}"/>
               </a:ext>
             </a:extLst>
           </p:cNvPr>
@@ -12556,7 +12653,7 @@
           <p:cNvPr id="14" name="">
             <a:extLst xmlns:a="http://schemas.openxmlformats.org/drawingml/2006/main">
               <a:ext uri="{FF2B5EF4-FFF2-40B4-BE49-F238E27FC236}">
-                <a16:creationId xmlns:a16="http://schemas.microsoft.com/office/drawing/2014/main" id="{2346480A-E722-4DAF-BE06-E82511DD8833}"/>
+                <a16:creationId xmlns:a16="http://schemas.microsoft.com/office/drawing/2014/main" id="{BEDF0454-CA89-4DE4-85C9-1D48095D0DA5}"/>
               </a:ext>
             </a:extLst>
           </p:cNvPr>
@@ -12589,7 +12686,7 @@
           <p:cNvPr id="15" name="">
             <a:extLst xmlns:a="http://schemas.openxmlformats.org/drawingml/2006/main">
               <a:ext uri="{FF2B5EF4-FFF2-40B4-BE49-F238E27FC236}">
-                <a16:creationId xmlns:a16="http://schemas.microsoft.com/office/drawing/2014/main" id="{C2E88035-7E2E-4070-AD65-484369FED1B2}"/>
+                <a16:creationId xmlns:a16="http://schemas.microsoft.com/office/drawing/2014/main" id="{82007D77-6966-4F1B-ACAD-7E14602883CB}"/>
               </a:ext>
             </a:extLst>
           </p:cNvPr>
@@ -12653,7 +12750,7 @@
           <p:cNvPr id="16" name="">
             <a:extLst xmlns:a="http://schemas.openxmlformats.org/drawingml/2006/main">
               <a:ext uri="{FF2B5EF4-FFF2-40B4-BE49-F238E27FC236}">
-                <a16:creationId xmlns:a16="http://schemas.microsoft.com/office/drawing/2014/main" id="{5B5CE9D4-6B02-46B0-896D-616822E04EEB}"/>
+                <a16:creationId xmlns:a16="http://schemas.microsoft.com/office/drawing/2014/main" id="{61E1E683-6456-45D1-9B06-0F3C9AF28249}"/>
               </a:ext>
             </a:extLst>
           </p:cNvPr>
@@ -12686,7 +12783,7 @@
           <p:cNvPr id="17" name="">
             <a:extLst xmlns:a="http://schemas.openxmlformats.org/drawingml/2006/main">
               <a:ext uri="{FF2B5EF4-FFF2-40B4-BE49-F238E27FC236}">
-                <a16:creationId xmlns:a16="http://schemas.microsoft.com/office/drawing/2014/main" id="{27838CA0-D6D6-4F2D-A352-DEF1CF563F66}"/>
+                <a16:creationId xmlns:a16="http://schemas.microsoft.com/office/drawing/2014/main" id="{F33C58A5-FF47-485A-9CE6-2FAE953C26B5}"/>
               </a:ext>
             </a:extLst>
           </p:cNvPr>
@@ -12750,7 +12847,7 @@
           <p:cNvPr id="18" name="">
             <a:extLst xmlns:a="http://schemas.openxmlformats.org/drawingml/2006/main">
               <a:ext uri="{FF2B5EF4-FFF2-40B4-BE49-F238E27FC236}">
-                <a16:creationId xmlns:a16="http://schemas.microsoft.com/office/drawing/2014/main" id="{39C7D9A2-637D-4CD8-9FA0-BFCAF24DF9A7}"/>
+                <a16:creationId xmlns:a16="http://schemas.microsoft.com/office/drawing/2014/main" id="{3932C213-D59C-40C6-9962-0289901D5E2B}"/>
               </a:ext>
             </a:extLst>
           </p:cNvPr>
@@ -12814,7 +12911,7 @@
           <p:cNvPr id="19" name="">
             <a:extLst xmlns:a="http://schemas.openxmlformats.org/drawingml/2006/main">
               <a:ext uri="{FF2B5EF4-FFF2-40B4-BE49-F238E27FC236}">
-                <a16:creationId xmlns:a16="http://schemas.microsoft.com/office/drawing/2014/main" id="{15C50105-888F-4DBF-BFF8-3E25EB3D2087}"/>
+                <a16:creationId xmlns:a16="http://schemas.microsoft.com/office/drawing/2014/main" id="{6FE58B3F-6020-4E6E-A01F-D8503A487D82}"/>
               </a:ext>
             </a:extLst>
           </p:cNvPr>
@@ -12876,7 +12973,7 @@
     </p:spTree>
     <p:extLst>
       <p:ext uri="{BB962C8B-B14F-4D97-AF65-F5344CB8AC3E}">
-        <p14:creationId xmlns:p14="http://schemas.microsoft.com/office/powerpoint/2010/main" val="1421475261"/>
+        <p14:creationId xmlns:p14="http://schemas.microsoft.com/office/powerpoint/2010/main" val="1634464185"/>
       </p:ext>
     </p:extLst>
   </p:cSld>
@@ -12900,7 +12997,7 @@
           <p:cNvPr id="1" name="">
             <a:extLst xmlns:a="http://schemas.openxmlformats.org/drawingml/2006/main">
               <a:ext uri="{FF2B5EF4-FFF2-40B4-BE49-F238E27FC236}">
-                <a16:creationId xmlns:a16="http://schemas.microsoft.com/office/drawing/2014/main" id="{FBA38A4B-C02B-4C58-8C1D-92AC96219D8B}"/>
+                <a16:creationId xmlns:a16="http://schemas.microsoft.com/office/drawing/2014/main" id="{8B3142E2-29D1-4551-9EFD-46285C63E0F5}"/>
               </a:ext>
             </a:extLst>
           </p:cNvPr>
@@ -12933,7 +13030,7 @@
           <p:cNvPr id="2" name="">
             <a:extLst xmlns:a="http://schemas.openxmlformats.org/drawingml/2006/main">
               <a:ext uri="{FF2B5EF4-FFF2-40B4-BE49-F238E27FC236}">
-                <a16:creationId xmlns:a16="http://schemas.microsoft.com/office/drawing/2014/main" id="{63CCFC13-2EFD-4D92-9567-7512317DE1CD}"/>
+                <a16:creationId xmlns:a16="http://schemas.microsoft.com/office/drawing/2014/main" id="{F70AA978-6FC9-4503-B26A-49E391C95A59}"/>
               </a:ext>
             </a:extLst>
           </p:cNvPr>
@@ -12966,7 +13063,7 @@
           <p:cNvPr id="3" name="">
             <a:extLst xmlns:a="http://schemas.openxmlformats.org/drawingml/2006/main">
               <a:ext uri="{FF2B5EF4-FFF2-40B4-BE49-F238E27FC236}">
-                <a16:creationId xmlns:a16="http://schemas.microsoft.com/office/drawing/2014/main" id="{3E0BEB59-A9F2-4F7B-80D9-5C5717496FF0}"/>
+                <a16:creationId xmlns:a16="http://schemas.microsoft.com/office/drawing/2014/main" id="{D3E905DF-2800-41AD-8E2F-9BC8E7B5B6EE}"/>
               </a:ext>
             </a:extLst>
           </p:cNvPr>
@@ -13030,7 +13127,7 @@
           <p:cNvPr id="4" name="">
             <a:extLst xmlns:a="http://schemas.openxmlformats.org/drawingml/2006/main">
               <a:ext uri="{FF2B5EF4-FFF2-40B4-BE49-F238E27FC236}">
-                <a16:creationId xmlns:a16="http://schemas.microsoft.com/office/drawing/2014/main" id="{BE19D8EA-4636-45D1-A57A-6AB0675A483A}"/>
+                <a16:creationId xmlns:a16="http://schemas.microsoft.com/office/drawing/2014/main" id="{01D750CE-0651-4896-B6B8-0051D788B52A}"/>
               </a:ext>
             </a:extLst>
           </p:cNvPr>
@@ -13094,7 +13191,7 @@
           <p:cNvPr id="5" name="">
             <a:extLst xmlns:a="http://schemas.openxmlformats.org/drawingml/2006/main">
               <a:ext uri="{FF2B5EF4-FFF2-40B4-BE49-F238E27FC236}">
-                <a16:creationId xmlns:a16="http://schemas.microsoft.com/office/drawing/2014/main" id="{54D05668-B126-4504-9201-DB6E770C0888}"/>
+                <a16:creationId xmlns:a16="http://schemas.microsoft.com/office/drawing/2014/main" id="{A3649152-2188-4CFB-A39C-3FD3B4ABB6F3}"/>
               </a:ext>
             </a:extLst>
           </p:cNvPr>
@@ -13127,7 +13224,7 @@
           <p:cNvPr id="6" name="">
             <a:extLst xmlns:a="http://schemas.openxmlformats.org/drawingml/2006/main">
               <a:ext uri="{FF2B5EF4-FFF2-40B4-BE49-F238E27FC236}">
-                <a16:creationId xmlns:a16="http://schemas.microsoft.com/office/drawing/2014/main" id="{515D23C4-2501-45BF-8823-4AEA74128301}"/>
+                <a16:creationId xmlns:a16="http://schemas.microsoft.com/office/drawing/2014/main" id="{1A8546C5-AD15-4613-B5E6-B74F054AFAB5}"/>
               </a:ext>
             </a:extLst>
           </p:cNvPr>
@@ -13160,7 +13257,7 @@
           <p:cNvPr id="7" name="">
             <a:extLst xmlns:a="http://schemas.openxmlformats.org/drawingml/2006/main">
               <a:ext uri="{FF2B5EF4-FFF2-40B4-BE49-F238E27FC236}">
-                <a16:creationId xmlns:a16="http://schemas.microsoft.com/office/drawing/2014/main" id="{9F940F28-F701-47C5-8869-D0A4A55DF6B8}"/>
+                <a16:creationId xmlns:a16="http://schemas.microsoft.com/office/drawing/2014/main" id="{C809414A-415D-4355-8FB9-3786ED8A3A9A}"/>
               </a:ext>
             </a:extLst>
           </p:cNvPr>
@@ -13224,7 +13321,7 @@
           <p:cNvPr id="8" name="">
             <a:extLst xmlns:a="http://schemas.openxmlformats.org/drawingml/2006/main">
               <a:ext uri="{FF2B5EF4-FFF2-40B4-BE49-F238E27FC236}">
-                <a16:creationId xmlns:a16="http://schemas.microsoft.com/office/drawing/2014/main" id="{15981F2A-1629-412A-B924-49EACFE7FE71}"/>
+                <a16:creationId xmlns:a16="http://schemas.microsoft.com/office/drawing/2014/main" id="{6E07D6B4-EE7A-42D6-9518-7D297E01A0E6}"/>
               </a:ext>
             </a:extLst>
           </p:cNvPr>
@@ -13257,7 +13354,7 @@
           <p:cNvPr id="9" name="">
             <a:extLst xmlns:a="http://schemas.openxmlformats.org/drawingml/2006/main">
               <a:ext uri="{FF2B5EF4-FFF2-40B4-BE49-F238E27FC236}">
-                <a16:creationId xmlns:a16="http://schemas.microsoft.com/office/drawing/2014/main" id="{B29FF78A-D363-4013-853B-D1E4594B8F92}"/>
+                <a16:creationId xmlns:a16="http://schemas.microsoft.com/office/drawing/2014/main" id="{A0B5354D-51AB-4BB5-9A5A-0E0FF3424D7B}"/>
               </a:ext>
             </a:extLst>
           </p:cNvPr>
@@ -13321,7 +13418,7 @@
           <p:cNvPr id="10" name="">
             <a:extLst xmlns:a="http://schemas.openxmlformats.org/drawingml/2006/main">
               <a:ext uri="{FF2B5EF4-FFF2-40B4-BE49-F238E27FC236}">
-                <a16:creationId xmlns:a16="http://schemas.microsoft.com/office/drawing/2014/main" id="{AD0270DD-91BB-4968-91BD-DDB607D431BB}"/>
+                <a16:creationId xmlns:a16="http://schemas.microsoft.com/office/drawing/2014/main" id="{A4ADB77F-7BB0-4C0D-BA04-CFE7262D9E17}"/>
               </a:ext>
             </a:extLst>
           </p:cNvPr>
@@ -13354,7 +13451,7 @@
           <p:cNvPr id="11" name="">
             <a:extLst xmlns:a="http://schemas.openxmlformats.org/drawingml/2006/main">
               <a:ext uri="{FF2B5EF4-FFF2-40B4-BE49-F238E27FC236}">
-                <a16:creationId xmlns:a16="http://schemas.microsoft.com/office/drawing/2014/main" id="{61C5DE14-5E6B-423D-BBAE-29BF754E3097}"/>
+                <a16:creationId xmlns:a16="http://schemas.microsoft.com/office/drawing/2014/main" id="{14B97D45-4A1B-46BF-BA26-F147140E3AF6}"/>
               </a:ext>
             </a:extLst>
           </p:cNvPr>
@@ -13418,7 +13515,7 @@
           <p:cNvPr id="12" name="">
             <a:extLst xmlns:a="http://schemas.openxmlformats.org/drawingml/2006/main">
               <a:ext uri="{FF2B5EF4-FFF2-40B4-BE49-F238E27FC236}">
-                <a16:creationId xmlns:a16="http://schemas.microsoft.com/office/drawing/2014/main" id="{E6C3EC2E-7356-498C-BAF5-02F39EEAD9F8}"/>
+                <a16:creationId xmlns:a16="http://schemas.microsoft.com/office/drawing/2014/main" id="{A1F86447-6A5D-4E64-886A-EACE2C7D6689}"/>
               </a:ext>
             </a:extLst>
           </p:cNvPr>
@@ -13451,7 +13548,7 @@
           <p:cNvPr id="13" name="">
             <a:extLst xmlns:a="http://schemas.openxmlformats.org/drawingml/2006/main">
               <a:ext uri="{FF2B5EF4-FFF2-40B4-BE49-F238E27FC236}">
-                <a16:creationId xmlns:a16="http://schemas.microsoft.com/office/drawing/2014/main" id="{5967E288-BD5D-4165-A210-F4FEEDD2244D}"/>
+                <a16:creationId xmlns:a16="http://schemas.microsoft.com/office/drawing/2014/main" id="{077E59FE-0843-4D03-9434-66C491ADD750}"/>
               </a:ext>
             </a:extLst>
           </p:cNvPr>
@@ -13515,7 +13612,7 @@
           <p:cNvPr id="14" name="">
             <a:extLst xmlns:a="http://schemas.openxmlformats.org/drawingml/2006/main">
               <a:ext uri="{FF2B5EF4-FFF2-40B4-BE49-F238E27FC236}">
-                <a16:creationId xmlns:a16="http://schemas.microsoft.com/office/drawing/2014/main" id="{D4376589-571A-40F4-8688-EDC90CF2D0B6}"/>
+                <a16:creationId xmlns:a16="http://schemas.microsoft.com/office/drawing/2014/main" id="{CF2C6626-3814-40CA-AC9C-121A0124E573}"/>
               </a:ext>
             </a:extLst>
           </p:cNvPr>
@@ -13548,7 +13645,7 @@
           <p:cNvPr id="15" name="">
             <a:extLst xmlns:a="http://schemas.openxmlformats.org/drawingml/2006/main">
               <a:ext uri="{FF2B5EF4-FFF2-40B4-BE49-F238E27FC236}">
-                <a16:creationId xmlns:a16="http://schemas.microsoft.com/office/drawing/2014/main" id="{A333F45D-51DC-4570-BDDF-5BE70E3BE68B}"/>
+                <a16:creationId xmlns:a16="http://schemas.microsoft.com/office/drawing/2014/main" id="{DC9476EC-71FF-4443-9579-3B0E8E0ED52E}"/>
               </a:ext>
             </a:extLst>
           </p:cNvPr>
@@ -13612,7 +13709,7 @@
           <p:cNvPr id="16" name="">
             <a:extLst xmlns:a="http://schemas.openxmlformats.org/drawingml/2006/main">
               <a:ext uri="{FF2B5EF4-FFF2-40B4-BE49-F238E27FC236}">
-                <a16:creationId xmlns:a16="http://schemas.microsoft.com/office/drawing/2014/main" id="{00E85442-1F4A-4A11-9C3F-495F6D2C70D8}"/>
+                <a16:creationId xmlns:a16="http://schemas.microsoft.com/office/drawing/2014/main" id="{EF713B34-4165-4A5C-83F9-39045B3AB57C}"/>
               </a:ext>
             </a:extLst>
           </p:cNvPr>
@@ -13645,7 +13742,7 @@
           <p:cNvPr id="17" name="">
             <a:extLst xmlns:a="http://schemas.openxmlformats.org/drawingml/2006/main">
               <a:ext uri="{FF2B5EF4-FFF2-40B4-BE49-F238E27FC236}">
-                <a16:creationId xmlns:a16="http://schemas.microsoft.com/office/drawing/2014/main" id="{3560420D-C0AE-485A-A6D8-CCE6D259A222}"/>
+                <a16:creationId xmlns:a16="http://schemas.microsoft.com/office/drawing/2014/main" id="{47AF7A7E-73E7-457D-822A-8194244C40A3}"/>
               </a:ext>
             </a:extLst>
           </p:cNvPr>
@@ -13709,7 +13806,7 @@
           <p:cNvPr id="18" name="">
             <a:extLst xmlns:a="http://schemas.openxmlformats.org/drawingml/2006/main">
               <a:ext uri="{FF2B5EF4-FFF2-40B4-BE49-F238E27FC236}">
-                <a16:creationId xmlns:a16="http://schemas.microsoft.com/office/drawing/2014/main" id="{EB24D409-3069-4994-B73B-BA38631B3F00}"/>
+                <a16:creationId xmlns:a16="http://schemas.microsoft.com/office/drawing/2014/main" id="{0096FF51-2B86-4718-BCFC-90CEDA547D90}"/>
               </a:ext>
             </a:extLst>
           </p:cNvPr>
@@ -13773,7 +13870,7 @@
           <p:cNvPr id="19" name="">
             <a:extLst xmlns:a="http://schemas.openxmlformats.org/drawingml/2006/main">
               <a:ext uri="{FF2B5EF4-FFF2-40B4-BE49-F238E27FC236}">
-                <a16:creationId xmlns:a16="http://schemas.microsoft.com/office/drawing/2014/main" id="{8EB8FCC0-91DF-4A33-87F0-419CBEF241D8}"/>
+                <a16:creationId xmlns:a16="http://schemas.microsoft.com/office/drawing/2014/main" id="{AC3F0EE2-E512-4958-B87A-05A1D5CB455F}"/>
               </a:ext>
             </a:extLst>
           </p:cNvPr>
@@ -13835,7 +13932,7 @@
     </p:spTree>
     <p:extLst>
       <p:ext uri="{BB962C8B-B14F-4D97-AF65-F5344CB8AC3E}">
-        <p14:creationId xmlns:p14="http://schemas.microsoft.com/office/powerpoint/2010/main" val="919434026"/>
+        <p14:creationId xmlns:p14="http://schemas.microsoft.com/office/powerpoint/2010/main" val="2037464340"/>
       </p:ext>
     </p:extLst>
   </p:cSld>
@@ -13859,7 +13956,7 @@
           <p:cNvPr id="1" name="">
             <a:extLst xmlns:a="http://schemas.openxmlformats.org/drawingml/2006/main">
               <a:ext uri="{FF2B5EF4-FFF2-40B4-BE49-F238E27FC236}">
-                <a16:creationId xmlns:a16="http://schemas.microsoft.com/office/drawing/2014/main" id="{10D42AD9-B29C-4FBA-91EB-CD0022D668C4}"/>
+                <a16:creationId xmlns:a16="http://schemas.microsoft.com/office/drawing/2014/main" id="{FF8590E7-B063-4E09-B137-B24F1FD9978D}"/>
               </a:ext>
             </a:extLst>
           </p:cNvPr>
@@ -13892,7 +13989,7 @@
           <p:cNvPr id="2" name="">
             <a:extLst xmlns:a="http://schemas.openxmlformats.org/drawingml/2006/main">
               <a:ext uri="{FF2B5EF4-FFF2-40B4-BE49-F238E27FC236}">
-                <a16:creationId xmlns:a16="http://schemas.microsoft.com/office/drawing/2014/main" id="{63F3A192-E660-4093-AF94-1DA58F8DD237}"/>
+                <a16:creationId xmlns:a16="http://schemas.microsoft.com/office/drawing/2014/main" id="{0F52C0EB-2C0C-4CF9-984A-AC1A27A12165}"/>
               </a:ext>
             </a:extLst>
           </p:cNvPr>
@@ -13925,7 +14022,7 @@
           <p:cNvPr id="3" name="">
             <a:extLst xmlns:a="http://schemas.openxmlformats.org/drawingml/2006/main">
               <a:ext uri="{FF2B5EF4-FFF2-40B4-BE49-F238E27FC236}">
-                <a16:creationId xmlns:a16="http://schemas.microsoft.com/office/drawing/2014/main" id="{F9FA4B01-FBB6-4450-831D-8F83ED48E2B0}"/>
+                <a16:creationId xmlns:a16="http://schemas.microsoft.com/office/drawing/2014/main" id="{D088B038-E8B4-4875-826F-5508C327CF71}"/>
               </a:ext>
             </a:extLst>
           </p:cNvPr>
@@ -13989,7 +14086,7 @@
           <p:cNvPr id="4" name="">
             <a:extLst xmlns:a="http://schemas.openxmlformats.org/drawingml/2006/main">
               <a:ext uri="{FF2B5EF4-FFF2-40B4-BE49-F238E27FC236}">
-                <a16:creationId xmlns:a16="http://schemas.microsoft.com/office/drawing/2014/main" id="{70BED417-0668-4958-8712-B621A93BBD3E}"/>
+                <a16:creationId xmlns:a16="http://schemas.microsoft.com/office/drawing/2014/main" id="{E0BCCBE3-395C-4070-92DB-F9B4252DE5E1}"/>
               </a:ext>
             </a:extLst>
           </p:cNvPr>
@@ -14053,7 +14150,7 @@
           <p:cNvPr id="5" name="">
             <a:extLst xmlns:a="http://schemas.openxmlformats.org/drawingml/2006/main">
               <a:ext uri="{FF2B5EF4-FFF2-40B4-BE49-F238E27FC236}">
-                <a16:creationId xmlns:a16="http://schemas.microsoft.com/office/drawing/2014/main" id="{B9BF7211-B8FE-424A-B8A2-DBFC9C9E6543}"/>
+                <a16:creationId xmlns:a16="http://schemas.microsoft.com/office/drawing/2014/main" id="{8E94C293-C152-4462-A596-FF74893A727E}"/>
               </a:ext>
             </a:extLst>
           </p:cNvPr>
@@ -14086,7 +14183,7 @@
           <p:cNvPr id="6" name="">
             <a:extLst xmlns:a="http://schemas.openxmlformats.org/drawingml/2006/main">
               <a:ext uri="{FF2B5EF4-FFF2-40B4-BE49-F238E27FC236}">
-                <a16:creationId xmlns:a16="http://schemas.microsoft.com/office/drawing/2014/main" id="{53AC2CD1-4DB6-4263-8EC5-6C99D464483B}"/>
+                <a16:creationId xmlns:a16="http://schemas.microsoft.com/office/drawing/2014/main" id="{2A570640-C8AB-41DC-B96A-07E6058B14ED}"/>
               </a:ext>
             </a:extLst>
           </p:cNvPr>
@@ -14119,7 +14216,7 @@
           <p:cNvPr id="7" name="">
             <a:extLst xmlns:a="http://schemas.openxmlformats.org/drawingml/2006/main">
               <a:ext uri="{FF2B5EF4-FFF2-40B4-BE49-F238E27FC236}">
-                <a16:creationId xmlns:a16="http://schemas.microsoft.com/office/drawing/2014/main" id="{A9FE0EA1-9E54-4FE1-B556-9C8635706292}"/>
+                <a16:creationId xmlns:a16="http://schemas.microsoft.com/office/drawing/2014/main" id="{A2C8D03F-0608-4E9F-ADCB-F6CD38D01E5F}"/>
               </a:ext>
             </a:extLst>
           </p:cNvPr>
@@ -14183,7 +14280,7 @@
           <p:cNvPr id="8" name="">
             <a:extLst xmlns:a="http://schemas.openxmlformats.org/drawingml/2006/main">
               <a:ext uri="{FF2B5EF4-FFF2-40B4-BE49-F238E27FC236}">
-                <a16:creationId xmlns:a16="http://schemas.microsoft.com/office/drawing/2014/main" id="{D8E9CE14-CDD7-4760-A16C-F631E164DE18}"/>
+                <a16:creationId xmlns:a16="http://schemas.microsoft.com/office/drawing/2014/main" id="{27C6216F-1B4E-431D-BC68-BB07C4BE309E}"/>
               </a:ext>
             </a:extLst>
           </p:cNvPr>
@@ -14216,7 +14313,7 @@
           <p:cNvPr id="9" name="">
             <a:extLst xmlns:a="http://schemas.openxmlformats.org/drawingml/2006/main">
               <a:ext uri="{FF2B5EF4-FFF2-40B4-BE49-F238E27FC236}">
-                <a16:creationId xmlns:a16="http://schemas.microsoft.com/office/drawing/2014/main" id="{BF96C864-05B0-4DA0-AB59-54B4930CD189}"/>
+                <a16:creationId xmlns:a16="http://schemas.microsoft.com/office/drawing/2014/main" id="{7D8AAFDD-B9D9-413A-AD37-1ABD8A325E18}"/>
               </a:ext>
             </a:extLst>
           </p:cNvPr>
@@ -14280,7 +14377,7 @@
           <p:cNvPr id="10" name="">
             <a:extLst xmlns:a="http://schemas.openxmlformats.org/drawingml/2006/main">
               <a:ext uri="{FF2B5EF4-FFF2-40B4-BE49-F238E27FC236}">
-                <a16:creationId xmlns:a16="http://schemas.microsoft.com/office/drawing/2014/main" id="{12B1E61A-B31C-4AED-B449-D05C04B36151}"/>
+                <a16:creationId xmlns:a16="http://schemas.microsoft.com/office/drawing/2014/main" id="{D2F616A5-57EC-412A-9E11-BE0B540C6BF5}"/>
               </a:ext>
             </a:extLst>
           </p:cNvPr>
@@ -14313,7 +14410,7 @@
           <p:cNvPr id="11" name="">
             <a:extLst xmlns:a="http://schemas.openxmlformats.org/drawingml/2006/main">
               <a:ext uri="{FF2B5EF4-FFF2-40B4-BE49-F238E27FC236}">
-                <a16:creationId xmlns:a16="http://schemas.microsoft.com/office/drawing/2014/main" id="{9E2548E7-9959-4B33-88E0-143C3C406157}"/>
+                <a16:creationId xmlns:a16="http://schemas.microsoft.com/office/drawing/2014/main" id="{6BC343DF-FEE1-49BD-94CA-98CB1F37B78F}"/>
               </a:ext>
             </a:extLst>
           </p:cNvPr>
@@ -14377,7 +14474,7 @@
           <p:cNvPr id="12" name="">
             <a:extLst xmlns:a="http://schemas.openxmlformats.org/drawingml/2006/main">
               <a:ext uri="{FF2B5EF4-FFF2-40B4-BE49-F238E27FC236}">
-                <a16:creationId xmlns:a16="http://schemas.microsoft.com/office/drawing/2014/main" id="{09F5E206-75F8-4A4F-AF7E-8349E4F2DC3A}"/>
+                <a16:creationId xmlns:a16="http://schemas.microsoft.com/office/drawing/2014/main" id="{91DC2BC9-A949-4E5F-A416-5A4BCFE63341}"/>
               </a:ext>
             </a:extLst>
           </p:cNvPr>
@@ -14410,7 +14507,7 @@
           <p:cNvPr id="13" name="">
             <a:extLst xmlns:a="http://schemas.openxmlformats.org/drawingml/2006/main">
               <a:ext uri="{FF2B5EF4-FFF2-40B4-BE49-F238E27FC236}">
-                <a16:creationId xmlns:a16="http://schemas.microsoft.com/office/drawing/2014/main" id="{7065D005-6209-4CEB-9C56-089E8256D8DB}"/>
+                <a16:creationId xmlns:a16="http://schemas.microsoft.com/office/drawing/2014/main" id="{1CE3AE8D-C58C-43FB-B953-6B2BC65D8272}"/>
               </a:ext>
             </a:extLst>
           </p:cNvPr>
@@ -14474,7 +14571,7 @@
           <p:cNvPr id="14" name="">
             <a:extLst xmlns:a="http://schemas.openxmlformats.org/drawingml/2006/main">
               <a:ext uri="{FF2B5EF4-FFF2-40B4-BE49-F238E27FC236}">
-                <a16:creationId xmlns:a16="http://schemas.microsoft.com/office/drawing/2014/main" id="{AF4E8E6D-6250-4946-B873-41B8F1D0135F}"/>
+                <a16:creationId xmlns:a16="http://schemas.microsoft.com/office/drawing/2014/main" id="{82D797C2-6042-4F92-9841-4176692FF8C3}"/>
               </a:ext>
             </a:extLst>
           </p:cNvPr>
@@ -14507,7 +14604,7 @@
           <p:cNvPr id="15" name="">
             <a:extLst xmlns:a="http://schemas.openxmlformats.org/drawingml/2006/main">
               <a:ext uri="{FF2B5EF4-FFF2-40B4-BE49-F238E27FC236}">
-                <a16:creationId xmlns:a16="http://schemas.microsoft.com/office/drawing/2014/main" id="{9DF3D9EA-B9BA-41AF-8873-17ACAF9D7FE4}"/>
+                <a16:creationId xmlns:a16="http://schemas.microsoft.com/office/drawing/2014/main" id="{464D7A5F-3989-4697-B936-B74E6A94B983}"/>
               </a:ext>
             </a:extLst>
           </p:cNvPr>
@@ -14571,7 +14668,7 @@
           <p:cNvPr id="16" name="">
             <a:extLst xmlns:a="http://schemas.openxmlformats.org/drawingml/2006/main">
               <a:ext uri="{FF2B5EF4-FFF2-40B4-BE49-F238E27FC236}">
-                <a16:creationId xmlns:a16="http://schemas.microsoft.com/office/drawing/2014/main" id="{8312D5E7-688C-49EC-B0BF-465E80E1315E}"/>
+                <a16:creationId xmlns:a16="http://schemas.microsoft.com/office/drawing/2014/main" id="{562158C0-7925-4BCE-A348-C3EA6D92A409}"/>
               </a:ext>
             </a:extLst>
           </p:cNvPr>
@@ -14635,7 +14732,7 @@
           <p:cNvPr id="17" name="">
             <a:extLst xmlns:a="http://schemas.openxmlformats.org/drawingml/2006/main">
               <a:ext uri="{FF2B5EF4-FFF2-40B4-BE49-F238E27FC236}">
-                <a16:creationId xmlns:a16="http://schemas.microsoft.com/office/drawing/2014/main" id="{840EA86A-B2A4-4A13-BFF5-8496CF51E209}"/>
+                <a16:creationId xmlns:a16="http://schemas.microsoft.com/office/drawing/2014/main" id="{FC053BBA-AC8D-4A81-9262-084552C8D4BD}"/>
               </a:ext>
             </a:extLst>
           </p:cNvPr>
@@ -14697,7 +14794,7 @@
     </p:spTree>
     <p:extLst>
       <p:ext uri="{BB962C8B-B14F-4D97-AF65-F5344CB8AC3E}">
-        <p14:creationId xmlns:p14="http://schemas.microsoft.com/office/powerpoint/2010/main" val="384411625"/>
+        <p14:creationId xmlns:p14="http://schemas.microsoft.com/office/powerpoint/2010/main" val="486219017"/>
       </p:ext>
     </p:extLst>
   </p:cSld>
@@ -14721,7 +14818,7 @@
           <p:cNvPr id="1" name="">
             <a:extLst xmlns:a="http://schemas.openxmlformats.org/drawingml/2006/main">
               <a:ext uri="{FF2B5EF4-FFF2-40B4-BE49-F238E27FC236}">
-                <a16:creationId xmlns:a16="http://schemas.microsoft.com/office/drawing/2014/main" id="{363F470A-334E-4E9D-B59F-424646320F23}"/>
+                <a16:creationId xmlns:a16="http://schemas.microsoft.com/office/drawing/2014/main" id="{713FB789-3147-49F6-8530-89C34A3E518A}"/>
               </a:ext>
             </a:extLst>
           </p:cNvPr>
@@ -14754,7 +14851,7 @@
           <p:cNvPr id="2" name="">
             <a:extLst xmlns:a="http://schemas.openxmlformats.org/drawingml/2006/main">
               <a:ext uri="{FF2B5EF4-FFF2-40B4-BE49-F238E27FC236}">
-                <a16:creationId xmlns:a16="http://schemas.microsoft.com/office/drawing/2014/main" id="{083472D2-2DD1-4FC0-9706-36104C538858}"/>
+                <a16:creationId xmlns:a16="http://schemas.microsoft.com/office/drawing/2014/main" id="{3B11B318-57CD-445C-BE00-604119C464E8}"/>
               </a:ext>
             </a:extLst>
           </p:cNvPr>
@@ -14787,7 +14884,7 @@
           <p:cNvPr id="3" name="">
             <a:extLst xmlns:a="http://schemas.openxmlformats.org/drawingml/2006/main">
               <a:ext uri="{FF2B5EF4-FFF2-40B4-BE49-F238E27FC236}">
-                <a16:creationId xmlns:a16="http://schemas.microsoft.com/office/drawing/2014/main" id="{79548736-6836-41BB-A7A9-3A04CFFA6422}"/>
+                <a16:creationId xmlns:a16="http://schemas.microsoft.com/office/drawing/2014/main" id="{337A319F-8872-4985-AAB1-D91F35B116FD}"/>
               </a:ext>
             </a:extLst>
           </p:cNvPr>
@@ -14851,7 +14948,7 @@
           <p:cNvPr id="4" name="">
             <a:extLst xmlns:a="http://schemas.openxmlformats.org/drawingml/2006/main">
               <a:ext uri="{FF2B5EF4-FFF2-40B4-BE49-F238E27FC236}">
-                <a16:creationId xmlns:a16="http://schemas.microsoft.com/office/drawing/2014/main" id="{79E5E17D-F61E-4111-9282-C48DCC8CF7EE}"/>
+                <a16:creationId xmlns:a16="http://schemas.microsoft.com/office/drawing/2014/main" id="{F62CFCE2-62DA-4590-ABAA-25C42AC26AEF}"/>
               </a:ext>
             </a:extLst>
           </p:cNvPr>
@@ -14915,7 +15012,7 @@
           <p:cNvPr id="5" name="">
             <a:extLst xmlns:a="http://schemas.openxmlformats.org/drawingml/2006/main">
               <a:ext uri="{FF2B5EF4-FFF2-40B4-BE49-F238E27FC236}">
-                <a16:creationId xmlns:a16="http://schemas.microsoft.com/office/drawing/2014/main" id="{8DBBD92B-C4DC-4516-A6CD-7F45BF10A2A6}"/>
+                <a16:creationId xmlns:a16="http://schemas.microsoft.com/office/drawing/2014/main" id="{3FF93224-D769-4DC6-AFE8-E95F967972CF}"/>
               </a:ext>
             </a:extLst>
           </p:cNvPr>
@@ -14948,7 +15045,7 @@
           <p:cNvPr id="6" name="">
             <a:extLst xmlns:a="http://schemas.openxmlformats.org/drawingml/2006/main">
               <a:ext uri="{FF2B5EF4-FFF2-40B4-BE49-F238E27FC236}">
-                <a16:creationId xmlns:a16="http://schemas.microsoft.com/office/drawing/2014/main" id="{14D90339-15DF-4DA5-9255-EDE41EF56FB8}"/>
+                <a16:creationId xmlns:a16="http://schemas.microsoft.com/office/drawing/2014/main" id="{6A74428E-F7BB-430E-822B-F2E01899DF91}"/>
               </a:ext>
             </a:extLst>
           </p:cNvPr>
@@ -14981,7 +15078,7 @@
           <p:cNvPr id="7" name="">
             <a:extLst xmlns:a="http://schemas.openxmlformats.org/drawingml/2006/main">
               <a:ext uri="{FF2B5EF4-FFF2-40B4-BE49-F238E27FC236}">
-                <a16:creationId xmlns:a16="http://schemas.microsoft.com/office/drawing/2014/main" id="{38FC42D5-F1C9-4101-B94B-9284CB90C647}"/>
+                <a16:creationId xmlns:a16="http://schemas.microsoft.com/office/drawing/2014/main" id="{DE92868B-EA94-4E33-A18A-7118BB63EDAD}"/>
               </a:ext>
             </a:extLst>
           </p:cNvPr>
@@ -15045,7 +15142,7 @@
           <p:cNvPr id="8" name="">
             <a:extLst xmlns:a="http://schemas.openxmlformats.org/drawingml/2006/main">
               <a:ext uri="{FF2B5EF4-FFF2-40B4-BE49-F238E27FC236}">
-                <a16:creationId xmlns:a16="http://schemas.microsoft.com/office/drawing/2014/main" id="{D9CEC810-F1E3-436B-AA36-FB30D5502F71}"/>
+                <a16:creationId xmlns:a16="http://schemas.microsoft.com/office/drawing/2014/main" id="{F7706630-F59E-445F-9B36-83E5C93B82AF}"/>
               </a:ext>
             </a:extLst>
           </p:cNvPr>
@@ -15078,7 +15175,7 @@
           <p:cNvPr id="9" name="">
             <a:extLst xmlns:a="http://schemas.openxmlformats.org/drawingml/2006/main">
               <a:ext uri="{FF2B5EF4-FFF2-40B4-BE49-F238E27FC236}">
-                <a16:creationId xmlns:a16="http://schemas.microsoft.com/office/drawing/2014/main" id="{15F087DA-602A-40EA-8CBA-FC649DC8F7FF}"/>
+                <a16:creationId xmlns:a16="http://schemas.microsoft.com/office/drawing/2014/main" id="{78D661E5-BDC3-4CFC-9B9D-729C78897736}"/>
               </a:ext>
             </a:extLst>
           </p:cNvPr>
@@ -15142,7 +15239,7 @@
           <p:cNvPr id="10" name="">
             <a:extLst xmlns:a="http://schemas.openxmlformats.org/drawingml/2006/main">
               <a:ext uri="{FF2B5EF4-FFF2-40B4-BE49-F238E27FC236}">
-                <a16:creationId xmlns:a16="http://schemas.microsoft.com/office/drawing/2014/main" id="{5EE54E9B-F41E-4B82-8242-2AFA284B58FD}"/>
+                <a16:creationId xmlns:a16="http://schemas.microsoft.com/office/drawing/2014/main" id="{AFAAFAE6-6265-4284-BF87-2A4138D09789}"/>
               </a:ext>
             </a:extLst>
           </p:cNvPr>
@@ -15175,7 +15272,7 @@
           <p:cNvPr id="11" name="">
             <a:extLst xmlns:a="http://schemas.openxmlformats.org/drawingml/2006/main">
               <a:ext uri="{FF2B5EF4-FFF2-40B4-BE49-F238E27FC236}">
-                <a16:creationId xmlns:a16="http://schemas.microsoft.com/office/drawing/2014/main" id="{20B7A80E-AA04-4F84-85E8-989BE86B951E}"/>
+                <a16:creationId xmlns:a16="http://schemas.microsoft.com/office/drawing/2014/main" id="{B8D18FC2-54F2-40B7-B7E2-D0CE866D91C8}"/>
               </a:ext>
             </a:extLst>
           </p:cNvPr>
@@ -15239,7 +15336,7 @@
           <p:cNvPr id="12" name="">
             <a:extLst xmlns:a="http://schemas.openxmlformats.org/drawingml/2006/main">
               <a:ext uri="{FF2B5EF4-FFF2-40B4-BE49-F238E27FC236}">
-                <a16:creationId xmlns:a16="http://schemas.microsoft.com/office/drawing/2014/main" id="{0EF783D4-C08E-4F61-AC0F-36AC16E298E4}"/>
+                <a16:creationId xmlns:a16="http://schemas.microsoft.com/office/drawing/2014/main" id="{FD4FC3E7-84FC-4375-B648-31B999D8243B}"/>
               </a:ext>
             </a:extLst>
           </p:cNvPr>
@@ -15272,7 +15369,7 @@
           <p:cNvPr id="13" name="">
             <a:extLst xmlns:a="http://schemas.openxmlformats.org/drawingml/2006/main">
               <a:ext uri="{FF2B5EF4-FFF2-40B4-BE49-F238E27FC236}">
-                <a16:creationId xmlns:a16="http://schemas.microsoft.com/office/drawing/2014/main" id="{F13EB16C-3AF7-4DC9-8065-EB0806002B46}"/>
+                <a16:creationId xmlns:a16="http://schemas.microsoft.com/office/drawing/2014/main" id="{356C440B-F037-48F0-839C-42AB75BA9BEE}"/>
               </a:ext>
             </a:extLst>
           </p:cNvPr>
@@ -15336,7 +15433,7 @@
           <p:cNvPr id="14" name="">
             <a:extLst xmlns:a="http://schemas.openxmlformats.org/drawingml/2006/main">
               <a:ext uri="{FF2B5EF4-FFF2-40B4-BE49-F238E27FC236}">
-                <a16:creationId xmlns:a16="http://schemas.microsoft.com/office/drawing/2014/main" id="{6835AC97-612A-436B-B55A-A4A8FEFADB3A}"/>
+                <a16:creationId xmlns:a16="http://schemas.microsoft.com/office/drawing/2014/main" id="{B0722453-AACB-4D80-B161-5E0B2DBFB921}"/>
               </a:ext>
             </a:extLst>
           </p:cNvPr>
@@ -15369,7 +15466,7 @@
           <p:cNvPr id="15" name="">
             <a:extLst xmlns:a="http://schemas.openxmlformats.org/drawingml/2006/main">
               <a:ext uri="{FF2B5EF4-FFF2-40B4-BE49-F238E27FC236}">
-                <a16:creationId xmlns:a16="http://schemas.microsoft.com/office/drawing/2014/main" id="{7C3E797E-EE34-48B7-AE68-98BBE3488C43}"/>
+                <a16:creationId xmlns:a16="http://schemas.microsoft.com/office/drawing/2014/main" id="{72624BE4-76CD-4C6B-BC8D-3DBC8EB60DF7}"/>
               </a:ext>
             </a:extLst>
           </p:cNvPr>
@@ -15433,7 +15530,7 @@
           <p:cNvPr id="16" name="">
             <a:extLst xmlns:a="http://schemas.openxmlformats.org/drawingml/2006/main">
               <a:ext uri="{FF2B5EF4-FFF2-40B4-BE49-F238E27FC236}">
-                <a16:creationId xmlns:a16="http://schemas.microsoft.com/office/drawing/2014/main" id="{89C6E68A-B62A-47FC-BE30-42A78259E6FC}"/>
+                <a16:creationId xmlns:a16="http://schemas.microsoft.com/office/drawing/2014/main" id="{6032FD02-FBC2-4007-A038-3E25C2E9B734}"/>
               </a:ext>
             </a:extLst>
           </p:cNvPr>
@@ -15466,7 +15563,7 @@
           <p:cNvPr id="17" name="">
             <a:extLst xmlns:a="http://schemas.openxmlformats.org/drawingml/2006/main">
               <a:ext uri="{FF2B5EF4-FFF2-40B4-BE49-F238E27FC236}">
-                <a16:creationId xmlns:a16="http://schemas.microsoft.com/office/drawing/2014/main" id="{AC2BFD39-7680-4959-BA00-0AA921FCCDEC}"/>
+                <a16:creationId xmlns:a16="http://schemas.microsoft.com/office/drawing/2014/main" id="{918B51A8-A423-4672-B9D5-C28070622ECC}"/>
               </a:ext>
             </a:extLst>
           </p:cNvPr>
@@ -15530,7 +15627,7 @@
           <p:cNvPr id="18" name="">
             <a:extLst xmlns:a="http://schemas.openxmlformats.org/drawingml/2006/main">
               <a:ext uri="{FF2B5EF4-FFF2-40B4-BE49-F238E27FC236}">
-                <a16:creationId xmlns:a16="http://schemas.microsoft.com/office/drawing/2014/main" id="{B0C805E9-2CCA-44B6-9F1B-D2DB96C8C1A1}"/>
+                <a16:creationId xmlns:a16="http://schemas.microsoft.com/office/drawing/2014/main" id="{3541F1CE-222B-4B8F-8E4E-AE0F9BC2DAA7}"/>
               </a:ext>
             </a:extLst>
           </p:cNvPr>
@@ -15594,7 +15691,7 @@
           <p:cNvPr id="19" name="">
             <a:extLst xmlns:a="http://schemas.openxmlformats.org/drawingml/2006/main">
               <a:ext uri="{FF2B5EF4-FFF2-40B4-BE49-F238E27FC236}">
-                <a16:creationId xmlns:a16="http://schemas.microsoft.com/office/drawing/2014/main" id="{F8A54040-8F85-44B0-A18B-954C9BC49828}"/>
+                <a16:creationId xmlns:a16="http://schemas.microsoft.com/office/drawing/2014/main" id="{020DE2BE-FB95-4A6D-AC1D-C98224528D36}"/>
               </a:ext>
             </a:extLst>
           </p:cNvPr>
@@ -15656,7 +15753,7 @@
     </p:spTree>
     <p:extLst>
       <p:ext uri="{BB962C8B-B14F-4D97-AF65-F5344CB8AC3E}">
-        <p14:creationId xmlns:p14="http://schemas.microsoft.com/office/powerpoint/2010/main" val="710729481"/>
+        <p14:creationId xmlns:p14="http://schemas.microsoft.com/office/powerpoint/2010/main" val="1329117304"/>
       </p:ext>
     </p:extLst>
   </p:cSld>
@@ -15680,7 +15777,7 @@
           <p:cNvPr id="1" name="">
             <a:extLst xmlns:a="http://schemas.openxmlformats.org/drawingml/2006/main">
               <a:ext uri="{FF2B5EF4-FFF2-40B4-BE49-F238E27FC236}">
-                <a16:creationId xmlns:a16="http://schemas.microsoft.com/office/drawing/2014/main" id="{3D2B4712-ADDE-4548-B6D1-4011A1DDE25E}"/>
+                <a16:creationId xmlns:a16="http://schemas.microsoft.com/office/drawing/2014/main" id="{620010BC-E3CC-4DD9-B762-CDD32E6DA095}"/>
               </a:ext>
             </a:extLst>
           </p:cNvPr>
@@ -15713,7 +15810,7 @@
           <p:cNvPr id="2" name="">
             <a:extLst xmlns:a="http://schemas.openxmlformats.org/drawingml/2006/main">
               <a:ext uri="{FF2B5EF4-FFF2-40B4-BE49-F238E27FC236}">
-                <a16:creationId xmlns:a16="http://schemas.microsoft.com/office/drawing/2014/main" id="{1FACFD56-62C2-4D2B-AFD7-9DBB380D8EA7}"/>
+                <a16:creationId xmlns:a16="http://schemas.microsoft.com/office/drawing/2014/main" id="{D35912D1-CEFC-4DFE-84B3-6EAF9EC54FA0}"/>
               </a:ext>
             </a:extLst>
           </p:cNvPr>
@@ -15746,7 +15843,7 @@
           <p:cNvPr id="3" name="">
             <a:extLst xmlns:a="http://schemas.openxmlformats.org/drawingml/2006/main">
               <a:ext uri="{FF2B5EF4-FFF2-40B4-BE49-F238E27FC236}">
-                <a16:creationId xmlns:a16="http://schemas.microsoft.com/office/drawing/2014/main" id="{0E486EA8-6F70-453E-A431-9E12ADB3B125}"/>
+                <a16:creationId xmlns:a16="http://schemas.microsoft.com/office/drawing/2014/main" id="{24A7AF64-4090-4EE3-B4B0-559B22660AB2}"/>
               </a:ext>
             </a:extLst>
           </p:cNvPr>
@@ -15810,7 +15907,7 @@
           <p:cNvPr id="4" name="">
             <a:extLst xmlns:a="http://schemas.openxmlformats.org/drawingml/2006/main">
               <a:ext uri="{FF2B5EF4-FFF2-40B4-BE49-F238E27FC236}">
-                <a16:creationId xmlns:a16="http://schemas.microsoft.com/office/drawing/2014/main" id="{5EF5B864-BDE4-4758-94E4-73FD0B54707B}"/>
+                <a16:creationId xmlns:a16="http://schemas.microsoft.com/office/drawing/2014/main" id="{9D8ACF24-0E6A-46D8-B5F7-47613CEFF1B6}"/>
               </a:ext>
             </a:extLst>
           </p:cNvPr>
@@ -15874,7 +15971,7 @@
           <p:cNvPr id="5" name="">
             <a:extLst xmlns:a="http://schemas.openxmlformats.org/drawingml/2006/main">
               <a:ext uri="{FF2B5EF4-FFF2-40B4-BE49-F238E27FC236}">
-                <a16:creationId xmlns:a16="http://schemas.microsoft.com/office/drawing/2014/main" id="{9A47C016-D1CB-4B3E-8C6E-B4AFB48556D1}"/>
+                <a16:creationId xmlns:a16="http://schemas.microsoft.com/office/drawing/2014/main" id="{53C91935-35D0-4330-A736-1D92CC4EE880}"/>
               </a:ext>
             </a:extLst>
           </p:cNvPr>
@@ -15907,7 +16004,7 @@
           <p:cNvPr id="6" name="">
             <a:extLst xmlns:a="http://schemas.openxmlformats.org/drawingml/2006/main">
               <a:ext uri="{FF2B5EF4-FFF2-40B4-BE49-F238E27FC236}">
-                <a16:creationId xmlns:a16="http://schemas.microsoft.com/office/drawing/2014/main" id="{9EC9B7DC-FD6E-4DB7-8074-0EBF1A08A45F}"/>
+                <a16:creationId xmlns:a16="http://schemas.microsoft.com/office/drawing/2014/main" id="{B22C4131-8EF5-4642-A3A1-9862726564B8}"/>
               </a:ext>
             </a:extLst>
           </p:cNvPr>
@@ -15940,7 +16037,7 @@
           <p:cNvPr id="7" name="">
             <a:extLst xmlns:a="http://schemas.openxmlformats.org/drawingml/2006/main">
               <a:ext uri="{FF2B5EF4-FFF2-40B4-BE49-F238E27FC236}">
-                <a16:creationId xmlns:a16="http://schemas.microsoft.com/office/drawing/2014/main" id="{5C6DAE36-CCE0-42B2-9CA3-7886A0EF4B07}"/>
+                <a16:creationId xmlns:a16="http://schemas.microsoft.com/office/drawing/2014/main" id="{D00648B1-5369-42F1-BEA6-58BFBEEA967B}"/>
               </a:ext>
             </a:extLst>
           </p:cNvPr>
@@ -16004,7 +16101,7 @@
           <p:cNvPr id="8" name="">
             <a:extLst xmlns:a="http://schemas.openxmlformats.org/drawingml/2006/main">
               <a:ext uri="{FF2B5EF4-FFF2-40B4-BE49-F238E27FC236}">
-                <a16:creationId xmlns:a16="http://schemas.microsoft.com/office/drawing/2014/main" id="{4C5003B8-482E-4662-A174-797EFDF93E9C}"/>
+                <a16:creationId xmlns:a16="http://schemas.microsoft.com/office/drawing/2014/main" id="{94CF67BE-6548-4AD6-B897-E56DB6F5AA3B}"/>
               </a:ext>
             </a:extLst>
           </p:cNvPr>
@@ -16037,7 +16134,7 @@
           <p:cNvPr id="9" name="">
             <a:extLst xmlns:a="http://schemas.openxmlformats.org/drawingml/2006/main">
               <a:ext uri="{FF2B5EF4-FFF2-40B4-BE49-F238E27FC236}">
-                <a16:creationId xmlns:a16="http://schemas.microsoft.com/office/drawing/2014/main" id="{4039DD64-115D-473B-A2DA-EAD5A31E0A42}"/>
+                <a16:creationId xmlns:a16="http://schemas.microsoft.com/office/drawing/2014/main" id="{FE087717-3A6D-423C-A28A-672CA84CADD5}"/>
               </a:ext>
             </a:extLst>
           </p:cNvPr>
@@ -16101,7 +16198,7 @@
           <p:cNvPr id="10" name="">
             <a:extLst xmlns:a="http://schemas.openxmlformats.org/drawingml/2006/main">
               <a:ext uri="{FF2B5EF4-FFF2-40B4-BE49-F238E27FC236}">
-                <a16:creationId xmlns:a16="http://schemas.microsoft.com/office/drawing/2014/main" id="{427D87BC-5B53-4CB6-8D64-AAD35A60E794}"/>
+                <a16:creationId xmlns:a16="http://schemas.microsoft.com/office/drawing/2014/main" id="{40322C2A-DCFE-4E49-A577-90A6CA7E0785}"/>
               </a:ext>
             </a:extLst>
           </p:cNvPr>
@@ -16134,7 +16231,7 @@
           <p:cNvPr id="11" name="">
             <a:extLst xmlns:a="http://schemas.openxmlformats.org/drawingml/2006/main">
               <a:ext uri="{FF2B5EF4-FFF2-40B4-BE49-F238E27FC236}">
-                <a16:creationId xmlns:a16="http://schemas.microsoft.com/office/drawing/2014/main" id="{4515AF11-6674-40A9-B085-40AAB01881C0}"/>
+                <a16:creationId xmlns:a16="http://schemas.microsoft.com/office/drawing/2014/main" id="{611E3831-6F16-4510-8A2C-DBFE5D96FA82}"/>
               </a:ext>
             </a:extLst>
           </p:cNvPr>
@@ -16198,7 +16295,7 @@
           <p:cNvPr id="12" name="">
             <a:extLst xmlns:a="http://schemas.openxmlformats.org/drawingml/2006/main">
               <a:ext uri="{FF2B5EF4-FFF2-40B4-BE49-F238E27FC236}">
-                <a16:creationId xmlns:a16="http://schemas.microsoft.com/office/drawing/2014/main" id="{A25B313F-CA17-493F-9AFE-2B86970A8A9B}"/>
+                <a16:creationId xmlns:a16="http://schemas.microsoft.com/office/drawing/2014/main" id="{91D82063-F38F-4CE5-97A6-49C34778E19E}"/>
               </a:ext>
             </a:extLst>
           </p:cNvPr>
@@ -16231,7 +16328,7 @@
           <p:cNvPr id="13" name="">
             <a:extLst xmlns:a="http://schemas.openxmlformats.org/drawingml/2006/main">
               <a:ext uri="{FF2B5EF4-FFF2-40B4-BE49-F238E27FC236}">
-                <a16:creationId xmlns:a16="http://schemas.microsoft.com/office/drawing/2014/main" id="{786512E5-A282-41DB-B5D2-F2DB60D4BB1C}"/>
+                <a16:creationId xmlns:a16="http://schemas.microsoft.com/office/drawing/2014/main" id="{C1FEE067-B8CE-4B5A-8A35-8724D4BFD5E0}"/>
               </a:ext>
             </a:extLst>
           </p:cNvPr>
@@ -16295,7 +16392,7 @@
           <p:cNvPr id="14" name="">
             <a:extLst xmlns:a="http://schemas.openxmlformats.org/drawingml/2006/main">
               <a:ext uri="{FF2B5EF4-FFF2-40B4-BE49-F238E27FC236}">
-                <a16:creationId xmlns:a16="http://schemas.microsoft.com/office/drawing/2014/main" id="{12D6F510-F22E-4280-9A23-F639FA815812}"/>
+                <a16:creationId xmlns:a16="http://schemas.microsoft.com/office/drawing/2014/main" id="{855641B5-324B-4E59-B9DB-586EF0092089}"/>
               </a:ext>
             </a:extLst>
           </p:cNvPr>
@@ -16328,7 +16425,7 @@
           <p:cNvPr id="15" name="">
             <a:extLst xmlns:a="http://schemas.openxmlformats.org/drawingml/2006/main">
               <a:ext uri="{FF2B5EF4-FFF2-40B4-BE49-F238E27FC236}">
-                <a16:creationId xmlns:a16="http://schemas.microsoft.com/office/drawing/2014/main" id="{2CDB82E7-C0B8-4734-BECC-FA80A384802F}"/>
+                <a16:creationId xmlns:a16="http://schemas.microsoft.com/office/drawing/2014/main" id="{A5125C69-49F3-41E2-9225-E8A477FC6DA9}"/>
               </a:ext>
             </a:extLst>
           </p:cNvPr>
@@ -16392,7 +16489,7 @@
           <p:cNvPr id="16" name="">
             <a:extLst xmlns:a="http://schemas.openxmlformats.org/drawingml/2006/main">
               <a:ext uri="{FF2B5EF4-FFF2-40B4-BE49-F238E27FC236}">
-                <a16:creationId xmlns:a16="http://schemas.microsoft.com/office/drawing/2014/main" id="{5643B45D-D0E0-4A3F-B117-DBC7DC818E9F}"/>
+                <a16:creationId xmlns:a16="http://schemas.microsoft.com/office/drawing/2014/main" id="{F02F9D19-E6EC-47BF-ADA4-6D8978392D26}"/>
               </a:ext>
             </a:extLst>
           </p:cNvPr>
@@ -16425,7 +16522,7 @@
           <p:cNvPr id="17" name="">
             <a:extLst xmlns:a="http://schemas.openxmlformats.org/drawingml/2006/main">
               <a:ext uri="{FF2B5EF4-FFF2-40B4-BE49-F238E27FC236}">
-                <a16:creationId xmlns:a16="http://schemas.microsoft.com/office/drawing/2014/main" id="{72E1907D-D0FB-4BAC-8D2A-0B4D7B173C38}"/>
+                <a16:creationId xmlns:a16="http://schemas.microsoft.com/office/drawing/2014/main" id="{DB2763C7-3607-46D7-A7D8-72E796960722}"/>
               </a:ext>
             </a:extLst>
           </p:cNvPr>
@@ -16489,7 +16586,7 @@
           <p:cNvPr id="18" name="">
             <a:extLst xmlns:a="http://schemas.openxmlformats.org/drawingml/2006/main">
               <a:ext uri="{FF2B5EF4-FFF2-40B4-BE49-F238E27FC236}">
-                <a16:creationId xmlns:a16="http://schemas.microsoft.com/office/drawing/2014/main" id="{C20CD3D1-B75B-46ED-8FC9-1F26AF535F9C}"/>
+                <a16:creationId xmlns:a16="http://schemas.microsoft.com/office/drawing/2014/main" id="{79BDADA2-088F-41BE-AB49-1707EDC6CEE1}"/>
               </a:ext>
             </a:extLst>
           </p:cNvPr>
@@ -16553,7 +16650,7 @@
           <p:cNvPr id="19" name="">
             <a:extLst xmlns:a="http://schemas.openxmlformats.org/drawingml/2006/main">
               <a:ext uri="{FF2B5EF4-FFF2-40B4-BE49-F238E27FC236}">
-                <a16:creationId xmlns:a16="http://schemas.microsoft.com/office/drawing/2014/main" id="{3B1F3045-0411-4DF3-804D-97AF233A866C}"/>
+                <a16:creationId xmlns:a16="http://schemas.microsoft.com/office/drawing/2014/main" id="{C7BFECA2-3822-4B0B-9F56-7D6465C62934}"/>
               </a:ext>
             </a:extLst>
           </p:cNvPr>
@@ -16615,7 +16712,7 @@
     </p:spTree>
     <p:extLst>
       <p:ext uri="{BB962C8B-B14F-4D97-AF65-F5344CB8AC3E}">
-        <p14:creationId xmlns:p14="http://schemas.microsoft.com/office/powerpoint/2010/main" val="857133593"/>
+        <p14:creationId xmlns:p14="http://schemas.microsoft.com/office/powerpoint/2010/main" val="420477869"/>
       </p:ext>
     </p:extLst>
   </p:cSld>
@@ -16639,7 +16736,7 @@
           <p:cNvPr id="1" name="">
             <a:extLst xmlns:a="http://schemas.openxmlformats.org/drawingml/2006/main">
               <a:ext uri="{FF2B5EF4-FFF2-40B4-BE49-F238E27FC236}">
-                <a16:creationId xmlns:a16="http://schemas.microsoft.com/office/drawing/2014/main" id="{CEDFF4E5-83CF-4D91-9D3B-FDCA9AFEA5DD}"/>
+                <a16:creationId xmlns:a16="http://schemas.microsoft.com/office/drawing/2014/main" id="{59C50E34-58C9-4BB3-8A68-98503BA0BF2D}"/>
               </a:ext>
             </a:extLst>
           </p:cNvPr>
@@ -16672,7 +16769,7 @@
           <p:cNvPr id="2" name="">
             <a:extLst xmlns:a="http://schemas.openxmlformats.org/drawingml/2006/main">
               <a:ext uri="{FF2B5EF4-FFF2-40B4-BE49-F238E27FC236}">
-                <a16:creationId xmlns:a16="http://schemas.microsoft.com/office/drawing/2014/main" id="{191B4CCA-CD5F-4740-97EF-A1DEF5256402}"/>
+                <a16:creationId xmlns:a16="http://schemas.microsoft.com/office/drawing/2014/main" id="{035BED6E-C165-4EEA-8E95-9C2CAA0732B9}"/>
               </a:ext>
             </a:extLst>
           </p:cNvPr>
@@ -16705,7 +16802,7 @@
           <p:cNvPr id="3" name="">
             <a:extLst xmlns:a="http://schemas.openxmlformats.org/drawingml/2006/main">
               <a:ext uri="{FF2B5EF4-FFF2-40B4-BE49-F238E27FC236}">
-                <a16:creationId xmlns:a16="http://schemas.microsoft.com/office/drawing/2014/main" id="{78AB9E02-9EA3-42D4-83C6-1F6771D2FEA9}"/>
+                <a16:creationId xmlns:a16="http://schemas.microsoft.com/office/drawing/2014/main" id="{396BCA02-D1F6-4E9F-BAD0-DCBD26A83489}"/>
               </a:ext>
             </a:extLst>
           </p:cNvPr>
@@ -16769,7 +16866,7 @@
           <p:cNvPr id="4" name="">
             <a:extLst xmlns:a="http://schemas.openxmlformats.org/drawingml/2006/main">
               <a:ext uri="{FF2B5EF4-FFF2-40B4-BE49-F238E27FC236}">
-                <a16:creationId xmlns:a16="http://schemas.microsoft.com/office/drawing/2014/main" id="{DC3A74EE-628A-466A-A4CA-D3140C7B64BB}"/>
+                <a16:creationId xmlns:a16="http://schemas.microsoft.com/office/drawing/2014/main" id="{5062EF4D-2B14-4B1E-85AA-811A8F58068A}"/>
               </a:ext>
             </a:extLst>
           </p:cNvPr>
@@ -16833,7 +16930,7 @@
           <p:cNvPr id="5" name="">
             <a:extLst xmlns:a="http://schemas.openxmlformats.org/drawingml/2006/main">
               <a:ext uri="{FF2B5EF4-FFF2-40B4-BE49-F238E27FC236}">
-                <a16:creationId xmlns:a16="http://schemas.microsoft.com/office/drawing/2014/main" id="{CDC061E3-B789-4969-A150-B25DAADA4894}"/>
+                <a16:creationId xmlns:a16="http://schemas.microsoft.com/office/drawing/2014/main" id="{5997BC43-B9D8-4687-9AC6-62E37CC0A1BE}"/>
               </a:ext>
             </a:extLst>
           </p:cNvPr>
@@ -16866,7 +16963,7 @@
           <p:cNvPr id="6" name="">
             <a:extLst xmlns:a="http://schemas.openxmlformats.org/drawingml/2006/main">
               <a:ext uri="{FF2B5EF4-FFF2-40B4-BE49-F238E27FC236}">
-                <a16:creationId xmlns:a16="http://schemas.microsoft.com/office/drawing/2014/main" id="{4B906A4F-45F2-40B9-990F-48C9BF0CDED1}"/>
+                <a16:creationId xmlns:a16="http://schemas.microsoft.com/office/drawing/2014/main" id="{9D087020-F94E-411E-9A04-F84D97452950}"/>
               </a:ext>
             </a:extLst>
           </p:cNvPr>
@@ -16899,7 +16996,7 @@
           <p:cNvPr id="7" name="">
             <a:extLst xmlns:a="http://schemas.openxmlformats.org/drawingml/2006/main">
               <a:ext uri="{FF2B5EF4-FFF2-40B4-BE49-F238E27FC236}">
-                <a16:creationId xmlns:a16="http://schemas.microsoft.com/office/drawing/2014/main" id="{4C686BD5-A8B4-4A4C-A4D2-CC9B13DF3A19}"/>
+                <a16:creationId xmlns:a16="http://schemas.microsoft.com/office/drawing/2014/main" id="{74F6B670-BC12-493E-8EE8-6C3D46D09D55}"/>
               </a:ext>
             </a:extLst>
           </p:cNvPr>
@@ -16963,7 +17060,7 @@
           <p:cNvPr id="8" name="">
             <a:extLst xmlns:a="http://schemas.openxmlformats.org/drawingml/2006/main">
               <a:ext uri="{FF2B5EF4-FFF2-40B4-BE49-F238E27FC236}">
-                <a16:creationId xmlns:a16="http://schemas.microsoft.com/office/drawing/2014/main" id="{DEE1F579-4934-40D7-AF3E-AEA42231E793}"/>
+                <a16:creationId xmlns:a16="http://schemas.microsoft.com/office/drawing/2014/main" id="{2FA70F46-0DD2-4414-84A3-623F613CC980}"/>
               </a:ext>
             </a:extLst>
           </p:cNvPr>
@@ -16996,7 +17093,7 @@
           <p:cNvPr id="9" name="">
             <a:extLst xmlns:a="http://schemas.openxmlformats.org/drawingml/2006/main">
               <a:ext uri="{FF2B5EF4-FFF2-40B4-BE49-F238E27FC236}">
-                <a16:creationId xmlns:a16="http://schemas.microsoft.com/office/drawing/2014/main" id="{91B366E0-CC56-4018-ADE3-CFC80ED098A3}"/>
+                <a16:creationId xmlns:a16="http://schemas.microsoft.com/office/drawing/2014/main" id="{1BD59F8C-04D4-4751-A4EE-ED041D57E55B}"/>
               </a:ext>
             </a:extLst>
           </p:cNvPr>
@@ -17060,7 +17157,7 @@
           <p:cNvPr id="10" name="">
             <a:extLst xmlns:a="http://schemas.openxmlformats.org/drawingml/2006/main">
               <a:ext uri="{FF2B5EF4-FFF2-40B4-BE49-F238E27FC236}">
-                <a16:creationId xmlns:a16="http://schemas.microsoft.com/office/drawing/2014/main" id="{6A0B00A7-1BE5-4B46-BA70-11C1C30D0528}"/>
+                <a16:creationId xmlns:a16="http://schemas.microsoft.com/office/drawing/2014/main" id="{7143E310-4AEC-44F1-9738-BC9CD949DAE9}"/>
               </a:ext>
             </a:extLst>
           </p:cNvPr>
@@ -17093,7 +17190,7 @@
           <p:cNvPr id="11" name="">
             <a:extLst xmlns:a="http://schemas.openxmlformats.org/drawingml/2006/main">
               <a:ext uri="{FF2B5EF4-FFF2-40B4-BE49-F238E27FC236}">
-                <a16:creationId xmlns:a16="http://schemas.microsoft.com/office/drawing/2014/main" id="{5F9CE458-82CC-46BE-ACE8-4DACA0E867C3}"/>
+                <a16:creationId xmlns:a16="http://schemas.microsoft.com/office/drawing/2014/main" id="{8DAFFC8E-517D-4CEE-B7C0-FCC986BF0E4C}"/>
               </a:ext>
             </a:extLst>
           </p:cNvPr>
@@ -17157,7 +17254,7 @@
           <p:cNvPr id="12" name="">
             <a:extLst xmlns:a="http://schemas.openxmlformats.org/drawingml/2006/main">
               <a:ext uri="{FF2B5EF4-FFF2-40B4-BE49-F238E27FC236}">
-                <a16:creationId xmlns:a16="http://schemas.microsoft.com/office/drawing/2014/main" id="{69E93ED0-A597-4F3E-B02D-E890FE232D55}"/>
+                <a16:creationId xmlns:a16="http://schemas.microsoft.com/office/drawing/2014/main" id="{69677BE0-D752-471B-B9C8-4EC129952390}"/>
               </a:ext>
             </a:extLst>
           </p:cNvPr>
@@ -17190,7 +17287,7 @@
           <p:cNvPr id="13" name="">
             <a:extLst xmlns:a="http://schemas.openxmlformats.org/drawingml/2006/main">
               <a:ext uri="{FF2B5EF4-FFF2-40B4-BE49-F238E27FC236}">
-                <a16:creationId xmlns:a16="http://schemas.microsoft.com/office/drawing/2014/main" id="{F796EA06-B129-44C5-A229-474653322F15}"/>
+                <a16:creationId xmlns:a16="http://schemas.microsoft.com/office/drawing/2014/main" id="{86F83451-5E34-4F2D-86A1-1523C7BE2652}"/>
               </a:ext>
             </a:extLst>
           </p:cNvPr>
@@ -17254,7 +17351,7 @@
           <p:cNvPr id="14" name="">
             <a:extLst xmlns:a="http://schemas.openxmlformats.org/drawingml/2006/main">
               <a:ext uri="{FF2B5EF4-FFF2-40B4-BE49-F238E27FC236}">
-                <a16:creationId xmlns:a16="http://schemas.microsoft.com/office/drawing/2014/main" id="{C7F766A7-EE20-4820-8A70-41CF4EFC6FE3}"/>
+                <a16:creationId xmlns:a16="http://schemas.microsoft.com/office/drawing/2014/main" id="{CEF0B0AA-3028-48D1-B85E-1E0C34B57067}"/>
               </a:ext>
             </a:extLst>
           </p:cNvPr>
@@ -17287,7 +17384,7 @@
           <p:cNvPr id="15" name="">
             <a:extLst xmlns:a="http://schemas.openxmlformats.org/drawingml/2006/main">
               <a:ext uri="{FF2B5EF4-FFF2-40B4-BE49-F238E27FC236}">
-                <a16:creationId xmlns:a16="http://schemas.microsoft.com/office/drawing/2014/main" id="{5C0A5E13-36B4-4092-BF36-DFEFD5C970A2}"/>
+                <a16:creationId xmlns:a16="http://schemas.microsoft.com/office/drawing/2014/main" id="{508C4E80-A20A-4CB0-97BB-B0BAFAA87A78}"/>
               </a:ext>
             </a:extLst>
           </p:cNvPr>
@@ -17351,7 +17448,7 @@
           <p:cNvPr id="16" name="">
             <a:extLst xmlns:a="http://schemas.openxmlformats.org/drawingml/2006/main">
               <a:ext uri="{FF2B5EF4-FFF2-40B4-BE49-F238E27FC236}">
-                <a16:creationId xmlns:a16="http://schemas.microsoft.com/office/drawing/2014/main" id="{21EA857F-B475-46C1-AADE-A4A681ED95CB}"/>
+                <a16:creationId xmlns:a16="http://schemas.microsoft.com/office/drawing/2014/main" id="{6A2D51F8-2D30-4F6B-A7F3-74215B8BA7A7}"/>
               </a:ext>
             </a:extLst>
           </p:cNvPr>
@@ -17384,7 +17481,7 @@
           <p:cNvPr id="17" name="">
             <a:extLst xmlns:a="http://schemas.openxmlformats.org/drawingml/2006/main">
               <a:ext uri="{FF2B5EF4-FFF2-40B4-BE49-F238E27FC236}">
-                <a16:creationId xmlns:a16="http://schemas.microsoft.com/office/drawing/2014/main" id="{59F54CC5-1372-451A-BD3D-2CB4316FDF77}"/>
+                <a16:creationId xmlns:a16="http://schemas.microsoft.com/office/drawing/2014/main" id="{2603A993-51B3-4A34-A834-E48F57AE043F}"/>
               </a:ext>
             </a:extLst>
           </p:cNvPr>
@@ -17448,7 +17545,7 @@
           <p:cNvPr id="18" name="">
             <a:extLst xmlns:a="http://schemas.openxmlformats.org/drawingml/2006/main">
               <a:ext uri="{FF2B5EF4-FFF2-40B4-BE49-F238E27FC236}">
-                <a16:creationId xmlns:a16="http://schemas.microsoft.com/office/drawing/2014/main" id="{74218131-00DB-47E9-988E-0A011384F3F0}"/>
+                <a16:creationId xmlns:a16="http://schemas.microsoft.com/office/drawing/2014/main" id="{BE503B68-E863-4809-8A05-68A1A123CB8E}"/>
               </a:ext>
             </a:extLst>
           </p:cNvPr>
@@ -17481,7 +17578,7 @@
           <p:cNvPr id="19" name="">
             <a:extLst xmlns:a="http://schemas.openxmlformats.org/drawingml/2006/main">
               <a:ext uri="{FF2B5EF4-FFF2-40B4-BE49-F238E27FC236}">
-                <a16:creationId xmlns:a16="http://schemas.microsoft.com/office/drawing/2014/main" id="{A3EC0423-FE71-4C29-99DE-979D6BF4AB9C}"/>
+                <a16:creationId xmlns:a16="http://schemas.microsoft.com/office/drawing/2014/main" id="{C9BB1B33-BB67-4F4D-B73D-49A6F86C3B9B}"/>
               </a:ext>
             </a:extLst>
           </p:cNvPr>
@@ -17545,7 +17642,7 @@
           <p:cNvPr id="20" name="">
             <a:extLst xmlns:a="http://schemas.openxmlformats.org/drawingml/2006/main">
               <a:ext uri="{FF2B5EF4-FFF2-40B4-BE49-F238E27FC236}">
-                <a16:creationId xmlns:a16="http://schemas.microsoft.com/office/drawing/2014/main" id="{E1C592D0-A6BA-458E-932C-E58BA23A83BD}"/>
+                <a16:creationId xmlns:a16="http://schemas.microsoft.com/office/drawing/2014/main" id="{9A8F41CB-CD1F-46BE-B8CA-B0DC47FEC2E0}"/>
               </a:ext>
             </a:extLst>
           </p:cNvPr>
@@ -17609,7 +17706,7 @@
           <p:cNvPr id="21" name="">
             <a:extLst xmlns:a="http://schemas.openxmlformats.org/drawingml/2006/main">
               <a:ext uri="{FF2B5EF4-FFF2-40B4-BE49-F238E27FC236}">
-                <a16:creationId xmlns:a16="http://schemas.microsoft.com/office/drawing/2014/main" id="{0DCA56D5-5330-40D2-A4A4-3C3011AED915}"/>
+                <a16:creationId xmlns:a16="http://schemas.microsoft.com/office/drawing/2014/main" id="{6BCC675D-939E-4070-803E-39BD211315AC}"/>
               </a:ext>
             </a:extLst>
           </p:cNvPr>
@@ -17671,7 +17768,7 @@
     </p:spTree>
     <p:extLst>
       <p:ext uri="{BB962C8B-B14F-4D97-AF65-F5344CB8AC3E}">
-        <p14:creationId xmlns:p14="http://schemas.microsoft.com/office/powerpoint/2010/main" val="734194788"/>
+        <p14:creationId xmlns:p14="http://schemas.microsoft.com/office/powerpoint/2010/main" val="904475847"/>
       </p:ext>
     </p:extLst>
   </p:cSld>
@@ -17695,7 +17792,7 @@
           <p:cNvPr id="1" name="">
             <a:extLst xmlns:a="http://schemas.openxmlformats.org/drawingml/2006/main">
               <a:ext uri="{FF2B5EF4-FFF2-40B4-BE49-F238E27FC236}">
-                <a16:creationId xmlns:a16="http://schemas.microsoft.com/office/drawing/2014/main" id="{B4F0EE79-F367-4E58-ABEE-2DEA06F5A49E}"/>
+                <a16:creationId xmlns:a16="http://schemas.microsoft.com/office/drawing/2014/main" id="{F5373489-61FB-4AB8-BF2A-284F68817188}"/>
               </a:ext>
             </a:extLst>
           </p:cNvPr>
@@ -17728,7 +17825,7 @@
           <p:cNvPr id="2" name="">
             <a:extLst xmlns:a="http://schemas.openxmlformats.org/drawingml/2006/main">
               <a:ext uri="{FF2B5EF4-FFF2-40B4-BE49-F238E27FC236}">
-                <a16:creationId xmlns:a16="http://schemas.microsoft.com/office/drawing/2014/main" id="{E6AECC8C-1BF3-4AAD-AFE0-E980D9C016D4}"/>
+                <a16:creationId xmlns:a16="http://schemas.microsoft.com/office/drawing/2014/main" id="{38C7035C-F6B8-4FC2-B382-4E0FBCA717D7}"/>
               </a:ext>
             </a:extLst>
           </p:cNvPr>
@@ -17761,7 +17858,7 @@
           <p:cNvPr id="3" name="">
             <a:extLst xmlns:a="http://schemas.openxmlformats.org/drawingml/2006/main">
               <a:ext uri="{FF2B5EF4-FFF2-40B4-BE49-F238E27FC236}">
-                <a16:creationId xmlns:a16="http://schemas.microsoft.com/office/drawing/2014/main" id="{4C6E11D5-48F0-4598-8032-CA14DB1191AE}"/>
+                <a16:creationId xmlns:a16="http://schemas.microsoft.com/office/drawing/2014/main" id="{666148C6-9A35-4184-970D-CAA3980C19CB}"/>
               </a:ext>
             </a:extLst>
           </p:cNvPr>
@@ -17825,7 +17922,7 @@
           <p:cNvPr id="4" name="">
             <a:extLst xmlns:a="http://schemas.openxmlformats.org/drawingml/2006/main">
               <a:ext uri="{FF2B5EF4-FFF2-40B4-BE49-F238E27FC236}">
-                <a16:creationId xmlns:a16="http://schemas.microsoft.com/office/drawing/2014/main" id="{5DEBE6DB-732A-4BCA-985D-53F99F9D9B0B}"/>
+                <a16:creationId xmlns:a16="http://schemas.microsoft.com/office/drawing/2014/main" id="{943371E3-7757-42D9-92AC-40AD5205696E}"/>
               </a:ext>
             </a:extLst>
           </p:cNvPr>
@@ -17889,7 +17986,7 @@
           <p:cNvPr id="5" name="">
             <a:extLst xmlns:a="http://schemas.openxmlformats.org/drawingml/2006/main">
               <a:ext uri="{FF2B5EF4-FFF2-40B4-BE49-F238E27FC236}">
-                <a16:creationId xmlns:a16="http://schemas.microsoft.com/office/drawing/2014/main" id="{9F1475C3-393D-4843-A7FF-5C2A86DE72A3}"/>
+                <a16:creationId xmlns:a16="http://schemas.microsoft.com/office/drawing/2014/main" id="{56FC0083-2652-4E28-AC5D-FFC0A3320C35}"/>
               </a:ext>
             </a:extLst>
           </p:cNvPr>
@@ -17922,7 +18019,7 @@
           <p:cNvPr id="6" name="">
             <a:extLst xmlns:a="http://schemas.openxmlformats.org/drawingml/2006/main">
               <a:ext uri="{FF2B5EF4-FFF2-40B4-BE49-F238E27FC236}">
-                <a16:creationId xmlns:a16="http://schemas.microsoft.com/office/drawing/2014/main" id="{7995B26F-0DBD-42B8-92E5-EC5CAE382085}"/>
+                <a16:creationId xmlns:a16="http://schemas.microsoft.com/office/drawing/2014/main" id="{8333894A-1676-4D05-B21D-23D6C6B71D03}"/>
               </a:ext>
             </a:extLst>
           </p:cNvPr>
@@ -17986,7 +18083,7 @@
           <p:cNvPr id="7" name="">
             <a:extLst xmlns:a="http://schemas.openxmlformats.org/drawingml/2006/main">
               <a:ext uri="{FF2B5EF4-FFF2-40B4-BE49-F238E27FC236}">
-                <a16:creationId xmlns:a16="http://schemas.microsoft.com/office/drawing/2014/main" id="{E69855D6-558B-464F-A737-545395BC87C7}"/>
+                <a16:creationId xmlns:a16="http://schemas.microsoft.com/office/drawing/2014/main" id="{18E4BAF5-6D7B-4FDD-91D5-FDADB52C423E}"/>
               </a:ext>
             </a:extLst>
           </p:cNvPr>
@@ -18019,7 +18116,7 @@
           <p:cNvPr id="8" name="">
             <a:extLst xmlns:a="http://schemas.openxmlformats.org/drawingml/2006/main">
               <a:ext uri="{FF2B5EF4-FFF2-40B4-BE49-F238E27FC236}">
-                <a16:creationId xmlns:a16="http://schemas.microsoft.com/office/drawing/2014/main" id="{235CB3A4-96FA-4FF8-880E-687F52AC69AF}"/>
+                <a16:creationId xmlns:a16="http://schemas.microsoft.com/office/drawing/2014/main" id="{510F5CC9-4A0E-41F5-8CC3-E76C5DC0F5B4}"/>
               </a:ext>
             </a:extLst>
           </p:cNvPr>
@@ -18083,7 +18180,7 @@
           <p:cNvPr id="9" name="">
             <a:extLst xmlns:a="http://schemas.openxmlformats.org/drawingml/2006/main">
               <a:ext uri="{FF2B5EF4-FFF2-40B4-BE49-F238E27FC236}">
-                <a16:creationId xmlns:a16="http://schemas.microsoft.com/office/drawing/2014/main" id="{C286E47D-956A-48E0-9229-5044091749B1}"/>
+                <a16:creationId xmlns:a16="http://schemas.microsoft.com/office/drawing/2014/main" id="{646A0B4E-C34E-47A9-A52B-8F37CC8026C1}"/>
               </a:ext>
             </a:extLst>
           </p:cNvPr>
@@ -18116,7 +18213,7 @@
           <p:cNvPr id="10" name="">
             <a:extLst xmlns:a="http://schemas.openxmlformats.org/drawingml/2006/main">
               <a:ext uri="{FF2B5EF4-FFF2-40B4-BE49-F238E27FC236}">
-                <a16:creationId xmlns:a16="http://schemas.microsoft.com/office/drawing/2014/main" id="{A6ECB6B8-759A-41D7-81BF-3177F4D9C6E1}"/>
+                <a16:creationId xmlns:a16="http://schemas.microsoft.com/office/drawing/2014/main" id="{C1FA2738-13AE-449D-828C-D494308D691D}"/>
               </a:ext>
             </a:extLst>
           </p:cNvPr>
@@ -18180,7 +18277,7 @@
           <p:cNvPr id="11" name="">
             <a:extLst xmlns:a="http://schemas.openxmlformats.org/drawingml/2006/main">
               <a:ext uri="{FF2B5EF4-FFF2-40B4-BE49-F238E27FC236}">
-                <a16:creationId xmlns:a16="http://schemas.microsoft.com/office/drawing/2014/main" id="{C5E64C7A-C438-4105-BFF8-F1E8D25EB611}"/>
+                <a16:creationId xmlns:a16="http://schemas.microsoft.com/office/drawing/2014/main" id="{D75BFF4C-1258-4E02-A5FD-BB959634A762}"/>
               </a:ext>
             </a:extLst>
           </p:cNvPr>
@@ -18213,7 +18310,7 @@
           <p:cNvPr id="12" name="">
             <a:extLst xmlns:a="http://schemas.openxmlformats.org/drawingml/2006/main">
               <a:ext uri="{FF2B5EF4-FFF2-40B4-BE49-F238E27FC236}">
-                <a16:creationId xmlns:a16="http://schemas.microsoft.com/office/drawing/2014/main" id="{D95DF5E7-06BC-4DB8-994C-1DEFA0676CD1}"/>
+                <a16:creationId xmlns:a16="http://schemas.microsoft.com/office/drawing/2014/main" id="{67C204FB-16F6-425F-BE67-DBD08C3D428F}"/>
               </a:ext>
             </a:extLst>
           </p:cNvPr>
@@ -18277,7 +18374,7 @@
           <p:cNvPr id="13" name="">
             <a:extLst xmlns:a="http://schemas.openxmlformats.org/drawingml/2006/main">
               <a:ext uri="{FF2B5EF4-FFF2-40B4-BE49-F238E27FC236}">
-                <a16:creationId xmlns:a16="http://schemas.microsoft.com/office/drawing/2014/main" id="{6BCEF3F7-1372-45EF-AD51-F25B813CD153}"/>
+                <a16:creationId xmlns:a16="http://schemas.microsoft.com/office/drawing/2014/main" id="{76564584-AF19-400E-88DC-592584BFEA0C}"/>
               </a:ext>
             </a:extLst>
           </p:cNvPr>
@@ -18310,7 +18407,7 @@
           <p:cNvPr id="14" name="">
             <a:extLst xmlns:a="http://schemas.openxmlformats.org/drawingml/2006/main">
               <a:ext uri="{FF2B5EF4-FFF2-40B4-BE49-F238E27FC236}">
-                <a16:creationId xmlns:a16="http://schemas.microsoft.com/office/drawing/2014/main" id="{CF9D09D2-80B1-4FB4-934E-2C7B3A6A8E8E}"/>
+                <a16:creationId xmlns:a16="http://schemas.microsoft.com/office/drawing/2014/main" id="{DE7B975C-DADF-40EB-A55F-2CD0A284DC8C}"/>
               </a:ext>
             </a:extLst>
           </p:cNvPr>
@@ -18374,7 +18471,7 @@
           <p:cNvPr id="15" name="">
             <a:extLst xmlns:a="http://schemas.openxmlformats.org/drawingml/2006/main">
               <a:ext uri="{FF2B5EF4-FFF2-40B4-BE49-F238E27FC236}">
-                <a16:creationId xmlns:a16="http://schemas.microsoft.com/office/drawing/2014/main" id="{EB6CAE9D-309A-4EFF-8A5F-74EBDEEA1304}"/>
+                <a16:creationId xmlns:a16="http://schemas.microsoft.com/office/drawing/2014/main" id="{11413294-08BC-4CC1-8C29-7EFA17906C67}"/>
               </a:ext>
             </a:extLst>
           </p:cNvPr>
@@ -18407,7 +18504,7 @@
           <p:cNvPr id="16" name="">
             <a:extLst xmlns:a="http://schemas.openxmlformats.org/drawingml/2006/main">
               <a:ext uri="{FF2B5EF4-FFF2-40B4-BE49-F238E27FC236}">
-                <a16:creationId xmlns:a16="http://schemas.microsoft.com/office/drawing/2014/main" id="{7E885B6F-60B7-4D55-A967-D0E1C69129B6}"/>
+                <a16:creationId xmlns:a16="http://schemas.microsoft.com/office/drawing/2014/main" id="{360EFE5E-0A92-4F99-A6D4-12CFDDCC7A14}"/>
               </a:ext>
             </a:extLst>
           </p:cNvPr>
@@ -18471,7 +18568,7 @@
           <p:cNvPr id="17" name="">
             <a:extLst xmlns:a="http://schemas.openxmlformats.org/drawingml/2006/main">
               <a:ext uri="{FF2B5EF4-FFF2-40B4-BE49-F238E27FC236}">
-                <a16:creationId xmlns:a16="http://schemas.microsoft.com/office/drawing/2014/main" id="{93E35D5B-E2C7-41AF-8D5C-C830A86132E3}"/>
+                <a16:creationId xmlns:a16="http://schemas.microsoft.com/office/drawing/2014/main" id="{C0C44A48-8726-4C4C-8F30-5D7D59434450}"/>
               </a:ext>
             </a:extLst>
           </p:cNvPr>
@@ -18535,7 +18632,7 @@
           <p:cNvPr id="18" name="">
             <a:extLst xmlns:a="http://schemas.openxmlformats.org/drawingml/2006/main">
               <a:ext uri="{FF2B5EF4-FFF2-40B4-BE49-F238E27FC236}">
-                <a16:creationId xmlns:a16="http://schemas.microsoft.com/office/drawing/2014/main" id="{B1D4B167-1546-4026-AB79-4B4EA05C95A0}"/>
+                <a16:creationId xmlns:a16="http://schemas.microsoft.com/office/drawing/2014/main" id="{A1D9DDB8-EACA-4485-B917-B39F92124209}"/>
               </a:ext>
             </a:extLst>
           </p:cNvPr>
@@ -18568,7 +18665,7 @@
           <p:cNvPr id="19" name="">
             <a:extLst xmlns:a="http://schemas.openxmlformats.org/drawingml/2006/main">
               <a:ext uri="{FF2B5EF4-FFF2-40B4-BE49-F238E27FC236}">
-                <a16:creationId xmlns:a16="http://schemas.microsoft.com/office/drawing/2014/main" id="{E9945601-BE35-4968-9900-7A96ED1CF0FF}"/>
+                <a16:creationId xmlns:a16="http://schemas.microsoft.com/office/drawing/2014/main" id="{8F76C182-DF11-4775-86E6-1BC462128B36}"/>
               </a:ext>
             </a:extLst>
           </p:cNvPr>
@@ -18632,7 +18729,7 @@
           <p:cNvPr id="20" name="">
             <a:extLst xmlns:a="http://schemas.openxmlformats.org/drawingml/2006/main">
               <a:ext uri="{FF2B5EF4-FFF2-40B4-BE49-F238E27FC236}">
-                <a16:creationId xmlns:a16="http://schemas.microsoft.com/office/drawing/2014/main" id="{5852FC9E-158E-401E-919A-57200898A742}"/>
+                <a16:creationId xmlns:a16="http://schemas.microsoft.com/office/drawing/2014/main" id="{362D6B41-EFAA-4EBB-ACA8-D36EBDCF741C}"/>
               </a:ext>
             </a:extLst>
           </p:cNvPr>
@@ -18665,7 +18762,7 @@
           <p:cNvPr id="21" name="">
             <a:extLst xmlns:a="http://schemas.openxmlformats.org/drawingml/2006/main">
               <a:ext uri="{FF2B5EF4-FFF2-40B4-BE49-F238E27FC236}">
-                <a16:creationId xmlns:a16="http://schemas.microsoft.com/office/drawing/2014/main" id="{C0B1A3DE-2E10-4AFF-A054-29992F00229C}"/>
+                <a16:creationId xmlns:a16="http://schemas.microsoft.com/office/drawing/2014/main" id="{C3DE8992-C032-4EBD-B637-568D7BD6B110}"/>
               </a:ext>
             </a:extLst>
           </p:cNvPr>
@@ -18729,7 +18826,7 @@
           <p:cNvPr id="22" name="">
             <a:extLst xmlns:a="http://schemas.openxmlformats.org/drawingml/2006/main">
               <a:ext uri="{FF2B5EF4-FFF2-40B4-BE49-F238E27FC236}">
-                <a16:creationId xmlns:a16="http://schemas.microsoft.com/office/drawing/2014/main" id="{C5AC26D1-FAAC-461A-AB13-223D8662E6F8}"/>
+                <a16:creationId xmlns:a16="http://schemas.microsoft.com/office/drawing/2014/main" id="{358F6CB5-20EF-4D33-8D72-CBF9D3019193}"/>
               </a:ext>
             </a:extLst>
           </p:cNvPr>
@@ -18762,7 +18859,7 @@
           <p:cNvPr id="23" name="">
             <a:extLst xmlns:a="http://schemas.openxmlformats.org/drawingml/2006/main">
               <a:ext uri="{FF2B5EF4-FFF2-40B4-BE49-F238E27FC236}">
-                <a16:creationId xmlns:a16="http://schemas.microsoft.com/office/drawing/2014/main" id="{E2528F47-6F77-45A8-BE7A-47AC421C8A51}"/>
+                <a16:creationId xmlns:a16="http://schemas.microsoft.com/office/drawing/2014/main" id="{E89A0B94-C490-446C-B0AD-86F4399A08AA}"/>
               </a:ext>
             </a:extLst>
           </p:cNvPr>
@@ -18826,7 +18923,7 @@
           <p:cNvPr id="24" name="">
             <a:extLst xmlns:a="http://schemas.openxmlformats.org/drawingml/2006/main">
               <a:ext uri="{FF2B5EF4-FFF2-40B4-BE49-F238E27FC236}">
-                <a16:creationId xmlns:a16="http://schemas.microsoft.com/office/drawing/2014/main" id="{17F295B0-902F-48B5-8E60-204D0E7D9949}"/>
+                <a16:creationId xmlns:a16="http://schemas.microsoft.com/office/drawing/2014/main" id="{6131DB2F-7384-4C10-8F1D-042CB8C5D745}"/>
               </a:ext>
             </a:extLst>
           </p:cNvPr>
@@ -18859,7 +18956,7 @@
           <p:cNvPr id="25" name="">
             <a:extLst xmlns:a="http://schemas.openxmlformats.org/drawingml/2006/main">
               <a:ext uri="{FF2B5EF4-FFF2-40B4-BE49-F238E27FC236}">
-                <a16:creationId xmlns:a16="http://schemas.microsoft.com/office/drawing/2014/main" id="{4FEC0395-4807-4F9D-91B1-B06E6273F90B}"/>
+                <a16:creationId xmlns:a16="http://schemas.microsoft.com/office/drawing/2014/main" id="{DE22CCA1-CB6D-4691-B6D5-F49B7D1ABB8D}"/>
               </a:ext>
             </a:extLst>
           </p:cNvPr>
@@ -18923,7 +19020,7 @@
           <p:cNvPr id="26" name="">
             <a:extLst xmlns:a="http://schemas.openxmlformats.org/drawingml/2006/main">
               <a:ext uri="{FF2B5EF4-FFF2-40B4-BE49-F238E27FC236}">
-                <a16:creationId xmlns:a16="http://schemas.microsoft.com/office/drawing/2014/main" id="{CF6BEA00-9271-4C6F-83E0-A916B14DBBB7}"/>
+                <a16:creationId xmlns:a16="http://schemas.microsoft.com/office/drawing/2014/main" id="{DED4D284-FF45-414B-A23C-E52374A739F7}"/>
               </a:ext>
             </a:extLst>
           </p:cNvPr>
@@ -18956,7 +19053,7 @@
           <p:cNvPr id="27" name="">
             <a:extLst xmlns:a="http://schemas.openxmlformats.org/drawingml/2006/main">
               <a:ext uri="{FF2B5EF4-FFF2-40B4-BE49-F238E27FC236}">
-                <a16:creationId xmlns:a16="http://schemas.microsoft.com/office/drawing/2014/main" id="{DFE333D0-A222-4596-BF85-701E0A8746A1}"/>
+                <a16:creationId xmlns:a16="http://schemas.microsoft.com/office/drawing/2014/main" id="{A978938F-7592-4214-943F-F2817EA45508}"/>
               </a:ext>
             </a:extLst>
           </p:cNvPr>
@@ -19020,7 +19117,7 @@
           <p:cNvPr id="28" name="">
             <a:extLst xmlns:a="http://schemas.openxmlformats.org/drawingml/2006/main">
               <a:ext uri="{FF2B5EF4-FFF2-40B4-BE49-F238E27FC236}">
-                <a16:creationId xmlns:a16="http://schemas.microsoft.com/office/drawing/2014/main" id="{1AA40E43-5CEC-4414-8FEF-AE8966643C06}"/>
+                <a16:creationId xmlns:a16="http://schemas.microsoft.com/office/drawing/2014/main" id="{12324B17-1A58-4669-BA15-EAA847D2A024}"/>
               </a:ext>
             </a:extLst>
           </p:cNvPr>
@@ -19084,7 +19181,7 @@
           <p:cNvPr id="29" name="">
             <a:extLst xmlns:a="http://schemas.openxmlformats.org/drawingml/2006/main">
               <a:ext uri="{FF2B5EF4-FFF2-40B4-BE49-F238E27FC236}">
-                <a16:creationId xmlns:a16="http://schemas.microsoft.com/office/drawing/2014/main" id="{6D702E12-88E1-4584-9068-F744D690CF25}"/>
+                <a16:creationId xmlns:a16="http://schemas.microsoft.com/office/drawing/2014/main" id="{BC99BEF4-1256-4466-A496-7988B8F264E8}"/>
               </a:ext>
             </a:extLst>
           </p:cNvPr>
@@ -19146,7 +19243,7 @@
     </p:spTree>
     <p:extLst>
       <p:ext uri="{BB962C8B-B14F-4D97-AF65-F5344CB8AC3E}">
-        <p14:creationId xmlns:p14="http://schemas.microsoft.com/office/powerpoint/2010/main" val="1388756115"/>
+        <p14:creationId xmlns:p14="http://schemas.microsoft.com/office/powerpoint/2010/main" val="91379027"/>
       </p:ext>
     </p:extLst>
   </p:cSld>
@@ -19170,7 +19267,7 @@
           <p:cNvPr id="1" name="">
             <a:extLst xmlns:a="http://schemas.openxmlformats.org/drawingml/2006/main">
               <a:ext uri="{FF2B5EF4-FFF2-40B4-BE49-F238E27FC236}">
-                <a16:creationId xmlns:a16="http://schemas.microsoft.com/office/drawing/2014/main" id="{D0FD4EAC-9C82-462E-99B8-4F275041514C}"/>
+                <a16:creationId xmlns:a16="http://schemas.microsoft.com/office/drawing/2014/main" id="{A1844978-6A96-4C1B-A33E-F3FA5ED098B2}"/>
               </a:ext>
             </a:extLst>
           </p:cNvPr>
@@ -19203,7 +19300,7 @@
           <p:cNvPr id="2" name="">
             <a:extLst xmlns:a="http://schemas.openxmlformats.org/drawingml/2006/main">
               <a:ext uri="{FF2B5EF4-FFF2-40B4-BE49-F238E27FC236}">
-                <a16:creationId xmlns:a16="http://schemas.microsoft.com/office/drawing/2014/main" id="{4E636D28-4429-48C9-8958-2FCB3C9891CC}"/>
+                <a16:creationId xmlns:a16="http://schemas.microsoft.com/office/drawing/2014/main" id="{A1A50176-A9E4-4966-8A4F-DEF23609CADC}"/>
               </a:ext>
             </a:extLst>
           </p:cNvPr>
@@ -19236,7 +19333,7 @@
           <p:cNvPr id="3" name="">
             <a:extLst xmlns:a="http://schemas.openxmlformats.org/drawingml/2006/main">
               <a:ext uri="{FF2B5EF4-FFF2-40B4-BE49-F238E27FC236}">
-                <a16:creationId xmlns:a16="http://schemas.microsoft.com/office/drawing/2014/main" id="{DE564F0D-75AE-4399-B652-AE14F788FA40}"/>
+                <a16:creationId xmlns:a16="http://schemas.microsoft.com/office/drawing/2014/main" id="{A96CA180-EB62-4260-B906-A446281A1148}"/>
               </a:ext>
             </a:extLst>
           </p:cNvPr>
@@ -19300,7 +19397,7 @@
           <p:cNvPr id="4" name="">
             <a:extLst xmlns:a="http://schemas.openxmlformats.org/drawingml/2006/main">
               <a:ext uri="{FF2B5EF4-FFF2-40B4-BE49-F238E27FC236}">
-                <a16:creationId xmlns:a16="http://schemas.microsoft.com/office/drawing/2014/main" id="{DABF2F86-68DA-4C76-BD62-0E8C9DCA1477}"/>
+                <a16:creationId xmlns:a16="http://schemas.microsoft.com/office/drawing/2014/main" id="{943CD71D-482A-4D08-9C9D-3C3542BADE35}"/>
               </a:ext>
             </a:extLst>
           </p:cNvPr>
@@ -19364,7 +19461,7 @@
           <p:cNvPr id="5" name="">
             <a:extLst xmlns:a="http://schemas.openxmlformats.org/drawingml/2006/main">
               <a:ext uri="{FF2B5EF4-FFF2-40B4-BE49-F238E27FC236}">
-                <a16:creationId xmlns:a16="http://schemas.microsoft.com/office/drawing/2014/main" id="{2662B3D0-2D42-4E42-B559-5943BC16DF4D}"/>
+                <a16:creationId xmlns:a16="http://schemas.microsoft.com/office/drawing/2014/main" id="{2E23333B-C8CD-4EA4-8C4B-57538943D5B6}"/>
               </a:ext>
             </a:extLst>
           </p:cNvPr>
@@ -19397,7 +19494,7 @@
           <p:cNvPr id="6" name="">
             <a:extLst xmlns:a="http://schemas.openxmlformats.org/drawingml/2006/main">
               <a:ext uri="{FF2B5EF4-FFF2-40B4-BE49-F238E27FC236}">
-                <a16:creationId xmlns:a16="http://schemas.microsoft.com/office/drawing/2014/main" id="{FA28218B-DD9A-4C8A-ABFC-3FF679A9DE2C}"/>
+                <a16:creationId xmlns:a16="http://schemas.microsoft.com/office/drawing/2014/main" id="{BB6A68BE-2A4E-4199-93FF-124220DFD9F8}"/>
               </a:ext>
             </a:extLst>
           </p:cNvPr>
@@ -19430,7 +19527,7 @@
           <p:cNvPr id="7" name="">
             <a:extLst xmlns:a="http://schemas.openxmlformats.org/drawingml/2006/main">
               <a:ext uri="{FF2B5EF4-FFF2-40B4-BE49-F238E27FC236}">
-                <a16:creationId xmlns:a16="http://schemas.microsoft.com/office/drawing/2014/main" id="{2375F379-B401-4D71-B1F5-ACD1D08D749A}"/>
+                <a16:creationId xmlns:a16="http://schemas.microsoft.com/office/drawing/2014/main" id="{E02B7C60-ABC6-45D6-ACAE-DDC4202E578D}"/>
               </a:ext>
             </a:extLst>
           </p:cNvPr>
@@ -19494,7 +19591,7 @@
           <p:cNvPr id="8" name="">
             <a:extLst xmlns:a="http://schemas.openxmlformats.org/drawingml/2006/main">
               <a:ext uri="{FF2B5EF4-FFF2-40B4-BE49-F238E27FC236}">
-                <a16:creationId xmlns:a16="http://schemas.microsoft.com/office/drawing/2014/main" id="{CA395DDC-BCCE-4C02-803E-1419F72094F7}"/>
+                <a16:creationId xmlns:a16="http://schemas.microsoft.com/office/drawing/2014/main" id="{3EA99E4E-20EB-4EFA-8229-2177DC1E8DF9}"/>
               </a:ext>
             </a:extLst>
           </p:cNvPr>
@@ -19527,7 +19624,7 @@
           <p:cNvPr id="9" name="">
             <a:extLst xmlns:a="http://schemas.openxmlformats.org/drawingml/2006/main">
               <a:ext uri="{FF2B5EF4-FFF2-40B4-BE49-F238E27FC236}">
-                <a16:creationId xmlns:a16="http://schemas.microsoft.com/office/drawing/2014/main" id="{D8C27730-0D7F-40EC-9A0C-6D4753B2305A}"/>
+                <a16:creationId xmlns:a16="http://schemas.microsoft.com/office/drawing/2014/main" id="{D56AD214-C703-4A83-9B96-91B8F10B1F08}"/>
               </a:ext>
             </a:extLst>
           </p:cNvPr>
@@ -19591,7 +19688,7 @@
           <p:cNvPr id="10" name="">
             <a:extLst xmlns:a="http://schemas.openxmlformats.org/drawingml/2006/main">
               <a:ext uri="{FF2B5EF4-FFF2-40B4-BE49-F238E27FC236}">
-                <a16:creationId xmlns:a16="http://schemas.microsoft.com/office/drawing/2014/main" id="{1EF204D9-8D8A-4F29-84CB-22FBA24B421E}"/>
+                <a16:creationId xmlns:a16="http://schemas.microsoft.com/office/drawing/2014/main" id="{584BD92C-67E2-4141-95DD-814AD5C982C1}"/>
               </a:ext>
             </a:extLst>
           </p:cNvPr>
@@ -19624,7 +19721,7 @@
           <p:cNvPr id="11" name="">
             <a:extLst xmlns:a="http://schemas.openxmlformats.org/drawingml/2006/main">
               <a:ext uri="{FF2B5EF4-FFF2-40B4-BE49-F238E27FC236}">
-                <a16:creationId xmlns:a16="http://schemas.microsoft.com/office/drawing/2014/main" id="{540FA80D-4081-447C-B893-3E02CA6C5823}"/>
+                <a16:creationId xmlns:a16="http://schemas.microsoft.com/office/drawing/2014/main" id="{921418CC-CEA2-49DB-BC36-A4B417484882}"/>
               </a:ext>
             </a:extLst>
           </p:cNvPr>
@@ -19688,7 +19785,7 @@
           <p:cNvPr id="12" name="">
             <a:extLst xmlns:a="http://schemas.openxmlformats.org/drawingml/2006/main">
               <a:ext uri="{FF2B5EF4-FFF2-40B4-BE49-F238E27FC236}">
-                <a16:creationId xmlns:a16="http://schemas.microsoft.com/office/drawing/2014/main" id="{A1857035-56DF-4347-9283-5036DAF70728}"/>
+                <a16:creationId xmlns:a16="http://schemas.microsoft.com/office/drawing/2014/main" id="{85D27B63-7DCA-407F-800F-FC4F4ABA6E1F}"/>
               </a:ext>
             </a:extLst>
           </p:cNvPr>
@@ -19721,7 +19818,7 @@
           <p:cNvPr id="13" name="">
             <a:extLst xmlns:a="http://schemas.openxmlformats.org/drawingml/2006/main">
               <a:ext uri="{FF2B5EF4-FFF2-40B4-BE49-F238E27FC236}">
-                <a16:creationId xmlns:a16="http://schemas.microsoft.com/office/drawing/2014/main" id="{F7F4BFD3-A557-4CBE-BD26-D739B3C453C5}"/>
+                <a16:creationId xmlns:a16="http://schemas.microsoft.com/office/drawing/2014/main" id="{BD1DD009-43FB-4761-BE46-0C1824A698C5}"/>
               </a:ext>
             </a:extLst>
           </p:cNvPr>
@@ -19785,7 +19882,7 @@
           <p:cNvPr id="14" name="">
             <a:extLst xmlns:a="http://schemas.openxmlformats.org/drawingml/2006/main">
               <a:ext uri="{FF2B5EF4-FFF2-40B4-BE49-F238E27FC236}">
-                <a16:creationId xmlns:a16="http://schemas.microsoft.com/office/drawing/2014/main" id="{2500229C-6A1D-4B48-AF7A-99A2A861F380}"/>
+                <a16:creationId xmlns:a16="http://schemas.microsoft.com/office/drawing/2014/main" id="{463EAFE1-E535-4CB0-B3E0-83EDB4E21A5F}"/>
               </a:ext>
             </a:extLst>
           </p:cNvPr>
@@ -19818,7 +19915,7 @@
           <p:cNvPr id="15" name="">
             <a:extLst xmlns:a="http://schemas.openxmlformats.org/drawingml/2006/main">
               <a:ext uri="{FF2B5EF4-FFF2-40B4-BE49-F238E27FC236}">
-                <a16:creationId xmlns:a16="http://schemas.microsoft.com/office/drawing/2014/main" id="{5B8D05EF-1073-40C8-9EB6-E82F8B339D60}"/>
+                <a16:creationId xmlns:a16="http://schemas.microsoft.com/office/drawing/2014/main" id="{805AD7D8-8B40-4086-B32F-D5FD048798B5}"/>
               </a:ext>
             </a:extLst>
           </p:cNvPr>
@@ -19882,7 +19979,7 @@
           <p:cNvPr id="16" name="">
             <a:extLst xmlns:a="http://schemas.openxmlformats.org/drawingml/2006/main">
               <a:ext uri="{FF2B5EF4-FFF2-40B4-BE49-F238E27FC236}">
-                <a16:creationId xmlns:a16="http://schemas.microsoft.com/office/drawing/2014/main" id="{2C8AC777-055B-42A6-9830-D79D52FDE2AF}"/>
+                <a16:creationId xmlns:a16="http://schemas.microsoft.com/office/drawing/2014/main" id="{41B225A2-EE2F-4387-B657-D6A30785C4F8}"/>
               </a:ext>
             </a:extLst>
           </p:cNvPr>
@@ -19915,7 +20012,7 @@
           <p:cNvPr id="17" name="">
             <a:extLst xmlns:a="http://schemas.openxmlformats.org/drawingml/2006/main">
               <a:ext uri="{FF2B5EF4-FFF2-40B4-BE49-F238E27FC236}">
-                <a16:creationId xmlns:a16="http://schemas.microsoft.com/office/drawing/2014/main" id="{FE100504-E0D0-44BC-89E5-14B70917384E}"/>
+                <a16:creationId xmlns:a16="http://schemas.microsoft.com/office/drawing/2014/main" id="{D478BC30-05FC-4810-873A-77AC7A5A34EA}"/>
               </a:ext>
             </a:extLst>
           </p:cNvPr>
@@ -19979,7 +20076,7 @@
           <p:cNvPr id="18" name="">
             <a:extLst xmlns:a="http://schemas.openxmlformats.org/drawingml/2006/main">
               <a:ext uri="{FF2B5EF4-FFF2-40B4-BE49-F238E27FC236}">
-                <a16:creationId xmlns:a16="http://schemas.microsoft.com/office/drawing/2014/main" id="{BC25417E-D0A2-410D-8070-2389AE409F46}"/>
+                <a16:creationId xmlns:a16="http://schemas.microsoft.com/office/drawing/2014/main" id="{53FE9B89-0ED1-40E7-AC81-A1D6B4971BD0}"/>
               </a:ext>
             </a:extLst>
           </p:cNvPr>
@@ -20043,7 +20140,7 @@
           <p:cNvPr id="19" name="">
             <a:extLst xmlns:a="http://schemas.openxmlformats.org/drawingml/2006/main">
               <a:ext uri="{FF2B5EF4-FFF2-40B4-BE49-F238E27FC236}">
-                <a16:creationId xmlns:a16="http://schemas.microsoft.com/office/drawing/2014/main" id="{912AB755-8E25-4640-940F-7C21E7CF4D78}"/>
+                <a16:creationId xmlns:a16="http://schemas.microsoft.com/office/drawing/2014/main" id="{0BDD9110-99D0-46A1-8651-287FEC2AE452}"/>
               </a:ext>
             </a:extLst>
           </p:cNvPr>
@@ -20105,7 +20202,7 @@
     </p:spTree>
     <p:extLst>
       <p:ext uri="{BB962C8B-B14F-4D97-AF65-F5344CB8AC3E}">
-        <p14:creationId xmlns:p14="http://schemas.microsoft.com/office/powerpoint/2010/main" val="1602666828"/>
+        <p14:creationId xmlns:p14="http://schemas.microsoft.com/office/powerpoint/2010/main" val="602608934"/>
       </p:ext>
     </p:extLst>
   </p:cSld>
@@ -20129,7 +20226,7 @@
           <p:cNvPr id="1" name="">
             <a:extLst xmlns:a="http://schemas.openxmlformats.org/drawingml/2006/main">
               <a:ext uri="{FF2B5EF4-FFF2-40B4-BE49-F238E27FC236}">
-                <a16:creationId xmlns:a16="http://schemas.microsoft.com/office/drawing/2014/main" id="{644D07A8-615E-4159-8F2B-BC963F0C16C6}"/>
+                <a16:creationId xmlns:a16="http://schemas.microsoft.com/office/drawing/2014/main" id="{BFD61871-97F9-46F4-B775-71D96CFD52BF}"/>
               </a:ext>
             </a:extLst>
           </p:cNvPr>
@@ -20162,7 +20259,7 @@
           <p:cNvPr id="2" name="">
             <a:extLst xmlns:a="http://schemas.openxmlformats.org/drawingml/2006/main">
               <a:ext uri="{FF2B5EF4-FFF2-40B4-BE49-F238E27FC236}">
-                <a16:creationId xmlns:a16="http://schemas.microsoft.com/office/drawing/2014/main" id="{CFBED9E6-47B3-4321-A608-368E0BCBBDFC}"/>
+                <a16:creationId xmlns:a16="http://schemas.microsoft.com/office/drawing/2014/main" id="{8F54247C-7333-4BA2-A22C-1EA2D4F5D203}"/>
               </a:ext>
             </a:extLst>
           </p:cNvPr>
@@ -20195,7 +20292,7 @@
           <p:cNvPr id="3" name="">
             <a:extLst xmlns:a="http://schemas.openxmlformats.org/drawingml/2006/main">
               <a:ext uri="{FF2B5EF4-FFF2-40B4-BE49-F238E27FC236}">
-                <a16:creationId xmlns:a16="http://schemas.microsoft.com/office/drawing/2014/main" id="{28999B4B-A042-4020-A847-07B49FB95624}"/>
+                <a16:creationId xmlns:a16="http://schemas.microsoft.com/office/drawing/2014/main" id="{747B185C-ECE4-44FD-A37B-9C77DBD7D9F7}"/>
               </a:ext>
             </a:extLst>
           </p:cNvPr>
@@ -20259,7 +20356,7 @@
           <p:cNvPr id="4" name="">
             <a:extLst xmlns:a="http://schemas.openxmlformats.org/drawingml/2006/main">
               <a:ext uri="{FF2B5EF4-FFF2-40B4-BE49-F238E27FC236}">
-                <a16:creationId xmlns:a16="http://schemas.microsoft.com/office/drawing/2014/main" id="{F2706A1E-668A-4DF7-AC2D-82F57F57C524}"/>
+                <a16:creationId xmlns:a16="http://schemas.microsoft.com/office/drawing/2014/main" id="{97FD88EB-31E6-4722-BB61-6CB059E1F6F2}"/>
               </a:ext>
             </a:extLst>
           </p:cNvPr>
@@ -20323,7 +20420,7 @@
           <p:cNvPr id="5" name="">
             <a:extLst xmlns:a="http://schemas.openxmlformats.org/drawingml/2006/main">
               <a:ext uri="{FF2B5EF4-FFF2-40B4-BE49-F238E27FC236}">
-                <a16:creationId xmlns:a16="http://schemas.microsoft.com/office/drawing/2014/main" id="{3AD03268-12F4-43D7-BA5E-20A9B46771C6}"/>
+                <a16:creationId xmlns:a16="http://schemas.microsoft.com/office/drawing/2014/main" id="{9DBFF22C-670F-4A73-BF78-EBC38522C069}"/>
               </a:ext>
             </a:extLst>
           </p:cNvPr>
@@ -20356,7 +20453,7 @@
           <p:cNvPr id="6" name="">
             <a:extLst xmlns:a="http://schemas.openxmlformats.org/drawingml/2006/main">
               <a:ext uri="{FF2B5EF4-FFF2-40B4-BE49-F238E27FC236}">
-                <a16:creationId xmlns:a16="http://schemas.microsoft.com/office/drawing/2014/main" id="{D3EBAC17-FAFD-4A10-B4BF-07CE504366C7}"/>
+                <a16:creationId xmlns:a16="http://schemas.microsoft.com/office/drawing/2014/main" id="{DB765120-C402-4A25-9DC0-D5701CE59CA6}"/>
               </a:ext>
             </a:extLst>
           </p:cNvPr>
@@ -20389,7 +20486,7 @@
           <p:cNvPr id="7" name="">
             <a:extLst xmlns:a="http://schemas.openxmlformats.org/drawingml/2006/main">
               <a:ext uri="{FF2B5EF4-FFF2-40B4-BE49-F238E27FC236}">
-                <a16:creationId xmlns:a16="http://schemas.microsoft.com/office/drawing/2014/main" id="{6228F28A-FA76-48BB-9ED9-65F4B7C34836}"/>
+                <a16:creationId xmlns:a16="http://schemas.microsoft.com/office/drawing/2014/main" id="{18237ED8-FB63-4805-A666-292EA5E92049}"/>
               </a:ext>
             </a:extLst>
           </p:cNvPr>
@@ -20453,7 +20550,7 @@
           <p:cNvPr id="8" name="">
             <a:extLst xmlns:a="http://schemas.openxmlformats.org/drawingml/2006/main">
               <a:ext uri="{FF2B5EF4-FFF2-40B4-BE49-F238E27FC236}">
-                <a16:creationId xmlns:a16="http://schemas.microsoft.com/office/drawing/2014/main" id="{2A4EAC65-F137-4661-B3E2-895C91E17B10}"/>
+                <a16:creationId xmlns:a16="http://schemas.microsoft.com/office/drawing/2014/main" id="{B50CF455-072B-468C-A64F-C9518C76DC69}"/>
               </a:ext>
             </a:extLst>
           </p:cNvPr>
@@ -20486,7 +20583,7 @@
           <p:cNvPr id="9" name="">
             <a:extLst xmlns:a="http://schemas.openxmlformats.org/drawingml/2006/main">
               <a:ext uri="{FF2B5EF4-FFF2-40B4-BE49-F238E27FC236}">
-                <a16:creationId xmlns:a16="http://schemas.microsoft.com/office/drawing/2014/main" id="{4C5257C9-D5F3-4B97-817D-41A4440AC26E}"/>
+                <a16:creationId xmlns:a16="http://schemas.microsoft.com/office/drawing/2014/main" id="{4D3988AD-03D8-4557-8C7A-D6A5E8F20DDA}"/>
               </a:ext>
             </a:extLst>
           </p:cNvPr>
@@ -20550,7 +20647,7 @@
           <p:cNvPr id="10" name="">
             <a:extLst xmlns:a="http://schemas.openxmlformats.org/drawingml/2006/main">
               <a:ext uri="{FF2B5EF4-FFF2-40B4-BE49-F238E27FC236}">
-                <a16:creationId xmlns:a16="http://schemas.microsoft.com/office/drawing/2014/main" id="{D7E694E3-DA3F-4C54-907C-CB47AAE5CE6E}"/>
+                <a16:creationId xmlns:a16="http://schemas.microsoft.com/office/drawing/2014/main" id="{36CB745C-A679-466A-BE70-C38C1F6EF870}"/>
               </a:ext>
             </a:extLst>
           </p:cNvPr>
@@ -20583,7 +20680,7 @@
           <p:cNvPr id="11" name="">
             <a:extLst xmlns:a="http://schemas.openxmlformats.org/drawingml/2006/main">
               <a:ext uri="{FF2B5EF4-FFF2-40B4-BE49-F238E27FC236}">
-                <a16:creationId xmlns:a16="http://schemas.microsoft.com/office/drawing/2014/main" id="{9C4A862C-0E48-4B3B-A7FD-26F49DB7A323}"/>
+                <a16:creationId xmlns:a16="http://schemas.microsoft.com/office/drawing/2014/main" id="{D835BC9D-2D60-499D-830A-08072C1186DE}"/>
               </a:ext>
             </a:extLst>
           </p:cNvPr>
@@ -20647,7 +20744,7 @@
           <p:cNvPr id="12" name="">
             <a:extLst xmlns:a="http://schemas.openxmlformats.org/drawingml/2006/main">
               <a:ext uri="{FF2B5EF4-FFF2-40B4-BE49-F238E27FC236}">
-                <a16:creationId xmlns:a16="http://schemas.microsoft.com/office/drawing/2014/main" id="{6B54F7EE-6CCD-4471-9F4F-6CA2D022FAC0}"/>
+                <a16:creationId xmlns:a16="http://schemas.microsoft.com/office/drawing/2014/main" id="{A76D77AE-8970-4A0E-97DB-9C6C7541A324}"/>
               </a:ext>
             </a:extLst>
           </p:cNvPr>
@@ -20680,7 +20777,7 @@
           <p:cNvPr id="13" name="">
             <a:extLst xmlns:a="http://schemas.openxmlformats.org/drawingml/2006/main">
               <a:ext uri="{FF2B5EF4-FFF2-40B4-BE49-F238E27FC236}">
-                <a16:creationId xmlns:a16="http://schemas.microsoft.com/office/drawing/2014/main" id="{38C7D1DB-8CFE-4C62-AAD5-3B61A64083FF}"/>
+                <a16:creationId xmlns:a16="http://schemas.microsoft.com/office/drawing/2014/main" id="{88E55F93-635E-49FD-ACD4-2CF9069C43D3}"/>
               </a:ext>
             </a:extLst>
           </p:cNvPr>
@@ -20744,7 +20841,7 @@
           <p:cNvPr id="14" name="">
             <a:extLst xmlns:a="http://schemas.openxmlformats.org/drawingml/2006/main">
               <a:ext uri="{FF2B5EF4-FFF2-40B4-BE49-F238E27FC236}">
-                <a16:creationId xmlns:a16="http://schemas.microsoft.com/office/drawing/2014/main" id="{C3C3D976-418C-4091-8A11-6F0E0072359A}"/>
+                <a16:creationId xmlns:a16="http://schemas.microsoft.com/office/drawing/2014/main" id="{66C509AC-7DE6-4FAA-8C05-F1480E820B03}"/>
               </a:ext>
             </a:extLst>
           </p:cNvPr>
@@ -20777,7 +20874,7 @@
           <p:cNvPr id="15" name="">
             <a:extLst xmlns:a="http://schemas.openxmlformats.org/drawingml/2006/main">
               <a:ext uri="{FF2B5EF4-FFF2-40B4-BE49-F238E27FC236}">
-                <a16:creationId xmlns:a16="http://schemas.microsoft.com/office/drawing/2014/main" id="{9770D562-37FE-4A80-BCB4-1C6DDA307C23}"/>
+                <a16:creationId xmlns:a16="http://schemas.microsoft.com/office/drawing/2014/main" id="{3EB70120-E11D-4079-8FD2-8DABFB486166}"/>
               </a:ext>
             </a:extLst>
           </p:cNvPr>
@@ -20841,7 +20938,7 @@
           <p:cNvPr id="16" name="">
             <a:extLst xmlns:a="http://schemas.openxmlformats.org/drawingml/2006/main">
               <a:ext uri="{FF2B5EF4-FFF2-40B4-BE49-F238E27FC236}">
-                <a16:creationId xmlns:a16="http://schemas.microsoft.com/office/drawing/2014/main" id="{7E6C09E9-3AE1-4FD3-A397-C73510C9517F}"/>
+                <a16:creationId xmlns:a16="http://schemas.microsoft.com/office/drawing/2014/main" id="{EDE98CF1-B0CC-426D-95D6-9F7D7454106F}"/>
               </a:ext>
             </a:extLst>
           </p:cNvPr>
@@ -20874,7 +20971,7 @@
           <p:cNvPr id="17" name="">
             <a:extLst xmlns:a="http://schemas.openxmlformats.org/drawingml/2006/main">
               <a:ext uri="{FF2B5EF4-FFF2-40B4-BE49-F238E27FC236}">
-                <a16:creationId xmlns:a16="http://schemas.microsoft.com/office/drawing/2014/main" id="{6745A186-8D69-4575-B9AC-20B5B910D5B9}"/>
+                <a16:creationId xmlns:a16="http://schemas.microsoft.com/office/drawing/2014/main" id="{DB0022D3-1B02-42B3-9A23-49ABB0677926}"/>
               </a:ext>
             </a:extLst>
           </p:cNvPr>
@@ -20938,7 +21035,7 @@
           <p:cNvPr id="18" name="">
             <a:extLst xmlns:a="http://schemas.openxmlformats.org/drawingml/2006/main">
               <a:ext uri="{FF2B5EF4-FFF2-40B4-BE49-F238E27FC236}">
-                <a16:creationId xmlns:a16="http://schemas.microsoft.com/office/drawing/2014/main" id="{7634D723-FCAD-4CC2-A8B0-0F409DECA40B}"/>
+                <a16:creationId xmlns:a16="http://schemas.microsoft.com/office/drawing/2014/main" id="{BF11378B-8E4A-4927-B9D5-272028EEA78C}"/>
               </a:ext>
             </a:extLst>
           </p:cNvPr>
@@ -21002,7 +21099,7 @@
           <p:cNvPr id="19" name="">
             <a:extLst xmlns:a="http://schemas.openxmlformats.org/drawingml/2006/main">
               <a:ext uri="{FF2B5EF4-FFF2-40B4-BE49-F238E27FC236}">
-                <a16:creationId xmlns:a16="http://schemas.microsoft.com/office/drawing/2014/main" id="{E5FD3D8D-2B2B-4E3E-883B-4F4D33FE721E}"/>
+                <a16:creationId xmlns:a16="http://schemas.microsoft.com/office/drawing/2014/main" id="{28B82062-DD0A-4745-BC26-C114F73BF001}"/>
               </a:ext>
             </a:extLst>
           </p:cNvPr>
@@ -21064,7 +21161,7 @@
     </p:spTree>
     <p:extLst>
       <p:ext uri="{BB962C8B-B14F-4D97-AF65-F5344CB8AC3E}">
-        <p14:creationId xmlns:p14="http://schemas.microsoft.com/office/powerpoint/2010/main" val="566565720"/>
+        <p14:creationId xmlns:p14="http://schemas.microsoft.com/office/powerpoint/2010/main" val="64314698"/>
       </p:ext>
     </p:extLst>
   </p:cSld>
@@ -21088,7 +21185,7 @@
           <p:cNvPr id="1" name="">
             <a:extLst xmlns:a="http://schemas.openxmlformats.org/drawingml/2006/main">
               <a:ext uri="{FF2B5EF4-FFF2-40B4-BE49-F238E27FC236}">
-                <a16:creationId xmlns:a16="http://schemas.microsoft.com/office/drawing/2014/main" id="{67632DC8-1A75-4951-B404-C88416C259C6}"/>
+                <a16:creationId xmlns:a16="http://schemas.microsoft.com/office/drawing/2014/main" id="{9B90F498-FFE2-4C06-809D-2E3B73ACBD6F}"/>
               </a:ext>
             </a:extLst>
           </p:cNvPr>
@@ -21121,7 +21218,7 @@
           <p:cNvPr id="2" name="">
             <a:extLst xmlns:a="http://schemas.openxmlformats.org/drawingml/2006/main">
               <a:ext uri="{FF2B5EF4-FFF2-40B4-BE49-F238E27FC236}">
-                <a16:creationId xmlns:a16="http://schemas.microsoft.com/office/drawing/2014/main" id="{0252F737-603B-4277-B5D4-128181641561}"/>
+                <a16:creationId xmlns:a16="http://schemas.microsoft.com/office/drawing/2014/main" id="{65BBDAC2-2731-4A10-BE61-DF6209186E91}"/>
               </a:ext>
             </a:extLst>
           </p:cNvPr>
@@ -21154,7 +21251,7 @@
           <p:cNvPr id="3" name="">
             <a:extLst xmlns:a="http://schemas.openxmlformats.org/drawingml/2006/main">
               <a:ext uri="{FF2B5EF4-FFF2-40B4-BE49-F238E27FC236}">
-                <a16:creationId xmlns:a16="http://schemas.microsoft.com/office/drawing/2014/main" id="{B1D65297-C5A2-4CC2-A173-CC326B2C3D2E}"/>
+                <a16:creationId xmlns:a16="http://schemas.microsoft.com/office/drawing/2014/main" id="{8F5B750A-F129-41B4-9613-37B0E3B96246}"/>
               </a:ext>
             </a:extLst>
           </p:cNvPr>
@@ -21218,7 +21315,7 @@
           <p:cNvPr id="4" name="">
             <a:extLst xmlns:a="http://schemas.openxmlformats.org/drawingml/2006/main">
               <a:ext uri="{FF2B5EF4-FFF2-40B4-BE49-F238E27FC236}">
-                <a16:creationId xmlns:a16="http://schemas.microsoft.com/office/drawing/2014/main" id="{5B6EE512-44D3-41D3-B23B-4311129A55DB}"/>
+                <a16:creationId xmlns:a16="http://schemas.microsoft.com/office/drawing/2014/main" id="{F57517BE-1E21-468E-9C59-7F219310B895}"/>
               </a:ext>
             </a:extLst>
           </p:cNvPr>
@@ -21282,7 +21379,7 @@
           <p:cNvPr id="5" name="">
             <a:extLst xmlns:a="http://schemas.openxmlformats.org/drawingml/2006/main">
               <a:ext uri="{FF2B5EF4-FFF2-40B4-BE49-F238E27FC236}">
-                <a16:creationId xmlns:a16="http://schemas.microsoft.com/office/drawing/2014/main" id="{4394705F-1770-431E-BEDE-C2C2D31BAAAE}"/>
+                <a16:creationId xmlns:a16="http://schemas.microsoft.com/office/drawing/2014/main" id="{D276169F-5913-47B4-AC85-61C3E65C64FD}"/>
               </a:ext>
             </a:extLst>
           </p:cNvPr>
@@ -21315,7 +21412,7 @@
           <p:cNvPr id="6" name="">
             <a:extLst xmlns:a="http://schemas.openxmlformats.org/drawingml/2006/main">
               <a:ext uri="{FF2B5EF4-FFF2-40B4-BE49-F238E27FC236}">
-                <a16:creationId xmlns:a16="http://schemas.microsoft.com/office/drawing/2014/main" id="{C2C9BB83-A28B-4C05-BC57-E6A1A48AD694}"/>
+                <a16:creationId xmlns:a16="http://schemas.microsoft.com/office/drawing/2014/main" id="{9FC09ED9-8C33-4CE4-B2D6-F1BACDAF88E4}"/>
               </a:ext>
             </a:extLst>
           </p:cNvPr>
@@ -21348,7 +21445,7 @@
           <p:cNvPr id="7" name="">
             <a:extLst xmlns:a="http://schemas.openxmlformats.org/drawingml/2006/main">
               <a:ext uri="{FF2B5EF4-FFF2-40B4-BE49-F238E27FC236}">
-                <a16:creationId xmlns:a16="http://schemas.microsoft.com/office/drawing/2014/main" id="{AD6581A8-52E5-4591-8CB3-B631453FFB71}"/>
+                <a16:creationId xmlns:a16="http://schemas.microsoft.com/office/drawing/2014/main" id="{1E187AF9-BF8F-4C12-9C0E-D5F52F19165F}"/>
               </a:ext>
             </a:extLst>
           </p:cNvPr>
@@ -21412,7 +21509,7 @@
           <p:cNvPr id="8" name="">
             <a:extLst xmlns:a="http://schemas.openxmlformats.org/drawingml/2006/main">
               <a:ext uri="{FF2B5EF4-FFF2-40B4-BE49-F238E27FC236}">
-                <a16:creationId xmlns:a16="http://schemas.microsoft.com/office/drawing/2014/main" id="{37E83AAE-98D6-407F-87C0-B8658C0B6CBA}"/>
+                <a16:creationId xmlns:a16="http://schemas.microsoft.com/office/drawing/2014/main" id="{CD739896-1601-4246-996F-3F3F55ECE82D}"/>
               </a:ext>
             </a:extLst>
           </p:cNvPr>
@@ -21445,7 +21542,7 @@
           <p:cNvPr id="9" name="">
             <a:extLst xmlns:a="http://schemas.openxmlformats.org/drawingml/2006/main">
               <a:ext uri="{FF2B5EF4-FFF2-40B4-BE49-F238E27FC236}">
-                <a16:creationId xmlns:a16="http://schemas.microsoft.com/office/drawing/2014/main" id="{F859E611-890D-428E-AD65-8D98DF6B79B0}"/>
+                <a16:creationId xmlns:a16="http://schemas.microsoft.com/office/drawing/2014/main" id="{3F2D88F3-8D83-45BC-9B92-28E9F7B6B75E}"/>
               </a:ext>
             </a:extLst>
           </p:cNvPr>
@@ -21509,7 +21606,7 @@
           <p:cNvPr id="10" name="">
             <a:extLst xmlns:a="http://schemas.openxmlformats.org/drawingml/2006/main">
               <a:ext uri="{FF2B5EF4-FFF2-40B4-BE49-F238E27FC236}">
-                <a16:creationId xmlns:a16="http://schemas.microsoft.com/office/drawing/2014/main" id="{B8192801-79FC-4ACA-8CC4-F11CEA127E57}"/>
+                <a16:creationId xmlns:a16="http://schemas.microsoft.com/office/drawing/2014/main" id="{ED2169AE-A260-433F-B4A8-73154BDDC214}"/>
               </a:ext>
             </a:extLst>
           </p:cNvPr>
@@ -21542,7 +21639,7 @@
           <p:cNvPr id="11" name="">
             <a:extLst xmlns:a="http://schemas.openxmlformats.org/drawingml/2006/main">
               <a:ext uri="{FF2B5EF4-FFF2-40B4-BE49-F238E27FC236}">
-                <a16:creationId xmlns:a16="http://schemas.microsoft.com/office/drawing/2014/main" id="{B8B78D2E-4EF3-42F5-AB18-D4A0FB5EA1BB}"/>
+                <a16:creationId xmlns:a16="http://schemas.microsoft.com/office/drawing/2014/main" id="{214C279B-F331-4831-83DD-23888BB94F87}"/>
               </a:ext>
             </a:extLst>
           </p:cNvPr>
@@ -21606,7 +21703,7 @@
           <p:cNvPr id="12" name="">
             <a:extLst xmlns:a="http://schemas.openxmlformats.org/drawingml/2006/main">
               <a:ext uri="{FF2B5EF4-FFF2-40B4-BE49-F238E27FC236}">
-                <a16:creationId xmlns:a16="http://schemas.microsoft.com/office/drawing/2014/main" id="{E90BC10C-5772-4AD8-BD87-DFBABB2AE798}"/>
+                <a16:creationId xmlns:a16="http://schemas.microsoft.com/office/drawing/2014/main" id="{88202BE3-4A3F-4AB1-ADA9-AE484E6D7194}"/>
               </a:ext>
             </a:extLst>
           </p:cNvPr>
@@ -21639,7 +21736,7 @@
           <p:cNvPr id="13" name="">
             <a:extLst xmlns:a="http://schemas.openxmlformats.org/drawingml/2006/main">
               <a:ext uri="{FF2B5EF4-FFF2-40B4-BE49-F238E27FC236}">
-                <a16:creationId xmlns:a16="http://schemas.microsoft.com/office/drawing/2014/main" id="{13E6C8B0-9CE0-4ACF-9A37-057845518BE6}"/>
+                <a16:creationId xmlns:a16="http://schemas.microsoft.com/office/drawing/2014/main" id="{B0D440AE-B618-4D99-BE03-899359D4C4B5}"/>
               </a:ext>
             </a:extLst>
           </p:cNvPr>
@@ -21703,7 +21800,7 @@
           <p:cNvPr id="14" name="">
             <a:extLst xmlns:a="http://schemas.openxmlformats.org/drawingml/2006/main">
               <a:ext uri="{FF2B5EF4-FFF2-40B4-BE49-F238E27FC236}">
-                <a16:creationId xmlns:a16="http://schemas.microsoft.com/office/drawing/2014/main" id="{C5E0923D-3ED0-4686-A713-E9860AD4E110}"/>
+                <a16:creationId xmlns:a16="http://schemas.microsoft.com/office/drawing/2014/main" id="{982EA378-FA9D-4CB0-B9C1-BFB9B408F7CF}"/>
               </a:ext>
             </a:extLst>
           </p:cNvPr>
@@ -21736,7 +21833,7 @@
           <p:cNvPr id="15" name="">
             <a:extLst xmlns:a="http://schemas.openxmlformats.org/drawingml/2006/main">
               <a:ext uri="{FF2B5EF4-FFF2-40B4-BE49-F238E27FC236}">
-                <a16:creationId xmlns:a16="http://schemas.microsoft.com/office/drawing/2014/main" id="{D75B6B36-8089-4AC8-8A2B-5B4FBE1AFA28}"/>
+                <a16:creationId xmlns:a16="http://schemas.microsoft.com/office/drawing/2014/main" id="{5CF4B90B-8451-4E4E-81E9-1911BC1C6D73}"/>
               </a:ext>
             </a:extLst>
           </p:cNvPr>
@@ -21800,7 +21897,7 @@
           <p:cNvPr id="16" name="">
             <a:extLst xmlns:a="http://schemas.openxmlformats.org/drawingml/2006/main">
               <a:ext uri="{FF2B5EF4-FFF2-40B4-BE49-F238E27FC236}">
-                <a16:creationId xmlns:a16="http://schemas.microsoft.com/office/drawing/2014/main" id="{B99CC5A2-1E83-4AA2-A0D9-2F3DA8C28A8C}"/>
+                <a16:creationId xmlns:a16="http://schemas.microsoft.com/office/drawing/2014/main" id="{00D5917C-4FAF-4306-8B07-9C052B2D9FA7}"/>
               </a:ext>
             </a:extLst>
           </p:cNvPr>
@@ -21833,7 +21930,7 @@
           <p:cNvPr id="17" name="">
             <a:extLst xmlns:a="http://schemas.openxmlformats.org/drawingml/2006/main">
               <a:ext uri="{FF2B5EF4-FFF2-40B4-BE49-F238E27FC236}">
-                <a16:creationId xmlns:a16="http://schemas.microsoft.com/office/drawing/2014/main" id="{86B5422A-6972-4D48-934E-BFA5C6D411EB}"/>
+                <a16:creationId xmlns:a16="http://schemas.microsoft.com/office/drawing/2014/main" id="{B5FAC43E-CE67-41BD-ADE9-400A8528C45C}"/>
               </a:ext>
             </a:extLst>
           </p:cNvPr>
@@ -21897,7 +21994,7 @@
           <p:cNvPr id="18" name="">
             <a:extLst xmlns:a="http://schemas.openxmlformats.org/drawingml/2006/main">
               <a:ext uri="{FF2B5EF4-FFF2-40B4-BE49-F238E27FC236}">
-                <a16:creationId xmlns:a16="http://schemas.microsoft.com/office/drawing/2014/main" id="{C69E232B-9BB6-455F-B3C9-6A48C41E67BF}"/>
+                <a16:creationId xmlns:a16="http://schemas.microsoft.com/office/drawing/2014/main" id="{8B9BD14C-224F-4ECC-BCA0-BA4942462870}"/>
               </a:ext>
             </a:extLst>
           </p:cNvPr>
@@ -21930,7 +22027,7 @@
           <p:cNvPr id="19" name="">
             <a:extLst xmlns:a="http://schemas.openxmlformats.org/drawingml/2006/main">
               <a:ext uri="{FF2B5EF4-FFF2-40B4-BE49-F238E27FC236}">
-                <a16:creationId xmlns:a16="http://schemas.microsoft.com/office/drawing/2014/main" id="{AD3BCCCA-4AE2-4A12-BD26-0F4FFD26D297}"/>
+                <a16:creationId xmlns:a16="http://schemas.microsoft.com/office/drawing/2014/main" id="{80541BB4-3FCD-4025-B76B-D23D5B130AC4}"/>
               </a:ext>
             </a:extLst>
           </p:cNvPr>
@@ -21994,7 +22091,7 @@
           <p:cNvPr id="20" name="">
             <a:extLst xmlns:a="http://schemas.openxmlformats.org/drawingml/2006/main">
               <a:ext uri="{FF2B5EF4-FFF2-40B4-BE49-F238E27FC236}">
-                <a16:creationId xmlns:a16="http://schemas.microsoft.com/office/drawing/2014/main" id="{1389FF40-FB6F-40EF-B998-A48901822490}"/>
+                <a16:creationId xmlns:a16="http://schemas.microsoft.com/office/drawing/2014/main" id="{06C8A198-B37A-4961-A4B5-3210C0B32CC3}"/>
               </a:ext>
             </a:extLst>
           </p:cNvPr>
@@ -22058,7 +22155,7 @@
           <p:cNvPr id="21" name="">
             <a:extLst xmlns:a="http://schemas.openxmlformats.org/drawingml/2006/main">
               <a:ext uri="{FF2B5EF4-FFF2-40B4-BE49-F238E27FC236}">
-                <a16:creationId xmlns:a16="http://schemas.microsoft.com/office/drawing/2014/main" id="{7E40607F-902F-4B1E-8E63-3539BC730867}"/>
+                <a16:creationId xmlns:a16="http://schemas.microsoft.com/office/drawing/2014/main" id="{BAA798BB-98B0-4A00-A2C3-441DB0E23636}"/>
               </a:ext>
             </a:extLst>
           </p:cNvPr>
@@ -22120,7 +22217,7 @@
     </p:spTree>
     <p:extLst>
       <p:ext uri="{BB962C8B-B14F-4D97-AF65-F5344CB8AC3E}">
-        <p14:creationId xmlns:p14="http://schemas.microsoft.com/office/powerpoint/2010/main" val="1782408232"/>
+        <p14:creationId xmlns:p14="http://schemas.microsoft.com/office/powerpoint/2010/main" val="2075766198"/>
       </p:ext>
     </p:extLst>
   </p:cSld>
@@ -22144,7 +22241,7 @@
           <p:cNvPr id="1" name="">
             <a:extLst xmlns:a="http://schemas.openxmlformats.org/drawingml/2006/main">
               <a:ext uri="{FF2B5EF4-FFF2-40B4-BE49-F238E27FC236}">
-                <a16:creationId xmlns:a16="http://schemas.microsoft.com/office/drawing/2014/main" id="{98D787C1-6121-46D4-9546-053B072EFE64}"/>
+                <a16:creationId xmlns:a16="http://schemas.microsoft.com/office/drawing/2014/main" id="{1926E502-A461-4C2B-A2D2-D79EDA3EE389}"/>
               </a:ext>
             </a:extLst>
           </p:cNvPr>
@@ -22177,7 +22274,7 @@
           <p:cNvPr id="2" name="">
             <a:extLst xmlns:a="http://schemas.openxmlformats.org/drawingml/2006/main">
               <a:ext uri="{FF2B5EF4-FFF2-40B4-BE49-F238E27FC236}">
-                <a16:creationId xmlns:a16="http://schemas.microsoft.com/office/drawing/2014/main" id="{39FB1EB2-3E0F-43F5-A83B-B9E325A4DA26}"/>
+                <a16:creationId xmlns:a16="http://schemas.microsoft.com/office/drawing/2014/main" id="{40B01B99-A7A9-4195-8F1D-6048714FA265}"/>
               </a:ext>
             </a:extLst>
           </p:cNvPr>
@@ -22210,7 +22307,7 @@
           <p:cNvPr id="3" name="">
             <a:extLst xmlns:a="http://schemas.openxmlformats.org/drawingml/2006/main">
               <a:ext uri="{FF2B5EF4-FFF2-40B4-BE49-F238E27FC236}">
-                <a16:creationId xmlns:a16="http://schemas.microsoft.com/office/drawing/2014/main" id="{90A6309D-1B30-4AC4-9F90-1EDFB6E78124}"/>
+                <a16:creationId xmlns:a16="http://schemas.microsoft.com/office/drawing/2014/main" id="{76F633E5-8D0A-40F8-A997-CB953702100B}"/>
               </a:ext>
             </a:extLst>
           </p:cNvPr>
@@ -22274,7 +22371,7 @@
           <p:cNvPr id="4" name="">
             <a:extLst xmlns:a="http://schemas.openxmlformats.org/drawingml/2006/main">
               <a:ext uri="{FF2B5EF4-FFF2-40B4-BE49-F238E27FC236}">
-                <a16:creationId xmlns:a16="http://schemas.microsoft.com/office/drawing/2014/main" id="{A304D59A-91D3-4DD0-97BA-39066A7AB77E}"/>
+                <a16:creationId xmlns:a16="http://schemas.microsoft.com/office/drawing/2014/main" id="{80257A02-78F3-4500-91A1-D5F5D4EAAE52}"/>
               </a:ext>
             </a:extLst>
           </p:cNvPr>
@@ -22338,7 +22435,7 @@
           <p:cNvPr id="5" name="">
             <a:extLst xmlns:a="http://schemas.openxmlformats.org/drawingml/2006/main">
               <a:ext uri="{FF2B5EF4-FFF2-40B4-BE49-F238E27FC236}">
-                <a16:creationId xmlns:a16="http://schemas.microsoft.com/office/drawing/2014/main" id="{6996FD23-5736-4578-8873-36153F505DC6}"/>
+                <a16:creationId xmlns:a16="http://schemas.microsoft.com/office/drawing/2014/main" id="{F3190699-E899-4DD4-838E-857BF18C2FD4}"/>
               </a:ext>
             </a:extLst>
           </p:cNvPr>
@@ -22371,7 +22468,7 @@
           <p:cNvPr id="6" name="">
             <a:extLst xmlns:a="http://schemas.openxmlformats.org/drawingml/2006/main">
               <a:ext uri="{FF2B5EF4-FFF2-40B4-BE49-F238E27FC236}">
-                <a16:creationId xmlns:a16="http://schemas.microsoft.com/office/drawing/2014/main" id="{72030145-63CF-4A86-80D4-9CF43FE3E8EB}"/>
+                <a16:creationId xmlns:a16="http://schemas.microsoft.com/office/drawing/2014/main" id="{83E28C19-201A-4BB2-A763-0D5C62E1A757}"/>
               </a:ext>
             </a:extLst>
           </p:cNvPr>
@@ -22404,7 +22501,7 @@
           <p:cNvPr id="7" name="">
             <a:extLst xmlns:a="http://schemas.openxmlformats.org/drawingml/2006/main">
               <a:ext uri="{FF2B5EF4-FFF2-40B4-BE49-F238E27FC236}">
-                <a16:creationId xmlns:a16="http://schemas.microsoft.com/office/drawing/2014/main" id="{73CF0009-2FFA-4152-8B09-154A16AAE5DC}"/>
+                <a16:creationId xmlns:a16="http://schemas.microsoft.com/office/drawing/2014/main" id="{356A4D1A-8683-4867-A521-D86DED803515}"/>
               </a:ext>
             </a:extLst>
           </p:cNvPr>
@@ -22468,7 +22565,7 @@
           <p:cNvPr id="8" name="">
             <a:extLst xmlns:a="http://schemas.openxmlformats.org/drawingml/2006/main">
               <a:ext uri="{FF2B5EF4-FFF2-40B4-BE49-F238E27FC236}">
-                <a16:creationId xmlns:a16="http://schemas.microsoft.com/office/drawing/2014/main" id="{BE2E4D96-8F75-4875-A905-C5AAE7DED207}"/>
+                <a16:creationId xmlns:a16="http://schemas.microsoft.com/office/drawing/2014/main" id="{BD709A4A-364C-4DFE-AD63-06AB91BE1D16}"/>
               </a:ext>
             </a:extLst>
           </p:cNvPr>
@@ -22501,7 +22598,7 @@
           <p:cNvPr id="9" name="">
             <a:extLst xmlns:a="http://schemas.openxmlformats.org/drawingml/2006/main">
               <a:ext uri="{FF2B5EF4-FFF2-40B4-BE49-F238E27FC236}">
-                <a16:creationId xmlns:a16="http://schemas.microsoft.com/office/drawing/2014/main" id="{8D88BCD6-B4EF-4BE0-86CC-021AD1ACC040}"/>
+                <a16:creationId xmlns:a16="http://schemas.microsoft.com/office/drawing/2014/main" id="{4C1454F1-B82B-49C7-975E-3A63AFD48D37}"/>
               </a:ext>
             </a:extLst>
           </p:cNvPr>
@@ -22565,7 +22662,7 @@
           <p:cNvPr id="10" name="">
             <a:extLst xmlns:a="http://schemas.openxmlformats.org/drawingml/2006/main">
               <a:ext uri="{FF2B5EF4-FFF2-40B4-BE49-F238E27FC236}">
-                <a16:creationId xmlns:a16="http://schemas.microsoft.com/office/drawing/2014/main" id="{F71FCE04-3888-4E61-8018-7E6A6A4C3FD6}"/>
+                <a16:creationId xmlns:a16="http://schemas.microsoft.com/office/drawing/2014/main" id="{0394A4E1-528A-4A1E-B5E3-35435493961B}"/>
               </a:ext>
             </a:extLst>
           </p:cNvPr>
@@ -22598,7 +22695,7 @@
           <p:cNvPr id="11" name="">
             <a:extLst xmlns:a="http://schemas.openxmlformats.org/drawingml/2006/main">
               <a:ext uri="{FF2B5EF4-FFF2-40B4-BE49-F238E27FC236}">
-                <a16:creationId xmlns:a16="http://schemas.microsoft.com/office/drawing/2014/main" id="{89982AFA-AE80-43E0-951F-A3EBB4F415FB}"/>
+                <a16:creationId xmlns:a16="http://schemas.microsoft.com/office/drawing/2014/main" id="{621AF587-B520-4373-AC8B-8F42A0F73577}"/>
               </a:ext>
             </a:extLst>
           </p:cNvPr>
@@ -22662,7 +22759,7 @@
           <p:cNvPr id="12" name="">
             <a:extLst xmlns:a="http://schemas.openxmlformats.org/drawingml/2006/main">
               <a:ext uri="{FF2B5EF4-FFF2-40B4-BE49-F238E27FC236}">
-                <a16:creationId xmlns:a16="http://schemas.microsoft.com/office/drawing/2014/main" id="{C288824D-B60A-41A6-8F57-1B4CDF450555}"/>
+                <a16:creationId xmlns:a16="http://schemas.microsoft.com/office/drawing/2014/main" id="{01652186-8C63-4E78-BDEE-266F42A09EBC}"/>
               </a:ext>
             </a:extLst>
           </p:cNvPr>
@@ -22695,7 +22792,7 @@
           <p:cNvPr id="13" name="">
             <a:extLst xmlns:a="http://schemas.openxmlformats.org/drawingml/2006/main">
               <a:ext uri="{FF2B5EF4-FFF2-40B4-BE49-F238E27FC236}">
-                <a16:creationId xmlns:a16="http://schemas.microsoft.com/office/drawing/2014/main" id="{4C0CE3AC-EFFF-4619-8274-8DF2D40A4315}"/>
+                <a16:creationId xmlns:a16="http://schemas.microsoft.com/office/drawing/2014/main" id="{FDB368BC-46AF-4E01-808C-462F422BDDE9}"/>
               </a:ext>
             </a:extLst>
           </p:cNvPr>
@@ -22759,7 +22856,7 @@
           <p:cNvPr id="14" name="">
             <a:extLst xmlns:a="http://schemas.openxmlformats.org/drawingml/2006/main">
               <a:ext uri="{FF2B5EF4-FFF2-40B4-BE49-F238E27FC236}">
-                <a16:creationId xmlns:a16="http://schemas.microsoft.com/office/drawing/2014/main" id="{35F45E03-ECE3-4E12-96FD-01480C255CB0}"/>
+                <a16:creationId xmlns:a16="http://schemas.microsoft.com/office/drawing/2014/main" id="{C731CF3A-CBEF-4AED-B657-2677E481679B}"/>
               </a:ext>
             </a:extLst>
           </p:cNvPr>
@@ -22792,7 +22889,7 @@
           <p:cNvPr id="15" name="">
             <a:extLst xmlns:a="http://schemas.openxmlformats.org/drawingml/2006/main">
               <a:ext uri="{FF2B5EF4-FFF2-40B4-BE49-F238E27FC236}">
-                <a16:creationId xmlns:a16="http://schemas.microsoft.com/office/drawing/2014/main" id="{76CBF1CB-BB1C-4201-8BC6-10F9D492439B}"/>
+                <a16:creationId xmlns:a16="http://schemas.microsoft.com/office/drawing/2014/main" id="{3FA51618-CB39-439B-8F26-397CDEE0B87F}"/>
               </a:ext>
             </a:extLst>
           </p:cNvPr>
@@ -22856,7 +22953,7 @@
           <p:cNvPr id="16" name="">
             <a:extLst xmlns:a="http://schemas.openxmlformats.org/drawingml/2006/main">
               <a:ext uri="{FF2B5EF4-FFF2-40B4-BE49-F238E27FC236}">
-                <a16:creationId xmlns:a16="http://schemas.microsoft.com/office/drawing/2014/main" id="{80512AD5-81DE-479A-AD87-988B75171C51}"/>
+                <a16:creationId xmlns:a16="http://schemas.microsoft.com/office/drawing/2014/main" id="{1906FEB9-8BE4-4F4D-A34B-93489CE2321A}"/>
               </a:ext>
             </a:extLst>
           </p:cNvPr>
@@ -22889,7 +22986,7 @@
           <p:cNvPr id="17" name="">
             <a:extLst xmlns:a="http://schemas.openxmlformats.org/drawingml/2006/main">
               <a:ext uri="{FF2B5EF4-FFF2-40B4-BE49-F238E27FC236}">
-                <a16:creationId xmlns:a16="http://schemas.microsoft.com/office/drawing/2014/main" id="{DD9D6CC5-6C01-4E4E-B292-13CF861C8BFA}"/>
+                <a16:creationId xmlns:a16="http://schemas.microsoft.com/office/drawing/2014/main" id="{D85B0484-8500-466E-9484-E3E801512863}"/>
               </a:ext>
             </a:extLst>
           </p:cNvPr>
@@ -22953,7 +23050,7 @@
           <p:cNvPr id="18" name="">
             <a:extLst xmlns:a="http://schemas.openxmlformats.org/drawingml/2006/main">
               <a:ext uri="{FF2B5EF4-FFF2-40B4-BE49-F238E27FC236}">
-                <a16:creationId xmlns:a16="http://schemas.microsoft.com/office/drawing/2014/main" id="{8961801A-31DD-4E8D-A779-6F1B87A23040}"/>
+                <a16:creationId xmlns:a16="http://schemas.microsoft.com/office/drawing/2014/main" id="{D1846016-9FA9-4021-8E4F-8E722B2F896D}"/>
               </a:ext>
             </a:extLst>
           </p:cNvPr>
@@ -23017,7 +23114,7 @@
           <p:cNvPr id="19" name="">
             <a:extLst xmlns:a="http://schemas.openxmlformats.org/drawingml/2006/main">
               <a:ext uri="{FF2B5EF4-FFF2-40B4-BE49-F238E27FC236}">
-                <a16:creationId xmlns:a16="http://schemas.microsoft.com/office/drawing/2014/main" id="{A905538B-F02D-46CE-BA11-6070CEC6336D}"/>
+                <a16:creationId xmlns:a16="http://schemas.microsoft.com/office/drawing/2014/main" id="{8ADF719B-22FA-455E-A698-FD41418937F7}"/>
               </a:ext>
             </a:extLst>
           </p:cNvPr>
@@ -23079,7 +23176,7 @@
     </p:spTree>
     <p:extLst>
       <p:ext uri="{BB962C8B-B14F-4D97-AF65-F5344CB8AC3E}">
-        <p14:creationId xmlns:p14="http://schemas.microsoft.com/office/powerpoint/2010/main" val="958698213"/>
+        <p14:creationId xmlns:p14="http://schemas.microsoft.com/office/powerpoint/2010/main" val="901478299"/>
       </p:ext>
     </p:extLst>
   </p:cSld>

</xml_diff>

<commit_message>
Keep final video set to five clips
</commit_message>
<xml_diff>
--- a/presentations/final/CODE_BLUE_RL_FINAL.pptx
+++ b/presentations/final/CODE_BLUE_RL_FINAL.pptx
@@ -2,30 +2,30 @@
 <file path=ppt/presentation.xml><?xml version="1.0" encoding="utf-8"?>
 <p:presentation xmlns:p="http://schemas.openxmlformats.org/presentationml/2006/main">
   <p:sldMasterIdLst>
-    <p:sldMasterId xmlns:r="http://schemas.openxmlformats.org/officeDocument/2006/relationships" id="2147483648" r:id="R52d7725644114391"/>
+    <p:sldMasterId xmlns:r="http://schemas.openxmlformats.org/officeDocument/2006/relationships" id="2147483648" r:id="Rfac0d91e509e4424"/>
   </p:sldMasterIdLst>
   <p:notesMasterIdLst>
-    <p:notesMasterId xmlns:r="http://schemas.openxmlformats.org/officeDocument/2006/relationships" r:id="R104b511619e74603"/>
+    <p:notesMasterId xmlns:r="http://schemas.openxmlformats.org/officeDocument/2006/relationships" r:id="Rec1082f9c5c34b51"/>
   </p:notesMasterIdLst>
   <p:sldIdLst>
-    <p:sldId xmlns:r="http://schemas.openxmlformats.org/officeDocument/2006/relationships" id="256" r:id="R8d79d93590fe475c"/>
-    <p:sldId xmlns:r="http://schemas.openxmlformats.org/officeDocument/2006/relationships" id="257" r:id="R79a1547025724a35"/>
-    <p:sldId xmlns:r="http://schemas.openxmlformats.org/officeDocument/2006/relationships" id="258" r:id="R1bf3ff047ab54439"/>
-    <p:sldId xmlns:r="http://schemas.openxmlformats.org/officeDocument/2006/relationships" id="259" r:id="R745949bac3ef47f2"/>
-    <p:sldId xmlns:r="http://schemas.openxmlformats.org/officeDocument/2006/relationships" id="260" r:id="R701b544c6ff34fc3"/>
-    <p:sldId xmlns:r="http://schemas.openxmlformats.org/officeDocument/2006/relationships" id="261" r:id="R0b9bf305b6954c3d"/>
-    <p:sldId xmlns:r="http://schemas.openxmlformats.org/officeDocument/2006/relationships" id="262" r:id="R2148578dfe9040a7"/>
-    <p:sldId xmlns:r="http://schemas.openxmlformats.org/officeDocument/2006/relationships" id="263" r:id="R5251335c4aec48c0"/>
-    <p:sldId xmlns:r="http://schemas.openxmlformats.org/officeDocument/2006/relationships" id="264" r:id="Rb89219f37c58464f"/>
-    <p:sldId xmlns:r="http://schemas.openxmlformats.org/officeDocument/2006/relationships" id="265" r:id="R2f3f43abda3b4448"/>
-    <p:sldId xmlns:r="http://schemas.openxmlformats.org/officeDocument/2006/relationships" id="266" r:id="R1c3a8f1366c842a8"/>
-    <p:sldId xmlns:r="http://schemas.openxmlformats.org/officeDocument/2006/relationships" id="267" r:id="R200642ed07af4784"/>
-    <p:sldId xmlns:r="http://schemas.openxmlformats.org/officeDocument/2006/relationships" id="268" r:id="Redf122642a2043fa"/>
-    <p:sldId xmlns:r="http://schemas.openxmlformats.org/officeDocument/2006/relationships" id="269" r:id="R4d51d750cc504276"/>
-    <p:sldId xmlns:r="http://schemas.openxmlformats.org/officeDocument/2006/relationships" id="270" r:id="Ra563284621f44edf"/>
-    <p:sldId xmlns:r="http://schemas.openxmlformats.org/officeDocument/2006/relationships" id="271" r:id="Rcd1871f22fd94d3a"/>
-    <p:sldId xmlns:r="http://schemas.openxmlformats.org/officeDocument/2006/relationships" id="272" r:id="R42d473ca427a4388"/>
-    <p:sldId xmlns:r="http://schemas.openxmlformats.org/officeDocument/2006/relationships" id="273" r:id="Rb80755d3b5dd4559"/>
+    <p:sldId xmlns:r="http://schemas.openxmlformats.org/officeDocument/2006/relationships" id="256" r:id="Rf189e69086c64f5b"/>
+    <p:sldId xmlns:r="http://schemas.openxmlformats.org/officeDocument/2006/relationships" id="257" r:id="R2c1ac58697334e64"/>
+    <p:sldId xmlns:r="http://schemas.openxmlformats.org/officeDocument/2006/relationships" id="258" r:id="Raa34b9c001dd4a8c"/>
+    <p:sldId xmlns:r="http://schemas.openxmlformats.org/officeDocument/2006/relationships" id="259" r:id="Rd69d6f25da114037"/>
+    <p:sldId xmlns:r="http://schemas.openxmlformats.org/officeDocument/2006/relationships" id="260" r:id="Racf4a8f0e1f24189"/>
+    <p:sldId xmlns:r="http://schemas.openxmlformats.org/officeDocument/2006/relationships" id="261" r:id="Rf1dab6f672c749f4"/>
+    <p:sldId xmlns:r="http://schemas.openxmlformats.org/officeDocument/2006/relationships" id="262" r:id="R92703d91fdf04b8c"/>
+    <p:sldId xmlns:r="http://schemas.openxmlformats.org/officeDocument/2006/relationships" id="263" r:id="Re361f49a40e24fba"/>
+    <p:sldId xmlns:r="http://schemas.openxmlformats.org/officeDocument/2006/relationships" id="264" r:id="R733c5b9deb2e428a"/>
+    <p:sldId xmlns:r="http://schemas.openxmlformats.org/officeDocument/2006/relationships" id="265" r:id="R21258a8d1e284838"/>
+    <p:sldId xmlns:r="http://schemas.openxmlformats.org/officeDocument/2006/relationships" id="266" r:id="R31c1f4b13bd24f6a"/>
+    <p:sldId xmlns:r="http://schemas.openxmlformats.org/officeDocument/2006/relationships" id="267" r:id="Rabb24a02e01b4924"/>
+    <p:sldId xmlns:r="http://schemas.openxmlformats.org/officeDocument/2006/relationships" id="268" r:id="R6438301ec6e54ab6"/>
+    <p:sldId xmlns:r="http://schemas.openxmlformats.org/officeDocument/2006/relationships" id="269" r:id="R373009efa12949b7"/>
+    <p:sldId xmlns:r="http://schemas.openxmlformats.org/officeDocument/2006/relationships" id="270" r:id="Rc656a56cd7de4dd8"/>
+    <p:sldId xmlns:r="http://schemas.openxmlformats.org/officeDocument/2006/relationships" id="271" r:id="R6a894bbddc0a4337"/>
+    <p:sldId xmlns:r="http://schemas.openxmlformats.org/officeDocument/2006/relationships" id="272" r:id="Ra38a0b757ad9429b"/>
+    <p:sldId xmlns:r="http://schemas.openxmlformats.org/officeDocument/2006/relationships" id="273" r:id="Re20af0b90dc94ab1"/>
   </p:sldIdLst>
   <p:sldSz cx="12192000" cy="6858000"/>
   <p:notesSz cx="6858000" cy="9144000"/>
@@ -1694,7 +1694,7 @@
   </p:cSld>
   <p:clrMap bg1="lt1" tx1="dk1" bg2="lt2" tx2="dk2" accent1="accent1" accent2="accent2" accent3="accent3" accent4="accent4" accent5="accent5" accent6="accent6" hlink="hlink" folHlink="folHlink"/>
   <p:sldLayoutIdLst>
-    <p:sldLayoutId xmlns:r="http://schemas.openxmlformats.org/officeDocument/2006/relationships" id="2147483649" r:id="Ra63a5442513d4189"/>
+    <p:sldLayoutId xmlns:r="http://schemas.openxmlformats.org/officeDocument/2006/relationships" id="2147483649" r:id="R169f5e59245f4ffc"/>
   </p:sldLayoutIdLst>
   <p:txStyles>
     <p:titleStyle>
@@ -2192,7 +2192,7 @@
           <p:cNvPr id="1" name="">
             <a:extLst xmlns:a="http://schemas.openxmlformats.org/drawingml/2006/main">
               <a:ext uri="{FF2B5EF4-FFF2-40B4-BE49-F238E27FC236}">
-                <a16:creationId xmlns:a16="http://schemas.microsoft.com/office/drawing/2014/main" id="{7024000B-08A8-477B-BCA2-AB78AE3FCAFE}"/>
+                <a16:creationId xmlns:a16="http://schemas.microsoft.com/office/drawing/2014/main" id="{B65B9307-4613-48BC-A95F-A19250FB1200}"/>
               </a:ext>
             </a:extLst>
           </p:cNvPr>
@@ -2225,7 +2225,7 @@
           <p:cNvPr id="2" name="">
             <a:extLst xmlns:a="http://schemas.openxmlformats.org/drawingml/2006/main">
               <a:ext uri="{FF2B5EF4-FFF2-40B4-BE49-F238E27FC236}">
-                <a16:creationId xmlns:a16="http://schemas.microsoft.com/office/drawing/2014/main" id="{8262DF5A-E5F3-4092-81BE-E32C6CD6CB47}"/>
+                <a16:creationId xmlns:a16="http://schemas.microsoft.com/office/drawing/2014/main" id="{EFBF3FEA-ADE9-4618-BEB2-60997F89C667}"/>
               </a:ext>
             </a:extLst>
           </p:cNvPr>
@@ -2258,7 +2258,7 @@
           <p:cNvPr id="3" name="">
             <a:extLst xmlns:a="http://schemas.openxmlformats.org/drawingml/2006/main">
               <a:ext uri="{FF2B5EF4-FFF2-40B4-BE49-F238E27FC236}">
-                <a16:creationId xmlns:a16="http://schemas.microsoft.com/office/drawing/2014/main" id="{9289742B-CB25-4174-9651-F79B72A49D0C}"/>
+                <a16:creationId xmlns:a16="http://schemas.microsoft.com/office/drawing/2014/main" id="{AD40214C-BCDC-42BA-B774-CBA344AE182C}"/>
               </a:ext>
             </a:extLst>
           </p:cNvPr>
@@ -2322,7 +2322,7 @@
           <p:cNvPr id="4" name="">
             <a:extLst xmlns:a="http://schemas.openxmlformats.org/drawingml/2006/main">
               <a:ext uri="{FF2B5EF4-FFF2-40B4-BE49-F238E27FC236}">
-                <a16:creationId xmlns:a16="http://schemas.microsoft.com/office/drawing/2014/main" id="{062E8DB0-94C1-46B9-B531-487BEBF63459}"/>
+                <a16:creationId xmlns:a16="http://schemas.microsoft.com/office/drawing/2014/main" id="{6D159331-9C6E-4A33-A684-C0F4795D2B64}"/>
               </a:ext>
             </a:extLst>
           </p:cNvPr>
@@ -2386,7 +2386,7 @@
           <p:cNvPr id="5" name="">
             <a:extLst xmlns:a="http://schemas.openxmlformats.org/drawingml/2006/main">
               <a:ext uri="{FF2B5EF4-FFF2-40B4-BE49-F238E27FC236}">
-                <a16:creationId xmlns:a16="http://schemas.microsoft.com/office/drawing/2014/main" id="{5EE43105-3ACF-49DA-A759-F21A184B0DAC}"/>
+                <a16:creationId xmlns:a16="http://schemas.microsoft.com/office/drawing/2014/main" id="{638D456E-92F9-4F54-8971-2FEF6943081B}"/>
               </a:ext>
             </a:extLst>
           </p:cNvPr>
@@ -2419,7 +2419,7 @@
           <p:cNvPr id="6" name="">
             <a:extLst xmlns:a="http://schemas.openxmlformats.org/drawingml/2006/main">
               <a:ext uri="{FF2B5EF4-FFF2-40B4-BE49-F238E27FC236}">
-                <a16:creationId xmlns:a16="http://schemas.microsoft.com/office/drawing/2014/main" id="{E24F6A60-8EE8-48D4-8347-0EC38B3A01B4}"/>
+                <a16:creationId xmlns:a16="http://schemas.microsoft.com/office/drawing/2014/main" id="{C446641C-9268-491F-BD22-A9140DC4B976}"/>
               </a:ext>
             </a:extLst>
           </p:cNvPr>
@@ -2452,7 +2452,7 @@
           <p:cNvPr id="7" name="">
             <a:extLst xmlns:a="http://schemas.openxmlformats.org/drawingml/2006/main">
               <a:ext uri="{FF2B5EF4-FFF2-40B4-BE49-F238E27FC236}">
-                <a16:creationId xmlns:a16="http://schemas.microsoft.com/office/drawing/2014/main" id="{65F35E72-A77E-4BFA-A1AF-3298C3FB392B}"/>
+                <a16:creationId xmlns:a16="http://schemas.microsoft.com/office/drawing/2014/main" id="{07B9C10F-89C3-4145-A43C-BBDEBE459B00}"/>
               </a:ext>
             </a:extLst>
           </p:cNvPr>
@@ -2516,7 +2516,7 @@
           <p:cNvPr id="8" name="">
             <a:extLst xmlns:a="http://schemas.openxmlformats.org/drawingml/2006/main">
               <a:ext uri="{FF2B5EF4-FFF2-40B4-BE49-F238E27FC236}">
-                <a16:creationId xmlns:a16="http://schemas.microsoft.com/office/drawing/2014/main" id="{28726E05-7120-4BBF-A17C-2950940BDF58}"/>
+                <a16:creationId xmlns:a16="http://schemas.microsoft.com/office/drawing/2014/main" id="{C5A47948-D5DC-485E-8BD7-8F9C008D7C42}"/>
               </a:ext>
             </a:extLst>
           </p:cNvPr>
@@ -2580,7 +2580,7 @@
           <p:cNvPr id="9" name="">
             <a:extLst xmlns:a="http://schemas.openxmlformats.org/drawingml/2006/main">
               <a:ext uri="{FF2B5EF4-FFF2-40B4-BE49-F238E27FC236}">
-                <a16:creationId xmlns:a16="http://schemas.microsoft.com/office/drawing/2014/main" id="{CDB611C3-EA1C-48D1-8628-A43711115B61}"/>
+                <a16:creationId xmlns:a16="http://schemas.microsoft.com/office/drawing/2014/main" id="{316B06B9-78AC-4207-9CF5-688BF941E95D}"/>
               </a:ext>
             </a:extLst>
           </p:cNvPr>
@@ -2613,7 +2613,7 @@
           <p:cNvPr id="10" name="">
             <a:extLst xmlns:a="http://schemas.openxmlformats.org/drawingml/2006/main">
               <a:ext uri="{FF2B5EF4-FFF2-40B4-BE49-F238E27FC236}">
-                <a16:creationId xmlns:a16="http://schemas.microsoft.com/office/drawing/2014/main" id="{61518698-5C34-4D29-91C2-6A05727F1D94}"/>
+                <a16:creationId xmlns:a16="http://schemas.microsoft.com/office/drawing/2014/main" id="{C9F8931D-7CF6-4539-9BF2-8FB9A8023182}"/>
               </a:ext>
             </a:extLst>
           </p:cNvPr>
@@ -2677,7 +2677,7 @@
           <p:cNvPr id="11" name="">
             <a:extLst xmlns:a="http://schemas.openxmlformats.org/drawingml/2006/main">
               <a:ext uri="{FF2B5EF4-FFF2-40B4-BE49-F238E27FC236}">
-                <a16:creationId xmlns:a16="http://schemas.microsoft.com/office/drawing/2014/main" id="{8F79BF80-475F-4F1A-A237-6D9DCA7C958B}"/>
+                <a16:creationId xmlns:a16="http://schemas.microsoft.com/office/drawing/2014/main" id="{E3ECAC49-E089-46D0-9BAA-CAE866DB9F01}"/>
               </a:ext>
             </a:extLst>
           </p:cNvPr>
@@ -2741,7 +2741,7 @@
           <p:cNvPr id="12" name="">
             <a:extLst xmlns:a="http://schemas.openxmlformats.org/drawingml/2006/main">
               <a:ext uri="{FF2B5EF4-FFF2-40B4-BE49-F238E27FC236}">
-                <a16:creationId xmlns:a16="http://schemas.microsoft.com/office/drawing/2014/main" id="{34970671-773F-4DB2-B79E-DB2AC1579113}"/>
+                <a16:creationId xmlns:a16="http://schemas.microsoft.com/office/drawing/2014/main" id="{CADCD707-836B-4F73-BFF9-BB09E4B3F442}"/>
               </a:ext>
             </a:extLst>
           </p:cNvPr>
@@ -2774,7 +2774,7 @@
           <p:cNvPr id="13" name="">
             <a:extLst xmlns:a="http://schemas.openxmlformats.org/drawingml/2006/main">
               <a:ext uri="{FF2B5EF4-FFF2-40B4-BE49-F238E27FC236}">
-                <a16:creationId xmlns:a16="http://schemas.microsoft.com/office/drawing/2014/main" id="{8C40727C-CFFA-4CF7-B125-E579200CE377}"/>
+                <a16:creationId xmlns:a16="http://schemas.microsoft.com/office/drawing/2014/main" id="{11FCD724-F08A-46FB-AB1B-6729FC772560}"/>
               </a:ext>
             </a:extLst>
           </p:cNvPr>
@@ -2838,7 +2838,7 @@
           <p:cNvPr id="14" name="">
             <a:extLst xmlns:a="http://schemas.openxmlformats.org/drawingml/2006/main">
               <a:ext uri="{FF2B5EF4-FFF2-40B4-BE49-F238E27FC236}">
-                <a16:creationId xmlns:a16="http://schemas.microsoft.com/office/drawing/2014/main" id="{049A35B1-B765-4AE7-8580-DA3198ED380A}"/>
+                <a16:creationId xmlns:a16="http://schemas.microsoft.com/office/drawing/2014/main" id="{05901D5A-BD38-42D5-A2B2-F4FFB3CDBA90}"/>
               </a:ext>
             </a:extLst>
           </p:cNvPr>
@@ -2902,7 +2902,7 @@
           <p:cNvPr id="15" name="">
             <a:extLst xmlns:a="http://schemas.openxmlformats.org/drawingml/2006/main">
               <a:ext uri="{FF2B5EF4-FFF2-40B4-BE49-F238E27FC236}">
-                <a16:creationId xmlns:a16="http://schemas.microsoft.com/office/drawing/2014/main" id="{1AE4FEA1-A9E0-4797-A293-62977D362EFF}"/>
+                <a16:creationId xmlns:a16="http://schemas.microsoft.com/office/drawing/2014/main" id="{1F25BCD3-8052-487F-9080-B5767CFE6DB3}"/>
               </a:ext>
             </a:extLst>
           </p:cNvPr>
@@ -2935,7 +2935,7 @@
           <p:cNvPr id="16" name="">
             <a:extLst xmlns:a="http://schemas.openxmlformats.org/drawingml/2006/main">
               <a:ext uri="{FF2B5EF4-FFF2-40B4-BE49-F238E27FC236}">
-                <a16:creationId xmlns:a16="http://schemas.microsoft.com/office/drawing/2014/main" id="{D3318D82-0290-4F7D-AD1F-E4C81012CDA7}"/>
+                <a16:creationId xmlns:a16="http://schemas.microsoft.com/office/drawing/2014/main" id="{D3F4274B-A82B-486D-A393-773DECA30611}"/>
               </a:ext>
             </a:extLst>
           </p:cNvPr>
@@ -2999,7 +2999,7 @@
           <p:cNvPr id="17" name="">
             <a:extLst xmlns:a="http://schemas.openxmlformats.org/drawingml/2006/main">
               <a:ext uri="{FF2B5EF4-FFF2-40B4-BE49-F238E27FC236}">
-                <a16:creationId xmlns:a16="http://schemas.microsoft.com/office/drawing/2014/main" id="{0DD8251A-040A-4A9E-85FC-2C5068EA94A2}"/>
+                <a16:creationId xmlns:a16="http://schemas.microsoft.com/office/drawing/2014/main" id="{9B5C77C9-B26E-4DEE-8228-432854BD4540}"/>
               </a:ext>
             </a:extLst>
           </p:cNvPr>
@@ -3063,7 +3063,7 @@
           <p:cNvPr id="18" name="">
             <a:extLst xmlns:a="http://schemas.openxmlformats.org/drawingml/2006/main">
               <a:ext uri="{FF2B5EF4-FFF2-40B4-BE49-F238E27FC236}">
-                <a16:creationId xmlns:a16="http://schemas.microsoft.com/office/drawing/2014/main" id="{D97674FE-F945-4AE0-9791-3DAFEAB2091E}"/>
+                <a16:creationId xmlns:a16="http://schemas.microsoft.com/office/drawing/2014/main" id="{906B70BC-7775-4D66-B6BD-A0BB6F90A482}"/>
               </a:ext>
             </a:extLst>
           </p:cNvPr>
@@ -3096,7 +3096,7 @@
           <p:cNvPr id="19" name="">
             <a:extLst xmlns:a="http://schemas.openxmlformats.org/drawingml/2006/main">
               <a:ext uri="{FF2B5EF4-FFF2-40B4-BE49-F238E27FC236}">
-                <a16:creationId xmlns:a16="http://schemas.microsoft.com/office/drawing/2014/main" id="{1D36C3CB-BFFA-4836-8D64-0A4EB5F24728}"/>
+                <a16:creationId xmlns:a16="http://schemas.microsoft.com/office/drawing/2014/main" id="{50122E4C-B7F9-4BE5-A13E-36C771E5DAAA}"/>
               </a:ext>
             </a:extLst>
           </p:cNvPr>
@@ -3160,7 +3160,7 @@
           <p:cNvPr id="20" name="">
             <a:extLst xmlns:a="http://schemas.openxmlformats.org/drawingml/2006/main">
               <a:ext uri="{FF2B5EF4-FFF2-40B4-BE49-F238E27FC236}">
-                <a16:creationId xmlns:a16="http://schemas.microsoft.com/office/drawing/2014/main" id="{EB2E85FD-4448-47BC-B024-BE5585059161}"/>
+                <a16:creationId xmlns:a16="http://schemas.microsoft.com/office/drawing/2014/main" id="{5461E1BA-B344-468F-BF3F-B69FC840E828}"/>
               </a:ext>
             </a:extLst>
           </p:cNvPr>
@@ -3193,7 +3193,7 @@
           <p:cNvPr id="21" name="">
             <a:extLst xmlns:a="http://schemas.openxmlformats.org/drawingml/2006/main">
               <a:ext uri="{FF2B5EF4-FFF2-40B4-BE49-F238E27FC236}">
-                <a16:creationId xmlns:a16="http://schemas.microsoft.com/office/drawing/2014/main" id="{B72F75AE-C9C2-4DF7-8994-98E9BF07B990}"/>
+                <a16:creationId xmlns:a16="http://schemas.microsoft.com/office/drawing/2014/main" id="{17850698-35D4-4E6D-B18A-49CE71857993}"/>
               </a:ext>
             </a:extLst>
           </p:cNvPr>
@@ -3257,7 +3257,7 @@
           <p:cNvPr id="22" name="">
             <a:extLst xmlns:a="http://schemas.openxmlformats.org/drawingml/2006/main">
               <a:ext uri="{FF2B5EF4-FFF2-40B4-BE49-F238E27FC236}">
-                <a16:creationId xmlns:a16="http://schemas.microsoft.com/office/drawing/2014/main" id="{C637890B-5D95-459A-AFD3-B883F369433F}"/>
+                <a16:creationId xmlns:a16="http://schemas.microsoft.com/office/drawing/2014/main" id="{EFC97ABB-4C43-4536-A033-1939B5956EDE}"/>
               </a:ext>
             </a:extLst>
           </p:cNvPr>
@@ -3290,7 +3290,7 @@
           <p:cNvPr id="23" name="">
             <a:extLst xmlns:a="http://schemas.openxmlformats.org/drawingml/2006/main">
               <a:ext uri="{FF2B5EF4-FFF2-40B4-BE49-F238E27FC236}">
-                <a16:creationId xmlns:a16="http://schemas.microsoft.com/office/drawing/2014/main" id="{16093573-0EBB-4C3C-A4D1-741B752E1ABA}"/>
+                <a16:creationId xmlns:a16="http://schemas.microsoft.com/office/drawing/2014/main" id="{D4E2C260-591A-47D5-8397-DAE51F486679}"/>
               </a:ext>
             </a:extLst>
           </p:cNvPr>
@@ -3354,7 +3354,7 @@
           <p:cNvPr id="24" name="">
             <a:extLst xmlns:a="http://schemas.openxmlformats.org/drawingml/2006/main">
               <a:ext uri="{FF2B5EF4-FFF2-40B4-BE49-F238E27FC236}">
-                <a16:creationId xmlns:a16="http://schemas.microsoft.com/office/drawing/2014/main" id="{7EE3F6A6-1529-44F8-ABDB-6C62EFEDF556}"/>
+                <a16:creationId xmlns:a16="http://schemas.microsoft.com/office/drawing/2014/main" id="{EBD34BAF-5DF1-43B6-8D94-460F4DED3C38}"/>
               </a:ext>
             </a:extLst>
           </p:cNvPr>
@@ -3387,7 +3387,7 @@
           <p:cNvPr id="25" name="">
             <a:extLst xmlns:a="http://schemas.openxmlformats.org/drawingml/2006/main">
               <a:ext uri="{FF2B5EF4-FFF2-40B4-BE49-F238E27FC236}">
-                <a16:creationId xmlns:a16="http://schemas.microsoft.com/office/drawing/2014/main" id="{ABD42D75-8520-4740-9576-986AD9225E5C}"/>
+                <a16:creationId xmlns:a16="http://schemas.microsoft.com/office/drawing/2014/main" id="{243B24F1-C9E3-4BD6-887E-156556F251BD}"/>
               </a:ext>
             </a:extLst>
           </p:cNvPr>
@@ -3451,7 +3451,7 @@
           <p:cNvPr id="26" name="">
             <a:extLst xmlns:a="http://schemas.openxmlformats.org/drawingml/2006/main">
               <a:ext uri="{FF2B5EF4-FFF2-40B4-BE49-F238E27FC236}">
-                <a16:creationId xmlns:a16="http://schemas.microsoft.com/office/drawing/2014/main" id="{982BBD56-04AB-48A4-AF24-76ACF4D7ED97}"/>
+                <a16:creationId xmlns:a16="http://schemas.microsoft.com/office/drawing/2014/main" id="{A50C9709-990C-44A7-968A-47C9F60C1B90}"/>
               </a:ext>
             </a:extLst>
           </p:cNvPr>
@@ -3484,7 +3484,7 @@
           <p:cNvPr id="27" name="">
             <a:extLst xmlns:a="http://schemas.openxmlformats.org/drawingml/2006/main">
               <a:ext uri="{FF2B5EF4-FFF2-40B4-BE49-F238E27FC236}">
-                <a16:creationId xmlns:a16="http://schemas.microsoft.com/office/drawing/2014/main" id="{CA04A76A-5A6F-4ACF-8389-FB821724914E}"/>
+                <a16:creationId xmlns:a16="http://schemas.microsoft.com/office/drawing/2014/main" id="{79769934-F85B-434A-82EF-5AE80325B49A}"/>
               </a:ext>
             </a:extLst>
           </p:cNvPr>
@@ -3548,7 +3548,7 @@
           <p:cNvPr id="28" name="">
             <a:extLst xmlns:a="http://schemas.openxmlformats.org/drawingml/2006/main">
               <a:ext uri="{FF2B5EF4-FFF2-40B4-BE49-F238E27FC236}">
-                <a16:creationId xmlns:a16="http://schemas.microsoft.com/office/drawing/2014/main" id="{987EA59E-0D5A-49B9-8578-DDA6B3855D06}"/>
+                <a16:creationId xmlns:a16="http://schemas.microsoft.com/office/drawing/2014/main" id="{9F255029-C102-4629-9047-C55D0C4956A9}"/>
               </a:ext>
             </a:extLst>
           </p:cNvPr>
@@ -3612,7 +3612,7 @@
           <p:cNvPr id="29" name="">
             <a:extLst xmlns:a="http://schemas.openxmlformats.org/drawingml/2006/main">
               <a:ext uri="{FF2B5EF4-FFF2-40B4-BE49-F238E27FC236}">
-                <a16:creationId xmlns:a16="http://schemas.microsoft.com/office/drawing/2014/main" id="{47A36635-1230-4A49-B2F3-81568527F078}"/>
+                <a16:creationId xmlns:a16="http://schemas.microsoft.com/office/drawing/2014/main" id="{19EB5040-B18E-4CD8-AE53-85C012BD81CA}"/>
               </a:ext>
             </a:extLst>
           </p:cNvPr>
@@ -3674,7 +3674,7 @@
     </p:spTree>
     <p:extLst>
       <p:ext uri="{BB962C8B-B14F-4D97-AF65-F5344CB8AC3E}">
-        <p14:creationId xmlns:p14="http://schemas.microsoft.com/office/powerpoint/2010/main" val="8427515"/>
+        <p14:creationId xmlns:p14="http://schemas.microsoft.com/office/powerpoint/2010/main" val="510247182"/>
       </p:ext>
     </p:extLst>
   </p:cSld>
@@ -3698,7 +3698,7 @@
           <p:cNvPr id="1" name="">
             <a:extLst xmlns:a="http://schemas.openxmlformats.org/drawingml/2006/main">
               <a:ext uri="{FF2B5EF4-FFF2-40B4-BE49-F238E27FC236}">
-                <a16:creationId xmlns:a16="http://schemas.microsoft.com/office/drawing/2014/main" id="{0421BBF7-C0A1-4072-93C7-57C962C2EDE9}"/>
+                <a16:creationId xmlns:a16="http://schemas.microsoft.com/office/drawing/2014/main" id="{D4F41C26-173E-43CB-8A45-FA3D76E393B8}"/>
               </a:ext>
             </a:extLst>
           </p:cNvPr>
@@ -3731,7 +3731,7 @@
           <p:cNvPr id="2" name="">
             <a:extLst xmlns:a="http://schemas.openxmlformats.org/drawingml/2006/main">
               <a:ext uri="{FF2B5EF4-FFF2-40B4-BE49-F238E27FC236}">
-                <a16:creationId xmlns:a16="http://schemas.microsoft.com/office/drawing/2014/main" id="{7724EDC9-D4F8-44A1-AB71-132F81DC1121}"/>
+                <a16:creationId xmlns:a16="http://schemas.microsoft.com/office/drawing/2014/main" id="{B4216514-32C8-4ED7-AE99-A44E20581515}"/>
               </a:ext>
             </a:extLst>
           </p:cNvPr>
@@ -3764,7 +3764,7 @@
           <p:cNvPr id="3" name="">
             <a:extLst xmlns:a="http://schemas.openxmlformats.org/drawingml/2006/main">
               <a:ext uri="{FF2B5EF4-FFF2-40B4-BE49-F238E27FC236}">
-                <a16:creationId xmlns:a16="http://schemas.microsoft.com/office/drawing/2014/main" id="{9F2FAE58-0B6A-415D-AA76-2EEF064E0754}"/>
+                <a16:creationId xmlns:a16="http://schemas.microsoft.com/office/drawing/2014/main" id="{C03228C7-C794-4696-A654-D9195947AA94}"/>
               </a:ext>
             </a:extLst>
           </p:cNvPr>
@@ -3828,7 +3828,7 @@
           <p:cNvPr id="4" name="">
             <a:extLst xmlns:a="http://schemas.openxmlformats.org/drawingml/2006/main">
               <a:ext uri="{FF2B5EF4-FFF2-40B4-BE49-F238E27FC236}">
-                <a16:creationId xmlns:a16="http://schemas.microsoft.com/office/drawing/2014/main" id="{B378BCB6-C7A9-4DE7-9EE8-8C7221D20BD5}"/>
+                <a16:creationId xmlns:a16="http://schemas.microsoft.com/office/drawing/2014/main" id="{C7A29752-A2B3-463D-BA92-2D19F4FA7635}"/>
               </a:ext>
             </a:extLst>
           </p:cNvPr>
@@ -3892,7 +3892,7 @@
           <p:cNvPr id="5" name="">
             <a:extLst xmlns:a="http://schemas.openxmlformats.org/drawingml/2006/main">
               <a:ext uri="{FF2B5EF4-FFF2-40B4-BE49-F238E27FC236}">
-                <a16:creationId xmlns:a16="http://schemas.microsoft.com/office/drawing/2014/main" id="{2DFC97EF-4E44-4FF0-94C2-86356EA984B4}"/>
+                <a16:creationId xmlns:a16="http://schemas.microsoft.com/office/drawing/2014/main" id="{8BDCB3F7-B616-4B2A-9C81-B4A8FE5DD09F}"/>
               </a:ext>
             </a:extLst>
           </p:cNvPr>
@@ -3925,7 +3925,7 @@
           <p:cNvPr id="6" name="">
             <a:extLst xmlns:a="http://schemas.openxmlformats.org/drawingml/2006/main">
               <a:ext uri="{FF2B5EF4-FFF2-40B4-BE49-F238E27FC236}">
-                <a16:creationId xmlns:a16="http://schemas.microsoft.com/office/drawing/2014/main" id="{22E2A748-F09C-4551-B9FB-54592254DCC6}"/>
+                <a16:creationId xmlns:a16="http://schemas.microsoft.com/office/drawing/2014/main" id="{8913A634-D308-450C-8CC3-9E2088C7ADA2}"/>
               </a:ext>
             </a:extLst>
           </p:cNvPr>
@@ -3958,7 +3958,7 @@
           <p:cNvPr id="7" name="">
             <a:extLst xmlns:a="http://schemas.openxmlformats.org/drawingml/2006/main">
               <a:ext uri="{FF2B5EF4-FFF2-40B4-BE49-F238E27FC236}">
-                <a16:creationId xmlns:a16="http://schemas.microsoft.com/office/drawing/2014/main" id="{4A61A1A0-322D-49EF-B0D8-599A3EA7C802}"/>
+                <a16:creationId xmlns:a16="http://schemas.microsoft.com/office/drawing/2014/main" id="{7A552006-2579-49ED-AC27-F98342E449C9}"/>
               </a:ext>
             </a:extLst>
           </p:cNvPr>
@@ -4022,7 +4022,7 @@
           <p:cNvPr id="8" name="">
             <a:extLst xmlns:a="http://schemas.openxmlformats.org/drawingml/2006/main">
               <a:ext uri="{FF2B5EF4-FFF2-40B4-BE49-F238E27FC236}">
-                <a16:creationId xmlns:a16="http://schemas.microsoft.com/office/drawing/2014/main" id="{0F090D74-6249-47EA-BC7C-55EF4F156EB2}"/>
+                <a16:creationId xmlns:a16="http://schemas.microsoft.com/office/drawing/2014/main" id="{25909C8B-BE34-48F6-B7AB-75244A093775}"/>
               </a:ext>
             </a:extLst>
           </p:cNvPr>
@@ -4055,7 +4055,7 @@
           <p:cNvPr id="9" name="">
             <a:extLst xmlns:a="http://schemas.openxmlformats.org/drawingml/2006/main">
               <a:ext uri="{FF2B5EF4-FFF2-40B4-BE49-F238E27FC236}">
-                <a16:creationId xmlns:a16="http://schemas.microsoft.com/office/drawing/2014/main" id="{27280F51-6E23-4A2F-AE7D-3A6AC8BB4419}"/>
+                <a16:creationId xmlns:a16="http://schemas.microsoft.com/office/drawing/2014/main" id="{5A92D807-34CE-4194-B585-F526C7E20699}"/>
               </a:ext>
             </a:extLst>
           </p:cNvPr>
@@ -4119,7 +4119,7 @@
           <p:cNvPr id="10" name="">
             <a:extLst xmlns:a="http://schemas.openxmlformats.org/drawingml/2006/main">
               <a:ext uri="{FF2B5EF4-FFF2-40B4-BE49-F238E27FC236}">
-                <a16:creationId xmlns:a16="http://schemas.microsoft.com/office/drawing/2014/main" id="{1FA5A333-70EE-49BC-AE2D-186A685417AA}"/>
+                <a16:creationId xmlns:a16="http://schemas.microsoft.com/office/drawing/2014/main" id="{054456CD-3E8D-418D-B11A-73825618071A}"/>
               </a:ext>
             </a:extLst>
           </p:cNvPr>
@@ -4152,7 +4152,7 @@
           <p:cNvPr id="11" name="">
             <a:extLst xmlns:a="http://schemas.openxmlformats.org/drawingml/2006/main">
               <a:ext uri="{FF2B5EF4-FFF2-40B4-BE49-F238E27FC236}">
-                <a16:creationId xmlns:a16="http://schemas.microsoft.com/office/drawing/2014/main" id="{0BDC542D-0143-489A-909D-E507FCAA0EF8}"/>
+                <a16:creationId xmlns:a16="http://schemas.microsoft.com/office/drawing/2014/main" id="{21549D70-BF2B-41E5-BD35-B8BC11D8EE87}"/>
               </a:ext>
             </a:extLst>
           </p:cNvPr>
@@ -4216,7 +4216,7 @@
           <p:cNvPr id="12" name="">
             <a:extLst xmlns:a="http://schemas.openxmlformats.org/drawingml/2006/main">
               <a:ext uri="{FF2B5EF4-FFF2-40B4-BE49-F238E27FC236}">
-                <a16:creationId xmlns:a16="http://schemas.microsoft.com/office/drawing/2014/main" id="{8D5A533C-5523-4067-AF21-1DC3C8CC80C9}"/>
+                <a16:creationId xmlns:a16="http://schemas.microsoft.com/office/drawing/2014/main" id="{13E0BE36-9365-4286-9F84-75E9D086CAC5}"/>
               </a:ext>
             </a:extLst>
           </p:cNvPr>
@@ -4249,7 +4249,7 @@
           <p:cNvPr id="13" name="">
             <a:extLst xmlns:a="http://schemas.openxmlformats.org/drawingml/2006/main">
               <a:ext uri="{FF2B5EF4-FFF2-40B4-BE49-F238E27FC236}">
-                <a16:creationId xmlns:a16="http://schemas.microsoft.com/office/drawing/2014/main" id="{EE20B45B-68B3-4954-B7DE-4A7E1A2BD71A}"/>
+                <a16:creationId xmlns:a16="http://schemas.microsoft.com/office/drawing/2014/main" id="{98E77EB1-8F6D-4399-852B-0A5BD42B56D9}"/>
               </a:ext>
             </a:extLst>
           </p:cNvPr>
@@ -4313,7 +4313,7 @@
           <p:cNvPr id="14" name="">
             <a:extLst xmlns:a="http://schemas.openxmlformats.org/drawingml/2006/main">
               <a:ext uri="{FF2B5EF4-FFF2-40B4-BE49-F238E27FC236}">
-                <a16:creationId xmlns:a16="http://schemas.microsoft.com/office/drawing/2014/main" id="{2D18FEEF-CECA-4844-93E2-64BC2A640D5C}"/>
+                <a16:creationId xmlns:a16="http://schemas.microsoft.com/office/drawing/2014/main" id="{838B1A09-DFC3-4141-A228-1ECB50D2CE58}"/>
               </a:ext>
             </a:extLst>
           </p:cNvPr>
@@ -4346,7 +4346,7 @@
           <p:cNvPr id="15" name="">
             <a:extLst xmlns:a="http://schemas.openxmlformats.org/drawingml/2006/main">
               <a:ext uri="{FF2B5EF4-FFF2-40B4-BE49-F238E27FC236}">
-                <a16:creationId xmlns:a16="http://schemas.microsoft.com/office/drawing/2014/main" id="{68D83C95-6D22-4C0A-B01B-5B6B0C87B163}"/>
+                <a16:creationId xmlns:a16="http://schemas.microsoft.com/office/drawing/2014/main" id="{EE26B3AA-07AB-4F1C-B266-65DF78818C53}"/>
               </a:ext>
             </a:extLst>
           </p:cNvPr>
@@ -4410,7 +4410,7 @@
           <p:cNvPr id="16" name="">
             <a:extLst xmlns:a="http://schemas.openxmlformats.org/drawingml/2006/main">
               <a:ext uri="{FF2B5EF4-FFF2-40B4-BE49-F238E27FC236}">
-                <a16:creationId xmlns:a16="http://schemas.microsoft.com/office/drawing/2014/main" id="{7FEB3238-5517-4869-857C-F4F8669A8C8C}"/>
+                <a16:creationId xmlns:a16="http://schemas.microsoft.com/office/drawing/2014/main" id="{C0F3C827-B731-4FB1-A752-5E64E3ED1B11}"/>
               </a:ext>
             </a:extLst>
           </p:cNvPr>
@@ -4443,7 +4443,7 @@
           <p:cNvPr id="17" name="">
             <a:extLst xmlns:a="http://schemas.openxmlformats.org/drawingml/2006/main">
               <a:ext uri="{FF2B5EF4-FFF2-40B4-BE49-F238E27FC236}">
-                <a16:creationId xmlns:a16="http://schemas.microsoft.com/office/drawing/2014/main" id="{8B2931C0-A4DE-4445-ABB7-D6408E317F22}"/>
+                <a16:creationId xmlns:a16="http://schemas.microsoft.com/office/drawing/2014/main" id="{D7AF7008-47A9-4CE6-B924-21E1FA164C7E}"/>
               </a:ext>
             </a:extLst>
           </p:cNvPr>
@@ -4507,7 +4507,7 @@
           <p:cNvPr id="18" name="">
             <a:extLst xmlns:a="http://schemas.openxmlformats.org/drawingml/2006/main">
               <a:ext uri="{FF2B5EF4-FFF2-40B4-BE49-F238E27FC236}">
-                <a16:creationId xmlns:a16="http://schemas.microsoft.com/office/drawing/2014/main" id="{53BE2549-411E-4AD6-B478-1D247411B610}"/>
+                <a16:creationId xmlns:a16="http://schemas.microsoft.com/office/drawing/2014/main" id="{ECF54F2A-6040-4453-94CB-44CCC50D8451}"/>
               </a:ext>
             </a:extLst>
           </p:cNvPr>
@@ -4571,7 +4571,7 @@
           <p:cNvPr id="19" name="">
             <a:extLst xmlns:a="http://schemas.openxmlformats.org/drawingml/2006/main">
               <a:ext uri="{FF2B5EF4-FFF2-40B4-BE49-F238E27FC236}">
-                <a16:creationId xmlns:a16="http://schemas.microsoft.com/office/drawing/2014/main" id="{C4F2FB9F-66AE-487F-B577-FACD4AE8AC45}"/>
+                <a16:creationId xmlns:a16="http://schemas.microsoft.com/office/drawing/2014/main" id="{1EC9E6A8-BE0B-46D4-A339-55654A5D8D46}"/>
               </a:ext>
             </a:extLst>
           </p:cNvPr>
@@ -4633,7 +4633,7 @@
     </p:spTree>
     <p:extLst>
       <p:ext uri="{BB962C8B-B14F-4D97-AF65-F5344CB8AC3E}">
-        <p14:creationId xmlns:p14="http://schemas.microsoft.com/office/powerpoint/2010/main" val="1962218869"/>
+        <p14:creationId xmlns:p14="http://schemas.microsoft.com/office/powerpoint/2010/main" val="1052733021"/>
       </p:ext>
     </p:extLst>
   </p:cSld>
@@ -4657,7 +4657,7 @@
           <p:cNvPr id="1" name="">
             <a:extLst xmlns:a="http://schemas.openxmlformats.org/drawingml/2006/main">
               <a:ext uri="{FF2B5EF4-FFF2-40B4-BE49-F238E27FC236}">
-                <a16:creationId xmlns:a16="http://schemas.microsoft.com/office/drawing/2014/main" id="{30D41E84-E3FB-4344-AEDE-45F92EC616E1}"/>
+                <a16:creationId xmlns:a16="http://schemas.microsoft.com/office/drawing/2014/main" id="{3B2B0E2A-FF1A-440F-80CC-91F81BBA4852}"/>
               </a:ext>
             </a:extLst>
           </p:cNvPr>
@@ -4690,7 +4690,7 @@
           <p:cNvPr id="2" name="">
             <a:extLst xmlns:a="http://schemas.openxmlformats.org/drawingml/2006/main">
               <a:ext uri="{FF2B5EF4-FFF2-40B4-BE49-F238E27FC236}">
-                <a16:creationId xmlns:a16="http://schemas.microsoft.com/office/drawing/2014/main" id="{1D69BFB6-3716-446A-850F-E70B842C4F27}"/>
+                <a16:creationId xmlns:a16="http://schemas.microsoft.com/office/drawing/2014/main" id="{FA5C88EB-2535-42AE-8211-51025359FA2A}"/>
               </a:ext>
             </a:extLst>
           </p:cNvPr>
@@ -4723,7 +4723,7 @@
           <p:cNvPr id="3" name="">
             <a:extLst xmlns:a="http://schemas.openxmlformats.org/drawingml/2006/main">
               <a:ext uri="{FF2B5EF4-FFF2-40B4-BE49-F238E27FC236}">
-                <a16:creationId xmlns:a16="http://schemas.microsoft.com/office/drawing/2014/main" id="{0779B165-EEC3-451A-8FCF-6A6D63283A78}"/>
+                <a16:creationId xmlns:a16="http://schemas.microsoft.com/office/drawing/2014/main" id="{8AE03623-C202-4F79-8448-D5166FC8D9B8}"/>
               </a:ext>
             </a:extLst>
           </p:cNvPr>
@@ -4787,7 +4787,7 @@
           <p:cNvPr id="4" name="">
             <a:extLst xmlns:a="http://schemas.openxmlformats.org/drawingml/2006/main">
               <a:ext uri="{FF2B5EF4-FFF2-40B4-BE49-F238E27FC236}">
-                <a16:creationId xmlns:a16="http://schemas.microsoft.com/office/drawing/2014/main" id="{1140FDB4-199E-44C4-B2FD-46F493163C8D}"/>
+                <a16:creationId xmlns:a16="http://schemas.microsoft.com/office/drawing/2014/main" id="{D851B539-80A6-4399-B232-D27A80F173D2}"/>
               </a:ext>
             </a:extLst>
           </p:cNvPr>
@@ -4851,7 +4851,7 @@
           <p:cNvPr id="5" name="">
             <a:extLst xmlns:a="http://schemas.openxmlformats.org/drawingml/2006/main">
               <a:ext uri="{FF2B5EF4-FFF2-40B4-BE49-F238E27FC236}">
-                <a16:creationId xmlns:a16="http://schemas.microsoft.com/office/drawing/2014/main" id="{73724613-A078-47FF-9AB2-1491AEFAA4C2}"/>
+                <a16:creationId xmlns:a16="http://schemas.microsoft.com/office/drawing/2014/main" id="{035FAA39-1745-4CA2-BD93-FDE18C8CC81C}"/>
               </a:ext>
             </a:extLst>
           </p:cNvPr>
@@ -4884,7 +4884,7 @@
           <p:cNvPr id="6" name="">
             <a:extLst xmlns:a="http://schemas.openxmlformats.org/drawingml/2006/main">
               <a:ext uri="{FF2B5EF4-FFF2-40B4-BE49-F238E27FC236}">
-                <a16:creationId xmlns:a16="http://schemas.microsoft.com/office/drawing/2014/main" id="{43C667D1-4D5A-4FE2-A36B-2C9781D24A46}"/>
+                <a16:creationId xmlns:a16="http://schemas.microsoft.com/office/drawing/2014/main" id="{74AD6791-456C-45A7-963A-594EEE7D9ACE}"/>
               </a:ext>
             </a:extLst>
           </p:cNvPr>
@@ -4917,7 +4917,7 @@
           <p:cNvPr id="7" name="">
             <a:extLst xmlns:a="http://schemas.openxmlformats.org/drawingml/2006/main">
               <a:ext uri="{FF2B5EF4-FFF2-40B4-BE49-F238E27FC236}">
-                <a16:creationId xmlns:a16="http://schemas.microsoft.com/office/drawing/2014/main" id="{3AE1B85A-1C68-40A3-98C5-E529A90D8A2C}"/>
+                <a16:creationId xmlns:a16="http://schemas.microsoft.com/office/drawing/2014/main" id="{0E7CF9BD-6776-416C-ACE6-9B1DD827499C}"/>
               </a:ext>
             </a:extLst>
           </p:cNvPr>
@@ -4981,7 +4981,7 @@
           <p:cNvPr id="8" name="">
             <a:extLst xmlns:a="http://schemas.openxmlformats.org/drawingml/2006/main">
               <a:ext uri="{FF2B5EF4-FFF2-40B4-BE49-F238E27FC236}">
-                <a16:creationId xmlns:a16="http://schemas.microsoft.com/office/drawing/2014/main" id="{29D554D2-035B-4CE3-8715-A0B7D66BAC67}"/>
+                <a16:creationId xmlns:a16="http://schemas.microsoft.com/office/drawing/2014/main" id="{1D0AAB8C-BBDA-4B8E-B6F3-3533CE2B5CFC}"/>
               </a:ext>
             </a:extLst>
           </p:cNvPr>
@@ -5045,7 +5045,7 @@
           <p:cNvPr id="9" name="">
             <a:extLst xmlns:a="http://schemas.openxmlformats.org/drawingml/2006/main">
               <a:ext uri="{FF2B5EF4-FFF2-40B4-BE49-F238E27FC236}">
-                <a16:creationId xmlns:a16="http://schemas.microsoft.com/office/drawing/2014/main" id="{3AB21C40-931D-450B-9C11-6561D6F76DC8}"/>
+                <a16:creationId xmlns:a16="http://schemas.microsoft.com/office/drawing/2014/main" id="{54601E8A-1B1C-403F-AD00-F5BF24FC9906}"/>
               </a:ext>
             </a:extLst>
           </p:cNvPr>
@@ -5078,7 +5078,7 @@
           <p:cNvPr id="10" name="">
             <a:extLst xmlns:a="http://schemas.openxmlformats.org/drawingml/2006/main">
               <a:ext uri="{FF2B5EF4-FFF2-40B4-BE49-F238E27FC236}">
-                <a16:creationId xmlns:a16="http://schemas.microsoft.com/office/drawing/2014/main" id="{ED77449F-90AB-4962-94CA-72BE46652FD3}"/>
+                <a16:creationId xmlns:a16="http://schemas.microsoft.com/office/drawing/2014/main" id="{3438E0FD-7420-4CFA-A474-008AD6A42948}"/>
               </a:ext>
             </a:extLst>
           </p:cNvPr>
@@ -5142,7 +5142,7 @@
           <p:cNvPr id="11" name="">
             <a:extLst xmlns:a="http://schemas.openxmlformats.org/drawingml/2006/main">
               <a:ext uri="{FF2B5EF4-FFF2-40B4-BE49-F238E27FC236}">
-                <a16:creationId xmlns:a16="http://schemas.microsoft.com/office/drawing/2014/main" id="{0CE7B341-D2A3-47C4-85B8-0B3F0219932D}"/>
+                <a16:creationId xmlns:a16="http://schemas.microsoft.com/office/drawing/2014/main" id="{6450E46B-9574-4A91-B26C-27A4FC6EE916}"/>
               </a:ext>
             </a:extLst>
           </p:cNvPr>
@@ -5206,7 +5206,7 @@
           <p:cNvPr id="12" name="">
             <a:extLst xmlns:a="http://schemas.openxmlformats.org/drawingml/2006/main">
               <a:ext uri="{FF2B5EF4-FFF2-40B4-BE49-F238E27FC236}">
-                <a16:creationId xmlns:a16="http://schemas.microsoft.com/office/drawing/2014/main" id="{7D19D466-F0F5-4577-9C1D-59F715C7512B}"/>
+                <a16:creationId xmlns:a16="http://schemas.microsoft.com/office/drawing/2014/main" id="{2E63FEA5-8673-48E2-A82B-9DB980230C6C}"/>
               </a:ext>
             </a:extLst>
           </p:cNvPr>
@@ -5239,7 +5239,7 @@
           <p:cNvPr id="13" name="">
             <a:extLst xmlns:a="http://schemas.openxmlformats.org/drawingml/2006/main">
               <a:ext uri="{FF2B5EF4-FFF2-40B4-BE49-F238E27FC236}">
-                <a16:creationId xmlns:a16="http://schemas.microsoft.com/office/drawing/2014/main" id="{9BA840E9-C86D-4722-B378-CB5E53B4E9A6}"/>
+                <a16:creationId xmlns:a16="http://schemas.microsoft.com/office/drawing/2014/main" id="{AB27CE7A-D43B-41AE-82A7-F57AEA2D2151}"/>
               </a:ext>
             </a:extLst>
           </p:cNvPr>
@@ -5303,7 +5303,7 @@
           <p:cNvPr id="14" name="">
             <a:extLst xmlns:a="http://schemas.openxmlformats.org/drawingml/2006/main">
               <a:ext uri="{FF2B5EF4-FFF2-40B4-BE49-F238E27FC236}">
-                <a16:creationId xmlns:a16="http://schemas.microsoft.com/office/drawing/2014/main" id="{0352EC0F-C384-49F8-820D-BE11017728B9}"/>
+                <a16:creationId xmlns:a16="http://schemas.microsoft.com/office/drawing/2014/main" id="{C6A4EF51-2FAE-42B9-A5B0-3BF4C1498537}"/>
               </a:ext>
             </a:extLst>
           </p:cNvPr>
@@ -5367,7 +5367,7 @@
           <p:cNvPr id="15" name="">
             <a:extLst xmlns:a="http://schemas.openxmlformats.org/drawingml/2006/main">
               <a:ext uri="{FF2B5EF4-FFF2-40B4-BE49-F238E27FC236}">
-                <a16:creationId xmlns:a16="http://schemas.microsoft.com/office/drawing/2014/main" id="{E57B5028-300A-49D5-897E-7F381C5502EE}"/>
+                <a16:creationId xmlns:a16="http://schemas.microsoft.com/office/drawing/2014/main" id="{A0DB51AE-A092-4FFC-9F8C-94A343CFCE05}"/>
               </a:ext>
             </a:extLst>
           </p:cNvPr>
@@ -5400,7 +5400,7 @@
           <p:cNvPr id="16" name="">
             <a:extLst xmlns:a="http://schemas.openxmlformats.org/drawingml/2006/main">
               <a:ext uri="{FF2B5EF4-FFF2-40B4-BE49-F238E27FC236}">
-                <a16:creationId xmlns:a16="http://schemas.microsoft.com/office/drawing/2014/main" id="{5D3CB7EB-B840-4062-B9D7-8BDEE658D4F9}"/>
+                <a16:creationId xmlns:a16="http://schemas.microsoft.com/office/drawing/2014/main" id="{102BE50F-EC6A-46F5-BA60-80AF157463B5}"/>
               </a:ext>
             </a:extLst>
           </p:cNvPr>
@@ -5464,7 +5464,7 @@
           <p:cNvPr id="17" name="">
             <a:extLst xmlns:a="http://schemas.openxmlformats.org/drawingml/2006/main">
               <a:ext uri="{FF2B5EF4-FFF2-40B4-BE49-F238E27FC236}">
-                <a16:creationId xmlns:a16="http://schemas.microsoft.com/office/drawing/2014/main" id="{73F9C485-C96B-4F84-9330-077579A7DA05}"/>
+                <a16:creationId xmlns:a16="http://schemas.microsoft.com/office/drawing/2014/main" id="{447BCC1A-4480-4FA3-B979-D708B15CFDD8}"/>
               </a:ext>
             </a:extLst>
           </p:cNvPr>
@@ -5528,7 +5528,7 @@
           <p:cNvPr id="18" name="">
             <a:extLst xmlns:a="http://schemas.openxmlformats.org/drawingml/2006/main">
               <a:ext uri="{FF2B5EF4-FFF2-40B4-BE49-F238E27FC236}">
-                <a16:creationId xmlns:a16="http://schemas.microsoft.com/office/drawing/2014/main" id="{7D8F8937-D800-40E7-86FE-24DCEC6E7FF6}"/>
+                <a16:creationId xmlns:a16="http://schemas.microsoft.com/office/drawing/2014/main" id="{11D4FB57-2E12-4148-8F98-8A6C9ACCA61A}"/>
               </a:ext>
             </a:extLst>
           </p:cNvPr>
@@ -5592,7 +5592,7 @@
           <p:cNvPr id="19" name="">
             <a:extLst xmlns:a="http://schemas.openxmlformats.org/drawingml/2006/main">
               <a:ext uri="{FF2B5EF4-FFF2-40B4-BE49-F238E27FC236}">
-                <a16:creationId xmlns:a16="http://schemas.microsoft.com/office/drawing/2014/main" id="{4CB99097-2F6F-4EFE-B729-2C3417B7D28C}"/>
+                <a16:creationId xmlns:a16="http://schemas.microsoft.com/office/drawing/2014/main" id="{03568F43-A5B1-48E4-85D8-F3E1A6ED4D80}"/>
               </a:ext>
             </a:extLst>
           </p:cNvPr>
@@ -5625,7 +5625,7 @@
           <p:cNvPr id="20" name="">
             <a:extLst xmlns:a="http://schemas.openxmlformats.org/drawingml/2006/main">
               <a:ext uri="{FF2B5EF4-FFF2-40B4-BE49-F238E27FC236}">
-                <a16:creationId xmlns:a16="http://schemas.microsoft.com/office/drawing/2014/main" id="{77DAB6A8-0F8F-4A2B-A0EC-4361231F3C86}"/>
+                <a16:creationId xmlns:a16="http://schemas.microsoft.com/office/drawing/2014/main" id="{CFE704D5-431E-4459-BD5A-B0EEC8BC827C}"/>
               </a:ext>
             </a:extLst>
           </p:cNvPr>
@@ -5658,7 +5658,7 @@
           <p:cNvPr id="21" name="">
             <a:extLst xmlns:a="http://schemas.openxmlformats.org/drawingml/2006/main">
               <a:ext uri="{FF2B5EF4-FFF2-40B4-BE49-F238E27FC236}">
-                <a16:creationId xmlns:a16="http://schemas.microsoft.com/office/drawing/2014/main" id="{C3E3CD90-4B29-42FB-A9F0-13FC09473268}"/>
+                <a16:creationId xmlns:a16="http://schemas.microsoft.com/office/drawing/2014/main" id="{3555FDCE-07B6-469B-BB01-42D713201314}"/>
               </a:ext>
             </a:extLst>
           </p:cNvPr>
@@ -5722,7 +5722,7 @@
           <p:cNvPr id="22" name="">
             <a:extLst xmlns:a="http://schemas.openxmlformats.org/drawingml/2006/main">
               <a:ext uri="{FF2B5EF4-FFF2-40B4-BE49-F238E27FC236}">
-                <a16:creationId xmlns:a16="http://schemas.microsoft.com/office/drawing/2014/main" id="{B9D870E4-AF3C-4F7C-B4CD-7E73DCAEEA9E}"/>
+                <a16:creationId xmlns:a16="http://schemas.microsoft.com/office/drawing/2014/main" id="{3E0EFC89-803B-4050-A242-3876156A163F}"/>
               </a:ext>
             </a:extLst>
           </p:cNvPr>
@@ -5755,7 +5755,7 @@
           <p:cNvPr id="23" name="">
             <a:extLst xmlns:a="http://schemas.openxmlformats.org/drawingml/2006/main">
               <a:ext uri="{FF2B5EF4-FFF2-40B4-BE49-F238E27FC236}">
-                <a16:creationId xmlns:a16="http://schemas.microsoft.com/office/drawing/2014/main" id="{35EEA282-62C5-4FEF-A442-EFD569F0B46D}"/>
+                <a16:creationId xmlns:a16="http://schemas.microsoft.com/office/drawing/2014/main" id="{33ABDD15-33B6-4FFE-AA3A-10A76764A185}"/>
               </a:ext>
             </a:extLst>
           </p:cNvPr>
@@ -5788,7 +5788,7 @@
           <p:cNvPr id="24" name="">
             <a:extLst xmlns:a="http://schemas.openxmlformats.org/drawingml/2006/main">
               <a:ext uri="{FF2B5EF4-FFF2-40B4-BE49-F238E27FC236}">
-                <a16:creationId xmlns:a16="http://schemas.microsoft.com/office/drawing/2014/main" id="{CFF106B7-C20A-4493-879B-ED7F7E1379DB}"/>
+                <a16:creationId xmlns:a16="http://schemas.microsoft.com/office/drawing/2014/main" id="{4215B940-73DE-4A56-9B71-6B23014821CD}"/>
               </a:ext>
             </a:extLst>
           </p:cNvPr>
@@ -5852,7 +5852,7 @@
           <p:cNvPr id="25" name="">
             <a:extLst xmlns:a="http://schemas.openxmlformats.org/drawingml/2006/main">
               <a:ext uri="{FF2B5EF4-FFF2-40B4-BE49-F238E27FC236}">
-                <a16:creationId xmlns:a16="http://schemas.microsoft.com/office/drawing/2014/main" id="{99EBCFF1-41E4-45C7-9FDA-60AD71DAF100}"/>
+                <a16:creationId xmlns:a16="http://schemas.microsoft.com/office/drawing/2014/main" id="{19BCF974-FB7B-4B60-9A21-CD75CB78FFAA}"/>
               </a:ext>
             </a:extLst>
           </p:cNvPr>
@@ -5885,7 +5885,7 @@
           <p:cNvPr id="26" name="">
             <a:extLst xmlns:a="http://schemas.openxmlformats.org/drawingml/2006/main">
               <a:ext uri="{FF2B5EF4-FFF2-40B4-BE49-F238E27FC236}">
-                <a16:creationId xmlns:a16="http://schemas.microsoft.com/office/drawing/2014/main" id="{98AFAFF3-3EE0-46C8-926E-786433E75B0B}"/>
+                <a16:creationId xmlns:a16="http://schemas.microsoft.com/office/drawing/2014/main" id="{08E79FD4-75A3-4512-B8E8-B5474F2CF55F}"/>
               </a:ext>
             </a:extLst>
           </p:cNvPr>
@@ -5918,7 +5918,7 @@
           <p:cNvPr id="27" name="">
             <a:extLst xmlns:a="http://schemas.openxmlformats.org/drawingml/2006/main">
               <a:ext uri="{FF2B5EF4-FFF2-40B4-BE49-F238E27FC236}">
-                <a16:creationId xmlns:a16="http://schemas.microsoft.com/office/drawing/2014/main" id="{7040DD48-FF44-4644-982E-584EE2073241}"/>
+                <a16:creationId xmlns:a16="http://schemas.microsoft.com/office/drawing/2014/main" id="{EB20887E-86D3-4599-A106-47D4D9052466}"/>
               </a:ext>
             </a:extLst>
           </p:cNvPr>
@@ -5951,7 +5951,7 @@
           <p:cNvPr id="28" name="">
             <a:extLst xmlns:a="http://schemas.openxmlformats.org/drawingml/2006/main">
               <a:ext uri="{FF2B5EF4-FFF2-40B4-BE49-F238E27FC236}">
-                <a16:creationId xmlns:a16="http://schemas.microsoft.com/office/drawing/2014/main" id="{1D96FDC2-5924-4022-A573-48C9D9774855}"/>
+                <a16:creationId xmlns:a16="http://schemas.microsoft.com/office/drawing/2014/main" id="{A0522E0B-0140-4343-8CC3-A6CE70F1AB29}"/>
               </a:ext>
             </a:extLst>
           </p:cNvPr>
@@ -6015,7 +6015,7 @@
           <p:cNvPr id="29" name="">
             <a:extLst xmlns:a="http://schemas.openxmlformats.org/drawingml/2006/main">
               <a:ext uri="{FF2B5EF4-FFF2-40B4-BE49-F238E27FC236}">
-                <a16:creationId xmlns:a16="http://schemas.microsoft.com/office/drawing/2014/main" id="{8D32AACC-F532-4446-9971-9B91F6471036}"/>
+                <a16:creationId xmlns:a16="http://schemas.microsoft.com/office/drawing/2014/main" id="{8A01D84A-94B3-43C0-BBF4-B8925530D3D7}"/>
               </a:ext>
             </a:extLst>
           </p:cNvPr>
@@ -6048,7 +6048,7 @@
           <p:cNvPr id="30" name="">
             <a:extLst xmlns:a="http://schemas.openxmlformats.org/drawingml/2006/main">
               <a:ext uri="{FF2B5EF4-FFF2-40B4-BE49-F238E27FC236}">
-                <a16:creationId xmlns:a16="http://schemas.microsoft.com/office/drawing/2014/main" id="{34926D96-999D-40EF-81EC-B3F900704A28}"/>
+                <a16:creationId xmlns:a16="http://schemas.microsoft.com/office/drawing/2014/main" id="{27D265D9-10B5-4690-81E0-2D4863780D8C}"/>
               </a:ext>
             </a:extLst>
           </p:cNvPr>
@@ -6112,7 +6112,7 @@
           <p:cNvPr id="31" name="">
             <a:extLst xmlns:a="http://schemas.openxmlformats.org/drawingml/2006/main">
               <a:ext uri="{FF2B5EF4-FFF2-40B4-BE49-F238E27FC236}">
-                <a16:creationId xmlns:a16="http://schemas.microsoft.com/office/drawing/2014/main" id="{276FE41A-F0BF-42A8-A9C0-E69A0EBE5519}"/>
+                <a16:creationId xmlns:a16="http://schemas.microsoft.com/office/drawing/2014/main" id="{88BCE1B9-3F8E-4E03-8E2D-EE761DBD2854}"/>
               </a:ext>
             </a:extLst>
           </p:cNvPr>
@@ -6145,7 +6145,7 @@
           <p:cNvPr id="32" name="">
             <a:extLst xmlns:a="http://schemas.openxmlformats.org/drawingml/2006/main">
               <a:ext uri="{FF2B5EF4-FFF2-40B4-BE49-F238E27FC236}">
-                <a16:creationId xmlns:a16="http://schemas.microsoft.com/office/drawing/2014/main" id="{6C16F63A-131E-4D9B-BD7E-5041145AFBB1}"/>
+                <a16:creationId xmlns:a16="http://schemas.microsoft.com/office/drawing/2014/main" id="{51CA45C9-6249-49B3-B2B8-EC27D943979B}"/>
               </a:ext>
             </a:extLst>
           </p:cNvPr>
@@ -6209,7 +6209,7 @@
           <p:cNvPr id="33" name="">
             <a:extLst xmlns:a="http://schemas.openxmlformats.org/drawingml/2006/main">
               <a:ext uri="{FF2B5EF4-FFF2-40B4-BE49-F238E27FC236}">
-                <a16:creationId xmlns:a16="http://schemas.microsoft.com/office/drawing/2014/main" id="{B7D7470A-084F-4394-B9BF-8AA6765AD1F2}"/>
+                <a16:creationId xmlns:a16="http://schemas.microsoft.com/office/drawing/2014/main" id="{A7F398D0-F558-41F1-AFCC-1E6EB39B8BB5}"/>
               </a:ext>
             </a:extLst>
           </p:cNvPr>
@@ -6242,7 +6242,7 @@
           <p:cNvPr id="34" name="">
             <a:extLst xmlns:a="http://schemas.openxmlformats.org/drawingml/2006/main">
               <a:ext uri="{FF2B5EF4-FFF2-40B4-BE49-F238E27FC236}">
-                <a16:creationId xmlns:a16="http://schemas.microsoft.com/office/drawing/2014/main" id="{0E7DC25D-E270-4A1F-AA21-81B224B99915}"/>
+                <a16:creationId xmlns:a16="http://schemas.microsoft.com/office/drawing/2014/main" id="{5E55DE43-9AC3-44F6-894C-96A71F4E22E9}"/>
               </a:ext>
             </a:extLst>
           </p:cNvPr>
@@ -6306,7 +6306,7 @@
           <p:cNvPr id="35" name="">
             <a:extLst xmlns:a="http://schemas.openxmlformats.org/drawingml/2006/main">
               <a:ext uri="{FF2B5EF4-FFF2-40B4-BE49-F238E27FC236}">
-                <a16:creationId xmlns:a16="http://schemas.microsoft.com/office/drawing/2014/main" id="{68CDF0A6-124A-4161-8877-D880F7C2C2C5}"/>
+                <a16:creationId xmlns:a16="http://schemas.microsoft.com/office/drawing/2014/main" id="{CCD027FE-9ED7-4FA5-8885-B7553316F015}"/>
               </a:ext>
             </a:extLst>
           </p:cNvPr>
@@ -6339,7 +6339,7 @@
           <p:cNvPr id="36" name="">
             <a:extLst xmlns:a="http://schemas.openxmlformats.org/drawingml/2006/main">
               <a:ext uri="{FF2B5EF4-FFF2-40B4-BE49-F238E27FC236}">
-                <a16:creationId xmlns:a16="http://schemas.microsoft.com/office/drawing/2014/main" id="{906638E5-4377-4422-87E9-55BABAEF5BBB}"/>
+                <a16:creationId xmlns:a16="http://schemas.microsoft.com/office/drawing/2014/main" id="{3851E88C-A8AF-484E-93C9-5AA1449EFF53}"/>
               </a:ext>
             </a:extLst>
           </p:cNvPr>
@@ -6403,7 +6403,7 @@
           <p:cNvPr id="37" name="">
             <a:extLst xmlns:a="http://schemas.openxmlformats.org/drawingml/2006/main">
               <a:ext uri="{FF2B5EF4-FFF2-40B4-BE49-F238E27FC236}">
-                <a16:creationId xmlns:a16="http://schemas.microsoft.com/office/drawing/2014/main" id="{2108A7E7-834E-4334-B463-88CFC5F59331}"/>
+                <a16:creationId xmlns:a16="http://schemas.microsoft.com/office/drawing/2014/main" id="{A9EB4A2E-93F5-45C3-8373-3867129D119C}"/>
               </a:ext>
             </a:extLst>
           </p:cNvPr>
@@ -6467,7 +6467,7 @@
           <p:cNvPr id="38" name="">
             <a:extLst xmlns:a="http://schemas.openxmlformats.org/drawingml/2006/main">
               <a:ext uri="{FF2B5EF4-FFF2-40B4-BE49-F238E27FC236}">
-                <a16:creationId xmlns:a16="http://schemas.microsoft.com/office/drawing/2014/main" id="{3908ECF8-72EB-4F2F-A336-33196840BB7A}"/>
+                <a16:creationId xmlns:a16="http://schemas.microsoft.com/office/drawing/2014/main" id="{E7DF2454-623C-46D7-B0CF-6D42B9E75946}"/>
               </a:ext>
             </a:extLst>
           </p:cNvPr>
@@ -6529,7 +6529,7 @@
     </p:spTree>
     <p:extLst>
       <p:ext uri="{BB962C8B-B14F-4D97-AF65-F5344CB8AC3E}">
-        <p14:creationId xmlns:p14="http://schemas.microsoft.com/office/powerpoint/2010/main" val="978331381"/>
+        <p14:creationId xmlns:p14="http://schemas.microsoft.com/office/powerpoint/2010/main" val="754824146"/>
       </p:ext>
     </p:extLst>
   </p:cSld>
@@ -6553,7 +6553,7 @@
           <p:cNvPr id="1" name="">
             <a:extLst xmlns:a="http://schemas.openxmlformats.org/drawingml/2006/main">
               <a:ext uri="{FF2B5EF4-FFF2-40B4-BE49-F238E27FC236}">
-                <a16:creationId xmlns:a16="http://schemas.microsoft.com/office/drawing/2014/main" id="{38FDF30E-CB8E-4D8A-81FB-AB5C01A2E042}"/>
+                <a16:creationId xmlns:a16="http://schemas.microsoft.com/office/drawing/2014/main" id="{790FC6F1-A09E-4083-886E-9DD39ECE4225}"/>
               </a:ext>
             </a:extLst>
           </p:cNvPr>
@@ -6586,7 +6586,7 @@
           <p:cNvPr id="2" name="">
             <a:extLst xmlns:a="http://schemas.openxmlformats.org/drawingml/2006/main">
               <a:ext uri="{FF2B5EF4-FFF2-40B4-BE49-F238E27FC236}">
-                <a16:creationId xmlns:a16="http://schemas.microsoft.com/office/drawing/2014/main" id="{24893034-09DB-4C2F-965F-FF67FC58A14E}"/>
+                <a16:creationId xmlns:a16="http://schemas.microsoft.com/office/drawing/2014/main" id="{2D456F0A-1146-4618-B3FB-6742F25720FB}"/>
               </a:ext>
             </a:extLst>
           </p:cNvPr>
@@ -6619,7 +6619,7 @@
           <p:cNvPr id="3" name="">
             <a:extLst xmlns:a="http://schemas.openxmlformats.org/drawingml/2006/main">
               <a:ext uri="{FF2B5EF4-FFF2-40B4-BE49-F238E27FC236}">
-                <a16:creationId xmlns:a16="http://schemas.microsoft.com/office/drawing/2014/main" id="{0C8FF635-38B7-424F-BE53-3FA4684E6094}"/>
+                <a16:creationId xmlns:a16="http://schemas.microsoft.com/office/drawing/2014/main" id="{D4E0AA53-4782-4F61-8F6C-626862D8F380}"/>
               </a:ext>
             </a:extLst>
           </p:cNvPr>
@@ -6683,7 +6683,7 @@
           <p:cNvPr id="4" name="">
             <a:extLst xmlns:a="http://schemas.openxmlformats.org/drawingml/2006/main">
               <a:ext uri="{FF2B5EF4-FFF2-40B4-BE49-F238E27FC236}">
-                <a16:creationId xmlns:a16="http://schemas.microsoft.com/office/drawing/2014/main" id="{CAAA8D5E-526E-40BF-8FE0-6E2308ECFB63}"/>
+                <a16:creationId xmlns:a16="http://schemas.microsoft.com/office/drawing/2014/main" id="{341CC1FD-194E-4073-BDEA-1FD569D5D01E}"/>
               </a:ext>
             </a:extLst>
           </p:cNvPr>
@@ -6747,7 +6747,7 @@
           <p:cNvPr id="5" name="">
             <a:extLst xmlns:a="http://schemas.openxmlformats.org/drawingml/2006/main">
               <a:ext uri="{FF2B5EF4-FFF2-40B4-BE49-F238E27FC236}">
-                <a16:creationId xmlns:a16="http://schemas.microsoft.com/office/drawing/2014/main" id="{0116F5C2-B4F2-4C6E-A07B-BD17FB3C2D9D}"/>
+                <a16:creationId xmlns:a16="http://schemas.microsoft.com/office/drawing/2014/main" id="{519E745E-C080-46AD-AFAD-F39F7F77239C}"/>
               </a:ext>
             </a:extLst>
           </p:cNvPr>
@@ -6780,7 +6780,7 @@
           <p:cNvPr id="6" name="">
             <a:extLst xmlns:a="http://schemas.openxmlformats.org/drawingml/2006/main">
               <a:ext uri="{FF2B5EF4-FFF2-40B4-BE49-F238E27FC236}">
-                <a16:creationId xmlns:a16="http://schemas.microsoft.com/office/drawing/2014/main" id="{4BFFFF1C-6309-497B-AD9B-C91BDCAE04B4}"/>
+                <a16:creationId xmlns:a16="http://schemas.microsoft.com/office/drawing/2014/main" id="{6D5A5FCF-A55E-49D8-9B02-046F21051F8A}"/>
               </a:ext>
             </a:extLst>
           </p:cNvPr>
@@ -6813,7 +6813,7 @@
           <p:cNvPr id="7" name="">
             <a:extLst xmlns:a="http://schemas.openxmlformats.org/drawingml/2006/main">
               <a:ext uri="{FF2B5EF4-FFF2-40B4-BE49-F238E27FC236}">
-                <a16:creationId xmlns:a16="http://schemas.microsoft.com/office/drawing/2014/main" id="{068EF2ED-44FF-479D-80F8-4F2B1E076590}"/>
+                <a16:creationId xmlns:a16="http://schemas.microsoft.com/office/drawing/2014/main" id="{AC04F4B2-0775-417D-A4EF-EBE8465FA66A}"/>
               </a:ext>
             </a:extLst>
           </p:cNvPr>
@@ -6877,7 +6877,7 @@
           <p:cNvPr id="8" name="">
             <a:extLst xmlns:a="http://schemas.openxmlformats.org/drawingml/2006/main">
               <a:ext uri="{FF2B5EF4-FFF2-40B4-BE49-F238E27FC236}">
-                <a16:creationId xmlns:a16="http://schemas.microsoft.com/office/drawing/2014/main" id="{5D149A31-C3EB-498B-BE46-D7B4C1C47EA9}"/>
+                <a16:creationId xmlns:a16="http://schemas.microsoft.com/office/drawing/2014/main" id="{B4D34447-6DB4-4EA1-A289-5FD5A3CCD0C9}"/>
               </a:ext>
             </a:extLst>
           </p:cNvPr>
@@ -6910,7 +6910,7 @@
           <p:cNvPr id="9" name="">
             <a:extLst xmlns:a="http://schemas.openxmlformats.org/drawingml/2006/main">
               <a:ext uri="{FF2B5EF4-FFF2-40B4-BE49-F238E27FC236}">
-                <a16:creationId xmlns:a16="http://schemas.microsoft.com/office/drawing/2014/main" id="{1B47364E-72AF-463C-B700-D7FBC03B5925}"/>
+                <a16:creationId xmlns:a16="http://schemas.microsoft.com/office/drawing/2014/main" id="{2CA03716-55BC-447F-B5DA-67F94B32BE6C}"/>
               </a:ext>
             </a:extLst>
           </p:cNvPr>
@@ -6974,7 +6974,7 @@
           <p:cNvPr id="10" name="">
             <a:extLst xmlns:a="http://schemas.openxmlformats.org/drawingml/2006/main">
               <a:ext uri="{FF2B5EF4-FFF2-40B4-BE49-F238E27FC236}">
-                <a16:creationId xmlns:a16="http://schemas.microsoft.com/office/drawing/2014/main" id="{0363CA20-69AF-42E1-8EA9-F9358FB125ED}"/>
+                <a16:creationId xmlns:a16="http://schemas.microsoft.com/office/drawing/2014/main" id="{1F0CE0D0-60EA-44C4-A217-24F396CC3FC0}"/>
               </a:ext>
             </a:extLst>
           </p:cNvPr>
@@ -7007,7 +7007,7 @@
           <p:cNvPr id="11" name="">
             <a:extLst xmlns:a="http://schemas.openxmlformats.org/drawingml/2006/main">
               <a:ext uri="{FF2B5EF4-FFF2-40B4-BE49-F238E27FC236}">
-                <a16:creationId xmlns:a16="http://schemas.microsoft.com/office/drawing/2014/main" id="{4AAA6183-D9DF-4AF2-9603-90D49B6CCC19}"/>
+                <a16:creationId xmlns:a16="http://schemas.microsoft.com/office/drawing/2014/main" id="{11D5AC6B-435F-4415-B537-0C86701E4BE9}"/>
               </a:ext>
             </a:extLst>
           </p:cNvPr>
@@ -7071,7 +7071,7 @@
           <p:cNvPr id="12" name="">
             <a:extLst xmlns:a="http://schemas.openxmlformats.org/drawingml/2006/main">
               <a:ext uri="{FF2B5EF4-FFF2-40B4-BE49-F238E27FC236}">
-                <a16:creationId xmlns:a16="http://schemas.microsoft.com/office/drawing/2014/main" id="{7ECB4EB3-C4A1-4CD5-9933-FC6CA90E1A3E}"/>
+                <a16:creationId xmlns:a16="http://schemas.microsoft.com/office/drawing/2014/main" id="{5EF758A3-A4F3-48AF-982F-51422215DFDE}"/>
               </a:ext>
             </a:extLst>
           </p:cNvPr>
@@ -7104,7 +7104,7 @@
           <p:cNvPr id="13" name="">
             <a:extLst xmlns:a="http://schemas.openxmlformats.org/drawingml/2006/main">
               <a:ext uri="{FF2B5EF4-FFF2-40B4-BE49-F238E27FC236}">
-                <a16:creationId xmlns:a16="http://schemas.microsoft.com/office/drawing/2014/main" id="{8C107B92-691C-4097-9CD4-2A44F1CA48C6}"/>
+                <a16:creationId xmlns:a16="http://schemas.microsoft.com/office/drawing/2014/main" id="{D370BD0B-15EF-43C4-AE03-52CEA359B4BB}"/>
               </a:ext>
             </a:extLst>
           </p:cNvPr>
@@ -7168,7 +7168,7 @@
           <p:cNvPr id="14" name="">
             <a:extLst xmlns:a="http://schemas.openxmlformats.org/drawingml/2006/main">
               <a:ext uri="{FF2B5EF4-FFF2-40B4-BE49-F238E27FC236}">
-                <a16:creationId xmlns:a16="http://schemas.microsoft.com/office/drawing/2014/main" id="{2DDE08B6-2337-482B-B53F-CA0D5DAA852E}"/>
+                <a16:creationId xmlns:a16="http://schemas.microsoft.com/office/drawing/2014/main" id="{5B8CCEAE-23F5-4531-89B9-F4AA3CBCEA1F}"/>
               </a:ext>
             </a:extLst>
           </p:cNvPr>
@@ -7201,7 +7201,7 @@
           <p:cNvPr id="15" name="">
             <a:extLst xmlns:a="http://schemas.openxmlformats.org/drawingml/2006/main">
               <a:ext uri="{FF2B5EF4-FFF2-40B4-BE49-F238E27FC236}">
-                <a16:creationId xmlns:a16="http://schemas.microsoft.com/office/drawing/2014/main" id="{31FBEB18-13F5-4D7A-B32E-B2ADE8C48A83}"/>
+                <a16:creationId xmlns:a16="http://schemas.microsoft.com/office/drawing/2014/main" id="{87C028EA-08F1-4E9B-B156-0C68A5ED9DF4}"/>
               </a:ext>
             </a:extLst>
           </p:cNvPr>
@@ -7265,7 +7265,7 @@
           <p:cNvPr id="16" name="">
             <a:extLst xmlns:a="http://schemas.openxmlformats.org/drawingml/2006/main">
               <a:ext uri="{FF2B5EF4-FFF2-40B4-BE49-F238E27FC236}">
-                <a16:creationId xmlns:a16="http://schemas.microsoft.com/office/drawing/2014/main" id="{85928106-3177-4C28-88C9-95CB3BB60BA7}"/>
+                <a16:creationId xmlns:a16="http://schemas.microsoft.com/office/drawing/2014/main" id="{FBDB9E57-6170-4084-AA8D-5AAAA92B898D}"/>
               </a:ext>
             </a:extLst>
           </p:cNvPr>
@@ -7298,7 +7298,7 @@
           <p:cNvPr id="17" name="">
             <a:extLst xmlns:a="http://schemas.openxmlformats.org/drawingml/2006/main">
               <a:ext uri="{FF2B5EF4-FFF2-40B4-BE49-F238E27FC236}">
-                <a16:creationId xmlns:a16="http://schemas.microsoft.com/office/drawing/2014/main" id="{D9A05751-5AB7-4A88-BE79-A0C06F035E92}"/>
+                <a16:creationId xmlns:a16="http://schemas.microsoft.com/office/drawing/2014/main" id="{FD8A8051-86FE-43DF-94C1-2F76E868E6A7}"/>
               </a:ext>
             </a:extLst>
           </p:cNvPr>
@@ -7362,7 +7362,7 @@
           <p:cNvPr id="18" name="">
             <a:extLst xmlns:a="http://schemas.openxmlformats.org/drawingml/2006/main">
               <a:ext uri="{FF2B5EF4-FFF2-40B4-BE49-F238E27FC236}">
-                <a16:creationId xmlns:a16="http://schemas.microsoft.com/office/drawing/2014/main" id="{53470D1E-0E60-4831-AE85-4356895F8BFC}"/>
+                <a16:creationId xmlns:a16="http://schemas.microsoft.com/office/drawing/2014/main" id="{F53443E3-B9E9-4135-BF37-A062826930E9}"/>
               </a:ext>
             </a:extLst>
           </p:cNvPr>
@@ -7395,7 +7395,7 @@
           <p:cNvPr id="19" name="">
             <a:extLst xmlns:a="http://schemas.openxmlformats.org/drawingml/2006/main">
               <a:ext uri="{FF2B5EF4-FFF2-40B4-BE49-F238E27FC236}">
-                <a16:creationId xmlns:a16="http://schemas.microsoft.com/office/drawing/2014/main" id="{51F97E80-A7ED-452B-9B76-DF98C6C364D8}"/>
+                <a16:creationId xmlns:a16="http://schemas.microsoft.com/office/drawing/2014/main" id="{D75E2A02-DE2E-40A7-B4D7-7AF507F8E503}"/>
               </a:ext>
             </a:extLst>
           </p:cNvPr>
@@ -7459,7 +7459,7 @@
           <p:cNvPr id="20" name="">
             <a:extLst xmlns:a="http://schemas.openxmlformats.org/drawingml/2006/main">
               <a:ext uri="{FF2B5EF4-FFF2-40B4-BE49-F238E27FC236}">
-                <a16:creationId xmlns:a16="http://schemas.microsoft.com/office/drawing/2014/main" id="{44C8E1AC-47A1-4045-B542-5856199B49B5}"/>
+                <a16:creationId xmlns:a16="http://schemas.microsoft.com/office/drawing/2014/main" id="{04005EA7-8FD4-4581-BCB8-8788AFB75285}"/>
               </a:ext>
             </a:extLst>
           </p:cNvPr>
@@ -7492,7 +7492,7 @@
           <p:cNvPr id="21" name="">
             <a:extLst xmlns:a="http://schemas.openxmlformats.org/drawingml/2006/main">
               <a:ext uri="{FF2B5EF4-FFF2-40B4-BE49-F238E27FC236}">
-                <a16:creationId xmlns:a16="http://schemas.microsoft.com/office/drawing/2014/main" id="{AF26E5C2-113D-4F69-87CD-5BFE44DB325C}"/>
+                <a16:creationId xmlns:a16="http://schemas.microsoft.com/office/drawing/2014/main" id="{8E7B6EB0-7942-4011-BCDB-255CF640CE77}"/>
               </a:ext>
             </a:extLst>
           </p:cNvPr>
@@ -7556,7 +7556,7 @@
           <p:cNvPr id="22" name="">
             <a:extLst xmlns:a="http://schemas.openxmlformats.org/drawingml/2006/main">
               <a:ext uri="{FF2B5EF4-FFF2-40B4-BE49-F238E27FC236}">
-                <a16:creationId xmlns:a16="http://schemas.microsoft.com/office/drawing/2014/main" id="{3BED5440-D013-4442-96AC-0E615095008F}"/>
+                <a16:creationId xmlns:a16="http://schemas.microsoft.com/office/drawing/2014/main" id="{27C2E790-881F-43A1-A99C-985D4A30203F}"/>
               </a:ext>
             </a:extLst>
           </p:cNvPr>
@@ -7589,7 +7589,7 @@
           <p:cNvPr id="23" name="">
             <a:extLst xmlns:a="http://schemas.openxmlformats.org/drawingml/2006/main">
               <a:ext uri="{FF2B5EF4-FFF2-40B4-BE49-F238E27FC236}">
-                <a16:creationId xmlns:a16="http://schemas.microsoft.com/office/drawing/2014/main" id="{8D12C8C3-6B85-4465-9B00-5AF0FC0490FC}"/>
+                <a16:creationId xmlns:a16="http://schemas.microsoft.com/office/drawing/2014/main" id="{9A7E1E58-9FB8-4246-B628-18151E35EADA}"/>
               </a:ext>
             </a:extLst>
           </p:cNvPr>
@@ -7653,7 +7653,7 @@
           <p:cNvPr id="24" name="">
             <a:extLst xmlns:a="http://schemas.openxmlformats.org/drawingml/2006/main">
               <a:ext uri="{FF2B5EF4-FFF2-40B4-BE49-F238E27FC236}">
-                <a16:creationId xmlns:a16="http://schemas.microsoft.com/office/drawing/2014/main" id="{A79D3158-0988-47FE-8B73-03FB55432757}"/>
+                <a16:creationId xmlns:a16="http://schemas.microsoft.com/office/drawing/2014/main" id="{27EFA941-DA31-4AD2-9A0E-BB809EB6963E}"/>
               </a:ext>
             </a:extLst>
           </p:cNvPr>
@@ -7686,7 +7686,7 @@
           <p:cNvPr id="25" name="">
             <a:extLst xmlns:a="http://schemas.openxmlformats.org/drawingml/2006/main">
               <a:ext uri="{FF2B5EF4-FFF2-40B4-BE49-F238E27FC236}">
-                <a16:creationId xmlns:a16="http://schemas.microsoft.com/office/drawing/2014/main" id="{EDA022F9-BE34-4B0C-BFCE-42AF0514AE01}"/>
+                <a16:creationId xmlns:a16="http://schemas.microsoft.com/office/drawing/2014/main" id="{9B51AA42-932D-43E6-AA1F-749897882282}"/>
               </a:ext>
             </a:extLst>
           </p:cNvPr>
@@ -7750,7 +7750,7 @@
           <p:cNvPr id="26" name="">
             <a:extLst xmlns:a="http://schemas.openxmlformats.org/drawingml/2006/main">
               <a:ext uri="{FF2B5EF4-FFF2-40B4-BE49-F238E27FC236}">
-                <a16:creationId xmlns:a16="http://schemas.microsoft.com/office/drawing/2014/main" id="{D5E10844-A222-495C-AD6F-F9B1B9799C15}"/>
+                <a16:creationId xmlns:a16="http://schemas.microsoft.com/office/drawing/2014/main" id="{B86B7F4B-31A6-4531-8B81-F8D4228C4DE1}"/>
               </a:ext>
             </a:extLst>
           </p:cNvPr>
@@ -7783,7 +7783,7 @@
           <p:cNvPr id="27" name="">
             <a:extLst xmlns:a="http://schemas.openxmlformats.org/drawingml/2006/main">
               <a:ext uri="{FF2B5EF4-FFF2-40B4-BE49-F238E27FC236}">
-                <a16:creationId xmlns:a16="http://schemas.microsoft.com/office/drawing/2014/main" id="{E9B48F7A-2394-445B-8DF2-8416E701E72B}"/>
+                <a16:creationId xmlns:a16="http://schemas.microsoft.com/office/drawing/2014/main" id="{C1180205-65DF-4239-BFA3-744A9479A1C6}"/>
               </a:ext>
             </a:extLst>
           </p:cNvPr>
@@ -7847,7 +7847,7 @@
           <p:cNvPr id="28" name="">
             <a:extLst xmlns:a="http://schemas.openxmlformats.org/drawingml/2006/main">
               <a:ext uri="{FF2B5EF4-FFF2-40B4-BE49-F238E27FC236}">
-                <a16:creationId xmlns:a16="http://schemas.microsoft.com/office/drawing/2014/main" id="{876FC809-2552-4161-9A88-78E326CA6DB6}"/>
+                <a16:creationId xmlns:a16="http://schemas.microsoft.com/office/drawing/2014/main" id="{192B459D-FDF9-47A1-9569-DC2963803210}"/>
               </a:ext>
             </a:extLst>
           </p:cNvPr>
@@ -7880,7 +7880,7 @@
           <p:cNvPr id="29" name="">
             <a:extLst xmlns:a="http://schemas.openxmlformats.org/drawingml/2006/main">
               <a:ext uri="{FF2B5EF4-FFF2-40B4-BE49-F238E27FC236}">
-                <a16:creationId xmlns:a16="http://schemas.microsoft.com/office/drawing/2014/main" id="{B3592F27-01B8-413D-BF61-06F9B90FB208}"/>
+                <a16:creationId xmlns:a16="http://schemas.microsoft.com/office/drawing/2014/main" id="{85AEC1B4-065A-4749-9DBC-EFA76A114A19}"/>
               </a:ext>
             </a:extLst>
           </p:cNvPr>
@@ -7944,7 +7944,7 @@
           <p:cNvPr id="30" name="">
             <a:extLst xmlns:a="http://schemas.openxmlformats.org/drawingml/2006/main">
               <a:ext uri="{FF2B5EF4-FFF2-40B4-BE49-F238E27FC236}">
-                <a16:creationId xmlns:a16="http://schemas.microsoft.com/office/drawing/2014/main" id="{5D9B55B6-B494-430D-870B-D5191BBFD994}"/>
+                <a16:creationId xmlns:a16="http://schemas.microsoft.com/office/drawing/2014/main" id="{CAFC77C2-F294-4C9A-8ED3-04833E0E041C}"/>
               </a:ext>
             </a:extLst>
           </p:cNvPr>
@@ -7977,7 +7977,7 @@
           <p:cNvPr id="31" name="">
             <a:extLst xmlns:a="http://schemas.openxmlformats.org/drawingml/2006/main">
               <a:ext uri="{FF2B5EF4-FFF2-40B4-BE49-F238E27FC236}">
-                <a16:creationId xmlns:a16="http://schemas.microsoft.com/office/drawing/2014/main" id="{10F09E3D-288D-464F-A6C5-510DC3F610BE}"/>
+                <a16:creationId xmlns:a16="http://schemas.microsoft.com/office/drawing/2014/main" id="{22A221BC-DA58-45FE-AD21-933FFDA67EE7}"/>
               </a:ext>
             </a:extLst>
           </p:cNvPr>
@@ -8041,7 +8041,7 @@
           <p:cNvPr id="32" name="">
             <a:extLst xmlns:a="http://schemas.openxmlformats.org/drawingml/2006/main">
               <a:ext uri="{FF2B5EF4-FFF2-40B4-BE49-F238E27FC236}">
-                <a16:creationId xmlns:a16="http://schemas.microsoft.com/office/drawing/2014/main" id="{ED4F33B5-195B-48AD-A37E-619FEE5AEB4C}"/>
+                <a16:creationId xmlns:a16="http://schemas.microsoft.com/office/drawing/2014/main" id="{6FB86340-CA81-474D-8FBB-61C396EEDE77}"/>
               </a:ext>
             </a:extLst>
           </p:cNvPr>
@@ -8074,7 +8074,7 @@
           <p:cNvPr id="33" name="">
             <a:extLst xmlns:a="http://schemas.openxmlformats.org/drawingml/2006/main">
               <a:ext uri="{FF2B5EF4-FFF2-40B4-BE49-F238E27FC236}">
-                <a16:creationId xmlns:a16="http://schemas.microsoft.com/office/drawing/2014/main" id="{C10D562E-25CC-47B3-9A19-991283EC4D06}"/>
+                <a16:creationId xmlns:a16="http://schemas.microsoft.com/office/drawing/2014/main" id="{8E77FA83-F8D2-4F93-9B02-521534392472}"/>
               </a:ext>
             </a:extLst>
           </p:cNvPr>
@@ -8138,7 +8138,7 @@
           <p:cNvPr id="34" name="">
             <a:extLst xmlns:a="http://schemas.openxmlformats.org/drawingml/2006/main">
               <a:ext uri="{FF2B5EF4-FFF2-40B4-BE49-F238E27FC236}">
-                <a16:creationId xmlns:a16="http://schemas.microsoft.com/office/drawing/2014/main" id="{00ACB91D-ABDE-4465-9E6C-C381B68A52B1}"/>
+                <a16:creationId xmlns:a16="http://schemas.microsoft.com/office/drawing/2014/main" id="{DCA9449F-9C20-4946-B911-896F08A95C35}"/>
               </a:ext>
             </a:extLst>
           </p:cNvPr>
@@ -8171,7 +8171,7 @@
           <p:cNvPr id="35" name="">
             <a:extLst xmlns:a="http://schemas.openxmlformats.org/drawingml/2006/main">
               <a:ext uri="{FF2B5EF4-FFF2-40B4-BE49-F238E27FC236}">
-                <a16:creationId xmlns:a16="http://schemas.microsoft.com/office/drawing/2014/main" id="{6FB617E1-401F-47AF-8DE0-FC76C14E9301}"/>
+                <a16:creationId xmlns:a16="http://schemas.microsoft.com/office/drawing/2014/main" id="{B55D8A32-B661-4FAA-BB59-7749817B8FE7}"/>
               </a:ext>
             </a:extLst>
           </p:cNvPr>
@@ -8235,7 +8235,7 @@
           <p:cNvPr id="36" name="">
             <a:extLst xmlns:a="http://schemas.openxmlformats.org/drawingml/2006/main">
               <a:ext uri="{FF2B5EF4-FFF2-40B4-BE49-F238E27FC236}">
-                <a16:creationId xmlns:a16="http://schemas.microsoft.com/office/drawing/2014/main" id="{7DD040CD-A55F-4141-867B-027505A2A274}"/>
+                <a16:creationId xmlns:a16="http://schemas.microsoft.com/office/drawing/2014/main" id="{F28D54F1-2F9A-48AE-9964-0529CE1ECDB7}"/>
               </a:ext>
             </a:extLst>
           </p:cNvPr>
@@ -8268,7 +8268,7 @@
           <p:cNvPr id="37" name="">
             <a:extLst xmlns:a="http://schemas.openxmlformats.org/drawingml/2006/main">
               <a:ext uri="{FF2B5EF4-FFF2-40B4-BE49-F238E27FC236}">
-                <a16:creationId xmlns:a16="http://schemas.microsoft.com/office/drawing/2014/main" id="{053ADA4D-B90A-4C95-8632-F1E20162E008}"/>
+                <a16:creationId xmlns:a16="http://schemas.microsoft.com/office/drawing/2014/main" id="{AD776B36-0DBF-4545-86FA-9FBA349DF22B}"/>
               </a:ext>
             </a:extLst>
           </p:cNvPr>
@@ -8332,7 +8332,7 @@
           <p:cNvPr id="38" name="">
             <a:extLst xmlns:a="http://schemas.openxmlformats.org/drawingml/2006/main">
               <a:ext uri="{FF2B5EF4-FFF2-40B4-BE49-F238E27FC236}">
-                <a16:creationId xmlns:a16="http://schemas.microsoft.com/office/drawing/2014/main" id="{C01A2F74-DD24-411F-9905-A406CCF69830}"/>
+                <a16:creationId xmlns:a16="http://schemas.microsoft.com/office/drawing/2014/main" id="{25347B2C-46B7-46C1-ABCF-10490EB75B8F}"/>
               </a:ext>
             </a:extLst>
           </p:cNvPr>
@@ -8365,7 +8365,7 @@
           <p:cNvPr id="39" name="">
             <a:extLst xmlns:a="http://schemas.openxmlformats.org/drawingml/2006/main">
               <a:ext uri="{FF2B5EF4-FFF2-40B4-BE49-F238E27FC236}">
-                <a16:creationId xmlns:a16="http://schemas.microsoft.com/office/drawing/2014/main" id="{AFE9269A-3CF6-4AFC-98F8-B9FBF846227E}"/>
+                <a16:creationId xmlns:a16="http://schemas.microsoft.com/office/drawing/2014/main" id="{39DD8CBA-C623-49CD-9542-20018CFFA3A5}"/>
               </a:ext>
             </a:extLst>
           </p:cNvPr>
@@ -8429,7 +8429,7 @@
           <p:cNvPr id="40" name="">
             <a:extLst xmlns:a="http://schemas.openxmlformats.org/drawingml/2006/main">
               <a:ext uri="{FF2B5EF4-FFF2-40B4-BE49-F238E27FC236}">
-                <a16:creationId xmlns:a16="http://schemas.microsoft.com/office/drawing/2014/main" id="{BADB8278-2049-4A46-85A7-56737E4D86B8}"/>
+                <a16:creationId xmlns:a16="http://schemas.microsoft.com/office/drawing/2014/main" id="{D4585788-4F1A-4E1F-AEC3-82F5308B0DFC}"/>
               </a:ext>
             </a:extLst>
           </p:cNvPr>
@@ -8462,7 +8462,7 @@
           <p:cNvPr id="41" name="">
             <a:extLst xmlns:a="http://schemas.openxmlformats.org/drawingml/2006/main">
               <a:ext uri="{FF2B5EF4-FFF2-40B4-BE49-F238E27FC236}">
-                <a16:creationId xmlns:a16="http://schemas.microsoft.com/office/drawing/2014/main" id="{6A824577-7E9E-4343-8C95-8BFE11E8B83B}"/>
+                <a16:creationId xmlns:a16="http://schemas.microsoft.com/office/drawing/2014/main" id="{13C05937-5660-4377-88D4-5DE7CE831802}"/>
               </a:ext>
             </a:extLst>
           </p:cNvPr>
@@ -8526,7 +8526,7 @@
           <p:cNvPr id="42" name="">
             <a:extLst xmlns:a="http://schemas.openxmlformats.org/drawingml/2006/main">
               <a:ext uri="{FF2B5EF4-FFF2-40B4-BE49-F238E27FC236}">
-                <a16:creationId xmlns:a16="http://schemas.microsoft.com/office/drawing/2014/main" id="{D91BE27D-83E5-4B45-8D72-26C5D2230073}"/>
+                <a16:creationId xmlns:a16="http://schemas.microsoft.com/office/drawing/2014/main" id="{3AE13418-C4C0-4583-8A81-D8B01013933C}"/>
               </a:ext>
             </a:extLst>
           </p:cNvPr>
@@ -8559,7 +8559,7 @@
           <p:cNvPr id="43" name="">
             <a:extLst xmlns:a="http://schemas.openxmlformats.org/drawingml/2006/main">
               <a:ext uri="{FF2B5EF4-FFF2-40B4-BE49-F238E27FC236}">
-                <a16:creationId xmlns:a16="http://schemas.microsoft.com/office/drawing/2014/main" id="{34583E81-5185-4688-83AC-0CB5BF602D67}"/>
+                <a16:creationId xmlns:a16="http://schemas.microsoft.com/office/drawing/2014/main" id="{FA8E69CA-6A58-4FAA-B894-969DEE1D0D12}"/>
               </a:ext>
             </a:extLst>
           </p:cNvPr>
@@ -8623,7 +8623,7 @@
           <p:cNvPr id="44" name="">
             <a:extLst xmlns:a="http://schemas.openxmlformats.org/drawingml/2006/main">
               <a:ext uri="{FF2B5EF4-FFF2-40B4-BE49-F238E27FC236}">
-                <a16:creationId xmlns:a16="http://schemas.microsoft.com/office/drawing/2014/main" id="{93533DF7-CE04-490C-ACD4-93988549240B}"/>
+                <a16:creationId xmlns:a16="http://schemas.microsoft.com/office/drawing/2014/main" id="{43A2D27E-06FB-4660-B26B-4E7FA4AB203F}"/>
               </a:ext>
             </a:extLst>
           </p:cNvPr>
@@ -8656,7 +8656,7 @@
           <p:cNvPr id="45" name="">
             <a:extLst xmlns:a="http://schemas.openxmlformats.org/drawingml/2006/main">
               <a:ext uri="{FF2B5EF4-FFF2-40B4-BE49-F238E27FC236}">
-                <a16:creationId xmlns:a16="http://schemas.microsoft.com/office/drawing/2014/main" id="{368358AD-2911-4B46-83F3-2A3104C9B49F}"/>
+                <a16:creationId xmlns:a16="http://schemas.microsoft.com/office/drawing/2014/main" id="{D70423BE-B12F-4FF6-88F5-25391A17F566}"/>
               </a:ext>
             </a:extLst>
           </p:cNvPr>
@@ -8720,7 +8720,7 @@
           <p:cNvPr id="46" name="">
             <a:extLst xmlns:a="http://schemas.openxmlformats.org/drawingml/2006/main">
               <a:ext uri="{FF2B5EF4-FFF2-40B4-BE49-F238E27FC236}">
-                <a16:creationId xmlns:a16="http://schemas.microsoft.com/office/drawing/2014/main" id="{BA63619B-6C64-4F53-BEFE-3B20993BD802}"/>
+                <a16:creationId xmlns:a16="http://schemas.microsoft.com/office/drawing/2014/main" id="{330C1326-ED22-48B5-9EF2-BA7F525E6158}"/>
               </a:ext>
             </a:extLst>
           </p:cNvPr>
@@ -8753,7 +8753,7 @@
           <p:cNvPr id="47" name="">
             <a:extLst xmlns:a="http://schemas.openxmlformats.org/drawingml/2006/main">
               <a:ext uri="{FF2B5EF4-FFF2-40B4-BE49-F238E27FC236}">
-                <a16:creationId xmlns:a16="http://schemas.microsoft.com/office/drawing/2014/main" id="{90971CBB-120B-47F6-B1B3-5BAE21FD2798}"/>
+                <a16:creationId xmlns:a16="http://schemas.microsoft.com/office/drawing/2014/main" id="{938F7E16-69DB-4EE2-9CE3-F089BCDF10D3}"/>
               </a:ext>
             </a:extLst>
           </p:cNvPr>
@@ -8817,7 +8817,7 @@
           <p:cNvPr id="48" name="">
             <a:extLst xmlns:a="http://schemas.openxmlformats.org/drawingml/2006/main">
               <a:ext uri="{FF2B5EF4-FFF2-40B4-BE49-F238E27FC236}">
-                <a16:creationId xmlns:a16="http://schemas.microsoft.com/office/drawing/2014/main" id="{5B49FED2-2E46-4B56-BD16-AF6E1519DE16}"/>
+                <a16:creationId xmlns:a16="http://schemas.microsoft.com/office/drawing/2014/main" id="{44D4C749-661F-41CD-A490-87164619F627}"/>
               </a:ext>
             </a:extLst>
           </p:cNvPr>
@@ -8881,7 +8881,7 @@
           <p:cNvPr id="49" name="">
             <a:extLst xmlns:a="http://schemas.openxmlformats.org/drawingml/2006/main">
               <a:ext uri="{FF2B5EF4-FFF2-40B4-BE49-F238E27FC236}">
-                <a16:creationId xmlns:a16="http://schemas.microsoft.com/office/drawing/2014/main" id="{77DCD44B-FD5C-4A5B-BCBC-4B1B78FC4F73}"/>
+                <a16:creationId xmlns:a16="http://schemas.microsoft.com/office/drawing/2014/main" id="{39045B8C-8F2A-444C-8A64-D82084F5A121}"/>
               </a:ext>
             </a:extLst>
           </p:cNvPr>
@@ -8943,7 +8943,7 @@
     </p:spTree>
     <p:extLst>
       <p:ext uri="{BB962C8B-B14F-4D97-AF65-F5344CB8AC3E}">
-        <p14:creationId xmlns:p14="http://schemas.microsoft.com/office/powerpoint/2010/main" val="1276119812"/>
+        <p14:creationId xmlns:p14="http://schemas.microsoft.com/office/powerpoint/2010/main" val="1975940558"/>
       </p:ext>
     </p:extLst>
   </p:cSld>
@@ -8967,7 +8967,7 @@
           <p:cNvPr id="1" name="">
             <a:extLst xmlns:a="http://schemas.openxmlformats.org/drawingml/2006/main">
               <a:ext uri="{FF2B5EF4-FFF2-40B4-BE49-F238E27FC236}">
-                <a16:creationId xmlns:a16="http://schemas.microsoft.com/office/drawing/2014/main" id="{62F56A14-EF66-4E64-A0E5-4D82372ECFBE}"/>
+                <a16:creationId xmlns:a16="http://schemas.microsoft.com/office/drawing/2014/main" id="{D2A4009E-2F46-4737-95BB-780AD64AC3F7}"/>
               </a:ext>
             </a:extLst>
           </p:cNvPr>
@@ -9000,7 +9000,7 @@
           <p:cNvPr id="2" name="">
             <a:extLst xmlns:a="http://schemas.openxmlformats.org/drawingml/2006/main">
               <a:ext uri="{FF2B5EF4-FFF2-40B4-BE49-F238E27FC236}">
-                <a16:creationId xmlns:a16="http://schemas.microsoft.com/office/drawing/2014/main" id="{E252B595-CB76-4B99-84BE-B7149B7B7117}"/>
+                <a16:creationId xmlns:a16="http://schemas.microsoft.com/office/drawing/2014/main" id="{2FEFD4D3-ABAA-4B74-AA8F-F3469D24AC57}"/>
               </a:ext>
             </a:extLst>
           </p:cNvPr>
@@ -9033,7 +9033,7 @@
           <p:cNvPr id="3" name="">
             <a:extLst xmlns:a="http://schemas.openxmlformats.org/drawingml/2006/main">
               <a:ext uri="{FF2B5EF4-FFF2-40B4-BE49-F238E27FC236}">
-                <a16:creationId xmlns:a16="http://schemas.microsoft.com/office/drawing/2014/main" id="{A3966BEF-7C43-4AB0-8872-143CF433A568}"/>
+                <a16:creationId xmlns:a16="http://schemas.microsoft.com/office/drawing/2014/main" id="{FCC21329-D40C-4818-8D86-E5EF860E179D}"/>
               </a:ext>
             </a:extLst>
           </p:cNvPr>
@@ -9097,7 +9097,7 @@
           <p:cNvPr id="4" name="">
             <a:extLst xmlns:a="http://schemas.openxmlformats.org/drawingml/2006/main">
               <a:ext uri="{FF2B5EF4-FFF2-40B4-BE49-F238E27FC236}">
-                <a16:creationId xmlns:a16="http://schemas.microsoft.com/office/drawing/2014/main" id="{7B0C0A16-F24C-470E-80FE-99C958D30FB9}"/>
+                <a16:creationId xmlns:a16="http://schemas.microsoft.com/office/drawing/2014/main" id="{48DFFAE5-5216-48BA-9583-34B5507FE203}"/>
               </a:ext>
             </a:extLst>
           </p:cNvPr>
@@ -9161,7 +9161,7 @@
           <p:cNvPr id="5" name="">
             <a:extLst xmlns:a="http://schemas.openxmlformats.org/drawingml/2006/main">
               <a:ext uri="{FF2B5EF4-FFF2-40B4-BE49-F238E27FC236}">
-                <a16:creationId xmlns:a16="http://schemas.microsoft.com/office/drawing/2014/main" id="{32364304-5673-4363-9C81-FFA4F2268731}"/>
+                <a16:creationId xmlns:a16="http://schemas.microsoft.com/office/drawing/2014/main" id="{040AF7CA-5CC1-48CD-8947-58B1E3C2C297}"/>
               </a:ext>
             </a:extLst>
           </p:cNvPr>
@@ -9194,7 +9194,7 @@
           <p:cNvPr id="6" name="">
             <a:extLst xmlns:a="http://schemas.openxmlformats.org/drawingml/2006/main">
               <a:ext uri="{FF2B5EF4-FFF2-40B4-BE49-F238E27FC236}">
-                <a16:creationId xmlns:a16="http://schemas.microsoft.com/office/drawing/2014/main" id="{5B87DB39-CF43-449E-B692-6B9548B3B954}"/>
+                <a16:creationId xmlns:a16="http://schemas.microsoft.com/office/drawing/2014/main" id="{2CC0DABE-7F81-43F4-BD6A-51904DB553E5}"/>
               </a:ext>
             </a:extLst>
           </p:cNvPr>
@@ -9227,7 +9227,7 @@
           <p:cNvPr id="7" name="">
             <a:extLst xmlns:a="http://schemas.openxmlformats.org/drawingml/2006/main">
               <a:ext uri="{FF2B5EF4-FFF2-40B4-BE49-F238E27FC236}">
-                <a16:creationId xmlns:a16="http://schemas.microsoft.com/office/drawing/2014/main" id="{18E0F4DE-EA71-4CE2-8DF0-F4535B8E0E23}"/>
+                <a16:creationId xmlns:a16="http://schemas.microsoft.com/office/drawing/2014/main" id="{ACD5E98B-7CE5-463A-BB48-160D28A495B5}"/>
               </a:ext>
             </a:extLst>
           </p:cNvPr>
@@ -9291,7 +9291,7 @@
           <p:cNvPr id="8" name="">
             <a:extLst xmlns:a="http://schemas.openxmlformats.org/drawingml/2006/main">
               <a:ext uri="{FF2B5EF4-FFF2-40B4-BE49-F238E27FC236}">
-                <a16:creationId xmlns:a16="http://schemas.microsoft.com/office/drawing/2014/main" id="{7DD0A23E-D3C9-4FED-BBDF-49FE521CEAAC}"/>
+                <a16:creationId xmlns:a16="http://schemas.microsoft.com/office/drawing/2014/main" id="{B6FF0DA6-93F9-4658-A700-F6CB52AB4B7C}"/>
               </a:ext>
             </a:extLst>
           </p:cNvPr>
@@ -9324,7 +9324,7 @@
           <p:cNvPr id="9" name="">
             <a:extLst xmlns:a="http://schemas.openxmlformats.org/drawingml/2006/main">
               <a:ext uri="{FF2B5EF4-FFF2-40B4-BE49-F238E27FC236}">
-                <a16:creationId xmlns:a16="http://schemas.microsoft.com/office/drawing/2014/main" id="{71954F30-B73E-41AE-85F6-99FB9A86F9C3}"/>
+                <a16:creationId xmlns:a16="http://schemas.microsoft.com/office/drawing/2014/main" id="{37060996-5609-48F3-A127-407EB5920351}"/>
               </a:ext>
             </a:extLst>
           </p:cNvPr>
@@ -9388,7 +9388,7 @@
           <p:cNvPr id="10" name="">
             <a:extLst xmlns:a="http://schemas.openxmlformats.org/drawingml/2006/main">
               <a:ext uri="{FF2B5EF4-FFF2-40B4-BE49-F238E27FC236}">
-                <a16:creationId xmlns:a16="http://schemas.microsoft.com/office/drawing/2014/main" id="{9C70D6C2-2438-404B-803C-FA4450497775}"/>
+                <a16:creationId xmlns:a16="http://schemas.microsoft.com/office/drawing/2014/main" id="{47C008FC-283B-4EBA-B2EC-A9DEA9D43B42}"/>
               </a:ext>
             </a:extLst>
           </p:cNvPr>
@@ -9421,7 +9421,7 @@
           <p:cNvPr id="11" name="">
             <a:extLst xmlns:a="http://schemas.openxmlformats.org/drawingml/2006/main">
               <a:ext uri="{FF2B5EF4-FFF2-40B4-BE49-F238E27FC236}">
-                <a16:creationId xmlns:a16="http://schemas.microsoft.com/office/drawing/2014/main" id="{8C0AB0A5-1C98-4FD9-9938-45777F6DD9E1}"/>
+                <a16:creationId xmlns:a16="http://schemas.microsoft.com/office/drawing/2014/main" id="{4FE4775F-7AC5-4763-A3AC-5668062857E3}"/>
               </a:ext>
             </a:extLst>
           </p:cNvPr>
@@ -9485,7 +9485,7 @@
           <p:cNvPr id="12" name="">
             <a:extLst xmlns:a="http://schemas.openxmlformats.org/drawingml/2006/main">
               <a:ext uri="{FF2B5EF4-FFF2-40B4-BE49-F238E27FC236}">
-                <a16:creationId xmlns:a16="http://schemas.microsoft.com/office/drawing/2014/main" id="{E6909545-5694-47BC-9278-21FF183E5249}"/>
+                <a16:creationId xmlns:a16="http://schemas.microsoft.com/office/drawing/2014/main" id="{30EAD31B-3583-43DB-9847-6A6836231B3E}"/>
               </a:ext>
             </a:extLst>
           </p:cNvPr>
@@ -9518,7 +9518,7 @@
           <p:cNvPr id="13" name="">
             <a:extLst xmlns:a="http://schemas.openxmlformats.org/drawingml/2006/main">
               <a:ext uri="{FF2B5EF4-FFF2-40B4-BE49-F238E27FC236}">
-                <a16:creationId xmlns:a16="http://schemas.microsoft.com/office/drawing/2014/main" id="{44599A29-0431-4E31-9F40-5082012223D0}"/>
+                <a16:creationId xmlns:a16="http://schemas.microsoft.com/office/drawing/2014/main" id="{9C72FFA2-4EAB-45AC-BA2C-B9EE50A31C5A}"/>
               </a:ext>
             </a:extLst>
           </p:cNvPr>
@@ -9582,7 +9582,7 @@
           <p:cNvPr id="14" name="">
             <a:extLst xmlns:a="http://schemas.openxmlformats.org/drawingml/2006/main">
               <a:ext uri="{FF2B5EF4-FFF2-40B4-BE49-F238E27FC236}">
-                <a16:creationId xmlns:a16="http://schemas.microsoft.com/office/drawing/2014/main" id="{B8B3DA88-19FD-4A68-B631-53F64D6065AD}"/>
+                <a16:creationId xmlns:a16="http://schemas.microsoft.com/office/drawing/2014/main" id="{5225AEDC-7308-42AB-A9F7-64BA7E2AC87F}"/>
               </a:ext>
             </a:extLst>
           </p:cNvPr>
@@ -9615,7 +9615,7 @@
           <p:cNvPr id="15" name="">
             <a:extLst xmlns:a="http://schemas.openxmlformats.org/drawingml/2006/main">
               <a:ext uri="{FF2B5EF4-FFF2-40B4-BE49-F238E27FC236}">
-                <a16:creationId xmlns:a16="http://schemas.microsoft.com/office/drawing/2014/main" id="{D0114FE0-0F76-4CF4-9407-45B49D6146FD}"/>
+                <a16:creationId xmlns:a16="http://schemas.microsoft.com/office/drawing/2014/main" id="{6BD9BBA0-866B-43BB-9D2C-397A22632CD9}"/>
               </a:ext>
             </a:extLst>
           </p:cNvPr>
@@ -9679,7 +9679,7 @@
           <p:cNvPr id="16" name="">
             <a:extLst xmlns:a="http://schemas.openxmlformats.org/drawingml/2006/main">
               <a:ext uri="{FF2B5EF4-FFF2-40B4-BE49-F238E27FC236}">
-                <a16:creationId xmlns:a16="http://schemas.microsoft.com/office/drawing/2014/main" id="{7C0CC1AB-7EC7-4423-84E0-E0796CF7A35B}"/>
+                <a16:creationId xmlns:a16="http://schemas.microsoft.com/office/drawing/2014/main" id="{D2CB5A44-F13B-4EA6-BDE1-D9209BEE2823}"/>
               </a:ext>
             </a:extLst>
           </p:cNvPr>
@@ -9712,7 +9712,7 @@
           <p:cNvPr id="17" name="">
             <a:extLst xmlns:a="http://schemas.openxmlformats.org/drawingml/2006/main">
               <a:ext uri="{FF2B5EF4-FFF2-40B4-BE49-F238E27FC236}">
-                <a16:creationId xmlns:a16="http://schemas.microsoft.com/office/drawing/2014/main" id="{0B9A2E2B-7D41-4543-82F4-1D23ECB6EF7A}"/>
+                <a16:creationId xmlns:a16="http://schemas.microsoft.com/office/drawing/2014/main" id="{AB1BE085-ECE4-419D-817E-135516F49C18}"/>
               </a:ext>
             </a:extLst>
           </p:cNvPr>
@@ -9776,7 +9776,7 @@
           <p:cNvPr id="18" name="">
             <a:extLst xmlns:a="http://schemas.openxmlformats.org/drawingml/2006/main">
               <a:ext uri="{FF2B5EF4-FFF2-40B4-BE49-F238E27FC236}">
-                <a16:creationId xmlns:a16="http://schemas.microsoft.com/office/drawing/2014/main" id="{DF6E6A2F-C5DC-4AAD-AEAD-12C14E6ABC2E}"/>
+                <a16:creationId xmlns:a16="http://schemas.microsoft.com/office/drawing/2014/main" id="{D410B364-D41A-4420-95FA-52E46DAC1453}"/>
               </a:ext>
             </a:extLst>
           </p:cNvPr>
@@ -9809,7 +9809,7 @@
           <p:cNvPr id="19" name="">
             <a:extLst xmlns:a="http://schemas.openxmlformats.org/drawingml/2006/main">
               <a:ext uri="{FF2B5EF4-FFF2-40B4-BE49-F238E27FC236}">
-                <a16:creationId xmlns:a16="http://schemas.microsoft.com/office/drawing/2014/main" id="{BCB1F725-681C-4253-A8E8-68051536E2E7}"/>
+                <a16:creationId xmlns:a16="http://schemas.microsoft.com/office/drawing/2014/main" id="{7C1DB5D5-853B-4E2A-B8DA-DB014CB62B22}"/>
               </a:ext>
             </a:extLst>
           </p:cNvPr>
@@ -9873,7 +9873,7 @@
           <p:cNvPr id="20" name="">
             <a:extLst xmlns:a="http://schemas.openxmlformats.org/drawingml/2006/main">
               <a:ext uri="{FF2B5EF4-FFF2-40B4-BE49-F238E27FC236}">
-                <a16:creationId xmlns:a16="http://schemas.microsoft.com/office/drawing/2014/main" id="{8DF6970B-7220-49FA-B9D6-B53B0ABDD36D}"/>
+                <a16:creationId xmlns:a16="http://schemas.microsoft.com/office/drawing/2014/main" id="{63A35F14-5CDD-4EB1-8F79-B8C41F856AB4}"/>
               </a:ext>
             </a:extLst>
           </p:cNvPr>
@@ -9937,7 +9937,7 @@
           <p:cNvPr id="21" name="">
             <a:extLst xmlns:a="http://schemas.openxmlformats.org/drawingml/2006/main">
               <a:ext uri="{FF2B5EF4-FFF2-40B4-BE49-F238E27FC236}">
-                <a16:creationId xmlns:a16="http://schemas.microsoft.com/office/drawing/2014/main" id="{906EFE5F-FFFD-43E1-88F3-702F4B8452B6}"/>
+                <a16:creationId xmlns:a16="http://schemas.microsoft.com/office/drawing/2014/main" id="{ED1C4CC8-20BD-4C4B-90B1-BA1F1C91A194}"/>
               </a:ext>
             </a:extLst>
           </p:cNvPr>
@@ -9999,7 +9999,7 @@
     </p:spTree>
     <p:extLst>
       <p:ext uri="{BB962C8B-B14F-4D97-AF65-F5344CB8AC3E}">
-        <p14:creationId xmlns:p14="http://schemas.microsoft.com/office/powerpoint/2010/main" val="292248782"/>
+        <p14:creationId xmlns:p14="http://schemas.microsoft.com/office/powerpoint/2010/main" val="651784703"/>
       </p:ext>
     </p:extLst>
   </p:cSld>
@@ -10023,7 +10023,7 @@
           <p:cNvPr id="1" name="">
             <a:extLst xmlns:a="http://schemas.openxmlformats.org/drawingml/2006/main">
               <a:ext uri="{FF2B5EF4-FFF2-40B4-BE49-F238E27FC236}">
-                <a16:creationId xmlns:a16="http://schemas.microsoft.com/office/drawing/2014/main" id="{1D04B483-F589-4F25-AF2B-BF92B9F9F0CE}"/>
+                <a16:creationId xmlns:a16="http://schemas.microsoft.com/office/drawing/2014/main" id="{21B7B47A-E4EF-49DD-B476-5F5188ABC625}"/>
               </a:ext>
             </a:extLst>
           </p:cNvPr>
@@ -10056,7 +10056,7 @@
           <p:cNvPr id="2" name="">
             <a:extLst xmlns:a="http://schemas.openxmlformats.org/drawingml/2006/main">
               <a:ext uri="{FF2B5EF4-FFF2-40B4-BE49-F238E27FC236}">
-                <a16:creationId xmlns:a16="http://schemas.microsoft.com/office/drawing/2014/main" id="{558ABD3F-F796-487C-A576-DF22700E6B5C}"/>
+                <a16:creationId xmlns:a16="http://schemas.microsoft.com/office/drawing/2014/main" id="{E1D878FE-D7CA-408B-80A3-9630E98FC5FF}"/>
               </a:ext>
             </a:extLst>
           </p:cNvPr>
@@ -10089,7 +10089,7 @@
           <p:cNvPr id="3" name="">
             <a:extLst xmlns:a="http://schemas.openxmlformats.org/drawingml/2006/main">
               <a:ext uri="{FF2B5EF4-FFF2-40B4-BE49-F238E27FC236}">
-                <a16:creationId xmlns:a16="http://schemas.microsoft.com/office/drawing/2014/main" id="{77CBAEEE-3B12-4C5E-ACF3-02EE93C1CB2E}"/>
+                <a16:creationId xmlns:a16="http://schemas.microsoft.com/office/drawing/2014/main" id="{1993EE93-75D2-4B17-8B12-36A5C48B7617}"/>
               </a:ext>
             </a:extLst>
           </p:cNvPr>
@@ -10143,7 +10143,7 @@
                 <a:ea typeface="Malgun Gothic"/>
                 <a:cs typeface="Malgun Gothic"/>
               </a:rPr>
-              <a:t>영상 2 학습 진행</a:t>
+              <a:t>영상 2 중기 정책</a:t>
             </a:r>
           </a:p>
         </p:txBody>
@@ -10153,7 +10153,7 @@
           <p:cNvPr id="4" name="">
             <a:extLst xmlns:a="http://schemas.openxmlformats.org/drawingml/2006/main">
               <a:ext uri="{FF2B5EF4-FFF2-40B4-BE49-F238E27FC236}">
-                <a16:creationId xmlns:a16="http://schemas.microsoft.com/office/drawing/2014/main" id="{ACF1CDF0-6F27-4AE8-B672-9078979581CE}"/>
+                <a16:creationId xmlns:a16="http://schemas.microsoft.com/office/drawing/2014/main" id="{991F55AC-7C90-4F4D-94E8-543C119096FD}"/>
               </a:ext>
             </a:extLst>
           </p:cNvPr>
@@ -10207,7 +10207,7 @@
                 <a:ea typeface="Malgun Gothic"/>
                 <a:cs typeface="Malgun Gothic"/>
               </a:rPr>
-              <a:t>checkpoint별 정책 변화로 long-run 효과를 제시</a:t>
+              <a:t>중기 정책은 부분 hit 이후 player_dead로 종료</a:t>
             </a:r>
           </a:p>
         </p:txBody>
@@ -10217,7 +10217,7 @@
           <p:cNvPr id="5" name="">
             <a:extLst xmlns:a="http://schemas.openxmlformats.org/drawingml/2006/main">
               <a:ext uri="{FF2B5EF4-FFF2-40B4-BE49-F238E27FC236}">
-                <a16:creationId xmlns:a16="http://schemas.microsoft.com/office/drawing/2014/main" id="{ECDD4522-2D25-44F2-845A-D8031B39C45E}"/>
+                <a16:creationId xmlns:a16="http://schemas.microsoft.com/office/drawing/2014/main" id="{C94E48DD-7CC9-42C1-A9EE-A022A7850134}"/>
               </a:ext>
             </a:extLst>
           </p:cNvPr>
@@ -10250,7 +10250,7 @@
           <p:cNvPr id="6" name="">
             <a:extLst xmlns:a="http://schemas.openxmlformats.org/drawingml/2006/main">
               <a:ext uri="{FF2B5EF4-FFF2-40B4-BE49-F238E27FC236}">
-                <a16:creationId xmlns:a16="http://schemas.microsoft.com/office/drawing/2014/main" id="{9A9945C1-8A4D-4838-B81B-85531CA797E7}"/>
+                <a16:creationId xmlns:a16="http://schemas.microsoft.com/office/drawing/2014/main" id="{B9180D79-A873-4C76-94B1-4E3200E329EE}"/>
               </a:ext>
             </a:extLst>
           </p:cNvPr>
@@ -10283,7 +10283,7 @@
           <p:cNvPr id="7" name="">
             <a:extLst xmlns:a="http://schemas.openxmlformats.org/drawingml/2006/main">
               <a:ext uri="{FF2B5EF4-FFF2-40B4-BE49-F238E27FC236}">
-                <a16:creationId xmlns:a16="http://schemas.microsoft.com/office/drawing/2014/main" id="{F6781BF5-3FC8-4CA7-AE4B-DCCD0591FDD4}"/>
+                <a16:creationId xmlns:a16="http://schemas.microsoft.com/office/drawing/2014/main" id="{AEFA1485-01B0-41B7-B537-85E7BFC1D8BB}"/>
               </a:ext>
             </a:extLst>
           </p:cNvPr>
@@ -10347,7 +10347,7 @@
           <p:cNvPr id="8" name="">
             <a:extLst xmlns:a="http://schemas.openxmlformats.org/drawingml/2006/main">
               <a:ext uri="{FF2B5EF4-FFF2-40B4-BE49-F238E27FC236}">
-                <a16:creationId xmlns:a16="http://schemas.microsoft.com/office/drawing/2014/main" id="{CEE71E93-BE0B-4D79-AAF0-42D1C5F3774F}"/>
+                <a16:creationId xmlns:a16="http://schemas.microsoft.com/office/drawing/2014/main" id="{974C8856-BB34-4660-B684-633AE554199A}"/>
               </a:ext>
             </a:extLst>
           </p:cNvPr>
@@ -10380,7 +10380,7 @@
           <p:cNvPr id="9" name="">
             <a:extLst xmlns:a="http://schemas.openxmlformats.org/drawingml/2006/main">
               <a:ext uri="{FF2B5EF4-FFF2-40B4-BE49-F238E27FC236}">
-                <a16:creationId xmlns:a16="http://schemas.microsoft.com/office/drawing/2014/main" id="{3AD0BB5B-2451-43CE-99A3-DB761029DBB0}"/>
+                <a16:creationId xmlns:a16="http://schemas.microsoft.com/office/drawing/2014/main" id="{B4C1AFCE-D336-4EAF-918E-CB4D3F4ABCC1}"/>
               </a:ext>
             </a:extLst>
           </p:cNvPr>
@@ -10434,7 +10434,7 @@
                 <a:ea typeface="Malgun Gothic"/>
                 <a:cs typeface="Malgun Gothic"/>
               </a:rPr>
-              <a:t>99K 499K 799K 1M 실제 gameplay montage</a:t>
+              <a:t>499K checkpoint 실제 gameplay</a:t>
             </a:r>
           </a:p>
         </p:txBody>
@@ -10444,7 +10444,7 @@
           <p:cNvPr id="10" name="">
             <a:extLst xmlns:a="http://schemas.openxmlformats.org/drawingml/2006/main">
               <a:ext uri="{FF2B5EF4-FFF2-40B4-BE49-F238E27FC236}">
-                <a16:creationId xmlns:a16="http://schemas.microsoft.com/office/drawing/2014/main" id="{6C6FE1E1-1DBF-453E-AA18-3BD7E22E53DD}"/>
+                <a16:creationId xmlns:a16="http://schemas.microsoft.com/office/drawing/2014/main" id="{5AC08879-DE83-44A1-B0D5-91C5603083BE}"/>
               </a:ext>
             </a:extLst>
           </p:cNvPr>
@@ -10477,7 +10477,7 @@
           <p:cNvPr id="11" name="">
             <a:extLst xmlns:a="http://schemas.openxmlformats.org/drawingml/2006/main">
               <a:ext uri="{FF2B5EF4-FFF2-40B4-BE49-F238E27FC236}">
-                <a16:creationId xmlns:a16="http://schemas.microsoft.com/office/drawing/2014/main" id="{0FCACF69-65B8-4927-93F1-76241AD5E8F9}"/>
+                <a16:creationId xmlns:a16="http://schemas.microsoft.com/office/drawing/2014/main" id="{83C029D0-3D80-4558-A65A-DCD9FD862DC9}"/>
               </a:ext>
             </a:extLst>
           </p:cNvPr>
@@ -10531,7 +10531,7 @@
                 <a:ea typeface="Malgun Gothic"/>
                 <a:cs typeface="Malgun Gothic"/>
               </a:rPr>
-              <a:t>checkpoint별 실제 플레이 비교</a:t>
+              <a:t>BossPlayer-499996.onnx</a:t>
             </a:r>
           </a:p>
         </p:txBody>
@@ -10541,7 +10541,7 @@
           <p:cNvPr id="12" name="">
             <a:extLst xmlns:a="http://schemas.openxmlformats.org/drawingml/2006/main">
               <a:ext uri="{FF2B5EF4-FFF2-40B4-BE49-F238E27FC236}">
-                <a16:creationId xmlns:a16="http://schemas.microsoft.com/office/drawing/2014/main" id="{E838B746-0901-422B-BFFA-27ED786B092F}"/>
+                <a16:creationId xmlns:a16="http://schemas.microsoft.com/office/drawing/2014/main" id="{785CB5C4-2289-4A0D-A71F-6481C6FD3296}"/>
               </a:ext>
             </a:extLst>
           </p:cNvPr>
@@ -10574,7 +10574,7 @@
           <p:cNvPr id="13" name="">
             <a:extLst xmlns:a="http://schemas.openxmlformats.org/drawingml/2006/main">
               <a:ext uri="{FF2B5EF4-FFF2-40B4-BE49-F238E27FC236}">
-                <a16:creationId xmlns:a16="http://schemas.microsoft.com/office/drawing/2014/main" id="{8F55AC3D-15D5-4E80-94C9-77E78D6B402B}"/>
+                <a16:creationId xmlns:a16="http://schemas.microsoft.com/office/drawing/2014/main" id="{664DF843-CCC6-4B42-A4DC-CA00D3D65A6A}"/>
               </a:ext>
             </a:extLst>
           </p:cNvPr>
@@ -10628,7 +10628,7 @@
                 <a:ea typeface="Malgun Gothic"/>
                 <a:cs typeface="Malgun Gothic"/>
               </a:rPr>
-              <a:t>hit_rate 상승</a:t>
+              <a:t>boss_damage 3</a:t>
             </a:r>
           </a:p>
         </p:txBody>
@@ -10638,7 +10638,7 @@
           <p:cNvPr id="14" name="">
             <a:extLst xmlns:a="http://schemas.openxmlformats.org/drawingml/2006/main">
               <a:ext uri="{FF2B5EF4-FFF2-40B4-BE49-F238E27FC236}">
-                <a16:creationId xmlns:a16="http://schemas.microsoft.com/office/drawing/2014/main" id="{63F4CF9A-CF12-4963-B548-300ECF76AD28}"/>
+                <a16:creationId xmlns:a16="http://schemas.microsoft.com/office/drawing/2014/main" id="{516FA4D3-7F85-4B72-AF9A-8574EACD3153}"/>
               </a:ext>
             </a:extLst>
           </p:cNvPr>
@@ -10671,7 +10671,7 @@
           <p:cNvPr id="15" name="">
             <a:extLst xmlns:a="http://schemas.openxmlformats.org/drawingml/2006/main">
               <a:ext uri="{FF2B5EF4-FFF2-40B4-BE49-F238E27FC236}">
-                <a16:creationId xmlns:a16="http://schemas.microsoft.com/office/drawing/2014/main" id="{FE2571A9-37EF-4851-BA4B-114B256996F8}"/>
+                <a16:creationId xmlns:a16="http://schemas.microsoft.com/office/drawing/2014/main" id="{15564AE7-3D0D-4528-A6E2-F160D7D071CB}"/>
               </a:ext>
             </a:extLst>
           </p:cNvPr>
@@ -10725,7 +10725,7 @@
                 <a:ea typeface="Malgun Gothic"/>
                 <a:cs typeface="Malgun Gothic"/>
               </a:rPr>
-              <a:t>in_range 증가</a:t>
+              <a:t>survival 25.0초</a:t>
             </a:r>
           </a:p>
         </p:txBody>
@@ -10735,7 +10735,7 @@
           <p:cNvPr id="16" name="">
             <a:extLst xmlns:a="http://schemas.openxmlformats.org/drawingml/2006/main">
               <a:ext uri="{FF2B5EF4-FFF2-40B4-BE49-F238E27FC236}">
-                <a16:creationId xmlns:a16="http://schemas.microsoft.com/office/drawing/2014/main" id="{B9E3AA1B-0F7D-4A8F-80AF-3A9CB9616CE1}"/>
+                <a16:creationId xmlns:a16="http://schemas.microsoft.com/office/drawing/2014/main" id="{C9EF1605-7C91-4FF6-BD46-0AC4F2819C15}"/>
               </a:ext>
             </a:extLst>
           </p:cNvPr>
@@ -10768,7 +10768,7 @@
           <p:cNvPr id="17" name="">
             <a:extLst xmlns:a="http://schemas.openxmlformats.org/drawingml/2006/main">
               <a:ext uri="{FF2B5EF4-FFF2-40B4-BE49-F238E27FC236}">
-                <a16:creationId xmlns:a16="http://schemas.microsoft.com/office/drawing/2014/main" id="{45F5EF45-CB58-443F-AD1A-A968BD96BF1E}"/>
+                <a16:creationId xmlns:a16="http://schemas.microsoft.com/office/drawing/2014/main" id="{3D37041A-A161-44FA-95F0-D0F85344C482}"/>
               </a:ext>
             </a:extLst>
           </p:cNvPr>
@@ -10822,7 +10822,7 @@
                 <a:ea typeface="Malgun Gothic"/>
                 <a:cs typeface="Malgun Gothic"/>
               </a:rPr>
-              <a:t>boss damage 증가</a:t>
+              <a:t>player_dead</a:t>
             </a:r>
           </a:p>
         </p:txBody>
@@ -10832,7 +10832,7 @@
           <p:cNvPr id="18" name="">
             <a:extLst xmlns:a="http://schemas.openxmlformats.org/drawingml/2006/main">
               <a:ext uri="{FF2B5EF4-FFF2-40B4-BE49-F238E27FC236}">
-                <a16:creationId xmlns:a16="http://schemas.microsoft.com/office/drawing/2014/main" id="{C212F16F-4690-4077-9516-25AB57FCE799}"/>
+                <a16:creationId xmlns:a16="http://schemas.microsoft.com/office/drawing/2014/main" id="{F6D43B50-010C-4C52-BEB4-4B840178CE12}"/>
               </a:ext>
             </a:extLst>
           </p:cNvPr>
@@ -10865,7 +10865,7 @@
           <p:cNvPr id="19" name="">
             <a:extLst xmlns:a="http://schemas.openxmlformats.org/drawingml/2006/main">
               <a:ext uri="{FF2B5EF4-FFF2-40B4-BE49-F238E27FC236}">
-                <a16:creationId xmlns:a16="http://schemas.microsoft.com/office/drawing/2014/main" id="{5016F848-D3B2-44B9-9EC3-8BB162678448}"/>
+                <a16:creationId xmlns:a16="http://schemas.microsoft.com/office/drawing/2014/main" id="{C22AC959-8638-4D32-8E23-A244F70E249B}"/>
               </a:ext>
             </a:extLst>
           </p:cNvPr>
@@ -10929,7 +10929,7 @@
           <p:cNvPr id="20" name="">
             <a:extLst xmlns:a="http://schemas.openxmlformats.org/drawingml/2006/main">
               <a:ext uri="{FF2B5EF4-FFF2-40B4-BE49-F238E27FC236}">
-                <a16:creationId xmlns:a16="http://schemas.microsoft.com/office/drawing/2014/main" id="{0A8480B6-14A6-4CF8-8456-ADD23D85202F}"/>
+                <a16:creationId xmlns:a16="http://schemas.microsoft.com/office/drawing/2014/main" id="{BC35AFBC-7FA6-4E01-B88F-A15DEFAE7336}"/>
               </a:ext>
             </a:extLst>
           </p:cNvPr>
@@ -10993,7 +10993,7 @@
           <p:cNvPr id="21" name="">
             <a:extLst xmlns:a="http://schemas.openxmlformats.org/drawingml/2006/main">
               <a:ext uri="{FF2B5EF4-FFF2-40B4-BE49-F238E27FC236}">
-                <a16:creationId xmlns:a16="http://schemas.microsoft.com/office/drawing/2014/main" id="{8281D9D9-3FE4-41A8-9D86-C2398C95297D}"/>
+                <a16:creationId xmlns:a16="http://schemas.microsoft.com/office/drawing/2014/main" id="{786DEE4A-6991-4B82-9351-F4C7E1DE0985}"/>
               </a:ext>
             </a:extLst>
           </p:cNvPr>
@@ -11055,7 +11055,7 @@
     </p:spTree>
     <p:extLst>
       <p:ext uri="{BB962C8B-B14F-4D97-AF65-F5344CB8AC3E}">
-        <p14:creationId xmlns:p14="http://schemas.microsoft.com/office/powerpoint/2010/main" val="436206472"/>
+        <p14:creationId xmlns:p14="http://schemas.microsoft.com/office/powerpoint/2010/main" val="1334432824"/>
       </p:ext>
     </p:extLst>
   </p:cSld>
@@ -11079,7 +11079,7 @@
           <p:cNvPr id="1" name="">
             <a:extLst xmlns:a="http://schemas.openxmlformats.org/drawingml/2006/main">
               <a:ext uri="{FF2B5EF4-FFF2-40B4-BE49-F238E27FC236}">
-                <a16:creationId xmlns:a16="http://schemas.microsoft.com/office/drawing/2014/main" id="{7DD72D40-8C6D-4B32-BD22-E82BBC65F2C8}"/>
+                <a16:creationId xmlns:a16="http://schemas.microsoft.com/office/drawing/2014/main" id="{C8D0C0A6-92AA-42CA-85F7-0172BB5035C6}"/>
               </a:ext>
             </a:extLst>
           </p:cNvPr>
@@ -11112,7 +11112,7 @@
           <p:cNvPr id="2" name="">
             <a:extLst xmlns:a="http://schemas.openxmlformats.org/drawingml/2006/main">
               <a:ext uri="{FF2B5EF4-FFF2-40B4-BE49-F238E27FC236}">
-                <a16:creationId xmlns:a16="http://schemas.microsoft.com/office/drawing/2014/main" id="{D9292D2B-E02C-4691-B24F-04AB69D3BD1E}"/>
+                <a16:creationId xmlns:a16="http://schemas.microsoft.com/office/drawing/2014/main" id="{BE0D4687-31F2-49C6-B66E-A7F108E5E5A9}"/>
               </a:ext>
             </a:extLst>
           </p:cNvPr>
@@ -11145,7 +11145,7 @@
           <p:cNvPr id="3" name="">
             <a:extLst xmlns:a="http://schemas.openxmlformats.org/drawingml/2006/main">
               <a:ext uri="{FF2B5EF4-FFF2-40B4-BE49-F238E27FC236}">
-                <a16:creationId xmlns:a16="http://schemas.microsoft.com/office/drawing/2014/main" id="{43B4FF6B-59C2-42DE-86C1-CA7320FA380A}"/>
+                <a16:creationId xmlns:a16="http://schemas.microsoft.com/office/drawing/2014/main" id="{E1376506-CC8E-492D-81F8-BBD5CFF1D571}"/>
               </a:ext>
             </a:extLst>
           </p:cNvPr>
@@ -11209,7 +11209,7 @@
           <p:cNvPr id="4" name="">
             <a:extLst xmlns:a="http://schemas.openxmlformats.org/drawingml/2006/main">
               <a:ext uri="{FF2B5EF4-FFF2-40B4-BE49-F238E27FC236}">
-                <a16:creationId xmlns:a16="http://schemas.microsoft.com/office/drawing/2014/main" id="{BD59E87F-5817-4DDE-B961-A6718041043F}"/>
+                <a16:creationId xmlns:a16="http://schemas.microsoft.com/office/drawing/2014/main" id="{1FF6B315-9A5D-465C-9361-6339A1679365}"/>
               </a:ext>
             </a:extLst>
           </p:cNvPr>
@@ -11273,7 +11273,7 @@
           <p:cNvPr id="5" name="">
             <a:extLst xmlns:a="http://schemas.openxmlformats.org/drawingml/2006/main">
               <a:ext uri="{FF2B5EF4-FFF2-40B4-BE49-F238E27FC236}">
-                <a16:creationId xmlns:a16="http://schemas.microsoft.com/office/drawing/2014/main" id="{B1B5BA86-77CB-410E-A58C-C14C732F506A}"/>
+                <a16:creationId xmlns:a16="http://schemas.microsoft.com/office/drawing/2014/main" id="{25CE8BFB-612F-4D90-B268-72E1CFCEF453}"/>
               </a:ext>
             </a:extLst>
           </p:cNvPr>
@@ -11306,7 +11306,7 @@
           <p:cNvPr id="6" name="">
             <a:extLst xmlns:a="http://schemas.openxmlformats.org/drawingml/2006/main">
               <a:ext uri="{FF2B5EF4-FFF2-40B4-BE49-F238E27FC236}">
-                <a16:creationId xmlns:a16="http://schemas.microsoft.com/office/drawing/2014/main" id="{DADA5E46-5604-485F-A416-F8FC3FAC112D}"/>
+                <a16:creationId xmlns:a16="http://schemas.microsoft.com/office/drawing/2014/main" id="{E217B38F-72CC-42B6-A36F-EAEF24C2EF19}"/>
               </a:ext>
             </a:extLst>
           </p:cNvPr>
@@ -11339,7 +11339,7 @@
           <p:cNvPr id="7" name="">
             <a:extLst xmlns:a="http://schemas.openxmlformats.org/drawingml/2006/main">
               <a:ext uri="{FF2B5EF4-FFF2-40B4-BE49-F238E27FC236}">
-                <a16:creationId xmlns:a16="http://schemas.microsoft.com/office/drawing/2014/main" id="{E056BDD7-A09B-4F21-9E68-7F1E73C3B4E8}"/>
+                <a16:creationId xmlns:a16="http://schemas.microsoft.com/office/drawing/2014/main" id="{E28E521E-EC9E-4C34-9158-32139E91003B}"/>
               </a:ext>
             </a:extLst>
           </p:cNvPr>
@@ -11403,7 +11403,7 @@
           <p:cNvPr id="8" name="">
             <a:extLst xmlns:a="http://schemas.openxmlformats.org/drawingml/2006/main">
               <a:ext uri="{FF2B5EF4-FFF2-40B4-BE49-F238E27FC236}">
-                <a16:creationId xmlns:a16="http://schemas.microsoft.com/office/drawing/2014/main" id="{49838B25-330F-4EA0-ADAA-86546B63D385}"/>
+                <a16:creationId xmlns:a16="http://schemas.microsoft.com/office/drawing/2014/main" id="{741761A9-1F1F-449B-99BD-06E3B51613D2}"/>
               </a:ext>
             </a:extLst>
           </p:cNvPr>
@@ -11436,7 +11436,7 @@
           <p:cNvPr id="9" name="">
             <a:extLst xmlns:a="http://schemas.openxmlformats.org/drawingml/2006/main">
               <a:ext uri="{FF2B5EF4-FFF2-40B4-BE49-F238E27FC236}">
-                <a16:creationId xmlns:a16="http://schemas.microsoft.com/office/drawing/2014/main" id="{DB10BE0C-C0F1-4F67-A67B-3D21F8FE2341}"/>
+                <a16:creationId xmlns:a16="http://schemas.microsoft.com/office/drawing/2014/main" id="{3E6587CC-016D-4F51-9940-8214456310FA}"/>
               </a:ext>
             </a:extLst>
           </p:cNvPr>
@@ -11500,7 +11500,7 @@
           <p:cNvPr id="10" name="">
             <a:extLst xmlns:a="http://schemas.openxmlformats.org/drawingml/2006/main">
               <a:ext uri="{FF2B5EF4-FFF2-40B4-BE49-F238E27FC236}">
-                <a16:creationId xmlns:a16="http://schemas.microsoft.com/office/drawing/2014/main" id="{B707A4CB-7668-4EA0-B669-9D4A4F31A0EC}"/>
+                <a16:creationId xmlns:a16="http://schemas.microsoft.com/office/drawing/2014/main" id="{601E55C6-4121-4B39-B81C-A1795E86377E}"/>
               </a:ext>
             </a:extLst>
           </p:cNvPr>
@@ -11533,7 +11533,7 @@
           <p:cNvPr id="11" name="">
             <a:extLst xmlns:a="http://schemas.openxmlformats.org/drawingml/2006/main">
               <a:ext uri="{FF2B5EF4-FFF2-40B4-BE49-F238E27FC236}">
-                <a16:creationId xmlns:a16="http://schemas.microsoft.com/office/drawing/2014/main" id="{8D13CFBA-2B82-4026-9EAD-6F9693530762}"/>
+                <a16:creationId xmlns:a16="http://schemas.microsoft.com/office/drawing/2014/main" id="{D1281F57-A314-4535-9C06-5D098396363B}"/>
               </a:ext>
             </a:extLst>
           </p:cNvPr>
@@ -11597,7 +11597,7 @@
           <p:cNvPr id="12" name="">
             <a:extLst xmlns:a="http://schemas.openxmlformats.org/drawingml/2006/main">
               <a:ext uri="{FF2B5EF4-FFF2-40B4-BE49-F238E27FC236}">
-                <a16:creationId xmlns:a16="http://schemas.microsoft.com/office/drawing/2014/main" id="{6F7CA58C-BE2E-400F-A84F-A6354E5802E8}"/>
+                <a16:creationId xmlns:a16="http://schemas.microsoft.com/office/drawing/2014/main" id="{A9780237-1B52-4917-983C-9FED66A27B95}"/>
               </a:ext>
             </a:extLst>
           </p:cNvPr>
@@ -11630,7 +11630,7 @@
           <p:cNvPr id="13" name="">
             <a:extLst xmlns:a="http://schemas.openxmlformats.org/drawingml/2006/main">
               <a:ext uri="{FF2B5EF4-FFF2-40B4-BE49-F238E27FC236}">
-                <a16:creationId xmlns:a16="http://schemas.microsoft.com/office/drawing/2014/main" id="{9BC5D190-054A-4841-BCEF-66B68D188DFA}"/>
+                <a16:creationId xmlns:a16="http://schemas.microsoft.com/office/drawing/2014/main" id="{6439AA76-5677-4798-B921-66D0A1DA147C}"/>
               </a:ext>
             </a:extLst>
           </p:cNvPr>
@@ -11694,7 +11694,7 @@
           <p:cNvPr id="14" name="">
             <a:extLst xmlns:a="http://schemas.openxmlformats.org/drawingml/2006/main">
               <a:ext uri="{FF2B5EF4-FFF2-40B4-BE49-F238E27FC236}">
-                <a16:creationId xmlns:a16="http://schemas.microsoft.com/office/drawing/2014/main" id="{F9E3A09B-59C4-4E6B-BCEA-B808FFF8CD15}"/>
+                <a16:creationId xmlns:a16="http://schemas.microsoft.com/office/drawing/2014/main" id="{3034D07C-80D4-48FB-A9DE-CF398F9698E1}"/>
               </a:ext>
             </a:extLst>
           </p:cNvPr>
@@ -11727,7 +11727,7 @@
           <p:cNvPr id="15" name="">
             <a:extLst xmlns:a="http://schemas.openxmlformats.org/drawingml/2006/main">
               <a:ext uri="{FF2B5EF4-FFF2-40B4-BE49-F238E27FC236}">
-                <a16:creationId xmlns:a16="http://schemas.microsoft.com/office/drawing/2014/main" id="{11F838B6-3FE2-4D9A-9AD7-97306CB6B577}"/>
+                <a16:creationId xmlns:a16="http://schemas.microsoft.com/office/drawing/2014/main" id="{D3E24BEC-8E6A-42D6-BF25-A5B533E0CDEB}"/>
               </a:ext>
             </a:extLst>
           </p:cNvPr>
@@ -11791,7 +11791,7 @@
           <p:cNvPr id="16" name="">
             <a:extLst xmlns:a="http://schemas.openxmlformats.org/drawingml/2006/main">
               <a:ext uri="{FF2B5EF4-FFF2-40B4-BE49-F238E27FC236}">
-                <a16:creationId xmlns:a16="http://schemas.microsoft.com/office/drawing/2014/main" id="{701604C4-735B-41FF-9006-95BF1B0EF04B}"/>
+                <a16:creationId xmlns:a16="http://schemas.microsoft.com/office/drawing/2014/main" id="{138F14A1-6EC7-4636-8A7F-EEDC85A22251}"/>
               </a:ext>
             </a:extLst>
           </p:cNvPr>
@@ -11824,7 +11824,7 @@
           <p:cNvPr id="17" name="">
             <a:extLst xmlns:a="http://schemas.openxmlformats.org/drawingml/2006/main">
               <a:ext uri="{FF2B5EF4-FFF2-40B4-BE49-F238E27FC236}">
-                <a16:creationId xmlns:a16="http://schemas.microsoft.com/office/drawing/2014/main" id="{0A52B95A-25A6-413E-B5D5-38CBF3E9093D}"/>
+                <a16:creationId xmlns:a16="http://schemas.microsoft.com/office/drawing/2014/main" id="{82CB878F-AF69-40CF-BB68-8C0669C31507}"/>
               </a:ext>
             </a:extLst>
           </p:cNvPr>
@@ -11888,7 +11888,7 @@
           <p:cNvPr id="18" name="">
             <a:extLst xmlns:a="http://schemas.openxmlformats.org/drawingml/2006/main">
               <a:ext uri="{FF2B5EF4-FFF2-40B4-BE49-F238E27FC236}">
-                <a16:creationId xmlns:a16="http://schemas.microsoft.com/office/drawing/2014/main" id="{370EBB3E-419F-4E49-ABFE-E590F52C2813}"/>
+                <a16:creationId xmlns:a16="http://schemas.microsoft.com/office/drawing/2014/main" id="{CC887E3B-6E65-4F41-A625-95CE190E9C43}"/>
               </a:ext>
             </a:extLst>
           </p:cNvPr>
@@ -11952,7 +11952,7 @@
           <p:cNvPr id="19" name="">
             <a:extLst xmlns:a="http://schemas.openxmlformats.org/drawingml/2006/main">
               <a:ext uri="{FF2B5EF4-FFF2-40B4-BE49-F238E27FC236}">
-                <a16:creationId xmlns:a16="http://schemas.microsoft.com/office/drawing/2014/main" id="{E78265EE-7B48-47FC-8395-B21F77E6C7EF}"/>
+                <a16:creationId xmlns:a16="http://schemas.microsoft.com/office/drawing/2014/main" id="{403BF0C6-BF72-4DB3-98E4-44B182F60A75}"/>
               </a:ext>
             </a:extLst>
           </p:cNvPr>
@@ -12014,7 +12014,7 @@
     </p:spTree>
     <p:extLst>
       <p:ext uri="{BB962C8B-B14F-4D97-AF65-F5344CB8AC3E}">
-        <p14:creationId xmlns:p14="http://schemas.microsoft.com/office/powerpoint/2010/main" val="560985683"/>
+        <p14:creationId xmlns:p14="http://schemas.microsoft.com/office/powerpoint/2010/main" val="1255536198"/>
       </p:ext>
     </p:extLst>
   </p:cSld>
@@ -12038,7 +12038,7 @@
           <p:cNvPr id="1" name="">
             <a:extLst xmlns:a="http://schemas.openxmlformats.org/drawingml/2006/main">
               <a:ext uri="{FF2B5EF4-FFF2-40B4-BE49-F238E27FC236}">
-                <a16:creationId xmlns:a16="http://schemas.microsoft.com/office/drawing/2014/main" id="{3AFB99FE-23BA-4C09-9DFD-89B9FA885E9C}"/>
+                <a16:creationId xmlns:a16="http://schemas.microsoft.com/office/drawing/2014/main" id="{6D1193C4-F9E0-4522-B5C7-08AA4A198517}"/>
               </a:ext>
             </a:extLst>
           </p:cNvPr>
@@ -12071,7 +12071,7 @@
           <p:cNvPr id="2" name="">
             <a:extLst xmlns:a="http://schemas.openxmlformats.org/drawingml/2006/main">
               <a:ext uri="{FF2B5EF4-FFF2-40B4-BE49-F238E27FC236}">
-                <a16:creationId xmlns:a16="http://schemas.microsoft.com/office/drawing/2014/main" id="{51D095CE-195E-42E8-A5DE-3AC3994BBFF5}"/>
+                <a16:creationId xmlns:a16="http://schemas.microsoft.com/office/drawing/2014/main" id="{70DC03F3-871C-49D9-BF2D-39C5B11B98BC}"/>
               </a:ext>
             </a:extLst>
           </p:cNvPr>
@@ -12104,7 +12104,7 @@
           <p:cNvPr id="3" name="">
             <a:extLst xmlns:a="http://schemas.openxmlformats.org/drawingml/2006/main">
               <a:ext uri="{FF2B5EF4-FFF2-40B4-BE49-F238E27FC236}">
-                <a16:creationId xmlns:a16="http://schemas.microsoft.com/office/drawing/2014/main" id="{A7A7C610-F753-483F-9C4C-D3481C12EDA7}"/>
+                <a16:creationId xmlns:a16="http://schemas.microsoft.com/office/drawing/2014/main" id="{787B4CDE-737D-4A20-84C8-8F7001A31368}"/>
               </a:ext>
             </a:extLst>
           </p:cNvPr>
@@ -12158,7 +12158,7 @@
                 <a:ea typeface="Malgun Gothic"/>
                 <a:cs typeface="Malgun Gothic"/>
               </a:rPr>
-              <a:t>영상 4 유효한 특이 행동</a:t>
+              <a:t>영상 4 패턴 스킵성 플레이</a:t>
             </a:r>
           </a:p>
         </p:txBody>
@@ -12168,7 +12168,7 @@
           <p:cNvPr id="4" name="">
             <a:extLst xmlns:a="http://schemas.openxmlformats.org/drawingml/2006/main">
               <a:ext uri="{FF2B5EF4-FFF2-40B4-BE49-F238E27FC236}">
-                <a16:creationId xmlns:a16="http://schemas.microsoft.com/office/drawing/2014/main" id="{C717A070-DB68-4065-9A75-60C88892F9D6}"/>
+                <a16:creationId xmlns:a16="http://schemas.microsoft.com/office/drawing/2014/main" id="{FAA7650D-3C6F-4AD8-AF6F-60D8DAA13FD2}"/>
               </a:ext>
             </a:extLst>
           </p:cNvPr>
@@ -12222,7 +12222,7 @@
                 <a:ea typeface="Malgun Gothic"/>
                 <a:cs typeface="Malgun Gothic"/>
               </a:rPr>
-              <a:t>꼼수처럼 보여도 규칙상 정상인 edge behavior</a:t>
+              <a:t>패턴 스킵처럼 보이는 버그성 장면은 성공 근거와 분리</a:t>
             </a:r>
           </a:p>
         </p:txBody>
@@ -12232,7 +12232,7 @@
           <p:cNvPr id="5" name="">
             <a:extLst xmlns:a="http://schemas.openxmlformats.org/drawingml/2006/main">
               <a:ext uri="{FF2B5EF4-FFF2-40B4-BE49-F238E27FC236}">
-                <a16:creationId xmlns:a16="http://schemas.microsoft.com/office/drawing/2014/main" id="{BDCC1EE9-8AFE-43A4-B0DB-67951DF28D28}"/>
+                <a16:creationId xmlns:a16="http://schemas.microsoft.com/office/drawing/2014/main" id="{A62D6949-2EB8-4A02-A0CF-35D96D3B46F7}"/>
               </a:ext>
             </a:extLst>
           </p:cNvPr>
@@ -12265,7 +12265,7 @@
           <p:cNvPr id="6" name="">
             <a:extLst xmlns:a="http://schemas.openxmlformats.org/drawingml/2006/main">
               <a:ext uri="{FF2B5EF4-FFF2-40B4-BE49-F238E27FC236}">
-                <a16:creationId xmlns:a16="http://schemas.microsoft.com/office/drawing/2014/main" id="{100566C8-DCA0-4D14-BA54-49B2081C5C31}"/>
+                <a16:creationId xmlns:a16="http://schemas.microsoft.com/office/drawing/2014/main" id="{47F45ADF-FEC0-43BA-8EFF-A7CF7B3369CA}"/>
               </a:ext>
             </a:extLst>
           </p:cNvPr>
@@ -12298,7 +12298,7 @@
           <p:cNvPr id="7" name="">
             <a:extLst xmlns:a="http://schemas.openxmlformats.org/drawingml/2006/main">
               <a:ext uri="{FF2B5EF4-FFF2-40B4-BE49-F238E27FC236}">
-                <a16:creationId xmlns:a16="http://schemas.microsoft.com/office/drawing/2014/main" id="{6539FEB8-2265-4D47-B536-62261C5325ED}"/>
+                <a16:creationId xmlns:a16="http://schemas.microsoft.com/office/drawing/2014/main" id="{ADAF8625-7643-4929-9849-88E6036CD0D9}"/>
               </a:ext>
             </a:extLst>
           </p:cNvPr>
@@ -12362,7 +12362,7 @@
           <p:cNvPr id="8" name="">
             <a:extLst xmlns:a="http://schemas.openxmlformats.org/drawingml/2006/main">
               <a:ext uri="{FF2B5EF4-FFF2-40B4-BE49-F238E27FC236}">
-                <a16:creationId xmlns:a16="http://schemas.microsoft.com/office/drawing/2014/main" id="{BD118551-7354-497A-A267-5747C3FF8C0A}"/>
+                <a16:creationId xmlns:a16="http://schemas.microsoft.com/office/drawing/2014/main" id="{E588A5B1-34A8-45BB-8572-F4E7060664EE}"/>
               </a:ext>
             </a:extLst>
           </p:cNvPr>
@@ -12395,7 +12395,7 @@
           <p:cNvPr id="9" name="">
             <a:extLst xmlns:a="http://schemas.openxmlformats.org/drawingml/2006/main">
               <a:ext uri="{FF2B5EF4-FFF2-40B4-BE49-F238E27FC236}">
-                <a16:creationId xmlns:a16="http://schemas.microsoft.com/office/drawing/2014/main" id="{0B978200-EEF9-44A9-B5CB-74750E5E5AA8}"/>
+                <a16:creationId xmlns:a16="http://schemas.microsoft.com/office/drawing/2014/main" id="{540D5B23-D94E-4D82-8703-A83733AF466B}"/>
               </a:ext>
             </a:extLst>
           </p:cNvPr>
@@ -12449,7 +12449,7 @@
                 <a:ea typeface="Malgun Gothic"/>
                 <a:cs typeface="Malgun Gothic"/>
               </a:rPr>
-              <a:t>root_visible_overlap</a:t>
+              <a:t>일부 패턴 생략처럼 보이는 빠른 클리어</a:t>
             </a:r>
           </a:p>
         </p:txBody>
@@ -12459,7 +12459,7 @@
           <p:cNvPr id="10" name="">
             <a:extLst xmlns:a="http://schemas.openxmlformats.org/drawingml/2006/main">
               <a:ext uri="{FF2B5EF4-FFF2-40B4-BE49-F238E27FC236}">
-                <a16:creationId xmlns:a16="http://schemas.microsoft.com/office/drawing/2014/main" id="{16551D17-7583-4768-A4C9-A103708E4EF8}"/>
+                <a16:creationId xmlns:a16="http://schemas.microsoft.com/office/drawing/2014/main" id="{879F76FA-AEE3-4F51-AE51-9651603C207A}"/>
               </a:ext>
             </a:extLst>
           </p:cNvPr>
@@ -12492,7 +12492,7 @@
           <p:cNvPr id="11" name="">
             <a:extLst xmlns:a="http://schemas.openxmlformats.org/drawingml/2006/main">
               <a:ext uri="{FF2B5EF4-FFF2-40B4-BE49-F238E27FC236}">
-                <a16:creationId xmlns:a16="http://schemas.microsoft.com/office/drawing/2014/main" id="{9B8A43ED-C3F4-4ADA-8D70-FA608A9C7544}"/>
+                <a16:creationId xmlns:a16="http://schemas.microsoft.com/office/drawing/2014/main" id="{D5F19D5D-7711-4AB8-8246-CD8132A57D4C}"/>
               </a:ext>
             </a:extLst>
           </p:cNvPr>
@@ -12546,7 +12546,7 @@
                 <a:ea typeface="Malgun Gothic"/>
                 <a:cs typeface="Malgun Gothic"/>
               </a:rPr>
-              <a:t>dash_current_overlap</a:t>
+              <a:t>root_visible_overlap</a:t>
             </a:r>
           </a:p>
         </p:txBody>
@@ -12556,7 +12556,7 @@
           <p:cNvPr id="12" name="">
             <a:extLst xmlns:a="http://schemas.openxmlformats.org/drawingml/2006/main">
               <a:ext uri="{FF2B5EF4-FFF2-40B4-BE49-F238E27FC236}">
-                <a16:creationId xmlns:a16="http://schemas.microsoft.com/office/drawing/2014/main" id="{F1A3E725-B373-489B-99B8-95771CB4DF46}"/>
+                <a16:creationId xmlns:a16="http://schemas.microsoft.com/office/drawing/2014/main" id="{A95C187C-8C8F-4F31-91F4-0EF1E3ED8838}"/>
               </a:ext>
             </a:extLst>
           </p:cNvPr>
@@ -12589,7 +12589,7 @@
           <p:cNvPr id="13" name="">
             <a:extLst xmlns:a="http://schemas.openxmlformats.org/drawingml/2006/main">
               <a:ext uri="{FF2B5EF4-FFF2-40B4-BE49-F238E27FC236}">
-                <a16:creationId xmlns:a16="http://schemas.microsoft.com/office/drawing/2014/main" id="{C0A831C2-88F1-4297-A4C9-9A7E79764216}"/>
+                <a16:creationId xmlns:a16="http://schemas.microsoft.com/office/drawing/2014/main" id="{72217853-FF36-476C-BFE1-14624C255032}"/>
               </a:ext>
             </a:extLst>
           </p:cNvPr>
@@ -12643,7 +12643,7 @@
                 <a:ea typeface="Malgun Gothic"/>
                 <a:cs typeface="Malgun Gothic"/>
               </a:rPr>
-              <a:t>warning edge 운영</a:t>
+              <a:t>dash_current_overlap</a:t>
             </a:r>
           </a:p>
         </p:txBody>
@@ -12653,7 +12653,7 @@
           <p:cNvPr id="14" name="">
             <a:extLst xmlns:a="http://schemas.openxmlformats.org/drawingml/2006/main">
               <a:ext uri="{FF2B5EF4-FFF2-40B4-BE49-F238E27FC236}">
-                <a16:creationId xmlns:a16="http://schemas.microsoft.com/office/drawing/2014/main" id="{BEDF0454-CA89-4DE4-85C9-1D48095D0DA5}"/>
+                <a16:creationId xmlns:a16="http://schemas.microsoft.com/office/drawing/2014/main" id="{0D4B42C8-464D-43FA-A7D9-A057FDF7640C}"/>
               </a:ext>
             </a:extLst>
           </p:cNvPr>
@@ -12686,7 +12686,7 @@
           <p:cNvPr id="15" name="">
             <a:extLst xmlns:a="http://schemas.openxmlformats.org/drawingml/2006/main">
               <a:ext uri="{FF2B5EF4-FFF2-40B4-BE49-F238E27FC236}">
-                <a16:creationId xmlns:a16="http://schemas.microsoft.com/office/drawing/2014/main" id="{82007D77-6966-4F1B-ACAD-7E14602883CB}"/>
+                <a16:creationId xmlns:a16="http://schemas.microsoft.com/office/drawing/2014/main" id="{120969E6-8093-496D-886A-B9C5660B07FA}"/>
               </a:ext>
             </a:extLst>
           </p:cNvPr>
@@ -12740,7 +12740,7 @@
                 <a:ea typeface="Malgun Gothic"/>
                 <a:cs typeface="Malgun Gothic"/>
               </a:rPr>
-              <a:t>현재 target gate 기준 정상 행동</a:t>
+              <a:t>현재 leak 0 근거상 exploit 확정 아님</a:t>
             </a:r>
           </a:p>
         </p:txBody>
@@ -12750,7 +12750,7 @@
           <p:cNvPr id="16" name="">
             <a:extLst xmlns:a="http://schemas.openxmlformats.org/drawingml/2006/main">
               <a:ext uri="{FF2B5EF4-FFF2-40B4-BE49-F238E27FC236}">
-                <a16:creationId xmlns:a16="http://schemas.microsoft.com/office/drawing/2014/main" id="{61E1E683-6456-45D1-9B06-0F3C9AF28249}"/>
+                <a16:creationId xmlns:a16="http://schemas.microsoft.com/office/drawing/2014/main" id="{FA11CC21-83CB-4689-91D5-0AE85596039C}"/>
               </a:ext>
             </a:extLst>
           </p:cNvPr>
@@ -12783,7 +12783,7 @@
           <p:cNvPr id="17" name="">
             <a:extLst xmlns:a="http://schemas.openxmlformats.org/drawingml/2006/main">
               <a:ext uri="{FF2B5EF4-FFF2-40B4-BE49-F238E27FC236}">
-                <a16:creationId xmlns:a16="http://schemas.microsoft.com/office/drawing/2014/main" id="{F33C58A5-FF47-485A-9CE6-2FAE953C26B5}"/>
+                <a16:creationId xmlns:a16="http://schemas.microsoft.com/office/drawing/2014/main" id="{8A042DAB-F9F5-47C5-BD86-666B9464247B}"/>
               </a:ext>
             </a:extLst>
           </p:cNvPr>
@@ -12837,7 +12837,7 @@
                 <a:ea typeface="Malgun Gothic"/>
                 <a:cs typeface="Malgun Gothic"/>
               </a:rPr>
-              <a:t>bug 또는 exploit로 명명 금지</a:t>
+              <a:t>bug case 명명 금지</a:t>
             </a:r>
           </a:p>
         </p:txBody>
@@ -12847,7 +12847,7 @@
           <p:cNvPr id="18" name="">
             <a:extLst xmlns:a="http://schemas.openxmlformats.org/drawingml/2006/main">
               <a:ext uri="{FF2B5EF4-FFF2-40B4-BE49-F238E27FC236}">
-                <a16:creationId xmlns:a16="http://schemas.microsoft.com/office/drawing/2014/main" id="{3932C213-D59C-40C6-9962-0289901D5E2B}"/>
+                <a16:creationId xmlns:a16="http://schemas.microsoft.com/office/drawing/2014/main" id="{AA26C74A-B109-482C-A90C-0DE983D4385B}"/>
               </a:ext>
             </a:extLst>
           </p:cNvPr>
@@ -12911,7 +12911,7 @@
           <p:cNvPr id="19" name="">
             <a:extLst xmlns:a="http://schemas.openxmlformats.org/drawingml/2006/main">
               <a:ext uri="{FF2B5EF4-FFF2-40B4-BE49-F238E27FC236}">
-                <a16:creationId xmlns:a16="http://schemas.microsoft.com/office/drawing/2014/main" id="{6FE58B3F-6020-4E6E-A01F-D8503A487D82}"/>
+                <a16:creationId xmlns:a16="http://schemas.microsoft.com/office/drawing/2014/main" id="{88BC17E4-FDA1-4880-A259-909F128A921A}"/>
               </a:ext>
             </a:extLst>
           </p:cNvPr>
@@ -12973,7 +12973,7 @@
     </p:spTree>
     <p:extLst>
       <p:ext uri="{BB962C8B-B14F-4D97-AF65-F5344CB8AC3E}">
-        <p14:creationId xmlns:p14="http://schemas.microsoft.com/office/powerpoint/2010/main" val="1634464185"/>
+        <p14:creationId xmlns:p14="http://schemas.microsoft.com/office/powerpoint/2010/main" val="528023655"/>
       </p:ext>
     </p:extLst>
   </p:cSld>
@@ -12997,7 +12997,7 @@
           <p:cNvPr id="1" name="">
             <a:extLst xmlns:a="http://schemas.openxmlformats.org/drawingml/2006/main">
               <a:ext uri="{FF2B5EF4-FFF2-40B4-BE49-F238E27FC236}">
-                <a16:creationId xmlns:a16="http://schemas.microsoft.com/office/drawing/2014/main" id="{8B3142E2-29D1-4551-9EFD-46285C63E0F5}"/>
+                <a16:creationId xmlns:a16="http://schemas.microsoft.com/office/drawing/2014/main" id="{1AE45794-4BC3-438A-9895-1701789A9D00}"/>
               </a:ext>
             </a:extLst>
           </p:cNvPr>
@@ -13030,7 +13030,7 @@
           <p:cNvPr id="2" name="">
             <a:extLst xmlns:a="http://schemas.openxmlformats.org/drawingml/2006/main">
               <a:ext uri="{FF2B5EF4-FFF2-40B4-BE49-F238E27FC236}">
-                <a16:creationId xmlns:a16="http://schemas.microsoft.com/office/drawing/2014/main" id="{F70AA978-6FC9-4503-B26A-49E391C95A59}"/>
+                <a16:creationId xmlns:a16="http://schemas.microsoft.com/office/drawing/2014/main" id="{DC13A9AA-13AA-47E0-A53E-8930B788888F}"/>
               </a:ext>
             </a:extLst>
           </p:cNvPr>
@@ -13063,7 +13063,7 @@
           <p:cNvPr id="3" name="">
             <a:extLst xmlns:a="http://schemas.openxmlformats.org/drawingml/2006/main">
               <a:ext uri="{FF2B5EF4-FFF2-40B4-BE49-F238E27FC236}">
-                <a16:creationId xmlns:a16="http://schemas.microsoft.com/office/drawing/2014/main" id="{D3E905DF-2800-41AD-8E2F-9BC8E7B5B6EE}"/>
+                <a16:creationId xmlns:a16="http://schemas.microsoft.com/office/drawing/2014/main" id="{C112AC60-DD28-4F77-9133-C05C98B971EC}"/>
               </a:ext>
             </a:extLst>
           </p:cNvPr>
@@ -13127,7 +13127,7 @@
           <p:cNvPr id="4" name="">
             <a:extLst xmlns:a="http://schemas.openxmlformats.org/drawingml/2006/main">
               <a:ext uri="{FF2B5EF4-FFF2-40B4-BE49-F238E27FC236}">
-                <a16:creationId xmlns:a16="http://schemas.microsoft.com/office/drawing/2014/main" id="{01D750CE-0651-4896-B6B8-0051D788B52A}"/>
+                <a16:creationId xmlns:a16="http://schemas.microsoft.com/office/drawing/2014/main" id="{8CC2279C-368B-4007-87EA-4AE24C854D66}"/>
               </a:ext>
             </a:extLst>
           </p:cNvPr>
@@ -13191,7 +13191,7 @@
           <p:cNvPr id="5" name="">
             <a:extLst xmlns:a="http://schemas.openxmlformats.org/drawingml/2006/main">
               <a:ext uri="{FF2B5EF4-FFF2-40B4-BE49-F238E27FC236}">
-                <a16:creationId xmlns:a16="http://schemas.microsoft.com/office/drawing/2014/main" id="{A3649152-2188-4CFB-A39C-3FD3B4ABB6F3}"/>
+                <a16:creationId xmlns:a16="http://schemas.microsoft.com/office/drawing/2014/main" id="{A91487E0-5F01-4A3B-B4BC-8B2886489A0D}"/>
               </a:ext>
             </a:extLst>
           </p:cNvPr>
@@ -13224,7 +13224,7 @@
           <p:cNvPr id="6" name="">
             <a:extLst xmlns:a="http://schemas.openxmlformats.org/drawingml/2006/main">
               <a:ext uri="{FF2B5EF4-FFF2-40B4-BE49-F238E27FC236}">
-                <a16:creationId xmlns:a16="http://schemas.microsoft.com/office/drawing/2014/main" id="{1A8546C5-AD15-4613-B5E6-B74F054AFAB5}"/>
+                <a16:creationId xmlns:a16="http://schemas.microsoft.com/office/drawing/2014/main" id="{5A44A194-AAF2-4EA7-813D-8AA3C414C8D9}"/>
               </a:ext>
             </a:extLst>
           </p:cNvPr>
@@ -13257,7 +13257,7 @@
           <p:cNvPr id="7" name="">
             <a:extLst xmlns:a="http://schemas.openxmlformats.org/drawingml/2006/main">
               <a:ext uri="{FF2B5EF4-FFF2-40B4-BE49-F238E27FC236}">
-                <a16:creationId xmlns:a16="http://schemas.microsoft.com/office/drawing/2014/main" id="{C809414A-415D-4355-8FB9-3786ED8A3A9A}"/>
+                <a16:creationId xmlns:a16="http://schemas.microsoft.com/office/drawing/2014/main" id="{36904762-68BF-4B68-B2EF-6D1AA9DC5687}"/>
               </a:ext>
             </a:extLst>
           </p:cNvPr>
@@ -13321,7 +13321,7 @@
           <p:cNvPr id="8" name="">
             <a:extLst xmlns:a="http://schemas.openxmlformats.org/drawingml/2006/main">
               <a:ext uri="{FF2B5EF4-FFF2-40B4-BE49-F238E27FC236}">
-                <a16:creationId xmlns:a16="http://schemas.microsoft.com/office/drawing/2014/main" id="{6E07D6B4-EE7A-42D6-9518-7D297E01A0E6}"/>
+                <a16:creationId xmlns:a16="http://schemas.microsoft.com/office/drawing/2014/main" id="{58FD8056-8EB8-4D44-801C-8D409766005F}"/>
               </a:ext>
             </a:extLst>
           </p:cNvPr>
@@ -13354,7 +13354,7 @@
           <p:cNvPr id="9" name="">
             <a:extLst xmlns:a="http://schemas.openxmlformats.org/drawingml/2006/main">
               <a:ext uri="{FF2B5EF4-FFF2-40B4-BE49-F238E27FC236}">
-                <a16:creationId xmlns:a16="http://schemas.microsoft.com/office/drawing/2014/main" id="{A0B5354D-51AB-4BB5-9A5A-0E0FF3424D7B}"/>
+                <a16:creationId xmlns:a16="http://schemas.microsoft.com/office/drawing/2014/main" id="{B88FBCC1-FD02-41E5-BAE8-0B026DA437B4}"/>
               </a:ext>
             </a:extLst>
           </p:cNvPr>
@@ -13418,7 +13418,7 @@
           <p:cNvPr id="10" name="">
             <a:extLst xmlns:a="http://schemas.openxmlformats.org/drawingml/2006/main">
               <a:ext uri="{FF2B5EF4-FFF2-40B4-BE49-F238E27FC236}">
-                <a16:creationId xmlns:a16="http://schemas.microsoft.com/office/drawing/2014/main" id="{A4ADB77F-7BB0-4C0D-BA04-CFE7262D9E17}"/>
+                <a16:creationId xmlns:a16="http://schemas.microsoft.com/office/drawing/2014/main" id="{21B0ADD6-5A60-4872-B4D0-1CDA9C66423C}"/>
               </a:ext>
             </a:extLst>
           </p:cNvPr>
@@ -13451,7 +13451,7 @@
           <p:cNvPr id="11" name="">
             <a:extLst xmlns:a="http://schemas.openxmlformats.org/drawingml/2006/main">
               <a:ext uri="{FF2B5EF4-FFF2-40B4-BE49-F238E27FC236}">
-                <a16:creationId xmlns:a16="http://schemas.microsoft.com/office/drawing/2014/main" id="{14B97D45-4A1B-46BF-BA26-F147140E3AF6}"/>
+                <a16:creationId xmlns:a16="http://schemas.microsoft.com/office/drawing/2014/main" id="{31DF5A08-343C-455F-80E9-30CB5BFF9579}"/>
               </a:ext>
             </a:extLst>
           </p:cNvPr>
@@ -13515,7 +13515,7 @@
           <p:cNvPr id="12" name="">
             <a:extLst xmlns:a="http://schemas.openxmlformats.org/drawingml/2006/main">
               <a:ext uri="{FF2B5EF4-FFF2-40B4-BE49-F238E27FC236}">
-                <a16:creationId xmlns:a16="http://schemas.microsoft.com/office/drawing/2014/main" id="{A1F86447-6A5D-4E64-886A-EACE2C7D6689}"/>
+                <a16:creationId xmlns:a16="http://schemas.microsoft.com/office/drawing/2014/main" id="{2A3FA4F3-A687-4FA9-AD8A-C31921D4013E}"/>
               </a:ext>
             </a:extLst>
           </p:cNvPr>
@@ -13548,7 +13548,7 @@
           <p:cNvPr id="13" name="">
             <a:extLst xmlns:a="http://schemas.openxmlformats.org/drawingml/2006/main">
               <a:ext uri="{FF2B5EF4-FFF2-40B4-BE49-F238E27FC236}">
-                <a16:creationId xmlns:a16="http://schemas.microsoft.com/office/drawing/2014/main" id="{077E59FE-0843-4D03-9434-66C491ADD750}"/>
+                <a16:creationId xmlns:a16="http://schemas.microsoft.com/office/drawing/2014/main" id="{E22F875A-BBB8-4827-8C47-A1D5A758B7DC}"/>
               </a:ext>
             </a:extLst>
           </p:cNvPr>
@@ -13612,7 +13612,7 @@
           <p:cNvPr id="14" name="">
             <a:extLst xmlns:a="http://schemas.openxmlformats.org/drawingml/2006/main">
               <a:ext uri="{FF2B5EF4-FFF2-40B4-BE49-F238E27FC236}">
-                <a16:creationId xmlns:a16="http://schemas.microsoft.com/office/drawing/2014/main" id="{CF2C6626-3814-40CA-AC9C-121A0124E573}"/>
+                <a16:creationId xmlns:a16="http://schemas.microsoft.com/office/drawing/2014/main" id="{09E2D54D-FF7F-4767-98C3-8978A046AF10}"/>
               </a:ext>
             </a:extLst>
           </p:cNvPr>
@@ -13645,7 +13645,7 @@
           <p:cNvPr id="15" name="">
             <a:extLst xmlns:a="http://schemas.openxmlformats.org/drawingml/2006/main">
               <a:ext uri="{FF2B5EF4-FFF2-40B4-BE49-F238E27FC236}">
-                <a16:creationId xmlns:a16="http://schemas.microsoft.com/office/drawing/2014/main" id="{DC9476EC-71FF-4443-9579-3B0E8E0ED52E}"/>
+                <a16:creationId xmlns:a16="http://schemas.microsoft.com/office/drawing/2014/main" id="{50FEF18F-5299-4B81-A664-EE1AF5429855}"/>
               </a:ext>
             </a:extLst>
           </p:cNvPr>
@@ -13709,7 +13709,7 @@
           <p:cNvPr id="16" name="">
             <a:extLst xmlns:a="http://schemas.openxmlformats.org/drawingml/2006/main">
               <a:ext uri="{FF2B5EF4-FFF2-40B4-BE49-F238E27FC236}">
-                <a16:creationId xmlns:a16="http://schemas.microsoft.com/office/drawing/2014/main" id="{EF713B34-4165-4A5C-83F9-39045B3AB57C}"/>
+                <a16:creationId xmlns:a16="http://schemas.microsoft.com/office/drawing/2014/main" id="{CD2C5A8B-15FF-475B-812B-3728FBAA9A08}"/>
               </a:ext>
             </a:extLst>
           </p:cNvPr>
@@ -13742,7 +13742,7 @@
           <p:cNvPr id="17" name="">
             <a:extLst xmlns:a="http://schemas.openxmlformats.org/drawingml/2006/main">
               <a:ext uri="{FF2B5EF4-FFF2-40B4-BE49-F238E27FC236}">
-                <a16:creationId xmlns:a16="http://schemas.microsoft.com/office/drawing/2014/main" id="{47AF7A7E-73E7-457D-822A-8194244C40A3}"/>
+                <a16:creationId xmlns:a16="http://schemas.microsoft.com/office/drawing/2014/main" id="{53C84DA1-5E26-4CA0-99E0-2371F9F1AD59}"/>
               </a:ext>
             </a:extLst>
           </p:cNvPr>
@@ -13806,7 +13806,7 @@
           <p:cNvPr id="18" name="">
             <a:extLst xmlns:a="http://schemas.openxmlformats.org/drawingml/2006/main">
               <a:ext uri="{FF2B5EF4-FFF2-40B4-BE49-F238E27FC236}">
-                <a16:creationId xmlns:a16="http://schemas.microsoft.com/office/drawing/2014/main" id="{0096FF51-2B86-4718-BCFC-90CEDA547D90}"/>
+                <a16:creationId xmlns:a16="http://schemas.microsoft.com/office/drawing/2014/main" id="{E1BC8CA2-0BF7-4E50-885B-42A7BAF56EC6}"/>
               </a:ext>
             </a:extLst>
           </p:cNvPr>
@@ -13870,7 +13870,7 @@
           <p:cNvPr id="19" name="">
             <a:extLst xmlns:a="http://schemas.openxmlformats.org/drawingml/2006/main">
               <a:ext uri="{FF2B5EF4-FFF2-40B4-BE49-F238E27FC236}">
-                <a16:creationId xmlns:a16="http://schemas.microsoft.com/office/drawing/2014/main" id="{AC3F0EE2-E512-4958-B87A-05A1D5CB455F}"/>
+                <a16:creationId xmlns:a16="http://schemas.microsoft.com/office/drawing/2014/main" id="{EEA2269F-176F-4FDB-A22F-8B34A012FB29}"/>
               </a:ext>
             </a:extLst>
           </p:cNvPr>
@@ -13932,7 +13932,7 @@
     </p:spTree>
     <p:extLst>
       <p:ext uri="{BB962C8B-B14F-4D97-AF65-F5344CB8AC3E}">
-        <p14:creationId xmlns:p14="http://schemas.microsoft.com/office/powerpoint/2010/main" val="2037464340"/>
+        <p14:creationId xmlns:p14="http://schemas.microsoft.com/office/powerpoint/2010/main" val="1052870523"/>
       </p:ext>
     </p:extLst>
   </p:cSld>
@@ -13956,7 +13956,7 @@
           <p:cNvPr id="1" name="">
             <a:extLst xmlns:a="http://schemas.openxmlformats.org/drawingml/2006/main">
               <a:ext uri="{FF2B5EF4-FFF2-40B4-BE49-F238E27FC236}">
-                <a16:creationId xmlns:a16="http://schemas.microsoft.com/office/drawing/2014/main" id="{FF8590E7-B063-4E09-B137-B24F1FD9978D}"/>
+                <a16:creationId xmlns:a16="http://schemas.microsoft.com/office/drawing/2014/main" id="{787B3432-076A-46A1-BE20-7437DCF0264E}"/>
               </a:ext>
             </a:extLst>
           </p:cNvPr>
@@ -13989,7 +13989,7 @@
           <p:cNvPr id="2" name="">
             <a:extLst xmlns:a="http://schemas.openxmlformats.org/drawingml/2006/main">
               <a:ext uri="{FF2B5EF4-FFF2-40B4-BE49-F238E27FC236}">
-                <a16:creationId xmlns:a16="http://schemas.microsoft.com/office/drawing/2014/main" id="{0F52C0EB-2C0C-4CF9-984A-AC1A27A12165}"/>
+                <a16:creationId xmlns:a16="http://schemas.microsoft.com/office/drawing/2014/main" id="{3F736E40-89F3-49F4-867D-0EB7BF769E7F}"/>
               </a:ext>
             </a:extLst>
           </p:cNvPr>
@@ -14022,7 +14022,7 @@
           <p:cNvPr id="3" name="">
             <a:extLst xmlns:a="http://schemas.openxmlformats.org/drawingml/2006/main">
               <a:ext uri="{FF2B5EF4-FFF2-40B4-BE49-F238E27FC236}">
-                <a16:creationId xmlns:a16="http://schemas.microsoft.com/office/drawing/2014/main" id="{D088B038-E8B4-4875-826F-5508C327CF71}"/>
+                <a16:creationId xmlns:a16="http://schemas.microsoft.com/office/drawing/2014/main" id="{107A180B-0B42-481B-887E-5FF1C13B362F}"/>
               </a:ext>
             </a:extLst>
           </p:cNvPr>
@@ -14086,7 +14086,7 @@
           <p:cNvPr id="4" name="">
             <a:extLst xmlns:a="http://schemas.openxmlformats.org/drawingml/2006/main">
               <a:ext uri="{FF2B5EF4-FFF2-40B4-BE49-F238E27FC236}">
-                <a16:creationId xmlns:a16="http://schemas.microsoft.com/office/drawing/2014/main" id="{E0BCCBE3-395C-4070-92DB-F9B4252DE5E1}"/>
+                <a16:creationId xmlns:a16="http://schemas.microsoft.com/office/drawing/2014/main" id="{01E7CEBC-7B50-45C0-AB5B-D428B15B84E8}"/>
               </a:ext>
             </a:extLst>
           </p:cNvPr>
@@ -14150,7 +14150,7 @@
           <p:cNvPr id="5" name="">
             <a:extLst xmlns:a="http://schemas.openxmlformats.org/drawingml/2006/main">
               <a:ext uri="{FF2B5EF4-FFF2-40B4-BE49-F238E27FC236}">
-                <a16:creationId xmlns:a16="http://schemas.microsoft.com/office/drawing/2014/main" id="{8E94C293-C152-4462-A596-FF74893A727E}"/>
+                <a16:creationId xmlns:a16="http://schemas.microsoft.com/office/drawing/2014/main" id="{CA00E382-8D63-4DE1-BE25-6C55041F8AAF}"/>
               </a:ext>
             </a:extLst>
           </p:cNvPr>
@@ -14183,7 +14183,7 @@
           <p:cNvPr id="6" name="">
             <a:extLst xmlns:a="http://schemas.openxmlformats.org/drawingml/2006/main">
               <a:ext uri="{FF2B5EF4-FFF2-40B4-BE49-F238E27FC236}">
-                <a16:creationId xmlns:a16="http://schemas.microsoft.com/office/drawing/2014/main" id="{2A570640-C8AB-41DC-B96A-07E6058B14ED}"/>
+                <a16:creationId xmlns:a16="http://schemas.microsoft.com/office/drawing/2014/main" id="{946C4997-3C99-4D92-85D7-041A48141A14}"/>
               </a:ext>
             </a:extLst>
           </p:cNvPr>
@@ -14216,7 +14216,7 @@
           <p:cNvPr id="7" name="">
             <a:extLst xmlns:a="http://schemas.openxmlformats.org/drawingml/2006/main">
               <a:ext uri="{FF2B5EF4-FFF2-40B4-BE49-F238E27FC236}">
-                <a16:creationId xmlns:a16="http://schemas.microsoft.com/office/drawing/2014/main" id="{A2C8D03F-0608-4E9F-ADCB-F6CD38D01E5F}"/>
+                <a16:creationId xmlns:a16="http://schemas.microsoft.com/office/drawing/2014/main" id="{B7489536-3E2F-4AC3-AD36-4C1E3609A91D}"/>
               </a:ext>
             </a:extLst>
           </p:cNvPr>
@@ -14280,7 +14280,7 @@
           <p:cNvPr id="8" name="">
             <a:extLst xmlns:a="http://schemas.openxmlformats.org/drawingml/2006/main">
               <a:ext uri="{FF2B5EF4-FFF2-40B4-BE49-F238E27FC236}">
-                <a16:creationId xmlns:a16="http://schemas.microsoft.com/office/drawing/2014/main" id="{27C6216F-1B4E-431D-BC68-BB07C4BE309E}"/>
+                <a16:creationId xmlns:a16="http://schemas.microsoft.com/office/drawing/2014/main" id="{269DA442-2A8D-4A4E-9146-ADE502400FBE}"/>
               </a:ext>
             </a:extLst>
           </p:cNvPr>
@@ -14313,7 +14313,7 @@
           <p:cNvPr id="9" name="">
             <a:extLst xmlns:a="http://schemas.openxmlformats.org/drawingml/2006/main">
               <a:ext uri="{FF2B5EF4-FFF2-40B4-BE49-F238E27FC236}">
-                <a16:creationId xmlns:a16="http://schemas.microsoft.com/office/drawing/2014/main" id="{7D8AAFDD-B9D9-413A-AD37-1ABD8A325E18}"/>
+                <a16:creationId xmlns:a16="http://schemas.microsoft.com/office/drawing/2014/main" id="{1767D87C-FA1C-45EA-A9DC-5A3D74E3DA02}"/>
               </a:ext>
             </a:extLst>
           </p:cNvPr>
@@ -14377,7 +14377,7 @@
           <p:cNvPr id="10" name="">
             <a:extLst xmlns:a="http://schemas.openxmlformats.org/drawingml/2006/main">
               <a:ext uri="{FF2B5EF4-FFF2-40B4-BE49-F238E27FC236}">
-                <a16:creationId xmlns:a16="http://schemas.microsoft.com/office/drawing/2014/main" id="{D2F616A5-57EC-412A-9E11-BE0B540C6BF5}"/>
+                <a16:creationId xmlns:a16="http://schemas.microsoft.com/office/drawing/2014/main" id="{372A0B9D-7077-4F37-8F25-31338F68D46A}"/>
               </a:ext>
             </a:extLst>
           </p:cNvPr>
@@ -14410,7 +14410,7 @@
           <p:cNvPr id="11" name="">
             <a:extLst xmlns:a="http://schemas.openxmlformats.org/drawingml/2006/main">
               <a:ext uri="{FF2B5EF4-FFF2-40B4-BE49-F238E27FC236}">
-                <a16:creationId xmlns:a16="http://schemas.microsoft.com/office/drawing/2014/main" id="{6BC343DF-FEE1-49BD-94CA-98CB1F37B78F}"/>
+                <a16:creationId xmlns:a16="http://schemas.microsoft.com/office/drawing/2014/main" id="{190DAF7B-F636-4B08-8BB3-47AF45F796FF}"/>
               </a:ext>
             </a:extLst>
           </p:cNvPr>
@@ -14474,7 +14474,7 @@
           <p:cNvPr id="12" name="">
             <a:extLst xmlns:a="http://schemas.openxmlformats.org/drawingml/2006/main">
               <a:ext uri="{FF2B5EF4-FFF2-40B4-BE49-F238E27FC236}">
-                <a16:creationId xmlns:a16="http://schemas.microsoft.com/office/drawing/2014/main" id="{91DC2BC9-A949-4E5F-A416-5A4BCFE63341}"/>
+                <a16:creationId xmlns:a16="http://schemas.microsoft.com/office/drawing/2014/main" id="{EA45F971-FA0D-4B94-8E0B-CA7E8DC89DD9}"/>
               </a:ext>
             </a:extLst>
           </p:cNvPr>
@@ -14507,7 +14507,7 @@
           <p:cNvPr id="13" name="">
             <a:extLst xmlns:a="http://schemas.openxmlformats.org/drawingml/2006/main">
               <a:ext uri="{FF2B5EF4-FFF2-40B4-BE49-F238E27FC236}">
-                <a16:creationId xmlns:a16="http://schemas.microsoft.com/office/drawing/2014/main" id="{1CE3AE8D-C58C-43FB-B953-6B2BC65D8272}"/>
+                <a16:creationId xmlns:a16="http://schemas.microsoft.com/office/drawing/2014/main" id="{39A47CF0-4D50-44EC-AB0E-397B0D70BB05}"/>
               </a:ext>
             </a:extLst>
           </p:cNvPr>
@@ -14571,7 +14571,7 @@
           <p:cNvPr id="14" name="">
             <a:extLst xmlns:a="http://schemas.openxmlformats.org/drawingml/2006/main">
               <a:ext uri="{FF2B5EF4-FFF2-40B4-BE49-F238E27FC236}">
-                <a16:creationId xmlns:a16="http://schemas.microsoft.com/office/drawing/2014/main" id="{82D797C2-6042-4F92-9841-4176692FF8C3}"/>
+                <a16:creationId xmlns:a16="http://schemas.microsoft.com/office/drawing/2014/main" id="{B3579ABF-D324-4228-8104-86C5459D3F12}"/>
               </a:ext>
             </a:extLst>
           </p:cNvPr>
@@ -14604,7 +14604,7 @@
           <p:cNvPr id="15" name="">
             <a:extLst xmlns:a="http://schemas.openxmlformats.org/drawingml/2006/main">
               <a:ext uri="{FF2B5EF4-FFF2-40B4-BE49-F238E27FC236}">
-                <a16:creationId xmlns:a16="http://schemas.microsoft.com/office/drawing/2014/main" id="{464D7A5F-3989-4697-B936-B74E6A94B983}"/>
+                <a16:creationId xmlns:a16="http://schemas.microsoft.com/office/drawing/2014/main" id="{940F2C8B-93BC-4AF9-B424-A23305BF9ED0}"/>
               </a:ext>
             </a:extLst>
           </p:cNvPr>
@@ -14668,7 +14668,7 @@
           <p:cNvPr id="16" name="">
             <a:extLst xmlns:a="http://schemas.openxmlformats.org/drawingml/2006/main">
               <a:ext uri="{FF2B5EF4-FFF2-40B4-BE49-F238E27FC236}">
-                <a16:creationId xmlns:a16="http://schemas.microsoft.com/office/drawing/2014/main" id="{562158C0-7925-4BCE-A348-C3EA6D92A409}"/>
+                <a16:creationId xmlns:a16="http://schemas.microsoft.com/office/drawing/2014/main" id="{76E74CA7-E0AE-4D09-AEB2-DAE1693FE608}"/>
               </a:ext>
             </a:extLst>
           </p:cNvPr>
@@ -14732,7 +14732,7 @@
           <p:cNvPr id="17" name="">
             <a:extLst xmlns:a="http://schemas.openxmlformats.org/drawingml/2006/main">
               <a:ext uri="{FF2B5EF4-FFF2-40B4-BE49-F238E27FC236}">
-                <a16:creationId xmlns:a16="http://schemas.microsoft.com/office/drawing/2014/main" id="{FC053BBA-AC8D-4A81-9262-084552C8D4BD}"/>
+                <a16:creationId xmlns:a16="http://schemas.microsoft.com/office/drawing/2014/main" id="{F3BED07B-858B-4EF0-A6A0-6A1E4596EC15}"/>
               </a:ext>
             </a:extLst>
           </p:cNvPr>
@@ -14794,7 +14794,7 @@
     </p:spTree>
     <p:extLst>
       <p:ext uri="{BB962C8B-B14F-4D97-AF65-F5344CB8AC3E}">
-        <p14:creationId xmlns:p14="http://schemas.microsoft.com/office/powerpoint/2010/main" val="486219017"/>
+        <p14:creationId xmlns:p14="http://schemas.microsoft.com/office/powerpoint/2010/main" val="1522699254"/>
       </p:ext>
     </p:extLst>
   </p:cSld>
@@ -14818,7 +14818,7 @@
           <p:cNvPr id="1" name="">
             <a:extLst xmlns:a="http://schemas.openxmlformats.org/drawingml/2006/main">
               <a:ext uri="{FF2B5EF4-FFF2-40B4-BE49-F238E27FC236}">
-                <a16:creationId xmlns:a16="http://schemas.microsoft.com/office/drawing/2014/main" id="{713FB789-3147-49F6-8530-89C34A3E518A}"/>
+                <a16:creationId xmlns:a16="http://schemas.microsoft.com/office/drawing/2014/main" id="{378AE5F4-66FE-4FD7-9324-9E84817A7552}"/>
               </a:ext>
             </a:extLst>
           </p:cNvPr>
@@ -14851,7 +14851,7 @@
           <p:cNvPr id="2" name="">
             <a:extLst xmlns:a="http://schemas.openxmlformats.org/drawingml/2006/main">
               <a:ext uri="{FF2B5EF4-FFF2-40B4-BE49-F238E27FC236}">
-                <a16:creationId xmlns:a16="http://schemas.microsoft.com/office/drawing/2014/main" id="{3B11B318-57CD-445C-BE00-604119C464E8}"/>
+                <a16:creationId xmlns:a16="http://schemas.microsoft.com/office/drawing/2014/main" id="{163ABC16-D5E7-4705-BA9D-52D8B8136399}"/>
               </a:ext>
             </a:extLst>
           </p:cNvPr>
@@ -14884,7 +14884,7 @@
           <p:cNvPr id="3" name="">
             <a:extLst xmlns:a="http://schemas.openxmlformats.org/drawingml/2006/main">
               <a:ext uri="{FF2B5EF4-FFF2-40B4-BE49-F238E27FC236}">
-                <a16:creationId xmlns:a16="http://schemas.microsoft.com/office/drawing/2014/main" id="{337A319F-8872-4985-AAB1-D91F35B116FD}"/>
+                <a16:creationId xmlns:a16="http://schemas.microsoft.com/office/drawing/2014/main" id="{BC3E1601-AE1F-4022-A758-5C456E2B2D54}"/>
               </a:ext>
             </a:extLst>
           </p:cNvPr>
@@ -14948,7 +14948,7 @@
           <p:cNvPr id="4" name="">
             <a:extLst xmlns:a="http://schemas.openxmlformats.org/drawingml/2006/main">
               <a:ext uri="{FF2B5EF4-FFF2-40B4-BE49-F238E27FC236}">
-                <a16:creationId xmlns:a16="http://schemas.microsoft.com/office/drawing/2014/main" id="{F62CFCE2-62DA-4590-ABAA-25C42AC26AEF}"/>
+                <a16:creationId xmlns:a16="http://schemas.microsoft.com/office/drawing/2014/main" id="{68F03967-06F0-4C32-997B-008F6DD3937C}"/>
               </a:ext>
             </a:extLst>
           </p:cNvPr>
@@ -15012,7 +15012,7 @@
           <p:cNvPr id="5" name="">
             <a:extLst xmlns:a="http://schemas.openxmlformats.org/drawingml/2006/main">
               <a:ext uri="{FF2B5EF4-FFF2-40B4-BE49-F238E27FC236}">
-                <a16:creationId xmlns:a16="http://schemas.microsoft.com/office/drawing/2014/main" id="{3FF93224-D769-4DC6-AFE8-E95F967972CF}"/>
+                <a16:creationId xmlns:a16="http://schemas.microsoft.com/office/drawing/2014/main" id="{C748F292-89D5-4719-9132-F46AA0E959DC}"/>
               </a:ext>
             </a:extLst>
           </p:cNvPr>
@@ -15045,7 +15045,7 @@
           <p:cNvPr id="6" name="">
             <a:extLst xmlns:a="http://schemas.openxmlformats.org/drawingml/2006/main">
               <a:ext uri="{FF2B5EF4-FFF2-40B4-BE49-F238E27FC236}">
-                <a16:creationId xmlns:a16="http://schemas.microsoft.com/office/drawing/2014/main" id="{6A74428E-F7BB-430E-822B-F2E01899DF91}"/>
+                <a16:creationId xmlns:a16="http://schemas.microsoft.com/office/drawing/2014/main" id="{BEAA7015-F45A-41C2-BC62-2B7C42CFA2A1}"/>
               </a:ext>
             </a:extLst>
           </p:cNvPr>
@@ -15078,7 +15078,7 @@
           <p:cNvPr id="7" name="">
             <a:extLst xmlns:a="http://schemas.openxmlformats.org/drawingml/2006/main">
               <a:ext uri="{FF2B5EF4-FFF2-40B4-BE49-F238E27FC236}">
-                <a16:creationId xmlns:a16="http://schemas.microsoft.com/office/drawing/2014/main" id="{DE92868B-EA94-4E33-A18A-7118BB63EDAD}"/>
+                <a16:creationId xmlns:a16="http://schemas.microsoft.com/office/drawing/2014/main" id="{760288C4-BB87-481C-B028-14F69CD2AB70}"/>
               </a:ext>
             </a:extLst>
           </p:cNvPr>
@@ -15142,7 +15142,7 @@
           <p:cNvPr id="8" name="">
             <a:extLst xmlns:a="http://schemas.openxmlformats.org/drawingml/2006/main">
               <a:ext uri="{FF2B5EF4-FFF2-40B4-BE49-F238E27FC236}">
-                <a16:creationId xmlns:a16="http://schemas.microsoft.com/office/drawing/2014/main" id="{F7706630-F59E-445F-9B36-83E5C93B82AF}"/>
+                <a16:creationId xmlns:a16="http://schemas.microsoft.com/office/drawing/2014/main" id="{427C1731-31DB-43F2-861D-5B2C359DCBC5}"/>
               </a:ext>
             </a:extLst>
           </p:cNvPr>
@@ -15175,7 +15175,7 @@
           <p:cNvPr id="9" name="">
             <a:extLst xmlns:a="http://schemas.openxmlformats.org/drawingml/2006/main">
               <a:ext uri="{FF2B5EF4-FFF2-40B4-BE49-F238E27FC236}">
-                <a16:creationId xmlns:a16="http://schemas.microsoft.com/office/drawing/2014/main" id="{78D661E5-BDC3-4CFC-9B9D-729C78897736}"/>
+                <a16:creationId xmlns:a16="http://schemas.microsoft.com/office/drawing/2014/main" id="{B31E2E66-8D93-436A-AFE6-AA145050E581}"/>
               </a:ext>
             </a:extLst>
           </p:cNvPr>
@@ -15239,7 +15239,7 @@
           <p:cNvPr id="10" name="">
             <a:extLst xmlns:a="http://schemas.openxmlformats.org/drawingml/2006/main">
               <a:ext uri="{FF2B5EF4-FFF2-40B4-BE49-F238E27FC236}">
-                <a16:creationId xmlns:a16="http://schemas.microsoft.com/office/drawing/2014/main" id="{AFAAFAE6-6265-4284-BF87-2A4138D09789}"/>
+                <a16:creationId xmlns:a16="http://schemas.microsoft.com/office/drawing/2014/main" id="{997FABA5-CB3B-41BC-9BB2-67657198C785}"/>
               </a:ext>
             </a:extLst>
           </p:cNvPr>
@@ -15272,7 +15272,7 @@
           <p:cNvPr id="11" name="">
             <a:extLst xmlns:a="http://schemas.openxmlformats.org/drawingml/2006/main">
               <a:ext uri="{FF2B5EF4-FFF2-40B4-BE49-F238E27FC236}">
-                <a16:creationId xmlns:a16="http://schemas.microsoft.com/office/drawing/2014/main" id="{B8D18FC2-54F2-40B7-B7E2-D0CE866D91C8}"/>
+                <a16:creationId xmlns:a16="http://schemas.microsoft.com/office/drawing/2014/main" id="{C35FF5CB-56DA-4D71-AFFB-7DCA1102EB5A}"/>
               </a:ext>
             </a:extLst>
           </p:cNvPr>
@@ -15336,7 +15336,7 @@
           <p:cNvPr id="12" name="">
             <a:extLst xmlns:a="http://schemas.openxmlformats.org/drawingml/2006/main">
               <a:ext uri="{FF2B5EF4-FFF2-40B4-BE49-F238E27FC236}">
-                <a16:creationId xmlns:a16="http://schemas.microsoft.com/office/drawing/2014/main" id="{FD4FC3E7-84FC-4375-B648-31B999D8243B}"/>
+                <a16:creationId xmlns:a16="http://schemas.microsoft.com/office/drawing/2014/main" id="{7A4DA577-1CFF-42B9-8E09-D72B3BAB1994}"/>
               </a:ext>
             </a:extLst>
           </p:cNvPr>
@@ -15369,7 +15369,7 @@
           <p:cNvPr id="13" name="">
             <a:extLst xmlns:a="http://schemas.openxmlformats.org/drawingml/2006/main">
               <a:ext uri="{FF2B5EF4-FFF2-40B4-BE49-F238E27FC236}">
-                <a16:creationId xmlns:a16="http://schemas.microsoft.com/office/drawing/2014/main" id="{356C440B-F037-48F0-839C-42AB75BA9BEE}"/>
+                <a16:creationId xmlns:a16="http://schemas.microsoft.com/office/drawing/2014/main" id="{340E50B8-DB81-4BFE-BA34-9D5E5FE88881}"/>
               </a:ext>
             </a:extLst>
           </p:cNvPr>
@@ -15433,7 +15433,7 @@
           <p:cNvPr id="14" name="">
             <a:extLst xmlns:a="http://schemas.openxmlformats.org/drawingml/2006/main">
               <a:ext uri="{FF2B5EF4-FFF2-40B4-BE49-F238E27FC236}">
-                <a16:creationId xmlns:a16="http://schemas.microsoft.com/office/drawing/2014/main" id="{B0722453-AACB-4D80-B161-5E0B2DBFB921}"/>
+                <a16:creationId xmlns:a16="http://schemas.microsoft.com/office/drawing/2014/main" id="{B69BD316-C4D9-4758-A9E1-67CA0E2E36FF}"/>
               </a:ext>
             </a:extLst>
           </p:cNvPr>
@@ -15466,7 +15466,7 @@
           <p:cNvPr id="15" name="">
             <a:extLst xmlns:a="http://schemas.openxmlformats.org/drawingml/2006/main">
               <a:ext uri="{FF2B5EF4-FFF2-40B4-BE49-F238E27FC236}">
-                <a16:creationId xmlns:a16="http://schemas.microsoft.com/office/drawing/2014/main" id="{72624BE4-76CD-4C6B-BC8D-3DBC8EB60DF7}"/>
+                <a16:creationId xmlns:a16="http://schemas.microsoft.com/office/drawing/2014/main" id="{F4D09634-70F3-4E4B-8A82-19F4AB875095}"/>
               </a:ext>
             </a:extLst>
           </p:cNvPr>
@@ -15530,7 +15530,7 @@
           <p:cNvPr id="16" name="">
             <a:extLst xmlns:a="http://schemas.openxmlformats.org/drawingml/2006/main">
               <a:ext uri="{FF2B5EF4-FFF2-40B4-BE49-F238E27FC236}">
-                <a16:creationId xmlns:a16="http://schemas.microsoft.com/office/drawing/2014/main" id="{6032FD02-FBC2-4007-A038-3E25C2E9B734}"/>
+                <a16:creationId xmlns:a16="http://schemas.microsoft.com/office/drawing/2014/main" id="{4630E995-8D72-4157-9A7F-D8EB5BBE9530}"/>
               </a:ext>
             </a:extLst>
           </p:cNvPr>
@@ -15563,7 +15563,7 @@
           <p:cNvPr id="17" name="">
             <a:extLst xmlns:a="http://schemas.openxmlformats.org/drawingml/2006/main">
               <a:ext uri="{FF2B5EF4-FFF2-40B4-BE49-F238E27FC236}">
-                <a16:creationId xmlns:a16="http://schemas.microsoft.com/office/drawing/2014/main" id="{918B51A8-A423-4672-B9D5-C28070622ECC}"/>
+                <a16:creationId xmlns:a16="http://schemas.microsoft.com/office/drawing/2014/main" id="{11F4CDC0-CE19-46BC-A7B1-16413B17282E}"/>
               </a:ext>
             </a:extLst>
           </p:cNvPr>
@@ -15627,7 +15627,7 @@
           <p:cNvPr id="18" name="">
             <a:extLst xmlns:a="http://schemas.openxmlformats.org/drawingml/2006/main">
               <a:ext uri="{FF2B5EF4-FFF2-40B4-BE49-F238E27FC236}">
-                <a16:creationId xmlns:a16="http://schemas.microsoft.com/office/drawing/2014/main" id="{3541F1CE-222B-4B8F-8E4E-AE0F9BC2DAA7}"/>
+                <a16:creationId xmlns:a16="http://schemas.microsoft.com/office/drawing/2014/main" id="{568D9479-65CF-4641-ABC6-7A02014BF8E4}"/>
               </a:ext>
             </a:extLst>
           </p:cNvPr>
@@ -15691,7 +15691,7 @@
           <p:cNvPr id="19" name="">
             <a:extLst xmlns:a="http://schemas.openxmlformats.org/drawingml/2006/main">
               <a:ext uri="{FF2B5EF4-FFF2-40B4-BE49-F238E27FC236}">
-                <a16:creationId xmlns:a16="http://schemas.microsoft.com/office/drawing/2014/main" id="{020DE2BE-FB95-4A6D-AC1D-C98224528D36}"/>
+                <a16:creationId xmlns:a16="http://schemas.microsoft.com/office/drawing/2014/main" id="{D1553202-6542-47D3-9DD0-D3D90A37922A}"/>
               </a:ext>
             </a:extLst>
           </p:cNvPr>
@@ -15753,7 +15753,7 @@
     </p:spTree>
     <p:extLst>
       <p:ext uri="{BB962C8B-B14F-4D97-AF65-F5344CB8AC3E}">
-        <p14:creationId xmlns:p14="http://schemas.microsoft.com/office/powerpoint/2010/main" val="1329117304"/>
+        <p14:creationId xmlns:p14="http://schemas.microsoft.com/office/powerpoint/2010/main" val="962544112"/>
       </p:ext>
     </p:extLst>
   </p:cSld>
@@ -15777,7 +15777,7 @@
           <p:cNvPr id="1" name="">
             <a:extLst xmlns:a="http://schemas.openxmlformats.org/drawingml/2006/main">
               <a:ext uri="{FF2B5EF4-FFF2-40B4-BE49-F238E27FC236}">
-                <a16:creationId xmlns:a16="http://schemas.microsoft.com/office/drawing/2014/main" id="{620010BC-E3CC-4DD9-B762-CDD32E6DA095}"/>
+                <a16:creationId xmlns:a16="http://schemas.microsoft.com/office/drawing/2014/main" id="{C416AC2A-C1D6-465C-ADAF-5C863EAAFBB8}"/>
               </a:ext>
             </a:extLst>
           </p:cNvPr>
@@ -15810,7 +15810,7 @@
           <p:cNvPr id="2" name="">
             <a:extLst xmlns:a="http://schemas.openxmlformats.org/drawingml/2006/main">
               <a:ext uri="{FF2B5EF4-FFF2-40B4-BE49-F238E27FC236}">
-                <a16:creationId xmlns:a16="http://schemas.microsoft.com/office/drawing/2014/main" id="{D35912D1-CEFC-4DFE-84B3-6EAF9EC54FA0}"/>
+                <a16:creationId xmlns:a16="http://schemas.microsoft.com/office/drawing/2014/main" id="{EACDFC11-F7F3-4E40-8B96-C7A29545F144}"/>
               </a:ext>
             </a:extLst>
           </p:cNvPr>
@@ -15843,7 +15843,7 @@
           <p:cNvPr id="3" name="">
             <a:extLst xmlns:a="http://schemas.openxmlformats.org/drawingml/2006/main">
               <a:ext uri="{FF2B5EF4-FFF2-40B4-BE49-F238E27FC236}">
-                <a16:creationId xmlns:a16="http://schemas.microsoft.com/office/drawing/2014/main" id="{24A7AF64-4090-4EE3-B4B0-559B22660AB2}"/>
+                <a16:creationId xmlns:a16="http://schemas.microsoft.com/office/drawing/2014/main" id="{00CF4805-B7C0-45A4-9807-116DEA0748D5}"/>
               </a:ext>
             </a:extLst>
           </p:cNvPr>
@@ -15907,7 +15907,7 @@
           <p:cNvPr id="4" name="">
             <a:extLst xmlns:a="http://schemas.openxmlformats.org/drawingml/2006/main">
               <a:ext uri="{FF2B5EF4-FFF2-40B4-BE49-F238E27FC236}">
-                <a16:creationId xmlns:a16="http://schemas.microsoft.com/office/drawing/2014/main" id="{9D8ACF24-0E6A-46D8-B5F7-47613CEFF1B6}"/>
+                <a16:creationId xmlns:a16="http://schemas.microsoft.com/office/drawing/2014/main" id="{18523791-35B8-4D3C-AB14-2CD34D9A74B6}"/>
               </a:ext>
             </a:extLst>
           </p:cNvPr>
@@ -15971,7 +15971,7 @@
           <p:cNvPr id="5" name="">
             <a:extLst xmlns:a="http://schemas.openxmlformats.org/drawingml/2006/main">
               <a:ext uri="{FF2B5EF4-FFF2-40B4-BE49-F238E27FC236}">
-                <a16:creationId xmlns:a16="http://schemas.microsoft.com/office/drawing/2014/main" id="{53C91935-35D0-4330-A736-1D92CC4EE880}"/>
+                <a16:creationId xmlns:a16="http://schemas.microsoft.com/office/drawing/2014/main" id="{CDF4E634-5FFC-4A7D-843F-1D9C3B01B281}"/>
               </a:ext>
             </a:extLst>
           </p:cNvPr>
@@ -16004,7 +16004,7 @@
           <p:cNvPr id="6" name="">
             <a:extLst xmlns:a="http://schemas.openxmlformats.org/drawingml/2006/main">
               <a:ext uri="{FF2B5EF4-FFF2-40B4-BE49-F238E27FC236}">
-                <a16:creationId xmlns:a16="http://schemas.microsoft.com/office/drawing/2014/main" id="{B22C4131-8EF5-4642-A3A1-9862726564B8}"/>
+                <a16:creationId xmlns:a16="http://schemas.microsoft.com/office/drawing/2014/main" id="{C4BF35A3-C422-47B7-9A5F-3D851DB7B0FA}"/>
               </a:ext>
             </a:extLst>
           </p:cNvPr>
@@ -16037,7 +16037,7 @@
           <p:cNvPr id="7" name="">
             <a:extLst xmlns:a="http://schemas.openxmlformats.org/drawingml/2006/main">
               <a:ext uri="{FF2B5EF4-FFF2-40B4-BE49-F238E27FC236}">
-                <a16:creationId xmlns:a16="http://schemas.microsoft.com/office/drawing/2014/main" id="{D00648B1-5369-42F1-BEA6-58BFBEEA967B}"/>
+                <a16:creationId xmlns:a16="http://schemas.microsoft.com/office/drawing/2014/main" id="{9B4BFBDF-BB74-4EA8-AF29-BCA8E16D3C25}"/>
               </a:ext>
             </a:extLst>
           </p:cNvPr>
@@ -16101,7 +16101,7 @@
           <p:cNvPr id="8" name="">
             <a:extLst xmlns:a="http://schemas.openxmlformats.org/drawingml/2006/main">
               <a:ext uri="{FF2B5EF4-FFF2-40B4-BE49-F238E27FC236}">
-                <a16:creationId xmlns:a16="http://schemas.microsoft.com/office/drawing/2014/main" id="{94CF67BE-6548-4AD6-B897-E56DB6F5AA3B}"/>
+                <a16:creationId xmlns:a16="http://schemas.microsoft.com/office/drawing/2014/main" id="{8C41B985-176D-4464-8637-419B6D29C50C}"/>
               </a:ext>
             </a:extLst>
           </p:cNvPr>
@@ -16134,7 +16134,7 @@
           <p:cNvPr id="9" name="">
             <a:extLst xmlns:a="http://schemas.openxmlformats.org/drawingml/2006/main">
               <a:ext uri="{FF2B5EF4-FFF2-40B4-BE49-F238E27FC236}">
-                <a16:creationId xmlns:a16="http://schemas.microsoft.com/office/drawing/2014/main" id="{FE087717-3A6D-423C-A28A-672CA84CADD5}"/>
+                <a16:creationId xmlns:a16="http://schemas.microsoft.com/office/drawing/2014/main" id="{3B96776C-6B4A-40EB-812C-CA76FA22D1DA}"/>
               </a:ext>
             </a:extLst>
           </p:cNvPr>
@@ -16198,7 +16198,7 @@
           <p:cNvPr id="10" name="">
             <a:extLst xmlns:a="http://schemas.openxmlformats.org/drawingml/2006/main">
               <a:ext uri="{FF2B5EF4-FFF2-40B4-BE49-F238E27FC236}">
-                <a16:creationId xmlns:a16="http://schemas.microsoft.com/office/drawing/2014/main" id="{40322C2A-DCFE-4E49-A577-90A6CA7E0785}"/>
+                <a16:creationId xmlns:a16="http://schemas.microsoft.com/office/drawing/2014/main" id="{36411FAF-708C-44F6-8B57-833E8AF59E98}"/>
               </a:ext>
             </a:extLst>
           </p:cNvPr>
@@ -16231,7 +16231,7 @@
           <p:cNvPr id="11" name="">
             <a:extLst xmlns:a="http://schemas.openxmlformats.org/drawingml/2006/main">
               <a:ext uri="{FF2B5EF4-FFF2-40B4-BE49-F238E27FC236}">
-                <a16:creationId xmlns:a16="http://schemas.microsoft.com/office/drawing/2014/main" id="{611E3831-6F16-4510-8A2C-DBFE5D96FA82}"/>
+                <a16:creationId xmlns:a16="http://schemas.microsoft.com/office/drawing/2014/main" id="{4CF7EE82-EAEC-4EF0-8F28-7ABAFFACE663}"/>
               </a:ext>
             </a:extLst>
           </p:cNvPr>
@@ -16295,7 +16295,7 @@
           <p:cNvPr id="12" name="">
             <a:extLst xmlns:a="http://schemas.openxmlformats.org/drawingml/2006/main">
               <a:ext uri="{FF2B5EF4-FFF2-40B4-BE49-F238E27FC236}">
-                <a16:creationId xmlns:a16="http://schemas.microsoft.com/office/drawing/2014/main" id="{91D82063-F38F-4CE5-97A6-49C34778E19E}"/>
+                <a16:creationId xmlns:a16="http://schemas.microsoft.com/office/drawing/2014/main" id="{473E5968-F413-49E8-8A44-9F464FD8D983}"/>
               </a:ext>
             </a:extLst>
           </p:cNvPr>
@@ -16328,7 +16328,7 @@
           <p:cNvPr id="13" name="">
             <a:extLst xmlns:a="http://schemas.openxmlformats.org/drawingml/2006/main">
               <a:ext uri="{FF2B5EF4-FFF2-40B4-BE49-F238E27FC236}">
-                <a16:creationId xmlns:a16="http://schemas.microsoft.com/office/drawing/2014/main" id="{C1FEE067-B8CE-4B5A-8A35-8724D4BFD5E0}"/>
+                <a16:creationId xmlns:a16="http://schemas.microsoft.com/office/drawing/2014/main" id="{4B662D04-836D-42CE-AF37-86F0983E7A4F}"/>
               </a:ext>
             </a:extLst>
           </p:cNvPr>
@@ -16392,7 +16392,7 @@
           <p:cNvPr id="14" name="">
             <a:extLst xmlns:a="http://schemas.openxmlformats.org/drawingml/2006/main">
               <a:ext uri="{FF2B5EF4-FFF2-40B4-BE49-F238E27FC236}">
-                <a16:creationId xmlns:a16="http://schemas.microsoft.com/office/drawing/2014/main" id="{855641B5-324B-4E59-B9DB-586EF0092089}"/>
+                <a16:creationId xmlns:a16="http://schemas.microsoft.com/office/drawing/2014/main" id="{8684CFDF-E33C-4E3A-B8AE-162F2F1BDCBE}"/>
               </a:ext>
             </a:extLst>
           </p:cNvPr>
@@ -16425,7 +16425,7 @@
           <p:cNvPr id="15" name="">
             <a:extLst xmlns:a="http://schemas.openxmlformats.org/drawingml/2006/main">
               <a:ext uri="{FF2B5EF4-FFF2-40B4-BE49-F238E27FC236}">
-                <a16:creationId xmlns:a16="http://schemas.microsoft.com/office/drawing/2014/main" id="{A5125C69-49F3-41E2-9225-E8A477FC6DA9}"/>
+                <a16:creationId xmlns:a16="http://schemas.microsoft.com/office/drawing/2014/main" id="{6EFB18BE-77F0-461E-9A0D-E0AA4D9A1BEB}"/>
               </a:ext>
             </a:extLst>
           </p:cNvPr>
@@ -16489,7 +16489,7 @@
           <p:cNvPr id="16" name="">
             <a:extLst xmlns:a="http://schemas.openxmlformats.org/drawingml/2006/main">
               <a:ext uri="{FF2B5EF4-FFF2-40B4-BE49-F238E27FC236}">
-                <a16:creationId xmlns:a16="http://schemas.microsoft.com/office/drawing/2014/main" id="{F02F9D19-E6EC-47BF-ADA4-6D8978392D26}"/>
+                <a16:creationId xmlns:a16="http://schemas.microsoft.com/office/drawing/2014/main" id="{AC9874C3-8CA2-4BC8-82EC-95D6E4A995DA}"/>
               </a:ext>
             </a:extLst>
           </p:cNvPr>
@@ -16522,7 +16522,7 @@
           <p:cNvPr id="17" name="">
             <a:extLst xmlns:a="http://schemas.openxmlformats.org/drawingml/2006/main">
               <a:ext uri="{FF2B5EF4-FFF2-40B4-BE49-F238E27FC236}">
-                <a16:creationId xmlns:a16="http://schemas.microsoft.com/office/drawing/2014/main" id="{DB2763C7-3607-46D7-A7D8-72E796960722}"/>
+                <a16:creationId xmlns:a16="http://schemas.microsoft.com/office/drawing/2014/main" id="{46576680-0A87-4D15-B153-38A614AF08EA}"/>
               </a:ext>
             </a:extLst>
           </p:cNvPr>
@@ -16586,7 +16586,7 @@
           <p:cNvPr id="18" name="">
             <a:extLst xmlns:a="http://schemas.openxmlformats.org/drawingml/2006/main">
               <a:ext uri="{FF2B5EF4-FFF2-40B4-BE49-F238E27FC236}">
-                <a16:creationId xmlns:a16="http://schemas.microsoft.com/office/drawing/2014/main" id="{79BDADA2-088F-41BE-AB49-1707EDC6CEE1}"/>
+                <a16:creationId xmlns:a16="http://schemas.microsoft.com/office/drawing/2014/main" id="{5AF82CBD-4B66-442A-9570-43370F1AF6C6}"/>
               </a:ext>
             </a:extLst>
           </p:cNvPr>
@@ -16650,7 +16650,7 @@
           <p:cNvPr id="19" name="">
             <a:extLst xmlns:a="http://schemas.openxmlformats.org/drawingml/2006/main">
               <a:ext uri="{FF2B5EF4-FFF2-40B4-BE49-F238E27FC236}">
-                <a16:creationId xmlns:a16="http://schemas.microsoft.com/office/drawing/2014/main" id="{C7BFECA2-3822-4B0B-9F56-7D6465C62934}"/>
+                <a16:creationId xmlns:a16="http://schemas.microsoft.com/office/drawing/2014/main" id="{6B5173A4-2076-4CAD-B977-CAF5DEC47D84}"/>
               </a:ext>
             </a:extLst>
           </p:cNvPr>
@@ -16712,7 +16712,7 @@
     </p:spTree>
     <p:extLst>
       <p:ext uri="{BB962C8B-B14F-4D97-AF65-F5344CB8AC3E}">
-        <p14:creationId xmlns:p14="http://schemas.microsoft.com/office/powerpoint/2010/main" val="420477869"/>
+        <p14:creationId xmlns:p14="http://schemas.microsoft.com/office/powerpoint/2010/main" val="1256523227"/>
       </p:ext>
     </p:extLst>
   </p:cSld>
@@ -16736,7 +16736,7 @@
           <p:cNvPr id="1" name="">
             <a:extLst xmlns:a="http://schemas.openxmlformats.org/drawingml/2006/main">
               <a:ext uri="{FF2B5EF4-FFF2-40B4-BE49-F238E27FC236}">
-                <a16:creationId xmlns:a16="http://schemas.microsoft.com/office/drawing/2014/main" id="{59C50E34-58C9-4BB3-8A68-98503BA0BF2D}"/>
+                <a16:creationId xmlns:a16="http://schemas.microsoft.com/office/drawing/2014/main" id="{1902E7F3-CEBC-45D5-9ED7-029193689E35}"/>
               </a:ext>
             </a:extLst>
           </p:cNvPr>
@@ -16769,7 +16769,7 @@
           <p:cNvPr id="2" name="">
             <a:extLst xmlns:a="http://schemas.openxmlformats.org/drawingml/2006/main">
               <a:ext uri="{FF2B5EF4-FFF2-40B4-BE49-F238E27FC236}">
-                <a16:creationId xmlns:a16="http://schemas.microsoft.com/office/drawing/2014/main" id="{035BED6E-C165-4EEA-8E95-9C2CAA0732B9}"/>
+                <a16:creationId xmlns:a16="http://schemas.microsoft.com/office/drawing/2014/main" id="{562F53C7-33F9-4603-AF52-AED553597B3C}"/>
               </a:ext>
             </a:extLst>
           </p:cNvPr>
@@ -16802,7 +16802,7 @@
           <p:cNvPr id="3" name="">
             <a:extLst xmlns:a="http://schemas.openxmlformats.org/drawingml/2006/main">
               <a:ext uri="{FF2B5EF4-FFF2-40B4-BE49-F238E27FC236}">
-                <a16:creationId xmlns:a16="http://schemas.microsoft.com/office/drawing/2014/main" id="{396BCA02-D1F6-4E9F-BAD0-DCBD26A83489}"/>
+                <a16:creationId xmlns:a16="http://schemas.microsoft.com/office/drawing/2014/main" id="{8941E563-1C2A-4DE8-9452-70E439EAE97F}"/>
               </a:ext>
             </a:extLst>
           </p:cNvPr>
@@ -16866,7 +16866,7 @@
           <p:cNvPr id="4" name="">
             <a:extLst xmlns:a="http://schemas.openxmlformats.org/drawingml/2006/main">
               <a:ext uri="{FF2B5EF4-FFF2-40B4-BE49-F238E27FC236}">
-                <a16:creationId xmlns:a16="http://schemas.microsoft.com/office/drawing/2014/main" id="{5062EF4D-2B14-4B1E-85AA-811A8F58068A}"/>
+                <a16:creationId xmlns:a16="http://schemas.microsoft.com/office/drawing/2014/main" id="{C9597100-946A-4FD5-98A2-1C3752A74A47}"/>
               </a:ext>
             </a:extLst>
           </p:cNvPr>
@@ -16930,7 +16930,7 @@
           <p:cNvPr id="5" name="">
             <a:extLst xmlns:a="http://schemas.openxmlformats.org/drawingml/2006/main">
               <a:ext uri="{FF2B5EF4-FFF2-40B4-BE49-F238E27FC236}">
-                <a16:creationId xmlns:a16="http://schemas.microsoft.com/office/drawing/2014/main" id="{5997BC43-B9D8-4687-9AC6-62E37CC0A1BE}"/>
+                <a16:creationId xmlns:a16="http://schemas.microsoft.com/office/drawing/2014/main" id="{2B4D8033-EED5-4FA3-829E-82E57C121514}"/>
               </a:ext>
             </a:extLst>
           </p:cNvPr>
@@ -16963,7 +16963,7 @@
           <p:cNvPr id="6" name="">
             <a:extLst xmlns:a="http://schemas.openxmlformats.org/drawingml/2006/main">
               <a:ext uri="{FF2B5EF4-FFF2-40B4-BE49-F238E27FC236}">
-                <a16:creationId xmlns:a16="http://schemas.microsoft.com/office/drawing/2014/main" id="{9D087020-F94E-411E-9A04-F84D97452950}"/>
+                <a16:creationId xmlns:a16="http://schemas.microsoft.com/office/drawing/2014/main" id="{E5A440DF-4FF2-43D9-B0AE-A9AC69D14584}"/>
               </a:ext>
             </a:extLst>
           </p:cNvPr>
@@ -16996,7 +16996,7 @@
           <p:cNvPr id="7" name="">
             <a:extLst xmlns:a="http://schemas.openxmlformats.org/drawingml/2006/main">
               <a:ext uri="{FF2B5EF4-FFF2-40B4-BE49-F238E27FC236}">
-                <a16:creationId xmlns:a16="http://schemas.microsoft.com/office/drawing/2014/main" id="{74F6B670-BC12-493E-8EE8-6C3D46D09D55}"/>
+                <a16:creationId xmlns:a16="http://schemas.microsoft.com/office/drawing/2014/main" id="{AD9F2A81-FDB8-4A93-92EC-1F0932E8DACD}"/>
               </a:ext>
             </a:extLst>
           </p:cNvPr>
@@ -17060,7 +17060,7 @@
           <p:cNvPr id="8" name="">
             <a:extLst xmlns:a="http://schemas.openxmlformats.org/drawingml/2006/main">
               <a:ext uri="{FF2B5EF4-FFF2-40B4-BE49-F238E27FC236}">
-                <a16:creationId xmlns:a16="http://schemas.microsoft.com/office/drawing/2014/main" id="{2FA70F46-0DD2-4414-84A3-623F613CC980}"/>
+                <a16:creationId xmlns:a16="http://schemas.microsoft.com/office/drawing/2014/main" id="{BCC9BBF3-5BB6-4025-B679-28F631A4973A}"/>
               </a:ext>
             </a:extLst>
           </p:cNvPr>
@@ -17093,7 +17093,7 @@
           <p:cNvPr id="9" name="">
             <a:extLst xmlns:a="http://schemas.openxmlformats.org/drawingml/2006/main">
               <a:ext uri="{FF2B5EF4-FFF2-40B4-BE49-F238E27FC236}">
-                <a16:creationId xmlns:a16="http://schemas.microsoft.com/office/drawing/2014/main" id="{1BD59F8C-04D4-4751-A4EE-ED041D57E55B}"/>
+                <a16:creationId xmlns:a16="http://schemas.microsoft.com/office/drawing/2014/main" id="{93A322FE-C12D-4ABF-864E-A1F8D3DA24A0}"/>
               </a:ext>
             </a:extLst>
           </p:cNvPr>
@@ -17157,7 +17157,7 @@
           <p:cNvPr id="10" name="">
             <a:extLst xmlns:a="http://schemas.openxmlformats.org/drawingml/2006/main">
               <a:ext uri="{FF2B5EF4-FFF2-40B4-BE49-F238E27FC236}">
-                <a16:creationId xmlns:a16="http://schemas.microsoft.com/office/drawing/2014/main" id="{7143E310-4AEC-44F1-9738-BC9CD949DAE9}"/>
+                <a16:creationId xmlns:a16="http://schemas.microsoft.com/office/drawing/2014/main" id="{F99BFD94-0C7C-43F8-9FD9-67A18B444725}"/>
               </a:ext>
             </a:extLst>
           </p:cNvPr>
@@ -17190,7 +17190,7 @@
           <p:cNvPr id="11" name="">
             <a:extLst xmlns:a="http://schemas.openxmlformats.org/drawingml/2006/main">
               <a:ext uri="{FF2B5EF4-FFF2-40B4-BE49-F238E27FC236}">
-                <a16:creationId xmlns:a16="http://schemas.microsoft.com/office/drawing/2014/main" id="{8DAFFC8E-517D-4CEE-B7C0-FCC986BF0E4C}"/>
+                <a16:creationId xmlns:a16="http://schemas.microsoft.com/office/drawing/2014/main" id="{1B78E810-23DD-4E43-BA5B-374B976BF2F2}"/>
               </a:ext>
             </a:extLst>
           </p:cNvPr>
@@ -17254,7 +17254,7 @@
           <p:cNvPr id="12" name="">
             <a:extLst xmlns:a="http://schemas.openxmlformats.org/drawingml/2006/main">
               <a:ext uri="{FF2B5EF4-FFF2-40B4-BE49-F238E27FC236}">
-                <a16:creationId xmlns:a16="http://schemas.microsoft.com/office/drawing/2014/main" id="{69677BE0-D752-471B-B9C8-4EC129952390}"/>
+                <a16:creationId xmlns:a16="http://schemas.microsoft.com/office/drawing/2014/main" id="{7B6C80BE-27BD-431A-B2EE-650B87EDEE1D}"/>
               </a:ext>
             </a:extLst>
           </p:cNvPr>
@@ -17287,7 +17287,7 @@
           <p:cNvPr id="13" name="">
             <a:extLst xmlns:a="http://schemas.openxmlformats.org/drawingml/2006/main">
               <a:ext uri="{FF2B5EF4-FFF2-40B4-BE49-F238E27FC236}">
-                <a16:creationId xmlns:a16="http://schemas.microsoft.com/office/drawing/2014/main" id="{86F83451-5E34-4F2D-86A1-1523C7BE2652}"/>
+                <a16:creationId xmlns:a16="http://schemas.microsoft.com/office/drawing/2014/main" id="{0E808A8D-253D-4D7B-B597-C609E29FB7C7}"/>
               </a:ext>
             </a:extLst>
           </p:cNvPr>
@@ -17351,7 +17351,7 @@
           <p:cNvPr id="14" name="">
             <a:extLst xmlns:a="http://schemas.openxmlformats.org/drawingml/2006/main">
               <a:ext uri="{FF2B5EF4-FFF2-40B4-BE49-F238E27FC236}">
-                <a16:creationId xmlns:a16="http://schemas.microsoft.com/office/drawing/2014/main" id="{CEF0B0AA-3028-48D1-B85E-1E0C34B57067}"/>
+                <a16:creationId xmlns:a16="http://schemas.microsoft.com/office/drawing/2014/main" id="{F64FF8CD-27E0-41C5-BC96-D813A377529C}"/>
               </a:ext>
             </a:extLst>
           </p:cNvPr>
@@ -17384,7 +17384,7 @@
           <p:cNvPr id="15" name="">
             <a:extLst xmlns:a="http://schemas.openxmlformats.org/drawingml/2006/main">
               <a:ext uri="{FF2B5EF4-FFF2-40B4-BE49-F238E27FC236}">
-                <a16:creationId xmlns:a16="http://schemas.microsoft.com/office/drawing/2014/main" id="{508C4E80-A20A-4CB0-97BB-B0BAFAA87A78}"/>
+                <a16:creationId xmlns:a16="http://schemas.microsoft.com/office/drawing/2014/main" id="{C7100DFB-946A-49E2-9244-713DE010427F}"/>
               </a:ext>
             </a:extLst>
           </p:cNvPr>
@@ -17448,7 +17448,7 @@
           <p:cNvPr id="16" name="">
             <a:extLst xmlns:a="http://schemas.openxmlformats.org/drawingml/2006/main">
               <a:ext uri="{FF2B5EF4-FFF2-40B4-BE49-F238E27FC236}">
-                <a16:creationId xmlns:a16="http://schemas.microsoft.com/office/drawing/2014/main" id="{6A2D51F8-2D30-4F6B-A7F3-74215B8BA7A7}"/>
+                <a16:creationId xmlns:a16="http://schemas.microsoft.com/office/drawing/2014/main" id="{81310FD8-3D26-4E93-972C-7EF50FDF644E}"/>
               </a:ext>
             </a:extLst>
           </p:cNvPr>
@@ -17481,7 +17481,7 @@
           <p:cNvPr id="17" name="">
             <a:extLst xmlns:a="http://schemas.openxmlformats.org/drawingml/2006/main">
               <a:ext uri="{FF2B5EF4-FFF2-40B4-BE49-F238E27FC236}">
-                <a16:creationId xmlns:a16="http://schemas.microsoft.com/office/drawing/2014/main" id="{2603A993-51B3-4A34-A834-E48F57AE043F}"/>
+                <a16:creationId xmlns:a16="http://schemas.microsoft.com/office/drawing/2014/main" id="{3931F435-C320-4C4E-8AAB-AB6B2CF15592}"/>
               </a:ext>
             </a:extLst>
           </p:cNvPr>
@@ -17545,7 +17545,7 @@
           <p:cNvPr id="18" name="">
             <a:extLst xmlns:a="http://schemas.openxmlformats.org/drawingml/2006/main">
               <a:ext uri="{FF2B5EF4-FFF2-40B4-BE49-F238E27FC236}">
-                <a16:creationId xmlns:a16="http://schemas.microsoft.com/office/drawing/2014/main" id="{BE503B68-E863-4809-8A05-68A1A123CB8E}"/>
+                <a16:creationId xmlns:a16="http://schemas.microsoft.com/office/drawing/2014/main" id="{9B74E966-A8F2-44FD-8493-0A6776788DED}"/>
               </a:ext>
             </a:extLst>
           </p:cNvPr>
@@ -17578,7 +17578,7 @@
           <p:cNvPr id="19" name="">
             <a:extLst xmlns:a="http://schemas.openxmlformats.org/drawingml/2006/main">
               <a:ext uri="{FF2B5EF4-FFF2-40B4-BE49-F238E27FC236}">
-                <a16:creationId xmlns:a16="http://schemas.microsoft.com/office/drawing/2014/main" id="{C9BB1B33-BB67-4F4D-B73D-49A6F86C3B9B}"/>
+                <a16:creationId xmlns:a16="http://schemas.microsoft.com/office/drawing/2014/main" id="{1678FD03-3657-46C9-9C31-951AD30A1330}"/>
               </a:ext>
             </a:extLst>
           </p:cNvPr>
@@ -17642,7 +17642,7 @@
           <p:cNvPr id="20" name="">
             <a:extLst xmlns:a="http://schemas.openxmlformats.org/drawingml/2006/main">
               <a:ext uri="{FF2B5EF4-FFF2-40B4-BE49-F238E27FC236}">
-                <a16:creationId xmlns:a16="http://schemas.microsoft.com/office/drawing/2014/main" id="{9A8F41CB-CD1F-46BE-B8CA-B0DC47FEC2E0}"/>
+                <a16:creationId xmlns:a16="http://schemas.microsoft.com/office/drawing/2014/main" id="{42853712-61CD-450A-B7F4-D94D33151AA7}"/>
               </a:ext>
             </a:extLst>
           </p:cNvPr>
@@ -17706,7 +17706,7 @@
           <p:cNvPr id="21" name="">
             <a:extLst xmlns:a="http://schemas.openxmlformats.org/drawingml/2006/main">
               <a:ext uri="{FF2B5EF4-FFF2-40B4-BE49-F238E27FC236}">
-                <a16:creationId xmlns:a16="http://schemas.microsoft.com/office/drawing/2014/main" id="{6BCC675D-939E-4070-803E-39BD211315AC}"/>
+                <a16:creationId xmlns:a16="http://schemas.microsoft.com/office/drawing/2014/main" id="{88BD2A32-CC66-44CE-9687-42DC322DE716}"/>
               </a:ext>
             </a:extLst>
           </p:cNvPr>
@@ -17768,7 +17768,7 @@
     </p:spTree>
     <p:extLst>
       <p:ext uri="{BB962C8B-B14F-4D97-AF65-F5344CB8AC3E}">
-        <p14:creationId xmlns:p14="http://schemas.microsoft.com/office/powerpoint/2010/main" val="904475847"/>
+        <p14:creationId xmlns:p14="http://schemas.microsoft.com/office/powerpoint/2010/main" val="1911543299"/>
       </p:ext>
     </p:extLst>
   </p:cSld>
@@ -17792,7 +17792,7 @@
           <p:cNvPr id="1" name="">
             <a:extLst xmlns:a="http://schemas.openxmlformats.org/drawingml/2006/main">
               <a:ext uri="{FF2B5EF4-FFF2-40B4-BE49-F238E27FC236}">
-                <a16:creationId xmlns:a16="http://schemas.microsoft.com/office/drawing/2014/main" id="{F5373489-61FB-4AB8-BF2A-284F68817188}"/>
+                <a16:creationId xmlns:a16="http://schemas.microsoft.com/office/drawing/2014/main" id="{AC16F2A1-0042-4ACD-94F2-2AD612A89D47}"/>
               </a:ext>
             </a:extLst>
           </p:cNvPr>
@@ -17825,7 +17825,7 @@
           <p:cNvPr id="2" name="">
             <a:extLst xmlns:a="http://schemas.openxmlformats.org/drawingml/2006/main">
               <a:ext uri="{FF2B5EF4-FFF2-40B4-BE49-F238E27FC236}">
-                <a16:creationId xmlns:a16="http://schemas.microsoft.com/office/drawing/2014/main" id="{38C7035C-F6B8-4FC2-B382-4E0FBCA717D7}"/>
+                <a16:creationId xmlns:a16="http://schemas.microsoft.com/office/drawing/2014/main" id="{171C7CF7-1C62-4A21-9B0C-4CA7A2F08276}"/>
               </a:ext>
             </a:extLst>
           </p:cNvPr>
@@ -17858,7 +17858,7 @@
           <p:cNvPr id="3" name="">
             <a:extLst xmlns:a="http://schemas.openxmlformats.org/drawingml/2006/main">
               <a:ext uri="{FF2B5EF4-FFF2-40B4-BE49-F238E27FC236}">
-                <a16:creationId xmlns:a16="http://schemas.microsoft.com/office/drawing/2014/main" id="{666148C6-9A35-4184-970D-CAA3980C19CB}"/>
+                <a16:creationId xmlns:a16="http://schemas.microsoft.com/office/drawing/2014/main" id="{017E93EF-D9A0-4C72-B0D4-C8064124A068}"/>
               </a:ext>
             </a:extLst>
           </p:cNvPr>
@@ -17922,7 +17922,7 @@
           <p:cNvPr id="4" name="">
             <a:extLst xmlns:a="http://schemas.openxmlformats.org/drawingml/2006/main">
               <a:ext uri="{FF2B5EF4-FFF2-40B4-BE49-F238E27FC236}">
-                <a16:creationId xmlns:a16="http://schemas.microsoft.com/office/drawing/2014/main" id="{943371E3-7757-42D9-92AC-40AD5205696E}"/>
+                <a16:creationId xmlns:a16="http://schemas.microsoft.com/office/drawing/2014/main" id="{61BA7C6B-400F-49A3-B254-841BF3E8A2C2}"/>
               </a:ext>
             </a:extLst>
           </p:cNvPr>
@@ -17986,7 +17986,7 @@
           <p:cNvPr id="5" name="">
             <a:extLst xmlns:a="http://schemas.openxmlformats.org/drawingml/2006/main">
               <a:ext uri="{FF2B5EF4-FFF2-40B4-BE49-F238E27FC236}">
-                <a16:creationId xmlns:a16="http://schemas.microsoft.com/office/drawing/2014/main" id="{56FC0083-2652-4E28-AC5D-FFC0A3320C35}"/>
+                <a16:creationId xmlns:a16="http://schemas.microsoft.com/office/drawing/2014/main" id="{4179CB21-BB46-403B-8B82-4C94E1EEB7F5}"/>
               </a:ext>
             </a:extLst>
           </p:cNvPr>
@@ -18019,7 +18019,7 @@
           <p:cNvPr id="6" name="">
             <a:extLst xmlns:a="http://schemas.openxmlformats.org/drawingml/2006/main">
               <a:ext uri="{FF2B5EF4-FFF2-40B4-BE49-F238E27FC236}">
-                <a16:creationId xmlns:a16="http://schemas.microsoft.com/office/drawing/2014/main" id="{8333894A-1676-4D05-B21D-23D6C6B71D03}"/>
+                <a16:creationId xmlns:a16="http://schemas.microsoft.com/office/drawing/2014/main" id="{D2E2D35E-5159-4008-AE8A-DCDCFC64A44B}"/>
               </a:ext>
             </a:extLst>
           </p:cNvPr>
@@ -18083,7 +18083,7 @@
           <p:cNvPr id="7" name="">
             <a:extLst xmlns:a="http://schemas.openxmlformats.org/drawingml/2006/main">
               <a:ext uri="{FF2B5EF4-FFF2-40B4-BE49-F238E27FC236}">
-                <a16:creationId xmlns:a16="http://schemas.microsoft.com/office/drawing/2014/main" id="{18E4BAF5-6D7B-4FDD-91D5-FDADB52C423E}"/>
+                <a16:creationId xmlns:a16="http://schemas.microsoft.com/office/drawing/2014/main" id="{260AB6E3-9FD8-40FF-98AD-BF5B65F30FC6}"/>
               </a:ext>
             </a:extLst>
           </p:cNvPr>
@@ -18116,7 +18116,7 @@
           <p:cNvPr id="8" name="">
             <a:extLst xmlns:a="http://schemas.openxmlformats.org/drawingml/2006/main">
               <a:ext uri="{FF2B5EF4-FFF2-40B4-BE49-F238E27FC236}">
-                <a16:creationId xmlns:a16="http://schemas.microsoft.com/office/drawing/2014/main" id="{510F5CC9-4A0E-41F5-8CC3-E76C5DC0F5B4}"/>
+                <a16:creationId xmlns:a16="http://schemas.microsoft.com/office/drawing/2014/main" id="{5BCD381F-3995-415C-8D68-C46803EEDE8E}"/>
               </a:ext>
             </a:extLst>
           </p:cNvPr>
@@ -18180,7 +18180,7 @@
           <p:cNvPr id="9" name="">
             <a:extLst xmlns:a="http://schemas.openxmlformats.org/drawingml/2006/main">
               <a:ext uri="{FF2B5EF4-FFF2-40B4-BE49-F238E27FC236}">
-                <a16:creationId xmlns:a16="http://schemas.microsoft.com/office/drawing/2014/main" id="{646A0B4E-C34E-47A9-A52B-8F37CC8026C1}"/>
+                <a16:creationId xmlns:a16="http://schemas.microsoft.com/office/drawing/2014/main" id="{F63F611C-37FF-4247-A540-D0834E150EE4}"/>
               </a:ext>
             </a:extLst>
           </p:cNvPr>
@@ -18213,7 +18213,7 @@
           <p:cNvPr id="10" name="">
             <a:extLst xmlns:a="http://schemas.openxmlformats.org/drawingml/2006/main">
               <a:ext uri="{FF2B5EF4-FFF2-40B4-BE49-F238E27FC236}">
-                <a16:creationId xmlns:a16="http://schemas.microsoft.com/office/drawing/2014/main" id="{C1FA2738-13AE-449D-828C-D494308D691D}"/>
+                <a16:creationId xmlns:a16="http://schemas.microsoft.com/office/drawing/2014/main" id="{EBE93B52-6D58-4A41-9C57-6AFE371BA3BF}"/>
               </a:ext>
             </a:extLst>
           </p:cNvPr>
@@ -18277,7 +18277,7 @@
           <p:cNvPr id="11" name="">
             <a:extLst xmlns:a="http://schemas.openxmlformats.org/drawingml/2006/main">
               <a:ext uri="{FF2B5EF4-FFF2-40B4-BE49-F238E27FC236}">
-                <a16:creationId xmlns:a16="http://schemas.microsoft.com/office/drawing/2014/main" id="{D75BFF4C-1258-4E02-A5FD-BB959634A762}"/>
+                <a16:creationId xmlns:a16="http://schemas.microsoft.com/office/drawing/2014/main" id="{7A9F8D60-1272-41BD-AD49-8A02FAB4CB3D}"/>
               </a:ext>
             </a:extLst>
           </p:cNvPr>
@@ -18310,7 +18310,7 @@
           <p:cNvPr id="12" name="">
             <a:extLst xmlns:a="http://schemas.openxmlformats.org/drawingml/2006/main">
               <a:ext uri="{FF2B5EF4-FFF2-40B4-BE49-F238E27FC236}">
-                <a16:creationId xmlns:a16="http://schemas.microsoft.com/office/drawing/2014/main" id="{67C204FB-16F6-425F-BE67-DBD08C3D428F}"/>
+                <a16:creationId xmlns:a16="http://schemas.microsoft.com/office/drawing/2014/main" id="{ED713F14-CFA5-47F4-AF5B-A5C98ECD272A}"/>
               </a:ext>
             </a:extLst>
           </p:cNvPr>
@@ -18374,7 +18374,7 @@
           <p:cNvPr id="13" name="">
             <a:extLst xmlns:a="http://schemas.openxmlformats.org/drawingml/2006/main">
               <a:ext uri="{FF2B5EF4-FFF2-40B4-BE49-F238E27FC236}">
-                <a16:creationId xmlns:a16="http://schemas.microsoft.com/office/drawing/2014/main" id="{76564584-AF19-400E-88DC-592584BFEA0C}"/>
+                <a16:creationId xmlns:a16="http://schemas.microsoft.com/office/drawing/2014/main" id="{9600FE4E-06F3-44C8-9E57-36D57ADEA6B9}"/>
               </a:ext>
             </a:extLst>
           </p:cNvPr>
@@ -18407,7 +18407,7 @@
           <p:cNvPr id="14" name="">
             <a:extLst xmlns:a="http://schemas.openxmlformats.org/drawingml/2006/main">
               <a:ext uri="{FF2B5EF4-FFF2-40B4-BE49-F238E27FC236}">
-                <a16:creationId xmlns:a16="http://schemas.microsoft.com/office/drawing/2014/main" id="{DE7B975C-DADF-40EB-A55F-2CD0A284DC8C}"/>
+                <a16:creationId xmlns:a16="http://schemas.microsoft.com/office/drawing/2014/main" id="{EDA34A87-F175-4C39-BF41-6836759847E7}"/>
               </a:ext>
             </a:extLst>
           </p:cNvPr>
@@ -18471,7 +18471,7 @@
           <p:cNvPr id="15" name="">
             <a:extLst xmlns:a="http://schemas.openxmlformats.org/drawingml/2006/main">
               <a:ext uri="{FF2B5EF4-FFF2-40B4-BE49-F238E27FC236}">
-                <a16:creationId xmlns:a16="http://schemas.microsoft.com/office/drawing/2014/main" id="{11413294-08BC-4CC1-8C29-7EFA17906C67}"/>
+                <a16:creationId xmlns:a16="http://schemas.microsoft.com/office/drawing/2014/main" id="{893DFB92-D499-4044-8E0A-AFF70B62FBAC}"/>
               </a:ext>
             </a:extLst>
           </p:cNvPr>
@@ -18504,7 +18504,7 @@
           <p:cNvPr id="16" name="">
             <a:extLst xmlns:a="http://schemas.openxmlformats.org/drawingml/2006/main">
               <a:ext uri="{FF2B5EF4-FFF2-40B4-BE49-F238E27FC236}">
-                <a16:creationId xmlns:a16="http://schemas.microsoft.com/office/drawing/2014/main" id="{360EFE5E-0A92-4F99-A6D4-12CFDDCC7A14}"/>
+                <a16:creationId xmlns:a16="http://schemas.microsoft.com/office/drawing/2014/main" id="{11B00419-BED4-45C4-A280-3166AE390F83}"/>
               </a:ext>
             </a:extLst>
           </p:cNvPr>
@@ -18568,7 +18568,7 @@
           <p:cNvPr id="17" name="">
             <a:extLst xmlns:a="http://schemas.openxmlformats.org/drawingml/2006/main">
               <a:ext uri="{FF2B5EF4-FFF2-40B4-BE49-F238E27FC236}">
-                <a16:creationId xmlns:a16="http://schemas.microsoft.com/office/drawing/2014/main" id="{C0C44A48-8726-4C4C-8F30-5D7D59434450}"/>
+                <a16:creationId xmlns:a16="http://schemas.microsoft.com/office/drawing/2014/main" id="{C152251D-8DC3-4BEC-80BB-92B5C7CC16B2}"/>
               </a:ext>
             </a:extLst>
           </p:cNvPr>
@@ -18632,7 +18632,7 @@
           <p:cNvPr id="18" name="">
             <a:extLst xmlns:a="http://schemas.openxmlformats.org/drawingml/2006/main">
               <a:ext uri="{FF2B5EF4-FFF2-40B4-BE49-F238E27FC236}">
-                <a16:creationId xmlns:a16="http://schemas.microsoft.com/office/drawing/2014/main" id="{A1D9DDB8-EACA-4485-B917-B39F92124209}"/>
+                <a16:creationId xmlns:a16="http://schemas.microsoft.com/office/drawing/2014/main" id="{C470A6C7-01D0-4519-A477-847551D0D5BC}"/>
               </a:ext>
             </a:extLst>
           </p:cNvPr>
@@ -18665,7 +18665,7 @@
           <p:cNvPr id="19" name="">
             <a:extLst xmlns:a="http://schemas.openxmlformats.org/drawingml/2006/main">
               <a:ext uri="{FF2B5EF4-FFF2-40B4-BE49-F238E27FC236}">
-                <a16:creationId xmlns:a16="http://schemas.microsoft.com/office/drawing/2014/main" id="{8F76C182-DF11-4775-86E6-1BC462128B36}"/>
+                <a16:creationId xmlns:a16="http://schemas.microsoft.com/office/drawing/2014/main" id="{B96117F0-085B-4596-BF13-DF5FFA7B4552}"/>
               </a:ext>
             </a:extLst>
           </p:cNvPr>
@@ -18729,7 +18729,7 @@
           <p:cNvPr id="20" name="">
             <a:extLst xmlns:a="http://schemas.openxmlformats.org/drawingml/2006/main">
               <a:ext uri="{FF2B5EF4-FFF2-40B4-BE49-F238E27FC236}">
-                <a16:creationId xmlns:a16="http://schemas.microsoft.com/office/drawing/2014/main" id="{362D6B41-EFAA-4EBB-ACA8-D36EBDCF741C}"/>
+                <a16:creationId xmlns:a16="http://schemas.microsoft.com/office/drawing/2014/main" id="{A8E5D597-96F9-4D22-95D6-3E8C44E68F16}"/>
               </a:ext>
             </a:extLst>
           </p:cNvPr>
@@ -18762,7 +18762,7 @@
           <p:cNvPr id="21" name="">
             <a:extLst xmlns:a="http://schemas.openxmlformats.org/drawingml/2006/main">
               <a:ext uri="{FF2B5EF4-FFF2-40B4-BE49-F238E27FC236}">
-                <a16:creationId xmlns:a16="http://schemas.microsoft.com/office/drawing/2014/main" id="{C3DE8992-C032-4EBD-B637-568D7BD6B110}"/>
+                <a16:creationId xmlns:a16="http://schemas.microsoft.com/office/drawing/2014/main" id="{AE06C150-BE3E-485D-9E49-D5F7878A4F7F}"/>
               </a:ext>
             </a:extLst>
           </p:cNvPr>
@@ -18826,7 +18826,7 @@
           <p:cNvPr id="22" name="">
             <a:extLst xmlns:a="http://schemas.openxmlformats.org/drawingml/2006/main">
               <a:ext uri="{FF2B5EF4-FFF2-40B4-BE49-F238E27FC236}">
-                <a16:creationId xmlns:a16="http://schemas.microsoft.com/office/drawing/2014/main" id="{358F6CB5-20EF-4D33-8D72-CBF9D3019193}"/>
+                <a16:creationId xmlns:a16="http://schemas.microsoft.com/office/drawing/2014/main" id="{8E7656DE-486A-455C-9CC4-5C8BC9440F5F}"/>
               </a:ext>
             </a:extLst>
           </p:cNvPr>
@@ -18859,7 +18859,7 @@
           <p:cNvPr id="23" name="">
             <a:extLst xmlns:a="http://schemas.openxmlformats.org/drawingml/2006/main">
               <a:ext uri="{FF2B5EF4-FFF2-40B4-BE49-F238E27FC236}">
-                <a16:creationId xmlns:a16="http://schemas.microsoft.com/office/drawing/2014/main" id="{E89A0B94-C490-446C-B0AD-86F4399A08AA}"/>
+                <a16:creationId xmlns:a16="http://schemas.microsoft.com/office/drawing/2014/main" id="{7AC88DAF-DD63-4EF2-A582-19AA47E16038}"/>
               </a:ext>
             </a:extLst>
           </p:cNvPr>
@@ -18923,7 +18923,7 @@
           <p:cNvPr id="24" name="">
             <a:extLst xmlns:a="http://schemas.openxmlformats.org/drawingml/2006/main">
               <a:ext uri="{FF2B5EF4-FFF2-40B4-BE49-F238E27FC236}">
-                <a16:creationId xmlns:a16="http://schemas.microsoft.com/office/drawing/2014/main" id="{6131DB2F-7384-4C10-8F1D-042CB8C5D745}"/>
+                <a16:creationId xmlns:a16="http://schemas.microsoft.com/office/drawing/2014/main" id="{F71E432E-0FBD-4FD3-AEEA-EA262DE9598E}"/>
               </a:ext>
             </a:extLst>
           </p:cNvPr>
@@ -18956,7 +18956,7 @@
           <p:cNvPr id="25" name="">
             <a:extLst xmlns:a="http://schemas.openxmlformats.org/drawingml/2006/main">
               <a:ext uri="{FF2B5EF4-FFF2-40B4-BE49-F238E27FC236}">
-                <a16:creationId xmlns:a16="http://schemas.microsoft.com/office/drawing/2014/main" id="{DE22CCA1-CB6D-4691-B6D5-F49B7D1ABB8D}"/>
+                <a16:creationId xmlns:a16="http://schemas.microsoft.com/office/drawing/2014/main" id="{1E98E710-A327-44F4-BCC6-3E269777686F}"/>
               </a:ext>
             </a:extLst>
           </p:cNvPr>
@@ -19020,7 +19020,7 @@
           <p:cNvPr id="26" name="">
             <a:extLst xmlns:a="http://schemas.openxmlformats.org/drawingml/2006/main">
               <a:ext uri="{FF2B5EF4-FFF2-40B4-BE49-F238E27FC236}">
-                <a16:creationId xmlns:a16="http://schemas.microsoft.com/office/drawing/2014/main" id="{DED4D284-FF45-414B-A23C-E52374A739F7}"/>
+                <a16:creationId xmlns:a16="http://schemas.microsoft.com/office/drawing/2014/main" id="{869A5B67-B050-4071-976C-885E0B4A380B}"/>
               </a:ext>
             </a:extLst>
           </p:cNvPr>
@@ -19053,7 +19053,7 @@
           <p:cNvPr id="27" name="">
             <a:extLst xmlns:a="http://schemas.openxmlformats.org/drawingml/2006/main">
               <a:ext uri="{FF2B5EF4-FFF2-40B4-BE49-F238E27FC236}">
-                <a16:creationId xmlns:a16="http://schemas.microsoft.com/office/drawing/2014/main" id="{A978938F-7592-4214-943F-F2817EA45508}"/>
+                <a16:creationId xmlns:a16="http://schemas.microsoft.com/office/drawing/2014/main" id="{AD1B12C0-839F-4971-828A-E0BDC6FAE109}"/>
               </a:ext>
             </a:extLst>
           </p:cNvPr>
@@ -19117,7 +19117,7 @@
           <p:cNvPr id="28" name="">
             <a:extLst xmlns:a="http://schemas.openxmlformats.org/drawingml/2006/main">
               <a:ext uri="{FF2B5EF4-FFF2-40B4-BE49-F238E27FC236}">
-                <a16:creationId xmlns:a16="http://schemas.microsoft.com/office/drawing/2014/main" id="{12324B17-1A58-4669-BA15-EAA847D2A024}"/>
+                <a16:creationId xmlns:a16="http://schemas.microsoft.com/office/drawing/2014/main" id="{263CDE27-150C-424D-BE95-455D8BD73D11}"/>
               </a:ext>
             </a:extLst>
           </p:cNvPr>
@@ -19181,7 +19181,7 @@
           <p:cNvPr id="29" name="">
             <a:extLst xmlns:a="http://schemas.openxmlformats.org/drawingml/2006/main">
               <a:ext uri="{FF2B5EF4-FFF2-40B4-BE49-F238E27FC236}">
-                <a16:creationId xmlns:a16="http://schemas.microsoft.com/office/drawing/2014/main" id="{BC99BEF4-1256-4466-A496-7988B8F264E8}"/>
+                <a16:creationId xmlns:a16="http://schemas.microsoft.com/office/drawing/2014/main" id="{C5F2D153-BC2B-4FF4-ACE6-B4DB0CA2E39C}"/>
               </a:ext>
             </a:extLst>
           </p:cNvPr>
@@ -19243,7 +19243,7 @@
     </p:spTree>
     <p:extLst>
       <p:ext uri="{BB962C8B-B14F-4D97-AF65-F5344CB8AC3E}">
-        <p14:creationId xmlns:p14="http://schemas.microsoft.com/office/powerpoint/2010/main" val="91379027"/>
+        <p14:creationId xmlns:p14="http://schemas.microsoft.com/office/powerpoint/2010/main" val="309246034"/>
       </p:ext>
     </p:extLst>
   </p:cSld>
@@ -19267,7 +19267,7 @@
           <p:cNvPr id="1" name="">
             <a:extLst xmlns:a="http://schemas.openxmlformats.org/drawingml/2006/main">
               <a:ext uri="{FF2B5EF4-FFF2-40B4-BE49-F238E27FC236}">
-                <a16:creationId xmlns:a16="http://schemas.microsoft.com/office/drawing/2014/main" id="{A1844978-6A96-4C1B-A33E-F3FA5ED098B2}"/>
+                <a16:creationId xmlns:a16="http://schemas.microsoft.com/office/drawing/2014/main" id="{191A86FB-D602-428E-B543-6C9E4F9A2282}"/>
               </a:ext>
             </a:extLst>
           </p:cNvPr>
@@ -19300,7 +19300,7 @@
           <p:cNvPr id="2" name="">
             <a:extLst xmlns:a="http://schemas.openxmlformats.org/drawingml/2006/main">
               <a:ext uri="{FF2B5EF4-FFF2-40B4-BE49-F238E27FC236}">
-                <a16:creationId xmlns:a16="http://schemas.microsoft.com/office/drawing/2014/main" id="{A1A50176-A9E4-4966-8A4F-DEF23609CADC}"/>
+                <a16:creationId xmlns:a16="http://schemas.microsoft.com/office/drawing/2014/main" id="{B415F412-290B-48BF-A4D8-04CA1BDFFCFF}"/>
               </a:ext>
             </a:extLst>
           </p:cNvPr>
@@ -19333,7 +19333,7 @@
           <p:cNvPr id="3" name="">
             <a:extLst xmlns:a="http://schemas.openxmlformats.org/drawingml/2006/main">
               <a:ext uri="{FF2B5EF4-FFF2-40B4-BE49-F238E27FC236}">
-                <a16:creationId xmlns:a16="http://schemas.microsoft.com/office/drawing/2014/main" id="{A96CA180-EB62-4260-B906-A446281A1148}"/>
+                <a16:creationId xmlns:a16="http://schemas.microsoft.com/office/drawing/2014/main" id="{910A1315-45BD-4246-8556-3739379EAD90}"/>
               </a:ext>
             </a:extLst>
           </p:cNvPr>
@@ -19397,7 +19397,7 @@
           <p:cNvPr id="4" name="">
             <a:extLst xmlns:a="http://schemas.openxmlformats.org/drawingml/2006/main">
               <a:ext uri="{FF2B5EF4-FFF2-40B4-BE49-F238E27FC236}">
-                <a16:creationId xmlns:a16="http://schemas.microsoft.com/office/drawing/2014/main" id="{943CD71D-482A-4D08-9C9D-3C3542BADE35}"/>
+                <a16:creationId xmlns:a16="http://schemas.microsoft.com/office/drawing/2014/main" id="{E58079F1-B092-4BB9-9679-BD037E999927}"/>
               </a:ext>
             </a:extLst>
           </p:cNvPr>
@@ -19461,7 +19461,7 @@
           <p:cNvPr id="5" name="">
             <a:extLst xmlns:a="http://schemas.openxmlformats.org/drawingml/2006/main">
               <a:ext uri="{FF2B5EF4-FFF2-40B4-BE49-F238E27FC236}">
-                <a16:creationId xmlns:a16="http://schemas.microsoft.com/office/drawing/2014/main" id="{2E23333B-C8CD-4EA4-8C4B-57538943D5B6}"/>
+                <a16:creationId xmlns:a16="http://schemas.microsoft.com/office/drawing/2014/main" id="{7C8EC484-AE21-47FF-8142-D6FEC9277259}"/>
               </a:ext>
             </a:extLst>
           </p:cNvPr>
@@ -19494,7 +19494,7 @@
           <p:cNvPr id="6" name="">
             <a:extLst xmlns:a="http://schemas.openxmlformats.org/drawingml/2006/main">
               <a:ext uri="{FF2B5EF4-FFF2-40B4-BE49-F238E27FC236}">
-                <a16:creationId xmlns:a16="http://schemas.microsoft.com/office/drawing/2014/main" id="{BB6A68BE-2A4E-4199-93FF-124220DFD9F8}"/>
+                <a16:creationId xmlns:a16="http://schemas.microsoft.com/office/drawing/2014/main" id="{93EB048F-C75E-416B-BF46-47D63F547B87}"/>
               </a:ext>
             </a:extLst>
           </p:cNvPr>
@@ -19527,7 +19527,7 @@
           <p:cNvPr id="7" name="">
             <a:extLst xmlns:a="http://schemas.openxmlformats.org/drawingml/2006/main">
               <a:ext uri="{FF2B5EF4-FFF2-40B4-BE49-F238E27FC236}">
-                <a16:creationId xmlns:a16="http://schemas.microsoft.com/office/drawing/2014/main" id="{E02B7C60-ABC6-45D6-ACAE-DDC4202E578D}"/>
+                <a16:creationId xmlns:a16="http://schemas.microsoft.com/office/drawing/2014/main" id="{FE27FC1F-9605-4387-9937-B816EE6265B9}"/>
               </a:ext>
             </a:extLst>
           </p:cNvPr>
@@ -19591,7 +19591,7 @@
           <p:cNvPr id="8" name="">
             <a:extLst xmlns:a="http://schemas.openxmlformats.org/drawingml/2006/main">
               <a:ext uri="{FF2B5EF4-FFF2-40B4-BE49-F238E27FC236}">
-                <a16:creationId xmlns:a16="http://schemas.microsoft.com/office/drawing/2014/main" id="{3EA99E4E-20EB-4EFA-8229-2177DC1E8DF9}"/>
+                <a16:creationId xmlns:a16="http://schemas.microsoft.com/office/drawing/2014/main" id="{0D132BCD-5B6E-41BE-AD40-934B6EC127DA}"/>
               </a:ext>
             </a:extLst>
           </p:cNvPr>
@@ -19624,7 +19624,7 @@
           <p:cNvPr id="9" name="">
             <a:extLst xmlns:a="http://schemas.openxmlformats.org/drawingml/2006/main">
               <a:ext uri="{FF2B5EF4-FFF2-40B4-BE49-F238E27FC236}">
-                <a16:creationId xmlns:a16="http://schemas.microsoft.com/office/drawing/2014/main" id="{D56AD214-C703-4A83-9B96-91B8F10B1F08}"/>
+                <a16:creationId xmlns:a16="http://schemas.microsoft.com/office/drawing/2014/main" id="{0B4BCB7D-285B-4400-BF05-088633ACDCCF}"/>
               </a:ext>
             </a:extLst>
           </p:cNvPr>
@@ -19688,7 +19688,7 @@
           <p:cNvPr id="10" name="">
             <a:extLst xmlns:a="http://schemas.openxmlformats.org/drawingml/2006/main">
               <a:ext uri="{FF2B5EF4-FFF2-40B4-BE49-F238E27FC236}">
-                <a16:creationId xmlns:a16="http://schemas.microsoft.com/office/drawing/2014/main" id="{584BD92C-67E2-4141-95DD-814AD5C982C1}"/>
+                <a16:creationId xmlns:a16="http://schemas.microsoft.com/office/drawing/2014/main" id="{E6371B16-5F4E-4E79-8701-65C4FCB6E6E0}"/>
               </a:ext>
             </a:extLst>
           </p:cNvPr>
@@ -19721,7 +19721,7 @@
           <p:cNvPr id="11" name="">
             <a:extLst xmlns:a="http://schemas.openxmlformats.org/drawingml/2006/main">
               <a:ext uri="{FF2B5EF4-FFF2-40B4-BE49-F238E27FC236}">
-                <a16:creationId xmlns:a16="http://schemas.microsoft.com/office/drawing/2014/main" id="{921418CC-CEA2-49DB-BC36-A4B417484882}"/>
+                <a16:creationId xmlns:a16="http://schemas.microsoft.com/office/drawing/2014/main" id="{5C2BDD7B-E6B3-4AAC-98E5-781666764A87}"/>
               </a:ext>
             </a:extLst>
           </p:cNvPr>
@@ -19785,7 +19785,7 @@
           <p:cNvPr id="12" name="">
             <a:extLst xmlns:a="http://schemas.openxmlformats.org/drawingml/2006/main">
               <a:ext uri="{FF2B5EF4-FFF2-40B4-BE49-F238E27FC236}">
-                <a16:creationId xmlns:a16="http://schemas.microsoft.com/office/drawing/2014/main" id="{85D27B63-7DCA-407F-800F-FC4F4ABA6E1F}"/>
+                <a16:creationId xmlns:a16="http://schemas.microsoft.com/office/drawing/2014/main" id="{67367250-5754-433D-B0C4-7BD8BDA88C68}"/>
               </a:ext>
             </a:extLst>
           </p:cNvPr>
@@ -19818,7 +19818,7 @@
           <p:cNvPr id="13" name="">
             <a:extLst xmlns:a="http://schemas.openxmlformats.org/drawingml/2006/main">
               <a:ext uri="{FF2B5EF4-FFF2-40B4-BE49-F238E27FC236}">
-                <a16:creationId xmlns:a16="http://schemas.microsoft.com/office/drawing/2014/main" id="{BD1DD009-43FB-4761-BE46-0C1824A698C5}"/>
+                <a16:creationId xmlns:a16="http://schemas.microsoft.com/office/drawing/2014/main" id="{1131EE58-FBB8-4289-9C63-816374ECDD57}"/>
               </a:ext>
             </a:extLst>
           </p:cNvPr>
@@ -19882,7 +19882,7 @@
           <p:cNvPr id="14" name="">
             <a:extLst xmlns:a="http://schemas.openxmlformats.org/drawingml/2006/main">
               <a:ext uri="{FF2B5EF4-FFF2-40B4-BE49-F238E27FC236}">
-                <a16:creationId xmlns:a16="http://schemas.microsoft.com/office/drawing/2014/main" id="{463EAFE1-E535-4CB0-B3E0-83EDB4E21A5F}"/>
+                <a16:creationId xmlns:a16="http://schemas.microsoft.com/office/drawing/2014/main" id="{D15F6957-CC15-4E23-A584-F16D5D4DB28B}"/>
               </a:ext>
             </a:extLst>
           </p:cNvPr>
@@ -19915,7 +19915,7 @@
           <p:cNvPr id="15" name="">
             <a:extLst xmlns:a="http://schemas.openxmlformats.org/drawingml/2006/main">
               <a:ext uri="{FF2B5EF4-FFF2-40B4-BE49-F238E27FC236}">
-                <a16:creationId xmlns:a16="http://schemas.microsoft.com/office/drawing/2014/main" id="{805AD7D8-8B40-4086-B32F-D5FD048798B5}"/>
+                <a16:creationId xmlns:a16="http://schemas.microsoft.com/office/drawing/2014/main" id="{83350407-72FF-4FD3-A937-111153444AC7}"/>
               </a:ext>
             </a:extLst>
           </p:cNvPr>
@@ -19979,7 +19979,7 @@
           <p:cNvPr id="16" name="">
             <a:extLst xmlns:a="http://schemas.openxmlformats.org/drawingml/2006/main">
               <a:ext uri="{FF2B5EF4-FFF2-40B4-BE49-F238E27FC236}">
-                <a16:creationId xmlns:a16="http://schemas.microsoft.com/office/drawing/2014/main" id="{41B225A2-EE2F-4387-B657-D6A30785C4F8}"/>
+                <a16:creationId xmlns:a16="http://schemas.microsoft.com/office/drawing/2014/main" id="{4287941B-B3F5-4D74-91BF-81ECB69BF3FE}"/>
               </a:ext>
             </a:extLst>
           </p:cNvPr>
@@ -20012,7 +20012,7 @@
           <p:cNvPr id="17" name="">
             <a:extLst xmlns:a="http://schemas.openxmlformats.org/drawingml/2006/main">
               <a:ext uri="{FF2B5EF4-FFF2-40B4-BE49-F238E27FC236}">
-                <a16:creationId xmlns:a16="http://schemas.microsoft.com/office/drawing/2014/main" id="{D478BC30-05FC-4810-873A-77AC7A5A34EA}"/>
+                <a16:creationId xmlns:a16="http://schemas.microsoft.com/office/drawing/2014/main" id="{2A0714EE-CD15-48C2-9EEF-84E5F4BD7A66}"/>
               </a:ext>
             </a:extLst>
           </p:cNvPr>
@@ -20076,7 +20076,7 @@
           <p:cNvPr id="18" name="">
             <a:extLst xmlns:a="http://schemas.openxmlformats.org/drawingml/2006/main">
               <a:ext uri="{FF2B5EF4-FFF2-40B4-BE49-F238E27FC236}">
-                <a16:creationId xmlns:a16="http://schemas.microsoft.com/office/drawing/2014/main" id="{53FE9B89-0ED1-40E7-AC81-A1D6B4971BD0}"/>
+                <a16:creationId xmlns:a16="http://schemas.microsoft.com/office/drawing/2014/main" id="{87C1AFFD-FD9C-4B56-ABC4-73293E92A245}"/>
               </a:ext>
             </a:extLst>
           </p:cNvPr>
@@ -20140,7 +20140,7 @@
           <p:cNvPr id="19" name="">
             <a:extLst xmlns:a="http://schemas.openxmlformats.org/drawingml/2006/main">
               <a:ext uri="{FF2B5EF4-FFF2-40B4-BE49-F238E27FC236}">
-                <a16:creationId xmlns:a16="http://schemas.microsoft.com/office/drawing/2014/main" id="{0BDD9110-99D0-46A1-8651-287FEC2AE452}"/>
+                <a16:creationId xmlns:a16="http://schemas.microsoft.com/office/drawing/2014/main" id="{75561949-41C2-422C-9943-D48D2380BEC1}"/>
               </a:ext>
             </a:extLst>
           </p:cNvPr>
@@ -20202,7 +20202,7 @@
     </p:spTree>
     <p:extLst>
       <p:ext uri="{BB962C8B-B14F-4D97-AF65-F5344CB8AC3E}">
-        <p14:creationId xmlns:p14="http://schemas.microsoft.com/office/powerpoint/2010/main" val="602608934"/>
+        <p14:creationId xmlns:p14="http://schemas.microsoft.com/office/powerpoint/2010/main" val="521720312"/>
       </p:ext>
     </p:extLst>
   </p:cSld>
@@ -20226,7 +20226,7 @@
           <p:cNvPr id="1" name="">
             <a:extLst xmlns:a="http://schemas.openxmlformats.org/drawingml/2006/main">
               <a:ext uri="{FF2B5EF4-FFF2-40B4-BE49-F238E27FC236}">
-                <a16:creationId xmlns:a16="http://schemas.microsoft.com/office/drawing/2014/main" id="{BFD61871-97F9-46F4-B775-71D96CFD52BF}"/>
+                <a16:creationId xmlns:a16="http://schemas.microsoft.com/office/drawing/2014/main" id="{F7F91CFA-22EB-44DC-BE3C-F9D897D77057}"/>
               </a:ext>
             </a:extLst>
           </p:cNvPr>
@@ -20259,7 +20259,7 @@
           <p:cNvPr id="2" name="">
             <a:extLst xmlns:a="http://schemas.openxmlformats.org/drawingml/2006/main">
               <a:ext uri="{FF2B5EF4-FFF2-40B4-BE49-F238E27FC236}">
-                <a16:creationId xmlns:a16="http://schemas.microsoft.com/office/drawing/2014/main" id="{8F54247C-7333-4BA2-A22C-1EA2D4F5D203}"/>
+                <a16:creationId xmlns:a16="http://schemas.microsoft.com/office/drawing/2014/main" id="{08ECF063-47B4-40D8-870C-F8D4A3E6B6D1}"/>
               </a:ext>
             </a:extLst>
           </p:cNvPr>
@@ -20292,7 +20292,7 @@
           <p:cNvPr id="3" name="">
             <a:extLst xmlns:a="http://schemas.openxmlformats.org/drawingml/2006/main">
               <a:ext uri="{FF2B5EF4-FFF2-40B4-BE49-F238E27FC236}">
-                <a16:creationId xmlns:a16="http://schemas.microsoft.com/office/drawing/2014/main" id="{747B185C-ECE4-44FD-A37B-9C77DBD7D9F7}"/>
+                <a16:creationId xmlns:a16="http://schemas.microsoft.com/office/drawing/2014/main" id="{FFBF6D6A-EB3A-469D-9419-BFFFC022F5D8}"/>
               </a:ext>
             </a:extLst>
           </p:cNvPr>
@@ -20356,7 +20356,7 @@
           <p:cNvPr id="4" name="">
             <a:extLst xmlns:a="http://schemas.openxmlformats.org/drawingml/2006/main">
               <a:ext uri="{FF2B5EF4-FFF2-40B4-BE49-F238E27FC236}">
-                <a16:creationId xmlns:a16="http://schemas.microsoft.com/office/drawing/2014/main" id="{97FD88EB-31E6-4722-BB61-6CB059E1F6F2}"/>
+                <a16:creationId xmlns:a16="http://schemas.microsoft.com/office/drawing/2014/main" id="{BECB65C6-FC0F-4259-B5E5-93C66645AF1C}"/>
               </a:ext>
             </a:extLst>
           </p:cNvPr>
@@ -20420,7 +20420,7 @@
           <p:cNvPr id="5" name="">
             <a:extLst xmlns:a="http://schemas.openxmlformats.org/drawingml/2006/main">
               <a:ext uri="{FF2B5EF4-FFF2-40B4-BE49-F238E27FC236}">
-                <a16:creationId xmlns:a16="http://schemas.microsoft.com/office/drawing/2014/main" id="{9DBFF22C-670F-4A73-BF78-EBC38522C069}"/>
+                <a16:creationId xmlns:a16="http://schemas.microsoft.com/office/drawing/2014/main" id="{066B2A6D-8FA0-4DA3-B69B-F0BECFCF7FE5}"/>
               </a:ext>
             </a:extLst>
           </p:cNvPr>
@@ -20453,7 +20453,7 @@
           <p:cNvPr id="6" name="">
             <a:extLst xmlns:a="http://schemas.openxmlformats.org/drawingml/2006/main">
               <a:ext uri="{FF2B5EF4-FFF2-40B4-BE49-F238E27FC236}">
-                <a16:creationId xmlns:a16="http://schemas.microsoft.com/office/drawing/2014/main" id="{DB765120-C402-4A25-9DC0-D5701CE59CA6}"/>
+                <a16:creationId xmlns:a16="http://schemas.microsoft.com/office/drawing/2014/main" id="{2469839B-196E-4C8B-848F-1F915B4F2F87}"/>
               </a:ext>
             </a:extLst>
           </p:cNvPr>
@@ -20486,7 +20486,7 @@
           <p:cNvPr id="7" name="">
             <a:extLst xmlns:a="http://schemas.openxmlformats.org/drawingml/2006/main">
               <a:ext uri="{FF2B5EF4-FFF2-40B4-BE49-F238E27FC236}">
-                <a16:creationId xmlns:a16="http://schemas.microsoft.com/office/drawing/2014/main" id="{18237ED8-FB63-4805-A666-292EA5E92049}"/>
+                <a16:creationId xmlns:a16="http://schemas.microsoft.com/office/drawing/2014/main" id="{231731AC-3594-44F6-BA21-E634E87F5703}"/>
               </a:ext>
             </a:extLst>
           </p:cNvPr>
@@ -20550,7 +20550,7 @@
           <p:cNvPr id="8" name="">
             <a:extLst xmlns:a="http://schemas.openxmlformats.org/drawingml/2006/main">
               <a:ext uri="{FF2B5EF4-FFF2-40B4-BE49-F238E27FC236}">
-                <a16:creationId xmlns:a16="http://schemas.microsoft.com/office/drawing/2014/main" id="{B50CF455-072B-468C-A64F-C9518C76DC69}"/>
+                <a16:creationId xmlns:a16="http://schemas.microsoft.com/office/drawing/2014/main" id="{FAE7142A-E0C8-47A3-A7C6-41D4C5B8B060}"/>
               </a:ext>
             </a:extLst>
           </p:cNvPr>
@@ -20583,7 +20583,7 @@
           <p:cNvPr id="9" name="">
             <a:extLst xmlns:a="http://schemas.openxmlformats.org/drawingml/2006/main">
               <a:ext uri="{FF2B5EF4-FFF2-40B4-BE49-F238E27FC236}">
-                <a16:creationId xmlns:a16="http://schemas.microsoft.com/office/drawing/2014/main" id="{4D3988AD-03D8-4557-8C7A-D6A5E8F20DDA}"/>
+                <a16:creationId xmlns:a16="http://schemas.microsoft.com/office/drawing/2014/main" id="{FA1458EA-B5CF-4600-8CC6-20FF980F342A}"/>
               </a:ext>
             </a:extLst>
           </p:cNvPr>
@@ -20647,7 +20647,7 @@
           <p:cNvPr id="10" name="">
             <a:extLst xmlns:a="http://schemas.openxmlformats.org/drawingml/2006/main">
               <a:ext uri="{FF2B5EF4-FFF2-40B4-BE49-F238E27FC236}">
-                <a16:creationId xmlns:a16="http://schemas.microsoft.com/office/drawing/2014/main" id="{36CB745C-A679-466A-BE70-C38C1F6EF870}"/>
+                <a16:creationId xmlns:a16="http://schemas.microsoft.com/office/drawing/2014/main" id="{8F0DF497-4457-4924-A8AC-8A5C5C4D4493}"/>
               </a:ext>
             </a:extLst>
           </p:cNvPr>
@@ -20680,7 +20680,7 @@
           <p:cNvPr id="11" name="">
             <a:extLst xmlns:a="http://schemas.openxmlformats.org/drawingml/2006/main">
               <a:ext uri="{FF2B5EF4-FFF2-40B4-BE49-F238E27FC236}">
-                <a16:creationId xmlns:a16="http://schemas.microsoft.com/office/drawing/2014/main" id="{D835BC9D-2D60-499D-830A-08072C1186DE}"/>
+                <a16:creationId xmlns:a16="http://schemas.microsoft.com/office/drawing/2014/main" id="{50BED319-4F2D-417E-B002-27B227C6A2E1}"/>
               </a:ext>
             </a:extLst>
           </p:cNvPr>
@@ -20744,7 +20744,7 @@
           <p:cNvPr id="12" name="">
             <a:extLst xmlns:a="http://schemas.openxmlformats.org/drawingml/2006/main">
               <a:ext uri="{FF2B5EF4-FFF2-40B4-BE49-F238E27FC236}">
-                <a16:creationId xmlns:a16="http://schemas.microsoft.com/office/drawing/2014/main" id="{A76D77AE-8970-4A0E-97DB-9C6C7541A324}"/>
+                <a16:creationId xmlns:a16="http://schemas.microsoft.com/office/drawing/2014/main" id="{77C27175-D614-4D65-88C7-672514032E30}"/>
               </a:ext>
             </a:extLst>
           </p:cNvPr>
@@ -20777,7 +20777,7 @@
           <p:cNvPr id="13" name="">
             <a:extLst xmlns:a="http://schemas.openxmlformats.org/drawingml/2006/main">
               <a:ext uri="{FF2B5EF4-FFF2-40B4-BE49-F238E27FC236}">
-                <a16:creationId xmlns:a16="http://schemas.microsoft.com/office/drawing/2014/main" id="{88E55F93-635E-49FD-ACD4-2CF9069C43D3}"/>
+                <a16:creationId xmlns:a16="http://schemas.microsoft.com/office/drawing/2014/main" id="{64C83568-3477-4FDA-9CFA-85F90441288B}"/>
               </a:ext>
             </a:extLst>
           </p:cNvPr>
@@ -20841,7 +20841,7 @@
           <p:cNvPr id="14" name="">
             <a:extLst xmlns:a="http://schemas.openxmlformats.org/drawingml/2006/main">
               <a:ext uri="{FF2B5EF4-FFF2-40B4-BE49-F238E27FC236}">
-                <a16:creationId xmlns:a16="http://schemas.microsoft.com/office/drawing/2014/main" id="{66C509AC-7DE6-4FAA-8C05-F1480E820B03}"/>
+                <a16:creationId xmlns:a16="http://schemas.microsoft.com/office/drawing/2014/main" id="{054B8116-376A-4FFE-BF3E-57A1E4C44A43}"/>
               </a:ext>
             </a:extLst>
           </p:cNvPr>
@@ -20874,7 +20874,7 @@
           <p:cNvPr id="15" name="">
             <a:extLst xmlns:a="http://schemas.openxmlformats.org/drawingml/2006/main">
               <a:ext uri="{FF2B5EF4-FFF2-40B4-BE49-F238E27FC236}">
-                <a16:creationId xmlns:a16="http://schemas.microsoft.com/office/drawing/2014/main" id="{3EB70120-E11D-4079-8FD2-8DABFB486166}"/>
+                <a16:creationId xmlns:a16="http://schemas.microsoft.com/office/drawing/2014/main" id="{EB9EB01C-C81E-4FF6-9AC1-8E69523FF624}"/>
               </a:ext>
             </a:extLst>
           </p:cNvPr>
@@ -20938,7 +20938,7 @@
           <p:cNvPr id="16" name="">
             <a:extLst xmlns:a="http://schemas.openxmlformats.org/drawingml/2006/main">
               <a:ext uri="{FF2B5EF4-FFF2-40B4-BE49-F238E27FC236}">
-                <a16:creationId xmlns:a16="http://schemas.microsoft.com/office/drawing/2014/main" id="{EDE98CF1-B0CC-426D-95D6-9F7D7454106F}"/>
+                <a16:creationId xmlns:a16="http://schemas.microsoft.com/office/drawing/2014/main" id="{F94452BB-49F4-4065-A2AD-212D0D88C9A2}"/>
               </a:ext>
             </a:extLst>
           </p:cNvPr>
@@ -20971,7 +20971,7 @@
           <p:cNvPr id="17" name="">
             <a:extLst xmlns:a="http://schemas.openxmlformats.org/drawingml/2006/main">
               <a:ext uri="{FF2B5EF4-FFF2-40B4-BE49-F238E27FC236}">
-                <a16:creationId xmlns:a16="http://schemas.microsoft.com/office/drawing/2014/main" id="{DB0022D3-1B02-42B3-9A23-49ABB0677926}"/>
+                <a16:creationId xmlns:a16="http://schemas.microsoft.com/office/drawing/2014/main" id="{94F99CC4-D5AF-407B-B190-7D46C881DA1B}"/>
               </a:ext>
             </a:extLst>
           </p:cNvPr>
@@ -21035,7 +21035,7 @@
           <p:cNvPr id="18" name="">
             <a:extLst xmlns:a="http://schemas.openxmlformats.org/drawingml/2006/main">
               <a:ext uri="{FF2B5EF4-FFF2-40B4-BE49-F238E27FC236}">
-                <a16:creationId xmlns:a16="http://schemas.microsoft.com/office/drawing/2014/main" id="{BF11378B-8E4A-4927-B9D5-272028EEA78C}"/>
+                <a16:creationId xmlns:a16="http://schemas.microsoft.com/office/drawing/2014/main" id="{D4F47875-1B1F-4534-89A4-B8ED06CD0DB8}"/>
               </a:ext>
             </a:extLst>
           </p:cNvPr>
@@ -21099,7 +21099,7 @@
           <p:cNvPr id="19" name="">
             <a:extLst xmlns:a="http://schemas.openxmlformats.org/drawingml/2006/main">
               <a:ext uri="{FF2B5EF4-FFF2-40B4-BE49-F238E27FC236}">
-                <a16:creationId xmlns:a16="http://schemas.microsoft.com/office/drawing/2014/main" id="{28B82062-DD0A-4745-BC26-C114F73BF001}"/>
+                <a16:creationId xmlns:a16="http://schemas.microsoft.com/office/drawing/2014/main" id="{A5864DB2-38C5-419F-9B8B-D10239AC0906}"/>
               </a:ext>
             </a:extLst>
           </p:cNvPr>
@@ -21161,7 +21161,7 @@
     </p:spTree>
     <p:extLst>
       <p:ext uri="{BB962C8B-B14F-4D97-AF65-F5344CB8AC3E}">
-        <p14:creationId xmlns:p14="http://schemas.microsoft.com/office/powerpoint/2010/main" val="64314698"/>
+        <p14:creationId xmlns:p14="http://schemas.microsoft.com/office/powerpoint/2010/main" val="1207421076"/>
       </p:ext>
     </p:extLst>
   </p:cSld>
@@ -21185,7 +21185,7 @@
           <p:cNvPr id="1" name="">
             <a:extLst xmlns:a="http://schemas.openxmlformats.org/drawingml/2006/main">
               <a:ext uri="{FF2B5EF4-FFF2-40B4-BE49-F238E27FC236}">
-                <a16:creationId xmlns:a16="http://schemas.microsoft.com/office/drawing/2014/main" id="{9B90F498-FFE2-4C06-809D-2E3B73ACBD6F}"/>
+                <a16:creationId xmlns:a16="http://schemas.microsoft.com/office/drawing/2014/main" id="{AC45D1A2-F247-495D-8B4C-5024A821A133}"/>
               </a:ext>
             </a:extLst>
           </p:cNvPr>
@@ -21218,7 +21218,7 @@
           <p:cNvPr id="2" name="">
             <a:extLst xmlns:a="http://schemas.openxmlformats.org/drawingml/2006/main">
               <a:ext uri="{FF2B5EF4-FFF2-40B4-BE49-F238E27FC236}">
-                <a16:creationId xmlns:a16="http://schemas.microsoft.com/office/drawing/2014/main" id="{65BBDAC2-2731-4A10-BE61-DF6209186E91}"/>
+                <a16:creationId xmlns:a16="http://schemas.microsoft.com/office/drawing/2014/main" id="{51F9B390-EE0F-425C-8D93-F33D19AF004B}"/>
               </a:ext>
             </a:extLst>
           </p:cNvPr>
@@ -21251,7 +21251,7 @@
           <p:cNvPr id="3" name="">
             <a:extLst xmlns:a="http://schemas.openxmlformats.org/drawingml/2006/main">
               <a:ext uri="{FF2B5EF4-FFF2-40B4-BE49-F238E27FC236}">
-                <a16:creationId xmlns:a16="http://schemas.microsoft.com/office/drawing/2014/main" id="{8F5B750A-F129-41B4-9613-37B0E3B96246}"/>
+                <a16:creationId xmlns:a16="http://schemas.microsoft.com/office/drawing/2014/main" id="{2FB9EAB6-92A6-4A52-A41A-6C33B5B5B2CB}"/>
               </a:ext>
             </a:extLst>
           </p:cNvPr>
@@ -21315,7 +21315,7 @@
           <p:cNvPr id="4" name="">
             <a:extLst xmlns:a="http://schemas.openxmlformats.org/drawingml/2006/main">
               <a:ext uri="{FF2B5EF4-FFF2-40B4-BE49-F238E27FC236}">
-                <a16:creationId xmlns:a16="http://schemas.microsoft.com/office/drawing/2014/main" id="{F57517BE-1E21-468E-9C59-7F219310B895}"/>
+                <a16:creationId xmlns:a16="http://schemas.microsoft.com/office/drawing/2014/main" id="{AD186086-7480-42D0-856A-67BF820DA601}"/>
               </a:ext>
             </a:extLst>
           </p:cNvPr>
@@ -21379,7 +21379,7 @@
           <p:cNvPr id="5" name="">
             <a:extLst xmlns:a="http://schemas.openxmlformats.org/drawingml/2006/main">
               <a:ext uri="{FF2B5EF4-FFF2-40B4-BE49-F238E27FC236}">
-                <a16:creationId xmlns:a16="http://schemas.microsoft.com/office/drawing/2014/main" id="{D276169F-5913-47B4-AC85-61C3E65C64FD}"/>
+                <a16:creationId xmlns:a16="http://schemas.microsoft.com/office/drawing/2014/main" id="{989FCD20-6504-4483-8575-CED7BAC90F6F}"/>
               </a:ext>
             </a:extLst>
           </p:cNvPr>
@@ -21412,7 +21412,7 @@
           <p:cNvPr id="6" name="">
             <a:extLst xmlns:a="http://schemas.openxmlformats.org/drawingml/2006/main">
               <a:ext uri="{FF2B5EF4-FFF2-40B4-BE49-F238E27FC236}">
-                <a16:creationId xmlns:a16="http://schemas.microsoft.com/office/drawing/2014/main" id="{9FC09ED9-8C33-4CE4-B2D6-F1BACDAF88E4}"/>
+                <a16:creationId xmlns:a16="http://schemas.microsoft.com/office/drawing/2014/main" id="{EB5009BE-B007-4BD5-AD22-62D4BFDFC908}"/>
               </a:ext>
             </a:extLst>
           </p:cNvPr>
@@ -21445,7 +21445,7 @@
           <p:cNvPr id="7" name="">
             <a:extLst xmlns:a="http://schemas.openxmlformats.org/drawingml/2006/main">
               <a:ext uri="{FF2B5EF4-FFF2-40B4-BE49-F238E27FC236}">
-                <a16:creationId xmlns:a16="http://schemas.microsoft.com/office/drawing/2014/main" id="{1E187AF9-BF8F-4C12-9C0E-D5F52F19165F}"/>
+                <a16:creationId xmlns:a16="http://schemas.microsoft.com/office/drawing/2014/main" id="{9F9074CC-E547-4BED-9DD9-A0D67F2D7554}"/>
               </a:ext>
             </a:extLst>
           </p:cNvPr>
@@ -21509,7 +21509,7 @@
           <p:cNvPr id="8" name="">
             <a:extLst xmlns:a="http://schemas.openxmlformats.org/drawingml/2006/main">
               <a:ext uri="{FF2B5EF4-FFF2-40B4-BE49-F238E27FC236}">
-                <a16:creationId xmlns:a16="http://schemas.microsoft.com/office/drawing/2014/main" id="{CD739896-1601-4246-996F-3F3F55ECE82D}"/>
+                <a16:creationId xmlns:a16="http://schemas.microsoft.com/office/drawing/2014/main" id="{A20A7AFD-2254-4466-A675-46A4CFD1053C}"/>
               </a:ext>
             </a:extLst>
           </p:cNvPr>
@@ -21542,7 +21542,7 @@
           <p:cNvPr id="9" name="">
             <a:extLst xmlns:a="http://schemas.openxmlformats.org/drawingml/2006/main">
               <a:ext uri="{FF2B5EF4-FFF2-40B4-BE49-F238E27FC236}">
-                <a16:creationId xmlns:a16="http://schemas.microsoft.com/office/drawing/2014/main" id="{3F2D88F3-8D83-45BC-9B92-28E9F7B6B75E}"/>
+                <a16:creationId xmlns:a16="http://schemas.microsoft.com/office/drawing/2014/main" id="{9BC1820B-587C-4B38-8956-0BBE48691F5F}"/>
               </a:ext>
             </a:extLst>
           </p:cNvPr>
@@ -21606,7 +21606,7 @@
           <p:cNvPr id="10" name="">
             <a:extLst xmlns:a="http://schemas.openxmlformats.org/drawingml/2006/main">
               <a:ext uri="{FF2B5EF4-FFF2-40B4-BE49-F238E27FC236}">
-                <a16:creationId xmlns:a16="http://schemas.microsoft.com/office/drawing/2014/main" id="{ED2169AE-A260-433F-B4A8-73154BDDC214}"/>
+                <a16:creationId xmlns:a16="http://schemas.microsoft.com/office/drawing/2014/main" id="{E5C08952-0B2B-4D5D-96A3-528F471BB16D}"/>
               </a:ext>
             </a:extLst>
           </p:cNvPr>
@@ -21639,7 +21639,7 @@
           <p:cNvPr id="11" name="">
             <a:extLst xmlns:a="http://schemas.openxmlformats.org/drawingml/2006/main">
               <a:ext uri="{FF2B5EF4-FFF2-40B4-BE49-F238E27FC236}">
-                <a16:creationId xmlns:a16="http://schemas.microsoft.com/office/drawing/2014/main" id="{214C279B-F331-4831-83DD-23888BB94F87}"/>
+                <a16:creationId xmlns:a16="http://schemas.microsoft.com/office/drawing/2014/main" id="{B841A41D-BEC2-4C57-BD1E-635F8D1E4701}"/>
               </a:ext>
             </a:extLst>
           </p:cNvPr>
@@ -21703,7 +21703,7 @@
           <p:cNvPr id="12" name="">
             <a:extLst xmlns:a="http://schemas.openxmlformats.org/drawingml/2006/main">
               <a:ext uri="{FF2B5EF4-FFF2-40B4-BE49-F238E27FC236}">
-                <a16:creationId xmlns:a16="http://schemas.microsoft.com/office/drawing/2014/main" id="{88202BE3-4A3F-4AB1-ADA9-AE484E6D7194}"/>
+                <a16:creationId xmlns:a16="http://schemas.microsoft.com/office/drawing/2014/main" id="{CCE98199-C93F-4F1D-AA1A-38FC467CF945}"/>
               </a:ext>
             </a:extLst>
           </p:cNvPr>
@@ -21736,7 +21736,7 @@
           <p:cNvPr id="13" name="">
             <a:extLst xmlns:a="http://schemas.openxmlformats.org/drawingml/2006/main">
               <a:ext uri="{FF2B5EF4-FFF2-40B4-BE49-F238E27FC236}">
-                <a16:creationId xmlns:a16="http://schemas.microsoft.com/office/drawing/2014/main" id="{B0D440AE-B618-4D99-BE03-899359D4C4B5}"/>
+                <a16:creationId xmlns:a16="http://schemas.microsoft.com/office/drawing/2014/main" id="{027184D6-6DB5-4C83-803B-250B2F5E9105}"/>
               </a:ext>
             </a:extLst>
           </p:cNvPr>
@@ -21800,7 +21800,7 @@
           <p:cNvPr id="14" name="">
             <a:extLst xmlns:a="http://schemas.openxmlformats.org/drawingml/2006/main">
               <a:ext uri="{FF2B5EF4-FFF2-40B4-BE49-F238E27FC236}">
-                <a16:creationId xmlns:a16="http://schemas.microsoft.com/office/drawing/2014/main" id="{982EA378-FA9D-4CB0-B9C1-BFB9B408F7CF}"/>
+                <a16:creationId xmlns:a16="http://schemas.microsoft.com/office/drawing/2014/main" id="{C1B4EC6C-ADB7-4870-B4A2-5803AFB42660}"/>
               </a:ext>
             </a:extLst>
           </p:cNvPr>
@@ -21833,7 +21833,7 @@
           <p:cNvPr id="15" name="">
             <a:extLst xmlns:a="http://schemas.openxmlformats.org/drawingml/2006/main">
               <a:ext uri="{FF2B5EF4-FFF2-40B4-BE49-F238E27FC236}">
-                <a16:creationId xmlns:a16="http://schemas.microsoft.com/office/drawing/2014/main" id="{5CF4B90B-8451-4E4E-81E9-1911BC1C6D73}"/>
+                <a16:creationId xmlns:a16="http://schemas.microsoft.com/office/drawing/2014/main" id="{CD5AC6DD-7779-4DBE-BB82-2AC4CE7AF7A4}"/>
               </a:ext>
             </a:extLst>
           </p:cNvPr>
@@ -21897,7 +21897,7 @@
           <p:cNvPr id="16" name="">
             <a:extLst xmlns:a="http://schemas.openxmlformats.org/drawingml/2006/main">
               <a:ext uri="{FF2B5EF4-FFF2-40B4-BE49-F238E27FC236}">
-                <a16:creationId xmlns:a16="http://schemas.microsoft.com/office/drawing/2014/main" id="{00D5917C-4FAF-4306-8B07-9C052B2D9FA7}"/>
+                <a16:creationId xmlns:a16="http://schemas.microsoft.com/office/drawing/2014/main" id="{AB4DB409-0C80-458C-A9F7-398B765D7DF9}"/>
               </a:ext>
             </a:extLst>
           </p:cNvPr>
@@ -21930,7 +21930,7 @@
           <p:cNvPr id="17" name="">
             <a:extLst xmlns:a="http://schemas.openxmlformats.org/drawingml/2006/main">
               <a:ext uri="{FF2B5EF4-FFF2-40B4-BE49-F238E27FC236}">
-                <a16:creationId xmlns:a16="http://schemas.microsoft.com/office/drawing/2014/main" id="{B5FAC43E-CE67-41BD-ADE9-400A8528C45C}"/>
+                <a16:creationId xmlns:a16="http://schemas.microsoft.com/office/drawing/2014/main" id="{E1E0AC9E-0CAE-40AE-AE74-773CC9B23550}"/>
               </a:ext>
             </a:extLst>
           </p:cNvPr>
@@ -21994,7 +21994,7 @@
           <p:cNvPr id="18" name="">
             <a:extLst xmlns:a="http://schemas.openxmlformats.org/drawingml/2006/main">
               <a:ext uri="{FF2B5EF4-FFF2-40B4-BE49-F238E27FC236}">
-                <a16:creationId xmlns:a16="http://schemas.microsoft.com/office/drawing/2014/main" id="{8B9BD14C-224F-4ECC-BCA0-BA4942462870}"/>
+                <a16:creationId xmlns:a16="http://schemas.microsoft.com/office/drawing/2014/main" id="{CE4FA011-C1FE-4011-B23F-F32F98C75668}"/>
               </a:ext>
             </a:extLst>
           </p:cNvPr>
@@ -22027,7 +22027,7 @@
           <p:cNvPr id="19" name="">
             <a:extLst xmlns:a="http://schemas.openxmlformats.org/drawingml/2006/main">
               <a:ext uri="{FF2B5EF4-FFF2-40B4-BE49-F238E27FC236}">
-                <a16:creationId xmlns:a16="http://schemas.microsoft.com/office/drawing/2014/main" id="{80541BB4-3FCD-4025-B76B-D23D5B130AC4}"/>
+                <a16:creationId xmlns:a16="http://schemas.microsoft.com/office/drawing/2014/main" id="{365A168A-D3F1-4779-B39E-5C268FE57BD4}"/>
               </a:ext>
             </a:extLst>
           </p:cNvPr>
@@ -22091,7 +22091,7 @@
           <p:cNvPr id="20" name="">
             <a:extLst xmlns:a="http://schemas.openxmlformats.org/drawingml/2006/main">
               <a:ext uri="{FF2B5EF4-FFF2-40B4-BE49-F238E27FC236}">
-                <a16:creationId xmlns:a16="http://schemas.microsoft.com/office/drawing/2014/main" id="{06C8A198-B37A-4961-A4B5-3210C0B32CC3}"/>
+                <a16:creationId xmlns:a16="http://schemas.microsoft.com/office/drawing/2014/main" id="{3C926582-988D-4917-B431-02AD5771B140}"/>
               </a:ext>
             </a:extLst>
           </p:cNvPr>
@@ -22155,7 +22155,7 @@
           <p:cNvPr id="21" name="">
             <a:extLst xmlns:a="http://schemas.openxmlformats.org/drawingml/2006/main">
               <a:ext uri="{FF2B5EF4-FFF2-40B4-BE49-F238E27FC236}">
-                <a16:creationId xmlns:a16="http://schemas.microsoft.com/office/drawing/2014/main" id="{BAA798BB-98B0-4A00-A2C3-441DB0E23636}"/>
+                <a16:creationId xmlns:a16="http://schemas.microsoft.com/office/drawing/2014/main" id="{3987D006-DB4B-45DE-A926-8E464A4D53BA}"/>
               </a:ext>
             </a:extLst>
           </p:cNvPr>
@@ -22217,7 +22217,7 @@
     </p:spTree>
     <p:extLst>
       <p:ext uri="{BB962C8B-B14F-4D97-AF65-F5344CB8AC3E}">
-        <p14:creationId xmlns:p14="http://schemas.microsoft.com/office/powerpoint/2010/main" val="2075766198"/>
+        <p14:creationId xmlns:p14="http://schemas.microsoft.com/office/powerpoint/2010/main" val="1791420259"/>
       </p:ext>
     </p:extLst>
   </p:cSld>
@@ -22241,7 +22241,7 @@
           <p:cNvPr id="1" name="">
             <a:extLst xmlns:a="http://schemas.openxmlformats.org/drawingml/2006/main">
               <a:ext uri="{FF2B5EF4-FFF2-40B4-BE49-F238E27FC236}">
-                <a16:creationId xmlns:a16="http://schemas.microsoft.com/office/drawing/2014/main" id="{1926E502-A461-4C2B-A2D2-D79EDA3EE389}"/>
+                <a16:creationId xmlns:a16="http://schemas.microsoft.com/office/drawing/2014/main" id="{FB6CFB2F-0DAB-4B6F-8973-6BEC784B78E5}"/>
               </a:ext>
             </a:extLst>
           </p:cNvPr>
@@ -22274,7 +22274,7 @@
           <p:cNvPr id="2" name="">
             <a:extLst xmlns:a="http://schemas.openxmlformats.org/drawingml/2006/main">
               <a:ext uri="{FF2B5EF4-FFF2-40B4-BE49-F238E27FC236}">
-                <a16:creationId xmlns:a16="http://schemas.microsoft.com/office/drawing/2014/main" id="{40B01B99-A7A9-4195-8F1D-6048714FA265}"/>
+                <a16:creationId xmlns:a16="http://schemas.microsoft.com/office/drawing/2014/main" id="{3B60F57F-EF52-46E6-89E4-A5C796946B03}"/>
               </a:ext>
             </a:extLst>
           </p:cNvPr>
@@ -22307,7 +22307,7 @@
           <p:cNvPr id="3" name="">
             <a:extLst xmlns:a="http://schemas.openxmlformats.org/drawingml/2006/main">
               <a:ext uri="{FF2B5EF4-FFF2-40B4-BE49-F238E27FC236}">
-                <a16:creationId xmlns:a16="http://schemas.microsoft.com/office/drawing/2014/main" id="{76F633E5-8D0A-40F8-A997-CB953702100B}"/>
+                <a16:creationId xmlns:a16="http://schemas.microsoft.com/office/drawing/2014/main" id="{DF306B4C-9CE8-449E-9F09-E1DD71DC1300}"/>
               </a:ext>
             </a:extLst>
           </p:cNvPr>
@@ -22371,7 +22371,7 @@
           <p:cNvPr id="4" name="">
             <a:extLst xmlns:a="http://schemas.openxmlformats.org/drawingml/2006/main">
               <a:ext uri="{FF2B5EF4-FFF2-40B4-BE49-F238E27FC236}">
-                <a16:creationId xmlns:a16="http://schemas.microsoft.com/office/drawing/2014/main" id="{80257A02-78F3-4500-91A1-D5F5D4EAAE52}"/>
+                <a16:creationId xmlns:a16="http://schemas.microsoft.com/office/drawing/2014/main" id="{A194BF21-1BB9-4DA9-B4AE-81B3C6445E9D}"/>
               </a:ext>
             </a:extLst>
           </p:cNvPr>
@@ -22435,7 +22435,7 @@
           <p:cNvPr id="5" name="">
             <a:extLst xmlns:a="http://schemas.openxmlformats.org/drawingml/2006/main">
               <a:ext uri="{FF2B5EF4-FFF2-40B4-BE49-F238E27FC236}">
-                <a16:creationId xmlns:a16="http://schemas.microsoft.com/office/drawing/2014/main" id="{F3190699-E899-4DD4-838E-857BF18C2FD4}"/>
+                <a16:creationId xmlns:a16="http://schemas.microsoft.com/office/drawing/2014/main" id="{9E263427-970F-4C8B-9C95-0F92B8FF9DD8}"/>
               </a:ext>
             </a:extLst>
           </p:cNvPr>
@@ -22468,7 +22468,7 @@
           <p:cNvPr id="6" name="">
             <a:extLst xmlns:a="http://schemas.openxmlformats.org/drawingml/2006/main">
               <a:ext uri="{FF2B5EF4-FFF2-40B4-BE49-F238E27FC236}">
-                <a16:creationId xmlns:a16="http://schemas.microsoft.com/office/drawing/2014/main" id="{83E28C19-201A-4BB2-A763-0D5C62E1A757}"/>
+                <a16:creationId xmlns:a16="http://schemas.microsoft.com/office/drawing/2014/main" id="{6F788F79-1364-4C6D-94DD-E2C8CA9483F2}"/>
               </a:ext>
             </a:extLst>
           </p:cNvPr>
@@ -22501,7 +22501,7 @@
           <p:cNvPr id="7" name="">
             <a:extLst xmlns:a="http://schemas.openxmlformats.org/drawingml/2006/main">
               <a:ext uri="{FF2B5EF4-FFF2-40B4-BE49-F238E27FC236}">
-                <a16:creationId xmlns:a16="http://schemas.microsoft.com/office/drawing/2014/main" id="{356A4D1A-8683-4867-A521-D86DED803515}"/>
+                <a16:creationId xmlns:a16="http://schemas.microsoft.com/office/drawing/2014/main" id="{60066ABB-2F77-4F2A-9A19-C666A14AD09C}"/>
               </a:ext>
             </a:extLst>
           </p:cNvPr>
@@ -22565,7 +22565,7 @@
           <p:cNvPr id="8" name="">
             <a:extLst xmlns:a="http://schemas.openxmlformats.org/drawingml/2006/main">
               <a:ext uri="{FF2B5EF4-FFF2-40B4-BE49-F238E27FC236}">
-                <a16:creationId xmlns:a16="http://schemas.microsoft.com/office/drawing/2014/main" id="{BD709A4A-364C-4DFE-AD63-06AB91BE1D16}"/>
+                <a16:creationId xmlns:a16="http://schemas.microsoft.com/office/drawing/2014/main" id="{0D2D791C-7F4B-4A07-BAB3-23944209C5B8}"/>
               </a:ext>
             </a:extLst>
           </p:cNvPr>
@@ -22598,7 +22598,7 @@
           <p:cNvPr id="9" name="">
             <a:extLst xmlns:a="http://schemas.openxmlformats.org/drawingml/2006/main">
               <a:ext uri="{FF2B5EF4-FFF2-40B4-BE49-F238E27FC236}">
-                <a16:creationId xmlns:a16="http://schemas.microsoft.com/office/drawing/2014/main" id="{4C1454F1-B82B-49C7-975E-3A63AFD48D37}"/>
+                <a16:creationId xmlns:a16="http://schemas.microsoft.com/office/drawing/2014/main" id="{2E952F00-34A3-4F22-8CF3-B8065D412942}"/>
               </a:ext>
             </a:extLst>
           </p:cNvPr>
@@ -22662,7 +22662,7 @@
           <p:cNvPr id="10" name="">
             <a:extLst xmlns:a="http://schemas.openxmlformats.org/drawingml/2006/main">
               <a:ext uri="{FF2B5EF4-FFF2-40B4-BE49-F238E27FC236}">
-                <a16:creationId xmlns:a16="http://schemas.microsoft.com/office/drawing/2014/main" id="{0394A4E1-528A-4A1E-B5E3-35435493961B}"/>
+                <a16:creationId xmlns:a16="http://schemas.microsoft.com/office/drawing/2014/main" id="{0C55F685-F269-4911-85F4-3B3B474CB326}"/>
               </a:ext>
             </a:extLst>
           </p:cNvPr>
@@ -22695,7 +22695,7 @@
           <p:cNvPr id="11" name="">
             <a:extLst xmlns:a="http://schemas.openxmlformats.org/drawingml/2006/main">
               <a:ext uri="{FF2B5EF4-FFF2-40B4-BE49-F238E27FC236}">
-                <a16:creationId xmlns:a16="http://schemas.microsoft.com/office/drawing/2014/main" id="{621AF587-B520-4373-AC8B-8F42A0F73577}"/>
+                <a16:creationId xmlns:a16="http://schemas.microsoft.com/office/drawing/2014/main" id="{69574CCD-1D9D-4762-BDBA-C9B458D9B4BA}"/>
               </a:ext>
             </a:extLst>
           </p:cNvPr>
@@ -22759,7 +22759,7 @@
           <p:cNvPr id="12" name="">
             <a:extLst xmlns:a="http://schemas.openxmlformats.org/drawingml/2006/main">
               <a:ext uri="{FF2B5EF4-FFF2-40B4-BE49-F238E27FC236}">
-                <a16:creationId xmlns:a16="http://schemas.microsoft.com/office/drawing/2014/main" id="{01652186-8C63-4E78-BDEE-266F42A09EBC}"/>
+                <a16:creationId xmlns:a16="http://schemas.microsoft.com/office/drawing/2014/main" id="{063E6B5F-CCD0-4AEF-9549-95AC37D91EEB}"/>
               </a:ext>
             </a:extLst>
           </p:cNvPr>
@@ -22792,7 +22792,7 @@
           <p:cNvPr id="13" name="">
             <a:extLst xmlns:a="http://schemas.openxmlformats.org/drawingml/2006/main">
               <a:ext uri="{FF2B5EF4-FFF2-40B4-BE49-F238E27FC236}">
-                <a16:creationId xmlns:a16="http://schemas.microsoft.com/office/drawing/2014/main" id="{FDB368BC-46AF-4E01-808C-462F422BDDE9}"/>
+                <a16:creationId xmlns:a16="http://schemas.microsoft.com/office/drawing/2014/main" id="{E64D87B2-3AB2-4F35-98B8-F88A2F830A90}"/>
               </a:ext>
             </a:extLst>
           </p:cNvPr>
@@ -22856,7 +22856,7 @@
           <p:cNvPr id="14" name="">
             <a:extLst xmlns:a="http://schemas.openxmlformats.org/drawingml/2006/main">
               <a:ext uri="{FF2B5EF4-FFF2-40B4-BE49-F238E27FC236}">
-                <a16:creationId xmlns:a16="http://schemas.microsoft.com/office/drawing/2014/main" id="{C731CF3A-CBEF-4AED-B657-2677E481679B}"/>
+                <a16:creationId xmlns:a16="http://schemas.microsoft.com/office/drawing/2014/main" id="{73ACD6C4-8993-4D1C-85F0-3955B8BBB0D3}"/>
               </a:ext>
             </a:extLst>
           </p:cNvPr>
@@ -22889,7 +22889,7 @@
           <p:cNvPr id="15" name="">
             <a:extLst xmlns:a="http://schemas.openxmlformats.org/drawingml/2006/main">
               <a:ext uri="{FF2B5EF4-FFF2-40B4-BE49-F238E27FC236}">
-                <a16:creationId xmlns:a16="http://schemas.microsoft.com/office/drawing/2014/main" id="{3FA51618-CB39-439B-8F26-397CDEE0B87F}"/>
+                <a16:creationId xmlns:a16="http://schemas.microsoft.com/office/drawing/2014/main" id="{D7F43DCC-5122-4DE3-B8AE-E683238C1603}"/>
               </a:ext>
             </a:extLst>
           </p:cNvPr>
@@ -22953,7 +22953,7 @@
           <p:cNvPr id="16" name="">
             <a:extLst xmlns:a="http://schemas.openxmlformats.org/drawingml/2006/main">
               <a:ext uri="{FF2B5EF4-FFF2-40B4-BE49-F238E27FC236}">
-                <a16:creationId xmlns:a16="http://schemas.microsoft.com/office/drawing/2014/main" id="{1906FEB9-8BE4-4F4D-A34B-93489CE2321A}"/>
+                <a16:creationId xmlns:a16="http://schemas.microsoft.com/office/drawing/2014/main" id="{71D647CB-2FBE-443F-A0D1-4FDF24F005C1}"/>
               </a:ext>
             </a:extLst>
           </p:cNvPr>
@@ -22986,7 +22986,7 @@
           <p:cNvPr id="17" name="">
             <a:extLst xmlns:a="http://schemas.openxmlformats.org/drawingml/2006/main">
               <a:ext uri="{FF2B5EF4-FFF2-40B4-BE49-F238E27FC236}">
-                <a16:creationId xmlns:a16="http://schemas.microsoft.com/office/drawing/2014/main" id="{D85B0484-8500-466E-9484-E3E801512863}"/>
+                <a16:creationId xmlns:a16="http://schemas.microsoft.com/office/drawing/2014/main" id="{636DE146-E719-4D3B-8900-920533A4DA6F}"/>
               </a:ext>
             </a:extLst>
           </p:cNvPr>
@@ -23050,7 +23050,7 @@
           <p:cNvPr id="18" name="">
             <a:extLst xmlns:a="http://schemas.openxmlformats.org/drawingml/2006/main">
               <a:ext uri="{FF2B5EF4-FFF2-40B4-BE49-F238E27FC236}">
-                <a16:creationId xmlns:a16="http://schemas.microsoft.com/office/drawing/2014/main" id="{D1846016-9FA9-4021-8E4F-8E722B2F896D}"/>
+                <a16:creationId xmlns:a16="http://schemas.microsoft.com/office/drawing/2014/main" id="{4EA038E3-DA67-4126-9C56-B013F2CE091F}"/>
               </a:ext>
             </a:extLst>
           </p:cNvPr>
@@ -23114,7 +23114,7 @@
           <p:cNvPr id="19" name="">
             <a:extLst xmlns:a="http://schemas.openxmlformats.org/drawingml/2006/main">
               <a:ext uri="{FF2B5EF4-FFF2-40B4-BE49-F238E27FC236}">
-                <a16:creationId xmlns:a16="http://schemas.microsoft.com/office/drawing/2014/main" id="{8ADF719B-22FA-455E-A698-FD41418937F7}"/>
+                <a16:creationId xmlns:a16="http://schemas.microsoft.com/office/drawing/2014/main" id="{0B1A5607-04F3-4BA6-A038-659B580ECD91}"/>
               </a:ext>
             </a:extLst>
           </p:cNvPr>
@@ -23176,7 +23176,7 @@
     </p:spTree>
     <p:extLst>
       <p:ext uri="{BB962C8B-B14F-4D97-AF65-F5344CB8AC3E}">
-        <p14:creationId xmlns:p14="http://schemas.microsoft.com/office/powerpoint/2010/main" val="901478299"/>
+        <p14:creationId xmlns:p14="http://schemas.microsoft.com/office/powerpoint/2010/main" val="2071022763"/>
       </p:ext>
     </p:extLst>
   </p:cSld>

</xml_diff>

<commit_message>
Clean repository final artifacts
</commit_message>
<xml_diff>
--- a/presentations/final/CODE_BLUE_RL_FINAL.pptx
+++ b/presentations/final/CODE_BLUE_RL_FINAL.pptx
@@ -2,30 +2,30 @@
 <file path=ppt/presentation.xml><?xml version="1.0" encoding="utf-8"?>
 <p:presentation xmlns:p="http://schemas.openxmlformats.org/presentationml/2006/main">
   <p:sldMasterIdLst>
-    <p:sldMasterId xmlns:r="http://schemas.openxmlformats.org/officeDocument/2006/relationships" id="2147483648" r:id="Rfac0d91e509e4424"/>
+    <p:sldMasterId xmlns:r="http://schemas.openxmlformats.org/officeDocument/2006/relationships" id="2147483648" r:id="R6b67b591742c477f"/>
   </p:sldMasterIdLst>
   <p:notesMasterIdLst>
-    <p:notesMasterId xmlns:r="http://schemas.openxmlformats.org/officeDocument/2006/relationships" r:id="Rec1082f9c5c34b51"/>
+    <p:notesMasterId xmlns:r="http://schemas.openxmlformats.org/officeDocument/2006/relationships" r:id="R5d5acf932f1f4ad9"/>
   </p:notesMasterIdLst>
   <p:sldIdLst>
-    <p:sldId xmlns:r="http://schemas.openxmlformats.org/officeDocument/2006/relationships" id="256" r:id="Rf189e69086c64f5b"/>
-    <p:sldId xmlns:r="http://schemas.openxmlformats.org/officeDocument/2006/relationships" id="257" r:id="R2c1ac58697334e64"/>
-    <p:sldId xmlns:r="http://schemas.openxmlformats.org/officeDocument/2006/relationships" id="258" r:id="Raa34b9c001dd4a8c"/>
-    <p:sldId xmlns:r="http://schemas.openxmlformats.org/officeDocument/2006/relationships" id="259" r:id="Rd69d6f25da114037"/>
-    <p:sldId xmlns:r="http://schemas.openxmlformats.org/officeDocument/2006/relationships" id="260" r:id="Racf4a8f0e1f24189"/>
-    <p:sldId xmlns:r="http://schemas.openxmlformats.org/officeDocument/2006/relationships" id="261" r:id="Rf1dab6f672c749f4"/>
-    <p:sldId xmlns:r="http://schemas.openxmlformats.org/officeDocument/2006/relationships" id="262" r:id="R92703d91fdf04b8c"/>
-    <p:sldId xmlns:r="http://schemas.openxmlformats.org/officeDocument/2006/relationships" id="263" r:id="Re361f49a40e24fba"/>
-    <p:sldId xmlns:r="http://schemas.openxmlformats.org/officeDocument/2006/relationships" id="264" r:id="R733c5b9deb2e428a"/>
-    <p:sldId xmlns:r="http://schemas.openxmlformats.org/officeDocument/2006/relationships" id="265" r:id="R21258a8d1e284838"/>
-    <p:sldId xmlns:r="http://schemas.openxmlformats.org/officeDocument/2006/relationships" id="266" r:id="R31c1f4b13bd24f6a"/>
-    <p:sldId xmlns:r="http://schemas.openxmlformats.org/officeDocument/2006/relationships" id="267" r:id="Rabb24a02e01b4924"/>
-    <p:sldId xmlns:r="http://schemas.openxmlformats.org/officeDocument/2006/relationships" id="268" r:id="R6438301ec6e54ab6"/>
-    <p:sldId xmlns:r="http://schemas.openxmlformats.org/officeDocument/2006/relationships" id="269" r:id="R373009efa12949b7"/>
-    <p:sldId xmlns:r="http://schemas.openxmlformats.org/officeDocument/2006/relationships" id="270" r:id="Rc656a56cd7de4dd8"/>
-    <p:sldId xmlns:r="http://schemas.openxmlformats.org/officeDocument/2006/relationships" id="271" r:id="R6a894bbddc0a4337"/>
-    <p:sldId xmlns:r="http://schemas.openxmlformats.org/officeDocument/2006/relationships" id="272" r:id="Ra38a0b757ad9429b"/>
-    <p:sldId xmlns:r="http://schemas.openxmlformats.org/officeDocument/2006/relationships" id="273" r:id="Re20af0b90dc94ab1"/>
+    <p:sldId xmlns:r="http://schemas.openxmlformats.org/officeDocument/2006/relationships" id="256" r:id="Rae646e89219747e2"/>
+    <p:sldId xmlns:r="http://schemas.openxmlformats.org/officeDocument/2006/relationships" id="257" r:id="Rb1094a4e42734ab7"/>
+    <p:sldId xmlns:r="http://schemas.openxmlformats.org/officeDocument/2006/relationships" id="258" r:id="Rdb2f40ea7fbe4544"/>
+    <p:sldId xmlns:r="http://schemas.openxmlformats.org/officeDocument/2006/relationships" id="259" r:id="R5b24a94b4b894ee4"/>
+    <p:sldId xmlns:r="http://schemas.openxmlformats.org/officeDocument/2006/relationships" id="260" r:id="R6aa2061db6e640a5"/>
+    <p:sldId xmlns:r="http://schemas.openxmlformats.org/officeDocument/2006/relationships" id="261" r:id="R22eb27626bb84ebd"/>
+    <p:sldId xmlns:r="http://schemas.openxmlformats.org/officeDocument/2006/relationships" id="262" r:id="Rfdfa485fb85b409d"/>
+    <p:sldId xmlns:r="http://schemas.openxmlformats.org/officeDocument/2006/relationships" id="263" r:id="Ra00acb15b105450d"/>
+    <p:sldId xmlns:r="http://schemas.openxmlformats.org/officeDocument/2006/relationships" id="264" r:id="Rda8e3b49c3444fbd"/>
+    <p:sldId xmlns:r="http://schemas.openxmlformats.org/officeDocument/2006/relationships" id="265" r:id="Rca51a41d6cff4e05"/>
+    <p:sldId xmlns:r="http://schemas.openxmlformats.org/officeDocument/2006/relationships" id="266" r:id="R424a37e81fe74cf2"/>
+    <p:sldId xmlns:r="http://schemas.openxmlformats.org/officeDocument/2006/relationships" id="267" r:id="Rbf5f8640e5a74800"/>
+    <p:sldId xmlns:r="http://schemas.openxmlformats.org/officeDocument/2006/relationships" id="268" r:id="R3024eecee39942fd"/>
+    <p:sldId xmlns:r="http://schemas.openxmlformats.org/officeDocument/2006/relationships" id="269" r:id="R1ecfe8cde095454b"/>
+    <p:sldId xmlns:r="http://schemas.openxmlformats.org/officeDocument/2006/relationships" id="270" r:id="R473971554632433c"/>
+    <p:sldId xmlns:r="http://schemas.openxmlformats.org/officeDocument/2006/relationships" id="271" r:id="Rca817b9d8cc44d50"/>
+    <p:sldId xmlns:r="http://schemas.openxmlformats.org/officeDocument/2006/relationships" id="272" r:id="R011817913afc4cbc"/>
+    <p:sldId xmlns:r="http://schemas.openxmlformats.org/officeDocument/2006/relationships" id="273" r:id="Rcd689eaa150f4ce9"/>
   </p:sldIdLst>
   <p:sldSz cx="12192000" cy="6858000"/>
   <p:notesSz cx="6858000" cy="9144000"/>
@@ -1694,7 +1694,7 @@
   </p:cSld>
   <p:clrMap bg1="lt1" tx1="dk1" bg2="lt2" tx2="dk2" accent1="accent1" accent2="accent2" accent3="accent3" accent4="accent4" accent5="accent5" accent6="accent6" hlink="hlink" folHlink="folHlink"/>
   <p:sldLayoutIdLst>
-    <p:sldLayoutId xmlns:r="http://schemas.openxmlformats.org/officeDocument/2006/relationships" id="2147483649" r:id="R169f5e59245f4ffc"/>
+    <p:sldLayoutId xmlns:r="http://schemas.openxmlformats.org/officeDocument/2006/relationships" id="2147483649" r:id="Rdc992a67665841ee"/>
   </p:sldLayoutIdLst>
   <p:txStyles>
     <p:titleStyle>
@@ -2192,7 +2192,7 @@
           <p:cNvPr id="1" name="">
             <a:extLst xmlns:a="http://schemas.openxmlformats.org/drawingml/2006/main">
               <a:ext uri="{FF2B5EF4-FFF2-40B4-BE49-F238E27FC236}">
-                <a16:creationId xmlns:a16="http://schemas.microsoft.com/office/drawing/2014/main" id="{B65B9307-4613-48BC-A95F-A19250FB1200}"/>
+                <a16:creationId xmlns:a16="http://schemas.microsoft.com/office/drawing/2014/main" id="{2C156C5C-54E6-490B-91DB-985B325DFFBD}"/>
               </a:ext>
             </a:extLst>
           </p:cNvPr>
@@ -2225,7 +2225,7 @@
           <p:cNvPr id="2" name="">
             <a:extLst xmlns:a="http://schemas.openxmlformats.org/drawingml/2006/main">
               <a:ext uri="{FF2B5EF4-FFF2-40B4-BE49-F238E27FC236}">
-                <a16:creationId xmlns:a16="http://schemas.microsoft.com/office/drawing/2014/main" id="{EFBF3FEA-ADE9-4618-BEB2-60997F89C667}"/>
+                <a16:creationId xmlns:a16="http://schemas.microsoft.com/office/drawing/2014/main" id="{841B2788-E634-4BCE-A6C4-F3AABEAA1B76}"/>
               </a:ext>
             </a:extLst>
           </p:cNvPr>
@@ -2258,7 +2258,7 @@
           <p:cNvPr id="3" name="">
             <a:extLst xmlns:a="http://schemas.openxmlformats.org/drawingml/2006/main">
               <a:ext uri="{FF2B5EF4-FFF2-40B4-BE49-F238E27FC236}">
-                <a16:creationId xmlns:a16="http://schemas.microsoft.com/office/drawing/2014/main" id="{AD40214C-BCDC-42BA-B774-CBA344AE182C}"/>
+                <a16:creationId xmlns:a16="http://schemas.microsoft.com/office/drawing/2014/main" id="{67212787-5138-4324-B665-F7AD5D42D801}"/>
               </a:ext>
             </a:extLst>
           </p:cNvPr>
@@ -2322,7 +2322,7 @@
           <p:cNvPr id="4" name="">
             <a:extLst xmlns:a="http://schemas.openxmlformats.org/drawingml/2006/main">
               <a:ext uri="{FF2B5EF4-FFF2-40B4-BE49-F238E27FC236}">
-                <a16:creationId xmlns:a16="http://schemas.microsoft.com/office/drawing/2014/main" id="{6D159331-9C6E-4A33-A684-C0F4795D2B64}"/>
+                <a16:creationId xmlns:a16="http://schemas.microsoft.com/office/drawing/2014/main" id="{687B0353-7AAE-4E13-B92A-7C63FEEE8D33}"/>
               </a:ext>
             </a:extLst>
           </p:cNvPr>
@@ -2386,7 +2386,7 @@
           <p:cNvPr id="5" name="">
             <a:extLst xmlns:a="http://schemas.openxmlformats.org/drawingml/2006/main">
               <a:ext uri="{FF2B5EF4-FFF2-40B4-BE49-F238E27FC236}">
-                <a16:creationId xmlns:a16="http://schemas.microsoft.com/office/drawing/2014/main" id="{638D456E-92F9-4F54-8971-2FEF6943081B}"/>
+                <a16:creationId xmlns:a16="http://schemas.microsoft.com/office/drawing/2014/main" id="{2951120A-2E92-4F9E-816C-9938826BCDBB}"/>
               </a:ext>
             </a:extLst>
           </p:cNvPr>
@@ -2419,7 +2419,7 @@
           <p:cNvPr id="6" name="">
             <a:extLst xmlns:a="http://schemas.openxmlformats.org/drawingml/2006/main">
               <a:ext uri="{FF2B5EF4-FFF2-40B4-BE49-F238E27FC236}">
-                <a16:creationId xmlns:a16="http://schemas.microsoft.com/office/drawing/2014/main" id="{C446641C-9268-491F-BD22-A9140DC4B976}"/>
+                <a16:creationId xmlns:a16="http://schemas.microsoft.com/office/drawing/2014/main" id="{F8E99CA6-31E1-4A90-863B-E62D6C51C8A4}"/>
               </a:ext>
             </a:extLst>
           </p:cNvPr>
@@ -2452,7 +2452,7 @@
           <p:cNvPr id="7" name="">
             <a:extLst xmlns:a="http://schemas.openxmlformats.org/drawingml/2006/main">
               <a:ext uri="{FF2B5EF4-FFF2-40B4-BE49-F238E27FC236}">
-                <a16:creationId xmlns:a16="http://schemas.microsoft.com/office/drawing/2014/main" id="{07B9C10F-89C3-4145-A43C-BBDEBE459B00}"/>
+                <a16:creationId xmlns:a16="http://schemas.microsoft.com/office/drawing/2014/main" id="{879B391F-E9AE-473D-B48C-FA77D971FBBA}"/>
               </a:ext>
             </a:extLst>
           </p:cNvPr>
@@ -2516,7 +2516,7 @@
           <p:cNvPr id="8" name="">
             <a:extLst xmlns:a="http://schemas.openxmlformats.org/drawingml/2006/main">
               <a:ext uri="{FF2B5EF4-FFF2-40B4-BE49-F238E27FC236}">
-                <a16:creationId xmlns:a16="http://schemas.microsoft.com/office/drawing/2014/main" id="{C5A47948-D5DC-485E-8BD7-8F9C008D7C42}"/>
+                <a16:creationId xmlns:a16="http://schemas.microsoft.com/office/drawing/2014/main" id="{1D9E1E83-1952-4CC1-BBC4-9E3F60C562AD}"/>
               </a:ext>
             </a:extLst>
           </p:cNvPr>
@@ -2580,7 +2580,7 @@
           <p:cNvPr id="9" name="">
             <a:extLst xmlns:a="http://schemas.openxmlformats.org/drawingml/2006/main">
               <a:ext uri="{FF2B5EF4-FFF2-40B4-BE49-F238E27FC236}">
-                <a16:creationId xmlns:a16="http://schemas.microsoft.com/office/drawing/2014/main" id="{316B06B9-78AC-4207-9CF5-688BF941E95D}"/>
+                <a16:creationId xmlns:a16="http://schemas.microsoft.com/office/drawing/2014/main" id="{14392324-399C-4B98-B5EB-5678F8DBBBF9}"/>
               </a:ext>
             </a:extLst>
           </p:cNvPr>
@@ -2613,7 +2613,7 @@
           <p:cNvPr id="10" name="">
             <a:extLst xmlns:a="http://schemas.openxmlformats.org/drawingml/2006/main">
               <a:ext uri="{FF2B5EF4-FFF2-40B4-BE49-F238E27FC236}">
-                <a16:creationId xmlns:a16="http://schemas.microsoft.com/office/drawing/2014/main" id="{C9F8931D-7CF6-4539-9BF2-8FB9A8023182}"/>
+                <a16:creationId xmlns:a16="http://schemas.microsoft.com/office/drawing/2014/main" id="{CAAE5FC8-5841-412E-BB04-DB5E9D121CAF}"/>
               </a:ext>
             </a:extLst>
           </p:cNvPr>
@@ -2677,7 +2677,7 @@
           <p:cNvPr id="11" name="">
             <a:extLst xmlns:a="http://schemas.openxmlformats.org/drawingml/2006/main">
               <a:ext uri="{FF2B5EF4-FFF2-40B4-BE49-F238E27FC236}">
-                <a16:creationId xmlns:a16="http://schemas.microsoft.com/office/drawing/2014/main" id="{E3ECAC49-E089-46D0-9BAA-CAE866DB9F01}"/>
+                <a16:creationId xmlns:a16="http://schemas.microsoft.com/office/drawing/2014/main" id="{9BD355D3-93BA-4342-8C2F-27207CABC8A3}"/>
               </a:ext>
             </a:extLst>
           </p:cNvPr>
@@ -2741,7 +2741,7 @@
           <p:cNvPr id="12" name="">
             <a:extLst xmlns:a="http://schemas.openxmlformats.org/drawingml/2006/main">
               <a:ext uri="{FF2B5EF4-FFF2-40B4-BE49-F238E27FC236}">
-                <a16:creationId xmlns:a16="http://schemas.microsoft.com/office/drawing/2014/main" id="{CADCD707-836B-4F73-BFF9-BB09E4B3F442}"/>
+                <a16:creationId xmlns:a16="http://schemas.microsoft.com/office/drawing/2014/main" id="{C638B23F-FF4D-42F5-A735-696FE579539E}"/>
               </a:ext>
             </a:extLst>
           </p:cNvPr>
@@ -2774,7 +2774,7 @@
           <p:cNvPr id="13" name="">
             <a:extLst xmlns:a="http://schemas.openxmlformats.org/drawingml/2006/main">
               <a:ext uri="{FF2B5EF4-FFF2-40B4-BE49-F238E27FC236}">
-                <a16:creationId xmlns:a16="http://schemas.microsoft.com/office/drawing/2014/main" id="{11FCD724-F08A-46FB-AB1B-6729FC772560}"/>
+                <a16:creationId xmlns:a16="http://schemas.microsoft.com/office/drawing/2014/main" id="{48FEC009-563C-4996-925C-1B29074844A0}"/>
               </a:ext>
             </a:extLst>
           </p:cNvPr>
@@ -2838,7 +2838,7 @@
           <p:cNvPr id="14" name="">
             <a:extLst xmlns:a="http://schemas.openxmlformats.org/drawingml/2006/main">
               <a:ext uri="{FF2B5EF4-FFF2-40B4-BE49-F238E27FC236}">
-                <a16:creationId xmlns:a16="http://schemas.microsoft.com/office/drawing/2014/main" id="{05901D5A-BD38-42D5-A2B2-F4FFB3CDBA90}"/>
+                <a16:creationId xmlns:a16="http://schemas.microsoft.com/office/drawing/2014/main" id="{2832BEC0-D4FC-49D5-BC83-F6E7999CE645}"/>
               </a:ext>
             </a:extLst>
           </p:cNvPr>
@@ -2902,7 +2902,7 @@
           <p:cNvPr id="15" name="">
             <a:extLst xmlns:a="http://schemas.openxmlformats.org/drawingml/2006/main">
               <a:ext uri="{FF2B5EF4-FFF2-40B4-BE49-F238E27FC236}">
-                <a16:creationId xmlns:a16="http://schemas.microsoft.com/office/drawing/2014/main" id="{1F25BCD3-8052-487F-9080-B5767CFE6DB3}"/>
+                <a16:creationId xmlns:a16="http://schemas.microsoft.com/office/drawing/2014/main" id="{67586705-0299-4832-B59B-E9F26080557E}"/>
               </a:ext>
             </a:extLst>
           </p:cNvPr>
@@ -2935,7 +2935,7 @@
           <p:cNvPr id="16" name="">
             <a:extLst xmlns:a="http://schemas.openxmlformats.org/drawingml/2006/main">
               <a:ext uri="{FF2B5EF4-FFF2-40B4-BE49-F238E27FC236}">
-                <a16:creationId xmlns:a16="http://schemas.microsoft.com/office/drawing/2014/main" id="{D3F4274B-A82B-486D-A393-773DECA30611}"/>
+                <a16:creationId xmlns:a16="http://schemas.microsoft.com/office/drawing/2014/main" id="{8ED6BDC6-05D5-420F-8A73-949A564B6F3F}"/>
               </a:ext>
             </a:extLst>
           </p:cNvPr>
@@ -2999,7 +2999,7 @@
           <p:cNvPr id="17" name="">
             <a:extLst xmlns:a="http://schemas.openxmlformats.org/drawingml/2006/main">
               <a:ext uri="{FF2B5EF4-FFF2-40B4-BE49-F238E27FC236}">
-                <a16:creationId xmlns:a16="http://schemas.microsoft.com/office/drawing/2014/main" id="{9B5C77C9-B26E-4DEE-8228-432854BD4540}"/>
+                <a16:creationId xmlns:a16="http://schemas.microsoft.com/office/drawing/2014/main" id="{FFDCFCE0-EFA4-4162-919E-600320F993C9}"/>
               </a:ext>
             </a:extLst>
           </p:cNvPr>
@@ -3063,7 +3063,7 @@
           <p:cNvPr id="18" name="">
             <a:extLst xmlns:a="http://schemas.openxmlformats.org/drawingml/2006/main">
               <a:ext uri="{FF2B5EF4-FFF2-40B4-BE49-F238E27FC236}">
-                <a16:creationId xmlns:a16="http://schemas.microsoft.com/office/drawing/2014/main" id="{906B70BC-7775-4D66-B6BD-A0BB6F90A482}"/>
+                <a16:creationId xmlns:a16="http://schemas.microsoft.com/office/drawing/2014/main" id="{6FCD5947-78BC-4D7B-B883-F3D79CBFF48B}"/>
               </a:ext>
             </a:extLst>
           </p:cNvPr>
@@ -3096,7 +3096,7 @@
           <p:cNvPr id="19" name="">
             <a:extLst xmlns:a="http://schemas.openxmlformats.org/drawingml/2006/main">
               <a:ext uri="{FF2B5EF4-FFF2-40B4-BE49-F238E27FC236}">
-                <a16:creationId xmlns:a16="http://schemas.microsoft.com/office/drawing/2014/main" id="{50122E4C-B7F9-4BE5-A13E-36C771E5DAAA}"/>
+                <a16:creationId xmlns:a16="http://schemas.microsoft.com/office/drawing/2014/main" id="{BD432F32-AD13-4223-87FC-3E1DE30CF8D6}"/>
               </a:ext>
             </a:extLst>
           </p:cNvPr>
@@ -3160,7 +3160,7 @@
           <p:cNvPr id="20" name="">
             <a:extLst xmlns:a="http://schemas.openxmlformats.org/drawingml/2006/main">
               <a:ext uri="{FF2B5EF4-FFF2-40B4-BE49-F238E27FC236}">
-                <a16:creationId xmlns:a16="http://schemas.microsoft.com/office/drawing/2014/main" id="{5461E1BA-B344-468F-BF3F-B69FC840E828}"/>
+                <a16:creationId xmlns:a16="http://schemas.microsoft.com/office/drawing/2014/main" id="{F6082954-5C1C-4002-81AD-13381CC645CA}"/>
               </a:ext>
             </a:extLst>
           </p:cNvPr>
@@ -3193,7 +3193,7 @@
           <p:cNvPr id="21" name="">
             <a:extLst xmlns:a="http://schemas.openxmlformats.org/drawingml/2006/main">
               <a:ext uri="{FF2B5EF4-FFF2-40B4-BE49-F238E27FC236}">
-                <a16:creationId xmlns:a16="http://schemas.microsoft.com/office/drawing/2014/main" id="{17850698-35D4-4E6D-B18A-49CE71857993}"/>
+                <a16:creationId xmlns:a16="http://schemas.microsoft.com/office/drawing/2014/main" id="{A9FE03C5-84D8-4B41-B1B5-6EE3600D3E8E}"/>
               </a:ext>
             </a:extLst>
           </p:cNvPr>
@@ -3257,7 +3257,7 @@
           <p:cNvPr id="22" name="">
             <a:extLst xmlns:a="http://schemas.openxmlformats.org/drawingml/2006/main">
               <a:ext uri="{FF2B5EF4-FFF2-40B4-BE49-F238E27FC236}">
-                <a16:creationId xmlns:a16="http://schemas.microsoft.com/office/drawing/2014/main" id="{EFC97ABB-4C43-4536-A033-1939B5956EDE}"/>
+                <a16:creationId xmlns:a16="http://schemas.microsoft.com/office/drawing/2014/main" id="{0DE44590-551B-4031-AB59-F71D9CFE5815}"/>
               </a:ext>
             </a:extLst>
           </p:cNvPr>
@@ -3290,7 +3290,7 @@
           <p:cNvPr id="23" name="">
             <a:extLst xmlns:a="http://schemas.openxmlformats.org/drawingml/2006/main">
               <a:ext uri="{FF2B5EF4-FFF2-40B4-BE49-F238E27FC236}">
-                <a16:creationId xmlns:a16="http://schemas.microsoft.com/office/drawing/2014/main" id="{D4E2C260-591A-47D5-8397-DAE51F486679}"/>
+                <a16:creationId xmlns:a16="http://schemas.microsoft.com/office/drawing/2014/main" id="{C12CB732-E130-4386-A613-CF1790BC7BFA}"/>
               </a:ext>
             </a:extLst>
           </p:cNvPr>
@@ -3354,7 +3354,7 @@
           <p:cNvPr id="24" name="">
             <a:extLst xmlns:a="http://schemas.openxmlformats.org/drawingml/2006/main">
               <a:ext uri="{FF2B5EF4-FFF2-40B4-BE49-F238E27FC236}">
-                <a16:creationId xmlns:a16="http://schemas.microsoft.com/office/drawing/2014/main" id="{EBD34BAF-5DF1-43B6-8D94-460F4DED3C38}"/>
+                <a16:creationId xmlns:a16="http://schemas.microsoft.com/office/drawing/2014/main" id="{F8A8F91E-1B1F-403C-A8F8-7353C6E6A6E8}"/>
               </a:ext>
             </a:extLst>
           </p:cNvPr>
@@ -3387,7 +3387,7 @@
           <p:cNvPr id="25" name="">
             <a:extLst xmlns:a="http://schemas.openxmlformats.org/drawingml/2006/main">
               <a:ext uri="{FF2B5EF4-FFF2-40B4-BE49-F238E27FC236}">
-                <a16:creationId xmlns:a16="http://schemas.microsoft.com/office/drawing/2014/main" id="{243B24F1-C9E3-4BD6-887E-156556F251BD}"/>
+                <a16:creationId xmlns:a16="http://schemas.microsoft.com/office/drawing/2014/main" id="{5DDE9CAA-2191-40DE-B7F0-3FC4E830C1FB}"/>
               </a:ext>
             </a:extLst>
           </p:cNvPr>
@@ -3451,7 +3451,7 @@
           <p:cNvPr id="26" name="">
             <a:extLst xmlns:a="http://schemas.openxmlformats.org/drawingml/2006/main">
               <a:ext uri="{FF2B5EF4-FFF2-40B4-BE49-F238E27FC236}">
-                <a16:creationId xmlns:a16="http://schemas.microsoft.com/office/drawing/2014/main" id="{A50C9709-990C-44A7-968A-47C9F60C1B90}"/>
+                <a16:creationId xmlns:a16="http://schemas.microsoft.com/office/drawing/2014/main" id="{C989474C-7507-4B64-A67A-D14FCB00D37A}"/>
               </a:ext>
             </a:extLst>
           </p:cNvPr>
@@ -3484,7 +3484,7 @@
           <p:cNvPr id="27" name="">
             <a:extLst xmlns:a="http://schemas.openxmlformats.org/drawingml/2006/main">
               <a:ext uri="{FF2B5EF4-FFF2-40B4-BE49-F238E27FC236}">
-                <a16:creationId xmlns:a16="http://schemas.microsoft.com/office/drawing/2014/main" id="{79769934-F85B-434A-82EF-5AE80325B49A}"/>
+                <a16:creationId xmlns:a16="http://schemas.microsoft.com/office/drawing/2014/main" id="{3C3FA4A6-7E2D-4AED-9C3C-9BF616BE8E87}"/>
               </a:ext>
             </a:extLst>
           </p:cNvPr>
@@ -3548,7 +3548,7 @@
           <p:cNvPr id="28" name="">
             <a:extLst xmlns:a="http://schemas.openxmlformats.org/drawingml/2006/main">
               <a:ext uri="{FF2B5EF4-FFF2-40B4-BE49-F238E27FC236}">
-                <a16:creationId xmlns:a16="http://schemas.microsoft.com/office/drawing/2014/main" id="{9F255029-C102-4629-9047-C55D0C4956A9}"/>
+                <a16:creationId xmlns:a16="http://schemas.microsoft.com/office/drawing/2014/main" id="{4C15B33F-D502-43A8-82A3-20757E80A0AA}"/>
               </a:ext>
             </a:extLst>
           </p:cNvPr>
@@ -3612,7 +3612,7 @@
           <p:cNvPr id="29" name="">
             <a:extLst xmlns:a="http://schemas.openxmlformats.org/drawingml/2006/main">
               <a:ext uri="{FF2B5EF4-FFF2-40B4-BE49-F238E27FC236}">
-                <a16:creationId xmlns:a16="http://schemas.microsoft.com/office/drawing/2014/main" id="{19EB5040-B18E-4CD8-AE53-85C012BD81CA}"/>
+                <a16:creationId xmlns:a16="http://schemas.microsoft.com/office/drawing/2014/main" id="{0BB896FA-3584-48E0-ACE1-AFD4848941FC}"/>
               </a:ext>
             </a:extLst>
           </p:cNvPr>
@@ -3674,7 +3674,7 @@
     </p:spTree>
     <p:extLst>
       <p:ext uri="{BB962C8B-B14F-4D97-AF65-F5344CB8AC3E}">
-        <p14:creationId xmlns:p14="http://schemas.microsoft.com/office/powerpoint/2010/main" val="510247182"/>
+        <p14:creationId xmlns:p14="http://schemas.microsoft.com/office/powerpoint/2010/main" val="873071959"/>
       </p:ext>
     </p:extLst>
   </p:cSld>
@@ -3698,7 +3698,7 @@
           <p:cNvPr id="1" name="">
             <a:extLst xmlns:a="http://schemas.openxmlformats.org/drawingml/2006/main">
               <a:ext uri="{FF2B5EF4-FFF2-40B4-BE49-F238E27FC236}">
-                <a16:creationId xmlns:a16="http://schemas.microsoft.com/office/drawing/2014/main" id="{D4F41C26-173E-43CB-8A45-FA3D76E393B8}"/>
+                <a16:creationId xmlns:a16="http://schemas.microsoft.com/office/drawing/2014/main" id="{6A603C36-F9F4-4FB5-AD98-EE0D5287B391}"/>
               </a:ext>
             </a:extLst>
           </p:cNvPr>
@@ -3731,7 +3731,7 @@
           <p:cNvPr id="2" name="">
             <a:extLst xmlns:a="http://schemas.openxmlformats.org/drawingml/2006/main">
               <a:ext uri="{FF2B5EF4-FFF2-40B4-BE49-F238E27FC236}">
-                <a16:creationId xmlns:a16="http://schemas.microsoft.com/office/drawing/2014/main" id="{B4216514-32C8-4ED7-AE99-A44E20581515}"/>
+                <a16:creationId xmlns:a16="http://schemas.microsoft.com/office/drawing/2014/main" id="{991EA265-2961-4B04-A0C9-BAF18C8589C4}"/>
               </a:ext>
             </a:extLst>
           </p:cNvPr>
@@ -3764,7 +3764,7 @@
           <p:cNvPr id="3" name="">
             <a:extLst xmlns:a="http://schemas.openxmlformats.org/drawingml/2006/main">
               <a:ext uri="{FF2B5EF4-FFF2-40B4-BE49-F238E27FC236}">
-                <a16:creationId xmlns:a16="http://schemas.microsoft.com/office/drawing/2014/main" id="{C03228C7-C794-4696-A654-D9195947AA94}"/>
+                <a16:creationId xmlns:a16="http://schemas.microsoft.com/office/drawing/2014/main" id="{8DA33E08-A192-410E-BFF9-B1BD79911EB4}"/>
               </a:ext>
             </a:extLst>
           </p:cNvPr>
@@ -3828,7 +3828,7 @@
           <p:cNvPr id="4" name="">
             <a:extLst xmlns:a="http://schemas.openxmlformats.org/drawingml/2006/main">
               <a:ext uri="{FF2B5EF4-FFF2-40B4-BE49-F238E27FC236}">
-                <a16:creationId xmlns:a16="http://schemas.microsoft.com/office/drawing/2014/main" id="{C7A29752-A2B3-463D-BA92-2D19F4FA7635}"/>
+                <a16:creationId xmlns:a16="http://schemas.microsoft.com/office/drawing/2014/main" id="{0EB21EFC-B48E-454C-B3F2-1AE38A7CA3F8}"/>
               </a:ext>
             </a:extLst>
           </p:cNvPr>
@@ -3892,7 +3892,7 @@
           <p:cNvPr id="5" name="">
             <a:extLst xmlns:a="http://schemas.openxmlformats.org/drawingml/2006/main">
               <a:ext uri="{FF2B5EF4-FFF2-40B4-BE49-F238E27FC236}">
-                <a16:creationId xmlns:a16="http://schemas.microsoft.com/office/drawing/2014/main" id="{8BDCB3F7-B616-4B2A-9C81-B4A8FE5DD09F}"/>
+                <a16:creationId xmlns:a16="http://schemas.microsoft.com/office/drawing/2014/main" id="{2BD7C34B-3277-4988-A95A-2C257C57F494}"/>
               </a:ext>
             </a:extLst>
           </p:cNvPr>
@@ -3925,7 +3925,7 @@
           <p:cNvPr id="6" name="">
             <a:extLst xmlns:a="http://schemas.openxmlformats.org/drawingml/2006/main">
               <a:ext uri="{FF2B5EF4-FFF2-40B4-BE49-F238E27FC236}">
-                <a16:creationId xmlns:a16="http://schemas.microsoft.com/office/drawing/2014/main" id="{8913A634-D308-450C-8CC3-9E2088C7ADA2}"/>
+                <a16:creationId xmlns:a16="http://schemas.microsoft.com/office/drawing/2014/main" id="{D631A5FA-E833-4AFA-9CCE-88A3A313D041}"/>
               </a:ext>
             </a:extLst>
           </p:cNvPr>
@@ -3958,7 +3958,7 @@
           <p:cNvPr id="7" name="">
             <a:extLst xmlns:a="http://schemas.openxmlformats.org/drawingml/2006/main">
               <a:ext uri="{FF2B5EF4-FFF2-40B4-BE49-F238E27FC236}">
-                <a16:creationId xmlns:a16="http://schemas.microsoft.com/office/drawing/2014/main" id="{7A552006-2579-49ED-AC27-F98342E449C9}"/>
+                <a16:creationId xmlns:a16="http://schemas.microsoft.com/office/drawing/2014/main" id="{669EDEC4-4858-4579-A853-B86E1C0F95DF}"/>
               </a:ext>
             </a:extLst>
           </p:cNvPr>
@@ -4022,7 +4022,7 @@
           <p:cNvPr id="8" name="">
             <a:extLst xmlns:a="http://schemas.openxmlformats.org/drawingml/2006/main">
               <a:ext uri="{FF2B5EF4-FFF2-40B4-BE49-F238E27FC236}">
-                <a16:creationId xmlns:a16="http://schemas.microsoft.com/office/drawing/2014/main" id="{25909C8B-BE34-48F6-B7AB-75244A093775}"/>
+                <a16:creationId xmlns:a16="http://schemas.microsoft.com/office/drawing/2014/main" id="{FD5F0D87-40CB-4284-A7FB-0CDFB6C63677}"/>
               </a:ext>
             </a:extLst>
           </p:cNvPr>
@@ -4055,7 +4055,7 @@
           <p:cNvPr id="9" name="">
             <a:extLst xmlns:a="http://schemas.openxmlformats.org/drawingml/2006/main">
               <a:ext uri="{FF2B5EF4-FFF2-40B4-BE49-F238E27FC236}">
-                <a16:creationId xmlns:a16="http://schemas.microsoft.com/office/drawing/2014/main" id="{5A92D807-34CE-4194-B585-F526C7E20699}"/>
+                <a16:creationId xmlns:a16="http://schemas.microsoft.com/office/drawing/2014/main" id="{9653BE26-C6CB-4FF3-8257-314124EFE721}"/>
               </a:ext>
             </a:extLst>
           </p:cNvPr>
@@ -4119,7 +4119,7 @@
           <p:cNvPr id="10" name="">
             <a:extLst xmlns:a="http://schemas.openxmlformats.org/drawingml/2006/main">
               <a:ext uri="{FF2B5EF4-FFF2-40B4-BE49-F238E27FC236}">
-                <a16:creationId xmlns:a16="http://schemas.microsoft.com/office/drawing/2014/main" id="{054456CD-3E8D-418D-B11A-73825618071A}"/>
+                <a16:creationId xmlns:a16="http://schemas.microsoft.com/office/drawing/2014/main" id="{F5494111-FBF9-4717-910B-6C66262AA366}"/>
               </a:ext>
             </a:extLst>
           </p:cNvPr>
@@ -4152,7 +4152,7 @@
           <p:cNvPr id="11" name="">
             <a:extLst xmlns:a="http://schemas.openxmlformats.org/drawingml/2006/main">
               <a:ext uri="{FF2B5EF4-FFF2-40B4-BE49-F238E27FC236}">
-                <a16:creationId xmlns:a16="http://schemas.microsoft.com/office/drawing/2014/main" id="{21549D70-BF2B-41E5-BD35-B8BC11D8EE87}"/>
+                <a16:creationId xmlns:a16="http://schemas.microsoft.com/office/drawing/2014/main" id="{C75FB10E-9BB7-4538-A456-3AAC9F2CB840}"/>
               </a:ext>
             </a:extLst>
           </p:cNvPr>
@@ -4216,7 +4216,7 @@
           <p:cNvPr id="12" name="">
             <a:extLst xmlns:a="http://schemas.openxmlformats.org/drawingml/2006/main">
               <a:ext uri="{FF2B5EF4-FFF2-40B4-BE49-F238E27FC236}">
-                <a16:creationId xmlns:a16="http://schemas.microsoft.com/office/drawing/2014/main" id="{13E0BE36-9365-4286-9F84-75E9D086CAC5}"/>
+                <a16:creationId xmlns:a16="http://schemas.microsoft.com/office/drawing/2014/main" id="{93C690A0-52F1-42B0-9D0E-AEF2ACA23146}"/>
               </a:ext>
             </a:extLst>
           </p:cNvPr>
@@ -4249,7 +4249,7 @@
           <p:cNvPr id="13" name="">
             <a:extLst xmlns:a="http://schemas.openxmlformats.org/drawingml/2006/main">
               <a:ext uri="{FF2B5EF4-FFF2-40B4-BE49-F238E27FC236}">
-                <a16:creationId xmlns:a16="http://schemas.microsoft.com/office/drawing/2014/main" id="{98E77EB1-8F6D-4399-852B-0A5BD42B56D9}"/>
+                <a16:creationId xmlns:a16="http://schemas.microsoft.com/office/drawing/2014/main" id="{C346C40B-1DB5-45A3-8D23-049299F1E5CC}"/>
               </a:ext>
             </a:extLst>
           </p:cNvPr>
@@ -4313,7 +4313,7 @@
           <p:cNvPr id="14" name="">
             <a:extLst xmlns:a="http://schemas.openxmlformats.org/drawingml/2006/main">
               <a:ext uri="{FF2B5EF4-FFF2-40B4-BE49-F238E27FC236}">
-                <a16:creationId xmlns:a16="http://schemas.microsoft.com/office/drawing/2014/main" id="{838B1A09-DFC3-4141-A228-1ECB50D2CE58}"/>
+                <a16:creationId xmlns:a16="http://schemas.microsoft.com/office/drawing/2014/main" id="{E453BDFB-E477-4E30-A099-B0E258F9F4F3}"/>
               </a:ext>
             </a:extLst>
           </p:cNvPr>
@@ -4346,7 +4346,7 @@
           <p:cNvPr id="15" name="">
             <a:extLst xmlns:a="http://schemas.openxmlformats.org/drawingml/2006/main">
               <a:ext uri="{FF2B5EF4-FFF2-40B4-BE49-F238E27FC236}">
-                <a16:creationId xmlns:a16="http://schemas.microsoft.com/office/drawing/2014/main" id="{EE26B3AA-07AB-4F1C-B266-65DF78818C53}"/>
+                <a16:creationId xmlns:a16="http://schemas.microsoft.com/office/drawing/2014/main" id="{1CE54300-EC9F-44BD-854B-5FDAC638CD09}"/>
               </a:ext>
             </a:extLst>
           </p:cNvPr>
@@ -4410,7 +4410,7 @@
           <p:cNvPr id="16" name="">
             <a:extLst xmlns:a="http://schemas.openxmlformats.org/drawingml/2006/main">
               <a:ext uri="{FF2B5EF4-FFF2-40B4-BE49-F238E27FC236}">
-                <a16:creationId xmlns:a16="http://schemas.microsoft.com/office/drawing/2014/main" id="{C0F3C827-B731-4FB1-A752-5E64E3ED1B11}"/>
+                <a16:creationId xmlns:a16="http://schemas.microsoft.com/office/drawing/2014/main" id="{B4B46909-534F-42FA-B266-7F0B26C5DE3E}"/>
               </a:ext>
             </a:extLst>
           </p:cNvPr>
@@ -4443,7 +4443,7 @@
           <p:cNvPr id="17" name="">
             <a:extLst xmlns:a="http://schemas.openxmlformats.org/drawingml/2006/main">
               <a:ext uri="{FF2B5EF4-FFF2-40B4-BE49-F238E27FC236}">
-                <a16:creationId xmlns:a16="http://schemas.microsoft.com/office/drawing/2014/main" id="{D7AF7008-47A9-4CE6-B924-21E1FA164C7E}"/>
+                <a16:creationId xmlns:a16="http://schemas.microsoft.com/office/drawing/2014/main" id="{7F137228-C0A7-460A-A0A1-6FC2EEA0FC3E}"/>
               </a:ext>
             </a:extLst>
           </p:cNvPr>
@@ -4507,7 +4507,7 @@
           <p:cNvPr id="18" name="">
             <a:extLst xmlns:a="http://schemas.openxmlformats.org/drawingml/2006/main">
               <a:ext uri="{FF2B5EF4-FFF2-40B4-BE49-F238E27FC236}">
-                <a16:creationId xmlns:a16="http://schemas.microsoft.com/office/drawing/2014/main" id="{ECF54F2A-6040-4453-94CB-44CCC50D8451}"/>
+                <a16:creationId xmlns:a16="http://schemas.microsoft.com/office/drawing/2014/main" id="{5A5070F4-96E2-4814-953B-91E9633BB1DA}"/>
               </a:ext>
             </a:extLst>
           </p:cNvPr>
@@ -4571,7 +4571,7 @@
           <p:cNvPr id="19" name="">
             <a:extLst xmlns:a="http://schemas.openxmlformats.org/drawingml/2006/main">
               <a:ext uri="{FF2B5EF4-FFF2-40B4-BE49-F238E27FC236}">
-                <a16:creationId xmlns:a16="http://schemas.microsoft.com/office/drawing/2014/main" id="{1EC9E6A8-BE0B-46D4-A339-55654A5D8D46}"/>
+                <a16:creationId xmlns:a16="http://schemas.microsoft.com/office/drawing/2014/main" id="{2D97B15C-6DC3-4262-95B1-E16F92C76EEF}"/>
               </a:ext>
             </a:extLst>
           </p:cNvPr>
@@ -4633,7 +4633,7 @@
     </p:spTree>
     <p:extLst>
       <p:ext uri="{BB962C8B-B14F-4D97-AF65-F5344CB8AC3E}">
-        <p14:creationId xmlns:p14="http://schemas.microsoft.com/office/powerpoint/2010/main" val="1052733021"/>
+        <p14:creationId xmlns:p14="http://schemas.microsoft.com/office/powerpoint/2010/main" val="1659009616"/>
       </p:ext>
     </p:extLst>
   </p:cSld>
@@ -4657,7 +4657,7 @@
           <p:cNvPr id="1" name="">
             <a:extLst xmlns:a="http://schemas.openxmlformats.org/drawingml/2006/main">
               <a:ext uri="{FF2B5EF4-FFF2-40B4-BE49-F238E27FC236}">
-                <a16:creationId xmlns:a16="http://schemas.microsoft.com/office/drawing/2014/main" id="{3B2B0E2A-FF1A-440F-80CC-91F81BBA4852}"/>
+                <a16:creationId xmlns:a16="http://schemas.microsoft.com/office/drawing/2014/main" id="{B57C3B4C-E5E0-4A0C-A0D6-9D294722E2C4}"/>
               </a:ext>
             </a:extLst>
           </p:cNvPr>
@@ -4690,7 +4690,7 @@
           <p:cNvPr id="2" name="">
             <a:extLst xmlns:a="http://schemas.openxmlformats.org/drawingml/2006/main">
               <a:ext uri="{FF2B5EF4-FFF2-40B4-BE49-F238E27FC236}">
-                <a16:creationId xmlns:a16="http://schemas.microsoft.com/office/drawing/2014/main" id="{FA5C88EB-2535-42AE-8211-51025359FA2A}"/>
+                <a16:creationId xmlns:a16="http://schemas.microsoft.com/office/drawing/2014/main" id="{78CCBD03-116A-4151-8DFB-DAFBECE5942E}"/>
               </a:ext>
             </a:extLst>
           </p:cNvPr>
@@ -4723,7 +4723,7 @@
           <p:cNvPr id="3" name="">
             <a:extLst xmlns:a="http://schemas.openxmlformats.org/drawingml/2006/main">
               <a:ext uri="{FF2B5EF4-FFF2-40B4-BE49-F238E27FC236}">
-                <a16:creationId xmlns:a16="http://schemas.microsoft.com/office/drawing/2014/main" id="{8AE03623-C202-4F79-8448-D5166FC8D9B8}"/>
+                <a16:creationId xmlns:a16="http://schemas.microsoft.com/office/drawing/2014/main" id="{A259D2F1-FD9E-4D1B-B50A-F493B343B364}"/>
               </a:ext>
             </a:extLst>
           </p:cNvPr>
@@ -4787,7 +4787,7 @@
           <p:cNvPr id="4" name="">
             <a:extLst xmlns:a="http://schemas.openxmlformats.org/drawingml/2006/main">
               <a:ext uri="{FF2B5EF4-FFF2-40B4-BE49-F238E27FC236}">
-                <a16:creationId xmlns:a16="http://schemas.microsoft.com/office/drawing/2014/main" id="{D851B539-80A6-4399-B232-D27A80F173D2}"/>
+                <a16:creationId xmlns:a16="http://schemas.microsoft.com/office/drawing/2014/main" id="{3ABDBBDF-596A-438F-A272-72C5BE8B6639}"/>
               </a:ext>
             </a:extLst>
           </p:cNvPr>
@@ -4851,7 +4851,7 @@
           <p:cNvPr id="5" name="">
             <a:extLst xmlns:a="http://schemas.openxmlformats.org/drawingml/2006/main">
               <a:ext uri="{FF2B5EF4-FFF2-40B4-BE49-F238E27FC236}">
-                <a16:creationId xmlns:a16="http://schemas.microsoft.com/office/drawing/2014/main" id="{035FAA39-1745-4CA2-BD93-FDE18C8CC81C}"/>
+                <a16:creationId xmlns:a16="http://schemas.microsoft.com/office/drawing/2014/main" id="{0A8CE96D-0CF7-4BB4-8387-ADB621C02A2D}"/>
               </a:ext>
             </a:extLst>
           </p:cNvPr>
@@ -4884,7 +4884,7 @@
           <p:cNvPr id="6" name="">
             <a:extLst xmlns:a="http://schemas.openxmlformats.org/drawingml/2006/main">
               <a:ext uri="{FF2B5EF4-FFF2-40B4-BE49-F238E27FC236}">
-                <a16:creationId xmlns:a16="http://schemas.microsoft.com/office/drawing/2014/main" id="{74AD6791-456C-45A7-963A-594EEE7D9ACE}"/>
+                <a16:creationId xmlns:a16="http://schemas.microsoft.com/office/drawing/2014/main" id="{8A260AC6-84D4-4BE4-9701-9B92BC0D91C2}"/>
               </a:ext>
             </a:extLst>
           </p:cNvPr>
@@ -4917,7 +4917,7 @@
           <p:cNvPr id="7" name="">
             <a:extLst xmlns:a="http://schemas.openxmlformats.org/drawingml/2006/main">
               <a:ext uri="{FF2B5EF4-FFF2-40B4-BE49-F238E27FC236}">
-                <a16:creationId xmlns:a16="http://schemas.microsoft.com/office/drawing/2014/main" id="{0E7CF9BD-6776-416C-ACE6-9B1DD827499C}"/>
+                <a16:creationId xmlns:a16="http://schemas.microsoft.com/office/drawing/2014/main" id="{3B2A3210-08E9-4B42-9725-BF6E16F8DA05}"/>
               </a:ext>
             </a:extLst>
           </p:cNvPr>
@@ -4981,7 +4981,7 @@
           <p:cNvPr id="8" name="">
             <a:extLst xmlns:a="http://schemas.openxmlformats.org/drawingml/2006/main">
               <a:ext uri="{FF2B5EF4-FFF2-40B4-BE49-F238E27FC236}">
-                <a16:creationId xmlns:a16="http://schemas.microsoft.com/office/drawing/2014/main" id="{1D0AAB8C-BBDA-4B8E-B6F3-3533CE2B5CFC}"/>
+                <a16:creationId xmlns:a16="http://schemas.microsoft.com/office/drawing/2014/main" id="{5110F71B-04D0-41A6-BD29-AF1422AEE93E}"/>
               </a:ext>
             </a:extLst>
           </p:cNvPr>
@@ -5045,7 +5045,7 @@
           <p:cNvPr id="9" name="">
             <a:extLst xmlns:a="http://schemas.openxmlformats.org/drawingml/2006/main">
               <a:ext uri="{FF2B5EF4-FFF2-40B4-BE49-F238E27FC236}">
-                <a16:creationId xmlns:a16="http://schemas.microsoft.com/office/drawing/2014/main" id="{54601E8A-1B1C-403F-AD00-F5BF24FC9906}"/>
+                <a16:creationId xmlns:a16="http://schemas.microsoft.com/office/drawing/2014/main" id="{16F472F0-5F33-47D2-A9CE-C854F372CBBD}"/>
               </a:ext>
             </a:extLst>
           </p:cNvPr>
@@ -5078,7 +5078,7 @@
           <p:cNvPr id="10" name="">
             <a:extLst xmlns:a="http://schemas.openxmlformats.org/drawingml/2006/main">
               <a:ext uri="{FF2B5EF4-FFF2-40B4-BE49-F238E27FC236}">
-                <a16:creationId xmlns:a16="http://schemas.microsoft.com/office/drawing/2014/main" id="{3438E0FD-7420-4CFA-A474-008AD6A42948}"/>
+                <a16:creationId xmlns:a16="http://schemas.microsoft.com/office/drawing/2014/main" id="{D63876F6-70B3-47DA-BB0C-EBB1A8B67E9E}"/>
               </a:ext>
             </a:extLst>
           </p:cNvPr>
@@ -5142,7 +5142,7 @@
           <p:cNvPr id="11" name="">
             <a:extLst xmlns:a="http://schemas.openxmlformats.org/drawingml/2006/main">
               <a:ext uri="{FF2B5EF4-FFF2-40B4-BE49-F238E27FC236}">
-                <a16:creationId xmlns:a16="http://schemas.microsoft.com/office/drawing/2014/main" id="{6450E46B-9574-4A91-B26C-27A4FC6EE916}"/>
+                <a16:creationId xmlns:a16="http://schemas.microsoft.com/office/drawing/2014/main" id="{A62155D7-D972-4E47-9C9D-6DAF7A21FA54}"/>
               </a:ext>
             </a:extLst>
           </p:cNvPr>
@@ -5206,7 +5206,7 @@
           <p:cNvPr id="12" name="">
             <a:extLst xmlns:a="http://schemas.openxmlformats.org/drawingml/2006/main">
               <a:ext uri="{FF2B5EF4-FFF2-40B4-BE49-F238E27FC236}">
-                <a16:creationId xmlns:a16="http://schemas.microsoft.com/office/drawing/2014/main" id="{2E63FEA5-8673-48E2-A82B-9DB980230C6C}"/>
+                <a16:creationId xmlns:a16="http://schemas.microsoft.com/office/drawing/2014/main" id="{FB875DEB-3B82-48D4-BEA9-ECEB8117FEE8}"/>
               </a:ext>
             </a:extLst>
           </p:cNvPr>
@@ -5239,7 +5239,7 @@
           <p:cNvPr id="13" name="">
             <a:extLst xmlns:a="http://schemas.openxmlformats.org/drawingml/2006/main">
               <a:ext uri="{FF2B5EF4-FFF2-40B4-BE49-F238E27FC236}">
-                <a16:creationId xmlns:a16="http://schemas.microsoft.com/office/drawing/2014/main" id="{AB27CE7A-D43B-41AE-82A7-F57AEA2D2151}"/>
+                <a16:creationId xmlns:a16="http://schemas.microsoft.com/office/drawing/2014/main" id="{4BDD5367-AA77-4C24-A0EF-5760B243404A}"/>
               </a:ext>
             </a:extLst>
           </p:cNvPr>
@@ -5303,7 +5303,7 @@
           <p:cNvPr id="14" name="">
             <a:extLst xmlns:a="http://schemas.openxmlformats.org/drawingml/2006/main">
               <a:ext uri="{FF2B5EF4-FFF2-40B4-BE49-F238E27FC236}">
-                <a16:creationId xmlns:a16="http://schemas.microsoft.com/office/drawing/2014/main" id="{C6A4EF51-2FAE-42B9-A5B0-3BF4C1498537}"/>
+                <a16:creationId xmlns:a16="http://schemas.microsoft.com/office/drawing/2014/main" id="{6491B55F-C63E-4124-8164-3D7E8D250B1A}"/>
               </a:ext>
             </a:extLst>
           </p:cNvPr>
@@ -5367,7 +5367,7 @@
           <p:cNvPr id="15" name="">
             <a:extLst xmlns:a="http://schemas.openxmlformats.org/drawingml/2006/main">
               <a:ext uri="{FF2B5EF4-FFF2-40B4-BE49-F238E27FC236}">
-                <a16:creationId xmlns:a16="http://schemas.microsoft.com/office/drawing/2014/main" id="{A0DB51AE-A092-4FFC-9F8C-94A343CFCE05}"/>
+                <a16:creationId xmlns:a16="http://schemas.microsoft.com/office/drawing/2014/main" id="{AE654D56-994D-406F-8FC1-E174C7D7DD83}"/>
               </a:ext>
             </a:extLst>
           </p:cNvPr>
@@ -5400,7 +5400,7 @@
           <p:cNvPr id="16" name="">
             <a:extLst xmlns:a="http://schemas.openxmlformats.org/drawingml/2006/main">
               <a:ext uri="{FF2B5EF4-FFF2-40B4-BE49-F238E27FC236}">
-                <a16:creationId xmlns:a16="http://schemas.microsoft.com/office/drawing/2014/main" id="{102BE50F-EC6A-46F5-BA60-80AF157463B5}"/>
+                <a16:creationId xmlns:a16="http://schemas.microsoft.com/office/drawing/2014/main" id="{53583C7A-23E1-490C-ACA8-AF16139E9DA3}"/>
               </a:ext>
             </a:extLst>
           </p:cNvPr>
@@ -5464,7 +5464,7 @@
           <p:cNvPr id="17" name="">
             <a:extLst xmlns:a="http://schemas.openxmlformats.org/drawingml/2006/main">
               <a:ext uri="{FF2B5EF4-FFF2-40B4-BE49-F238E27FC236}">
-                <a16:creationId xmlns:a16="http://schemas.microsoft.com/office/drawing/2014/main" id="{447BCC1A-4480-4FA3-B979-D708B15CFDD8}"/>
+                <a16:creationId xmlns:a16="http://schemas.microsoft.com/office/drawing/2014/main" id="{FB451D3A-144F-4D96-878D-90CEA441906E}"/>
               </a:ext>
             </a:extLst>
           </p:cNvPr>
@@ -5528,7 +5528,7 @@
           <p:cNvPr id="18" name="">
             <a:extLst xmlns:a="http://schemas.openxmlformats.org/drawingml/2006/main">
               <a:ext uri="{FF2B5EF4-FFF2-40B4-BE49-F238E27FC236}">
-                <a16:creationId xmlns:a16="http://schemas.microsoft.com/office/drawing/2014/main" id="{11D4FB57-2E12-4148-8F98-8A6C9ACCA61A}"/>
+                <a16:creationId xmlns:a16="http://schemas.microsoft.com/office/drawing/2014/main" id="{9B296FCA-08A2-4418-A80F-7AC73C423255}"/>
               </a:ext>
             </a:extLst>
           </p:cNvPr>
@@ -5592,7 +5592,7 @@
           <p:cNvPr id="19" name="">
             <a:extLst xmlns:a="http://schemas.openxmlformats.org/drawingml/2006/main">
               <a:ext uri="{FF2B5EF4-FFF2-40B4-BE49-F238E27FC236}">
-                <a16:creationId xmlns:a16="http://schemas.microsoft.com/office/drawing/2014/main" id="{03568F43-A5B1-48E4-85D8-F3E1A6ED4D80}"/>
+                <a16:creationId xmlns:a16="http://schemas.microsoft.com/office/drawing/2014/main" id="{809D0DB1-E0C3-4C41-8CCE-C04E21A83E2F}"/>
               </a:ext>
             </a:extLst>
           </p:cNvPr>
@@ -5625,7 +5625,7 @@
           <p:cNvPr id="20" name="">
             <a:extLst xmlns:a="http://schemas.openxmlformats.org/drawingml/2006/main">
               <a:ext uri="{FF2B5EF4-FFF2-40B4-BE49-F238E27FC236}">
-                <a16:creationId xmlns:a16="http://schemas.microsoft.com/office/drawing/2014/main" id="{CFE704D5-431E-4459-BD5A-B0EEC8BC827C}"/>
+                <a16:creationId xmlns:a16="http://schemas.microsoft.com/office/drawing/2014/main" id="{2992F13B-F7CE-4EDB-B1E5-C722CC7A005B}"/>
               </a:ext>
             </a:extLst>
           </p:cNvPr>
@@ -5658,7 +5658,7 @@
           <p:cNvPr id="21" name="">
             <a:extLst xmlns:a="http://schemas.openxmlformats.org/drawingml/2006/main">
               <a:ext uri="{FF2B5EF4-FFF2-40B4-BE49-F238E27FC236}">
-                <a16:creationId xmlns:a16="http://schemas.microsoft.com/office/drawing/2014/main" id="{3555FDCE-07B6-469B-BB01-42D713201314}"/>
+                <a16:creationId xmlns:a16="http://schemas.microsoft.com/office/drawing/2014/main" id="{481350BF-94AE-4366-92FD-444006B0480E}"/>
               </a:ext>
             </a:extLst>
           </p:cNvPr>
@@ -5722,7 +5722,7 @@
           <p:cNvPr id="22" name="">
             <a:extLst xmlns:a="http://schemas.openxmlformats.org/drawingml/2006/main">
               <a:ext uri="{FF2B5EF4-FFF2-40B4-BE49-F238E27FC236}">
-                <a16:creationId xmlns:a16="http://schemas.microsoft.com/office/drawing/2014/main" id="{3E0EFC89-803B-4050-A242-3876156A163F}"/>
+                <a16:creationId xmlns:a16="http://schemas.microsoft.com/office/drawing/2014/main" id="{32FD4DF7-6DF0-4BAE-9162-F2AA4EF0215E}"/>
               </a:ext>
             </a:extLst>
           </p:cNvPr>
@@ -5755,7 +5755,7 @@
           <p:cNvPr id="23" name="">
             <a:extLst xmlns:a="http://schemas.openxmlformats.org/drawingml/2006/main">
               <a:ext uri="{FF2B5EF4-FFF2-40B4-BE49-F238E27FC236}">
-                <a16:creationId xmlns:a16="http://schemas.microsoft.com/office/drawing/2014/main" id="{33ABDD15-33B6-4FFE-AA3A-10A76764A185}"/>
+                <a16:creationId xmlns:a16="http://schemas.microsoft.com/office/drawing/2014/main" id="{9A1D14B8-E9ED-4C13-8193-AF8D9690D785}"/>
               </a:ext>
             </a:extLst>
           </p:cNvPr>
@@ -5788,7 +5788,7 @@
           <p:cNvPr id="24" name="">
             <a:extLst xmlns:a="http://schemas.openxmlformats.org/drawingml/2006/main">
               <a:ext uri="{FF2B5EF4-FFF2-40B4-BE49-F238E27FC236}">
-                <a16:creationId xmlns:a16="http://schemas.microsoft.com/office/drawing/2014/main" id="{4215B940-73DE-4A56-9B71-6B23014821CD}"/>
+                <a16:creationId xmlns:a16="http://schemas.microsoft.com/office/drawing/2014/main" id="{A7061E71-62A9-4B80-B72E-E53CB13FF5CA}"/>
               </a:ext>
             </a:extLst>
           </p:cNvPr>
@@ -5852,7 +5852,7 @@
           <p:cNvPr id="25" name="">
             <a:extLst xmlns:a="http://schemas.openxmlformats.org/drawingml/2006/main">
               <a:ext uri="{FF2B5EF4-FFF2-40B4-BE49-F238E27FC236}">
-                <a16:creationId xmlns:a16="http://schemas.microsoft.com/office/drawing/2014/main" id="{19BCF974-FB7B-4B60-9A21-CD75CB78FFAA}"/>
+                <a16:creationId xmlns:a16="http://schemas.microsoft.com/office/drawing/2014/main" id="{A478321F-6A39-4F2F-B19A-FF7EB88D9867}"/>
               </a:ext>
             </a:extLst>
           </p:cNvPr>
@@ -5885,7 +5885,7 @@
           <p:cNvPr id="26" name="">
             <a:extLst xmlns:a="http://schemas.openxmlformats.org/drawingml/2006/main">
               <a:ext uri="{FF2B5EF4-FFF2-40B4-BE49-F238E27FC236}">
-                <a16:creationId xmlns:a16="http://schemas.microsoft.com/office/drawing/2014/main" id="{08E79FD4-75A3-4512-B8E8-B5474F2CF55F}"/>
+                <a16:creationId xmlns:a16="http://schemas.microsoft.com/office/drawing/2014/main" id="{C6941074-6F36-484F-8D8B-106547FFA358}"/>
               </a:ext>
             </a:extLst>
           </p:cNvPr>
@@ -5918,7 +5918,7 @@
           <p:cNvPr id="27" name="">
             <a:extLst xmlns:a="http://schemas.openxmlformats.org/drawingml/2006/main">
               <a:ext uri="{FF2B5EF4-FFF2-40B4-BE49-F238E27FC236}">
-                <a16:creationId xmlns:a16="http://schemas.microsoft.com/office/drawing/2014/main" id="{EB20887E-86D3-4599-A106-47D4D9052466}"/>
+                <a16:creationId xmlns:a16="http://schemas.microsoft.com/office/drawing/2014/main" id="{8F309213-6C42-4803-92F1-1BFA0AD220E1}"/>
               </a:ext>
             </a:extLst>
           </p:cNvPr>
@@ -5951,7 +5951,7 @@
           <p:cNvPr id="28" name="">
             <a:extLst xmlns:a="http://schemas.openxmlformats.org/drawingml/2006/main">
               <a:ext uri="{FF2B5EF4-FFF2-40B4-BE49-F238E27FC236}">
-                <a16:creationId xmlns:a16="http://schemas.microsoft.com/office/drawing/2014/main" id="{A0522E0B-0140-4343-8CC3-A6CE70F1AB29}"/>
+                <a16:creationId xmlns:a16="http://schemas.microsoft.com/office/drawing/2014/main" id="{FA4CC54F-BAB7-4978-98F9-079E0C8F1481}"/>
               </a:ext>
             </a:extLst>
           </p:cNvPr>
@@ -6015,7 +6015,7 @@
           <p:cNvPr id="29" name="">
             <a:extLst xmlns:a="http://schemas.openxmlformats.org/drawingml/2006/main">
               <a:ext uri="{FF2B5EF4-FFF2-40B4-BE49-F238E27FC236}">
-                <a16:creationId xmlns:a16="http://schemas.microsoft.com/office/drawing/2014/main" id="{8A01D84A-94B3-43C0-BBF4-B8925530D3D7}"/>
+                <a16:creationId xmlns:a16="http://schemas.microsoft.com/office/drawing/2014/main" id="{0FABE245-A5C7-48D3-B77E-D18CE2AB9B22}"/>
               </a:ext>
             </a:extLst>
           </p:cNvPr>
@@ -6048,7 +6048,7 @@
           <p:cNvPr id="30" name="">
             <a:extLst xmlns:a="http://schemas.openxmlformats.org/drawingml/2006/main">
               <a:ext uri="{FF2B5EF4-FFF2-40B4-BE49-F238E27FC236}">
-                <a16:creationId xmlns:a16="http://schemas.microsoft.com/office/drawing/2014/main" id="{27D265D9-10B5-4690-81E0-2D4863780D8C}"/>
+                <a16:creationId xmlns:a16="http://schemas.microsoft.com/office/drawing/2014/main" id="{8C221F60-D32E-4257-8299-C6E231047808}"/>
               </a:ext>
             </a:extLst>
           </p:cNvPr>
@@ -6112,7 +6112,7 @@
           <p:cNvPr id="31" name="">
             <a:extLst xmlns:a="http://schemas.openxmlformats.org/drawingml/2006/main">
               <a:ext uri="{FF2B5EF4-FFF2-40B4-BE49-F238E27FC236}">
-                <a16:creationId xmlns:a16="http://schemas.microsoft.com/office/drawing/2014/main" id="{88BCE1B9-3F8E-4E03-8E2D-EE761DBD2854}"/>
+                <a16:creationId xmlns:a16="http://schemas.microsoft.com/office/drawing/2014/main" id="{6CBF59B5-0536-44A2-B207-6FDFA83453E9}"/>
               </a:ext>
             </a:extLst>
           </p:cNvPr>
@@ -6145,7 +6145,7 @@
           <p:cNvPr id="32" name="">
             <a:extLst xmlns:a="http://schemas.openxmlformats.org/drawingml/2006/main">
               <a:ext uri="{FF2B5EF4-FFF2-40B4-BE49-F238E27FC236}">
-                <a16:creationId xmlns:a16="http://schemas.microsoft.com/office/drawing/2014/main" id="{51CA45C9-6249-49B3-B2B8-EC27D943979B}"/>
+                <a16:creationId xmlns:a16="http://schemas.microsoft.com/office/drawing/2014/main" id="{408D738A-B2BB-4E31-A2A5-C7E92CB69EFD}"/>
               </a:ext>
             </a:extLst>
           </p:cNvPr>
@@ -6209,7 +6209,7 @@
           <p:cNvPr id="33" name="">
             <a:extLst xmlns:a="http://schemas.openxmlformats.org/drawingml/2006/main">
               <a:ext uri="{FF2B5EF4-FFF2-40B4-BE49-F238E27FC236}">
-                <a16:creationId xmlns:a16="http://schemas.microsoft.com/office/drawing/2014/main" id="{A7F398D0-F558-41F1-AFCC-1E6EB39B8BB5}"/>
+                <a16:creationId xmlns:a16="http://schemas.microsoft.com/office/drawing/2014/main" id="{09599A8B-FBA4-40E9-9B7E-9E26823E7B10}"/>
               </a:ext>
             </a:extLst>
           </p:cNvPr>
@@ -6242,7 +6242,7 @@
           <p:cNvPr id="34" name="">
             <a:extLst xmlns:a="http://schemas.openxmlformats.org/drawingml/2006/main">
               <a:ext uri="{FF2B5EF4-FFF2-40B4-BE49-F238E27FC236}">
-                <a16:creationId xmlns:a16="http://schemas.microsoft.com/office/drawing/2014/main" id="{5E55DE43-9AC3-44F6-894C-96A71F4E22E9}"/>
+                <a16:creationId xmlns:a16="http://schemas.microsoft.com/office/drawing/2014/main" id="{F4F16A19-4839-42E2-B514-5FF4532DE9E0}"/>
               </a:ext>
             </a:extLst>
           </p:cNvPr>
@@ -6306,7 +6306,7 @@
           <p:cNvPr id="35" name="">
             <a:extLst xmlns:a="http://schemas.openxmlformats.org/drawingml/2006/main">
               <a:ext uri="{FF2B5EF4-FFF2-40B4-BE49-F238E27FC236}">
-                <a16:creationId xmlns:a16="http://schemas.microsoft.com/office/drawing/2014/main" id="{CCD027FE-9ED7-4FA5-8885-B7553316F015}"/>
+                <a16:creationId xmlns:a16="http://schemas.microsoft.com/office/drawing/2014/main" id="{D9BBA9CE-E589-4409-8AEA-930A0C660933}"/>
               </a:ext>
             </a:extLst>
           </p:cNvPr>
@@ -6339,7 +6339,7 @@
           <p:cNvPr id="36" name="">
             <a:extLst xmlns:a="http://schemas.openxmlformats.org/drawingml/2006/main">
               <a:ext uri="{FF2B5EF4-FFF2-40B4-BE49-F238E27FC236}">
-                <a16:creationId xmlns:a16="http://schemas.microsoft.com/office/drawing/2014/main" id="{3851E88C-A8AF-484E-93C9-5AA1449EFF53}"/>
+                <a16:creationId xmlns:a16="http://schemas.microsoft.com/office/drawing/2014/main" id="{55F86CA2-8E84-4C2D-AAB0-8AA1A800A39D}"/>
               </a:ext>
             </a:extLst>
           </p:cNvPr>
@@ -6403,7 +6403,7 @@
           <p:cNvPr id="37" name="">
             <a:extLst xmlns:a="http://schemas.openxmlformats.org/drawingml/2006/main">
               <a:ext uri="{FF2B5EF4-FFF2-40B4-BE49-F238E27FC236}">
-                <a16:creationId xmlns:a16="http://schemas.microsoft.com/office/drawing/2014/main" id="{A9EB4A2E-93F5-45C3-8373-3867129D119C}"/>
+                <a16:creationId xmlns:a16="http://schemas.microsoft.com/office/drawing/2014/main" id="{5B33E419-799E-4526-BA7B-172A0066E958}"/>
               </a:ext>
             </a:extLst>
           </p:cNvPr>
@@ -6467,7 +6467,7 @@
           <p:cNvPr id="38" name="">
             <a:extLst xmlns:a="http://schemas.openxmlformats.org/drawingml/2006/main">
               <a:ext uri="{FF2B5EF4-FFF2-40B4-BE49-F238E27FC236}">
-                <a16:creationId xmlns:a16="http://schemas.microsoft.com/office/drawing/2014/main" id="{E7DF2454-623C-46D7-B0CF-6D42B9E75946}"/>
+                <a16:creationId xmlns:a16="http://schemas.microsoft.com/office/drawing/2014/main" id="{892FBEAA-9682-4985-9866-C8CA15F59496}"/>
               </a:ext>
             </a:extLst>
           </p:cNvPr>
@@ -6529,7 +6529,7 @@
     </p:spTree>
     <p:extLst>
       <p:ext uri="{BB962C8B-B14F-4D97-AF65-F5344CB8AC3E}">
-        <p14:creationId xmlns:p14="http://schemas.microsoft.com/office/powerpoint/2010/main" val="754824146"/>
+        <p14:creationId xmlns:p14="http://schemas.microsoft.com/office/powerpoint/2010/main" val="754411089"/>
       </p:ext>
     </p:extLst>
   </p:cSld>
@@ -6553,7 +6553,7 @@
           <p:cNvPr id="1" name="">
             <a:extLst xmlns:a="http://schemas.openxmlformats.org/drawingml/2006/main">
               <a:ext uri="{FF2B5EF4-FFF2-40B4-BE49-F238E27FC236}">
-                <a16:creationId xmlns:a16="http://schemas.microsoft.com/office/drawing/2014/main" id="{790FC6F1-A09E-4083-886E-9DD39ECE4225}"/>
+                <a16:creationId xmlns:a16="http://schemas.microsoft.com/office/drawing/2014/main" id="{F665CDD5-4787-45D3-ABA9-219BCDDD0FBC}"/>
               </a:ext>
             </a:extLst>
           </p:cNvPr>
@@ -6586,7 +6586,7 @@
           <p:cNvPr id="2" name="">
             <a:extLst xmlns:a="http://schemas.openxmlformats.org/drawingml/2006/main">
               <a:ext uri="{FF2B5EF4-FFF2-40B4-BE49-F238E27FC236}">
-                <a16:creationId xmlns:a16="http://schemas.microsoft.com/office/drawing/2014/main" id="{2D456F0A-1146-4618-B3FB-6742F25720FB}"/>
+                <a16:creationId xmlns:a16="http://schemas.microsoft.com/office/drawing/2014/main" id="{0CAD6F05-E88E-4808-8207-A9A3DE3860E8}"/>
               </a:ext>
             </a:extLst>
           </p:cNvPr>
@@ -6619,7 +6619,7 @@
           <p:cNvPr id="3" name="">
             <a:extLst xmlns:a="http://schemas.openxmlformats.org/drawingml/2006/main">
               <a:ext uri="{FF2B5EF4-FFF2-40B4-BE49-F238E27FC236}">
-                <a16:creationId xmlns:a16="http://schemas.microsoft.com/office/drawing/2014/main" id="{D4E0AA53-4782-4F61-8F6C-626862D8F380}"/>
+                <a16:creationId xmlns:a16="http://schemas.microsoft.com/office/drawing/2014/main" id="{150E2792-0B57-4D21-B35C-BBE7B073E09D}"/>
               </a:ext>
             </a:extLst>
           </p:cNvPr>
@@ -6683,7 +6683,7 @@
           <p:cNvPr id="4" name="">
             <a:extLst xmlns:a="http://schemas.openxmlformats.org/drawingml/2006/main">
               <a:ext uri="{FF2B5EF4-FFF2-40B4-BE49-F238E27FC236}">
-                <a16:creationId xmlns:a16="http://schemas.microsoft.com/office/drawing/2014/main" id="{341CC1FD-194E-4073-BDEA-1FD569D5D01E}"/>
+                <a16:creationId xmlns:a16="http://schemas.microsoft.com/office/drawing/2014/main" id="{AB1F06B6-E155-4A9E-9CB2-0D908251E3F4}"/>
               </a:ext>
             </a:extLst>
           </p:cNvPr>
@@ -6747,7 +6747,7 @@
           <p:cNvPr id="5" name="">
             <a:extLst xmlns:a="http://schemas.openxmlformats.org/drawingml/2006/main">
               <a:ext uri="{FF2B5EF4-FFF2-40B4-BE49-F238E27FC236}">
-                <a16:creationId xmlns:a16="http://schemas.microsoft.com/office/drawing/2014/main" id="{519E745E-C080-46AD-AFAD-F39F7F77239C}"/>
+                <a16:creationId xmlns:a16="http://schemas.microsoft.com/office/drawing/2014/main" id="{A5B2B9DF-AD47-48CC-A2A7-B1A27A037638}"/>
               </a:ext>
             </a:extLst>
           </p:cNvPr>
@@ -6780,7 +6780,7 @@
           <p:cNvPr id="6" name="">
             <a:extLst xmlns:a="http://schemas.openxmlformats.org/drawingml/2006/main">
               <a:ext uri="{FF2B5EF4-FFF2-40B4-BE49-F238E27FC236}">
-                <a16:creationId xmlns:a16="http://schemas.microsoft.com/office/drawing/2014/main" id="{6D5A5FCF-A55E-49D8-9B02-046F21051F8A}"/>
+                <a16:creationId xmlns:a16="http://schemas.microsoft.com/office/drawing/2014/main" id="{80C85EDB-25E4-46EC-87CF-9E6ACBF601A9}"/>
               </a:ext>
             </a:extLst>
           </p:cNvPr>
@@ -6813,7 +6813,7 @@
           <p:cNvPr id="7" name="">
             <a:extLst xmlns:a="http://schemas.openxmlformats.org/drawingml/2006/main">
               <a:ext uri="{FF2B5EF4-FFF2-40B4-BE49-F238E27FC236}">
-                <a16:creationId xmlns:a16="http://schemas.microsoft.com/office/drawing/2014/main" id="{AC04F4B2-0775-417D-A4EF-EBE8465FA66A}"/>
+                <a16:creationId xmlns:a16="http://schemas.microsoft.com/office/drawing/2014/main" id="{85E681C7-E47A-431F-8E80-E5D502BC3122}"/>
               </a:ext>
             </a:extLst>
           </p:cNvPr>
@@ -6877,7 +6877,7 @@
           <p:cNvPr id="8" name="">
             <a:extLst xmlns:a="http://schemas.openxmlformats.org/drawingml/2006/main">
               <a:ext uri="{FF2B5EF4-FFF2-40B4-BE49-F238E27FC236}">
-                <a16:creationId xmlns:a16="http://schemas.microsoft.com/office/drawing/2014/main" id="{B4D34447-6DB4-4EA1-A289-5FD5A3CCD0C9}"/>
+                <a16:creationId xmlns:a16="http://schemas.microsoft.com/office/drawing/2014/main" id="{40D5961B-3641-4477-A017-A730B750CFD3}"/>
               </a:ext>
             </a:extLst>
           </p:cNvPr>
@@ -6910,7 +6910,7 @@
           <p:cNvPr id="9" name="">
             <a:extLst xmlns:a="http://schemas.openxmlformats.org/drawingml/2006/main">
               <a:ext uri="{FF2B5EF4-FFF2-40B4-BE49-F238E27FC236}">
-                <a16:creationId xmlns:a16="http://schemas.microsoft.com/office/drawing/2014/main" id="{2CA03716-55BC-447F-B5DA-67F94B32BE6C}"/>
+                <a16:creationId xmlns:a16="http://schemas.microsoft.com/office/drawing/2014/main" id="{BC5E49D9-86CA-4ABE-AEAF-4EB741F29808}"/>
               </a:ext>
             </a:extLst>
           </p:cNvPr>
@@ -6974,7 +6974,7 @@
           <p:cNvPr id="10" name="">
             <a:extLst xmlns:a="http://schemas.openxmlformats.org/drawingml/2006/main">
               <a:ext uri="{FF2B5EF4-FFF2-40B4-BE49-F238E27FC236}">
-                <a16:creationId xmlns:a16="http://schemas.microsoft.com/office/drawing/2014/main" id="{1F0CE0D0-60EA-44C4-A217-24F396CC3FC0}"/>
+                <a16:creationId xmlns:a16="http://schemas.microsoft.com/office/drawing/2014/main" id="{F915DC35-6B58-4A51-B054-7354CFF7D394}"/>
               </a:ext>
             </a:extLst>
           </p:cNvPr>
@@ -7007,7 +7007,7 @@
           <p:cNvPr id="11" name="">
             <a:extLst xmlns:a="http://schemas.openxmlformats.org/drawingml/2006/main">
               <a:ext uri="{FF2B5EF4-FFF2-40B4-BE49-F238E27FC236}">
-                <a16:creationId xmlns:a16="http://schemas.microsoft.com/office/drawing/2014/main" id="{11D5AC6B-435F-4415-B537-0C86701E4BE9}"/>
+                <a16:creationId xmlns:a16="http://schemas.microsoft.com/office/drawing/2014/main" id="{C191BA48-8C33-44B7-B6D8-E03651528581}"/>
               </a:ext>
             </a:extLst>
           </p:cNvPr>
@@ -7071,7 +7071,7 @@
           <p:cNvPr id="12" name="">
             <a:extLst xmlns:a="http://schemas.openxmlformats.org/drawingml/2006/main">
               <a:ext uri="{FF2B5EF4-FFF2-40B4-BE49-F238E27FC236}">
-                <a16:creationId xmlns:a16="http://schemas.microsoft.com/office/drawing/2014/main" id="{5EF758A3-A4F3-48AF-982F-51422215DFDE}"/>
+                <a16:creationId xmlns:a16="http://schemas.microsoft.com/office/drawing/2014/main" id="{B6B79F7D-B1E8-4CD1-85DF-F3189A7C7877}"/>
               </a:ext>
             </a:extLst>
           </p:cNvPr>
@@ -7104,7 +7104,7 @@
           <p:cNvPr id="13" name="">
             <a:extLst xmlns:a="http://schemas.openxmlformats.org/drawingml/2006/main">
               <a:ext uri="{FF2B5EF4-FFF2-40B4-BE49-F238E27FC236}">
-                <a16:creationId xmlns:a16="http://schemas.microsoft.com/office/drawing/2014/main" id="{D370BD0B-15EF-43C4-AE03-52CEA359B4BB}"/>
+                <a16:creationId xmlns:a16="http://schemas.microsoft.com/office/drawing/2014/main" id="{9F660F0A-E3F5-440E-8135-6716B762E890}"/>
               </a:ext>
             </a:extLst>
           </p:cNvPr>
@@ -7168,7 +7168,7 @@
           <p:cNvPr id="14" name="">
             <a:extLst xmlns:a="http://schemas.openxmlformats.org/drawingml/2006/main">
               <a:ext uri="{FF2B5EF4-FFF2-40B4-BE49-F238E27FC236}">
-                <a16:creationId xmlns:a16="http://schemas.microsoft.com/office/drawing/2014/main" id="{5B8CCEAE-23F5-4531-89B9-F4AA3CBCEA1F}"/>
+                <a16:creationId xmlns:a16="http://schemas.microsoft.com/office/drawing/2014/main" id="{89D57043-7D32-4BAF-9142-B3F900F1B767}"/>
               </a:ext>
             </a:extLst>
           </p:cNvPr>
@@ -7201,7 +7201,7 @@
           <p:cNvPr id="15" name="">
             <a:extLst xmlns:a="http://schemas.openxmlformats.org/drawingml/2006/main">
               <a:ext uri="{FF2B5EF4-FFF2-40B4-BE49-F238E27FC236}">
-                <a16:creationId xmlns:a16="http://schemas.microsoft.com/office/drawing/2014/main" id="{87C028EA-08F1-4E9B-B156-0C68A5ED9DF4}"/>
+                <a16:creationId xmlns:a16="http://schemas.microsoft.com/office/drawing/2014/main" id="{F2CD5F24-FB2E-4FB1-9702-0997435DDBCA}"/>
               </a:ext>
             </a:extLst>
           </p:cNvPr>
@@ -7265,7 +7265,7 @@
           <p:cNvPr id="16" name="">
             <a:extLst xmlns:a="http://schemas.openxmlformats.org/drawingml/2006/main">
               <a:ext uri="{FF2B5EF4-FFF2-40B4-BE49-F238E27FC236}">
-                <a16:creationId xmlns:a16="http://schemas.microsoft.com/office/drawing/2014/main" id="{FBDB9E57-6170-4084-AA8D-5AAAA92B898D}"/>
+                <a16:creationId xmlns:a16="http://schemas.microsoft.com/office/drawing/2014/main" id="{D61FD50F-A273-4296-A0D6-F64D70B70747}"/>
               </a:ext>
             </a:extLst>
           </p:cNvPr>
@@ -7298,7 +7298,7 @@
           <p:cNvPr id="17" name="">
             <a:extLst xmlns:a="http://schemas.openxmlformats.org/drawingml/2006/main">
               <a:ext uri="{FF2B5EF4-FFF2-40B4-BE49-F238E27FC236}">
-                <a16:creationId xmlns:a16="http://schemas.microsoft.com/office/drawing/2014/main" id="{FD8A8051-86FE-43DF-94C1-2F76E868E6A7}"/>
+                <a16:creationId xmlns:a16="http://schemas.microsoft.com/office/drawing/2014/main" id="{232D24DD-C621-40F1-BC22-ADE7833CA01F}"/>
               </a:ext>
             </a:extLst>
           </p:cNvPr>
@@ -7362,7 +7362,7 @@
           <p:cNvPr id="18" name="">
             <a:extLst xmlns:a="http://schemas.openxmlformats.org/drawingml/2006/main">
               <a:ext uri="{FF2B5EF4-FFF2-40B4-BE49-F238E27FC236}">
-                <a16:creationId xmlns:a16="http://schemas.microsoft.com/office/drawing/2014/main" id="{F53443E3-B9E9-4135-BF37-A062826930E9}"/>
+                <a16:creationId xmlns:a16="http://schemas.microsoft.com/office/drawing/2014/main" id="{E4B34003-461A-4C8D-B84C-01DCAF60D5F8}"/>
               </a:ext>
             </a:extLst>
           </p:cNvPr>
@@ -7395,7 +7395,7 @@
           <p:cNvPr id="19" name="">
             <a:extLst xmlns:a="http://schemas.openxmlformats.org/drawingml/2006/main">
               <a:ext uri="{FF2B5EF4-FFF2-40B4-BE49-F238E27FC236}">
-                <a16:creationId xmlns:a16="http://schemas.microsoft.com/office/drawing/2014/main" id="{D75E2A02-DE2E-40A7-B4D7-7AF507F8E503}"/>
+                <a16:creationId xmlns:a16="http://schemas.microsoft.com/office/drawing/2014/main" id="{A1359A7A-3B02-4F47-8F80-91C3C15A689D}"/>
               </a:ext>
             </a:extLst>
           </p:cNvPr>
@@ -7459,7 +7459,7 @@
           <p:cNvPr id="20" name="">
             <a:extLst xmlns:a="http://schemas.openxmlformats.org/drawingml/2006/main">
               <a:ext uri="{FF2B5EF4-FFF2-40B4-BE49-F238E27FC236}">
-                <a16:creationId xmlns:a16="http://schemas.microsoft.com/office/drawing/2014/main" id="{04005EA7-8FD4-4581-BCB8-8788AFB75285}"/>
+                <a16:creationId xmlns:a16="http://schemas.microsoft.com/office/drawing/2014/main" id="{76362FB5-548E-4551-8DB2-062E28DBFC3A}"/>
               </a:ext>
             </a:extLst>
           </p:cNvPr>
@@ -7492,7 +7492,7 @@
           <p:cNvPr id="21" name="">
             <a:extLst xmlns:a="http://schemas.openxmlformats.org/drawingml/2006/main">
               <a:ext uri="{FF2B5EF4-FFF2-40B4-BE49-F238E27FC236}">
-                <a16:creationId xmlns:a16="http://schemas.microsoft.com/office/drawing/2014/main" id="{8E7B6EB0-7942-4011-BCDB-255CF640CE77}"/>
+                <a16:creationId xmlns:a16="http://schemas.microsoft.com/office/drawing/2014/main" id="{D303F4CA-1507-42A6-879B-31804EF78AAE}"/>
               </a:ext>
             </a:extLst>
           </p:cNvPr>
@@ -7556,7 +7556,7 @@
           <p:cNvPr id="22" name="">
             <a:extLst xmlns:a="http://schemas.openxmlformats.org/drawingml/2006/main">
               <a:ext uri="{FF2B5EF4-FFF2-40B4-BE49-F238E27FC236}">
-                <a16:creationId xmlns:a16="http://schemas.microsoft.com/office/drawing/2014/main" id="{27C2E790-881F-43A1-A99C-985D4A30203F}"/>
+                <a16:creationId xmlns:a16="http://schemas.microsoft.com/office/drawing/2014/main" id="{88658974-06BF-4C5E-B528-D41524B2BC17}"/>
               </a:ext>
             </a:extLst>
           </p:cNvPr>
@@ -7589,7 +7589,7 @@
           <p:cNvPr id="23" name="">
             <a:extLst xmlns:a="http://schemas.openxmlformats.org/drawingml/2006/main">
               <a:ext uri="{FF2B5EF4-FFF2-40B4-BE49-F238E27FC236}">
-                <a16:creationId xmlns:a16="http://schemas.microsoft.com/office/drawing/2014/main" id="{9A7E1E58-9FB8-4246-B628-18151E35EADA}"/>
+                <a16:creationId xmlns:a16="http://schemas.microsoft.com/office/drawing/2014/main" id="{0652193C-D5DC-4B96-80FD-B856E873C2F6}"/>
               </a:ext>
             </a:extLst>
           </p:cNvPr>
@@ -7653,7 +7653,7 @@
           <p:cNvPr id="24" name="">
             <a:extLst xmlns:a="http://schemas.openxmlformats.org/drawingml/2006/main">
               <a:ext uri="{FF2B5EF4-FFF2-40B4-BE49-F238E27FC236}">
-                <a16:creationId xmlns:a16="http://schemas.microsoft.com/office/drawing/2014/main" id="{27EFA941-DA31-4AD2-9A0E-BB809EB6963E}"/>
+                <a16:creationId xmlns:a16="http://schemas.microsoft.com/office/drawing/2014/main" id="{4762945F-0926-4477-A4A1-39F10239496E}"/>
               </a:ext>
             </a:extLst>
           </p:cNvPr>
@@ -7686,7 +7686,7 @@
           <p:cNvPr id="25" name="">
             <a:extLst xmlns:a="http://schemas.openxmlformats.org/drawingml/2006/main">
               <a:ext uri="{FF2B5EF4-FFF2-40B4-BE49-F238E27FC236}">
-                <a16:creationId xmlns:a16="http://schemas.microsoft.com/office/drawing/2014/main" id="{9B51AA42-932D-43E6-AA1F-749897882282}"/>
+                <a16:creationId xmlns:a16="http://schemas.microsoft.com/office/drawing/2014/main" id="{CC92CD42-3693-410F-BD6C-8FF0FC318A5F}"/>
               </a:ext>
             </a:extLst>
           </p:cNvPr>
@@ -7750,7 +7750,7 @@
           <p:cNvPr id="26" name="">
             <a:extLst xmlns:a="http://schemas.openxmlformats.org/drawingml/2006/main">
               <a:ext uri="{FF2B5EF4-FFF2-40B4-BE49-F238E27FC236}">
-                <a16:creationId xmlns:a16="http://schemas.microsoft.com/office/drawing/2014/main" id="{B86B7F4B-31A6-4531-8B81-F8D4228C4DE1}"/>
+                <a16:creationId xmlns:a16="http://schemas.microsoft.com/office/drawing/2014/main" id="{7210D323-BE65-4ED7-8387-DF2A3573A8CF}"/>
               </a:ext>
             </a:extLst>
           </p:cNvPr>
@@ -7783,7 +7783,7 @@
           <p:cNvPr id="27" name="">
             <a:extLst xmlns:a="http://schemas.openxmlformats.org/drawingml/2006/main">
               <a:ext uri="{FF2B5EF4-FFF2-40B4-BE49-F238E27FC236}">
-                <a16:creationId xmlns:a16="http://schemas.microsoft.com/office/drawing/2014/main" id="{C1180205-65DF-4239-BFA3-744A9479A1C6}"/>
+                <a16:creationId xmlns:a16="http://schemas.microsoft.com/office/drawing/2014/main" id="{4FCB714E-5092-4FA7-BE37-3A847B850BF2}"/>
               </a:ext>
             </a:extLst>
           </p:cNvPr>
@@ -7847,7 +7847,7 @@
           <p:cNvPr id="28" name="">
             <a:extLst xmlns:a="http://schemas.openxmlformats.org/drawingml/2006/main">
               <a:ext uri="{FF2B5EF4-FFF2-40B4-BE49-F238E27FC236}">
-                <a16:creationId xmlns:a16="http://schemas.microsoft.com/office/drawing/2014/main" id="{192B459D-FDF9-47A1-9569-DC2963803210}"/>
+                <a16:creationId xmlns:a16="http://schemas.microsoft.com/office/drawing/2014/main" id="{63910D49-CF18-4767-AAB3-418A6EBD4902}"/>
               </a:ext>
             </a:extLst>
           </p:cNvPr>
@@ -7880,7 +7880,7 @@
           <p:cNvPr id="29" name="">
             <a:extLst xmlns:a="http://schemas.openxmlformats.org/drawingml/2006/main">
               <a:ext uri="{FF2B5EF4-FFF2-40B4-BE49-F238E27FC236}">
-                <a16:creationId xmlns:a16="http://schemas.microsoft.com/office/drawing/2014/main" id="{85AEC1B4-065A-4749-9DBC-EFA76A114A19}"/>
+                <a16:creationId xmlns:a16="http://schemas.microsoft.com/office/drawing/2014/main" id="{8AB23E36-8C7C-4106-9B78-1E9B9B17A0AD}"/>
               </a:ext>
             </a:extLst>
           </p:cNvPr>
@@ -7944,7 +7944,7 @@
           <p:cNvPr id="30" name="">
             <a:extLst xmlns:a="http://schemas.openxmlformats.org/drawingml/2006/main">
               <a:ext uri="{FF2B5EF4-FFF2-40B4-BE49-F238E27FC236}">
-                <a16:creationId xmlns:a16="http://schemas.microsoft.com/office/drawing/2014/main" id="{CAFC77C2-F294-4C9A-8ED3-04833E0E041C}"/>
+                <a16:creationId xmlns:a16="http://schemas.microsoft.com/office/drawing/2014/main" id="{EF63692F-7A4E-4AFE-A739-52311FEAD454}"/>
               </a:ext>
             </a:extLst>
           </p:cNvPr>
@@ -7977,7 +7977,7 @@
           <p:cNvPr id="31" name="">
             <a:extLst xmlns:a="http://schemas.openxmlformats.org/drawingml/2006/main">
               <a:ext uri="{FF2B5EF4-FFF2-40B4-BE49-F238E27FC236}">
-                <a16:creationId xmlns:a16="http://schemas.microsoft.com/office/drawing/2014/main" id="{22A221BC-DA58-45FE-AD21-933FFDA67EE7}"/>
+                <a16:creationId xmlns:a16="http://schemas.microsoft.com/office/drawing/2014/main" id="{2F9488AA-55D7-4D27-BF07-17A9DAE96B3D}"/>
               </a:ext>
             </a:extLst>
           </p:cNvPr>
@@ -8041,7 +8041,7 @@
           <p:cNvPr id="32" name="">
             <a:extLst xmlns:a="http://schemas.openxmlformats.org/drawingml/2006/main">
               <a:ext uri="{FF2B5EF4-FFF2-40B4-BE49-F238E27FC236}">
-                <a16:creationId xmlns:a16="http://schemas.microsoft.com/office/drawing/2014/main" id="{6FB86340-CA81-474D-8FBB-61C396EEDE77}"/>
+                <a16:creationId xmlns:a16="http://schemas.microsoft.com/office/drawing/2014/main" id="{E6686318-F6D0-4391-BAFD-255BE56B75EF}"/>
               </a:ext>
             </a:extLst>
           </p:cNvPr>
@@ -8074,7 +8074,7 @@
           <p:cNvPr id="33" name="">
             <a:extLst xmlns:a="http://schemas.openxmlformats.org/drawingml/2006/main">
               <a:ext uri="{FF2B5EF4-FFF2-40B4-BE49-F238E27FC236}">
-                <a16:creationId xmlns:a16="http://schemas.microsoft.com/office/drawing/2014/main" id="{8E77FA83-F8D2-4F93-9B02-521534392472}"/>
+                <a16:creationId xmlns:a16="http://schemas.microsoft.com/office/drawing/2014/main" id="{209061D5-DC6D-4BC1-AA13-25C44705E296}"/>
               </a:ext>
             </a:extLst>
           </p:cNvPr>
@@ -8138,7 +8138,7 @@
           <p:cNvPr id="34" name="">
             <a:extLst xmlns:a="http://schemas.openxmlformats.org/drawingml/2006/main">
               <a:ext uri="{FF2B5EF4-FFF2-40B4-BE49-F238E27FC236}">
-                <a16:creationId xmlns:a16="http://schemas.microsoft.com/office/drawing/2014/main" id="{DCA9449F-9C20-4946-B911-896F08A95C35}"/>
+                <a16:creationId xmlns:a16="http://schemas.microsoft.com/office/drawing/2014/main" id="{45BAB7E1-C63B-4BEE-B43C-77D7D775AA68}"/>
               </a:ext>
             </a:extLst>
           </p:cNvPr>
@@ -8171,7 +8171,7 @@
           <p:cNvPr id="35" name="">
             <a:extLst xmlns:a="http://schemas.openxmlformats.org/drawingml/2006/main">
               <a:ext uri="{FF2B5EF4-FFF2-40B4-BE49-F238E27FC236}">
-                <a16:creationId xmlns:a16="http://schemas.microsoft.com/office/drawing/2014/main" id="{B55D8A32-B661-4FAA-BB59-7749817B8FE7}"/>
+                <a16:creationId xmlns:a16="http://schemas.microsoft.com/office/drawing/2014/main" id="{A14996EF-CE5E-41A9-9BB4-D491465CF96E}"/>
               </a:ext>
             </a:extLst>
           </p:cNvPr>
@@ -8235,7 +8235,7 @@
           <p:cNvPr id="36" name="">
             <a:extLst xmlns:a="http://schemas.openxmlformats.org/drawingml/2006/main">
               <a:ext uri="{FF2B5EF4-FFF2-40B4-BE49-F238E27FC236}">
-                <a16:creationId xmlns:a16="http://schemas.microsoft.com/office/drawing/2014/main" id="{F28D54F1-2F9A-48AE-9964-0529CE1ECDB7}"/>
+                <a16:creationId xmlns:a16="http://schemas.microsoft.com/office/drawing/2014/main" id="{1DCBE90F-67E0-40B5-A55C-262C3EABADF5}"/>
               </a:ext>
             </a:extLst>
           </p:cNvPr>
@@ -8268,7 +8268,7 @@
           <p:cNvPr id="37" name="">
             <a:extLst xmlns:a="http://schemas.openxmlformats.org/drawingml/2006/main">
               <a:ext uri="{FF2B5EF4-FFF2-40B4-BE49-F238E27FC236}">
-                <a16:creationId xmlns:a16="http://schemas.microsoft.com/office/drawing/2014/main" id="{AD776B36-0DBF-4545-86FA-9FBA349DF22B}"/>
+                <a16:creationId xmlns:a16="http://schemas.microsoft.com/office/drawing/2014/main" id="{A9AECA82-EF3D-4D57-B5BE-B86F682B2ACE}"/>
               </a:ext>
             </a:extLst>
           </p:cNvPr>
@@ -8332,7 +8332,7 @@
           <p:cNvPr id="38" name="">
             <a:extLst xmlns:a="http://schemas.openxmlformats.org/drawingml/2006/main">
               <a:ext uri="{FF2B5EF4-FFF2-40B4-BE49-F238E27FC236}">
-                <a16:creationId xmlns:a16="http://schemas.microsoft.com/office/drawing/2014/main" id="{25347B2C-46B7-46C1-ABCF-10490EB75B8F}"/>
+                <a16:creationId xmlns:a16="http://schemas.microsoft.com/office/drawing/2014/main" id="{0C36BD44-B93F-43B3-ADE5-0B295F6C23F8}"/>
               </a:ext>
             </a:extLst>
           </p:cNvPr>
@@ -8365,7 +8365,7 @@
           <p:cNvPr id="39" name="">
             <a:extLst xmlns:a="http://schemas.openxmlformats.org/drawingml/2006/main">
               <a:ext uri="{FF2B5EF4-FFF2-40B4-BE49-F238E27FC236}">
-                <a16:creationId xmlns:a16="http://schemas.microsoft.com/office/drawing/2014/main" id="{39DD8CBA-C623-49CD-9542-20018CFFA3A5}"/>
+                <a16:creationId xmlns:a16="http://schemas.microsoft.com/office/drawing/2014/main" id="{64D9C460-CE6D-42FA-BEC9-27E30526F72B}"/>
               </a:ext>
             </a:extLst>
           </p:cNvPr>
@@ -8429,7 +8429,7 @@
           <p:cNvPr id="40" name="">
             <a:extLst xmlns:a="http://schemas.openxmlformats.org/drawingml/2006/main">
               <a:ext uri="{FF2B5EF4-FFF2-40B4-BE49-F238E27FC236}">
-                <a16:creationId xmlns:a16="http://schemas.microsoft.com/office/drawing/2014/main" id="{D4585788-4F1A-4E1F-AEC3-82F5308B0DFC}"/>
+                <a16:creationId xmlns:a16="http://schemas.microsoft.com/office/drawing/2014/main" id="{492AEB87-8C05-4525-8D9D-6ADC264D5473}"/>
               </a:ext>
             </a:extLst>
           </p:cNvPr>
@@ -8462,7 +8462,7 @@
           <p:cNvPr id="41" name="">
             <a:extLst xmlns:a="http://schemas.openxmlformats.org/drawingml/2006/main">
               <a:ext uri="{FF2B5EF4-FFF2-40B4-BE49-F238E27FC236}">
-                <a16:creationId xmlns:a16="http://schemas.microsoft.com/office/drawing/2014/main" id="{13C05937-5660-4377-88D4-5DE7CE831802}"/>
+                <a16:creationId xmlns:a16="http://schemas.microsoft.com/office/drawing/2014/main" id="{9F885EEE-B85E-44BC-AF8A-0C2385B0BFF7}"/>
               </a:ext>
             </a:extLst>
           </p:cNvPr>
@@ -8526,7 +8526,7 @@
           <p:cNvPr id="42" name="">
             <a:extLst xmlns:a="http://schemas.openxmlformats.org/drawingml/2006/main">
               <a:ext uri="{FF2B5EF4-FFF2-40B4-BE49-F238E27FC236}">
-                <a16:creationId xmlns:a16="http://schemas.microsoft.com/office/drawing/2014/main" id="{3AE13418-C4C0-4583-8A81-D8B01013933C}"/>
+                <a16:creationId xmlns:a16="http://schemas.microsoft.com/office/drawing/2014/main" id="{161ABC69-B8D2-4229-A314-FA7CC522E5C6}"/>
               </a:ext>
             </a:extLst>
           </p:cNvPr>
@@ -8559,7 +8559,7 @@
           <p:cNvPr id="43" name="">
             <a:extLst xmlns:a="http://schemas.openxmlformats.org/drawingml/2006/main">
               <a:ext uri="{FF2B5EF4-FFF2-40B4-BE49-F238E27FC236}">
-                <a16:creationId xmlns:a16="http://schemas.microsoft.com/office/drawing/2014/main" id="{FA8E69CA-6A58-4FAA-B894-969DEE1D0D12}"/>
+                <a16:creationId xmlns:a16="http://schemas.microsoft.com/office/drawing/2014/main" id="{F5995EB5-AE1C-47E1-980E-5519C6226349}"/>
               </a:ext>
             </a:extLst>
           </p:cNvPr>
@@ -8623,7 +8623,7 @@
           <p:cNvPr id="44" name="">
             <a:extLst xmlns:a="http://schemas.openxmlformats.org/drawingml/2006/main">
               <a:ext uri="{FF2B5EF4-FFF2-40B4-BE49-F238E27FC236}">
-                <a16:creationId xmlns:a16="http://schemas.microsoft.com/office/drawing/2014/main" id="{43A2D27E-06FB-4660-B26B-4E7FA4AB203F}"/>
+                <a16:creationId xmlns:a16="http://schemas.microsoft.com/office/drawing/2014/main" id="{29693C5F-2811-4017-8957-DD62FBE297F6}"/>
               </a:ext>
             </a:extLst>
           </p:cNvPr>
@@ -8656,7 +8656,7 @@
           <p:cNvPr id="45" name="">
             <a:extLst xmlns:a="http://schemas.openxmlformats.org/drawingml/2006/main">
               <a:ext uri="{FF2B5EF4-FFF2-40B4-BE49-F238E27FC236}">
-                <a16:creationId xmlns:a16="http://schemas.microsoft.com/office/drawing/2014/main" id="{D70423BE-B12F-4FF6-88F5-25391A17F566}"/>
+                <a16:creationId xmlns:a16="http://schemas.microsoft.com/office/drawing/2014/main" id="{794649F2-A4F3-42FE-86E9-F187C00CB1AB}"/>
               </a:ext>
             </a:extLst>
           </p:cNvPr>
@@ -8720,7 +8720,7 @@
           <p:cNvPr id="46" name="">
             <a:extLst xmlns:a="http://schemas.openxmlformats.org/drawingml/2006/main">
               <a:ext uri="{FF2B5EF4-FFF2-40B4-BE49-F238E27FC236}">
-                <a16:creationId xmlns:a16="http://schemas.microsoft.com/office/drawing/2014/main" id="{330C1326-ED22-48B5-9EF2-BA7F525E6158}"/>
+                <a16:creationId xmlns:a16="http://schemas.microsoft.com/office/drawing/2014/main" id="{44D155E2-0508-4A6D-AA58-34EF7A4B8E87}"/>
               </a:ext>
             </a:extLst>
           </p:cNvPr>
@@ -8753,7 +8753,7 @@
           <p:cNvPr id="47" name="">
             <a:extLst xmlns:a="http://schemas.openxmlformats.org/drawingml/2006/main">
               <a:ext uri="{FF2B5EF4-FFF2-40B4-BE49-F238E27FC236}">
-                <a16:creationId xmlns:a16="http://schemas.microsoft.com/office/drawing/2014/main" id="{938F7E16-69DB-4EE2-9CE3-F089BCDF10D3}"/>
+                <a16:creationId xmlns:a16="http://schemas.microsoft.com/office/drawing/2014/main" id="{1E1CE9E7-3049-4F3B-B3CC-954A61FC0F08}"/>
               </a:ext>
             </a:extLst>
           </p:cNvPr>
@@ -8817,7 +8817,7 @@
           <p:cNvPr id="48" name="">
             <a:extLst xmlns:a="http://schemas.openxmlformats.org/drawingml/2006/main">
               <a:ext uri="{FF2B5EF4-FFF2-40B4-BE49-F238E27FC236}">
-                <a16:creationId xmlns:a16="http://schemas.microsoft.com/office/drawing/2014/main" id="{44D4C749-661F-41CD-A490-87164619F627}"/>
+                <a16:creationId xmlns:a16="http://schemas.microsoft.com/office/drawing/2014/main" id="{F9F89717-572A-4DD4-BE46-963F62F4639D}"/>
               </a:ext>
             </a:extLst>
           </p:cNvPr>
@@ -8881,7 +8881,7 @@
           <p:cNvPr id="49" name="">
             <a:extLst xmlns:a="http://schemas.openxmlformats.org/drawingml/2006/main">
               <a:ext uri="{FF2B5EF4-FFF2-40B4-BE49-F238E27FC236}">
-                <a16:creationId xmlns:a16="http://schemas.microsoft.com/office/drawing/2014/main" id="{39045B8C-8F2A-444C-8A64-D82084F5A121}"/>
+                <a16:creationId xmlns:a16="http://schemas.microsoft.com/office/drawing/2014/main" id="{DDD7848D-A481-422D-9C6D-8126C9A198A0}"/>
               </a:ext>
             </a:extLst>
           </p:cNvPr>
@@ -8943,7 +8943,7 @@
     </p:spTree>
     <p:extLst>
       <p:ext uri="{BB962C8B-B14F-4D97-AF65-F5344CB8AC3E}">
-        <p14:creationId xmlns:p14="http://schemas.microsoft.com/office/powerpoint/2010/main" val="1975940558"/>
+        <p14:creationId xmlns:p14="http://schemas.microsoft.com/office/powerpoint/2010/main" val="1892103292"/>
       </p:ext>
     </p:extLst>
   </p:cSld>
@@ -8967,7 +8967,7 @@
           <p:cNvPr id="1" name="">
             <a:extLst xmlns:a="http://schemas.openxmlformats.org/drawingml/2006/main">
               <a:ext uri="{FF2B5EF4-FFF2-40B4-BE49-F238E27FC236}">
-                <a16:creationId xmlns:a16="http://schemas.microsoft.com/office/drawing/2014/main" id="{D2A4009E-2F46-4737-95BB-780AD64AC3F7}"/>
+                <a16:creationId xmlns:a16="http://schemas.microsoft.com/office/drawing/2014/main" id="{1FD9D1D3-66B4-49D4-BE05-8DE3C46451CA}"/>
               </a:ext>
             </a:extLst>
           </p:cNvPr>
@@ -9000,7 +9000,7 @@
           <p:cNvPr id="2" name="">
             <a:extLst xmlns:a="http://schemas.openxmlformats.org/drawingml/2006/main">
               <a:ext uri="{FF2B5EF4-FFF2-40B4-BE49-F238E27FC236}">
-                <a16:creationId xmlns:a16="http://schemas.microsoft.com/office/drawing/2014/main" id="{2FEFD4D3-ABAA-4B74-AA8F-F3469D24AC57}"/>
+                <a16:creationId xmlns:a16="http://schemas.microsoft.com/office/drawing/2014/main" id="{5F12A10F-79F2-47B2-A5FD-AF618D7E31E8}"/>
               </a:ext>
             </a:extLst>
           </p:cNvPr>
@@ -9033,7 +9033,7 @@
           <p:cNvPr id="3" name="">
             <a:extLst xmlns:a="http://schemas.openxmlformats.org/drawingml/2006/main">
               <a:ext uri="{FF2B5EF4-FFF2-40B4-BE49-F238E27FC236}">
-                <a16:creationId xmlns:a16="http://schemas.microsoft.com/office/drawing/2014/main" id="{FCC21329-D40C-4818-8D86-E5EF860E179D}"/>
+                <a16:creationId xmlns:a16="http://schemas.microsoft.com/office/drawing/2014/main" id="{8A8559DE-A5F4-4BE4-8735-81AEAB488B12}"/>
               </a:ext>
             </a:extLst>
           </p:cNvPr>
@@ -9097,7 +9097,7 @@
           <p:cNvPr id="4" name="">
             <a:extLst xmlns:a="http://schemas.openxmlformats.org/drawingml/2006/main">
               <a:ext uri="{FF2B5EF4-FFF2-40B4-BE49-F238E27FC236}">
-                <a16:creationId xmlns:a16="http://schemas.microsoft.com/office/drawing/2014/main" id="{48DFFAE5-5216-48BA-9583-34B5507FE203}"/>
+                <a16:creationId xmlns:a16="http://schemas.microsoft.com/office/drawing/2014/main" id="{C2F426A1-1799-4762-A223-A9E8AD5D3AB1}"/>
               </a:ext>
             </a:extLst>
           </p:cNvPr>
@@ -9161,7 +9161,7 @@
           <p:cNvPr id="5" name="">
             <a:extLst xmlns:a="http://schemas.openxmlformats.org/drawingml/2006/main">
               <a:ext uri="{FF2B5EF4-FFF2-40B4-BE49-F238E27FC236}">
-                <a16:creationId xmlns:a16="http://schemas.microsoft.com/office/drawing/2014/main" id="{040AF7CA-5CC1-48CD-8947-58B1E3C2C297}"/>
+                <a16:creationId xmlns:a16="http://schemas.microsoft.com/office/drawing/2014/main" id="{F9BB10F5-FD88-43D7-850B-A44BBE7FB861}"/>
               </a:ext>
             </a:extLst>
           </p:cNvPr>
@@ -9194,7 +9194,7 @@
           <p:cNvPr id="6" name="">
             <a:extLst xmlns:a="http://schemas.openxmlformats.org/drawingml/2006/main">
               <a:ext uri="{FF2B5EF4-FFF2-40B4-BE49-F238E27FC236}">
-                <a16:creationId xmlns:a16="http://schemas.microsoft.com/office/drawing/2014/main" id="{2CC0DABE-7F81-43F4-BD6A-51904DB553E5}"/>
+                <a16:creationId xmlns:a16="http://schemas.microsoft.com/office/drawing/2014/main" id="{DFDFF6F7-F7CC-4825-900C-FA4DA29C6315}"/>
               </a:ext>
             </a:extLst>
           </p:cNvPr>
@@ -9227,7 +9227,7 @@
           <p:cNvPr id="7" name="">
             <a:extLst xmlns:a="http://schemas.openxmlformats.org/drawingml/2006/main">
               <a:ext uri="{FF2B5EF4-FFF2-40B4-BE49-F238E27FC236}">
-                <a16:creationId xmlns:a16="http://schemas.microsoft.com/office/drawing/2014/main" id="{ACD5E98B-7CE5-463A-BB48-160D28A495B5}"/>
+                <a16:creationId xmlns:a16="http://schemas.microsoft.com/office/drawing/2014/main" id="{5DB0449A-C592-4EF2-91C7-C5C9545387DF}"/>
               </a:ext>
             </a:extLst>
           </p:cNvPr>
@@ -9291,7 +9291,7 @@
           <p:cNvPr id="8" name="">
             <a:extLst xmlns:a="http://schemas.openxmlformats.org/drawingml/2006/main">
               <a:ext uri="{FF2B5EF4-FFF2-40B4-BE49-F238E27FC236}">
-                <a16:creationId xmlns:a16="http://schemas.microsoft.com/office/drawing/2014/main" id="{B6FF0DA6-93F9-4658-A700-F6CB52AB4B7C}"/>
+                <a16:creationId xmlns:a16="http://schemas.microsoft.com/office/drawing/2014/main" id="{F2D58656-1882-4FBB-AEF6-1AD9A259CC93}"/>
               </a:ext>
             </a:extLst>
           </p:cNvPr>
@@ -9324,7 +9324,7 @@
           <p:cNvPr id="9" name="">
             <a:extLst xmlns:a="http://schemas.openxmlformats.org/drawingml/2006/main">
               <a:ext uri="{FF2B5EF4-FFF2-40B4-BE49-F238E27FC236}">
-                <a16:creationId xmlns:a16="http://schemas.microsoft.com/office/drawing/2014/main" id="{37060996-5609-48F3-A127-407EB5920351}"/>
+                <a16:creationId xmlns:a16="http://schemas.microsoft.com/office/drawing/2014/main" id="{637ABDA2-E6FF-452A-B20F-169CA46293D2}"/>
               </a:ext>
             </a:extLst>
           </p:cNvPr>
@@ -9388,7 +9388,7 @@
           <p:cNvPr id="10" name="">
             <a:extLst xmlns:a="http://schemas.openxmlformats.org/drawingml/2006/main">
               <a:ext uri="{FF2B5EF4-FFF2-40B4-BE49-F238E27FC236}">
-                <a16:creationId xmlns:a16="http://schemas.microsoft.com/office/drawing/2014/main" id="{47C008FC-283B-4EBA-B2EC-A9DEA9D43B42}"/>
+                <a16:creationId xmlns:a16="http://schemas.microsoft.com/office/drawing/2014/main" id="{1A31C888-E784-4201-BAB4-B1F760CF9274}"/>
               </a:ext>
             </a:extLst>
           </p:cNvPr>
@@ -9421,7 +9421,7 @@
           <p:cNvPr id="11" name="">
             <a:extLst xmlns:a="http://schemas.openxmlformats.org/drawingml/2006/main">
               <a:ext uri="{FF2B5EF4-FFF2-40B4-BE49-F238E27FC236}">
-                <a16:creationId xmlns:a16="http://schemas.microsoft.com/office/drawing/2014/main" id="{4FE4775F-7AC5-4763-A3AC-5668062857E3}"/>
+                <a16:creationId xmlns:a16="http://schemas.microsoft.com/office/drawing/2014/main" id="{014EE651-FF11-4751-AD9E-BC2B0518584C}"/>
               </a:ext>
             </a:extLst>
           </p:cNvPr>
@@ -9485,7 +9485,7 @@
           <p:cNvPr id="12" name="">
             <a:extLst xmlns:a="http://schemas.openxmlformats.org/drawingml/2006/main">
               <a:ext uri="{FF2B5EF4-FFF2-40B4-BE49-F238E27FC236}">
-                <a16:creationId xmlns:a16="http://schemas.microsoft.com/office/drawing/2014/main" id="{30EAD31B-3583-43DB-9847-6A6836231B3E}"/>
+                <a16:creationId xmlns:a16="http://schemas.microsoft.com/office/drawing/2014/main" id="{53F6D3C3-D639-4EE9-B3FC-3A7D6B8D670E}"/>
               </a:ext>
             </a:extLst>
           </p:cNvPr>
@@ -9518,7 +9518,7 @@
           <p:cNvPr id="13" name="">
             <a:extLst xmlns:a="http://schemas.openxmlformats.org/drawingml/2006/main">
               <a:ext uri="{FF2B5EF4-FFF2-40B4-BE49-F238E27FC236}">
-                <a16:creationId xmlns:a16="http://schemas.microsoft.com/office/drawing/2014/main" id="{9C72FFA2-4EAB-45AC-BA2C-B9EE50A31C5A}"/>
+                <a16:creationId xmlns:a16="http://schemas.microsoft.com/office/drawing/2014/main" id="{7158C1D0-957B-42D7-BB88-F94925F1EF25}"/>
               </a:ext>
             </a:extLst>
           </p:cNvPr>
@@ -9582,7 +9582,7 @@
           <p:cNvPr id="14" name="">
             <a:extLst xmlns:a="http://schemas.openxmlformats.org/drawingml/2006/main">
               <a:ext uri="{FF2B5EF4-FFF2-40B4-BE49-F238E27FC236}">
-                <a16:creationId xmlns:a16="http://schemas.microsoft.com/office/drawing/2014/main" id="{5225AEDC-7308-42AB-A9F7-64BA7E2AC87F}"/>
+                <a16:creationId xmlns:a16="http://schemas.microsoft.com/office/drawing/2014/main" id="{35F379E6-680C-4A8D-91A4-D60DE21FB5E2}"/>
               </a:ext>
             </a:extLst>
           </p:cNvPr>
@@ -9615,7 +9615,7 @@
           <p:cNvPr id="15" name="">
             <a:extLst xmlns:a="http://schemas.openxmlformats.org/drawingml/2006/main">
               <a:ext uri="{FF2B5EF4-FFF2-40B4-BE49-F238E27FC236}">
-                <a16:creationId xmlns:a16="http://schemas.microsoft.com/office/drawing/2014/main" id="{6BD9BBA0-866B-43BB-9D2C-397A22632CD9}"/>
+                <a16:creationId xmlns:a16="http://schemas.microsoft.com/office/drawing/2014/main" id="{BBABBC88-3D67-47A4-91F2-3DBDA723F0FD}"/>
               </a:ext>
             </a:extLst>
           </p:cNvPr>
@@ -9679,7 +9679,7 @@
           <p:cNvPr id="16" name="">
             <a:extLst xmlns:a="http://schemas.openxmlformats.org/drawingml/2006/main">
               <a:ext uri="{FF2B5EF4-FFF2-40B4-BE49-F238E27FC236}">
-                <a16:creationId xmlns:a16="http://schemas.microsoft.com/office/drawing/2014/main" id="{D2CB5A44-F13B-4EA6-BDE1-D9209BEE2823}"/>
+                <a16:creationId xmlns:a16="http://schemas.microsoft.com/office/drawing/2014/main" id="{C2E9384F-B93F-499F-8B3F-2C511CBAE7DB}"/>
               </a:ext>
             </a:extLst>
           </p:cNvPr>
@@ -9712,7 +9712,7 @@
           <p:cNvPr id="17" name="">
             <a:extLst xmlns:a="http://schemas.openxmlformats.org/drawingml/2006/main">
               <a:ext uri="{FF2B5EF4-FFF2-40B4-BE49-F238E27FC236}">
-                <a16:creationId xmlns:a16="http://schemas.microsoft.com/office/drawing/2014/main" id="{AB1BE085-ECE4-419D-817E-135516F49C18}"/>
+                <a16:creationId xmlns:a16="http://schemas.microsoft.com/office/drawing/2014/main" id="{000B5F39-5C89-4F45-9EF6-19A8C94839E3}"/>
               </a:ext>
             </a:extLst>
           </p:cNvPr>
@@ -9776,7 +9776,7 @@
           <p:cNvPr id="18" name="">
             <a:extLst xmlns:a="http://schemas.openxmlformats.org/drawingml/2006/main">
               <a:ext uri="{FF2B5EF4-FFF2-40B4-BE49-F238E27FC236}">
-                <a16:creationId xmlns:a16="http://schemas.microsoft.com/office/drawing/2014/main" id="{D410B364-D41A-4420-95FA-52E46DAC1453}"/>
+                <a16:creationId xmlns:a16="http://schemas.microsoft.com/office/drawing/2014/main" id="{37AA92A1-8AE9-4265-809E-0D93F1D740F7}"/>
               </a:ext>
             </a:extLst>
           </p:cNvPr>
@@ -9809,7 +9809,7 @@
           <p:cNvPr id="19" name="">
             <a:extLst xmlns:a="http://schemas.openxmlformats.org/drawingml/2006/main">
               <a:ext uri="{FF2B5EF4-FFF2-40B4-BE49-F238E27FC236}">
-                <a16:creationId xmlns:a16="http://schemas.microsoft.com/office/drawing/2014/main" id="{7C1DB5D5-853B-4E2A-B8DA-DB014CB62B22}"/>
+                <a16:creationId xmlns:a16="http://schemas.microsoft.com/office/drawing/2014/main" id="{A8CEC125-F5BC-48B5-94D6-9FC5E304CD19}"/>
               </a:ext>
             </a:extLst>
           </p:cNvPr>
@@ -9873,7 +9873,7 @@
           <p:cNvPr id="20" name="">
             <a:extLst xmlns:a="http://schemas.openxmlformats.org/drawingml/2006/main">
               <a:ext uri="{FF2B5EF4-FFF2-40B4-BE49-F238E27FC236}">
-                <a16:creationId xmlns:a16="http://schemas.microsoft.com/office/drawing/2014/main" id="{63A35F14-5CDD-4EB1-8F79-B8C41F856AB4}"/>
+                <a16:creationId xmlns:a16="http://schemas.microsoft.com/office/drawing/2014/main" id="{9FC7EAAF-A856-47DD-BE13-38D9EA7DA960}"/>
               </a:ext>
             </a:extLst>
           </p:cNvPr>
@@ -9937,7 +9937,7 @@
           <p:cNvPr id="21" name="">
             <a:extLst xmlns:a="http://schemas.openxmlformats.org/drawingml/2006/main">
               <a:ext uri="{FF2B5EF4-FFF2-40B4-BE49-F238E27FC236}">
-                <a16:creationId xmlns:a16="http://schemas.microsoft.com/office/drawing/2014/main" id="{ED1C4CC8-20BD-4C4B-90B1-BA1F1C91A194}"/>
+                <a16:creationId xmlns:a16="http://schemas.microsoft.com/office/drawing/2014/main" id="{DB2844A1-7855-4FFB-9CFE-117359B137BB}"/>
               </a:ext>
             </a:extLst>
           </p:cNvPr>
@@ -9999,7 +9999,7 @@
     </p:spTree>
     <p:extLst>
       <p:ext uri="{BB962C8B-B14F-4D97-AF65-F5344CB8AC3E}">
-        <p14:creationId xmlns:p14="http://schemas.microsoft.com/office/powerpoint/2010/main" val="651784703"/>
+        <p14:creationId xmlns:p14="http://schemas.microsoft.com/office/powerpoint/2010/main" val="210190241"/>
       </p:ext>
     </p:extLst>
   </p:cSld>
@@ -10023,7 +10023,7 @@
           <p:cNvPr id="1" name="">
             <a:extLst xmlns:a="http://schemas.openxmlformats.org/drawingml/2006/main">
               <a:ext uri="{FF2B5EF4-FFF2-40B4-BE49-F238E27FC236}">
-                <a16:creationId xmlns:a16="http://schemas.microsoft.com/office/drawing/2014/main" id="{21B7B47A-E4EF-49DD-B476-5F5188ABC625}"/>
+                <a16:creationId xmlns:a16="http://schemas.microsoft.com/office/drawing/2014/main" id="{406FA99A-24A2-4670-ABB3-B5E69915158D}"/>
               </a:ext>
             </a:extLst>
           </p:cNvPr>
@@ -10056,7 +10056,7 @@
           <p:cNvPr id="2" name="">
             <a:extLst xmlns:a="http://schemas.openxmlformats.org/drawingml/2006/main">
               <a:ext uri="{FF2B5EF4-FFF2-40B4-BE49-F238E27FC236}">
-                <a16:creationId xmlns:a16="http://schemas.microsoft.com/office/drawing/2014/main" id="{E1D878FE-D7CA-408B-80A3-9630E98FC5FF}"/>
+                <a16:creationId xmlns:a16="http://schemas.microsoft.com/office/drawing/2014/main" id="{48506521-5C3B-4730-B7C3-0F3FF965FAF4}"/>
               </a:ext>
             </a:extLst>
           </p:cNvPr>
@@ -10089,7 +10089,7 @@
           <p:cNvPr id="3" name="">
             <a:extLst xmlns:a="http://schemas.openxmlformats.org/drawingml/2006/main">
               <a:ext uri="{FF2B5EF4-FFF2-40B4-BE49-F238E27FC236}">
-                <a16:creationId xmlns:a16="http://schemas.microsoft.com/office/drawing/2014/main" id="{1993EE93-75D2-4B17-8B12-36A5C48B7617}"/>
+                <a16:creationId xmlns:a16="http://schemas.microsoft.com/office/drawing/2014/main" id="{65D69485-3942-40D9-A101-349A69B87950}"/>
               </a:ext>
             </a:extLst>
           </p:cNvPr>
@@ -10153,7 +10153,7 @@
           <p:cNvPr id="4" name="">
             <a:extLst xmlns:a="http://schemas.openxmlformats.org/drawingml/2006/main">
               <a:ext uri="{FF2B5EF4-FFF2-40B4-BE49-F238E27FC236}">
-                <a16:creationId xmlns:a16="http://schemas.microsoft.com/office/drawing/2014/main" id="{991F55AC-7C90-4F4D-94E8-543C119096FD}"/>
+                <a16:creationId xmlns:a16="http://schemas.microsoft.com/office/drawing/2014/main" id="{66F74A16-2180-4A83-AEC5-2CFB17877AF1}"/>
               </a:ext>
             </a:extLst>
           </p:cNvPr>
@@ -10217,7 +10217,7 @@
           <p:cNvPr id="5" name="">
             <a:extLst xmlns:a="http://schemas.openxmlformats.org/drawingml/2006/main">
               <a:ext uri="{FF2B5EF4-FFF2-40B4-BE49-F238E27FC236}">
-                <a16:creationId xmlns:a16="http://schemas.microsoft.com/office/drawing/2014/main" id="{C94E48DD-7CC9-42C1-A9EE-A022A7850134}"/>
+                <a16:creationId xmlns:a16="http://schemas.microsoft.com/office/drawing/2014/main" id="{D79E7EDA-A9D5-478E-A10F-5AFD4BB0A592}"/>
               </a:ext>
             </a:extLst>
           </p:cNvPr>
@@ -10250,7 +10250,7 @@
           <p:cNvPr id="6" name="">
             <a:extLst xmlns:a="http://schemas.openxmlformats.org/drawingml/2006/main">
               <a:ext uri="{FF2B5EF4-FFF2-40B4-BE49-F238E27FC236}">
-                <a16:creationId xmlns:a16="http://schemas.microsoft.com/office/drawing/2014/main" id="{B9180D79-A873-4C76-94B1-4E3200E329EE}"/>
+                <a16:creationId xmlns:a16="http://schemas.microsoft.com/office/drawing/2014/main" id="{B36C8947-AB95-4698-BDD3-BF5FCBAEE3E8}"/>
               </a:ext>
             </a:extLst>
           </p:cNvPr>
@@ -10283,7 +10283,7 @@
           <p:cNvPr id="7" name="">
             <a:extLst xmlns:a="http://schemas.openxmlformats.org/drawingml/2006/main">
               <a:ext uri="{FF2B5EF4-FFF2-40B4-BE49-F238E27FC236}">
-                <a16:creationId xmlns:a16="http://schemas.microsoft.com/office/drawing/2014/main" id="{AEFA1485-01B0-41B7-B537-85E7BFC1D8BB}"/>
+                <a16:creationId xmlns:a16="http://schemas.microsoft.com/office/drawing/2014/main" id="{B14E995B-539C-407D-BEAA-5A155709EE0E}"/>
               </a:ext>
             </a:extLst>
           </p:cNvPr>
@@ -10347,7 +10347,7 @@
           <p:cNvPr id="8" name="">
             <a:extLst xmlns:a="http://schemas.openxmlformats.org/drawingml/2006/main">
               <a:ext uri="{FF2B5EF4-FFF2-40B4-BE49-F238E27FC236}">
-                <a16:creationId xmlns:a16="http://schemas.microsoft.com/office/drawing/2014/main" id="{974C8856-BB34-4660-B684-633AE554199A}"/>
+                <a16:creationId xmlns:a16="http://schemas.microsoft.com/office/drawing/2014/main" id="{5F9A49B0-4A4D-4324-94DB-01B24B6D280D}"/>
               </a:ext>
             </a:extLst>
           </p:cNvPr>
@@ -10380,7 +10380,7 @@
           <p:cNvPr id="9" name="">
             <a:extLst xmlns:a="http://schemas.openxmlformats.org/drawingml/2006/main">
               <a:ext uri="{FF2B5EF4-FFF2-40B4-BE49-F238E27FC236}">
-                <a16:creationId xmlns:a16="http://schemas.microsoft.com/office/drawing/2014/main" id="{B4C1AFCE-D336-4EAF-918E-CB4D3F4ABCC1}"/>
+                <a16:creationId xmlns:a16="http://schemas.microsoft.com/office/drawing/2014/main" id="{06482D20-9D5D-49E8-B8EC-30B11186F2ED}"/>
               </a:ext>
             </a:extLst>
           </p:cNvPr>
@@ -10444,7 +10444,7 @@
           <p:cNvPr id="10" name="">
             <a:extLst xmlns:a="http://schemas.openxmlformats.org/drawingml/2006/main">
               <a:ext uri="{FF2B5EF4-FFF2-40B4-BE49-F238E27FC236}">
-                <a16:creationId xmlns:a16="http://schemas.microsoft.com/office/drawing/2014/main" id="{5AC08879-DE83-44A1-B0D5-91C5603083BE}"/>
+                <a16:creationId xmlns:a16="http://schemas.microsoft.com/office/drawing/2014/main" id="{B136DF6A-6752-48D8-90DD-7AB5E069ED0B}"/>
               </a:ext>
             </a:extLst>
           </p:cNvPr>
@@ -10477,7 +10477,7 @@
           <p:cNvPr id="11" name="">
             <a:extLst xmlns:a="http://schemas.openxmlformats.org/drawingml/2006/main">
               <a:ext uri="{FF2B5EF4-FFF2-40B4-BE49-F238E27FC236}">
-                <a16:creationId xmlns:a16="http://schemas.microsoft.com/office/drawing/2014/main" id="{83C029D0-3D80-4558-A65A-DCD9FD862DC9}"/>
+                <a16:creationId xmlns:a16="http://schemas.microsoft.com/office/drawing/2014/main" id="{B5C5B8D3-EDF3-404B-A79D-24ACB6F840A6}"/>
               </a:ext>
             </a:extLst>
           </p:cNvPr>
@@ -10541,7 +10541,7 @@
           <p:cNvPr id="12" name="">
             <a:extLst xmlns:a="http://schemas.openxmlformats.org/drawingml/2006/main">
               <a:ext uri="{FF2B5EF4-FFF2-40B4-BE49-F238E27FC236}">
-                <a16:creationId xmlns:a16="http://schemas.microsoft.com/office/drawing/2014/main" id="{785CB5C4-2289-4A0D-A71F-6481C6FD3296}"/>
+                <a16:creationId xmlns:a16="http://schemas.microsoft.com/office/drawing/2014/main" id="{058A5A1C-3531-4D27-8132-709826C8E18C}"/>
               </a:ext>
             </a:extLst>
           </p:cNvPr>
@@ -10574,7 +10574,7 @@
           <p:cNvPr id="13" name="">
             <a:extLst xmlns:a="http://schemas.openxmlformats.org/drawingml/2006/main">
               <a:ext uri="{FF2B5EF4-FFF2-40B4-BE49-F238E27FC236}">
-                <a16:creationId xmlns:a16="http://schemas.microsoft.com/office/drawing/2014/main" id="{664DF843-CCC6-4B42-A4DC-CA00D3D65A6A}"/>
+                <a16:creationId xmlns:a16="http://schemas.microsoft.com/office/drawing/2014/main" id="{4F5CA209-DBAC-40FB-B9FD-C04BED0BCC5A}"/>
               </a:ext>
             </a:extLst>
           </p:cNvPr>
@@ -10638,7 +10638,7 @@
           <p:cNvPr id="14" name="">
             <a:extLst xmlns:a="http://schemas.openxmlformats.org/drawingml/2006/main">
               <a:ext uri="{FF2B5EF4-FFF2-40B4-BE49-F238E27FC236}">
-                <a16:creationId xmlns:a16="http://schemas.microsoft.com/office/drawing/2014/main" id="{516FA4D3-7F85-4B72-AF9A-8574EACD3153}"/>
+                <a16:creationId xmlns:a16="http://schemas.microsoft.com/office/drawing/2014/main" id="{78D987BD-E609-4C51-87E0-7534C774F3CA}"/>
               </a:ext>
             </a:extLst>
           </p:cNvPr>
@@ -10671,7 +10671,7 @@
           <p:cNvPr id="15" name="">
             <a:extLst xmlns:a="http://schemas.openxmlformats.org/drawingml/2006/main">
               <a:ext uri="{FF2B5EF4-FFF2-40B4-BE49-F238E27FC236}">
-                <a16:creationId xmlns:a16="http://schemas.microsoft.com/office/drawing/2014/main" id="{15564AE7-3D0D-4528-A6E2-F160D7D071CB}"/>
+                <a16:creationId xmlns:a16="http://schemas.microsoft.com/office/drawing/2014/main" id="{40FCC70C-121B-4907-A8D1-2DB143C1A731}"/>
               </a:ext>
             </a:extLst>
           </p:cNvPr>
@@ -10735,7 +10735,7 @@
           <p:cNvPr id="16" name="">
             <a:extLst xmlns:a="http://schemas.openxmlformats.org/drawingml/2006/main">
               <a:ext uri="{FF2B5EF4-FFF2-40B4-BE49-F238E27FC236}">
-                <a16:creationId xmlns:a16="http://schemas.microsoft.com/office/drawing/2014/main" id="{C9EF1605-7C91-4FF6-BD46-0AC4F2819C15}"/>
+                <a16:creationId xmlns:a16="http://schemas.microsoft.com/office/drawing/2014/main" id="{0D472B95-D297-4690-92F4-AED4C2F014A7}"/>
               </a:ext>
             </a:extLst>
           </p:cNvPr>
@@ -10768,7 +10768,7 @@
           <p:cNvPr id="17" name="">
             <a:extLst xmlns:a="http://schemas.openxmlformats.org/drawingml/2006/main">
               <a:ext uri="{FF2B5EF4-FFF2-40B4-BE49-F238E27FC236}">
-                <a16:creationId xmlns:a16="http://schemas.microsoft.com/office/drawing/2014/main" id="{3D37041A-A161-44FA-95F0-D0F85344C482}"/>
+                <a16:creationId xmlns:a16="http://schemas.microsoft.com/office/drawing/2014/main" id="{126D50D4-27DB-417C-9123-8FC1B3EC07B8}"/>
               </a:ext>
             </a:extLst>
           </p:cNvPr>
@@ -10832,7 +10832,7 @@
           <p:cNvPr id="18" name="">
             <a:extLst xmlns:a="http://schemas.openxmlformats.org/drawingml/2006/main">
               <a:ext uri="{FF2B5EF4-FFF2-40B4-BE49-F238E27FC236}">
-                <a16:creationId xmlns:a16="http://schemas.microsoft.com/office/drawing/2014/main" id="{F6D43B50-010C-4C52-BEB4-4B840178CE12}"/>
+                <a16:creationId xmlns:a16="http://schemas.microsoft.com/office/drawing/2014/main" id="{1A784FDD-F61B-4032-9FD9-F6445597420D}"/>
               </a:ext>
             </a:extLst>
           </p:cNvPr>
@@ -10865,7 +10865,7 @@
           <p:cNvPr id="19" name="">
             <a:extLst xmlns:a="http://schemas.openxmlformats.org/drawingml/2006/main">
               <a:ext uri="{FF2B5EF4-FFF2-40B4-BE49-F238E27FC236}">
-                <a16:creationId xmlns:a16="http://schemas.microsoft.com/office/drawing/2014/main" id="{C22AC959-8638-4D32-8E23-A244F70E249B}"/>
+                <a16:creationId xmlns:a16="http://schemas.microsoft.com/office/drawing/2014/main" id="{81D0465B-FABA-459E-884E-AE4B61AEB58F}"/>
               </a:ext>
             </a:extLst>
           </p:cNvPr>
@@ -10929,7 +10929,7 @@
           <p:cNvPr id="20" name="">
             <a:extLst xmlns:a="http://schemas.openxmlformats.org/drawingml/2006/main">
               <a:ext uri="{FF2B5EF4-FFF2-40B4-BE49-F238E27FC236}">
-                <a16:creationId xmlns:a16="http://schemas.microsoft.com/office/drawing/2014/main" id="{BC35AFBC-7FA6-4E01-B88F-A15DEFAE7336}"/>
+                <a16:creationId xmlns:a16="http://schemas.microsoft.com/office/drawing/2014/main" id="{55517FB7-058D-4714-B165-5F51C0E3EB15}"/>
               </a:ext>
             </a:extLst>
           </p:cNvPr>
@@ -10993,7 +10993,7 @@
           <p:cNvPr id="21" name="">
             <a:extLst xmlns:a="http://schemas.openxmlformats.org/drawingml/2006/main">
               <a:ext uri="{FF2B5EF4-FFF2-40B4-BE49-F238E27FC236}">
-                <a16:creationId xmlns:a16="http://schemas.microsoft.com/office/drawing/2014/main" id="{786DEE4A-6991-4B82-9351-F4C7E1DE0985}"/>
+                <a16:creationId xmlns:a16="http://schemas.microsoft.com/office/drawing/2014/main" id="{0965B285-0A7E-4408-A753-2F5B5024763B}"/>
               </a:ext>
             </a:extLst>
           </p:cNvPr>
@@ -11055,7 +11055,7 @@
     </p:spTree>
     <p:extLst>
       <p:ext uri="{BB962C8B-B14F-4D97-AF65-F5344CB8AC3E}">
-        <p14:creationId xmlns:p14="http://schemas.microsoft.com/office/powerpoint/2010/main" val="1334432824"/>
+        <p14:creationId xmlns:p14="http://schemas.microsoft.com/office/powerpoint/2010/main" val="2100560129"/>
       </p:ext>
     </p:extLst>
   </p:cSld>
@@ -11079,7 +11079,7 @@
           <p:cNvPr id="1" name="">
             <a:extLst xmlns:a="http://schemas.openxmlformats.org/drawingml/2006/main">
               <a:ext uri="{FF2B5EF4-FFF2-40B4-BE49-F238E27FC236}">
-                <a16:creationId xmlns:a16="http://schemas.microsoft.com/office/drawing/2014/main" id="{C8D0C0A6-92AA-42CA-85F7-0172BB5035C6}"/>
+                <a16:creationId xmlns:a16="http://schemas.microsoft.com/office/drawing/2014/main" id="{6D78A3E8-6876-45C5-B09C-15DE7401ACD3}"/>
               </a:ext>
             </a:extLst>
           </p:cNvPr>
@@ -11112,7 +11112,7 @@
           <p:cNvPr id="2" name="">
             <a:extLst xmlns:a="http://schemas.openxmlformats.org/drawingml/2006/main">
               <a:ext uri="{FF2B5EF4-FFF2-40B4-BE49-F238E27FC236}">
-                <a16:creationId xmlns:a16="http://schemas.microsoft.com/office/drawing/2014/main" id="{BE0D4687-31F2-49C6-B66E-A7F108E5E5A9}"/>
+                <a16:creationId xmlns:a16="http://schemas.microsoft.com/office/drawing/2014/main" id="{C7D34EBF-E8D9-4ADE-9DC0-FEF49653453D}"/>
               </a:ext>
             </a:extLst>
           </p:cNvPr>
@@ -11145,7 +11145,7 @@
           <p:cNvPr id="3" name="">
             <a:extLst xmlns:a="http://schemas.openxmlformats.org/drawingml/2006/main">
               <a:ext uri="{FF2B5EF4-FFF2-40B4-BE49-F238E27FC236}">
-                <a16:creationId xmlns:a16="http://schemas.microsoft.com/office/drawing/2014/main" id="{E1376506-CC8E-492D-81F8-BBD5CFF1D571}"/>
+                <a16:creationId xmlns:a16="http://schemas.microsoft.com/office/drawing/2014/main" id="{0E484C97-F763-4180-82C3-67838A0B23FD}"/>
               </a:ext>
             </a:extLst>
           </p:cNvPr>
@@ -11209,7 +11209,7 @@
           <p:cNvPr id="4" name="">
             <a:extLst xmlns:a="http://schemas.openxmlformats.org/drawingml/2006/main">
               <a:ext uri="{FF2B5EF4-FFF2-40B4-BE49-F238E27FC236}">
-                <a16:creationId xmlns:a16="http://schemas.microsoft.com/office/drawing/2014/main" id="{1FF6B315-9A5D-465C-9361-6339A1679365}"/>
+                <a16:creationId xmlns:a16="http://schemas.microsoft.com/office/drawing/2014/main" id="{B10C96F0-66A2-4E97-8CA8-844558B24E41}"/>
               </a:ext>
             </a:extLst>
           </p:cNvPr>
@@ -11273,7 +11273,7 @@
           <p:cNvPr id="5" name="">
             <a:extLst xmlns:a="http://schemas.openxmlformats.org/drawingml/2006/main">
               <a:ext uri="{FF2B5EF4-FFF2-40B4-BE49-F238E27FC236}">
-                <a16:creationId xmlns:a16="http://schemas.microsoft.com/office/drawing/2014/main" id="{25CE8BFB-612F-4D90-B268-72E1CFCEF453}"/>
+                <a16:creationId xmlns:a16="http://schemas.microsoft.com/office/drawing/2014/main" id="{E22912AE-46B4-48EB-BC55-70BB31A41E7E}"/>
               </a:ext>
             </a:extLst>
           </p:cNvPr>
@@ -11306,7 +11306,7 @@
           <p:cNvPr id="6" name="">
             <a:extLst xmlns:a="http://schemas.openxmlformats.org/drawingml/2006/main">
               <a:ext uri="{FF2B5EF4-FFF2-40B4-BE49-F238E27FC236}">
-                <a16:creationId xmlns:a16="http://schemas.microsoft.com/office/drawing/2014/main" id="{E217B38F-72CC-42B6-A36F-EAEF24C2EF19}"/>
+                <a16:creationId xmlns:a16="http://schemas.microsoft.com/office/drawing/2014/main" id="{7E5DA8C3-7753-4F82-B393-1E156D8F0EB1}"/>
               </a:ext>
             </a:extLst>
           </p:cNvPr>
@@ -11339,7 +11339,7 @@
           <p:cNvPr id="7" name="">
             <a:extLst xmlns:a="http://schemas.openxmlformats.org/drawingml/2006/main">
               <a:ext uri="{FF2B5EF4-FFF2-40B4-BE49-F238E27FC236}">
-                <a16:creationId xmlns:a16="http://schemas.microsoft.com/office/drawing/2014/main" id="{E28E521E-EC9E-4C34-9158-32139E91003B}"/>
+                <a16:creationId xmlns:a16="http://schemas.microsoft.com/office/drawing/2014/main" id="{C9D5DC6B-D4E3-4FD6-B59F-228E6D9149EB}"/>
               </a:ext>
             </a:extLst>
           </p:cNvPr>
@@ -11403,7 +11403,7 @@
           <p:cNvPr id="8" name="">
             <a:extLst xmlns:a="http://schemas.openxmlformats.org/drawingml/2006/main">
               <a:ext uri="{FF2B5EF4-FFF2-40B4-BE49-F238E27FC236}">
-                <a16:creationId xmlns:a16="http://schemas.microsoft.com/office/drawing/2014/main" id="{741761A9-1F1F-449B-99BD-06E3B51613D2}"/>
+                <a16:creationId xmlns:a16="http://schemas.microsoft.com/office/drawing/2014/main" id="{7FD52018-A423-4680-A3F9-E8A139A1ACE6}"/>
               </a:ext>
             </a:extLst>
           </p:cNvPr>
@@ -11436,7 +11436,7 @@
           <p:cNvPr id="9" name="">
             <a:extLst xmlns:a="http://schemas.openxmlformats.org/drawingml/2006/main">
               <a:ext uri="{FF2B5EF4-FFF2-40B4-BE49-F238E27FC236}">
-                <a16:creationId xmlns:a16="http://schemas.microsoft.com/office/drawing/2014/main" id="{3E6587CC-016D-4F51-9940-8214456310FA}"/>
+                <a16:creationId xmlns:a16="http://schemas.microsoft.com/office/drawing/2014/main" id="{025F9BB7-3F52-49BD-ADF1-E6B365DF7D63}"/>
               </a:ext>
             </a:extLst>
           </p:cNvPr>
@@ -11500,7 +11500,7 @@
           <p:cNvPr id="10" name="">
             <a:extLst xmlns:a="http://schemas.openxmlformats.org/drawingml/2006/main">
               <a:ext uri="{FF2B5EF4-FFF2-40B4-BE49-F238E27FC236}">
-                <a16:creationId xmlns:a16="http://schemas.microsoft.com/office/drawing/2014/main" id="{601E55C6-4121-4B39-B81C-A1795E86377E}"/>
+                <a16:creationId xmlns:a16="http://schemas.microsoft.com/office/drawing/2014/main" id="{A48B2D3C-D7C3-46B4-A110-20D8404DD206}"/>
               </a:ext>
             </a:extLst>
           </p:cNvPr>
@@ -11533,7 +11533,7 @@
           <p:cNvPr id="11" name="">
             <a:extLst xmlns:a="http://schemas.openxmlformats.org/drawingml/2006/main">
               <a:ext uri="{FF2B5EF4-FFF2-40B4-BE49-F238E27FC236}">
-                <a16:creationId xmlns:a16="http://schemas.microsoft.com/office/drawing/2014/main" id="{D1281F57-A314-4535-9C06-5D098396363B}"/>
+                <a16:creationId xmlns:a16="http://schemas.microsoft.com/office/drawing/2014/main" id="{73966C62-C1A8-46A8-9975-A389A6756023}"/>
               </a:ext>
             </a:extLst>
           </p:cNvPr>
@@ -11597,7 +11597,7 @@
           <p:cNvPr id="12" name="">
             <a:extLst xmlns:a="http://schemas.openxmlformats.org/drawingml/2006/main">
               <a:ext uri="{FF2B5EF4-FFF2-40B4-BE49-F238E27FC236}">
-                <a16:creationId xmlns:a16="http://schemas.microsoft.com/office/drawing/2014/main" id="{A9780237-1B52-4917-983C-9FED66A27B95}"/>
+                <a16:creationId xmlns:a16="http://schemas.microsoft.com/office/drawing/2014/main" id="{B5FA73D3-1AC1-4DE7-A0C6-1C52C5858A8E}"/>
               </a:ext>
             </a:extLst>
           </p:cNvPr>
@@ -11630,7 +11630,7 @@
           <p:cNvPr id="13" name="">
             <a:extLst xmlns:a="http://schemas.openxmlformats.org/drawingml/2006/main">
               <a:ext uri="{FF2B5EF4-FFF2-40B4-BE49-F238E27FC236}">
-                <a16:creationId xmlns:a16="http://schemas.microsoft.com/office/drawing/2014/main" id="{6439AA76-5677-4798-B921-66D0A1DA147C}"/>
+                <a16:creationId xmlns:a16="http://schemas.microsoft.com/office/drawing/2014/main" id="{F33530AA-A266-49B4-9E1C-1483E245B769}"/>
               </a:ext>
             </a:extLst>
           </p:cNvPr>
@@ -11694,7 +11694,7 @@
           <p:cNvPr id="14" name="">
             <a:extLst xmlns:a="http://schemas.openxmlformats.org/drawingml/2006/main">
               <a:ext uri="{FF2B5EF4-FFF2-40B4-BE49-F238E27FC236}">
-                <a16:creationId xmlns:a16="http://schemas.microsoft.com/office/drawing/2014/main" id="{3034D07C-80D4-48FB-A9DE-CF398F9698E1}"/>
+                <a16:creationId xmlns:a16="http://schemas.microsoft.com/office/drawing/2014/main" id="{78BAF7CB-1C1D-4DD0-8519-9840F6387DE7}"/>
               </a:ext>
             </a:extLst>
           </p:cNvPr>
@@ -11727,7 +11727,7 @@
           <p:cNvPr id="15" name="">
             <a:extLst xmlns:a="http://schemas.openxmlformats.org/drawingml/2006/main">
               <a:ext uri="{FF2B5EF4-FFF2-40B4-BE49-F238E27FC236}">
-                <a16:creationId xmlns:a16="http://schemas.microsoft.com/office/drawing/2014/main" id="{D3E24BEC-8E6A-42D6-BF25-A5B533E0CDEB}"/>
+                <a16:creationId xmlns:a16="http://schemas.microsoft.com/office/drawing/2014/main" id="{831FD557-E8D0-4C52-8A56-2E5BA7179EDA}"/>
               </a:ext>
             </a:extLst>
           </p:cNvPr>
@@ -11791,7 +11791,7 @@
           <p:cNvPr id="16" name="">
             <a:extLst xmlns:a="http://schemas.openxmlformats.org/drawingml/2006/main">
               <a:ext uri="{FF2B5EF4-FFF2-40B4-BE49-F238E27FC236}">
-                <a16:creationId xmlns:a16="http://schemas.microsoft.com/office/drawing/2014/main" id="{138F14A1-6EC7-4636-8A7F-EEDC85A22251}"/>
+                <a16:creationId xmlns:a16="http://schemas.microsoft.com/office/drawing/2014/main" id="{F0185F07-7CC2-4A3D-9670-2D25F7FFE151}"/>
               </a:ext>
             </a:extLst>
           </p:cNvPr>
@@ -11824,7 +11824,7 @@
           <p:cNvPr id="17" name="">
             <a:extLst xmlns:a="http://schemas.openxmlformats.org/drawingml/2006/main">
               <a:ext uri="{FF2B5EF4-FFF2-40B4-BE49-F238E27FC236}">
-                <a16:creationId xmlns:a16="http://schemas.microsoft.com/office/drawing/2014/main" id="{82CB878F-AF69-40CF-BB68-8C0669C31507}"/>
+                <a16:creationId xmlns:a16="http://schemas.microsoft.com/office/drawing/2014/main" id="{E9753051-7DFE-49DF-A74E-F1370AD84120}"/>
               </a:ext>
             </a:extLst>
           </p:cNvPr>
@@ -11888,7 +11888,7 @@
           <p:cNvPr id="18" name="">
             <a:extLst xmlns:a="http://schemas.openxmlformats.org/drawingml/2006/main">
               <a:ext uri="{FF2B5EF4-FFF2-40B4-BE49-F238E27FC236}">
-                <a16:creationId xmlns:a16="http://schemas.microsoft.com/office/drawing/2014/main" id="{CC887E3B-6E65-4F41-A625-95CE190E9C43}"/>
+                <a16:creationId xmlns:a16="http://schemas.microsoft.com/office/drawing/2014/main" id="{B44497E5-D7FC-43DD-9E0D-489D1D74B768}"/>
               </a:ext>
             </a:extLst>
           </p:cNvPr>
@@ -11952,7 +11952,7 @@
           <p:cNvPr id="19" name="">
             <a:extLst xmlns:a="http://schemas.openxmlformats.org/drawingml/2006/main">
               <a:ext uri="{FF2B5EF4-FFF2-40B4-BE49-F238E27FC236}">
-                <a16:creationId xmlns:a16="http://schemas.microsoft.com/office/drawing/2014/main" id="{403BF0C6-BF72-4DB3-98E4-44B182F60A75}"/>
+                <a16:creationId xmlns:a16="http://schemas.microsoft.com/office/drawing/2014/main" id="{573F2EA6-2F14-4521-9F7C-6048AF866BB0}"/>
               </a:ext>
             </a:extLst>
           </p:cNvPr>
@@ -12014,7 +12014,7 @@
     </p:spTree>
     <p:extLst>
       <p:ext uri="{BB962C8B-B14F-4D97-AF65-F5344CB8AC3E}">
-        <p14:creationId xmlns:p14="http://schemas.microsoft.com/office/powerpoint/2010/main" val="1255536198"/>
+        <p14:creationId xmlns:p14="http://schemas.microsoft.com/office/powerpoint/2010/main" val="1105725536"/>
       </p:ext>
     </p:extLst>
   </p:cSld>
@@ -12038,7 +12038,7 @@
           <p:cNvPr id="1" name="">
             <a:extLst xmlns:a="http://schemas.openxmlformats.org/drawingml/2006/main">
               <a:ext uri="{FF2B5EF4-FFF2-40B4-BE49-F238E27FC236}">
-                <a16:creationId xmlns:a16="http://schemas.microsoft.com/office/drawing/2014/main" id="{6D1193C4-F9E0-4522-B5C7-08AA4A198517}"/>
+                <a16:creationId xmlns:a16="http://schemas.microsoft.com/office/drawing/2014/main" id="{A41AD9BC-CCF4-4D00-AC1C-D1D38F5BF3C8}"/>
               </a:ext>
             </a:extLst>
           </p:cNvPr>
@@ -12071,7 +12071,7 @@
           <p:cNvPr id="2" name="">
             <a:extLst xmlns:a="http://schemas.openxmlformats.org/drawingml/2006/main">
               <a:ext uri="{FF2B5EF4-FFF2-40B4-BE49-F238E27FC236}">
-                <a16:creationId xmlns:a16="http://schemas.microsoft.com/office/drawing/2014/main" id="{70DC03F3-871C-49D9-BF2D-39C5B11B98BC}"/>
+                <a16:creationId xmlns:a16="http://schemas.microsoft.com/office/drawing/2014/main" id="{F92FA0F5-4C6D-43A6-B275-234FA3799635}"/>
               </a:ext>
             </a:extLst>
           </p:cNvPr>
@@ -12104,7 +12104,7 @@
           <p:cNvPr id="3" name="">
             <a:extLst xmlns:a="http://schemas.openxmlformats.org/drawingml/2006/main">
               <a:ext uri="{FF2B5EF4-FFF2-40B4-BE49-F238E27FC236}">
-                <a16:creationId xmlns:a16="http://schemas.microsoft.com/office/drawing/2014/main" id="{787B4CDE-737D-4A20-84C8-8F7001A31368}"/>
+                <a16:creationId xmlns:a16="http://schemas.microsoft.com/office/drawing/2014/main" id="{CC8EDB7C-C1F8-4001-A228-9F958D0601B4}"/>
               </a:ext>
             </a:extLst>
           </p:cNvPr>
@@ -12168,7 +12168,7 @@
           <p:cNvPr id="4" name="">
             <a:extLst xmlns:a="http://schemas.openxmlformats.org/drawingml/2006/main">
               <a:ext uri="{FF2B5EF4-FFF2-40B4-BE49-F238E27FC236}">
-                <a16:creationId xmlns:a16="http://schemas.microsoft.com/office/drawing/2014/main" id="{FAA7650D-3C6F-4AD8-AF6F-60D8DAA13FD2}"/>
+                <a16:creationId xmlns:a16="http://schemas.microsoft.com/office/drawing/2014/main" id="{CAED97CC-8F92-49C7-B650-CC4F6BBA8382}"/>
               </a:ext>
             </a:extLst>
           </p:cNvPr>
@@ -12232,7 +12232,7 @@
           <p:cNvPr id="5" name="">
             <a:extLst xmlns:a="http://schemas.openxmlformats.org/drawingml/2006/main">
               <a:ext uri="{FF2B5EF4-FFF2-40B4-BE49-F238E27FC236}">
-                <a16:creationId xmlns:a16="http://schemas.microsoft.com/office/drawing/2014/main" id="{A62D6949-2EB8-4A02-A0CF-35D96D3B46F7}"/>
+                <a16:creationId xmlns:a16="http://schemas.microsoft.com/office/drawing/2014/main" id="{47060378-2DB1-4EEB-BB1F-36D5DFFC785A}"/>
               </a:ext>
             </a:extLst>
           </p:cNvPr>
@@ -12265,7 +12265,7 @@
           <p:cNvPr id="6" name="">
             <a:extLst xmlns:a="http://schemas.openxmlformats.org/drawingml/2006/main">
               <a:ext uri="{FF2B5EF4-FFF2-40B4-BE49-F238E27FC236}">
-                <a16:creationId xmlns:a16="http://schemas.microsoft.com/office/drawing/2014/main" id="{47F45ADF-FEC0-43BA-8EFF-A7CF7B3369CA}"/>
+                <a16:creationId xmlns:a16="http://schemas.microsoft.com/office/drawing/2014/main" id="{2D6FF9CA-1056-4B1A-AED0-091485064074}"/>
               </a:ext>
             </a:extLst>
           </p:cNvPr>
@@ -12298,7 +12298,7 @@
           <p:cNvPr id="7" name="">
             <a:extLst xmlns:a="http://schemas.openxmlformats.org/drawingml/2006/main">
               <a:ext uri="{FF2B5EF4-FFF2-40B4-BE49-F238E27FC236}">
-                <a16:creationId xmlns:a16="http://schemas.microsoft.com/office/drawing/2014/main" id="{ADAF8625-7643-4929-9849-88E6036CD0D9}"/>
+                <a16:creationId xmlns:a16="http://schemas.microsoft.com/office/drawing/2014/main" id="{3761902E-2F7A-4ED3-94D4-4C9E01F001AB}"/>
               </a:ext>
             </a:extLst>
           </p:cNvPr>
@@ -12362,7 +12362,7 @@
           <p:cNvPr id="8" name="">
             <a:extLst xmlns:a="http://schemas.openxmlformats.org/drawingml/2006/main">
               <a:ext uri="{FF2B5EF4-FFF2-40B4-BE49-F238E27FC236}">
-                <a16:creationId xmlns:a16="http://schemas.microsoft.com/office/drawing/2014/main" id="{E588A5B1-34A8-45BB-8572-F4E7060664EE}"/>
+                <a16:creationId xmlns:a16="http://schemas.microsoft.com/office/drawing/2014/main" id="{C2CDABDA-B5D9-4F16-9F69-7C961D571AF6}"/>
               </a:ext>
             </a:extLst>
           </p:cNvPr>
@@ -12395,7 +12395,7 @@
           <p:cNvPr id="9" name="">
             <a:extLst xmlns:a="http://schemas.openxmlformats.org/drawingml/2006/main">
               <a:ext uri="{FF2B5EF4-FFF2-40B4-BE49-F238E27FC236}">
-                <a16:creationId xmlns:a16="http://schemas.microsoft.com/office/drawing/2014/main" id="{540D5B23-D94E-4D82-8703-A83733AF466B}"/>
+                <a16:creationId xmlns:a16="http://schemas.microsoft.com/office/drawing/2014/main" id="{E25B11F3-BB5C-432F-BF1B-96BA2D4442D2}"/>
               </a:ext>
             </a:extLst>
           </p:cNvPr>
@@ -12459,7 +12459,7 @@
           <p:cNvPr id="10" name="">
             <a:extLst xmlns:a="http://schemas.openxmlformats.org/drawingml/2006/main">
               <a:ext uri="{FF2B5EF4-FFF2-40B4-BE49-F238E27FC236}">
-                <a16:creationId xmlns:a16="http://schemas.microsoft.com/office/drawing/2014/main" id="{879F76FA-AEE3-4F51-AE51-9651603C207A}"/>
+                <a16:creationId xmlns:a16="http://schemas.microsoft.com/office/drawing/2014/main" id="{7FF829D8-3E98-4168-80AC-9A0244402ECE}"/>
               </a:ext>
             </a:extLst>
           </p:cNvPr>
@@ -12492,7 +12492,7 @@
           <p:cNvPr id="11" name="">
             <a:extLst xmlns:a="http://schemas.openxmlformats.org/drawingml/2006/main">
               <a:ext uri="{FF2B5EF4-FFF2-40B4-BE49-F238E27FC236}">
-                <a16:creationId xmlns:a16="http://schemas.microsoft.com/office/drawing/2014/main" id="{D5F19D5D-7711-4AB8-8246-CD8132A57D4C}"/>
+                <a16:creationId xmlns:a16="http://schemas.microsoft.com/office/drawing/2014/main" id="{F69C12DE-0BBA-4CB3-93DC-472CB46F0112}"/>
               </a:ext>
             </a:extLst>
           </p:cNvPr>
@@ -12556,7 +12556,7 @@
           <p:cNvPr id="12" name="">
             <a:extLst xmlns:a="http://schemas.openxmlformats.org/drawingml/2006/main">
               <a:ext uri="{FF2B5EF4-FFF2-40B4-BE49-F238E27FC236}">
-                <a16:creationId xmlns:a16="http://schemas.microsoft.com/office/drawing/2014/main" id="{A95C187C-8C8F-4F31-91F4-0EF1E3ED8838}"/>
+                <a16:creationId xmlns:a16="http://schemas.microsoft.com/office/drawing/2014/main" id="{6325C7DB-1A41-4A6B-973A-9C28AE6BA3EC}"/>
               </a:ext>
             </a:extLst>
           </p:cNvPr>
@@ -12589,7 +12589,7 @@
           <p:cNvPr id="13" name="">
             <a:extLst xmlns:a="http://schemas.openxmlformats.org/drawingml/2006/main">
               <a:ext uri="{FF2B5EF4-FFF2-40B4-BE49-F238E27FC236}">
-                <a16:creationId xmlns:a16="http://schemas.microsoft.com/office/drawing/2014/main" id="{72217853-FF36-476C-BFE1-14624C255032}"/>
+                <a16:creationId xmlns:a16="http://schemas.microsoft.com/office/drawing/2014/main" id="{AEEFC3F6-14D3-4379-90D5-9CD1AE0EA3AB}"/>
               </a:ext>
             </a:extLst>
           </p:cNvPr>
@@ -12653,7 +12653,7 @@
           <p:cNvPr id="14" name="">
             <a:extLst xmlns:a="http://schemas.openxmlformats.org/drawingml/2006/main">
               <a:ext uri="{FF2B5EF4-FFF2-40B4-BE49-F238E27FC236}">
-                <a16:creationId xmlns:a16="http://schemas.microsoft.com/office/drawing/2014/main" id="{0D4B42C8-464D-43FA-A7D9-A057FDF7640C}"/>
+                <a16:creationId xmlns:a16="http://schemas.microsoft.com/office/drawing/2014/main" id="{D64E6A3A-01CA-4096-BD37-D856946CE375}"/>
               </a:ext>
             </a:extLst>
           </p:cNvPr>
@@ -12686,7 +12686,7 @@
           <p:cNvPr id="15" name="">
             <a:extLst xmlns:a="http://schemas.openxmlformats.org/drawingml/2006/main">
               <a:ext uri="{FF2B5EF4-FFF2-40B4-BE49-F238E27FC236}">
-                <a16:creationId xmlns:a16="http://schemas.microsoft.com/office/drawing/2014/main" id="{120969E6-8093-496D-886A-B9C5660B07FA}"/>
+                <a16:creationId xmlns:a16="http://schemas.microsoft.com/office/drawing/2014/main" id="{3DC22179-3B67-40D7-9A00-BA8E7B7E96F2}"/>
               </a:ext>
             </a:extLst>
           </p:cNvPr>
@@ -12750,7 +12750,7 @@
           <p:cNvPr id="16" name="">
             <a:extLst xmlns:a="http://schemas.openxmlformats.org/drawingml/2006/main">
               <a:ext uri="{FF2B5EF4-FFF2-40B4-BE49-F238E27FC236}">
-                <a16:creationId xmlns:a16="http://schemas.microsoft.com/office/drawing/2014/main" id="{FA11CC21-83CB-4689-91D5-0AE85596039C}"/>
+                <a16:creationId xmlns:a16="http://schemas.microsoft.com/office/drawing/2014/main" id="{42BC5661-3EAB-4518-AA7E-7554D4750B26}"/>
               </a:ext>
             </a:extLst>
           </p:cNvPr>
@@ -12783,7 +12783,7 @@
           <p:cNvPr id="17" name="">
             <a:extLst xmlns:a="http://schemas.openxmlformats.org/drawingml/2006/main">
               <a:ext uri="{FF2B5EF4-FFF2-40B4-BE49-F238E27FC236}">
-                <a16:creationId xmlns:a16="http://schemas.microsoft.com/office/drawing/2014/main" id="{8A042DAB-F9F5-47C5-BD86-666B9464247B}"/>
+                <a16:creationId xmlns:a16="http://schemas.microsoft.com/office/drawing/2014/main" id="{9AAC11FA-49E4-48BF-BA9C-0728190247F3}"/>
               </a:ext>
             </a:extLst>
           </p:cNvPr>
@@ -12847,7 +12847,7 @@
           <p:cNvPr id="18" name="">
             <a:extLst xmlns:a="http://schemas.openxmlformats.org/drawingml/2006/main">
               <a:ext uri="{FF2B5EF4-FFF2-40B4-BE49-F238E27FC236}">
-                <a16:creationId xmlns:a16="http://schemas.microsoft.com/office/drawing/2014/main" id="{AA26C74A-B109-482C-A90C-0DE983D4385B}"/>
+                <a16:creationId xmlns:a16="http://schemas.microsoft.com/office/drawing/2014/main" id="{89FA431C-F129-4151-8E84-67554C01C0AB}"/>
               </a:ext>
             </a:extLst>
           </p:cNvPr>
@@ -12911,7 +12911,7 @@
           <p:cNvPr id="19" name="">
             <a:extLst xmlns:a="http://schemas.openxmlformats.org/drawingml/2006/main">
               <a:ext uri="{FF2B5EF4-FFF2-40B4-BE49-F238E27FC236}">
-                <a16:creationId xmlns:a16="http://schemas.microsoft.com/office/drawing/2014/main" id="{88BC17E4-FDA1-4880-A259-909F128A921A}"/>
+                <a16:creationId xmlns:a16="http://schemas.microsoft.com/office/drawing/2014/main" id="{EB6BD8B2-E95C-466E-A35A-5F0B386BD5BB}"/>
               </a:ext>
             </a:extLst>
           </p:cNvPr>
@@ -12973,7 +12973,7 @@
     </p:spTree>
     <p:extLst>
       <p:ext uri="{BB962C8B-B14F-4D97-AF65-F5344CB8AC3E}">
-        <p14:creationId xmlns:p14="http://schemas.microsoft.com/office/powerpoint/2010/main" val="528023655"/>
+        <p14:creationId xmlns:p14="http://schemas.microsoft.com/office/powerpoint/2010/main" val="1700405711"/>
       </p:ext>
     </p:extLst>
   </p:cSld>
@@ -12997,7 +12997,7 @@
           <p:cNvPr id="1" name="">
             <a:extLst xmlns:a="http://schemas.openxmlformats.org/drawingml/2006/main">
               <a:ext uri="{FF2B5EF4-FFF2-40B4-BE49-F238E27FC236}">
-                <a16:creationId xmlns:a16="http://schemas.microsoft.com/office/drawing/2014/main" id="{1AE45794-4BC3-438A-9895-1701789A9D00}"/>
+                <a16:creationId xmlns:a16="http://schemas.microsoft.com/office/drawing/2014/main" id="{DF002C48-B929-4ADC-9089-FC02CB305337}"/>
               </a:ext>
             </a:extLst>
           </p:cNvPr>
@@ -13030,7 +13030,7 @@
           <p:cNvPr id="2" name="">
             <a:extLst xmlns:a="http://schemas.openxmlformats.org/drawingml/2006/main">
               <a:ext uri="{FF2B5EF4-FFF2-40B4-BE49-F238E27FC236}">
-                <a16:creationId xmlns:a16="http://schemas.microsoft.com/office/drawing/2014/main" id="{DC13A9AA-13AA-47E0-A53E-8930B788888F}"/>
+                <a16:creationId xmlns:a16="http://schemas.microsoft.com/office/drawing/2014/main" id="{629E8DDF-8061-4B78-9137-8556E68211B4}"/>
               </a:ext>
             </a:extLst>
           </p:cNvPr>
@@ -13063,7 +13063,7 @@
           <p:cNvPr id="3" name="">
             <a:extLst xmlns:a="http://schemas.openxmlformats.org/drawingml/2006/main">
               <a:ext uri="{FF2B5EF4-FFF2-40B4-BE49-F238E27FC236}">
-                <a16:creationId xmlns:a16="http://schemas.microsoft.com/office/drawing/2014/main" id="{C112AC60-DD28-4F77-9133-C05C98B971EC}"/>
+                <a16:creationId xmlns:a16="http://schemas.microsoft.com/office/drawing/2014/main" id="{3B9E88AA-BA30-4165-A521-0418B74C10E9}"/>
               </a:ext>
             </a:extLst>
           </p:cNvPr>
@@ -13127,7 +13127,7 @@
           <p:cNvPr id="4" name="">
             <a:extLst xmlns:a="http://schemas.openxmlformats.org/drawingml/2006/main">
               <a:ext uri="{FF2B5EF4-FFF2-40B4-BE49-F238E27FC236}">
-                <a16:creationId xmlns:a16="http://schemas.microsoft.com/office/drawing/2014/main" id="{8CC2279C-368B-4007-87EA-4AE24C854D66}"/>
+                <a16:creationId xmlns:a16="http://schemas.microsoft.com/office/drawing/2014/main" id="{A9640DD2-6DFE-44FB-94A0-C67465BB5AD2}"/>
               </a:ext>
             </a:extLst>
           </p:cNvPr>
@@ -13191,7 +13191,7 @@
           <p:cNvPr id="5" name="">
             <a:extLst xmlns:a="http://schemas.openxmlformats.org/drawingml/2006/main">
               <a:ext uri="{FF2B5EF4-FFF2-40B4-BE49-F238E27FC236}">
-                <a16:creationId xmlns:a16="http://schemas.microsoft.com/office/drawing/2014/main" id="{A91487E0-5F01-4A3B-B4BC-8B2886489A0D}"/>
+                <a16:creationId xmlns:a16="http://schemas.microsoft.com/office/drawing/2014/main" id="{D23536A6-4D39-4D1D-AA76-6E002C78736F}"/>
               </a:ext>
             </a:extLst>
           </p:cNvPr>
@@ -13224,7 +13224,7 @@
           <p:cNvPr id="6" name="">
             <a:extLst xmlns:a="http://schemas.openxmlformats.org/drawingml/2006/main">
               <a:ext uri="{FF2B5EF4-FFF2-40B4-BE49-F238E27FC236}">
-                <a16:creationId xmlns:a16="http://schemas.microsoft.com/office/drawing/2014/main" id="{5A44A194-AAF2-4EA7-813D-8AA3C414C8D9}"/>
+                <a16:creationId xmlns:a16="http://schemas.microsoft.com/office/drawing/2014/main" id="{DC46FEE8-4E56-406C-8ADC-7F9C6F162A51}"/>
               </a:ext>
             </a:extLst>
           </p:cNvPr>
@@ -13257,7 +13257,7 @@
           <p:cNvPr id="7" name="">
             <a:extLst xmlns:a="http://schemas.openxmlformats.org/drawingml/2006/main">
               <a:ext uri="{FF2B5EF4-FFF2-40B4-BE49-F238E27FC236}">
-                <a16:creationId xmlns:a16="http://schemas.microsoft.com/office/drawing/2014/main" id="{36904762-68BF-4B68-B2EF-6D1AA9DC5687}"/>
+                <a16:creationId xmlns:a16="http://schemas.microsoft.com/office/drawing/2014/main" id="{5A770414-B7C3-4A5F-9670-B78217DF4423}"/>
               </a:ext>
             </a:extLst>
           </p:cNvPr>
@@ -13321,7 +13321,7 @@
           <p:cNvPr id="8" name="">
             <a:extLst xmlns:a="http://schemas.openxmlformats.org/drawingml/2006/main">
               <a:ext uri="{FF2B5EF4-FFF2-40B4-BE49-F238E27FC236}">
-                <a16:creationId xmlns:a16="http://schemas.microsoft.com/office/drawing/2014/main" id="{58FD8056-8EB8-4D44-801C-8D409766005F}"/>
+                <a16:creationId xmlns:a16="http://schemas.microsoft.com/office/drawing/2014/main" id="{A2AA246E-0003-4325-A362-3BCE88D040C1}"/>
               </a:ext>
             </a:extLst>
           </p:cNvPr>
@@ -13354,7 +13354,7 @@
           <p:cNvPr id="9" name="">
             <a:extLst xmlns:a="http://schemas.openxmlformats.org/drawingml/2006/main">
               <a:ext uri="{FF2B5EF4-FFF2-40B4-BE49-F238E27FC236}">
-                <a16:creationId xmlns:a16="http://schemas.microsoft.com/office/drawing/2014/main" id="{B88FBCC1-FD02-41E5-BAE8-0B026DA437B4}"/>
+                <a16:creationId xmlns:a16="http://schemas.microsoft.com/office/drawing/2014/main" id="{39248F81-31E3-49DB-B839-67253EABD597}"/>
               </a:ext>
             </a:extLst>
           </p:cNvPr>
@@ -13418,7 +13418,7 @@
           <p:cNvPr id="10" name="">
             <a:extLst xmlns:a="http://schemas.openxmlformats.org/drawingml/2006/main">
               <a:ext uri="{FF2B5EF4-FFF2-40B4-BE49-F238E27FC236}">
-                <a16:creationId xmlns:a16="http://schemas.microsoft.com/office/drawing/2014/main" id="{21B0ADD6-5A60-4872-B4D0-1CDA9C66423C}"/>
+                <a16:creationId xmlns:a16="http://schemas.microsoft.com/office/drawing/2014/main" id="{98DF4282-A14B-49CC-87F5-0F2867737D4E}"/>
               </a:ext>
             </a:extLst>
           </p:cNvPr>
@@ -13451,7 +13451,7 @@
           <p:cNvPr id="11" name="">
             <a:extLst xmlns:a="http://schemas.openxmlformats.org/drawingml/2006/main">
               <a:ext uri="{FF2B5EF4-FFF2-40B4-BE49-F238E27FC236}">
-                <a16:creationId xmlns:a16="http://schemas.microsoft.com/office/drawing/2014/main" id="{31DF5A08-343C-455F-80E9-30CB5BFF9579}"/>
+                <a16:creationId xmlns:a16="http://schemas.microsoft.com/office/drawing/2014/main" id="{D14A6293-6F8C-46A2-87A6-954D6E06B5E7}"/>
               </a:ext>
             </a:extLst>
           </p:cNvPr>
@@ -13515,7 +13515,7 @@
           <p:cNvPr id="12" name="">
             <a:extLst xmlns:a="http://schemas.openxmlformats.org/drawingml/2006/main">
               <a:ext uri="{FF2B5EF4-FFF2-40B4-BE49-F238E27FC236}">
-                <a16:creationId xmlns:a16="http://schemas.microsoft.com/office/drawing/2014/main" id="{2A3FA4F3-A687-4FA9-AD8A-C31921D4013E}"/>
+                <a16:creationId xmlns:a16="http://schemas.microsoft.com/office/drawing/2014/main" id="{4DA5114E-7F31-4428-8C8B-50F220EEF860}"/>
               </a:ext>
             </a:extLst>
           </p:cNvPr>
@@ -13548,7 +13548,7 @@
           <p:cNvPr id="13" name="">
             <a:extLst xmlns:a="http://schemas.openxmlformats.org/drawingml/2006/main">
               <a:ext uri="{FF2B5EF4-FFF2-40B4-BE49-F238E27FC236}">
-                <a16:creationId xmlns:a16="http://schemas.microsoft.com/office/drawing/2014/main" id="{E22F875A-BBB8-4827-8C47-A1D5A758B7DC}"/>
+                <a16:creationId xmlns:a16="http://schemas.microsoft.com/office/drawing/2014/main" id="{A2C00A48-0A67-4D3C-99B0-B84077669CF2}"/>
               </a:ext>
             </a:extLst>
           </p:cNvPr>
@@ -13612,7 +13612,7 @@
           <p:cNvPr id="14" name="">
             <a:extLst xmlns:a="http://schemas.openxmlformats.org/drawingml/2006/main">
               <a:ext uri="{FF2B5EF4-FFF2-40B4-BE49-F238E27FC236}">
-                <a16:creationId xmlns:a16="http://schemas.microsoft.com/office/drawing/2014/main" id="{09E2D54D-FF7F-4767-98C3-8978A046AF10}"/>
+                <a16:creationId xmlns:a16="http://schemas.microsoft.com/office/drawing/2014/main" id="{2C4062D2-B460-4324-832E-DAB88FB12FBC}"/>
               </a:ext>
             </a:extLst>
           </p:cNvPr>
@@ -13645,7 +13645,7 @@
           <p:cNvPr id="15" name="">
             <a:extLst xmlns:a="http://schemas.openxmlformats.org/drawingml/2006/main">
               <a:ext uri="{FF2B5EF4-FFF2-40B4-BE49-F238E27FC236}">
-                <a16:creationId xmlns:a16="http://schemas.microsoft.com/office/drawing/2014/main" id="{50FEF18F-5299-4B81-A664-EE1AF5429855}"/>
+                <a16:creationId xmlns:a16="http://schemas.microsoft.com/office/drawing/2014/main" id="{90274795-E1E4-4F32-A1BE-2A066664D0AD}"/>
               </a:ext>
             </a:extLst>
           </p:cNvPr>
@@ -13709,7 +13709,7 @@
           <p:cNvPr id="16" name="">
             <a:extLst xmlns:a="http://schemas.openxmlformats.org/drawingml/2006/main">
               <a:ext uri="{FF2B5EF4-FFF2-40B4-BE49-F238E27FC236}">
-                <a16:creationId xmlns:a16="http://schemas.microsoft.com/office/drawing/2014/main" id="{CD2C5A8B-15FF-475B-812B-3728FBAA9A08}"/>
+                <a16:creationId xmlns:a16="http://schemas.microsoft.com/office/drawing/2014/main" id="{359A459C-A1A6-41A3-A44D-507B112E4A57}"/>
               </a:ext>
             </a:extLst>
           </p:cNvPr>
@@ -13742,7 +13742,7 @@
           <p:cNvPr id="17" name="">
             <a:extLst xmlns:a="http://schemas.openxmlformats.org/drawingml/2006/main">
               <a:ext uri="{FF2B5EF4-FFF2-40B4-BE49-F238E27FC236}">
-                <a16:creationId xmlns:a16="http://schemas.microsoft.com/office/drawing/2014/main" id="{53C84DA1-5E26-4CA0-99E0-2371F9F1AD59}"/>
+                <a16:creationId xmlns:a16="http://schemas.microsoft.com/office/drawing/2014/main" id="{7A9C74C2-B39C-40BE-936D-A77257954C1B}"/>
               </a:ext>
             </a:extLst>
           </p:cNvPr>
@@ -13806,7 +13806,7 @@
           <p:cNvPr id="18" name="">
             <a:extLst xmlns:a="http://schemas.openxmlformats.org/drawingml/2006/main">
               <a:ext uri="{FF2B5EF4-FFF2-40B4-BE49-F238E27FC236}">
-                <a16:creationId xmlns:a16="http://schemas.microsoft.com/office/drawing/2014/main" id="{E1BC8CA2-0BF7-4E50-885B-42A7BAF56EC6}"/>
+                <a16:creationId xmlns:a16="http://schemas.microsoft.com/office/drawing/2014/main" id="{BA96FA19-00CE-4AC9-A9A6-B179C239E6EA}"/>
               </a:ext>
             </a:extLst>
           </p:cNvPr>
@@ -13870,7 +13870,7 @@
           <p:cNvPr id="19" name="">
             <a:extLst xmlns:a="http://schemas.openxmlformats.org/drawingml/2006/main">
               <a:ext uri="{FF2B5EF4-FFF2-40B4-BE49-F238E27FC236}">
-                <a16:creationId xmlns:a16="http://schemas.microsoft.com/office/drawing/2014/main" id="{EEA2269F-176F-4FDB-A22F-8B34A012FB29}"/>
+                <a16:creationId xmlns:a16="http://schemas.microsoft.com/office/drawing/2014/main" id="{C95D4FC1-B9CE-408C-8077-C9206810F6FD}"/>
               </a:ext>
             </a:extLst>
           </p:cNvPr>
@@ -13932,7 +13932,7 @@
     </p:spTree>
     <p:extLst>
       <p:ext uri="{BB962C8B-B14F-4D97-AF65-F5344CB8AC3E}">
-        <p14:creationId xmlns:p14="http://schemas.microsoft.com/office/powerpoint/2010/main" val="1052870523"/>
+        <p14:creationId xmlns:p14="http://schemas.microsoft.com/office/powerpoint/2010/main" val="1698112314"/>
       </p:ext>
     </p:extLst>
   </p:cSld>
@@ -13956,7 +13956,7 @@
           <p:cNvPr id="1" name="">
             <a:extLst xmlns:a="http://schemas.openxmlformats.org/drawingml/2006/main">
               <a:ext uri="{FF2B5EF4-FFF2-40B4-BE49-F238E27FC236}">
-                <a16:creationId xmlns:a16="http://schemas.microsoft.com/office/drawing/2014/main" id="{787B3432-076A-46A1-BE20-7437DCF0264E}"/>
+                <a16:creationId xmlns:a16="http://schemas.microsoft.com/office/drawing/2014/main" id="{64AB5A32-6F38-49DE-AC37-090BCDE04016}"/>
               </a:ext>
             </a:extLst>
           </p:cNvPr>
@@ -13989,7 +13989,7 @@
           <p:cNvPr id="2" name="">
             <a:extLst xmlns:a="http://schemas.openxmlformats.org/drawingml/2006/main">
               <a:ext uri="{FF2B5EF4-FFF2-40B4-BE49-F238E27FC236}">
-                <a16:creationId xmlns:a16="http://schemas.microsoft.com/office/drawing/2014/main" id="{3F736E40-89F3-49F4-867D-0EB7BF769E7F}"/>
+                <a16:creationId xmlns:a16="http://schemas.microsoft.com/office/drawing/2014/main" id="{A05150C5-F02B-4CD0-B3FA-74E74D70AAF0}"/>
               </a:ext>
             </a:extLst>
           </p:cNvPr>
@@ -14022,7 +14022,7 @@
           <p:cNvPr id="3" name="">
             <a:extLst xmlns:a="http://schemas.openxmlformats.org/drawingml/2006/main">
               <a:ext uri="{FF2B5EF4-FFF2-40B4-BE49-F238E27FC236}">
-                <a16:creationId xmlns:a16="http://schemas.microsoft.com/office/drawing/2014/main" id="{107A180B-0B42-481B-887E-5FF1C13B362F}"/>
+                <a16:creationId xmlns:a16="http://schemas.microsoft.com/office/drawing/2014/main" id="{6E95DA58-D047-4530-B2B4-88D40935BBAD}"/>
               </a:ext>
             </a:extLst>
           </p:cNvPr>
@@ -14086,7 +14086,7 @@
           <p:cNvPr id="4" name="">
             <a:extLst xmlns:a="http://schemas.openxmlformats.org/drawingml/2006/main">
               <a:ext uri="{FF2B5EF4-FFF2-40B4-BE49-F238E27FC236}">
-                <a16:creationId xmlns:a16="http://schemas.microsoft.com/office/drawing/2014/main" id="{01E7CEBC-7B50-45C0-AB5B-D428B15B84E8}"/>
+                <a16:creationId xmlns:a16="http://schemas.microsoft.com/office/drawing/2014/main" id="{9B61D5F8-A104-4190-B1DF-CBC3662F1411}"/>
               </a:ext>
             </a:extLst>
           </p:cNvPr>
@@ -14150,7 +14150,7 @@
           <p:cNvPr id="5" name="">
             <a:extLst xmlns:a="http://schemas.openxmlformats.org/drawingml/2006/main">
               <a:ext uri="{FF2B5EF4-FFF2-40B4-BE49-F238E27FC236}">
-                <a16:creationId xmlns:a16="http://schemas.microsoft.com/office/drawing/2014/main" id="{CA00E382-8D63-4DE1-BE25-6C55041F8AAF}"/>
+                <a16:creationId xmlns:a16="http://schemas.microsoft.com/office/drawing/2014/main" id="{3A12565A-7B99-4C13-800A-B611C094F06E}"/>
               </a:ext>
             </a:extLst>
           </p:cNvPr>
@@ -14183,7 +14183,7 @@
           <p:cNvPr id="6" name="">
             <a:extLst xmlns:a="http://schemas.openxmlformats.org/drawingml/2006/main">
               <a:ext uri="{FF2B5EF4-FFF2-40B4-BE49-F238E27FC236}">
-                <a16:creationId xmlns:a16="http://schemas.microsoft.com/office/drawing/2014/main" id="{946C4997-3C99-4D92-85D7-041A48141A14}"/>
+                <a16:creationId xmlns:a16="http://schemas.microsoft.com/office/drawing/2014/main" id="{BB733838-A1ED-493E-AC02-1EEEB59F2501}"/>
               </a:ext>
             </a:extLst>
           </p:cNvPr>
@@ -14216,7 +14216,7 @@
           <p:cNvPr id="7" name="">
             <a:extLst xmlns:a="http://schemas.openxmlformats.org/drawingml/2006/main">
               <a:ext uri="{FF2B5EF4-FFF2-40B4-BE49-F238E27FC236}">
-                <a16:creationId xmlns:a16="http://schemas.microsoft.com/office/drawing/2014/main" id="{B7489536-3E2F-4AC3-AD36-4C1E3609A91D}"/>
+                <a16:creationId xmlns:a16="http://schemas.microsoft.com/office/drawing/2014/main" id="{BE3B149C-FA90-4FBA-8451-DA642D839286}"/>
               </a:ext>
             </a:extLst>
           </p:cNvPr>
@@ -14280,7 +14280,7 @@
           <p:cNvPr id="8" name="">
             <a:extLst xmlns:a="http://schemas.openxmlformats.org/drawingml/2006/main">
               <a:ext uri="{FF2B5EF4-FFF2-40B4-BE49-F238E27FC236}">
-                <a16:creationId xmlns:a16="http://schemas.microsoft.com/office/drawing/2014/main" id="{269DA442-2A8D-4A4E-9146-ADE502400FBE}"/>
+                <a16:creationId xmlns:a16="http://schemas.microsoft.com/office/drawing/2014/main" id="{92542563-F2A2-4F67-BFB0-851077C02EE3}"/>
               </a:ext>
             </a:extLst>
           </p:cNvPr>
@@ -14313,7 +14313,7 @@
           <p:cNvPr id="9" name="">
             <a:extLst xmlns:a="http://schemas.openxmlformats.org/drawingml/2006/main">
               <a:ext uri="{FF2B5EF4-FFF2-40B4-BE49-F238E27FC236}">
-                <a16:creationId xmlns:a16="http://schemas.microsoft.com/office/drawing/2014/main" id="{1767D87C-FA1C-45EA-A9DC-5A3D74E3DA02}"/>
+                <a16:creationId xmlns:a16="http://schemas.microsoft.com/office/drawing/2014/main" id="{D9597332-FCAF-4601-B90B-FF1F81D8C17E}"/>
               </a:ext>
             </a:extLst>
           </p:cNvPr>
@@ -14377,7 +14377,7 @@
           <p:cNvPr id="10" name="">
             <a:extLst xmlns:a="http://schemas.openxmlformats.org/drawingml/2006/main">
               <a:ext uri="{FF2B5EF4-FFF2-40B4-BE49-F238E27FC236}">
-                <a16:creationId xmlns:a16="http://schemas.microsoft.com/office/drawing/2014/main" id="{372A0B9D-7077-4F37-8F25-31338F68D46A}"/>
+                <a16:creationId xmlns:a16="http://schemas.microsoft.com/office/drawing/2014/main" id="{62B4AD2B-8B76-4A7A-8D18-1CA9599A6447}"/>
               </a:ext>
             </a:extLst>
           </p:cNvPr>
@@ -14410,7 +14410,7 @@
           <p:cNvPr id="11" name="">
             <a:extLst xmlns:a="http://schemas.openxmlformats.org/drawingml/2006/main">
               <a:ext uri="{FF2B5EF4-FFF2-40B4-BE49-F238E27FC236}">
-                <a16:creationId xmlns:a16="http://schemas.microsoft.com/office/drawing/2014/main" id="{190DAF7B-F636-4B08-8BB3-47AF45F796FF}"/>
+                <a16:creationId xmlns:a16="http://schemas.microsoft.com/office/drawing/2014/main" id="{BCF248B6-59C3-4A30-B8F2-C3E9493825FE}"/>
               </a:ext>
             </a:extLst>
           </p:cNvPr>
@@ -14474,7 +14474,7 @@
           <p:cNvPr id="12" name="">
             <a:extLst xmlns:a="http://schemas.openxmlformats.org/drawingml/2006/main">
               <a:ext uri="{FF2B5EF4-FFF2-40B4-BE49-F238E27FC236}">
-                <a16:creationId xmlns:a16="http://schemas.microsoft.com/office/drawing/2014/main" id="{EA45F971-FA0D-4B94-8E0B-CA7E8DC89DD9}"/>
+                <a16:creationId xmlns:a16="http://schemas.microsoft.com/office/drawing/2014/main" id="{97D78451-19C9-4D5B-87AF-9D2AED811204}"/>
               </a:ext>
             </a:extLst>
           </p:cNvPr>
@@ -14507,7 +14507,7 @@
           <p:cNvPr id="13" name="">
             <a:extLst xmlns:a="http://schemas.openxmlformats.org/drawingml/2006/main">
               <a:ext uri="{FF2B5EF4-FFF2-40B4-BE49-F238E27FC236}">
-                <a16:creationId xmlns:a16="http://schemas.microsoft.com/office/drawing/2014/main" id="{39A47CF0-4D50-44EC-AB0E-397B0D70BB05}"/>
+                <a16:creationId xmlns:a16="http://schemas.microsoft.com/office/drawing/2014/main" id="{683726CD-514F-4F0F-BEB1-682EB5E53414}"/>
               </a:ext>
             </a:extLst>
           </p:cNvPr>
@@ -14571,7 +14571,7 @@
           <p:cNvPr id="14" name="">
             <a:extLst xmlns:a="http://schemas.openxmlformats.org/drawingml/2006/main">
               <a:ext uri="{FF2B5EF4-FFF2-40B4-BE49-F238E27FC236}">
-                <a16:creationId xmlns:a16="http://schemas.microsoft.com/office/drawing/2014/main" id="{B3579ABF-D324-4228-8104-86C5459D3F12}"/>
+                <a16:creationId xmlns:a16="http://schemas.microsoft.com/office/drawing/2014/main" id="{AA2336D1-A52E-41F8-A26B-EB5C98350F87}"/>
               </a:ext>
             </a:extLst>
           </p:cNvPr>
@@ -14604,7 +14604,7 @@
           <p:cNvPr id="15" name="">
             <a:extLst xmlns:a="http://schemas.openxmlformats.org/drawingml/2006/main">
               <a:ext uri="{FF2B5EF4-FFF2-40B4-BE49-F238E27FC236}">
-                <a16:creationId xmlns:a16="http://schemas.microsoft.com/office/drawing/2014/main" id="{940F2C8B-93BC-4AF9-B424-A23305BF9ED0}"/>
+                <a16:creationId xmlns:a16="http://schemas.microsoft.com/office/drawing/2014/main" id="{219FD13F-0D18-457F-8706-523829B71F93}"/>
               </a:ext>
             </a:extLst>
           </p:cNvPr>
@@ -14668,7 +14668,7 @@
           <p:cNvPr id="16" name="">
             <a:extLst xmlns:a="http://schemas.openxmlformats.org/drawingml/2006/main">
               <a:ext uri="{FF2B5EF4-FFF2-40B4-BE49-F238E27FC236}">
-                <a16:creationId xmlns:a16="http://schemas.microsoft.com/office/drawing/2014/main" id="{76E74CA7-E0AE-4D09-AEB2-DAE1693FE608}"/>
+                <a16:creationId xmlns:a16="http://schemas.microsoft.com/office/drawing/2014/main" id="{69272A55-9BBB-4DFB-ACD9-5387084B5C03}"/>
               </a:ext>
             </a:extLst>
           </p:cNvPr>
@@ -14732,7 +14732,7 @@
           <p:cNvPr id="17" name="">
             <a:extLst xmlns:a="http://schemas.openxmlformats.org/drawingml/2006/main">
               <a:ext uri="{FF2B5EF4-FFF2-40B4-BE49-F238E27FC236}">
-                <a16:creationId xmlns:a16="http://schemas.microsoft.com/office/drawing/2014/main" id="{F3BED07B-858B-4EF0-A6A0-6A1E4596EC15}"/>
+                <a16:creationId xmlns:a16="http://schemas.microsoft.com/office/drawing/2014/main" id="{E8D06485-26D6-4950-9A27-639A7A0BADE8}"/>
               </a:ext>
             </a:extLst>
           </p:cNvPr>
@@ -14794,7 +14794,7 @@
     </p:spTree>
     <p:extLst>
       <p:ext uri="{BB962C8B-B14F-4D97-AF65-F5344CB8AC3E}">
-        <p14:creationId xmlns:p14="http://schemas.microsoft.com/office/powerpoint/2010/main" val="1522699254"/>
+        <p14:creationId xmlns:p14="http://schemas.microsoft.com/office/powerpoint/2010/main" val="416410417"/>
       </p:ext>
     </p:extLst>
   </p:cSld>
@@ -14818,7 +14818,7 @@
           <p:cNvPr id="1" name="">
             <a:extLst xmlns:a="http://schemas.openxmlformats.org/drawingml/2006/main">
               <a:ext uri="{FF2B5EF4-FFF2-40B4-BE49-F238E27FC236}">
-                <a16:creationId xmlns:a16="http://schemas.microsoft.com/office/drawing/2014/main" id="{378AE5F4-66FE-4FD7-9324-9E84817A7552}"/>
+                <a16:creationId xmlns:a16="http://schemas.microsoft.com/office/drawing/2014/main" id="{CC02CA39-AC0F-42E1-815B-E84A8EB7CFD9}"/>
               </a:ext>
             </a:extLst>
           </p:cNvPr>
@@ -14851,7 +14851,7 @@
           <p:cNvPr id="2" name="">
             <a:extLst xmlns:a="http://schemas.openxmlformats.org/drawingml/2006/main">
               <a:ext uri="{FF2B5EF4-FFF2-40B4-BE49-F238E27FC236}">
-                <a16:creationId xmlns:a16="http://schemas.microsoft.com/office/drawing/2014/main" id="{163ABC16-D5E7-4705-BA9D-52D8B8136399}"/>
+                <a16:creationId xmlns:a16="http://schemas.microsoft.com/office/drawing/2014/main" id="{B2773B3B-5E0B-413C-932C-56817A5C146C}"/>
               </a:ext>
             </a:extLst>
           </p:cNvPr>
@@ -14884,7 +14884,7 @@
           <p:cNvPr id="3" name="">
             <a:extLst xmlns:a="http://schemas.openxmlformats.org/drawingml/2006/main">
               <a:ext uri="{FF2B5EF4-FFF2-40B4-BE49-F238E27FC236}">
-                <a16:creationId xmlns:a16="http://schemas.microsoft.com/office/drawing/2014/main" id="{BC3E1601-AE1F-4022-A758-5C456E2B2D54}"/>
+                <a16:creationId xmlns:a16="http://schemas.microsoft.com/office/drawing/2014/main" id="{13537843-A450-443A-9A44-80A8932D9D79}"/>
               </a:ext>
             </a:extLst>
           </p:cNvPr>
@@ -14948,7 +14948,7 @@
           <p:cNvPr id="4" name="">
             <a:extLst xmlns:a="http://schemas.openxmlformats.org/drawingml/2006/main">
               <a:ext uri="{FF2B5EF4-FFF2-40B4-BE49-F238E27FC236}">
-                <a16:creationId xmlns:a16="http://schemas.microsoft.com/office/drawing/2014/main" id="{68F03967-06F0-4C32-997B-008F6DD3937C}"/>
+                <a16:creationId xmlns:a16="http://schemas.microsoft.com/office/drawing/2014/main" id="{5DD6AA77-5B51-402D-B16F-E4474F7B0A91}"/>
               </a:ext>
             </a:extLst>
           </p:cNvPr>
@@ -15012,7 +15012,7 @@
           <p:cNvPr id="5" name="">
             <a:extLst xmlns:a="http://schemas.openxmlformats.org/drawingml/2006/main">
               <a:ext uri="{FF2B5EF4-FFF2-40B4-BE49-F238E27FC236}">
-                <a16:creationId xmlns:a16="http://schemas.microsoft.com/office/drawing/2014/main" id="{C748F292-89D5-4719-9132-F46AA0E959DC}"/>
+                <a16:creationId xmlns:a16="http://schemas.microsoft.com/office/drawing/2014/main" id="{A265824D-356B-4721-944D-257EC5480CA6}"/>
               </a:ext>
             </a:extLst>
           </p:cNvPr>
@@ -15045,7 +15045,7 @@
           <p:cNvPr id="6" name="">
             <a:extLst xmlns:a="http://schemas.openxmlformats.org/drawingml/2006/main">
               <a:ext uri="{FF2B5EF4-FFF2-40B4-BE49-F238E27FC236}">
-                <a16:creationId xmlns:a16="http://schemas.microsoft.com/office/drawing/2014/main" id="{BEAA7015-F45A-41C2-BC62-2B7C42CFA2A1}"/>
+                <a16:creationId xmlns:a16="http://schemas.microsoft.com/office/drawing/2014/main" id="{AAB5E4F7-0775-49A1-911E-6EB51A5254FF}"/>
               </a:ext>
             </a:extLst>
           </p:cNvPr>
@@ -15078,7 +15078,7 @@
           <p:cNvPr id="7" name="">
             <a:extLst xmlns:a="http://schemas.openxmlformats.org/drawingml/2006/main">
               <a:ext uri="{FF2B5EF4-FFF2-40B4-BE49-F238E27FC236}">
-                <a16:creationId xmlns:a16="http://schemas.microsoft.com/office/drawing/2014/main" id="{760288C4-BB87-481C-B028-14F69CD2AB70}"/>
+                <a16:creationId xmlns:a16="http://schemas.microsoft.com/office/drawing/2014/main" id="{61D9699D-0DB6-41D0-936A-211D7FE6E5DC}"/>
               </a:ext>
             </a:extLst>
           </p:cNvPr>
@@ -15142,7 +15142,7 @@
           <p:cNvPr id="8" name="">
             <a:extLst xmlns:a="http://schemas.openxmlformats.org/drawingml/2006/main">
               <a:ext uri="{FF2B5EF4-FFF2-40B4-BE49-F238E27FC236}">
-                <a16:creationId xmlns:a16="http://schemas.microsoft.com/office/drawing/2014/main" id="{427C1731-31DB-43F2-861D-5B2C359DCBC5}"/>
+                <a16:creationId xmlns:a16="http://schemas.microsoft.com/office/drawing/2014/main" id="{AD558684-AA84-45CA-8CED-0A9F35C14BDF}"/>
               </a:ext>
             </a:extLst>
           </p:cNvPr>
@@ -15175,7 +15175,7 @@
           <p:cNvPr id="9" name="">
             <a:extLst xmlns:a="http://schemas.openxmlformats.org/drawingml/2006/main">
               <a:ext uri="{FF2B5EF4-FFF2-40B4-BE49-F238E27FC236}">
-                <a16:creationId xmlns:a16="http://schemas.microsoft.com/office/drawing/2014/main" id="{B31E2E66-8D93-436A-AFE6-AA145050E581}"/>
+                <a16:creationId xmlns:a16="http://schemas.microsoft.com/office/drawing/2014/main" id="{31183F67-02C8-4FEF-BD96-3979AD3DD7A3}"/>
               </a:ext>
             </a:extLst>
           </p:cNvPr>
@@ -15239,7 +15239,7 @@
           <p:cNvPr id="10" name="">
             <a:extLst xmlns:a="http://schemas.openxmlformats.org/drawingml/2006/main">
               <a:ext uri="{FF2B5EF4-FFF2-40B4-BE49-F238E27FC236}">
-                <a16:creationId xmlns:a16="http://schemas.microsoft.com/office/drawing/2014/main" id="{997FABA5-CB3B-41BC-9BB2-67657198C785}"/>
+                <a16:creationId xmlns:a16="http://schemas.microsoft.com/office/drawing/2014/main" id="{98A15B16-AB63-4AFB-9739-A6CA793905D6}"/>
               </a:ext>
             </a:extLst>
           </p:cNvPr>
@@ -15272,7 +15272,7 @@
           <p:cNvPr id="11" name="">
             <a:extLst xmlns:a="http://schemas.openxmlformats.org/drawingml/2006/main">
               <a:ext uri="{FF2B5EF4-FFF2-40B4-BE49-F238E27FC236}">
-                <a16:creationId xmlns:a16="http://schemas.microsoft.com/office/drawing/2014/main" id="{C35FF5CB-56DA-4D71-AFFB-7DCA1102EB5A}"/>
+                <a16:creationId xmlns:a16="http://schemas.microsoft.com/office/drawing/2014/main" id="{B9B4B691-395C-4967-A936-1CEF321CC7C2}"/>
               </a:ext>
             </a:extLst>
           </p:cNvPr>
@@ -15336,7 +15336,7 @@
           <p:cNvPr id="12" name="">
             <a:extLst xmlns:a="http://schemas.openxmlformats.org/drawingml/2006/main">
               <a:ext uri="{FF2B5EF4-FFF2-40B4-BE49-F238E27FC236}">
-                <a16:creationId xmlns:a16="http://schemas.microsoft.com/office/drawing/2014/main" id="{7A4DA577-1CFF-42B9-8E09-D72B3BAB1994}"/>
+                <a16:creationId xmlns:a16="http://schemas.microsoft.com/office/drawing/2014/main" id="{B536819D-88C8-4065-A3DC-CE42F6D80747}"/>
               </a:ext>
             </a:extLst>
           </p:cNvPr>
@@ -15369,7 +15369,7 @@
           <p:cNvPr id="13" name="">
             <a:extLst xmlns:a="http://schemas.openxmlformats.org/drawingml/2006/main">
               <a:ext uri="{FF2B5EF4-FFF2-40B4-BE49-F238E27FC236}">
-                <a16:creationId xmlns:a16="http://schemas.microsoft.com/office/drawing/2014/main" id="{340E50B8-DB81-4BFE-BA34-9D5E5FE88881}"/>
+                <a16:creationId xmlns:a16="http://schemas.microsoft.com/office/drawing/2014/main" id="{0152A620-8C0F-4582-9271-05A4AAA123C9}"/>
               </a:ext>
             </a:extLst>
           </p:cNvPr>
@@ -15433,7 +15433,7 @@
           <p:cNvPr id="14" name="">
             <a:extLst xmlns:a="http://schemas.openxmlformats.org/drawingml/2006/main">
               <a:ext uri="{FF2B5EF4-FFF2-40B4-BE49-F238E27FC236}">
-                <a16:creationId xmlns:a16="http://schemas.microsoft.com/office/drawing/2014/main" id="{B69BD316-C4D9-4758-A9E1-67CA0E2E36FF}"/>
+                <a16:creationId xmlns:a16="http://schemas.microsoft.com/office/drawing/2014/main" id="{9F6333B5-C19B-4324-B257-5DE3B37B8366}"/>
               </a:ext>
             </a:extLst>
           </p:cNvPr>
@@ -15466,7 +15466,7 @@
           <p:cNvPr id="15" name="">
             <a:extLst xmlns:a="http://schemas.openxmlformats.org/drawingml/2006/main">
               <a:ext uri="{FF2B5EF4-FFF2-40B4-BE49-F238E27FC236}">
-                <a16:creationId xmlns:a16="http://schemas.microsoft.com/office/drawing/2014/main" id="{F4D09634-70F3-4E4B-8A82-19F4AB875095}"/>
+                <a16:creationId xmlns:a16="http://schemas.microsoft.com/office/drawing/2014/main" id="{6E4206A8-DFC6-4D5E-BE8F-69B0C5BF2DA6}"/>
               </a:ext>
             </a:extLst>
           </p:cNvPr>
@@ -15530,7 +15530,7 @@
           <p:cNvPr id="16" name="">
             <a:extLst xmlns:a="http://schemas.openxmlformats.org/drawingml/2006/main">
               <a:ext uri="{FF2B5EF4-FFF2-40B4-BE49-F238E27FC236}">
-                <a16:creationId xmlns:a16="http://schemas.microsoft.com/office/drawing/2014/main" id="{4630E995-8D72-4157-9A7F-D8EB5BBE9530}"/>
+                <a16:creationId xmlns:a16="http://schemas.microsoft.com/office/drawing/2014/main" id="{C492AC89-E0B2-410B-81D5-121C0AB529D9}"/>
               </a:ext>
             </a:extLst>
           </p:cNvPr>
@@ -15563,7 +15563,7 @@
           <p:cNvPr id="17" name="">
             <a:extLst xmlns:a="http://schemas.openxmlformats.org/drawingml/2006/main">
               <a:ext uri="{FF2B5EF4-FFF2-40B4-BE49-F238E27FC236}">
-                <a16:creationId xmlns:a16="http://schemas.microsoft.com/office/drawing/2014/main" id="{11F4CDC0-CE19-46BC-A7B1-16413B17282E}"/>
+                <a16:creationId xmlns:a16="http://schemas.microsoft.com/office/drawing/2014/main" id="{B675A184-0EF9-407F-B685-C32B6A8E69B7}"/>
               </a:ext>
             </a:extLst>
           </p:cNvPr>
@@ -15627,7 +15627,7 @@
           <p:cNvPr id="18" name="">
             <a:extLst xmlns:a="http://schemas.openxmlformats.org/drawingml/2006/main">
               <a:ext uri="{FF2B5EF4-FFF2-40B4-BE49-F238E27FC236}">
-                <a16:creationId xmlns:a16="http://schemas.microsoft.com/office/drawing/2014/main" id="{568D9479-65CF-4641-ABC6-7A02014BF8E4}"/>
+                <a16:creationId xmlns:a16="http://schemas.microsoft.com/office/drawing/2014/main" id="{B46B3058-8C35-489C-86DA-806EF6B2FA90}"/>
               </a:ext>
             </a:extLst>
           </p:cNvPr>
@@ -15691,7 +15691,7 @@
           <p:cNvPr id="19" name="">
             <a:extLst xmlns:a="http://schemas.openxmlformats.org/drawingml/2006/main">
               <a:ext uri="{FF2B5EF4-FFF2-40B4-BE49-F238E27FC236}">
-                <a16:creationId xmlns:a16="http://schemas.microsoft.com/office/drawing/2014/main" id="{D1553202-6542-47D3-9DD0-D3D90A37922A}"/>
+                <a16:creationId xmlns:a16="http://schemas.microsoft.com/office/drawing/2014/main" id="{1C09B253-F096-4BDC-B57E-311B605F2F6D}"/>
               </a:ext>
             </a:extLst>
           </p:cNvPr>
@@ -15753,7 +15753,7 @@
     </p:spTree>
     <p:extLst>
       <p:ext uri="{BB962C8B-B14F-4D97-AF65-F5344CB8AC3E}">
-        <p14:creationId xmlns:p14="http://schemas.microsoft.com/office/powerpoint/2010/main" val="962544112"/>
+        <p14:creationId xmlns:p14="http://schemas.microsoft.com/office/powerpoint/2010/main" val="122148747"/>
       </p:ext>
     </p:extLst>
   </p:cSld>
@@ -15777,7 +15777,7 @@
           <p:cNvPr id="1" name="">
             <a:extLst xmlns:a="http://schemas.openxmlformats.org/drawingml/2006/main">
               <a:ext uri="{FF2B5EF4-FFF2-40B4-BE49-F238E27FC236}">
-                <a16:creationId xmlns:a16="http://schemas.microsoft.com/office/drawing/2014/main" id="{C416AC2A-C1D6-465C-ADAF-5C863EAAFBB8}"/>
+                <a16:creationId xmlns:a16="http://schemas.microsoft.com/office/drawing/2014/main" id="{D29DA883-1E76-450E-B9D1-2A2B10FC6921}"/>
               </a:ext>
             </a:extLst>
           </p:cNvPr>
@@ -15810,7 +15810,7 @@
           <p:cNvPr id="2" name="">
             <a:extLst xmlns:a="http://schemas.openxmlformats.org/drawingml/2006/main">
               <a:ext uri="{FF2B5EF4-FFF2-40B4-BE49-F238E27FC236}">
-                <a16:creationId xmlns:a16="http://schemas.microsoft.com/office/drawing/2014/main" id="{EACDFC11-F7F3-4E40-8B96-C7A29545F144}"/>
+                <a16:creationId xmlns:a16="http://schemas.microsoft.com/office/drawing/2014/main" id="{B9E41A22-7DFC-4846-91B7-A8644761D0CA}"/>
               </a:ext>
             </a:extLst>
           </p:cNvPr>
@@ -15843,7 +15843,7 @@
           <p:cNvPr id="3" name="">
             <a:extLst xmlns:a="http://schemas.openxmlformats.org/drawingml/2006/main">
               <a:ext uri="{FF2B5EF4-FFF2-40B4-BE49-F238E27FC236}">
-                <a16:creationId xmlns:a16="http://schemas.microsoft.com/office/drawing/2014/main" id="{00CF4805-B7C0-45A4-9807-116DEA0748D5}"/>
+                <a16:creationId xmlns:a16="http://schemas.microsoft.com/office/drawing/2014/main" id="{7EA432B0-799B-4ABC-AA4C-9583FCA2F140}"/>
               </a:ext>
             </a:extLst>
           </p:cNvPr>
@@ -15907,7 +15907,7 @@
           <p:cNvPr id="4" name="">
             <a:extLst xmlns:a="http://schemas.openxmlformats.org/drawingml/2006/main">
               <a:ext uri="{FF2B5EF4-FFF2-40B4-BE49-F238E27FC236}">
-                <a16:creationId xmlns:a16="http://schemas.microsoft.com/office/drawing/2014/main" id="{18523791-35B8-4D3C-AB14-2CD34D9A74B6}"/>
+                <a16:creationId xmlns:a16="http://schemas.microsoft.com/office/drawing/2014/main" id="{17905D8C-B88C-474D-8740-02DE684D32C6}"/>
               </a:ext>
             </a:extLst>
           </p:cNvPr>
@@ -15971,7 +15971,7 @@
           <p:cNvPr id="5" name="">
             <a:extLst xmlns:a="http://schemas.openxmlformats.org/drawingml/2006/main">
               <a:ext uri="{FF2B5EF4-FFF2-40B4-BE49-F238E27FC236}">
-                <a16:creationId xmlns:a16="http://schemas.microsoft.com/office/drawing/2014/main" id="{CDF4E634-5FFC-4A7D-843F-1D9C3B01B281}"/>
+                <a16:creationId xmlns:a16="http://schemas.microsoft.com/office/drawing/2014/main" id="{A944EDEF-BA56-4D90-86AE-EBF3EA7CCB27}"/>
               </a:ext>
             </a:extLst>
           </p:cNvPr>
@@ -16004,7 +16004,7 @@
           <p:cNvPr id="6" name="">
             <a:extLst xmlns:a="http://schemas.openxmlformats.org/drawingml/2006/main">
               <a:ext uri="{FF2B5EF4-FFF2-40B4-BE49-F238E27FC236}">
-                <a16:creationId xmlns:a16="http://schemas.microsoft.com/office/drawing/2014/main" id="{C4BF35A3-C422-47B7-9A5F-3D851DB7B0FA}"/>
+                <a16:creationId xmlns:a16="http://schemas.microsoft.com/office/drawing/2014/main" id="{3836228A-D82E-4297-85CE-B844BC47B3E8}"/>
               </a:ext>
             </a:extLst>
           </p:cNvPr>
@@ -16037,7 +16037,7 @@
           <p:cNvPr id="7" name="">
             <a:extLst xmlns:a="http://schemas.openxmlformats.org/drawingml/2006/main">
               <a:ext uri="{FF2B5EF4-FFF2-40B4-BE49-F238E27FC236}">
-                <a16:creationId xmlns:a16="http://schemas.microsoft.com/office/drawing/2014/main" id="{9B4BFBDF-BB74-4EA8-AF29-BCA8E16D3C25}"/>
+                <a16:creationId xmlns:a16="http://schemas.microsoft.com/office/drawing/2014/main" id="{D06CB2F0-FE4C-41AE-981A-1C75B5294CA8}"/>
               </a:ext>
             </a:extLst>
           </p:cNvPr>
@@ -16101,7 +16101,7 @@
           <p:cNvPr id="8" name="">
             <a:extLst xmlns:a="http://schemas.openxmlformats.org/drawingml/2006/main">
               <a:ext uri="{FF2B5EF4-FFF2-40B4-BE49-F238E27FC236}">
-                <a16:creationId xmlns:a16="http://schemas.microsoft.com/office/drawing/2014/main" id="{8C41B985-176D-4464-8637-419B6D29C50C}"/>
+                <a16:creationId xmlns:a16="http://schemas.microsoft.com/office/drawing/2014/main" id="{550BF7CA-55CB-486D-B669-0588A01C7210}"/>
               </a:ext>
             </a:extLst>
           </p:cNvPr>
@@ -16134,7 +16134,7 @@
           <p:cNvPr id="9" name="">
             <a:extLst xmlns:a="http://schemas.openxmlformats.org/drawingml/2006/main">
               <a:ext uri="{FF2B5EF4-FFF2-40B4-BE49-F238E27FC236}">
-                <a16:creationId xmlns:a16="http://schemas.microsoft.com/office/drawing/2014/main" id="{3B96776C-6B4A-40EB-812C-CA76FA22D1DA}"/>
+                <a16:creationId xmlns:a16="http://schemas.microsoft.com/office/drawing/2014/main" id="{2BEF2A69-14EE-41F3-B88F-9213049D2010}"/>
               </a:ext>
             </a:extLst>
           </p:cNvPr>
@@ -16198,7 +16198,7 @@
           <p:cNvPr id="10" name="">
             <a:extLst xmlns:a="http://schemas.openxmlformats.org/drawingml/2006/main">
               <a:ext uri="{FF2B5EF4-FFF2-40B4-BE49-F238E27FC236}">
-                <a16:creationId xmlns:a16="http://schemas.microsoft.com/office/drawing/2014/main" id="{36411FAF-708C-44F6-8B57-833E8AF59E98}"/>
+                <a16:creationId xmlns:a16="http://schemas.microsoft.com/office/drawing/2014/main" id="{3FABA5AF-C34F-4926-870F-E12314CB76E6}"/>
               </a:ext>
             </a:extLst>
           </p:cNvPr>
@@ -16231,7 +16231,7 @@
           <p:cNvPr id="11" name="">
             <a:extLst xmlns:a="http://schemas.openxmlformats.org/drawingml/2006/main">
               <a:ext uri="{FF2B5EF4-FFF2-40B4-BE49-F238E27FC236}">
-                <a16:creationId xmlns:a16="http://schemas.microsoft.com/office/drawing/2014/main" id="{4CF7EE82-EAEC-4EF0-8F28-7ABAFFACE663}"/>
+                <a16:creationId xmlns:a16="http://schemas.microsoft.com/office/drawing/2014/main" id="{CB51D4BD-25B6-4112-B994-3865CC0C58BB}"/>
               </a:ext>
             </a:extLst>
           </p:cNvPr>
@@ -16295,7 +16295,7 @@
           <p:cNvPr id="12" name="">
             <a:extLst xmlns:a="http://schemas.openxmlformats.org/drawingml/2006/main">
               <a:ext uri="{FF2B5EF4-FFF2-40B4-BE49-F238E27FC236}">
-                <a16:creationId xmlns:a16="http://schemas.microsoft.com/office/drawing/2014/main" id="{473E5968-F413-49E8-8A44-9F464FD8D983}"/>
+                <a16:creationId xmlns:a16="http://schemas.microsoft.com/office/drawing/2014/main" id="{5CB7C55D-E422-4269-9AB6-E2725C6CA032}"/>
               </a:ext>
             </a:extLst>
           </p:cNvPr>
@@ -16328,7 +16328,7 @@
           <p:cNvPr id="13" name="">
             <a:extLst xmlns:a="http://schemas.openxmlformats.org/drawingml/2006/main">
               <a:ext uri="{FF2B5EF4-FFF2-40B4-BE49-F238E27FC236}">
-                <a16:creationId xmlns:a16="http://schemas.microsoft.com/office/drawing/2014/main" id="{4B662D04-836D-42CE-AF37-86F0983E7A4F}"/>
+                <a16:creationId xmlns:a16="http://schemas.microsoft.com/office/drawing/2014/main" id="{F73CD337-B198-4D4C-8B82-91AC2815E90F}"/>
               </a:ext>
             </a:extLst>
           </p:cNvPr>
@@ -16392,7 +16392,7 @@
           <p:cNvPr id="14" name="">
             <a:extLst xmlns:a="http://schemas.openxmlformats.org/drawingml/2006/main">
               <a:ext uri="{FF2B5EF4-FFF2-40B4-BE49-F238E27FC236}">
-                <a16:creationId xmlns:a16="http://schemas.microsoft.com/office/drawing/2014/main" id="{8684CFDF-E33C-4E3A-B8AE-162F2F1BDCBE}"/>
+                <a16:creationId xmlns:a16="http://schemas.microsoft.com/office/drawing/2014/main" id="{7901BAAE-7C6B-4035-B9C2-E78403B36368}"/>
               </a:ext>
             </a:extLst>
           </p:cNvPr>
@@ -16425,7 +16425,7 @@
           <p:cNvPr id="15" name="">
             <a:extLst xmlns:a="http://schemas.openxmlformats.org/drawingml/2006/main">
               <a:ext uri="{FF2B5EF4-FFF2-40B4-BE49-F238E27FC236}">
-                <a16:creationId xmlns:a16="http://schemas.microsoft.com/office/drawing/2014/main" id="{6EFB18BE-77F0-461E-9A0D-E0AA4D9A1BEB}"/>
+                <a16:creationId xmlns:a16="http://schemas.microsoft.com/office/drawing/2014/main" id="{F9ED2D13-B058-47DC-A52F-AB12D4DD7FE9}"/>
               </a:ext>
             </a:extLst>
           </p:cNvPr>
@@ -16489,7 +16489,7 @@
           <p:cNvPr id="16" name="">
             <a:extLst xmlns:a="http://schemas.openxmlformats.org/drawingml/2006/main">
               <a:ext uri="{FF2B5EF4-FFF2-40B4-BE49-F238E27FC236}">
-                <a16:creationId xmlns:a16="http://schemas.microsoft.com/office/drawing/2014/main" id="{AC9874C3-8CA2-4BC8-82EC-95D6E4A995DA}"/>
+                <a16:creationId xmlns:a16="http://schemas.microsoft.com/office/drawing/2014/main" id="{61D7A329-7A75-4AE1-801B-9A40C22A0327}"/>
               </a:ext>
             </a:extLst>
           </p:cNvPr>
@@ -16522,7 +16522,7 @@
           <p:cNvPr id="17" name="">
             <a:extLst xmlns:a="http://schemas.openxmlformats.org/drawingml/2006/main">
               <a:ext uri="{FF2B5EF4-FFF2-40B4-BE49-F238E27FC236}">
-                <a16:creationId xmlns:a16="http://schemas.microsoft.com/office/drawing/2014/main" id="{46576680-0A87-4D15-B153-38A614AF08EA}"/>
+                <a16:creationId xmlns:a16="http://schemas.microsoft.com/office/drawing/2014/main" id="{CB790A79-7562-4579-9B04-24CD648D9D34}"/>
               </a:ext>
             </a:extLst>
           </p:cNvPr>
@@ -16586,7 +16586,7 @@
           <p:cNvPr id="18" name="">
             <a:extLst xmlns:a="http://schemas.openxmlformats.org/drawingml/2006/main">
               <a:ext uri="{FF2B5EF4-FFF2-40B4-BE49-F238E27FC236}">
-                <a16:creationId xmlns:a16="http://schemas.microsoft.com/office/drawing/2014/main" id="{5AF82CBD-4B66-442A-9570-43370F1AF6C6}"/>
+                <a16:creationId xmlns:a16="http://schemas.microsoft.com/office/drawing/2014/main" id="{2E12BC35-F85B-4AE8-B8FE-CBDA76B891FD}"/>
               </a:ext>
             </a:extLst>
           </p:cNvPr>
@@ -16650,7 +16650,7 @@
           <p:cNvPr id="19" name="">
             <a:extLst xmlns:a="http://schemas.openxmlformats.org/drawingml/2006/main">
               <a:ext uri="{FF2B5EF4-FFF2-40B4-BE49-F238E27FC236}">
-                <a16:creationId xmlns:a16="http://schemas.microsoft.com/office/drawing/2014/main" id="{6B5173A4-2076-4CAD-B977-CAF5DEC47D84}"/>
+                <a16:creationId xmlns:a16="http://schemas.microsoft.com/office/drawing/2014/main" id="{9BA6C18A-4690-4FDF-BF48-E828A7F54419}"/>
               </a:ext>
             </a:extLst>
           </p:cNvPr>
@@ -16712,7 +16712,7 @@
     </p:spTree>
     <p:extLst>
       <p:ext uri="{BB962C8B-B14F-4D97-AF65-F5344CB8AC3E}">
-        <p14:creationId xmlns:p14="http://schemas.microsoft.com/office/powerpoint/2010/main" val="1256523227"/>
+        <p14:creationId xmlns:p14="http://schemas.microsoft.com/office/powerpoint/2010/main" val="1029035547"/>
       </p:ext>
     </p:extLst>
   </p:cSld>
@@ -16736,7 +16736,7 @@
           <p:cNvPr id="1" name="">
             <a:extLst xmlns:a="http://schemas.openxmlformats.org/drawingml/2006/main">
               <a:ext uri="{FF2B5EF4-FFF2-40B4-BE49-F238E27FC236}">
-                <a16:creationId xmlns:a16="http://schemas.microsoft.com/office/drawing/2014/main" id="{1902E7F3-CEBC-45D5-9ED7-029193689E35}"/>
+                <a16:creationId xmlns:a16="http://schemas.microsoft.com/office/drawing/2014/main" id="{4804EC36-BC04-489E-B8DE-E34866C41E87}"/>
               </a:ext>
             </a:extLst>
           </p:cNvPr>
@@ -16769,7 +16769,7 @@
           <p:cNvPr id="2" name="">
             <a:extLst xmlns:a="http://schemas.openxmlformats.org/drawingml/2006/main">
               <a:ext uri="{FF2B5EF4-FFF2-40B4-BE49-F238E27FC236}">
-                <a16:creationId xmlns:a16="http://schemas.microsoft.com/office/drawing/2014/main" id="{562F53C7-33F9-4603-AF52-AED553597B3C}"/>
+                <a16:creationId xmlns:a16="http://schemas.microsoft.com/office/drawing/2014/main" id="{9159C126-4752-4A07-8633-CCA44C1FF38C}"/>
               </a:ext>
             </a:extLst>
           </p:cNvPr>
@@ -16802,7 +16802,7 @@
           <p:cNvPr id="3" name="">
             <a:extLst xmlns:a="http://schemas.openxmlformats.org/drawingml/2006/main">
               <a:ext uri="{FF2B5EF4-FFF2-40B4-BE49-F238E27FC236}">
-                <a16:creationId xmlns:a16="http://schemas.microsoft.com/office/drawing/2014/main" id="{8941E563-1C2A-4DE8-9452-70E439EAE97F}"/>
+                <a16:creationId xmlns:a16="http://schemas.microsoft.com/office/drawing/2014/main" id="{3E8DB33E-CF2C-459F-839D-F4CA7BF3839A}"/>
               </a:ext>
             </a:extLst>
           </p:cNvPr>
@@ -16866,7 +16866,7 @@
           <p:cNvPr id="4" name="">
             <a:extLst xmlns:a="http://schemas.openxmlformats.org/drawingml/2006/main">
               <a:ext uri="{FF2B5EF4-FFF2-40B4-BE49-F238E27FC236}">
-                <a16:creationId xmlns:a16="http://schemas.microsoft.com/office/drawing/2014/main" id="{C9597100-946A-4FD5-98A2-1C3752A74A47}"/>
+                <a16:creationId xmlns:a16="http://schemas.microsoft.com/office/drawing/2014/main" id="{E67A89E0-9903-4C7C-969E-0C2F767B9D53}"/>
               </a:ext>
             </a:extLst>
           </p:cNvPr>
@@ -16930,7 +16930,7 @@
           <p:cNvPr id="5" name="">
             <a:extLst xmlns:a="http://schemas.openxmlformats.org/drawingml/2006/main">
               <a:ext uri="{FF2B5EF4-FFF2-40B4-BE49-F238E27FC236}">
-                <a16:creationId xmlns:a16="http://schemas.microsoft.com/office/drawing/2014/main" id="{2B4D8033-EED5-4FA3-829E-82E57C121514}"/>
+                <a16:creationId xmlns:a16="http://schemas.microsoft.com/office/drawing/2014/main" id="{86B2B6C8-6803-45F2-8FE6-93D517717A0D}"/>
               </a:ext>
             </a:extLst>
           </p:cNvPr>
@@ -16963,7 +16963,7 @@
           <p:cNvPr id="6" name="">
             <a:extLst xmlns:a="http://schemas.openxmlformats.org/drawingml/2006/main">
               <a:ext uri="{FF2B5EF4-FFF2-40B4-BE49-F238E27FC236}">
-                <a16:creationId xmlns:a16="http://schemas.microsoft.com/office/drawing/2014/main" id="{E5A440DF-4FF2-43D9-B0AE-A9AC69D14584}"/>
+                <a16:creationId xmlns:a16="http://schemas.microsoft.com/office/drawing/2014/main" id="{66612447-D4C4-4587-90F4-6FA954C3F6A0}"/>
               </a:ext>
             </a:extLst>
           </p:cNvPr>
@@ -16996,7 +16996,7 @@
           <p:cNvPr id="7" name="">
             <a:extLst xmlns:a="http://schemas.openxmlformats.org/drawingml/2006/main">
               <a:ext uri="{FF2B5EF4-FFF2-40B4-BE49-F238E27FC236}">
-                <a16:creationId xmlns:a16="http://schemas.microsoft.com/office/drawing/2014/main" id="{AD9F2A81-FDB8-4A93-92EC-1F0932E8DACD}"/>
+                <a16:creationId xmlns:a16="http://schemas.microsoft.com/office/drawing/2014/main" id="{67B239EB-466E-4508-AC94-089D2D6038F3}"/>
               </a:ext>
             </a:extLst>
           </p:cNvPr>
@@ -17060,7 +17060,7 @@
           <p:cNvPr id="8" name="">
             <a:extLst xmlns:a="http://schemas.openxmlformats.org/drawingml/2006/main">
               <a:ext uri="{FF2B5EF4-FFF2-40B4-BE49-F238E27FC236}">
-                <a16:creationId xmlns:a16="http://schemas.microsoft.com/office/drawing/2014/main" id="{BCC9BBF3-5BB6-4025-B679-28F631A4973A}"/>
+                <a16:creationId xmlns:a16="http://schemas.microsoft.com/office/drawing/2014/main" id="{5BE0A217-F5D9-4B06-AAD8-3D7B9D603491}"/>
               </a:ext>
             </a:extLst>
           </p:cNvPr>
@@ -17093,7 +17093,7 @@
           <p:cNvPr id="9" name="">
             <a:extLst xmlns:a="http://schemas.openxmlformats.org/drawingml/2006/main">
               <a:ext uri="{FF2B5EF4-FFF2-40B4-BE49-F238E27FC236}">
-                <a16:creationId xmlns:a16="http://schemas.microsoft.com/office/drawing/2014/main" id="{93A322FE-C12D-4ABF-864E-A1F8D3DA24A0}"/>
+                <a16:creationId xmlns:a16="http://schemas.microsoft.com/office/drawing/2014/main" id="{4C039734-B69E-4852-AD53-5AD4719531CC}"/>
               </a:ext>
             </a:extLst>
           </p:cNvPr>
@@ -17157,7 +17157,7 @@
           <p:cNvPr id="10" name="">
             <a:extLst xmlns:a="http://schemas.openxmlformats.org/drawingml/2006/main">
               <a:ext uri="{FF2B5EF4-FFF2-40B4-BE49-F238E27FC236}">
-                <a16:creationId xmlns:a16="http://schemas.microsoft.com/office/drawing/2014/main" id="{F99BFD94-0C7C-43F8-9FD9-67A18B444725}"/>
+                <a16:creationId xmlns:a16="http://schemas.microsoft.com/office/drawing/2014/main" id="{BFAD4354-669D-4CDA-8464-647B8BFFBC01}"/>
               </a:ext>
             </a:extLst>
           </p:cNvPr>
@@ -17190,7 +17190,7 @@
           <p:cNvPr id="11" name="">
             <a:extLst xmlns:a="http://schemas.openxmlformats.org/drawingml/2006/main">
               <a:ext uri="{FF2B5EF4-FFF2-40B4-BE49-F238E27FC236}">
-                <a16:creationId xmlns:a16="http://schemas.microsoft.com/office/drawing/2014/main" id="{1B78E810-23DD-4E43-BA5B-374B976BF2F2}"/>
+                <a16:creationId xmlns:a16="http://schemas.microsoft.com/office/drawing/2014/main" id="{C416E79B-D524-41DC-985C-609EDE9D0267}"/>
               </a:ext>
             </a:extLst>
           </p:cNvPr>
@@ -17254,7 +17254,7 @@
           <p:cNvPr id="12" name="">
             <a:extLst xmlns:a="http://schemas.openxmlformats.org/drawingml/2006/main">
               <a:ext uri="{FF2B5EF4-FFF2-40B4-BE49-F238E27FC236}">
-                <a16:creationId xmlns:a16="http://schemas.microsoft.com/office/drawing/2014/main" id="{7B6C80BE-27BD-431A-B2EE-650B87EDEE1D}"/>
+                <a16:creationId xmlns:a16="http://schemas.microsoft.com/office/drawing/2014/main" id="{8FEFA705-D6E5-4AF3-9651-096B58101799}"/>
               </a:ext>
             </a:extLst>
           </p:cNvPr>
@@ -17287,7 +17287,7 @@
           <p:cNvPr id="13" name="">
             <a:extLst xmlns:a="http://schemas.openxmlformats.org/drawingml/2006/main">
               <a:ext uri="{FF2B5EF4-FFF2-40B4-BE49-F238E27FC236}">
-                <a16:creationId xmlns:a16="http://schemas.microsoft.com/office/drawing/2014/main" id="{0E808A8D-253D-4D7B-B597-C609E29FB7C7}"/>
+                <a16:creationId xmlns:a16="http://schemas.microsoft.com/office/drawing/2014/main" id="{A608930A-DA5B-4876-8967-FC6B8D3D9BA0}"/>
               </a:ext>
             </a:extLst>
           </p:cNvPr>
@@ -17351,7 +17351,7 @@
           <p:cNvPr id="14" name="">
             <a:extLst xmlns:a="http://schemas.openxmlformats.org/drawingml/2006/main">
               <a:ext uri="{FF2B5EF4-FFF2-40B4-BE49-F238E27FC236}">
-                <a16:creationId xmlns:a16="http://schemas.microsoft.com/office/drawing/2014/main" id="{F64FF8CD-27E0-41C5-BC96-D813A377529C}"/>
+                <a16:creationId xmlns:a16="http://schemas.microsoft.com/office/drawing/2014/main" id="{FA9B9CD6-F931-4857-895C-465E6BD57503}"/>
               </a:ext>
             </a:extLst>
           </p:cNvPr>
@@ -17384,7 +17384,7 @@
           <p:cNvPr id="15" name="">
             <a:extLst xmlns:a="http://schemas.openxmlformats.org/drawingml/2006/main">
               <a:ext uri="{FF2B5EF4-FFF2-40B4-BE49-F238E27FC236}">
-                <a16:creationId xmlns:a16="http://schemas.microsoft.com/office/drawing/2014/main" id="{C7100DFB-946A-49E2-9244-713DE010427F}"/>
+                <a16:creationId xmlns:a16="http://schemas.microsoft.com/office/drawing/2014/main" id="{3CFF6C6F-02D0-4168-8AEE-3498C131391F}"/>
               </a:ext>
             </a:extLst>
           </p:cNvPr>
@@ -17448,7 +17448,7 @@
           <p:cNvPr id="16" name="">
             <a:extLst xmlns:a="http://schemas.openxmlformats.org/drawingml/2006/main">
               <a:ext uri="{FF2B5EF4-FFF2-40B4-BE49-F238E27FC236}">
-                <a16:creationId xmlns:a16="http://schemas.microsoft.com/office/drawing/2014/main" id="{81310FD8-3D26-4E93-972C-7EF50FDF644E}"/>
+                <a16:creationId xmlns:a16="http://schemas.microsoft.com/office/drawing/2014/main" id="{DEE97BE8-C883-4F59-879F-EC857DF32232}"/>
               </a:ext>
             </a:extLst>
           </p:cNvPr>
@@ -17481,7 +17481,7 @@
           <p:cNvPr id="17" name="">
             <a:extLst xmlns:a="http://schemas.openxmlformats.org/drawingml/2006/main">
               <a:ext uri="{FF2B5EF4-FFF2-40B4-BE49-F238E27FC236}">
-                <a16:creationId xmlns:a16="http://schemas.microsoft.com/office/drawing/2014/main" id="{3931F435-C320-4C4E-8AAB-AB6B2CF15592}"/>
+                <a16:creationId xmlns:a16="http://schemas.microsoft.com/office/drawing/2014/main" id="{A6ADE638-7963-479E-8839-E52BD4926542}"/>
               </a:ext>
             </a:extLst>
           </p:cNvPr>
@@ -17545,7 +17545,7 @@
           <p:cNvPr id="18" name="">
             <a:extLst xmlns:a="http://schemas.openxmlformats.org/drawingml/2006/main">
               <a:ext uri="{FF2B5EF4-FFF2-40B4-BE49-F238E27FC236}">
-                <a16:creationId xmlns:a16="http://schemas.microsoft.com/office/drawing/2014/main" id="{9B74E966-A8F2-44FD-8493-0A6776788DED}"/>
+                <a16:creationId xmlns:a16="http://schemas.microsoft.com/office/drawing/2014/main" id="{2386437D-244F-4093-83D6-82A707BFFC85}"/>
               </a:ext>
             </a:extLst>
           </p:cNvPr>
@@ -17578,7 +17578,7 @@
           <p:cNvPr id="19" name="">
             <a:extLst xmlns:a="http://schemas.openxmlformats.org/drawingml/2006/main">
               <a:ext uri="{FF2B5EF4-FFF2-40B4-BE49-F238E27FC236}">
-                <a16:creationId xmlns:a16="http://schemas.microsoft.com/office/drawing/2014/main" id="{1678FD03-3657-46C9-9C31-951AD30A1330}"/>
+                <a16:creationId xmlns:a16="http://schemas.microsoft.com/office/drawing/2014/main" id="{2C399B87-FF11-4706-BC54-68AE9B27AC18}"/>
               </a:ext>
             </a:extLst>
           </p:cNvPr>
@@ -17642,7 +17642,7 @@
           <p:cNvPr id="20" name="">
             <a:extLst xmlns:a="http://schemas.openxmlformats.org/drawingml/2006/main">
               <a:ext uri="{FF2B5EF4-FFF2-40B4-BE49-F238E27FC236}">
-                <a16:creationId xmlns:a16="http://schemas.microsoft.com/office/drawing/2014/main" id="{42853712-61CD-450A-B7F4-D94D33151AA7}"/>
+                <a16:creationId xmlns:a16="http://schemas.microsoft.com/office/drawing/2014/main" id="{3E6AE5F1-4126-4F95-9975-6D4C8227CC29}"/>
               </a:ext>
             </a:extLst>
           </p:cNvPr>
@@ -17706,7 +17706,7 @@
           <p:cNvPr id="21" name="">
             <a:extLst xmlns:a="http://schemas.openxmlformats.org/drawingml/2006/main">
               <a:ext uri="{FF2B5EF4-FFF2-40B4-BE49-F238E27FC236}">
-                <a16:creationId xmlns:a16="http://schemas.microsoft.com/office/drawing/2014/main" id="{88BD2A32-CC66-44CE-9687-42DC322DE716}"/>
+                <a16:creationId xmlns:a16="http://schemas.microsoft.com/office/drawing/2014/main" id="{F6F02777-B0A4-4F6C-B592-EA50D465B780}"/>
               </a:ext>
             </a:extLst>
           </p:cNvPr>
@@ -17768,7 +17768,7 @@
     </p:spTree>
     <p:extLst>
       <p:ext uri="{BB962C8B-B14F-4D97-AF65-F5344CB8AC3E}">
-        <p14:creationId xmlns:p14="http://schemas.microsoft.com/office/powerpoint/2010/main" val="1911543299"/>
+        <p14:creationId xmlns:p14="http://schemas.microsoft.com/office/powerpoint/2010/main" val="246963305"/>
       </p:ext>
     </p:extLst>
   </p:cSld>
@@ -17792,7 +17792,7 @@
           <p:cNvPr id="1" name="">
             <a:extLst xmlns:a="http://schemas.openxmlformats.org/drawingml/2006/main">
               <a:ext uri="{FF2B5EF4-FFF2-40B4-BE49-F238E27FC236}">
-                <a16:creationId xmlns:a16="http://schemas.microsoft.com/office/drawing/2014/main" id="{AC16F2A1-0042-4ACD-94F2-2AD612A89D47}"/>
+                <a16:creationId xmlns:a16="http://schemas.microsoft.com/office/drawing/2014/main" id="{1AA396C3-5CE7-4123-BDE1-B75521B6F4CD}"/>
               </a:ext>
             </a:extLst>
           </p:cNvPr>
@@ -17825,7 +17825,7 @@
           <p:cNvPr id="2" name="">
             <a:extLst xmlns:a="http://schemas.openxmlformats.org/drawingml/2006/main">
               <a:ext uri="{FF2B5EF4-FFF2-40B4-BE49-F238E27FC236}">
-                <a16:creationId xmlns:a16="http://schemas.microsoft.com/office/drawing/2014/main" id="{171C7CF7-1C62-4A21-9B0C-4CA7A2F08276}"/>
+                <a16:creationId xmlns:a16="http://schemas.microsoft.com/office/drawing/2014/main" id="{EB6C2ED8-B515-4B1C-A5B6-4C58F5948442}"/>
               </a:ext>
             </a:extLst>
           </p:cNvPr>
@@ -17858,7 +17858,7 @@
           <p:cNvPr id="3" name="">
             <a:extLst xmlns:a="http://schemas.openxmlformats.org/drawingml/2006/main">
               <a:ext uri="{FF2B5EF4-FFF2-40B4-BE49-F238E27FC236}">
-                <a16:creationId xmlns:a16="http://schemas.microsoft.com/office/drawing/2014/main" id="{017E93EF-D9A0-4C72-B0D4-C8064124A068}"/>
+                <a16:creationId xmlns:a16="http://schemas.microsoft.com/office/drawing/2014/main" id="{7CEB680D-DCA6-44B7-981F-B96B748A3320}"/>
               </a:ext>
             </a:extLst>
           </p:cNvPr>
@@ -17922,7 +17922,7 @@
           <p:cNvPr id="4" name="">
             <a:extLst xmlns:a="http://schemas.openxmlformats.org/drawingml/2006/main">
               <a:ext uri="{FF2B5EF4-FFF2-40B4-BE49-F238E27FC236}">
-                <a16:creationId xmlns:a16="http://schemas.microsoft.com/office/drawing/2014/main" id="{61BA7C6B-400F-49A3-B254-841BF3E8A2C2}"/>
+                <a16:creationId xmlns:a16="http://schemas.microsoft.com/office/drawing/2014/main" id="{327B7C1E-E3FB-4C45-B1B6-6FA0DBB32368}"/>
               </a:ext>
             </a:extLst>
           </p:cNvPr>
@@ -17976,7 +17976,7 @@
                 <a:ea typeface="Malgun Gothic"/>
                 <a:cs typeface="Malgun Gothic"/>
               </a:rPr>
-              <a:t>위치와 위험 타일이 다음 의사결정을 구성</a:t>
+              <a:t>플레이어 MDP와 보스 MDP를 같은 decision step에서 결합</a:t>
             </a:r>
           </a:p>
         </p:txBody>
@@ -17986,7 +17986,7 @@
           <p:cNvPr id="5" name="">
             <a:extLst xmlns:a="http://schemas.openxmlformats.org/drawingml/2006/main">
               <a:ext uri="{FF2B5EF4-FFF2-40B4-BE49-F238E27FC236}">
-                <a16:creationId xmlns:a16="http://schemas.microsoft.com/office/drawing/2014/main" id="{4179CB21-BB46-403B-8B82-4C94E1EEB7F5}"/>
+                <a16:creationId xmlns:a16="http://schemas.microsoft.com/office/drawing/2014/main" id="{FE442AEF-4D93-4360-A925-980C112C3047}"/>
               </a:ext>
             </a:extLst>
           </p:cNvPr>
@@ -18019,7 +18019,7 @@
           <p:cNvPr id="6" name="">
             <a:extLst xmlns:a="http://schemas.openxmlformats.org/drawingml/2006/main">
               <a:ext uri="{FF2B5EF4-FFF2-40B4-BE49-F238E27FC236}">
-                <a16:creationId xmlns:a16="http://schemas.microsoft.com/office/drawing/2014/main" id="{D2E2D35E-5159-4008-AE8A-DCDCFC64A44B}"/>
+                <a16:creationId xmlns:a16="http://schemas.microsoft.com/office/drawing/2014/main" id="{E42E1963-4296-4403-9677-3FFEA29D4B11}"/>
               </a:ext>
             </a:extLst>
           </p:cNvPr>
@@ -18073,7 +18073,7 @@
                 <a:ea typeface="Malgun Gothic"/>
                 <a:cs typeface="Malgun Gothic"/>
               </a:rPr>
-              <a:t>State</a:t>
+              <a:t>플레이어 MDP</a:t>
             </a:r>
           </a:p>
         </p:txBody>
@@ -18083,7 +18083,7 @@
           <p:cNvPr id="7" name="">
             <a:extLst xmlns:a="http://schemas.openxmlformats.org/drawingml/2006/main">
               <a:ext uri="{FF2B5EF4-FFF2-40B4-BE49-F238E27FC236}">
-                <a16:creationId xmlns:a16="http://schemas.microsoft.com/office/drawing/2014/main" id="{260AB6E3-9FD8-40FF-98AD-BF5B65F30FC6}"/>
+                <a16:creationId xmlns:a16="http://schemas.microsoft.com/office/drawing/2014/main" id="{0582FE3E-5033-47B9-BC07-B18580790225}"/>
               </a:ext>
             </a:extLst>
           </p:cNvPr>
@@ -18116,7 +18116,7 @@
           <p:cNvPr id="8" name="">
             <a:extLst xmlns:a="http://schemas.openxmlformats.org/drawingml/2006/main">
               <a:ext uri="{FF2B5EF4-FFF2-40B4-BE49-F238E27FC236}">
-                <a16:creationId xmlns:a16="http://schemas.microsoft.com/office/drawing/2014/main" id="{5BCD381F-3995-415C-8D68-C46803EEDE8E}"/>
+                <a16:creationId xmlns:a16="http://schemas.microsoft.com/office/drawing/2014/main" id="{E02B08EF-4E78-4945-987C-F1B56648344D}"/>
               </a:ext>
             </a:extLst>
           </p:cNvPr>
@@ -18170,7 +18170,7 @@
                 <a:ea typeface="Malgun Gothic"/>
                 <a:cs typeface="Malgun Gothic"/>
               </a:rPr>
-              <a:t>플레이어 위치</a:t>
+              <a:t>State 위치 방향 체력</a:t>
             </a:r>
           </a:p>
         </p:txBody>
@@ -18180,7 +18180,7 @@
           <p:cNvPr id="9" name="">
             <a:extLst xmlns:a="http://schemas.openxmlformats.org/drawingml/2006/main">
               <a:ext uri="{FF2B5EF4-FFF2-40B4-BE49-F238E27FC236}">
-                <a16:creationId xmlns:a16="http://schemas.microsoft.com/office/drawing/2014/main" id="{F63F611C-37FF-4247-A540-D0834E150EE4}"/>
+                <a16:creationId xmlns:a16="http://schemas.microsoft.com/office/drawing/2014/main" id="{90D575AD-8C2C-4A43-8010-80F4B3CA954A}"/>
               </a:ext>
             </a:extLst>
           </p:cNvPr>
@@ -18213,7 +18213,7 @@
           <p:cNvPr id="10" name="">
             <a:extLst xmlns:a="http://schemas.openxmlformats.org/drawingml/2006/main">
               <a:ext uri="{FF2B5EF4-FFF2-40B4-BE49-F238E27FC236}">
-                <a16:creationId xmlns:a16="http://schemas.microsoft.com/office/drawing/2014/main" id="{EBE93B52-6D58-4A41-9C57-6AFE371BA3BF}"/>
+                <a16:creationId xmlns:a16="http://schemas.microsoft.com/office/drawing/2014/main" id="{8B60BCB6-CFBC-4F1B-B533-7F890233599E}"/>
               </a:ext>
             </a:extLst>
           </p:cNvPr>
@@ -18267,7 +18267,7 @@
                 <a:ea typeface="Malgun Gothic"/>
                 <a:cs typeface="Malgun Gothic"/>
               </a:rPr>
-              <a:t>보스 위치 및 방향</a:t>
+              <a:t>State 공격 가능 범위</a:t>
             </a:r>
           </a:p>
         </p:txBody>
@@ -18277,7 +18277,7 @@
           <p:cNvPr id="11" name="">
             <a:extLst xmlns:a="http://schemas.openxmlformats.org/drawingml/2006/main">
               <a:ext uri="{FF2B5EF4-FFF2-40B4-BE49-F238E27FC236}">
-                <a16:creationId xmlns:a16="http://schemas.microsoft.com/office/drawing/2014/main" id="{7A9F8D60-1272-41BD-AD49-8A02FAB4CB3D}"/>
+                <a16:creationId xmlns:a16="http://schemas.microsoft.com/office/drawing/2014/main" id="{81E29C8E-77A6-4B4B-89A2-DA38D4AD9968}"/>
               </a:ext>
             </a:extLst>
           </p:cNvPr>
@@ -18310,7 +18310,7 @@
           <p:cNvPr id="12" name="">
             <a:extLst xmlns:a="http://schemas.openxmlformats.org/drawingml/2006/main">
               <a:ext uri="{FF2B5EF4-FFF2-40B4-BE49-F238E27FC236}">
-                <a16:creationId xmlns:a16="http://schemas.microsoft.com/office/drawing/2014/main" id="{ED713F14-CFA5-47F4-AF5B-A5C98ECD272A}"/>
+                <a16:creationId xmlns:a16="http://schemas.microsoft.com/office/drawing/2014/main" id="{B82DB04B-6950-4BC0-8BAA-59972CCC15DD}"/>
               </a:ext>
             </a:extLst>
           </p:cNvPr>
@@ -18364,7 +18364,7 @@
                 <a:ea typeface="Malgun Gothic"/>
                 <a:cs typeface="Malgun Gothic"/>
               </a:rPr>
-              <a:t>warning damage tile</a:t>
+              <a:t>Action move [5]</a:t>
             </a:r>
           </a:p>
         </p:txBody>
@@ -18374,7 +18374,7 @@
           <p:cNvPr id="13" name="">
             <a:extLst xmlns:a="http://schemas.openxmlformats.org/drawingml/2006/main">
               <a:ext uri="{FF2B5EF4-FFF2-40B4-BE49-F238E27FC236}">
-                <a16:creationId xmlns:a16="http://schemas.microsoft.com/office/drawing/2014/main" id="{9600FE4E-06F3-44C8-9E57-36D57ADEA6B9}"/>
+                <a16:creationId xmlns:a16="http://schemas.microsoft.com/office/drawing/2014/main" id="{53F7C4D9-6360-4AB6-BDA8-62086E13ACB7}"/>
               </a:ext>
             </a:extLst>
           </p:cNvPr>
@@ -18407,7 +18407,7 @@
           <p:cNvPr id="14" name="">
             <a:extLst xmlns:a="http://schemas.openxmlformats.org/drawingml/2006/main">
               <a:ext uri="{FF2B5EF4-FFF2-40B4-BE49-F238E27FC236}">
-                <a16:creationId xmlns:a16="http://schemas.microsoft.com/office/drawing/2014/main" id="{EDA34A87-F175-4C39-BF41-6836759847E7}"/>
+                <a16:creationId xmlns:a16="http://schemas.microsoft.com/office/drawing/2014/main" id="{6882B380-BF3B-46D0-AA94-793D74521D70}"/>
               </a:ext>
             </a:extLst>
           </p:cNvPr>
@@ -18461,7 +18461,7 @@
                 <a:ea typeface="Malgun Gothic"/>
                 <a:cs typeface="Malgun Gothic"/>
               </a:rPr>
-              <a:t>MarkATK visible cue</a:t>
+              <a:t>Action attack [2]</a:t>
             </a:r>
           </a:p>
         </p:txBody>
@@ -18471,7 +18471,7 @@
           <p:cNvPr id="15" name="">
             <a:extLst xmlns:a="http://schemas.openxmlformats.org/drawingml/2006/main">
               <a:ext uri="{FF2B5EF4-FFF2-40B4-BE49-F238E27FC236}">
-                <a16:creationId xmlns:a16="http://schemas.microsoft.com/office/drawing/2014/main" id="{893DFB92-D499-4044-8E0A-AFF70B62FBAC}"/>
+                <a16:creationId xmlns:a16="http://schemas.microsoft.com/office/drawing/2014/main" id="{23798445-2008-4FA2-A9EC-6D0DDFE14935}"/>
               </a:ext>
             </a:extLst>
           </p:cNvPr>
@@ -18504,7 +18504,7 @@
           <p:cNvPr id="16" name="">
             <a:extLst xmlns:a="http://schemas.openxmlformats.org/drawingml/2006/main">
               <a:ext uri="{FF2B5EF4-FFF2-40B4-BE49-F238E27FC236}">
-                <a16:creationId xmlns:a16="http://schemas.microsoft.com/office/drawing/2014/main" id="{11B00419-BED4-45C4-A280-3166AE390F83}"/>
+                <a16:creationId xmlns:a16="http://schemas.microsoft.com/office/drawing/2014/main" id="{4E034748-34A1-4E31-B8E2-9A351B7C8575}"/>
               </a:ext>
             </a:extLst>
           </p:cNvPr>
@@ -18558,7 +18558,7 @@
                 <a:ea typeface="Malgun Gothic"/>
                 <a:cs typeface="Malgun Gothic"/>
               </a:rPr>
-              <a:t>Phase2 sweep history</a:t>
+              <a:t>Transition 이동 공격 피격</a:t>
             </a:r>
           </a:p>
         </p:txBody>
@@ -18568,7 +18568,104 @@
           <p:cNvPr id="17" name="">
             <a:extLst xmlns:a="http://schemas.openxmlformats.org/drawingml/2006/main">
               <a:ext uri="{FF2B5EF4-FFF2-40B4-BE49-F238E27FC236}">
-                <a16:creationId xmlns:a16="http://schemas.microsoft.com/office/drawing/2014/main" id="{C152251D-8DC3-4BEC-80BB-92B5C7CC16B2}"/>
+                <a16:creationId xmlns:a16="http://schemas.microsoft.com/office/drawing/2014/main" id="{C7A19462-2C3B-4352-9CAA-E17B2EF757A2}"/>
+              </a:ext>
+            </a:extLst>
+          </p:cNvPr>
+          <p:cNvSpPr>
+            <a:spLocks xmlns:a="http://schemas.openxmlformats.org/drawingml/2006/main" noGrp="1"/>
+          </p:cNvSpPr>
+          <p:nvPr/>
+        </p:nvSpPr>
+        <p:spPr>
+          <a:xfrm xmlns:a="http://schemas.openxmlformats.org/drawingml/2006/main">
+            <a:off x="704850" y="3819525"/>
+            <a:ext cx="95250" cy="95250"/>
+          </a:xfrm>
+          <a:prstGeom xmlns:a="http://schemas.openxmlformats.org/drawingml/2006/main" prst="rect">
+            <a:avLst/>
+          </a:prstGeom>
+          <a:solidFill xmlns:a="http://schemas.openxmlformats.org/drawingml/2006/main">
+            <a:srgbClr val="2F6FAD"/>
+          </a:solidFill>
+          <a:ln xmlns:a="http://schemas.openxmlformats.org/drawingml/2006/main" w="0">
+            <a:solidFill>
+              <a:srgbClr val="2F6FAD"/>
+            </a:solidFill>
+            <a:prstDash val="solid"/>
+          </a:ln>
+        </p:spPr>
+      </p:sp>
+      <p:sp>
+        <p:nvSpPr>
+          <p:cNvPr id="18" name="">
+            <a:extLst xmlns:a="http://schemas.openxmlformats.org/drawingml/2006/main">
+              <a:ext uri="{FF2B5EF4-FFF2-40B4-BE49-F238E27FC236}">
+                <a16:creationId xmlns:a16="http://schemas.microsoft.com/office/drawing/2014/main" id="{D1F10951-6629-4487-A1FD-AF37A3F7A6B1}"/>
+              </a:ext>
+            </a:extLst>
+          </p:cNvPr>
+          <p:cNvSpPr>
+            <a:spLocks xmlns:a="http://schemas.openxmlformats.org/drawingml/2006/main" noGrp="1"/>
+          </p:cNvSpPr>
+          <p:nvPr/>
+        </p:nvSpPr>
+        <p:spPr>
+          <a:xfrm xmlns:a="http://schemas.openxmlformats.org/drawingml/2006/main">
+            <a:off x="914400" y="3733800"/>
+            <a:ext cx="4552950" cy="361950"/>
+          </a:xfrm>
+          <a:prstGeom xmlns:a="http://schemas.openxmlformats.org/drawingml/2006/main" prst="rect">
+            <a:avLst/>
+          </a:prstGeom>
+          <a:solidFill xmlns:a="http://schemas.openxmlformats.org/drawingml/2006/main">
+            <a:srgbClr val="FFFFFF">
+              <a:alpha val="0"/>
+            </a:srgbClr>
+          </a:solidFill>
+          <a:ln xmlns:a="http://schemas.openxmlformats.org/drawingml/2006/main" w="0">
+            <a:solidFill>
+              <a:srgbClr val="FFFFFF">
+                <a:alpha val="0"/>
+              </a:srgbClr>
+            </a:solidFill>
+            <a:prstDash val="solid"/>
+          </a:ln>
+        </p:spPr>
+        <p:txBody>
+          <a:bodyPr xmlns:a="http://schemas.openxmlformats.org/drawingml/2006/main" lIns="0" tIns="0" rIns="38100" bIns="0" anchor="t"/>
+          <a:lstStyle xmlns:a="http://schemas.openxmlformats.org/drawingml/2006/main"/>
+          <a:p xmlns:a="http://schemas.openxmlformats.org/drawingml/2006/main">
+            <a:pPr algn="l">
+              <a:defRPr sz="1575" b="0">
+                <a:solidFill>
+                  <a:srgbClr val="1F2933"/>
+                </a:solidFill>
+                <a:latin typeface="Malgun Gothic"/>
+                <a:ea typeface="Malgun Gothic"/>
+                <a:cs typeface="Malgun Gothic"/>
+              </a:defRPr>
+            </a:pPr>
+            <a:r>
+              <a:rPr sz="1575" b="0">
+                <a:solidFill>
+                  <a:srgbClr val="1F2933"/>
+                </a:solidFill>
+                <a:latin typeface="Malgun Gothic"/>
+                <a:ea typeface="Malgun Gothic"/>
+                <a:cs typeface="Malgun Gothic"/>
+              </a:rPr>
+              <a:t>Termination player_dead</a:t>
+            </a:r>
+          </a:p>
+        </p:txBody>
+      </p:sp>
+      <p:sp>
+        <p:nvSpPr>
+          <p:cNvPr id="19" name="">
+            <a:extLst xmlns:a="http://schemas.openxmlformats.org/drawingml/2006/main">
+              <a:ext uri="{FF2B5EF4-FFF2-40B4-BE49-F238E27FC236}">
+                <a16:creationId xmlns:a16="http://schemas.microsoft.com/office/drawing/2014/main" id="{49D46C93-4A74-44F6-AD91-130A22EC2FE6}"/>
               </a:ext>
             </a:extLst>
           </p:cNvPr>
@@ -18622,17 +18719,17 @@
                 <a:ea typeface="Malgun Gothic"/>
                 <a:cs typeface="Malgun Gothic"/>
               </a:rPr>
-              <a:t>Action Reward Termination</a:t>
+              <a:t>보스 MDP</a:t>
             </a:r>
           </a:p>
         </p:txBody>
       </p:sp>
       <p:sp>
         <p:nvSpPr>
-          <p:cNvPr id="18" name="">
-            <a:extLst xmlns:a="http://schemas.openxmlformats.org/drawingml/2006/main">
-              <a:ext uri="{FF2B5EF4-FFF2-40B4-BE49-F238E27FC236}">
-                <a16:creationId xmlns:a16="http://schemas.microsoft.com/office/drawing/2014/main" id="{C470A6C7-01D0-4519-A477-847551D0D5BC}"/>
+          <p:cNvPr id="20" name="">
+            <a:extLst xmlns:a="http://schemas.openxmlformats.org/drawingml/2006/main">
+              <a:ext uri="{FF2B5EF4-FFF2-40B4-BE49-F238E27FC236}">
+                <a16:creationId xmlns:a16="http://schemas.microsoft.com/office/drawing/2014/main" id="{CAE9759F-8106-4D21-BCD8-6268FBC668F0}"/>
               </a:ext>
             </a:extLst>
           </p:cNvPr>
@@ -18662,10 +18759,10 @@
       </p:sp>
       <p:sp>
         <p:nvSpPr>
-          <p:cNvPr id="19" name="">
-            <a:extLst xmlns:a="http://schemas.openxmlformats.org/drawingml/2006/main">
-              <a:ext uri="{FF2B5EF4-FFF2-40B4-BE49-F238E27FC236}">
-                <a16:creationId xmlns:a16="http://schemas.microsoft.com/office/drawing/2014/main" id="{B96117F0-085B-4596-BF13-DF5FFA7B4552}"/>
+          <p:cNvPr id="21" name="">
+            <a:extLst xmlns:a="http://schemas.openxmlformats.org/drawingml/2006/main">
+              <a:ext uri="{FF2B5EF4-FFF2-40B4-BE49-F238E27FC236}">
+                <a16:creationId xmlns:a16="http://schemas.microsoft.com/office/drawing/2014/main" id="{C3625769-A080-4165-889B-3623F81B1514}"/>
               </a:ext>
             </a:extLst>
           </p:cNvPr>
@@ -18719,17 +18816,17 @@
                 <a:ea typeface="Malgun Gothic"/>
                 <a:cs typeface="Malgun Gothic"/>
               </a:rPr>
-              <a:t>move [5]</a:t>
+              <a:t>State 위치 방향 HP phase</a:t>
             </a:r>
           </a:p>
         </p:txBody>
       </p:sp>
       <p:sp>
         <p:nvSpPr>
-          <p:cNvPr id="20" name="">
-            <a:extLst xmlns:a="http://schemas.openxmlformats.org/drawingml/2006/main">
-              <a:ext uri="{FF2B5EF4-FFF2-40B4-BE49-F238E27FC236}">
-                <a16:creationId xmlns:a16="http://schemas.microsoft.com/office/drawing/2014/main" id="{A8E5D597-96F9-4D22-95D6-3E8C44E68F16}"/>
+          <p:cNvPr id="22" name="">
+            <a:extLst xmlns:a="http://schemas.openxmlformats.org/drawingml/2006/main">
+              <a:ext uri="{FF2B5EF4-FFF2-40B4-BE49-F238E27FC236}">
+                <a16:creationId xmlns:a16="http://schemas.microsoft.com/office/drawing/2014/main" id="{E5FA8355-9427-4D0A-9EB6-3C65EC3F9A55}"/>
               </a:ext>
             </a:extLst>
           </p:cNvPr>
@@ -18759,10 +18856,10 @@
       </p:sp>
       <p:sp>
         <p:nvSpPr>
-          <p:cNvPr id="21" name="">
-            <a:extLst xmlns:a="http://schemas.openxmlformats.org/drawingml/2006/main">
-              <a:ext uri="{FF2B5EF4-FFF2-40B4-BE49-F238E27FC236}">
-                <a16:creationId xmlns:a16="http://schemas.microsoft.com/office/drawing/2014/main" id="{AE06C150-BE3E-485D-9E49-D5F7878A4F7F}"/>
+          <p:cNvPr id="23" name="">
+            <a:extLst xmlns:a="http://schemas.openxmlformats.org/drawingml/2006/main">
+              <a:ext uri="{FF2B5EF4-FFF2-40B4-BE49-F238E27FC236}">
+                <a16:creationId xmlns:a16="http://schemas.microsoft.com/office/drawing/2014/main" id="{9984FBB7-4EED-4CA6-BB2D-5C42C737F898}"/>
               </a:ext>
             </a:extLst>
           </p:cNvPr>
@@ -18816,17 +18913,17 @@
                 <a:ea typeface="Malgun Gothic"/>
                 <a:cs typeface="Malgun Gothic"/>
               </a:rPr>
-              <a:t>attack [2]</a:t>
+              <a:t>State pattern warning damage</a:t>
             </a:r>
           </a:p>
         </p:txBody>
       </p:sp>
       <p:sp>
         <p:nvSpPr>
-          <p:cNvPr id="22" name="">
-            <a:extLst xmlns:a="http://schemas.openxmlformats.org/drawingml/2006/main">
-              <a:ext uri="{FF2B5EF4-FFF2-40B4-BE49-F238E27FC236}">
-                <a16:creationId xmlns:a16="http://schemas.microsoft.com/office/drawing/2014/main" id="{8E7656DE-486A-455C-9CC4-5C8BC9440F5F}"/>
+          <p:cNvPr id="24" name="">
+            <a:extLst xmlns:a="http://schemas.openxmlformats.org/drawingml/2006/main">
+              <a:ext uri="{FF2B5EF4-FFF2-40B4-BE49-F238E27FC236}">
+                <a16:creationId xmlns:a16="http://schemas.microsoft.com/office/drawing/2014/main" id="{89B01A19-4AA1-4D20-9FE2-EBEFEDA5D2F7}"/>
               </a:ext>
             </a:extLst>
           </p:cNvPr>
@@ -18856,10 +18953,10 @@
       </p:sp>
       <p:sp>
         <p:nvSpPr>
-          <p:cNvPr id="23" name="">
-            <a:extLst xmlns:a="http://schemas.openxmlformats.org/drawingml/2006/main">
-              <a:ext uri="{FF2B5EF4-FFF2-40B4-BE49-F238E27FC236}">
-                <a16:creationId xmlns:a16="http://schemas.microsoft.com/office/drawing/2014/main" id="{7AC88DAF-DD63-4EF2-A582-19AA47E16038}"/>
+          <p:cNvPr id="25" name="">
+            <a:extLst xmlns:a="http://schemas.openxmlformats.org/drawingml/2006/main">
+              <a:ext uri="{FF2B5EF4-FFF2-40B4-BE49-F238E27FC236}">
+                <a16:creationId xmlns:a16="http://schemas.microsoft.com/office/drawing/2014/main" id="{85FEF42F-29B4-44EE-9A2F-C959B60BED44}"/>
               </a:ext>
             </a:extLst>
           </p:cNvPr>
@@ -18913,17 +19010,17 @@
                 <a:ea typeface="Malgun Gothic"/>
                 <a:cs typeface="Malgun Gothic"/>
               </a:rPr>
-              <a:t>HP 감소 및 처치 보상</a:t>
+              <a:t>State MarkATK real fake cue</a:t>
             </a:r>
           </a:p>
         </p:txBody>
       </p:sp>
       <p:sp>
         <p:nvSpPr>
-          <p:cNvPr id="24" name="">
-            <a:extLst xmlns:a="http://schemas.openxmlformats.org/drawingml/2006/main">
-              <a:ext uri="{FF2B5EF4-FFF2-40B4-BE49-F238E27FC236}">
-                <a16:creationId xmlns:a16="http://schemas.microsoft.com/office/drawing/2014/main" id="{F71E432E-0FBD-4FD3-AEEA-EA262DE9598E}"/>
+          <p:cNvPr id="26" name="">
+            <a:extLst xmlns:a="http://schemas.openxmlformats.org/drawingml/2006/main">
+              <a:ext uri="{FF2B5EF4-FFF2-40B4-BE49-F238E27FC236}">
+                <a16:creationId xmlns:a16="http://schemas.microsoft.com/office/drawing/2014/main" id="{2BEC6F8C-8E05-4EB1-91DD-F85DE750ABED}"/>
               </a:ext>
             </a:extLst>
           </p:cNvPr>
@@ -18953,10 +19050,10 @@
       </p:sp>
       <p:sp>
         <p:nvSpPr>
-          <p:cNvPr id="25" name="">
-            <a:extLst xmlns:a="http://schemas.openxmlformats.org/drawingml/2006/main">
-              <a:ext uri="{FF2B5EF4-FFF2-40B4-BE49-F238E27FC236}">
-                <a16:creationId xmlns:a16="http://schemas.microsoft.com/office/drawing/2014/main" id="{1E98E710-A327-44F4-BCC6-3E269777686F}"/>
+          <p:cNvPr id="27" name="">
+            <a:extLst xmlns:a="http://schemas.openxmlformats.org/drawingml/2006/main">
+              <a:ext uri="{FF2B5EF4-FFF2-40B4-BE49-F238E27FC236}">
+                <a16:creationId xmlns:a16="http://schemas.microsoft.com/office/drawing/2014/main" id="{956F900E-3786-4453-B68F-90B5FE03C35E}"/>
               </a:ext>
             </a:extLst>
           </p:cNvPr>
@@ -19010,17 +19107,17 @@
                 <a:ea typeface="Malgun Gothic"/>
                 <a:cs typeface="Malgun Gothic"/>
               </a:rPr>
-              <a:t>피격 사망 위험 패널티</a:t>
+              <a:t>Transition phase pattern 진행</a:t>
             </a:r>
           </a:p>
         </p:txBody>
       </p:sp>
       <p:sp>
         <p:nvSpPr>
-          <p:cNvPr id="26" name="">
-            <a:extLst xmlns:a="http://schemas.openxmlformats.org/drawingml/2006/main">
-              <a:ext uri="{FF2B5EF4-FFF2-40B4-BE49-F238E27FC236}">
-                <a16:creationId xmlns:a16="http://schemas.microsoft.com/office/drawing/2014/main" id="{869A5B67-B050-4071-976C-885E0B4A380B}"/>
+          <p:cNvPr id="28" name="">
+            <a:extLst xmlns:a="http://schemas.openxmlformats.org/drawingml/2006/main">
+              <a:ext uri="{FF2B5EF4-FFF2-40B4-BE49-F238E27FC236}">
+                <a16:creationId xmlns:a16="http://schemas.microsoft.com/office/drawing/2014/main" id="{D7C247EF-47B1-41DE-9575-B5F9389197ED}"/>
               </a:ext>
             </a:extLst>
           </p:cNvPr>
@@ -19050,10 +19147,10 @@
       </p:sp>
       <p:sp>
         <p:nvSpPr>
-          <p:cNvPr id="27" name="">
-            <a:extLst xmlns:a="http://schemas.openxmlformats.org/drawingml/2006/main">
-              <a:ext uri="{FF2B5EF4-FFF2-40B4-BE49-F238E27FC236}">
-                <a16:creationId xmlns:a16="http://schemas.microsoft.com/office/drawing/2014/main" id="{AD1B12C0-839F-4971-828A-E0BDC6FAE109}"/>
+          <p:cNvPr id="29" name="">
+            <a:extLst xmlns:a="http://schemas.openxmlformats.org/drawingml/2006/main">
+              <a:ext uri="{FF2B5EF4-FFF2-40B4-BE49-F238E27FC236}">
+                <a16:creationId xmlns:a16="http://schemas.microsoft.com/office/drawing/2014/main" id="{EDF437A5-926E-4734-B363-6FDAFC0C2A0D}"/>
               </a:ext>
             </a:extLst>
           </p:cNvPr>
@@ -19107,17 +19204,114 @@
                 <a:ea typeface="Malgun Gothic"/>
                 <a:cs typeface="Malgun Gothic"/>
               </a:rPr>
-              <a:t>boss_dead player_dead timeout</a:t>
+              <a:t>Transition HP 감소</a:t>
             </a:r>
           </a:p>
         </p:txBody>
       </p:sp>
       <p:sp>
         <p:nvSpPr>
-          <p:cNvPr id="28" name="">
-            <a:extLst xmlns:a="http://schemas.openxmlformats.org/drawingml/2006/main">
-              <a:ext uri="{FF2B5EF4-FFF2-40B4-BE49-F238E27FC236}">
-                <a16:creationId xmlns:a16="http://schemas.microsoft.com/office/drawing/2014/main" id="{263CDE27-150C-424D-BE95-455D8BD73D11}"/>
+          <p:cNvPr id="30" name="">
+            <a:extLst xmlns:a="http://schemas.openxmlformats.org/drawingml/2006/main">
+              <a:ext uri="{FF2B5EF4-FFF2-40B4-BE49-F238E27FC236}">
+                <a16:creationId xmlns:a16="http://schemas.microsoft.com/office/drawing/2014/main" id="{26EEB6E2-1D50-45A4-850D-687FA3BC3747}"/>
+              </a:ext>
+            </a:extLst>
+          </p:cNvPr>
+          <p:cNvSpPr>
+            <a:spLocks xmlns:a="http://schemas.openxmlformats.org/drawingml/2006/main" noGrp="1"/>
+          </p:cNvSpPr>
+          <p:nvPr/>
+        </p:nvSpPr>
+        <p:spPr>
+          <a:xfrm xmlns:a="http://schemas.openxmlformats.org/drawingml/2006/main">
+            <a:off x="6496050" y="3819525"/>
+            <a:ext cx="95250" cy="95250"/>
+          </a:xfrm>
+          <a:prstGeom xmlns:a="http://schemas.openxmlformats.org/drawingml/2006/main" prst="rect">
+            <a:avLst/>
+          </a:prstGeom>
+          <a:solidFill xmlns:a="http://schemas.openxmlformats.org/drawingml/2006/main">
+            <a:srgbClr val="C44536"/>
+          </a:solidFill>
+          <a:ln xmlns:a="http://schemas.openxmlformats.org/drawingml/2006/main" w="0">
+            <a:solidFill>
+              <a:srgbClr val="C44536"/>
+            </a:solidFill>
+            <a:prstDash val="solid"/>
+          </a:ln>
+        </p:spPr>
+      </p:sp>
+      <p:sp>
+        <p:nvSpPr>
+          <p:cNvPr id="31" name="">
+            <a:extLst xmlns:a="http://schemas.openxmlformats.org/drawingml/2006/main">
+              <a:ext uri="{FF2B5EF4-FFF2-40B4-BE49-F238E27FC236}">
+                <a16:creationId xmlns:a16="http://schemas.microsoft.com/office/drawing/2014/main" id="{8897A116-A3BF-4228-B725-4EBE670BC797}"/>
+              </a:ext>
+            </a:extLst>
+          </p:cNvPr>
+          <p:cNvSpPr>
+            <a:spLocks xmlns:a="http://schemas.openxmlformats.org/drawingml/2006/main" noGrp="1"/>
+          </p:cNvSpPr>
+          <p:nvPr/>
+        </p:nvSpPr>
+        <p:spPr>
+          <a:xfrm xmlns:a="http://schemas.openxmlformats.org/drawingml/2006/main">
+            <a:off x="6705600" y="3733800"/>
+            <a:ext cx="4552950" cy="361950"/>
+          </a:xfrm>
+          <a:prstGeom xmlns:a="http://schemas.openxmlformats.org/drawingml/2006/main" prst="rect">
+            <a:avLst/>
+          </a:prstGeom>
+          <a:solidFill xmlns:a="http://schemas.openxmlformats.org/drawingml/2006/main">
+            <a:srgbClr val="FFFFFF">
+              <a:alpha val="0"/>
+            </a:srgbClr>
+          </a:solidFill>
+          <a:ln xmlns:a="http://schemas.openxmlformats.org/drawingml/2006/main" w="0">
+            <a:solidFill>
+              <a:srgbClr val="FFFFFF">
+                <a:alpha val="0"/>
+              </a:srgbClr>
+            </a:solidFill>
+            <a:prstDash val="solid"/>
+          </a:ln>
+        </p:spPr>
+        <p:txBody>
+          <a:bodyPr xmlns:a="http://schemas.openxmlformats.org/drawingml/2006/main" lIns="0" tIns="0" rIns="38100" bIns="0" anchor="t"/>
+          <a:lstStyle xmlns:a="http://schemas.openxmlformats.org/drawingml/2006/main"/>
+          <a:p xmlns:a="http://schemas.openxmlformats.org/drawingml/2006/main">
+            <a:pPr algn="l">
+              <a:defRPr sz="1575" b="0">
+                <a:solidFill>
+                  <a:srgbClr val="1F2933"/>
+                </a:solidFill>
+                <a:latin typeface="Malgun Gothic"/>
+                <a:ea typeface="Malgun Gothic"/>
+                <a:cs typeface="Malgun Gothic"/>
+              </a:defRPr>
+            </a:pPr>
+            <a:r>
+              <a:rPr sz="1575" b="0">
+                <a:solidFill>
+                  <a:srgbClr val="1F2933"/>
+                </a:solidFill>
+                <a:latin typeface="Malgun Gothic"/>
+                <a:ea typeface="Malgun Gothic"/>
+                <a:cs typeface="Malgun Gothic"/>
+              </a:rPr>
+              <a:t>Termination boss_dead timeout</a:t>
+            </a:r>
+          </a:p>
+        </p:txBody>
+      </p:sp>
+      <p:sp>
+        <p:nvSpPr>
+          <p:cNvPr id="32" name="">
+            <a:extLst xmlns:a="http://schemas.openxmlformats.org/drawingml/2006/main">
+              <a:ext uri="{FF2B5EF4-FFF2-40B4-BE49-F238E27FC236}">
+                <a16:creationId xmlns:a16="http://schemas.microsoft.com/office/drawing/2014/main" id="{E0422402-4461-4C66-A145-AC336D8C7293}"/>
               </a:ext>
             </a:extLst>
           </p:cNvPr>
@@ -19178,10 +19372,10 @@
       </p:sp>
       <p:sp>
         <p:nvSpPr>
-          <p:cNvPr id="29" name="">
-            <a:extLst xmlns:a="http://schemas.openxmlformats.org/drawingml/2006/main">
-              <a:ext uri="{FF2B5EF4-FFF2-40B4-BE49-F238E27FC236}">
-                <a16:creationId xmlns:a16="http://schemas.microsoft.com/office/drawing/2014/main" id="{C5F2D153-BC2B-4FF4-ACE6-B4DB0CA2E39C}"/>
+          <p:cNvPr id="33" name="">
+            <a:extLst xmlns:a="http://schemas.openxmlformats.org/drawingml/2006/main">
+              <a:ext uri="{FF2B5EF4-FFF2-40B4-BE49-F238E27FC236}">
+                <a16:creationId xmlns:a16="http://schemas.microsoft.com/office/drawing/2014/main" id="{1615CC36-EFA4-4247-B359-38CA7023DEC5}"/>
               </a:ext>
             </a:extLst>
           </p:cNvPr>
@@ -19243,7 +19437,7 @@
     </p:spTree>
     <p:extLst>
       <p:ext uri="{BB962C8B-B14F-4D97-AF65-F5344CB8AC3E}">
-        <p14:creationId xmlns:p14="http://schemas.microsoft.com/office/powerpoint/2010/main" val="309246034"/>
+        <p14:creationId xmlns:p14="http://schemas.microsoft.com/office/powerpoint/2010/main" val="2100954524"/>
       </p:ext>
     </p:extLst>
   </p:cSld>
@@ -19267,7 +19461,7 @@
           <p:cNvPr id="1" name="">
             <a:extLst xmlns:a="http://schemas.openxmlformats.org/drawingml/2006/main">
               <a:ext uri="{FF2B5EF4-FFF2-40B4-BE49-F238E27FC236}">
-                <a16:creationId xmlns:a16="http://schemas.microsoft.com/office/drawing/2014/main" id="{191A86FB-D602-428E-B543-6C9E4F9A2282}"/>
+                <a16:creationId xmlns:a16="http://schemas.microsoft.com/office/drawing/2014/main" id="{C66F5930-0F26-4A15-94DE-24B730A3DD7F}"/>
               </a:ext>
             </a:extLst>
           </p:cNvPr>
@@ -19300,7 +19494,7 @@
           <p:cNvPr id="2" name="">
             <a:extLst xmlns:a="http://schemas.openxmlformats.org/drawingml/2006/main">
               <a:ext uri="{FF2B5EF4-FFF2-40B4-BE49-F238E27FC236}">
-                <a16:creationId xmlns:a16="http://schemas.microsoft.com/office/drawing/2014/main" id="{B415F412-290B-48BF-A4D8-04CA1BDFFCFF}"/>
+                <a16:creationId xmlns:a16="http://schemas.microsoft.com/office/drawing/2014/main" id="{AF739C18-B82B-46E9-A613-F8A848248D45}"/>
               </a:ext>
             </a:extLst>
           </p:cNvPr>
@@ -19333,7 +19527,7 @@
           <p:cNvPr id="3" name="">
             <a:extLst xmlns:a="http://schemas.openxmlformats.org/drawingml/2006/main">
               <a:ext uri="{FF2B5EF4-FFF2-40B4-BE49-F238E27FC236}">
-                <a16:creationId xmlns:a16="http://schemas.microsoft.com/office/drawing/2014/main" id="{910A1315-45BD-4246-8556-3739379EAD90}"/>
+                <a16:creationId xmlns:a16="http://schemas.microsoft.com/office/drawing/2014/main" id="{87F18B7B-A4E3-4793-A6D5-5F0342341580}"/>
               </a:ext>
             </a:extLst>
           </p:cNvPr>
@@ -19397,7 +19591,7 @@
           <p:cNvPr id="4" name="">
             <a:extLst xmlns:a="http://schemas.openxmlformats.org/drawingml/2006/main">
               <a:ext uri="{FF2B5EF4-FFF2-40B4-BE49-F238E27FC236}">
-                <a16:creationId xmlns:a16="http://schemas.microsoft.com/office/drawing/2014/main" id="{E58079F1-B092-4BB9-9679-BD037E999927}"/>
+                <a16:creationId xmlns:a16="http://schemas.microsoft.com/office/drawing/2014/main" id="{7A64816D-4077-4CE0-9788-E054B81E4950}"/>
               </a:ext>
             </a:extLst>
           </p:cNvPr>
@@ -19461,7 +19655,7 @@
           <p:cNvPr id="5" name="">
             <a:extLst xmlns:a="http://schemas.openxmlformats.org/drawingml/2006/main">
               <a:ext uri="{FF2B5EF4-FFF2-40B4-BE49-F238E27FC236}">
-                <a16:creationId xmlns:a16="http://schemas.microsoft.com/office/drawing/2014/main" id="{7C8EC484-AE21-47FF-8142-D6FEC9277259}"/>
+                <a16:creationId xmlns:a16="http://schemas.microsoft.com/office/drawing/2014/main" id="{DC59F908-20B8-4C33-9089-AF9D62907117}"/>
               </a:ext>
             </a:extLst>
           </p:cNvPr>
@@ -19494,7 +19688,7 @@
           <p:cNvPr id="6" name="">
             <a:extLst xmlns:a="http://schemas.openxmlformats.org/drawingml/2006/main">
               <a:ext uri="{FF2B5EF4-FFF2-40B4-BE49-F238E27FC236}">
-                <a16:creationId xmlns:a16="http://schemas.microsoft.com/office/drawing/2014/main" id="{93EB048F-C75E-416B-BF46-47D63F547B87}"/>
+                <a16:creationId xmlns:a16="http://schemas.microsoft.com/office/drawing/2014/main" id="{BCFBC6B3-5B6D-49D7-8CFB-B91DC5BBA808}"/>
               </a:ext>
             </a:extLst>
           </p:cNvPr>
@@ -19527,7 +19721,7 @@
           <p:cNvPr id="7" name="">
             <a:extLst xmlns:a="http://schemas.openxmlformats.org/drawingml/2006/main">
               <a:ext uri="{FF2B5EF4-FFF2-40B4-BE49-F238E27FC236}">
-                <a16:creationId xmlns:a16="http://schemas.microsoft.com/office/drawing/2014/main" id="{FE27FC1F-9605-4387-9937-B816EE6265B9}"/>
+                <a16:creationId xmlns:a16="http://schemas.microsoft.com/office/drawing/2014/main" id="{8F1DF9E6-30D5-4254-ABEF-1034C2739495}"/>
               </a:ext>
             </a:extLst>
           </p:cNvPr>
@@ -19591,7 +19785,7 @@
           <p:cNvPr id="8" name="">
             <a:extLst xmlns:a="http://schemas.openxmlformats.org/drawingml/2006/main">
               <a:ext uri="{FF2B5EF4-FFF2-40B4-BE49-F238E27FC236}">
-                <a16:creationId xmlns:a16="http://schemas.microsoft.com/office/drawing/2014/main" id="{0D132BCD-5B6E-41BE-AD40-934B6EC127DA}"/>
+                <a16:creationId xmlns:a16="http://schemas.microsoft.com/office/drawing/2014/main" id="{3177C53B-723E-4562-94BB-122B47ECE15A}"/>
               </a:ext>
             </a:extLst>
           </p:cNvPr>
@@ -19624,7 +19818,7 @@
           <p:cNvPr id="9" name="">
             <a:extLst xmlns:a="http://schemas.openxmlformats.org/drawingml/2006/main">
               <a:ext uri="{FF2B5EF4-FFF2-40B4-BE49-F238E27FC236}">
-                <a16:creationId xmlns:a16="http://schemas.microsoft.com/office/drawing/2014/main" id="{0B4BCB7D-285B-4400-BF05-088633ACDCCF}"/>
+                <a16:creationId xmlns:a16="http://schemas.microsoft.com/office/drawing/2014/main" id="{0932861A-36D7-4794-B322-EFF2ED6504D9}"/>
               </a:ext>
             </a:extLst>
           </p:cNvPr>
@@ -19688,7 +19882,7 @@
           <p:cNvPr id="10" name="">
             <a:extLst xmlns:a="http://schemas.openxmlformats.org/drawingml/2006/main">
               <a:ext uri="{FF2B5EF4-FFF2-40B4-BE49-F238E27FC236}">
-                <a16:creationId xmlns:a16="http://schemas.microsoft.com/office/drawing/2014/main" id="{E6371B16-5F4E-4E79-8701-65C4FCB6E6E0}"/>
+                <a16:creationId xmlns:a16="http://schemas.microsoft.com/office/drawing/2014/main" id="{78C8F0EC-C979-43B7-8AAF-26997ECA834A}"/>
               </a:ext>
             </a:extLst>
           </p:cNvPr>
@@ -19721,7 +19915,7 @@
           <p:cNvPr id="11" name="">
             <a:extLst xmlns:a="http://schemas.openxmlformats.org/drawingml/2006/main">
               <a:ext uri="{FF2B5EF4-FFF2-40B4-BE49-F238E27FC236}">
-                <a16:creationId xmlns:a16="http://schemas.microsoft.com/office/drawing/2014/main" id="{5C2BDD7B-E6B3-4AAC-98E5-781666764A87}"/>
+                <a16:creationId xmlns:a16="http://schemas.microsoft.com/office/drawing/2014/main" id="{99368495-90F7-496A-B433-E57A469AA789}"/>
               </a:ext>
             </a:extLst>
           </p:cNvPr>
@@ -19785,7 +19979,7 @@
           <p:cNvPr id="12" name="">
             <a:extLst xmlns:a="http://schemas.openxmlformats.org/drawingml/2006/main">
               <a:ext uri="{FF2B5EF4-FFF2-40B4-BE49-F238E27FC236}">
-                <a16:creationId xmlns:a16="http://schemas.microsoft.com/office/drawing/2014/main" id="{67367250-5754-433D-B0C4-7BD8BDA88C68}"/>
+                <a16:creationId xmlns:a16="http://schemas.microsoft.com/office/drawing/2014/main" id="{40231D35-1C88-4E9F-BDFD-047167387854}"/>
               </a:ext>
             </a:extLst>
           </p:cNvPr>
@@ -19818,7 +20012,7 @@
           <p:cNvPr id="13" name="">
             <a:extLst xmlns:a="http://schemas.openxmlformats.org/drawingml/2006/main">
               <a:ext uri="{FF2B5EF4-FFF2-40B4-BE49-F238E27FC236}">
-                <a16:creationId xmlns:a16="http://schemas.microsoft.com/office/drawing/2014/main" id="{1131EE58-FBB8-4289-9C63-816374ECDD57}"/>
+                <a16:creationId xmlns:a16="http://schemas.microsoft.com/office/drawing/2014/main" id="{0845225D-F3E8-4E7E-AE6E-84533DF504F8}"/>
               </a:ext>
             </a:extLst>
           </p:cNvPr>
@@ -19882,7 +20076,7 @@
           <p:cNvPr id="14" name="">
             <a:extLst xmlns:a="http://schemas.openxmlformats.org/drawingml/2006/main">
               <a:ext uri="{FF2B5EF4-FFF2-40B4-BE49-F238E27FC236}">
-                <a16:creationId xmlns:a16="http://schemas.microsoft.com/office/drawing/2014/main" id="{D15F6957-CC15-4E23-A584-F16D5D4DB28B}"/>
+                <a16:creationId xmlns:a16="http://schemas.microsoft.com/office/drawing/2014/main" id="{6EA50706-ECCC-4902-97C6-5B8DBB16A31A}"/>
               </a:ext>
             </a:extLst>
           </p:cNvPr>
@@ -19915,7 +20109,7 @@
           <p:cNvPr id="15" name="">
             <a:extLst xmlns:a="http://schemas.openxmlformats.org/drawingml/2006/main">
               <a:ext uri="{FF2B5EF4-FFF2-40B4-BE49-F238E27FC236}">
-                <a16:creationId xmlns:a16="http://schemas.microsoft.com/office/drawing/2014/main" id="{83350407-72FF-4FD3-A937-111153444AC7}"/>
+                <a16:creationId xmlns:a16="http://schemas.microsoft.com/office/drawing/2014/main" id="{5F74C060-0843-4E00-B21F-7A102E87DB69}"/>
               </a:ext>
             </a:extLst>
           </p:cNvPr>
@@ -19979,7 +20173,7 @@
           <p:cNvPr id="16" name="">
             <a:extLst xmlns:a="http://schemas.openxmlformats.org/drawingml/2006/main">
               <a:ext uri="{FF2B5EF4-FFF2-40B4-BE49-F238E27FC236}">
-                <a16:creationId xmlns:a16="http://schemas.microsoft.com/office/drawing/2014/main" id="{4287941B-B3F5-4D74-91BF-81ECB69BF3FE}"/>
+                <a16:creationId xmlns:a16="http://schemas.microsoft.com/office/drawing/2014/main" id="{0E5FEFA4-AB23-4203-9BB2-742AFF3D88DB}"/>
               </a:ext>
             </a:extLst>
           </p:cNvPr>
@@ -20012,7 +20206,7 @@
           <p:cNvPr id="17" name="">
             <a:extLst xmlns:a="http://schemas.openxmlformats.org/drawingml/2006/main">
               <a:ext uri="{FF2B5EF4-FFF2-40B4-BE49-F238E27FC236}">
-                <a16:creationId xmlns:a16="http://schemas.microsoft.com/office/drawing/2014/main" id="{2A0714EE-CD15-48C2-9EEF-84E5F4BD7A66}"/>
+                <a16:creationId xmlns:a16="http://schemas.microsoft.com/office/drawing/2014/main" id="{96D96D1D-CA96-447C-A7CF-BFFAFA463E01}"/>
               </a:ext>
             </a:extLst>
           </p:cNvPr>
@@ -20076,7 +20270,7 @@
           <p:cNvPr id="18" name="">
             <a:extLst xmlns:a="http://schemas.openxmlformats.org/drawingml/2006/main">
               <a:ext uri="{FF2B5EF4-FFF2-40B4-BE49-F238E27FC236}">
-                <a16:creationId xmlns:a16="http://schemas.microsoft.com/office/drawing/2014/main" id="{87C1AFFD-FD9C-4B56-ABC4-73293E92A245}"/>
+                <a16:creationId xmlns:a16="http://schemas.microsoft.com/office/drawing/2014/main" id="{55332940-FF78-4E12-A13B-5A0C5CBFAD1D}"/>
               </a:ext>
             </a:extLst>
           </p:cNvPr>
@@ -20140,7 +20334,7 @@
           <p:cNvPr id="19" name="">
             <a:extLst xmlns:a="http://schemas.openxmlformats.org/drawingml/2006/main">
               <a:ext uri="{FF2B5EF4-FFF2-40B4-BE49-F238E27FC236}">
-                <a16:creationId xmlns:a16="http://schemas.microsoft.com/office/drawing/2014/main" id="{75561949-41C2-422C-9943-D48D2380BEC1}"/>
+                <a16:creationId xmlns:a16="http://schemas.microsoft.com/office/drawing/2014/main" id="{14868826-416E-4FD9-8A5C-5E078F1F66C2}"/>
               </a:ext>
             </a:extLst>
           </p:cNvPr>
@@ -20202,7 +20396,7 @@
     </p:spTree>
     <p:extLst>
       <p:ext uri="{BB962C8B-B14F-4D97-AF65-F5344CB8AC3E}">
-        <p14:creationId xmlns:p14="http://schemas.microsoft.com/office/powerpoint/2010/main" val="521720312"/>
+        <p14:creationId xmlns:p14="http://schemas.microsoft.com/office/powerpoint/2010/main" val="491633885"/>
       </p:ext>
     </p:extLst>
   </p:cSld>
@@ -20226,7 +20420,7 @@
           <p:cNvPr id="1" name="">
             <a:extLst xmlns:a="http://schemas.openxmlformats.org/drawingml/2006/main">
               <a:ext uri="{FF2B5EF4-FFF2-40B4-BE49-F238E27FC236}">
-                <a16:creationId xmlns:a16="http://schemas.microsoft.com/office/drawing/2014/main" id="{F7F91CFA-22EB-44DC-BE3C-F9D897D77057}"/>
+                <a16:creationId xmlns:a16="http://schemas.microsoft.com/office/drawing/2014/main" id="{60AF801B-2FCC-4114-8368-BFF5F7052B81}"/>
               </a:ext>
             </a:extLst>
           </p:cNvPr>
@@ -20259,7 +20453,7 @@
           <p:cNvPr id="2" name="">
             <a:extLst xmlns:a="http://schemas.openxmlformats.org/drawingml/2006/main">
               <a:ext uri="{FF2B5EF4-FFF2-40B4-BE49-F238E27FC236}">
-                <a16:creationId xmlns:a16="http://schemas.microsoft.com/office/drawing/2014/main" id="{08ECF063-47B4-40D8-870C-F8D4A3E6B6D1}"/>
+                <a16:creationId xmlns:a16="http://schemas.microsoft.com/office/drawing/2014/main" id="{F7D65059-DC72-4521-A95A-AA43ED79EE7E}"/>
               </a:ext>
             </a:extLst>
           </p:cNvPr>
@@ -20292,7 +20486,7 @@
           <p:cNvPr id="3" name="">
             <a:extLst xmlns:a="http://schemas.openxmlformats.org/drawingml/2006/main">
               <a:ext uri="{FF2B5EF4-FFF2-40B4-BE49-F238E27FC236}">
-                <a16:creationId xmlns:a16="http://schemas.microsoft.com/office/drawing/2014/main" id="{FFBF6D6A-EB3A-469D-9419-BFFFC022F5D8}"/>
+                <a16:creationId xmlns:a16="http://schemas.microsoft.com/office/drawing/2014/main" id="{6476BB93-6F4B-443C-AD76-95CAE1D9A9F1}"/>
               </a:ext>
             </a:extLst>
           </p:cNvPr>
@@ -20356,7 +20550,7 @@
           <p:cNvPr id="4" name="">
             <a:extLst xmlns:a="http://schemas.openxmlformats.org/drawingml/2006/main">
               <a:ext uri="{FF2B5EF4-FFF2-40B4-BE49-F238E27FC236}">
-                <a16:creationId xmlns:a16="http://schemas.microsoft.com/office/drawing/2014/main" id="{BECB65C6-FC0F-4259-B5E5-93C66645AF1C}"/>
+                <a16:creationId xmlns:a16="http://schemas.microsoft.com/office/drawing/2014/main" id="{A2DF5305-716D-4FBA-9637-603B68065575}"/>
               </a:ext>
             </a:extLst>
           </p:cNvPr>
@@ -20420,7 +20614,7 @@
           <p:cNvPr id="5" name="">
             <a:extLst xmlns:a="http://schemas.openxmlformats.org/drawingml/2006/main">
               <a:ext uri="{FF2B5EF4-FFF2-40B4-BE49-F238E27FC236}">
-                <a16:creationId xmlns:a16="http://schemas.microsoft.com/office/drawing/2014/main" id="{066B2A6D-8FA0-4DA3-B69B-F0BECFCF7FE5}"/>
+                <a16:creationId xmlns:a16="http://schemas.microsoft.com/office/drawing/2014/main" id="{CDAC31B3-2084-4306-96DB-C7D5F58C648C}"/>
               </a:ext>
             </a:extLst>
           </p:cNvPr>
@@ -20453,7 +20647,7 @@
           <p:cNvPr id="6" name="">
             <a:extLst xmlns:a="http://schemas.openxmlformats.org/drawingml/2006/main">
               <a:ext uri="{FF2B5EF4-FFF2-40B4-BE49-F238E27FC236}">
-                <a16:creationId xmlns:a16="http://schemas.microsoft.com/office/drawing/2014/main" id="{2469839B-196E-4C8B-848F-1F915B4F2F87}"/>
+                <a16:creationId xmlns:a16="http://schemas.microsoft.com/office/drawing/2014/main" id="{DDE16980-6AEA-40DF-99CC-D2E7EA643AF1}"/>
               </a:ext>
             </a:extLst>
           </p:cNvPr>
@@ -20486,7 +20680,7 @@
           <p:cNvPr id="7" name="">
             <a:extLst xmlns:a="http://schemas.openxmlformats.org/drawingml/2006/main">
               <a:ext uri="{FF2B5EF4-FFF2-40B4-BE49-F238E27FC236}">
-                <a16:creationId xmlns:a16="http://schemas.microsoft.com/office/drawing/2014/main" id="{231731AC-3594-44F6-BA21-E634E87F5703}"/>
+                <a16:creationId xmlns:a16="http://schemas.microsoft.com/office/drawing/2014/main" id="{604F6FCF-A63B-40DE-A22A-36552422F4E3}"/>
               </a:ext>
             </a:extLst>
           </p:cNvPr>
@@ -20550,7 +20744,7 @@
           <p:cNvPr id="8" name="">
             <a:extLst xmlns:a="http://schemas.openxmlformats.org/drawingml/2006/main">
               <a:ext uri="{FF2B5EF4-FFF2-40B4-BE49-F238E27FC236}">
-                <a16:creationId xmlns:a16="http://schemas.microsoft.com/office/drawing/2014/main" id="{FAE7142A-E0C8-47A3-A7C6-41D4C5B8B060}"/>
+                <a16:creationId xmlns:a16="http://schemas.microsoft.com/office/drawing/2014/main" id="{FB0A2130-18A4-45DE-BFA3-E1F4C01CB388}"/>
               </a:ext>
             </a:extLst>
           </p:cNvPr>
@@ -20583,7 +20777,7 @@
           <p:cNvPr id="9" name="">
             <a:extLst xmlns:a="http://schemas.openxmlformats.org/drawingml/2006/main">
               <a:ext uri="{FF2B5EF4-FFF2-40B4-BE49-F238E27FC236}">
-                <a16:creationId xmlns:a16="http://schemas.microsoft.com/office/drawing/2014/main" id="{FA1458EA-B5CF-4600-8CC6-20FF980F342A}"/>
+                <a16:creationId xmlns:a16="http://schemas.microsoft.com/office/drawing/2014/main" id="{BCECB7FE-9AAA-48DC-AB76-7516D157097A}"/>
               </a:ext>
             </a:extLst>
           </p:cNvPr>
@@ -20647,7 +20841,7 @@
           <p:cNvPr id="10" name="">
             <a:extLst xmlns:a="http://schemas.openxmlformats.org/drawingml/2006/main">
               <a:ext uri="{FF2B5EF4-FFF2-40B4-BE49-F238E27FC236}">
-                <a16:creationId xmlns:a16="http://schemas.microsoft.com/office/drawing/2014/main" id="{8F0DF497-4457-4924-A8AC-8A5C5C4D4493}"/>
+                <a16:creationId xmlns:a16="http://schemas.microsoft.com/office/drawing/2014/main" id="{5207CF20-E870-4599-8EC9-7DCCC62CB440}"/>
               </a:ext>
             </a:extLst>
           </p:cNvPr>
@@ -20680,7 +20874,7 @@
           <p:cNvPr id="11" name="">
             <a:extLst xmlns:a="http://schemas.openxmlformats.org/drawingml/2006/main">
               <a:ext uri="{FF2B5EF4-FFF2-40B4-BE49-F238E27FC236}">
-                <a16:creationId xmlns:a16="http://schemas.microsoft.com/office/drawing/2014/main" id="{50BED319-4F2D-417E-B002-27B227C6A2E1}"/>
+                <a16:creationId xmlns:a16="http://schemas.microsoft.com/office/drawing/2014/main" id="{94578FFC-DA3D-4340-8501-19FD587E34BA}"/>
               </a:ext>
             </a:extLst>
           </p:cNvPr>
@@ -20744,7 +20938,7 @@
           <p:cNvPr id="12" name="">
             <a:extLst xmlns:a="http://schemas.openxmlformats.org/drawingml/2006/main">
               <a:ext uri="{FF2B5EF4-FFF2-40B4-BE49-F238E27FC236}">
-                <a16:creationId xmlns:a16="http://schemas.microsoft.com/office/drawing/2014/main" id="{77C27175-D614-4D65-88C7-672514032E30}"/>
+                <a16:creationId xmlns:a16="http://schemas.microsoft.com/office/drawing/2014/main" id="{FBA17848-3EA8-40E6-AE8E-E72EEAFD705A}"/>
               </a:ext>
             </a:extLst>
           </p:cNvPr>
@@ -20777,7 +20971,7 @@
           <p:cNvPr id="13" name="">
             <a:extLst xmlns:a="http://schemas.openxmlformats.org/drawingml/2006/main">
               <a:ext uri="{FF2B5EF4-FFF2-40B4-BE49-F238E27FC236}">
-                <a16:creationId xmlns:a16="http://schemas.microsoft.com/office/drawing/2014/main" id="{64C83568-3477-4FDA-9CFA-85F90441288B}"/>
+                <a16:creationId xmlns:a16="http://schemas.microsoft.com/office/drawing/2014/main" id="{B5F002AD-AF41-4169-A73A-EF62E7AEC6EC}"/>
               </a:ext>
             </a:extLst>
           </p:cNvPr>
@@ -20841,7 +21035,7 @@
           <p:cNvPr id="14" name="">
             <a:extLst xmlns:a="http://schemas.openxmlformats.org/drawingml/2006/main">
               <a:ext uri="{FF2B5EF4-FFF2-40B4-BE49-F238E27FC236}">
-                <a16:creationId xmlns:a16="http://schemas.microsoft.com/office/drawing/2014/main" id="{054B8116-376A-4FFE-BF3E-57A1E4C44A43}"/>
+                <a16:creationId xmlns:a16="http://schemas.microsoft.com/office/drawing/2014/main" id="{80984125-741E-4264-8940-A850EDCB9D58}"/>
               </a:ext>
             </a:extLst>
           </p:cNvPr>
@@ -20874,7 +21068,7 @@
           <p:cNvPr id="15" name="">
             <a:extLst xmlns:a="http://schemas.openxmlformats.org/drawingml/2006/main">
               <a:ext uri="{FF2B5EF4-FFF2-40B4-BE49-F238E27FC236}">
-                <a16:creationId xmlns:a16="http://schemas.microsoft.com/office/drawing/2014/main" id="{EB9EB01C-C81E-4FF6-9AC1-8E69523FF624}"/>
+                <a16:creationId xmlns:a16="http://schemas.microsoft.com/office/drawing/2014/main" id="{B8B5E5A6-5CB3-4346-A0D5-1E8F81ECD971}"/>
               </a:ext>
             </a:extLst>
           </p:cNvPr>
@@ -20938,7 +21132,7 @@
           <p:cNvPr id="16" name="">
             <a:extLst xmlns:a="http://schemas.openxmlformats.org/drawingml/2006/main">
               <a:ext uri="{FF2B5EF4-FFF2-40B4-BE49-F238E27FC236}">
-                <a16:creationId xmlns:a16="http://schemas.microsoft.com/office/drawing/2014/main" id="{F94452BB-49F4-4065-A2AD-212D0D88C9A2}"/>
+                <a16:creationId xmlns:a16="http://schemas.microsoft.com/office/drawing/2014/main" id="{844BE32C-DBE0-4E01-85E1-5599F21FC5E1}"/>
               </a:ext>
             </a:extLst>
           </p:cNvPr>
@@ -20971,7 +21165,7 @@
           <p:cNvPr id="17" name="">
             <a:extLst xmlns:a="http://schemas.openxmlformats.org/drawingml/2006/main">
               <a:ext uri="{FF2B5EF4-FFF2-40B4-BE49-F238E27FC236}">
-                <a16:creationId xmlns:a16="http://schemas.microsoft.com/office/drawing/2014/main" id="{94F99CC4-D5AF-407B-B190-7D46C881DA1B}"/>
+                <a16:creationId xmlns:a16="http://schemas.microsoft.com/office/drawing/2014/main" id="{61375732-3F12-4392-ADE3-BC9EB93929E4}"/>
               </a:ext>
             </a:extLst>
           </p:cNvPr>
@@ -21035,7 +21229,7 @@
           <p:cNvPr id="18" name="">
             <a:extLst xmlns:a="http://schemas.openxmlformats.org/drawingml/2006/main">
               <a:ext uri="{FF2B5EF4-FFF2-40B4-BE49-F238E27FC236}">
-                <a16:creationId xmlns:a16="http://schemas.microsoft.com/office/drawing/2014/main" id="{D4F47875-1B1F-4534-89A4-B8ED06CD0DB8}"/>
+                <a16:creationId xmlns:a16="http://schemas.microsoft.com/office/drawing/2014/main" id="{7B7F8759-E146-4509-916F-E15CF3FB4AF4}"/>
               </a:ext>
             </a:extLst>
           </p:cNvPr>
@@ -21099,7 +21293,7 @@
           <p:cNvPr id="19" name="">
             <a:extLst xmlns:a="http://schemas.openxmlformats.org/drawingml/2006/main">
               <a:ext uri="{FF2B5EF4-FFF2-40B4-BE49-F238E27FC236}">
-                <a16:creationId xmlns:a16="http://schemas.microsoft.com/office/drawing/2014/main" id="{A5864DB2-38C5-419F-9B8B-D10239AC0906}"/>
+                <a16:creationId xmlns:a16="http://schemas.microsoft.com/office/drawing/2014/main" id="{2015573E-9733-4799-89E5-5CAFA013B7A3}"/>
               </a:ext>
             </a:extLst>
           </p:cNvPr>
@@ -21161,7 +21355,7 @@
     </p:spTree>
     <p:extLst>
       <p:ext uri="{BB962C8B-B14F-4D97-AF65-F5344CB8AC3E}">
-        <p14:creationId xmlns:p14="http://schemas.microsoft.com/office/powerpoint/2010/main" val="1207421076"/>
+        <p14:creationId xmlns:p14="http://schemas.microsoft.com/office/powerpoint/2010/main" val="1917725475"/>
       </p:ext>
     </p:extLst>
   </p:cSld>
@@ -21185,7 +21379,7 @@
           <p:cNvPr id="1" name="">
             <a:extLst xmlns:a="http://schemas.openxmlformats.org/drawingml/2006/main">
               <a:ext uri="{FF2B5EF4-FFF2-40B4-BE49-F238E27FC236}">
-                <a16:creationId xmlns:a16="http://schemas.microsoft.com/office/drawing/2014/main" id="{AC45D1A2-F247-495D-8B4C-5024A821A133}"/>
+                <a16:creationId xmlns:a16="http://schemas.microsoft.com/office/drawing/2014/main" id="{9D52F365-74A2-43F0-8B30-FE5B8E07B95D}"/>
               </a:ext>
             </a:extLst>
           </p:cNvPr>
@@ -21218,7 +21412,7 @@
           <p:cNvPr id="2" name="">
             <a:extLst xmlns:a="http://schemas.openxmlformats.org/drawingml/2006/main">
               <a:ext uri="{FF2B5EF4-FFF2-40B4-BE49-F238E27FC236}">
-                <a16:creationId xmlns:a16="http://schemas.microsoft.com/office/drawing/2014/main" id="{51F9B390-EE0F-425C-8D93-F33D19AF004B}"/>
+                <a16:creationId xmlns:a16="http://schemas.microsoft.com/office/drawing/2014/main" id="{7AB27BCD-2719-48E0-84AC-4DFFB79784CF}"/>
               </a:ext>
             </a:extLst>
           </p:cNvPr>
@@ -21251,7 +21445,7 @@
           <p:cNvPr id="3" name="">
             <a:extLst xmlns:a="http://schemas.openxmlformats.org/drawingml/2006/main">
               <a:ext uri="{FF2B5EF4-FFF2-40B4-BE49-F238E27FC236}">
-                <a16:creationId xmlns:a16="http://schemas.microsoft.com/office/drawing/2014/main" id="{2FB9EAB6-92A6-4A52-A41A-6C33B5B5B2CB}"/>
+                <a16:creationId xmlns:a16="http://schemas.microsoft.com/office/drawing/2014/main" id="{9839220C-16B9-4B32-870A-55BD140AA876}"/>
               </a:ext>
             </a:extLst>
           </p:cNvPr>
@@ -21315,7 +21509,7 @@
           <p:cNvPr id="4" name="">
             <a:extLst xmlns:a="http://schemas.openxmlformats.org/drawingml/2006/main">
               <a:ext uri="{FF2B5EF4-FFF2-40B4-BE49-F238E27FC236}">
-                <a16:creationId xmlns:a16="http://schemas.microsoft.com/office/drawing/2014/main" id="{AD186086-7480-42D0-856A-67BF820DA601}"/>
+                <a16:creationId xmlns:a16="http://schemas.microsoft.com/office/drawing/2014/main" id="{ADCF64AF-4509-4B94-9914-82C041AC203F}"/>
               </a:ext>
             </a:extLst>
           </p:cNvPr>
@@ -21379,7 +21573,7 @@
           <p:cNvPr id="5" name="">
             <a:extLst xmlns:a="http://schemas.openxmlformats.org/drawingml/2006/main">
               <a:ext uri="{FF2B5EF4-FFF2-40B4-BE49-F238E27FC236}">
-                <a16:creationId xmlns:a16="http://schemas.microsoft.com/office/drawing/2014/main" id="{989FCD20-6504-4483-8575-CED7BAC90F6F}"/>
+                <a16:creationId xmlns:a16="http://schemas.microsoft.com/office/drawing/2014/main" id="{DE573EB8-07F9-4C74-9D8E-3C8D9D4F14B2}"/>
               </a:ext>
             </a:extLst>
           </p:cNvPr>
@@ -21412,7 +21606,7 @@
           <p:cNvPr id="6" name="">
             <a:extLst xmlns:a="http://schemas.openxmlformats.org/drawingml/2006/main">
               <a:ext uri="{FF2B5EF4-FFF2-40B4-BE49-F238E27FC236}">
-                <a16:creationId xmlns:a16="http://schemas.microsoft.com/office/drawing/2014/main" id="{EB5009BE-B007-4BD5-AD22-62D4BFDFC908}"/>
+                <a16:creationId xmlns:a16="http://schemas.microsoft.com/office/drawing/2014/main" id="{64A2CC4E-C85E-49F7-B7DD-3E8A0301B4B5}"/>
               </a:ext>
             </a:extLst>
           </p:cNvPr>
@@ -21445,7 +21639,7 @@
           <p:cNvPr id="7" name="">
             <a:extLst xmlns:a="http://schemas.openxmlformats.org/drawingml/2006/main">
               <a:ext uri="{FF2B5EF4-FFF2-40B4-BE49-F238E27FC236}">
-                <a16:creationId xmlns:a16="http://schemas.microsoft.com/office/drawing/2014/main" id="{9F9074CC-E547-4BED-9DD9-A0D67F2D7554}"/>
+                <a16:creationId xmlns:a16="http://schemas.microsoft.com/office/drawing/2014/main" id="{47605DB9-16A0-4AD8-A5B4-CDA9BF21373D}"/>
               </a:ext>
             </a:extLst>
           </p:cNvPr>
@@ -21509,7 +21703,7 @@
           <p:cNvPr id="8" name="">
             <a:extLst xmlns:a="http://schemas.openxmlformats.org/drawingml/2006/main">
               <a:ext uri="{FF2B5EF4-FFF2-40B4-BE49-F238E27FC236}">
-                <a16:creationId xmlns:a16="http://schemas.microsoft.com/office/drawing/2014/main" id="{A20A7AFD-2254-4466-A675-46A4CFD1053C}"/>
+                <a16:creationId xmlns:a16="http://schemas.microsoft.com/office/drawing/2014/main" id="{4F2054F4-CD59-4E93-B1B4-95174D04C146}"/>
               </a:ext>
             </a:extLst>
           </p:cNvPr>
@@ -21542,7 +21736,7 @@
           <p:cNvPr id="9" name="">
             <a:extLst xmlns:a="http://schemas.openxmlformats.org/drawingml/2006/main">
               <a:ext uri="{FF2B5EF4-FFF2-40B4-BE49-F238E27FC236}">
-                <a16:creationId xmlns:a16="http://schemas.microsoft.com/office/drawing/2014/main" id="{9BC1820B-587C-4B38-8956-0BBE48691F5F}"/>
+                <a16:creationId xmlns:a16="http://schemas.microsoft.com/office/drawing/2014/main" id="{06C90E0C-8D8E-4699-821A-3DDFC0559704}"/>
               </a:ext>
             </a:extLst>
           </p:cNvPr>
@@ -21606,7 +21800,7 @@
           <p:cNvPr id="10" name="">
             <a:extLst xmlns:a="http://schemas.openxmlformats.org/drawingml/2006/main">
               <a:ext uri="{FF2B5EF4-FFF2-40B4-BE49-F238E27FC236}">
-                <a16:creationId xmlns:a16="http://schemas.microsoft.com/office/drawing/2014/main" id="{E5C08952-0B2B-4D5D-96A3-528F471BB16D}"/>
+                <a16:creationId xmlns:a16="http://schemas.microsoft.com/office/drawing/2014/main" id="{DA8DA0E3-31D4-4714-802C-F08B5C4C8EF2}"/>
               </a:ext>
             </a:extLst>
           </p:cNvPr>
@@ -21639,7 +21833,7 @@
           <p:cNvPr id="11" name="">
             <a:extLst xmlns:a="http://schemas.openxmlformats.org/drawingml/2006/main">
               <a:ext uri="{FF2B5EF4-FFF2-40B4-BE49-F238E27FC236}">
-                <a16:creationId xmlns:a16="http://schemas.microsoft.com/office/drawing/2014/main" id="{B841A41D-BEC2-4C57-BD1E-635F8D1E4701}"/>
+                <a16:creationId xmlns:a16="http://schemas.microsoft.com/office/drawing/2014/main" id="{E2065BEE-1316-45AB-97F8-C040EF2235E7}"/>
               </a:ext>
             </a:extLst>
           </p:cNvPr>
@@ -21703,7 +21897,7 @@
           <p:cNvPr id="12" name="">
             <a:extLst xmlns:a="http://schemas.openxmlformats.org/drawingml/2006/main">
               <a:ext uri="{FF2B5EF4-FFF2-40B4-BE49-F238E27FC236}">
-                <a16:creationId xmlns:a16="http://schemas.microsoft.com/office/drawing/2014/main" id="{CCE98199-C93F-4F1D-AA1A-38FC467CF945}"/>
+                <a16:creationId xmlns:a16="http://schemas.microsoft.com/office/drawing/2014/main" id="{5A49688D-2FE1-4425-A74D-32D5C491ADA5}"/>
               </a:ext>
             </a:extLst>
           </p:cNvPr>
@@ -21736,7 +21930,7 @@
           <p:cNvPr id="13" name="">
             <a:extLst xmlns:a="http://schemas.openxmlformats.org/drawingml/2006/main">
               <a:ext uri="{FF2B5EF4-FFF2-40B4-BE49-F238E27FC236}">
-                <a16:creationId xmlns:a16="http://schemas.microsoft.com/office/drawing/2014/main" id="{027184D6-6DB5-4C83-803B-250B2F5E9105}"/>
+                <a16:creationId xmlns:a16="http://schemas.microsoft.com/office/drawing/2014/main" id="{1A608769-19A0-4024-87B0-42795E10E6D0}"/>
               </a:ext>
             </a:extLst>
           </p:cNvPr>
@@ -21800,7 +21994,7 @@
           <p:cNvPr id="14" name="">
             <a:extLst xmlns:a="http://schemas.openxmlformats.org/drawingml/2006/main">
               <a:ext uri="{FF2B5EF4-FFF2-40B4-BE49-F238E27FC236}">
-                <a16:creationId xmlns:a16="http://schemas.microsoft.com/office/drawing/2014/main" id="{C1B4EC6C-ADB7-4870-B4A2-5803AFB42660}"/>
+                <a16:creationId xmlns:a16="http://schemas.microsoft.com/office/drawing/2014/main" id="{F817D365-2B9F-4DE8-8489-C96A018F6BE9}"/>
               </a:ext>
             </a:extLst>
           </p:cNvPr>
@@ -21833,7 +22027,7 @@
           <p:cNvPr id="15" name="">
             <a:extLst xmlns:a="http://schemas.openxmlformats.org/drawingml/2006/main">
               <a:ext uri="{FF2B5EF4-FFF2-40B4-BE49-F238E27FC236}">
-                <a16:creationId xmlns:a16="http://schemas.microsoft.com/office/drawing/2014/main" id="{CD5AC6DD-7779-4DBE-BB82-2AC4CE7AF7A4}"/>
+                <a16:creationId xmlns:a16="http://schemas.microsoft.com/office/drawing/2014/main" id="{0D96974A-844D-4679-A584-D0C2460602A8}"/>
               </a:ext>
             </a:extLst>
           </p:cNvPr>
@@ -21897,7 +22091,7 @@
           <p:cNvPr id="16" name="">
             <a:extLst xmlns:a="http://schemas.openxmlformats.org/drawingml/2006/main">
               <a:ext uri="{FF2B5EF4-FFF2-40B4-BE49-F238E27FC236}">
-                <a16:creationId xmlns:a16="http://schemas.microsoft.com/office/drawing/2014/main" id="{AB4DB409-0C80-458C-A9F7-398B765D7DF9}"/>
+                <a16:creationId xmlns:a16="http://schemas.microsoft.com/office/drawing/2014/main" id="{7109B8DC-B318-4A31-AC86-D966DF57E20D}"/>
               </a:ext>
             </a:extLst>
           </p:cNvPr>
@@ -21930,7 +22124,7 @@
           <p:cNvPr id="17" name="">
             <a:extLst xmlns:a="http://schemas.openxmlformats.org/drawingml/2006/main">
               <a:ext uri="{FF2B5EF4-FFF2-40B4-BE49-F238E27FC236}">
-                <a16:creationId xmlns:a16="http://schemas.microsoft.com/office/drawing/2014/main" id="{E1E0AC9E-0CAE-40AE-AE74-773CC9B23550}"/>
+                <a16:creationId xmlns:a16="http://schemas.microsoft.com/office/drawing/2014/main" id="{00DD0C6E-2FC7-4E2C-AAF8-1586F7DF6C62}"/>
               </a:ext>
             </a:extLst>
           </p:cNvPr>
@@ -21994,7 +22188,7 @@
           <p:cNvPr id="18" name="">
             <a:extLst xmlns:a="http://schemas.openxmlformats.org/drawingml/2006/main">
               <a:ext uri="{FF2B5EF4-FFF2-40B4-BE49-F238E27FC236}">
-                <a16:creationId xmlns:a16="http://schemas.microsoft.com/office/drawing/2014/main" id="{CE4FA011-C1FE-4011-B23F-F32F98C75668}"/>
+                <a16:creationId xmlns:a16="http://schemas.microsoft.com/office/drawing/2014/main" id="{CAD5669B-22EF-435E-B981-4F30650608E0}"/>
               </a:ext>
             </a:extLst>
           </p:cNvPr>
@@ -22027,7 +22221,7 @@
           <p:cNvPr id="19" name="">
             <a:extLst xmlns:a="http://schemas.openxmlformats.org/drawingml/2006/main">
               <a:ext uri="{FF2B5EF4-FFF2-40B4-BE49-F238E27FC236}">
-                <a16:creationId xmlns:a16="http://schemas.microsoft.com/office/drawing/2014/main" id="{365A168A-D3F1-4779-B39E-5C268FE57BD4}"/>
+                <a16:creationId xmlns:a16="http://schemas.microsoft.com/office/drawing/2014/main" id="{A1E7642B-F2F4-488C-9B2B-6F848280DBDA}"/>
               </a:ext>
             </a:extLst>
           </p:cNvPr>
@@ -22091,7 +22285,7 @@
           <p:cNvPr id="20" name="">
             <a:extLst xmlns:a="http://schemas.openxmlformats.org/drawingml/2006/main">
               <a:ext uri="{FF2B5EF4-FFF2-40B4-BE49-F238E27FC236}">
-                <a16:creationId xmlns:a16="http://schemas.microsoft.com/office/drawing/2014/main" id="{3C926582-988D-4917-B431-02AD5771B140}"/>
+                <a16:creationId xmlns:a16="http://schemas.microsoft.com/office/drawing/2014/main" id="{F2634359-21F7-4D4A-9F87-0491AD7B6F47}"/>
               </a:ext>
             </a:extLst>
           </p:cNvPr>
@@ -22155,7 +22349,7 @@
           <p:cNvPr id="21" name="">
             <a:extLst xmlns:a="http://schemas.openxmlformats.org/drawingml/2006/main">
               <a:ext uri="{FF2B5EF4-FFF2-40B4-BE49-F238E27FC236}">
-                <a16:creationId xmlns:a16="http://schemas.microsoft.com/office/drawing/2014/main" id="{3987D006-DB4B-45DE-A926-8E464A4D53BA}"/>
+                <a16:creationId xmlns:a16="http://schemas.microsoft.com/office/drawing/2014/main" id="{364984BC-325F-4D6A-81E7-2CA5C5FD8973}"/>
               </a:ext>
             </a:extLst>
           </p:cNvPr>
@@ -22217,7 +22411,7 @@
     </p:spTree>
     <p:extLst>
       <p:ext uri="{BB962C8B-B14F-4D97-AF65-F5344CB8AC3E}">
-        <p14:creationId xmlns:p14="http://schemas.microsoft.com/office/powerpoint/2010/main" val="1791420259"/>
+        <p14:creationId xmlns:p14="http://schemas.microsoft.com/office/powerpoint/2010/main" val="756859523"/>
       </p:ext>
     </p:extLst>
   </p:cSld>
@@ -22241,7 +22435,7 @@
           <p:cNvPr id="1" name="">
             <a:extLst xmlns:a="http://schemas.openxmlformats.org/drawingml/2006/main">
               <a:ext uri="{FF2B5EF4-FFF2-40B4-BE49-F238E27FC236}">
-                <a16:creationId xmlns:a16="http://schemas.microsoft.com/office/drawing/2014/main" id="{FB6CFB2F-0DAB-4B6F-8973-6BEC784B78E5}"/>
+                <a16:creationId xmlns:a16="http://schemas.microsoft.com/office/drawing/2014/main" id="{87D6F071-FEB2-47AC-8901-7B7E7035C9B1}"/>
               </a:ext>
             </a:extLst>
           </p:cNvPr>
@@ -22274,7 +22468,7 @@
           <p:cNvPr id="2" name="">
             <a:extLst xmlns:a="http://schemas.openxmlformats.org/drawingml/2006/main">
               <a:ext uri="{FF2B5EF4-FFF2-40B4-BE49-F238E27FC236}">
-                <a16:creationId xmlns:a16="http://schemas.microsoft.com/office/drawing/2014/main" id="{3B60F57F-EF52-46E6-89E4-A5C796946B03}"/>
+                <a16:creationId xmlns:a16="http://schemas.microsoft.com/office/drawing/2014/main" id="{7BCCD6E5-638A-4CD8-B74F-75D1C40DBA3E}"/>
               </a:ext>
             </a:extLst>
           </p:cNvPr>
@@ -22307,7 +22501,7 @@
           <p:cNvPr id="3" name="">
             <a:extLst xmlns:a="http://schemas.openxmlformats.org/drawingml/2006/main">
               <a:ext uri="{FF2B5EF4-FFF2-40B4-BE49-F238E27FC236}">
-                <a16:creationId xmlns:a16="http://schemas.microsoft.com/office/drawing/2014/main" id="{DF306B4C-9CE8-449E-9F09-E1DD71DC1300}"/>
+                <a16:creationId xmlns:a16="http://schemas.microsoft.com/office/drawing/2014/main" id="{A4A9EE96-75B2-4CEC-8576-40CF019FCB7A}"/>
               </a:ext>
             </a:extLst>
           </p:cNvPr>
@@ -22371,7 +22565,7 @@
           <p:cNvPr id="4" name="">
             <a:extLst xmlns:a="http://schemas.openxmlformats.org/drawingml/2006/main">
               <a:ext uri="{FF2B5EF4-FFF2-40B4-BE49-F238E27FC236}">
-                <a16:creationId xmlns:a16="http://schemas.microsoft.com/office/drawing/2014/main" id="{A194BF21-1BB9-4DA9-B4AE-81B3C6445E9D}"/>
+                <a16:creationId xmlns:a16="http://schemas.microsoft.com/office/drawing/2014/main" id="{1F385520-26BD-41D4-BD35-C584D63D8138}"/>
               </a:ext>
             </a:extLst>
           </p:cNvPr>
@@ -22435,7 +22629,7 @@
           <p:cNvPr id="5" name="">
             <a:extLst xmlns:a="http://schemas.openxmlformats.org/drawingml/2006/main">
               <a:ext uri="{FF2B5EF4-FFF2-40B4-BE49-F238E27FC236}">
-                <a16:creationId xmlns:a16="http://schemas.microsoft.com/office/drawing/2014/main" id="{9E263427-970F-4C8B-9C95-0F92B8FF9DD8}"/>
+                <a16:creationId xmlns:a16="http://schemas.microsoft.com/office/drawing/2014/main" id="{0ABBF3C3-FAB2-4A59-8680-536125463925}"/>
               </a:ext>
             </a:extLst>
           </p:cNvPr>
@@ -22468,7 +22662,7 @@
           <p:cNvPr id="6" name="">
             <a:extLst xmlns:a="http://schemas.openxmlformats.org/drawingml/2006/main">
               <a:ext uri="{FF2B5EF4-FFF2-40B4-BE49-F238E27FC236}">
-                <a16:creationId xmlns:a16="http://schemas.microsoft.com/office/drawing/2014/main" id="{6F788F79-1364-4C6D-94DD-E2C8CA9483F2}"/>
+                <a16:creationId xmlns:a16="http://schemas.microsoft.com/office/drawing/2014/main" id="{7868AD6B-DA58-4B98-92CD-CB5FB890E01F}"/>
               </a:ext>
             </a:extLst>
           </p:cNvPr>
@@ -22501,7 +22695,7 @@
           <p:cNvPr id="7" name="">
             <a:extLst xmlns:a="http://schemas.openxmlformats.org/drawingml/2006/main">
               <a:ext uri="{FF2B5EF4-FFF2-40B4-BE49-F238E27FC236}">
-                <a16:creationId xmlns:a16="http://schemas.microsoft.com/office/drawing/2014/main" id="{60066ABB-2F77-4F2A-9A19-C666A14AD09C}"/>
+                <a16:creationId xmlns:a16="http://schemas.microsoft.com/office/drawing/2014/main" id="{2A39E558-2438-4AA0-8C02-46AF099E04BD}"/>
               </a:ext>
             </a:extLst>
           </p:cNvPr>
@@ -22565,7 +22759,7 @@
           <p:cNvPr id="8" name="">
             <a:extLst xmlns:a="http://schemas.openxmlformats.org/drawingml/2006/main">
               <a:ext uri="{FF2B5EF4-FFF2-40B4-BE49-F238E27FC236}">
-                <a16:creationId xmlns:a16="http://schemas.microsoft.com/office/drawing/2014/main" id="{0D2D791C-7F4B-4A07-BAB3-23944209C5B8}"/>
+                <a16:creationId xmlns:a16="http://schemas.microsoft.com/office/drawing/2014/main" id="{21F7CAC8-4545-4FF6-8294-18AC79820D70}"/>
               </a:ext>
             </a:extLst>
           </p:cNvPr>
@@ -22598,7 +22792,7 @@
           <p:cNvPr id="9" name="">
             <a:extLst xmlns:a="http://schemas.openxmlformats.org/drawingml/2006/main">
               <a:ext uri="{FF2B5EF4-FFF2-40B4-BE49-F238E27FC236}">
-                <a16:creationId xmlns:a16="http://schemas.microsoft.com/office/drawing/2014/main" id="{2E952F00-34A3-4F22-8CF3-B8065D412942}"/>
+                <a16:creationId xmlns:a16="http://schemas.microsoft.com/office/drawing/2014/main" id="{B30E30F6-AFA7-44FE-811C-19CF88181C9F}"/>
               </a:ext>
             </a:extLst>
           </p:cNvPr>
@@ -22662,7 +22856,7 @@
           <p:cNvPr id="10" name="">
             <a:extLst xmlns:a="http://schemas.openxmlformats.org/drawingml/2006/main">
               <a:ext uri="{FF2B5EF4-FFF2-40B4-BE49-F238E27FC236}">
-                <a16:creationId xmlns:a16="http://schemas.microsoft.com/office/drawing/2014/main" id="{0C55F685-F269-4911-85F4-3B3B474CB326}"/>
+                <a16:creationId xmlns:a16="http://schemas.microsoft.com/office/drawing/2014/main" id="{6EFBA1DC-75C4-48EB-9510-4FB87F8DC7C5}"/>
               </a:ext>
             </a:extLst>
           </p:cNvPr>
@@ -22695,7 +22889,7 @@
           <p:cNvPr id="11" name="">
             <a:extLst xmlns:a="http://schemas.openxmlformats.org/drawingml/2006/main">
               <a:ext uri="{FF2B5EF4-FFF2-40B4-BE49-F238E27FC236}">
-                <a16:creationId xmlns:a16="http://schemas.microsoft.com/office/drawing/2014/main" id="{69574CCD-1D9D-4762-BDBA-C9B458D9B4BA}"/>
+                <a16:creationId xmlns:a16="http://schemas.microsoft.com/office/drawing/2014/main" id="{E79CF2CF-F09B-4D09-AC1D-71E66163176D}"/>
               </a:ext>
             </a:extLst>
           </p:cNvPr>
@@ -22759,7 +22953,7 @@
           <p:cNvPr id="12" name="">
             <a:extLst xmlns:a="http://schemas.openxmlformats.org/drawingml/2006/main">
               <a:ext uri="{FF2B5EF4-FFF2-40B4-BE49-F238E27FC236}">
-                <a16:creationId xmlns:a16="http://schemas.microsoft.com/office/drawing/2014/main" id="{063E6B5F-CCD0-4AEF-9549-95AC37D91EEB}"/>
+                <a16:creationId xmlns:a16="http://schemas.microsoft.com/office/drawing/2014/main" id="{C7FAD9AA-A120-412A-A513-48EEABB3619C}"/>
               </a:ext>
             </a:extLst>
           </p:cNvPr>
@@ -22792,7 +22986,7 @@
           <p:cNvPr id="13" name="">
             <a:extLst xmlns:a="http://schemas.openxmlformats.org/drawingml/2006/main">
               <a:ext uri="{FF2B5EF4-FFF2-40B4-BE49-F238E27FC236}">
-                <a16:creationId xmlns:a16="http://schemas.microsoft.com/office/drawing/2014/main" id="{E64D87B2-3AB2-4F35-98B8-F88A2F830A90}"/>
+                <a16:creationId xmlns:a16="http://schemas.microsoft.com/office/drawing/2014/main" id="{E71B809B-77C0-46A5-B15C-321B257B1CB5}"/>
               </a:ext>
             </a:extLst>
           </p:cNvPr>
@@ -22856,7 +23050,7 @@
           <p:cNvPr id="14" name="">
             <a:extLst xmlns:a="http://schemas.openxmlformats.org/drawingml/2006/main">
               <a:ext uri="{FF2B5EF4-FFF2-40B4-BE49-F238E27FC236}">
-                <a16:creationId xmlns:a16="http://schemas.microsoft.com/office/drawing/2014/main" id="{73ACD6C4-8993-4D1C-85F0-3955B8BBB0D3}"/>
+                <a16:creationId xmlns:a16="http://schemas.microsoft.com/office/drawing/2014/main" id="{E9F7EB0D-A394-4D98-95F7-A84C133AD61D}"/>
               </a:ext>
             </a:extLst>
           </p:cNvPr>
@@ -22889,7 +23083,7 @@
           <p:cNvPr id="15" name="">
             <a:extLst xmlns:a="http://schemas.openxmlformats.org/drawingml/2006/main">
               <a:ext uri="{FF2B5EF4-FFF2-40B4-BE49-F238E27FC236}">
-                <a16:creationId xmlns:a16="http://schemas.microsoft.com/office/drawing/2014/main" id="{D7F43DCC-5122-4DE3-B8AE-E683238C1603}"/>
+                <a16:creationId xmlns:a16="http://schemas.microsoft.com/office/drawing/2014/main" id="{7A6CFF54-1349-4BD5-948D-6FA580AE59E8}"/>
               </a:ext>
             </a:extLst>
           </p:cNvPr>
@@ -22953,7 +23147,7 @@
           <p:cNvPr id="16" name="">
             <a:extLst xmlns:a="http://schemas.openxmlformats.org/drawingml/2006/main">
               <a:ext uri="{FF2B5EF4-FFF2-40B4-BE49-F238E27FC236}">
-                <a16:creationId xmlns:a16="http://schemas.microsoft.com/office/drawing/2014/main" id="{71D647CB-2FBE-443F-A0D1-4FDF24F005C1}"/>
+                <a16:creationId xmlns:a16="http://schemas.microsoft.com/office/drawing/2014/main" id="{90B0A1E3-B760-445E-B20A-A3494C6E0A0B}"/>
               </a:ext>
             </a:extLst>
           </p:cNvPr>
@@ -22986,7 +23180,7 @@
           <p:cNvPr id="17" name="">
             <a:extLst xmlns:a="http://schemas.openxmlformats.org/drawingml/2006/main">
               <a:ext uri="{FF2B5EF4-FFF2-40B4-BE49-F238E27FC236}">
-                <a16:creationId xmlns:a16="http://schemas.microsoft.com/office/drawing/2014/main" id="{636DE146-E719-4D3B-8900-920533A4DA6F}"/>
+                <a16:creationId xmlns:a16="http://schemas.microsoft.com/office/drawing/2014/main" id="{03FAE1EB-F54B-4D30-A68B-3ACE9D67320B}"/>
               </a:ext>
             </a:extLst>
           </p:cNvPr>
@@ -23050,7 +23244,7 @@
           <p:cNvPr id="18" name="">
             <a:extLst xmlns:a="http://schemas.openxmlformats.org/drawingml/2006/main">
               <a:ext uri="{FF2B5EF4-FFF2-40B4-BE49-F238E27FC236}">
-                <a16:creationId xmlns:a16="http://schemas.microsoft.com/office/drawing/2014/main" id="{4EA038E3-DA67-4126-9C56-B013F2CE091F}"/>
+                <a16:creationId xmlns:a16="http://schemas.microsoft.com/office/drawing/2014/main" id="{526AEB7C-6114-47A8-8340-D52545A5ED2D}"/>
               </a:ext>
             </a:extLst>
           </p:cNvPr>
@@ -23114,7 +23308,7 @@
           <p:cNvPr id="19" name="">
             <a:extLst xmlns:a="http://schemas.openxmlformats.org/drawingml/2006/main">
               <a:ext uri="{FF2B5EF4-FFF2-40B4-BE49-F238E27FC236}">
-                <a16:creationId xmlns:a16="http://schemas.microsoft.com/office/drawing/2014/main" id="{0B1A5607-04F3-4BA6-A038-659B580ECD91}"/>
+                <a16:creationId xmlns:a16="http://schemas.microsoft.com/office/drawing/2014/main" id="{718DE26E-DE34-486F-BEBE-F3EF737FB0CD}"/>
               </a:ext>
             </a:extLst>
           </p:cNvPr>
@@ -23176,7 +23370,7 @@
     </p:spTree>
     <p:extLst>
       <p:ext uri="{BB962C8B-B14F-4D97-AF65-F5344CB8AC3E}">
-        <p14:creationId xmlns:p14="http://schemas.microsoft.com/office/powerpoint/2010/main" val="2071022763"/>
+        <p14:creationId xmlns:p14="http://schemas.microsoft.com/office/powerpoint/2010/main" val="1731280495"/>
       </p:ext>
     </p:extLst>
   </p:cSld>

</xml_diff>